<commit_message>
Update Data Sources from LFX
Signed-off-by: github-actions[bot] <41898282+github-actions[bot]@users.noreply.github.com>
</commit_message>
<xml_diff>
--- a/overview_deck/LF Energy High Level Overview.pptx
+++ b/overview_deck/LF Energy High Level Overview.pptx
@@ -25946,7 +25946,7 @@
             <a:tbl>
               <a:tblPr>
                 <a:noFill/>
-                <a:tableStyleId>{751CCFF3-9EA1-4AD6-A2DD-811D0323C3BA}</a:tableStyleId>
+                <a:tableStyleId>{F37AABCB-8023-49C7-A8FB-B28CF5C3E58C}</a:tableStyleId>
               </a:tblPr>
               <a:tblGrid>
                 <a:gridCol w="1695200"/>
@@ -26736,7 +26736,7 @@
             <a:tbl>
               <a:tblPr>
                 <a:noFill/>
-                <a:tableStyleId>{751CCFF3-9EA1-4AD6-A2DD-811D0323C3BA}</a:tableStyleId>
+                <a:tableStyleId>{F37AABCB-8023-49C7-A8FB-B28CF5C3E58C}</a:tableStyleId>
               </a:tblPr>
               <a:tblGrid>
                 <a:gridCol w="1695200"/>
@@ -27426,7 +27426,7 @@
             <a:tbl>
               <a:tblPr>
                 <a:noFill/>
-                <a:tableStyleId>{751CCFF3-9EA1-4AD6-A2DD-811D0323C3BA}</a:tableStyleId>
+                <a:tableStyleId>{F37AABCB-8023-49C7-A8FB-B28CF5C3E58C}</a:tableStyleId>
               </a:tblPr>
               <a:tblGrid>
                 <a:gridCol w="1695200"/>
@@ -28678,7 +28678,7 @@
             <a:tbl>
               <a:tblPr>
                 <a:noFill/>
-                <a:tableStyleId>{751CCFF3-9EA1-4AD6-A2DD-811D0323C3BA}</a:tableStyleId>
+                <a:tableStyleId>{F37AABCB-8023-49C7-A8FB-B28CF5C3E58C}</a:tableStyleId>
               </a:tblPr>
               <a:tblGrid>
                 <a:gridCol w="1695200"/>
@@ -29670,7 +29670,7 @@
             <a:tbl>
               <a:tblPr>
                 <a:noFill/>
-                <a:tableStyleId>{751CCFF3-9EA1-4AD6-A2DD-811D0323C3BA}</a:tableStyleId>
+                <a:tableStyleId>{F37AABCB-8023-49C7-A8FB-B28CF5C3E58C}</a:tableStyleId>
               </a:tblPr>
               <a:tblGrid>
                 <a:gridCol w="3048000"/>
@@ -33175,7 +33175,7 @@
             <a:tbl>
               <a:tblPr>
                 <a:noFill/>
-                <a:tableStyleId>{751CCFF3-9EA1-4AD6-A2DD-811D0323C3BA}</a:tableStyleId>
+                <a:tableStyleId>{F37AABCB-8023-49C7-A8FB-B28CF5C3E58C}</a:tableStyleId>
               </a:tblPr>
               <a:tblGrid>
                 <a:gridCol w="1828800"/>
@@ -34002,6 +34002,285 @@
 </file>
 
 <file path=ppt/theme/theme1.xml><?xml version="1.0" encoding="utf-8"?>
+<a:theme xmlns:a="http://schemas.openxmlformats.org/drawingml/2006/main" xmlns:r="http://schemas.openxmlformats.org/officeDocument/2006/relationships" name="Simple Light">
+  <a:themeElements>
+    <a:clrScheme name="Simple Light">
+      <a:dk1>
+        <a:srgbClr val="000000"/>
+      </a:dk1>
+      <a:lt1>
+        <a:srgbClr val="FFFFFF"/>
+      </a:lt1>
+      <a:dk2>
+        <a:srgbClr val="595959"/>
+      </a:dk2>
+      <a:lt2>
+        <a:srgbClr val="EEEEEE"/>
+      </a:lt2>
+      <a:accent1>
+        <a:srgbClr val="4285F4"/>
+      </a:accent1>
+      <a:accent2>
+        <a:srgbClr val="212121"/>
+      </a:accent2>
+      <a:accent3>
+        <a:srgbClr val="78909C"/>
+      </a:accent3>
+      <a:accent4>
+        <a:srgbClr val="FFAB40"/>
+      </a:accent4>
+      <a:accent5>
+        <a:srgbClr val="0097A7"/>
+      </a:accent5>
+      <a:accent6>
+        <a:srgbClr val="EEFF41"/>
+      </a:accent6>
+      <a:hlink>
+        <a:srgbClr val="0097A7"/>
+      </a:hlink>
+      <a:folHlink>
+        <a:srgbClr val="0097A7"/>
+      </a:folHlink>
+    </a:clrScheme>
+    <a:fontScheme name="Office">
+      <a:majorFont>
+        <a:latin typeface="Arial"/>
+        <a:ea typeface=""/>
+        <a:cs typeface=""/>
+        <a:font script="Jpan" typeface="ＭＳ Ｐゴシック"/>
+        <a:font script="Hang" typeface="맑은 고딕"/>
+        <a:font script="Hans" typeface="宋体"/>
+        <a:font script="Hant" typeface="新細明體"/>
+        <a:font script="Arab" typeface="Times New Roman"/>
+        <a:font script="Hebr" typeface="Times New Roman"/>
+        <a:font script="Thai" typeface="Angsana New"/>
+        <a:font script="Ethi" typeface="Nyala"/>
+        <a:font script="Beng" typeface="Vrinda"/>
+        <a:font script="Gujr" typeface="Shruti"/>
+        <a:font script="Khmr" typeface="MoolBoran"/>
+        <a:font script="Knda" typeface="Tunga"/>
+        <a:font script="Guru" typeface="Raavi"/>
+        <a:font script="Cans" typeface="Euphemia"/>
+        <a:font script="Cher" typeface="Plantagenet Cherokee"/>
+        <a:font script="Yiii" typeface="Microsoft Yi Baiti"/>
+        <a:font script="Tibt" typeface="Microsoft Himalaya"/>
+        <a:font script="Thaa" typeface="MV Boli"/>
+        <a:font script="Deva" typeface="Mangal"/>
+        <a:font script="Telu" typeface="Gautami"/>
+        <a:font script="Taml" typeface="Latha"/>
+        <a:font script="Syrc" typeface="Estrangelo Edessa"/>
+        <a:font script="Orya" typeface="Kalinga"/>
+        <a:font script="Mlym" typeface="Kartika"/>
+        <a:font script="Laoo" typeface="DokChampa"/>
+        <a:font script="Sinh" typeface="Iskoola Pota"/>
+        <a:font script="Mong" typeface="Mongolian Baiti"/>
+        <a:font script="Viet" typeface="Times New Roman"/>
+        <a:font script="Uigh" typeface="Microsoft Uighur"/>
+        <a:font script="Geor" typeface="Sylfaen"/>
+      </a:majorFont>
+      <a:minorFont>
+        <a:latin typeface="Arial"/>
+        <a:ea typeface=""/>
+        <a:cs typeface=""/>
+        <a:font script="Jpan" typeface="ＭＳ Ｐゴシック"/>
+        <a:font script="Hang" typeface="맑은 고딕"/>
+        <a:font script="Hans" typeface="宋体"/>
+        <a:font script="Hant" typeface="新細明體"/>
+        <a:font script="Arab" typeface="Arial"/>
+        <a:font script="Hebr" typeface="Arial"/>
+        <a:font script="Thai" typeface="Cordia New"/>
+        <a:font script="Ethi" typeface="Nyala"/>
+        <a:font script="Beng" typeface="Vrinda"/>
+        <a:font script="Gujr" typeface="Shruti"/>
+        <a:font script="Khmr" typeface="DaunPenh"/>
+        <a:font script="Knda" typeface="Tunga"/>
+        <a:font script="Guru" typeface="Raavi"/>
+        <a:font script="Cans" typeface="Euphemia"/>
+        <a:font script="Cher" typeface="Plantagenet Cherokee"/>
+        <a:font script="Yiii" typeface="Microsoft Yi Baiti"/>
+        <a:font script="Tibt" typeface="Microsoft Himalaya"/>
+        <a:font script="Thaa" typeface="MV Boli"/>
+        <a:font script="Deva" typeface="Mangal"/>
+        <a:font script="Telu" typeface="Gautami"/>
+        <a:font script="Taml" typeface="Latha"/>
+        <a:font script="Syrc" typeface="Estrangelo Edessa"/>
+        <a:font script="Orya" typeface="Kalinga"/>
+        <a:font script="Mlym" typeface="Kartika"/>
+        <a:font script="Laoo" typeface="DokChampa"/>
+        <a:font script="Sinh" typeface="Iskoola Pota"/>
+        <a:font script="Mong" typeface="Mongolian Baiti"/>
+        <a:font script="Viet" typeface="Arial"/>
+        <a:font script="Uigh" typeface="Microsoft Uighur"/>
+        <a:font script="Geor" typeface="Sylfaen"/>
+      </a:minorFont>
+    </a:fontScheme>
+    <a:fmtScheme name="Office">
+      <a:fillStyleLst>
+        <a:solidFill>
+          <a:schemeClr val="phClr"/>
+        </a:solidFill>
+        <a:gradFill rotWithShape="1">
+          <a:gsLst>
+            <a:gs pos="0">
+              <a:schemeClr val="phClr">
+                <a:tint val="50000"/>
+                <a:satMod val="300000"/>
+              </a:schemeClr>
+            </a:gs>
+            <a:gs pos="35000">
+              <a:schemeClr val="phClr">
+                <a:tint val="37000"/>
+                <a:satMod val="300000"/>
+              </a:schemeClr>
+            </a:gs>
+            <a:gs pos="100000">
+              <a:schemeClr val="phClr">
+                <a:tint val="15000"/>
+                <a:satMod val="350000"/>
+              </a:schemeClr>
+            </a:gs>
+          </a:gsLst>
+          <a:lin ang="16200000" scaled="1"/>
+        </a:gradFill>
+        <a:gradFill rotWithShape="1">
+          <a:gsLst>
+            <a:gs pos="0">
+              <a:schemeClr val="phClr">
+                <a:tint val="100000"/>
+                <a:shade val="100000"/>
+                <a:satMod val="130000"/>
+              </a:schemeClr>
+            </a:gs>
+            <a:gs pos="100000">
+              <a:schemeClr val="phClr">
+                <a:tint val="50000"/>
+                <a:shade val="100000"/>
+                <a:satMod val="350000"/>
+              </a:schemeClr>
+            </a:gs>
+          </a:gsLst>
+          <a:lin ang="16200000" scaled="0"/>
+        </a:gradFill>
+      </a:fillStyleLst>
+      <a:lnStyleLst>
+        <a:ln w="9525" cap="flat" cmpd="sng" algn="ctr">
+          <a:solidFill>
+            <a:schemeClr val="phClr">
+              <a:shade val="95000"/>
+              <a:satMod val="105000"/>
+            </a:schemeClr>
+          </a:solidFill>
+          <a:prstDash val="solid"/>
+        </a:ln>
+        <a:ln w="25400" cap="flat" cmpd="sng" algn="ctr">
+          <a:solidFill>
+            <a:schemeClr val="phClr"/>
+          </a:solidFill>
+          <a:prstDash val="solid"/>
+        </a:ln>
+        <a:ln w="38100" cap="flat" cmpd="sng" algn="ctr">
+          <a:solidFill>
+            <a:schemeClr val="phClr"/>
+          </a:solidFill>
+          <a:prstDash val="solid"/>
+        </a:ln>
+      </a:lnStyleLst>
+      <a:effectStyleLst>
+        <a:effectStyle>
+          <a:effectLst>
+            <a:outerShdw blurRad="40000" dist="20000" dir="5400000" rotWithShape="0">
+              <a:srgbClr val="000000">
+                <a:alpha val="38000"/>
+              </a:srgbClr>
+            </a:outerShdw>
+          </a:effectLst>
+        </a:effectStyle>
+        <a:effectStyle>
+          <a:effectLst>
+            <a:outerShdw blurRad="40000" dist="23000" dir="5400000" rotWithShape="0">
+              <a:srgbClr val="000000">
+                <a:alpha val="35000"/>
+              </a:srgbClr>
+            </a:outerShdw>
+          </a:effectLst>
+        </a:effectStyle>
+        <a:effectStyle>
+          <a:effectLst>
+            <a:outerShdw blurRad="40000" dist="23000" dir="5400000" rotWithShape="0">
+              <a:srgbClr val="000000">
+                <a:alpha val="35000"/>
+              </a:srgbClr>
+            </a:outerShdw>
+          </a:effectLst>
+          <a:scene3d>
+            <a:camera prst="orthographicFront">
+              <a:rot lat="0" lon="0" rev="0"/>
+            </a:camera>
+            <a:lightRig rig="threePt" dir="t">
+              <a:rot lat="0" lon="0" rev="1200000"/>
+            </a:lightRig>
+          </a:scene3d>
+          <a:sp3d>
+            <a:bevelT w="63500" h="25400"/>
+          </a:sp3d>
+        </a:effectStyle>
+      </a:effectStyleLst>
+      <a:bgFillStyleLst>
+        <a:solidFill>
+          <a:schemeClr val="phClr"/>
+        </a:solidFill>
+        <a:gradFill rotWithShape="1">
+          <a:gsLst>
+            <a:gs pos="0">
+              <a:schemeClr val="phClr">
+                <a:tint val="40000"/>
+                <a:satMod val="350000"/>
+              </a:schemeClr>
+            </a:gs>
+            <a:gs pos="40000">
+              <a:schemeClr val="phClr">
+                <a:tint val="45000"/>
+                <a:shade val="99000"/>
+                <a:satMod val="350000"/>
+              </a:schemeClr>
+            </a:gs>
+            <a:gs pos="100000">
+              <a:schemeClr val="phClr">
+                <a:shade val="20000"/>
+                <a:satMod val="255000"/>
+              </a:schemeClr>
+            </a:gs>
+          </a:gsLst>
+          <a:path path="circle">
+            <a:fillToRect l="50000" t="-80000" r="50000" b="180000"/>
+          </a:path>
+        </a:gradFill>
+        <a:gradFill rotWithShape="1">
+          <a:gsLst>
+            <a:gs pos="0">
+              <a:schemeClr val="phClr">
+                <a:tint val="80000"/>
+                <a:satMod val="300000"/>
+              </a:schemeClr>
+            </a:gs>
+            <a:gs pos="100000">
+              <a:schemeClr val="phClr">
+                <a:shade val="30000"/>
+                <a:satMod val="200000"/>
+              </a:schemeClr>
+            </a:gs>
+          </a:gsLst>
+          <a:path path="circle">
+            <a:fillToRect l="50000" t="50000" r="50000" b="50000"/>
+          </a:path>
+        </a:gradFill>
+      </a:bgFillStyleLst>
+    </a:fmtScheme>
+  </a:themeElements>
+</a:theme>
+</file>
+
+<file path=ppt/theme/theme2.xml><?xml version="1.0" encoding="utf-8"?>
 <a:theme xmlns:a="http://schemas.openxmlformats.org/drawingml/2006/main" xmlns:r="http://schemas.openxmlformats.org/officeDocument/2006/relationships">
   <a:themeElements>
     <a:clrScheme name="Default">
@@ -34280,7 +34559,7 @@
 </a:theme>
 </file>
 
-<file path=ppt/theme/theme2.xml><?xml version="1.0" encoding="utf-8"?>
+<file path=ppt/theme/theme3.xml><?xml version="1.0" encoding="utf-8"?>
 <a:theme xmlns:a="http://schemas.openxmlformats.org/drawingml/2006/main" xmlns:r="http://schemas.openxmlformats.org/officeDocument/2006/relationships" name="LF Energy Theme 2023">
   <a:themeElements>
     <a:clrScheme name="Geometric">
@@ -34557,283 +34836,4 @@
     </a:fmtScheme>
   </a:themeElements>
 </a:theme>
-</file>
-
-<file path=ppt/theme/theme3.xml><?xml version="1.0" encoding="utf-8"?>
-<a:theme xmlns:a="http://schemas.openxmlformats.org/drawingml/2006/main" xmlns:r="http://schemas.openxmlformats.org/officeDocument/2006/relationships" name="Simple Light">
-  <a:themeElements>
-    <a:clrScheme name="Simple Light">
-      <a:dk1>
-        <a:srgbClr val="000000"/>
-      </a:dk1>
-      <a:lt1>
-        <a:srgbClr val="FFFFFF"/>
-      </a:lt1>
-      <a:dk2>
-        <a:srgbClr val="595959"/>
-      </a:dk2>
-      <a:lt2>
-        <a:srgbClr val="EEEEEE"/>
-      </a:lt2>
-      <a:accent1>
-        <a:srgbClr val="4285F4"/>
-      </a:accent1>
-      <a:accent2>
-        <a:srgbClr val="212121"/>
-      </a:accent2>
-      <a:accent3>
-        <a:srgbClr val="78909C"/>
-      </a:accent3>
-      <a:accent4>
-        <a:srgbClr val="FFAB40"/>
-      </a:accent4>
-      <a:accent5>
-        <a:srgbClr val="0097A7"/>
-      </a:accent5>
-      <a:accent6>
-        <a:srgbClr val="EEFF41"/>
-      </a:accent6>
-      <a:hlink>
-        <a:srgbClr val="0097A7"/>
-      </a:hlink>
-      <a:folHlink>
-        <a:srgbClr val="0097A7"/>
-      </a:folHlink>
-    </a:clrScheme>
-    <a:fontScheme name="Office">
-      <a:majorFont>
-        <a:latin typeface="Arial"/>
-        <a:ea typeface=""/>
-        <a:cs typeface=""/>
-        <a:font script="Jpan" typeface="ＭＳ Ｐゴシック"/>
-        <a:font script="Hang" typeface="맑은 고딕"/>
-        <a:font script="Hans" typeface="宋体"/>
-        <a:font script="Hant" typeface="新細明體"/>
-        <a:font script="Arab" typeface="Times New Roman"/>
-        <a:font script="Hebr" typeface="Times New Roman"/>
-        <a:font script="Thai" typeface="Angsana New"/>
-        <a:font script="Ethi" typeface="Nyala"/>
-        <a:font script="Beng" typeface="Vrinda"/>
-        <a:font script="Gujr" typeface="Shruti"/>
-        <a:font script="Khmr" typeface="MoolBoran"/>
-        <a:font script="Knda" typeface="Tunga"/>
-        <a:font script="Guru" typeface="Raavi"/>
-        <a:font script="Cans" typeface="Euphemia"/>
-        <a:font script="Cher" typeface="Plantagenet Cherokee"/>
-        <a:font script="Yiii" typeface="Microsoft Yi Baiti"/>
-        <a:font script="Tibt" typeface="Microsoft Himalaya"/>
-        <a:font script="Thaa" typeface="MV Boli"/>
-        <a:font script="Deva" typeface="Mangal"/>
-        <a:font script="Telu" typeface="Gautami"/>
-        <a:font script="Taml" typeface="Latha"/>
-        <a:font script="Syrc" typeface="Estrangelo Edessa"/>
-        <a:font script="Orya" typeface="Kalinga"/>
-        <a:font script="Mlym" typeface="Kartika"/>
-        <a:font script="Laoo" typeface="DokChampa"/>
-        <a:font script="Sinh" typeface="Iskoola Pota"/>
-        <a:font script="Mong" typeface="Mongolian Baiti"/>
-        <a:font script="Viet" typeface="Times New Roman"/>
-        <a:font script="Uigh" typeface="Microsoft Uighur"/>
-        <a:font script="Geor" typeface="Sylfaen"/>
-      </a:majorFont>
-      <a:minorFont>
-        <a:latin typeface="Arial"/>
-        <a:ea typeface=""/>
-        <a:cs typeface=""/>
-        <a:font script="Jpan" typeface="ＭＳ Ｐゴシック"/>
-        <a:font script="Hang" typeface="맑은 고딕"/>
-        <a:font script="Hans" typeface="宋体"/>
-        <a:font script="Hant" typeface="新細明體"/>
-        <a:font script="Arab" typeface="Arial"/>
-        <a:font script="Hebr" typeface="Arial"/>
-        <a:font script="Thai" typeface="Cordia New"/>
-        <a:font script="Ethi" typeface="Nyala"/>
-        <a:font script="Beng" typeface="Vrinda"/>
-        <a:font script="Gujr" typeface="Shruti"/>
-        <a:font script="Khmr" typeface="DaunPenh"/>
-        <a:font script="Knda" typeface="Tunga"/>
-        <a:font script="Guru" typeface="Raavi"/>
-        <a:font script="Cans" typeface="Euphemia"/>
-        <a:font script="Cher" typeface="Plantagenet Cherokee"/>
-        <a:font script="Yiii" typeface="Microsoft Yi Baiti"/>
-        <a:font script="Tibt" typeface="Microsoft Himalaya"/>
-        <a:font script="Thaa" typeface="MV Boli"/>
-        <a:font script="Deva" typeface="Mangal"/>
-        <a:font script="Telu" typeface="Gautami"/>
-        <a:font script="Taml" typeface="Latha"/>
-        <a:font script="Syrc" typeface="Estrangelo Edessa"/>
-        <a:font script="Orya" typeface="Kalinga"/>
-        <a:font script="Mlym" typeface="Kartika"/>
-        <a:font script="Laoo" typeface="DokChampa"/>
-        <a:font script="Sinh" typeface="Iskoola Pota"/>
-        <a:font script="Mong" typeface="Mongolian Baiti"/>
-        <a:font script="Viet" typeface="Arial"/>
-        <a:font script="Uigh" typeface="Microsoft Uighur"/>
-        <a:font script="Geor" typeface="Sylfaen"/>
-      </a:minorFont>
-    </a:fontScheme>
-    <a:fmtScheme name="Office">
-      <a:fillStyleLst>
-        <a:solidFill>
-          <a:schemeClr val="phClr"/>
-        </a:solidFill>
-        <a:gradFill rotWithShape="1">
-          <a:gsLst>
-            <a:gs pos="0">
-              <a:schemeClr val="phClr">
-                <a:tint val="50000"/>
-                <a:satMod val="300000"/>
-              </a:schemeClr>
-            </a:gs>
-            <a:gs pos="35000">
-              <a:schemeClr val="phClr">
-                <a:tint val="37000"/>
-                <a:satMod val="300000"/>
-              </a:schemeClr>
-            </a:gs>
-            <a:gs pos="100000">
-              <a:schemeClr val="phClr">
-                <a:tint val="15000"/>
-                <a:satMod val="350000"/>
-              </a:schemeClr>
-            </a:gs>
-          </a:gsLst>
-          <a:lin ang="16200000" scaled="1"/>
-        </a:gradFill>
-        <a:gradFill rotWithShape="1">
-          <a:gsLst>
-            <a:gs pos="0">
-              <a:schemeClr val="phClr">
-                <a:tint val="100000"/>
-                <a:shade val="100000"/>
-                <a:satMod val="130000"/>
-              </a:schemeClr>
-            </a:gs>
-            <a:gs pos="100000">
-              <a:schemeClr val="phClr">
-                <a:tint val="50000"/>
-                <a:shade val="100000"/>
-                <a:satMod val="350000"/>
-              </a:schemeClr>
-            </a:gs>
-          </a:gsLst>
-          <a:lin ang="16200000" scaled="0"/>
-        </a:gradFill>
-      </a:fillStyleLst>
-      <a:lnStyleLst>
-        <a:ln w="9525" cap="flat" cmpd="sng" algn="ctr">
-          <a:solidFill>
-            <a:schemeClr val="phClr">
-              <a:shade val="95000"/>
-              <a:satMod val="105000"/>
-            </a:schemeClr>
-          </a:solidFill>
-          <a:prstDash val="solid"/>
-        </a:ln>
-        <a:ln w="25400" cap="flat" cmpd="sng" algn="ctr">
-          <a:solidFill>
-            <a:schemeClr val="phClr"/>
-          </a:solidFill>
-          <a:prstDash val="solid"/>
-        </a:ln>
-        <a:ln w="38100" cap="flat" cmpd="sng" algn="ctr">
-          <a:solidFill>
-            <a:schemeClr val="phClr"/>
-          </a:solidFill>
-          <a:prstDash val="solid"/>
-        </a:ln>
-      </a:lnStyleLst>
-      <a:effectStyleLst>
-        <a:effectStyle>
-          <a:effectLst>
-            <a:outerShdw blurRad="40000" dist="20000" dir="5400000" rotWithShape="0">
-              <a:srgbClr val="000000">
-                <a:alpha val="38000"/>
-              </a:srgbClr>
-            </a:outerShdw>
-          </a:effectLst>
-        </a:effectStyle>
-        <a:effectStyle>
-          <a:effectLst>
-            <a:outerShdw blurRad="40000" dist="23000" dir="5400000" rotWithShape="0">
-              <a:srgbClr val="000000">
-                <a:alpha val="35000"/>
-              </a:srgbClr>
-            </a:outerShdw>
-          </a:effectLst>
-        </a:effectStyle>
-        <a:effectStyle>
-          <a:effectLst>
-            <a:outerShdw blurRad="40000" dist="23000" dir="5400000" rotWithShape="0">
-              <a:srgbClr val="000000">
-                <a:alpha val="35000"/>
-              </a:srgbClr>
-            </a:outerShdw>
-          </a:effectLst>
-          <a:scene3d>
-            <a:camera prst="orthographicFront">
-              <a:rot lat="0" lon="0" rev="0"/>
-            </a:camera>
-            <a:lightRig rig="threePt" dir="t">
-              <a:rot lat="0" lon="0" rev="1200000"/>
-            </a:lightRig>
-          </a:scene3d>
-          <a:sp3d>
-            <a:bevelT w="63500" h="25400"/>
-          </a:sp3d>
-        </a:effectStyle>
-      </a:effectStyleLst>
-      <a:bgFillStyleLst>
-        <a:solidFill>
-          <a:schemeClr val="phClr"/>
-        </a:solidFill>
-        <a:gradFill rotWithShape="1">
-          <a:gsLst>
-            <a:gs pos="0">
-              <a:schemeClr val="phClr">
-                <a:tint val="40000"/>
-                <a:satMod val="350000"/>
-              </a:schemeClr>
-            </a:gs>
-            <a:gs pos="40000">
-              <a:schemeClr val="phClr">
-                <a:tint val="45000"/>
-                <a:shade val="99000"/>
-                <a:satMod val="350000"/>
-              </a:schemeClr>
-            </a:gs>
-            <a:gs pos="100000">
-              <a:schemeClr val="phClr">
-                <a:shade val="20000"/>
-                <a:satMod val="255000"/>
-              </a:schemeClr>
-            </a:gs>
-          </a:gsLst>
-          <a:path path="circle">
-            <a:fillToRect l="50000" t="-80000" r="50000" b="180000"/>
-          </a:path>
-        </a:gradFill>
-        <a:gradFill rotWithShape="1">
-          <a:gsLst>
-            <a:gs pos="0">
-              <a:schemeClr val="phClr">
-                <a:tint val="80000"/>
-                <a:satMod val="300000"/>
-              </a:schemeClr>
-            </a:gs>
-            <a:gs pos="100000">
-              <a:schemeClr val="phClr">
-                <a:shade val="30000"/>
-                <a:satMod val="200000"/>
-              </a:schemeClr>
-            </a:gs>
-          </a:gsLst>
-          <a:path path="circle">
-            <a:fillToRect l="50000" t="50000" r="50000" b="50000"/>
-          </a:path>
-        </a:gradFill>
-      </a:bgFillStyleLst>
-    </a:fmtScheme>
-  </a:themeElements>
-</a:theme>
 </file>
</xml_diff>

<commit_message>
Update Data Sources from LFX 2026-09-06 (#300)
Update Data Sources from LFX

Signed-off-by: github-actions[bot] <41898282+github-actions[bot]@users.noreply.github.com>
</commit_message>
<xml_diff>
--- a/overview_deck/LF Energy High Level Overview.pptx
+++ b/overview_deck/LF Energy High Level Overview.pptx
@@ -25946,7 +25946,7 @@
             <a:tbl>
               <a:tblPr>
                 <a:noFill/>
-                <a:tableStyleId>{751CCFF3-9EA1-4AD6-A2DD-811D0323C3BA}</a:tableStyleId>
+                <a:tableStyleId>{F37AABCB-8023-49C7-A8FB-B28CF5C3E58C}</a:tableStyleId>
               </a:tblPr>
               <a:tblGrid>
                 <a:gridCol w="1695200"/>
@@ -26736,7 +26736,7 @@
             <a:tbl>
               <a:tblPr>
                 <a:noFill/>
-                <a:tableStyleId>{751CCFF3-9EA1-4AD6-A2DD-811D0323C3BA}</a:tableStyleId>
+                <a:tableStyleId>{F37AABCB-8023-49C7-A8FB-B28CF5C3E58C}</a:tableStyleId>
               </a:tblPr>
               <a:tblGrid>
                 <a:gridCol w="1695200"/>
@@ -27426,7 +27426,7 @@
             <a:tbl>
               <a:tblPr>
                 <a:noFill/>
-                <a:tableStyleId>{751CCFF3-9EA1-4AD6-A2DD-811D0323C3BA}</a:tableStyleId>
+                <a:tableStyleId>{F37AABCB-8023-49C7-A8FB-B28CF5C3E58C}</a:tableStyleId>
               </a:tblPr>
               <a:tblGrid>
                 <a:gridCol w="1695200"/>
@@ -28678,7 +28678,7 @@
             <a:tbl>
               <a:tblPr>
                 <a:noFill/>
-                <a:tableStyleId>{751CCFF3-9EA1-4AD6-A2DD-811D0323C3BA}</a:tableStyleId>
+                <a:tableStyleId>{F37AABCB-8023-49C7-A8FB-B28CF5C3E58C}</a:tableStyleId>
               </a:tblPr>
               <a:tblGrid>
                 <a:gridCol w="1695200"/>
@@ -29670,7 +29670,7 @@
             <a:tbl>
               <a:tblPr>
                 <a:noFill/>
-                <a:tableStyleId>{751CCFF3-9EA1-4AD6-A2DD-811D0323C3BA}</a:tableStyleId>
+                <a:tableStyleId>{F37AABCB-8023-49C7-A8FB-B28CF5C3E58C}</a:tableStyleId>
               </a:tblPr>
               <a:tblGrid>
                 <a:gridCol w="3048000"/>
@@ -33175,7 +33175,7 @@
             <a:tbl>
               <a:tblPr>
                 <a:noFill/>
-                <a:tableStyleId>{751CCFF3-9EA1-4AD6-A2DD-811D0323C3BA}</a:tableStyleId>
+                <a:tableStyleId>{F37AABCB-8023-49C7-A8FB-B28CF5C3E58C}</a:tableStyleId>
               </a:tblPr>
               <a:tblGrid>
                 <a:gridCol w="1828800"/>
@@ -34002,6 +34002,285 @@
 </file>
 
 <file path=ppt/theme/theme1.xml><?xml version="1.0" encoding="utf-8"?>
+<a:theme xmlns:a="http://schemas.openxmlformats.org/drawingml/2006/main" xmlns:r="http://schemas.openxmlformats.org/officeDocument/2006/relationships" name="Simple Light">
+  <a:themeElements>
+    <a:clrScheme name="Simple Light">
+      <a:dk1>
+        <a:srgbClr val="000000"/>
+      </a:dk1>
+      <a:lt1>
+        <a:srgbClr val="FFFFFF"/>
+      </a:lt1>
+      <a:dk2>
+        <a:srgbClr val="595959"/>
+      </a:dk2>
+      <a:lt2>
+        <a:srgbClr val="EEEEEE"/>
+      </a:lt2>
+      <a:accent1>
+        <a:srgbClr val="4285F4"/>
+      </a:accent1>
+      <a:accent2>
+        <a:srgbClr val="212121"/>
+      </a:accent2>
+      <a:accent3>
+        <a:srgbClr val="78909C"/>
+      </a:accent3>
+      <a:accent4>
+        <a:srgbClr val="FFAB40"/>
+      </a:accent4>
+      <a:accent5>
+        <a:srgbClr val="0097A7"/>
+      </a:accent5>
+      <a:accent6>
+        <a:srgbClr val="EEFF41"/>
+      </a:accent6>
+      <a:hlink>
+        <a:srgbClr val="0097A7"/>
+      </a:hlink>
+      <a:folHlink>
+        <a:srgbClr val="0097A7"/>
+      </a:folHlink>
+    </a:clrScheme>
+    <a:fontScheme name="Office">
+      <a:majorFont>
+        <a:latin typeface="Arial"/>
+        <a:ea typeface=""/>
+        <a:cs typeface=""/>
+        <a:font script="Jpan" typeface="ＭＳ Ｐゴシック"/>
+        <a:font script="Hang" typeface="맑은 고딕"/>
+        <a:font script="Hans" typeface="宋体"/>
+        <a:font script="Hant" typeface="新細明體"/>
+        <a:font script="Arab" typeface="Times New Roman"/>
+        <a:font script="Hebr" typeface="Times New Roman"/>
+        <a:font script="Thai" typeface="Angsana New"/>
+        <a:font script="Ethi" typeface="Nyala"/>
+        <a:font script="Beng" typeface="Vrinda"/>
+        <a:font script="Gujr" typeface="Shruti"/>
+        <a:font script="Khmr" typeface="MoolBoran"/>
+        <a:font script="Knda" typeface="Tunga"/>
+        <a:font script="Guru" typeface="Raavi"/>
+        <a:font script="Cans" typeface="Euphemia"/>
+        <a:font script="Cher" typeface="Plantagenet Cherokee"/>
+        <a:font script="Yiii" typeface="Microsoft Yi Baiti"/>
+        <a:font script="Tibt" typeface="Microsoft Himalaya"/>
+        <a:font script="Thaa" typeface="MV Boli"/>
+        <a:font script="Deva" typeface="Mangal"/>
+        <a:font script="Telu" typeface="Gautami"/>
+        <a:font script="Taml" typeface="Latha"/>
+        <a:font script="Syrc" typeface="Estrangelo Edessa"/>
+        <a:font script="Orya" typeface="Kalinga"/>
+        <a:font script="Mlym" typeface="Kartika"/>
+        <a:font script="Laoo" typeface="DokChampa"/>
+        <a:font script="Sinh" typeface="Iskoola Pota"/>
+        <a:font script="Mong" typeface="Mongolian Baiti"/>
+        <a:font script="Viet" typeface="Times New Roman"/>
+        <a:font script="Uigh" typeface="Microsoft Uighur"/>
+        <a:font script="Geor" typeface="Sylfaen"/>
+      </a:majorFont>
+      <a:minorFont>
+        <a:latin typeface="Arial"/>
+        <a:ea typeface=""/>
+        <a:cs typeface=""/>
+        <a:font script="Jpan" typeface="ＭＳ Ｐゴシック"/>
+        <a:font script="Hang" typeface="맑은 고딕"/>
+        <a:font script="Hans" typeface="宋体"/>
+        <a:font script="Hant" typeface="新細明體"/>
+        <a:font script="Arab" typeface="Arial"/>
+        <a:font script="Hebr" typeface="Arial"/>
+        <a:font script="Thai" typeface="Cordia New"/>
+        <a:font script="Ethi" typeface="Nyala"/>
+        <a:font script="Beng" typeface="Vrinda"/>
+        <a:font script="Gujr" typeface="Shruti"/>
+        <a:font script="Khmr" typeface="DaunPenh"/>
+        <a:font script="Knda" typeface="Tunga"/>
+        <a:font script="Guru" typeface="Raavi"/>
+        <a:font script="Cans" typeface="Euphemia"/>
+        <a:font script="Cher" typeface="Plantagenet Cherokee"/>
+        <a:font script="Yiii" typeface="Microsoft Yi Baiti"/>
+        <a:font script="Tibt" typeface="Microsoft Himalaya"/>
+        <a:font script="Thaa" typeface="MV Boli"/>
+        <a:font script="Deva" typeface="Mangal"/>
+        <a:font script="Telu" typeface="Gautami"/>
+        <a:font script="Taml" typeface="Latha"/>
+        <a:font script="Syrc" typeface="Estrangelo Edessa"/>
+        <a:font script="Orya" typeface="Kalinga"/>
+        <a:font script="Mlym" typeface="Kartika"/>
+        <a:font script="Laoo" typeface="DokChampa"/>
+        <a:font script="Sinh" typeface="Iskoola Pota"/>
+        <a:font script="Mong" typeface="Mongolian Baiti"/>
+        <a:font script="Viet" typeface="Arial"/>
+        <a:font script="Uigh" typeface="Microsoft Uighur"/>
+        <a:font script="Geor" typeface="Sylfaen"/>
+      </a:minorFont>
+    </a:fontScheme>
+    <a:fmtScheme name="Office">
+      <a:fillStyleLst>
+        <a:solidFill>
+          <a:schemeClr val="phClr"/>
+        </a:solidFill>
+        <a:gradFill rotWithShape="1">
+          <a:gsLst>
+            <a:gs pos="0">
+              <a:schemeClr val="phClr">
+                <a:tint val="50000"/>
+                <a:satMod val="300000"/>
+              </a:schemeClr>
+            </a:gs>
+            <a:gs pos="35000">
+              <a:schemeClr val="phClr">
+                <a:tint val="37000"/>
+                <a:satMod val="300000"/>
+              </a:schemeClr>
+            </a:gs>
+            <a:gs pos="100000">
+              <a:schemeClr val="phClr">
+                <a:tint val="15000"/>
+                <a:satMod val="350000"/>
+              </a:schemeClr>
+            </a:gs>
+          </a:gsLst>
+          <a:lin ang="16200000" scaled="1"/>
+        </a:gradFill>
+        <a:gradFill rotWithShape="1">
+          <a:gsLst>
+            <a:gs pos="0">
+              <a:schemeClr val="phClr">
+                <a:tint val="100000"/>
+                <a:shade val="100000"/>
+                <a:satMod val="130000"/>
+              </a:schemeClr>
+            </a:gs>
+            <a:gs pos="100000">
+              <a:schemeClr val="phClr">
+                <a:tint val="50000"/>
+                <a:shade val="100000"/>
+                <a:satMod val="350000"/>
+              </a:schemeClr>
+            </a:gs>
+          </a:gsLst>
+          <a:lin ang="16200000" scaled="0"/>
+        </a:gradFill>
+      </a:fillStyleLst>
+      <a:lnStyleLst>
+        <a:ln w="9525" cap="flat" cmpd="sng" algn="ctr">
+          <a:solidFill>
+            <a:schemeClr val="phClr">
+              <a:shade val="95000"/>
+              <a:satMod val="105000"/>
+            </a:schemeClr>
+          </a:solidFill>
+          <a:prstDash val="solid"/>
+        </a:ln>
+        <a:ln w="25400" cap="flat" cmpd="sng" algn="ctr">
+          <a:solidFill>
+            <a:schemeClr val="phClr"/>
+          </a:solidFill>
+          <a:prstDash val="solid"/>
+        </a:ln>
+        <a:ln w="38100" cap="flat" cmpd="sng" algn="ctr">
+          <a:solidFill>
+            <a:schemeClr val="phClr"/>
+          </a:solidFill>
+          <a:prstDash val="solid"/>
+        </a:ln>
+      </a:lnStyleLst>
+      <a:effectStyleLst>
+        <a:effectStyle>
+          <a:effectLst>
+            <a:outerShdw blurRad="40000" dist="20000" dir="5400000" rotWithShape="0">
+              <a:srgbClr val="000000">
+                <a:alpha val="38000"/>
+              </a:srgbClr>
+            </a:outerShdw>
+          </a:effectLst>
+        </a:effectStyle>
+        <a:effectStyle>
+          <a:effectLst>
+            <a:outerShdw blurRad="40000" dist="23000" dir="5400000" rotWithShape="0">
+              <a:srgbClr val="000000">
+                <a:alpha val="35000"/>
+              </a:srgbClr>
+            </a:outerShdw>
+          </a:effectLst>
+        </a:effectStyle>
+        <a:effectStyle>
+          <a:effectLst>
+            <a:outerShdw blurRad="40000" dist="23000" dir="5400000" rotWithShape="0">
+              <a:srgbClr val="000000">
+                <a:alpha val="35000"/>
+              </a:srgbClr>
+            </a:outerShdw>
+          </a:effectLst>
+          <a:scene3d>
+            <a:camera prst="orthographicFront">
+              <a:rot lat="0" lon="0" rev="0"/>
+            </a:camera>
+            <a:lightRig rig="threePt" dir="t">
+              <a:rot lat="0" lon="0" rev="1200000"/>
+            </a:lightRig>
+          </a:scene3d>
+          <a:sp3d>
+            <a:bevelT w="63500" h="25400"/>
+          </a:sp3d>
+        </a:effectStyle>
+      </a:effectStyleLst>
+      <a:bgFillStyleLst>
+        <a:solidFill>
+          <a:schemeClr val="phClr"/>
+        </a:solidFill>
+        <a:gradFill rotWithShape="1">
+          <a:gsLst>
+            <a:gs pos="0">
+              <a:schemeClr val="phClr">
+                <a:tint val="40000"/>
+                <a:satMod val="350000"/>
+              </a:schemeClr>
+            </a:gs>
+            <a:gs pos="40000">
+              <a:schemeClr val="phClr">
+                <a:tint val="45000"/>
+                <a:shade val="99000"/>
+                <a:satMod val="350000"/>
+              </a:schemeClr>
+            </a:gs>
+            <a:gs pos="100000">
+              <a:schemeClr val="phClr">
+                <a:shade val="20000"/>
+                <a:satMod val="255000"/>
+              </a:schemeClr>
+            </a:gs>
+          </a:gsLst>
+          <a:path path="circle">
+            <a:fillToRect l="50000" t="-80000" r="50000" b="180000"/>
+          </a:path>
+        </a:gradFill>
+        <a:gradFill rotWithShape="1">
+          <a:gsLst>
+            <a:gs pos="0">
+              <a:schemeClr val="phClr">
+                <a:tint val="80000"/>
+                <a:satMod val="300000"/>
+              </a:schemeClr>
+            </a:gs>
+            <a:gs pos="100000">
+              <a:schemeClr val="phClr">
+                <a:shade val="30000"/>
+                <a:satMod val="200000"/>
+              </a:schemeClr>
+            </a:gs>
+          </a:gsLst>
+          <a:path path="circle">
+            <a:fillToRect l="50000" t="50000" r="50000" b="50000"/>
+          </a:path>
+        </a:gradFill>
+      </a:bgFillStyleLst>
+    </a:fmtScheme>
+  </a:themeElements>
+</a:theme>
+</file>
+
+<file path=ppt/theme/theme2.xml><?xml version="1.0" encoding="utf-8"?>
 <a:theme xmlns:a="http://schemas.openxmlformats.org/drawingml/2006/main" xmlns:r="http://schemas.openxmlformats.org/officeDocument/2006/relationships">
   <a:themeElements>
     <a:clrScheme name="Default">
@@ -34280,7 +34559,7 @@
 </a:theme>
 </file>
 
-<file path=ppt/theme/theme2.xml><?xml version="1.0" encoding="utf-8"?>
+<file path=ppt/theme/theme3.xml><?xml version="1.0" encoding="utf-8"?>
 <a:theme xmlns:a="http://schemas.openxmlformats.org/drawingml/2006/main" xmlns:r="http://schemas.openxmlformats.org/officeDocument/2006/relationships" name="LF Energy Theme 2023">
   <a:themeElements>
     <a:clrScheme name="Geometric">
@@ -34557,283 +34836,4 @@
     </a:fmtScheme>
   </a:themeElements>
 </a:theme>
-</file>
-
-<file path=ppt/theme/theme3.xml><?xml version="1.0" encoding="utf-8"?>
-<a:theme xmlns:a="http://schemas.openxmlformats.org/drawingml/2006/main" xmlns:r="http://schemas.openxmlformats.org/officeDocument/2006/relationships" name="Simple Light">
-  <a:themeElements>
-    <a:clrScheme name="Simple Light">
-      <a:dk1>
-        <a:srgbClr val="000000"/>
-      </a:dk1>
-      <a:lt1>
-        <a:srgbClr val="FFFFFF"/>
-      </a:lt1>
-      <a:dk2>
-        <a:srgbClr val="595959"/>
-      </a:dk2>
-      <a:lt2>
-        <a:srgbClr val="EEEEEE"/>
-      </a:lt2>
-      <a:accent1>
-        <a:srgbClr val="4285F4"/>
-      </a:accent1>
-      <a:accent2>
-        <a:srgbClr val="212121"/>
-      </a:accent2>
-      <a:accent3>
-        <a:srgbClr val="78909C"/>
-      </a:accent3>
-      <a:accent4>
-        <a:srgbClr val="FFAB40"/>
-      </a:accent4>
-      <a:accent5>
-        <a:srgbClr val="0097A7"/>
-      </a:accent5>
-      <a:accent6>
-        <a:srgbClr val="EEFF41"/>
-      </a:accent6>
-      <a:hlink>
-        <a:srgbClr val="0097A7"/>
-      </a:hlink>
-      <a:folHlink>
-        <a:srgbClr val="0097A7"/>
-      </a:folHlink>
-    </a:clrScheme>
-    <a:fontScheme name="Office">
-      <a:majorFont>
-        <a:latin typeface="Arial"/>
-        <a:ea typeface=""/>
-        <a:cs typeface=""/>
-        <a:font script="Jpan" typeface="ＭＳ Ｐゴシック"/>
-        <a:font script="Hang" typeface="맑은 고딕"/>
-        <a:font script="Hans" typeface="宋体"/>
-        <a:font script="Hant" typeface="新細明體"/>
-        <a:font script="Arab" typeface="Times New Roman"/>
-        <a:font script="Hebr" typeface="Times New Roman"/>
-        <a:font script="Thai" typeface="Angsana New"/>
-        <a:font script="Ethi" typeface="Nyala"/>
-        <a:font script="Beng" typeface="Vrinda"/>
-        <a:font script="Gujr" typeface="Shruti"/>
-        <a:font script="Khmr" typeface="MoolBoran"/>
-        <a:font script="Knda" typeface="Tunga"/>
-        <a:font script="Guru" typeface="Raavi"/>
-        <a:font script="Cans" typeface="Euphemia"/>
-        <a:font script="Cher" typeface="Plantagenet Cherokee"/>
-        <a:font script="Yiii" typeface="Microsoft Yi Baiti"/>
-        <a:font script="Tibt" typeface="Microsoft Himalaya"/>
-        <a:font script="Thaa" typeface="MV Boli"/>
-        <a:font script="Deva" typeface="Mangal"/>
-        <a:font script="Telu" typeface="Gautami"/>
-        <a:font script="Taml" typeface="Latha"/>
-        <a:font script="Syrc" typeface="Estrangelo Edessa"/>
-        <a:font script="Orya" typeface="Kalinga"/>
-        <a:font script="Mlym" typeface="Kartika"/>
-        <a:font script="Laoo" typeface="DokChampa"/>
-        <a:font script="Sinh" typeface="Iskoola Pota"/>
-        <a:font script="Mong" typeface="Mongolian Baiti"/>
-        <a:font script="Viet" typeface="Times New Roman"/>
-        <a:font script="Uigh" typeface="Microsoft Uighur"/>
-        <a:font script="Geor" typeface="Sylfaen"/>
-      </a:majorFont>
-      <a:minorFont>
-        <a:latin typeface="Arial"/>
-        <a:ea typeface=""/>
-        <a:cs typeface=""/>
-        <a:font script="Jpan" typeface="ＭＳ Ｐゴシック"/>
-        <a:font script="Hang" typeface="맑은 고딕"/>
-        <a:font script="Hans" typeface="宋体"/>
-        <a:font script="Hant" typeface="新細明體"/>
-        <a:font script="Arab" typeface="Arial"/>
-        <a:font script="Hebr" typeface="Arial"/>
-        <a:font script="Thai" typeface="Cordia New"/>
-        <a:font script="Ethi" typeface="Nyala"/>
-        <a:font script="Beng" typeface="Vrinda"/>
-        <a:font script="Gujr" typeface="Shruti"/>
-        <a:font script="Khmr" typeface="DaunPenh"/>
-        <a:font script="Knda" typeface="Tunga"/>
-        <a:font script="Guru" typeface="Raavi"/>
-        <a:font script="Cans" typeface="Euphemia"/>
-        <a:font script="Cher" typeface="Plantagenet Cherokee"/>
-        <a:font script="Yiii" typeface="Microsoft Yi Baiti"/>
-        <a:font script="Tibt" typeface="Microsoft Himalaya"/>
-        <a:font script="Thaa" typeface="MV Boli"/>
-        <a:font script="Deva" typeface="Mangal"/>
-        <a:font script="Telu" typeface="Gautami"/>
-        <a:font script="Taml" typeface="Latha"/>
-        <a:font script="Syrc" typeface="Estrangelo Edessa"/>
-        <a:font script="Orya" typeface="Kalinga"/>
-        <a:font script="Mlym" typeface="Kartika"/>
-        <a:font script="Laoo" typeface="DokChampa"/>
-        <a:font script="Sinh" typeface="Iskoola Pota"/>
-        <a:font script="Mong" typeface="Mongolian Baiti"/>
-        <a:font script="Viet" typeface="Arial"/>
-        <a:font script="Uigh" typeface="Microsoft Uighur"/>
-        <a:font script="Geor" typeface="Sylfaen"/>
-      </a:minorFont>
-    </a:fontScheme>
-    <a:fmtScheme name="Office">
-      <a:fillStyleLst>
-        <a:solidFill>
-          <a:schemeClr val="phClr"/>
-        </a:solidFill>
-        <a:gradFill rotWithShape="1">
-          <a:gsLst>
-            <a:gs pos="0">
-              <a:schemeClr val="phClr">
-                <a:tint val="50000"/>
-                <a:satMod val="300000"/>
-              </a:schemeClr>
-            </a:gs>
-            <a:gs pos="35000">
-              <a:schemeClr val="phClr">
-                <a:tint val="37000"/>
-                <a:satMod val="300000"/>
-              </a:schemeClr>
-            </a:gs>
-            <a:gs pos="100000">
-              <a:schemeClr val="phClr">
-                <a:tint val="15000"/>
-                <a:satMod val="350000"/>
-              </a:schemeClr>
-            </a:gs>
-          </a:gsLst>
-          <a:lin ang="16200000" scaled="1"/>
-        </a:gradFill>
-        <a:gradFill rotWithShape="1">
-          <a:gsLst>
-            <a:gs pos="0">
-              <a:schemeClr val="phClr">
-                <a:tint val="100000"/>
-                <a:shade val="100000"/>
-                <a:satMod val="130000"/>
-              </a:schemeClr>
-            </a:gs>
-            <a:gs pos="100000">
-              <a:schemeClr val="phClr">
-                <a:tint val="50000"/>
-                <a:shade val="100000"/>
-                <a:satMod val="350000"/>
-              </a:schemeClr>
-            </a:gs>
-          </a:gsLst>
-          <a:lin ang="16200000" scaled="0"/>
-        </a:gradFill>
-      </a:fillStyleLst>
-      <a:lnStyleLst>
-        <a:ln w="9525" cap="flat" cmpd="sng" algn="ctr">
-          <a:solidFill>
-            <a:schemeClr val="phClr">
-              <a:shade val="95000"/>
-              <a:satMod val="105000"/>
-            </a:schemeClr>
-          </a:solidFill>
-          <a:prstDash val="solid"/>
-        </a:ln>
-        <a:ln w="25400" cap="flat" cmpd="sng" algn="ctr">
-          <a:solidFill>
-            <a:schemeClr val="phClr"/>
-          </a:solidFill>
-          <a:prstDash val="solid"/>
-        </a:ln>
-        <a:ln w="38100" cap="flat" cmpd="sng" algn="ctr">
-          <a:solidFill>
-            <a:schemeClr val="phClr"/>
-          </a:solidFill>
-          <a:prstDash val="solid"/>
-        </a:ln>
-      </a:lnStyleLst>
-      <a:effectStyleLst>
-        <a:effectStyle>
-          <a:effectLst>
-            <a:outerShdw blurRad="40000" dist="20000" dir="5400000" rotWithShape="0">
-              <a:srgbClr val="000000">
-                <a:alpha val="38000"/>
-              </a:srgbClr>
-            </a:outerShdw>
-          </a:effectLst>
-        </a:effectStyle>
-        <a:effectStyle>
-          <a:effectLst>
-            <a:outerShdw blurRad="40000" dist="23000" dir="5400000" rotWithShape="0">
-              <a:srgbClr val="000000">
-                <a:alpha val="35000"/>
-              </a:srgbClr>
-            </a:outerShdw>
-          </a:effectLst>
-        </a:effectStyle>
-        <a:effectStyle>
-          <a:effectLst>
-            <a:outerShdw blurRad="40000" dist="23000" dir="5400000" rotWithShape="0">
-              <a:srgbClr val="000000">
-                <a:alpha val="35000"/>
-              </a:srgbClr>
-            </a:outerShdw>
-          </a:effectLst>
-          <a:scene3d>
-            <a:camera prst="orthographicFront">
-              <a:rot lat="0" lon="0" rev="0"/>
-            </a:camera>
-            <a:lightRig rig="threePt" dir="t">
-              <a:rot lat="0" lon="0" rev="1200000"/>
-            </a:lightRig>
-          </a:scene3d>
-          <a:sp3d>
-            <a:bevelT w="63500" h="25400"/>
-          </a:sp3d>
-        </a:effectStyle>
-      </a:effectStyleLst>
-      <a:bgFillStyleLst>
-        <a:solidFill>
-          <a:schemeClr val="phClr"/>
-        </a:solidFill>
-        <a:gradFill rotWithShape="1">
-          <a:gsLst>
-            <a:gs pos="0">
-              <a:schemeClr val="phClr">
-                <a:tint val="40000"/>
-                <a:satMod val="350000"/>
-              </a:schemeClr>
-            </a:gs>
-            <a:gs pos="40000">
-              <a:schemeClr val="phClr">
-                <a:tint val="45000"/>
-                <a:shade val="99000"/>
-                <a:satMod val="350000"/>
-              </a:schemeClr>
-            </a:gs>
-            <a:gs pos="100000">
-              <a:schemeClr val="phClr">
-                <a:shade val="20000"/>
-                <a:satMod val="255000"/>
-              </a:schemeClr>
-            </a:gs>
-          </a:gsLst>
-          <a:path path="circle">
-            <a:fillToRect l="50000" t="-80000" r="50000" b="180000"/>
-          </a:path>
-        </a:gradFill>
-        <a:gradFill rotWithShape="1">
-          <a:gsLst>
-            <a:gs pos="0">
-              <a:schemeClr val="phClr">
-                <a:tint val="80000"/>
-                <a:satMod val="300000"/>
-              </a:schemeClr>
-            </a:gs>
-            <a:gs pos="100000">
-              <a:schemeClr val="phClr">
-                <a:shade val="30000"/>
-                <a:satMod val="200000"/>
-              </a:schemeClr>
-            </a:gs>
-          </a:gsLst>
-          <a:path path="circle">
-            <a:fillToRect l="50000" t="50000" r="50000" b="50000"/>
-          </a:path>
-        </a:gradFill>
-      </a:bgFillStyleLst>
-    </a:fmtScheme>
-  </a:themeElements>
-</a:theme>
 </file>
</xml_diff>

<commit_message>
Update Data Sources from LFX 2026-09-07 (#301)
Update Data Sources from LFX

Signed-off-by: github-actions[bot] <41898282+github-actions[bot]@users.noreply.github.com>
</commit_message>
<xml_diff>
--- a/overview_deck/LF Energy High Level Overview.pptx
+++ b/overview_deck/LF Energy High Level Overview.pptx
@@ -25946,7 +25946,7 @@
             <a:tbl>
               <a:tblPr>
                 <a:noFill/>
-                <a:tableStyleId>{F37AABCB-8023-49C7-A8FB-B28CF5C3E58C}</a:tableStyleId>
+                <a:tableStyleId>{725460A2-16E6-4345-8395-7449A917BFE6}</a:tableStyleId>
               </a:tblPr>
               <a:tblGrid>
                 <a:gridCol w="1695200"/>
@@ -26736,7 +26736,7 @@
             <a:tbl>
               <a:tblPr>
                 <a:noFill/>
-                <a:tableStyleId>{F37AABCB-8023-49C7-A8FB-B28CF5C3E58C}</a:tableStyleId>
+                <a:tableStyleId>{725460A2-16E6-4345-8395-7449A917BFE6}</a:tableStyleId>
               </a:tblPr>
               <a:tblGrid>
                 <a:gridCol w="1695200"/>
@@ -27426,7 +27426,7 @@
             <a:tbl>
               <a:tblPr>
                 <a:noFill/>
-                <a:tableStyleId>{F37AABCB-8023-49C7-A8FB-B28CF5C3E58C}</a:tableStyleId>
+                <a:tableStyleId>{725460A2-16E6-4345-8395-7449A917BFE6}</a:tableStyleId>
               </a:tblPr>
               <a:tblGrid>
                 <a:gridCol w="1695200"/>
@@ -28678,7 +28678,7 @@
             <a:tbl>
               <a:tblPr>
                 <a:noFill/>
-                <a:tableStyleId>{F37AABCB-8023-49C7-A8FB-B28CF5C3E58C}</a:tableStyleId>
+                <a:tableStyleId>{725460A2-16E6-4345-8395-7449A917BFE6}</a:tableStyleId>
               </a:tblPr>
               <a:tblGrid>
                 <a:gridCol w="1695200"/>
@@ -29670,7 +29670,7 @@
             <a:tbl>
               <a:tblPr>
                 <a:noFill/>
-                <a:tableStyleId>{F37AABCB-8023-49C7-A8FB-B28CF5C3E58C}</a:tableStyleId>
+                <a:tableStyleId>{725460A2-16E6-4345-8395-7449A917BFE6}</a:tableStyleId>
               </a:tblPr>
               <a:tblGrid>
                 <a:gridCol w="3048000"/>
@@ -33175,7 +33175,7 @@
             <a:tbl>
               <a:tblPr>
                 <a:noFill/>
-                <a:tableStyleId>{F37AABCB-8023-49C7-A8FB-B28CF5C3E58C}</a:tableStyleId>
+                <a:tableStyleId>{725460A2-16E6-4345-8395-7449A917BFE6}</a:tableStyleId>
               </a:tblPr>
               <a:tblGrid>
                 <a:gridCol w="1828800"/>
@@ -34002,6 +34002,285 @@
 </file>
 
 <file path=ppt/theme/theme1.xml><?xml version="1.0" encoding="utf-8"?>
+<a:theme xmlns:a="http://schemas.openxmlformats.org/drawingml/2006/main" xmlns:r="http://schemas.openxmlformats.org/officeDocument/2006/relationships" name="LF Energy Theme 2023">
+  <a:themeElements>
+    <a:clrScheme name="Geometric">
+      <a:dk1>
+        <a:srgbClr val="222222"/>
+      </a:dk1>
+      <a:lt1>
+        <a:srgbClr val="FFFFFF"/>
+      </a:lt1>
+      <a:dk2>
+        <a:srgbClr val="434343"/>
+      </a:dk2>
+      <a:lt2>
+        <a:srgbClr val="999999"/>
+      </a:lt2>
+      <a:accent1>
+        <a:srgbClr val="003778"/>
+      </a:accent1>
+      <a:accent2>
+        <a:srgbClr val="0094FF"/>
+      </a:accent2>
+      <a:accent3>
+        <a:srgbClr val="5B1DE7"/>
+      </a:accent3>
+      <a:accent4>
+        <a:srgbClr val="12E2E2"/>
+      </a:accent4>
+      <a:accent5>
+        <a:srgbClr val="FF00AA"/>
+      </a:accent5>
+      <a:accent6>
+        <a:srgbClr val="ACDE1F"/>
+      </a:accent6>
+      <a:hlink>
+        <a:srgbClr val="0077CC"/>
+      </a:hlink>
+      <a:folHlink>
+        <a:srgbClr val="F06292"/>
+      </a:folHlink>
+    </a:clrScheme>
+    <a:fontScheme name="Office">
+      <a:majorFont>
+        <a:latin typeface="Arial"/>
+        <a:ea typeface=""/>
+        <a:cs typeface=""/>
+        <a:font script="Jpan" typeface="ＭＳ Ｐゴシック"/>
+        <a:font script="Hang" typeface="맑은 고딕"/>
+        <a:font script="Hans" typeface="宋体"/>
+        <a:font script="Hant" typeface="新細明體"/>
+        <a:font script="Arab" typeface="Times New Roman"/>
+        <a:font script="Hebr" typeface="Times New Roman"/>
+        <a:font script="Thai" typeface="Angsana New"/>
+        <a:font script="Ethi" typeface="Nyala"/>
+        <a:font script="Beng" typeface="Vrinda"/>
+        <a:font script="Gujr" typeface="Shruti"/>
+        <a:font script="Khmr" typeface="MoolBoran"/>
+        <a:font script="Knda" typeface="Tunga"/>
+        <a:font script="Guru" typeface="Raavi"/>
+        <a:font script="Cans" typeface="Euphemia"/>
+        <a:font script="Cher" typeface="Plantagenet Cherokee"/>
+        <a:font script="Yiii" typeface="Microsoft Yi Baiti"/>
+        <a:font script="Tibt" typeface="Microsoft Himalaya"/>
+        <a:font script="Thaa" typeface="MV Boli"/>
+        <a:font script="Deva" typeface="Mangal"/>
+        <a:font script="Telu" typeface="Gautami"/>
+        <a:font script="Taml" typeface="Latha"/>
+        <a:font script="Syrc" typeface="Estrangelo Edessa"/>
+        <a:font script="Orya" typeface="Kalinga"/>
+        <a:font script="Mlym" typeface="Kartika"/>
+        <a:font script="Laoo" typeface="DokChampa"/>
+        <a:font script="Sinh" typeface="Iskoola Pota"/>
+        <a:font script="Mong" typeface="Mongolian Baiti"/>
+        <a:font script="Viet" typeface="Times New Roman"/>
+        <a:font script="Uigh" typeface="Microsoft Uighur"/>
+        <a:font script="Geor" typeface="Sylfaen"/>
+      </a:majorFont>
+      <a:minorFont>
+        <a:latin typeface="Arial"/>
+        <a:ea typeface=""/>
+        <a:cs typeface=""/>
+        <a:font script="Jpan" typeface="ＭＳ Ｐゴシック"/>
+        <a:font script="Hang" typeface="맑은 고딕"/>
+        <a:font script="Hans" typeface="宋体"/>
+        <a:font script="Hant" typeface="新細明體"/>
+        <a:font script="Arab" typeface="Arial"/>
+        <a:font script="Hebr" typeface="Arial"/>
+        <a:font script="Thai" typeface="Cordia New"/>
+        <a:font script="Ethi" typeface="Nyala"/>
+        <a:font script="Beng" typeface="Vrinda"/>
+        <a:font script="Gujr" typeface="Shruti"/>
+        <a:font script="Khmr" typeface="DaunPenh"/>
+        <a:font script="Knda" typeface="Tunga"/>
+        <a:font script="Guru" typeface="Raavi"/>
+        <a:font script="Cans" typeface="Euphemia"/>
+        <a:font script="Cher" typeface="Plantagenet Cherokee"/>
+        <a:font script="Yiii" typeface="Microsoft Yi Baiti"/>
+        <a:font script="Tibt" typeface="Microsoft Himalaya"/>
+        <a:font script="Thaa" typeface="MV Boli"/>
+        <a:font script="Deva" typeface="Mangal"/>
+        <a:font script="Telu" typeface="Gautami"/>
+        <a:font script="Taml" typeface="Latha"/>
+        <a:font script="Syrc" typeface="Estrangelo Edessa"/>
+        <a:font script="Orya" typeface="Kalinga"/>
+        <a:font script="Mlym" typeface="Kartika"/>
+        <a:font script="Laoo" typeface="DokChampa"/>
+        <a:font script="Sinh" typeface="Iskoola Pota"/>
+        <a:font script="Mong" typeface="Mongolian Baiti"/>
+        <a:font script="Viet" typeface="Arial"/>
+        <a:font script="Uigh" typeface="Microsoft Uighur"/>
+        <a:font script="Geor" typeface="Sylfaen"/>
+      </a:minorFont>
+    </a:fontScheme>
+    <a:fmtScheme name="Office">
+      <a:fillStyleLst>
+        <a:solidFill>
+          <a:schemeClr val="phClr"/>
+        </a:solidFill>
+        <a:gradFill rotWithShape="1">
+          <a:gsLst>
+            <a:gs pos="0">
+              <a:schemeClr val="phClr">
+                <a:tint val="50000"/>
+                <a:satMod val="300000"/>
+              </a:schemeClr>
+            </a:gs>
+            <a:gs pos="35000">
+              <a:schemeClr val="phClr">
+                <a:tint val="37000"/>
+                <a:satMod val="300000"/>
+              </a:schemeClr>
+            </a:gs>
+            <a:gs pos="100000">
+              <a:schemeClr val="phClr">
+                <a:tint val="15000"/>
+                <a:satMod val="350000"/>
+              </a:schemeClr>
+            </a:gs>
+          </a:gsLst>
+          <a:lin ang="16200000" scaled="1"/>
+        </a:gradFill>
+        <a:gradFill rotWithShape="1">
+          <a:gsLst>
+            <a:gs pos="0">
+              <a:schemeClr val="phClr">
+                <a:tint val="100000"/>
+                <a:shade val="100000"/>
+                <a:satMod val="130000"/>
+              </a:schemeClr>
+            </a:gs>
+            <a:gs pos="100000">
+              <a:schemeClr val="phClr">
+                <a:tint val="50000"/>
+                <a:shade val="100000"/>
+                <a:satMod val="350000"/>
+              </a:schemeClr>
+            </a:gs>
+          </a:gsLst>
+          <a:lin ang="16200000" scaled="0"/>
+        </a:gradFill>
+      </a:fillStyleLst>
+      <a:lnStyleLst>
+        <a:ln w="9525" cap="flat" cmpd="sng" algn="ctr">
+          <a:solidFill>
+            <a:schemeClr val="phClr">
+              <a:shade val="95000"/>
+              <a:satMod val="105000"/>
+            </a:schemeClr>
+          </a:solidFill>
+          <a:prstDash val="solid"/>
+        </a:ln>
+        <a:ln w="25400" cap="flat" cmpd="sng" algn="ctr">
+          <a:solidFill>
+            <a:schemeClr val="phClr"/>
+          </a:solidFill>
+          <a:prstDash val="solid"/>
+        </a:ln>
+        <a:ln w="38100" cap="flat" cmpd="sng" algn="ctr">
+          <a:solidFill>
+            <a:schemeClr val="phClr"/>
+          </a:solidFill>
+          <a:prstDash val="solid"/>
+        </a:ln>
+      </a:lnStyleLst>
+      <a:effectStyleLst>
+        <a:effectStyle>
+          <a:effectLst>
+            <a:outerShdw blurRad="40000" dist="20000" dir="5400000" rotWithShape="0">
+              <a:srgbClr val="000000">
+                <a:alpha val="38000"/>
+              </a:srgbClr>
+            </a:outerShdw>
+          </a:effectLst>
+        </a:effectStyle>
+        <a:effectStyle>
+          <a:effectLst>
+            <a:outerShdw blurRad="40000" dist="23000" dir="5400000" rotWithShape="0">
+              <a:srgbClr val="000000">
+                <a:alpha val="35000"/>
+              </a:srgbClr>
+            </a:outerShdw>
+          </a:effectLst>
+        </a:effectStyle>
+        <a:effectStyle>
+          <a:effectLst>
+            <a:outerShdw blurRad="40000" dist="23000" dir="5400000" rotWithShape="0">
+              <a:srgbClr val="000000">
+                <a:alpha val="35000"/>
+              </a:srgbClr>
+            </a:outerShdw>
+          </a:effectLst>
+          <a:scene3d>
+            <a:camera prst="orthographicFront">
+              <a:rot lat="0" lon="0" rev="0"/>
+            </a:camera>
+            <a:lightRig rig="threePt" dir="t">
+              <a:rot lat="0" lon="0" rev="1200000"/>
+            </a:lightRig>
+          </a:scene3d>
+          <a:sp3d>
+            <a:bevelT w="63500" h="25400"/>
+          </a:sp3d>
+        </a:effectStyle>
+      </a:effectStyleLst>
+      <a:bgFillStyleLst>
+        <a:solidFill>
+          <a:schemeClr val="phClr"/>
+        </a:solidFill>
+        <a:gradFill rotWithShape="1">
+          <a:gsLst>
+            <a:gs pos="0">
+              <a:schemeClr val="phClr">
+                <a:tint val="40000"/>
+                <a:satMod val="350000"/>
+              </a:schemeClr>
+            </a:gs>
+            <a:gs pos="40000">
+              <a:schemeClr val="phClr">
+                <a:tint val="45000"/>
+                <a:shade val="99000"/>
+                <a:satMod val="350000"/>
+              </a:schemeClr>
+            </a:gs>
+            <a:gs pos="100000">
+              <a:schemeClr val="phClr">
+                <a:shade val="20000"/>
+                <a:satMod val="255000"/>
+              </a:schemeClr>
+            </a:gs>
+          </a:gsLst>
+          <a:path path="circle">
+            <a:fillToRect l="50000" t="-80000" r="50000" b="180000"/>
+          </a:path>
+        </a:gradFill>
+        <a:gradFill rotWithShape="1">
+          <a:gsLst>
+            <a:gs pos="0">
+              <a:schemeClr val="phClr">
+                <a:tint val="80000"/>
+                <a:satMod val="300000"/>
+              </a:schemeClr>
+            </a:gs>
+            <a:gs pos="100000">
+              <a:schemeClr val="phClr">
+                <a:shade val="30000"/>
+                <a:satMod val="200000"/>
+              </a:schemeClr>
+            </a:gs>
+          </a:gsLst>
+          <a:path path="circle">
+            <a:fillToRect l="50000" t="50000" r="50000" b="50000"/>
+          </a:path>
+        </a:gradFill>
+      </a:bgFillStyleLst>
+    </a:fmtScheme>
+  </a:themeElements>
+</a:theme>
+</file>
+
+<file path=ppt/theme/theme2.xml><?xml version="1.0" encoding="utf-8"?>
 <a:theme xmlns:a="http://schemas.openxmlformats.org/drawingml/2006/main" xmlns:r="http://schemas.openxmlformats.org/officeDocument/2006/relationships" name="Simple Light">
   <a:themeElements>
     <a:clrScheme name="Simple Light">
@@ -34280,7 +34559,7 @@
 </a:theme>
 </file>
 
-<file path=ppt/theme/theme2.xml><?xml version="1.0" encoding="utf-8"?>
+<file path=ppt/theme/theme3.xml><?xml version="1.0" encoding="utf-8"?>
 <a:theme xmlns:a="http://schemas.openxmlformats.org/drawingml/2006/main" xmlns:r="http://schemas.openxmlformats.org/officeDocument/2006/relationships">
   <a:themeElements>
     <a:clrScheme name="Default">
@@ -34557,283 +34836,4 @@
     </a:fmtScheme>
   </a:themeElements>
 </a:theme>
-</file>
-
-<file path=ppt/theme/theme3.xml><?xml version="1.0" encoding="utf-8"?>
-<a:theme xmlns:a="http://schemas.openxmlformats.org/drawingml/2006/main" xmlns:r="http://schemas.openxmlformats.org/officeDocument/2006/relationships" name="LF Energy Theme 2023">
-  <a:themeElements>
-    <a:clrScheme name="Geometric">
-      <a:dk1>
-        <a:srgbClr val="222222"/>
-      </a:dk1>
-      <a:lt1>
-        <a:srgbClr val="FFFFFF"/>
-      </a:lt1>
-      <a:dk2>
-        <a:srgbClr val="434343"/>
-      </a:dk2>
-      <a:lt2>
-        <a:srgbClr val="999999"/>
-      </a:lt2>
-      <a:accent1>
-        <a:srgbClr val="003778"/>
-      </a:accent1>
-      <a:accent2>
-        <a:srgbClr val="0094FF"/>
-      </a:accent2>
-      <a:accent3>
-        <a:srgbClr val="5B1DE7"/>
-      </a:accent3>
-      <a:accent4>
-        <a:srgbClr val="12E2E2"/>
-      </a:accent4>
-      <a:accent5>
-        <a:srgbClr val="FF00AA"/>
-      </a:accent5>
-      <a:accent6>
-        <a:srgbClr val="ACDE1F"/>
-      </a:accent6>
-      <a:hlink>
-        <a:srgbClr val="0077CC"/>
-      </a:hlink>
-      <a:folHlink>
-        <a:srgbClr val="F06292"/>
-      </a:folHlink>
-    </a:clrScheme>
-    <a:fontScheme name="Office">
-      <a:majorFont>
-        <a:latin typeface="Arial"/>
-        <a:ea typeface=""/>
-        <a:cs typeface=""/>
-        <a:font script="Jpan" typeface="ＭＳ Ｐゴシック"/>
-        <a:font script="Hang" typeface="맑은 고딕"/>
-        <a:font script="Hans" typeface="宋体"/>
-        <a:font script="Hant" typeface="新細明體"/>
-        <a:font script="Arab" typeface="Times New Roman"/>
-        <a:font script="Hebr" typeface="Times New Roman"/>
-        <a:font script="Thai" typeface="Angsana New"/>
-        <a:font script="Ethi" typeface="Nyala"/>
-        <a:font script="Beng" typeface="Vrinda"/>
-        <a:font script="Gujr" typeface="Shruti"/>
-        <a:font script="Khmr" typeface="MoolBoran"/>
-        <a:font script="Knda" typeface="Tunga"/>
-        <a:font script="Guru" typeface="Raavi"/>
-        <a:font script="Cans" typeface="Euphemia"/>
-        <a:font script="Cher" typeface="Plantagenet Cherokee"/>
-        <a:font script="Yiii" typeface="Microsoft Yi Baiti"/>
-        <a:font script="Tibt" typeface="Microsoft Himalaya"/>
-        <a:font script="Thaa" typeface="MV Boli"/>
-        <a:font script="Deva" typeface="Mangal"/>
-        <a:font script="Telu" typeface="Gautami"/>
-        <a:font script="Taml" typeface="Latha"/>
-        <a:font script="Syrc" typeface="Estrangelo Edessa"/>
-        <a:font script="Orya" typeface="Kalinga"/>
-        <a:font script="Mlym" typeface="Kartika"/>
-        <a:font script="Laoo" typeface="DokChampa"/>
-        <a:font script="Sinh" typeface="Iskoola Pota"/>
-        <a:font script="Mong" typeface="Mongolian Baiti"/>
-        <a:font script="Viet" typeface="Times New Roman"/>
-        <a:font script="Uigh" typeface="Microsoft Uighur"/>
-        <a:font script="Geor" typeface="Sylfaen"/>
-      </a:majorFont>
-      <a:minorFont>
-        <a:latin typeface="Arial"/>
-        <a:ea typeface=""/>
-        <a:cs typeface=""/>
-        <a:font script="Jpan" typeface="ＭＳ Ｐゴシック"/>
-        <a:font script="Hang" typeface="맑은 고딕"/>
-        <a:font script="Hans" typeface="宋体"/>
-        <a:font script="Hant" typeface="新細明體"/>
-        <a:font script="Arab" typeface="Arial"/>
-        <a:font script="Hebr" typeface="Arial"/>
-        <a:font script="Thai" typeface="Cordia New"/>
-        <a:font script="Ethi" typeface="Nyala"/>
-        <a:font script="Beng" typeface="Vrinda"/>
-        <a:font script="Gujr" typeface="Shruti"/>
-        <a:font script="Khmr" typeface="DaunPenh"/>
-        <a:font script="Knda" typeface="Tunga"/>
-        <a:font script="Guru" typeface="Raavi"/>
-        <a:font script="Cans" typeface="Euphemia"/>
-        <a:font script="Cher" typeface="Plantagenet Cherokee"/>
-        <a:font script="Yiii" typeface="Microsoft Yi Baiti"/>
-        <a:font script="Tibt" typeface="Microsoft Himalaya"/>
-        <a:font script="Thaa" typeface="MV Boli"/>
-        <a:font script="Deva" typeface="Mangal"/>
-        <a:font script="Telu" typeface="Gautami"/>
-        <a:font script="Taml" typeface="Latha"/>
-        <a:font script="Syrc" typeface="Estrangelo Edessa"/>
-        <a:font script="Orya" typeface="Kalinga"/>
-        <a:font script="Mlym" typeface="Kartika"/>
-        <a:font script="Laoo" typeface="DokChampa"/>
-        <a:font script="Sinh" typeface="Iskoola Pota"/>
-        <a:font script="Mong" typeface="Mongolian Baiti"/>
-        <a:font script="Viet" typeface="Arial"/>
-        <a:font script="Uigh" typeface="Microsoft Uighur"/>
-        <a:font script="Geor" typeface="Sylfaen"/>
-      </a:minorFont>
-    </a:fontScheme>
-    <a:fmtScheme name="Office">
-      <a:fillStyleLst>
-        <a:solidFill>
-          <a:schemeClr val="phClr"/>
-        </a:solidFill>
-        <a:gradFill rotWithShape="1">
-          <a:gsLst>
-            <a:gs pos="0">
-              <a:schemeClr val="phClr">
-                <a:tint val="50000"/>
-                <a:satMod val="300000"/>
-              </a:schemeClr>
-            </a:gs>
-            <a:gs pos="35000">
-              <a:schemeClr val="phClr">
-                <a:tint val="37000"/>
-                <a:satMod val="300000"/>
-              </a:schemeClr>
-            </a:gs>
-            <a:gs pos="100000">
-              <a:schemeClr val="phClr">
-                <a:tint val="15000"/>
-                <a:satMod val="350000"/>
-              </a:schemeClr>
-            </a:gs>
-          </a:gsLst>
-          <a:lin ang="16200000" scaled="1"/>
-        </a:gradFill>
-        <a:gradFill rotWithShape="1">
-          <a:gsLst>
-            <a:gs pos="0">
-              <a:schemeClr val="phClr">
-                <a:tint val="100000"/>
-                <a:shade val="100000"/>
-                <a:satMod val="130000"/>
-              </a:schemeClr>
-            </a:gs>
-            <a:gs pos="100000">
-              <a:schemeClr val="phClr">
-                <a:tint val="50000"/>
-                <a:shade val="100000"/>
-                <a:satMod val="350000"/>
-              </a:schemeClr>
-            </a:gs>
-          </a:gsLst>
-          <a:lin ang="16200000" scaled="0"/>
-        </a:gradFill>
-      </a:fillStyleLst>
-      <a:lnStyleLst>
-        <a:ln w="9525" cap="flat" cmpd="sng" algn="ctr">
-          <a:solidFill>
-            <a:schemeClr val="phClr">
-              <a:shade val="95000"/>
-              <a:satMod val="105000"/>
-            </a:schemeClr>
-          </a:solidFill>
-          <a:prstDash val="solid"/>
-        </a:ln>
-        <a:ln w="25400" cap="flat" cmpd="sng" algn="ctr">
-          <a:solidFill>
-            <a:schemeClr val="phClr"/>
-          </a:solidFill>
-          <a:prstDash val="solid"/>
-        </a:ln>
-        <a:ln w="38100" cap="flat" cmpd="sng" algn="ctr">
-          <a:solidFill>
-            <a:schemeClr val="phClr"/>
-          </a:solidFill>
-          <a:prstDash val="solid"/>
-        </a:ln>
-      </a:lnStyleLst>
-      <a:effectStyleLst>
-        <a:effectStyle>
-          <a:effectLst>
-            <a:outerShdw blurRad="40000" dist="20000" dir="5400000" rotWithShape="0">
-              <a:srgbClr val="000000">
-                <a:alpha val="38000"/>
-              </a:srgbClr>
-            </a:outerShdw>
-          </a:effectLst>
-        </a:effectStyle>
-        <a:effectStyle>
-          <a:effectLst>
-            <a:outerShdw blurRad="40000" dist="23000" dir="5400000" rotWithShape="0">
-              <a:srgbClr val="000000">
-                <a:alpha val="35000"/>
-              </a:srgbClr>
-            </a:outerShdw>
-          </a:effectLst>
-        </a:effectStyle>
-        <a:effectStyle>
-          <a:effectLst>
-            <a:outerShdw blurRad="40000" dist="23000" dir="5400000" rotWithShape="0">
-              <a:srgbClr val="000000">
-                <a:alpha val="35000"/>
-              </a:srgbClr>
-            </a:outerShdw>
-          </a:effectLst>
-          <a:scene3d>
-            <a:camera prst="orthographicFront">
-              <a:rot lat="0" lon="0" rev="0"/>
-            </a:camera>
-            <a:lightRig rig="threePt" dir="t">
-              <a:rot lat="0" lon="0" rev="1200000"/>
-            </a:lightRig>
-          </a:scene3d>
-          <a:sp3d>
-            <a:bevelT w="63500" h="25400"/>
-          </a:sp3d>
-        </a:effectStyle>
-      </a:effectStyleLst>
-      <a:bgFillStyleLst>
-        <a:solidFill>
-          <a:schemeClr val="phClr"/>
-        </a:solidFill>
-        <a:gradFill rotWithShape="1">
-          <a:gsLst>
-            <a:gs pos="0">
-              <a:schemeClr val="phClr">
-                <a:tint val="40000"/>
-                <a:satMod val="350000"/>
-              </a:schemeClr>
-            </a:gs>
-            <a:gs pos="40000">
-              <a:schemeClr val="phClr">
-                <a:tint val="45000"/>
-                <a:shade val="99000"/>
-                <a:satMod val="350000"/>
-              </a:schemeClr>
-            </a:gs>
-            <a:gs pos="100000">
-              <a:schemeClr val="phClr">
-                <a:shade val="20000"/>
-                <a:satMod val="255000"/>
-              </a:schemeClr>
-            </a:gs>
-          </a:gsLst>
-          <a:path path="circle">
-            <a:fillToRect l="50000" t="-80000" r="50000" b="180000"/>
-          </a:path>
-        </a:gradFill>
-        <a:gradFill rotWithShape="1">
-          <a:gsLst>
-            <a:gs pos="0">
-              <a:schemeClr val="phClr">
-                <a:tint val="80000"/>
-                <a:satMod val="300000"/>
-              </a:schemeClr>
-            </a:gs>
-            <a:gs pos="100000">
-              <a:schemeClr val="phClr">
-                <a:shade val="30000"/>
-                <a:satMod val="200000"/>
-              </a:schemeClr>
-            </a:gs>
-          </a:gsLst>
-          <a:path path="circle">
-            <a:fillToRect l="50000" t="50000" r="50000" b="50000"/>
-          </a:path>
-        </a:gradFill>
-      </a:bgFillStyleLst>
-    </a:fmtScheme>
-  </a:themeElements>
-</a:theme>
 </file>
</xml_diff>

<commit_message>
Update Data Sources from LFX 2026-09-08 (#302)
Update Data Sources from LFX

Signed-off-by: github-actions[bot] <41898282+github-actions[bot]@users.noreply.github.com>
</commit_message>
<xml_diff>
--- a/overview_deck/LF Energy High Level Overview.pptx
+++ b/overview_deck/LF Energy High Level Overview.pptx
@@ -25946,7 +25946,7 @@
             <a:tbl>
               <a:tblPr>
                 <a:noFill/>
-                <a:tableStyleId>{725460A2-16E6-4345-8395-7449A917BFE6}</a:tableStyleId>
+                <a:tableStyleId>{6E5ADE8E-6630-4EA3-99C8-5FA4D6AC2806}</a:tableStyleId>
               </a:tblPr>
               <a:tblGrid>
                 <a:gridCol w="1695200"/>
@@ -26736,7 +26736,7 @@
             <a:tbl>
               <a:tblPr>
                 <a:noFill/>
-                <a:tableStyleId>{725460A2-16E6-4345-8395-7449A917BFE6}</a:tableStyleId>
+                <a:tableStyleId>{6E5ADE8E-6630-4EA3-99C8-5FA4D6AC2806}</a:tableStyleId>
               </a:tblPr>
               <a:tblGrid>
                 <a:gridCol w="1695200"/>
@@ -27426,7 +27426,7 @@
             <a:tbl>
               <a:tblPr>
                 <a:noFill/>
-                <a:tableStyleId>{725460A2-16E6-4345-8395-7449A917BFE6}</a:tableStyleId>
+                <a:tableStyleId>{6E5ADE8E-6630-4EA3-99C8-5FA4D6AC2806}</a:tableStyleId>
               </a:tblPr>
               <a:tblGrid>
                 <a:gridCol w="1695200"/>
@@ -28678,7 +28678,7 @@
             <a:tbl>
               <a:tblPr>
                 <a:noFill/>
-                <a:tableStyleId>{725460A2-16E6-4345-8395-7449A917BFE6}</a:tableStyleId>
+                <a:tableStyleId>{6E5ADE8E-6630-4EA3-99C8-5FA4D6AC2806}</a:tableStyleId>
               </a:tblPr>
               <a:tblGrid>
                 <a:gridCol w="1695200"/>
@@ -29670,7 +29670,7 @@
             <a:tbl>
               <a:tblPr>
                 <a:noFill/>
-                <a:tableStyleId>{725460A2-16E6-4345-8395-7449A917BFE6}</a:tableStyleId>
+                <a:tableStyleId>{6E5ADE8E-6630-4EA3-99C8-5FA4D6AC2806}</a:tableStyleId>
               </a:tblPr>
               <a:tblGrid>
                 <a:gridCol w="3048000"/>
@@ -33175,7 +33175,7 @@
             <a:tbl>
               <a:tblPr>
                 <a:noFill/>
-                <a:tableStyleId>{725460A2-16E6-4345-8395-7449A917BFE6}</a:tableStyleId>
+                <a:tableStyleId>{6E5ADE8E-6630-4EA3-99C8-5FA4D6AC2806}</a:tableStyleId>
               </a:tblPr>
               <a:tblGrid>
                 <a:gridCol w="1828800"/>
@@ -34002,44 +34002,44 @@
 </file>
 
 <file path=ppt/theme/theme1.xml><?xml version="1.0" encoding="utf-8"?>
-<a:theme xmlns:a="http://schemas.openxmlformats.org/drawingml/2006/main" xmlns:r="http://schemas.openxmlformats.org/officeDocument/2006/relationships" name="LF Energy Theme 2023">
+<a:theme xmlns:a="http://schemas.openxmlformats.org/drawingml/2006/main" xmlns:r="http://schemas.openxmlformats.org/officeDocument/2006/relationships">
   <a:themeElements>
-    <a:clrScheme name="Geometric">
+    <a:clrScheme name="Default">
       <a:dk1>
-        <a:srgbClr val="222222"/>
+        <a:srgbClr val="000000"/>
       </a:dk1>
       <a:lt1>
         <a:srgbClr val="FFFFFF"/>
       </a:lt1>
       <a:dk2>
-        <a:srgbClr val="434343"/>
+        <a:srgbClr val="158158"/>
       </a:dk2>
       <a:lt2>
-        <a:srgbClr val="999999"/>
+        <a:srgbClr val="F3F3F3"/>
       </a:lt2>
       <a:accent1>
-        <a:srgbClr val="003778"/>
+        <a:srgbClr val="058DC7"/>
       </a:accent1>
       <a:accent2>
-        <a:srgbClr val="0094FF"/>
+        <a:srgbClr val="50B432"/>
       </a:accent2>
       <a:accent3>
-        <a:srgbClr val="5B1DE7"/>
+        <a:srgbClr val="ED561B"/>
       </a:accent3>
       <a:accent4>
-        <a:srgbClr val="12E2E2"/>
+        <a:srgbClr val="EDEF00"/>
       </a:accent4>
       <a:accent5>
-        <a:srgbClr val="FF00AA"/>
+        <a:srgbClr val="24CBE5"/>
       </a:accent5>
       <a:accent6>
-        <a:srgbClr val="ACDE1F"/>
+        <a:srgbClr val="64E572"/>
       </a:accent6>
       <a:hlink>
-        <a:srgbClr val="0077CC"/>
+        <a:srgbClr val="2200CC"/>
       </a:hlink>
       <a:folHlink>
-        <a:srgbClr val="F06292"/>
+        <a:srgbClr val="551A8B"/>
       </a:folHlink>
     </a:clrScheme>
     <a:fontScheme name="Office">
@@ -34560,44 +34560,44 @@
 </file>
 
 <file path=ppt/theme/theme3.xml><?xml version="1.0" encoding="utf-8"?>
-<a:theme xmlns:a="http://schemas.openxmlformats.org/drawingml/2006/main" xmlns:r="http://schemas.openxmlformats.org/officeDocument/2006/relationships">
+<a:theme xmlns:a="http://schemas.openxmlformats.org/drawingml/2006/main" xmlns:r="http://schemas.openxmlformats.org/officeDocument/2006/relationships" name="LF Energy Theme 2023">
   <a:themeElements>
-    <a:clrScheme name="Default">
+    <a:clrScheme name="Geometric">
       <a:dk1>
-        <a:srgbClr val="000000"/>
+        <a:srgbClr val="222222"/>
       </a:dk1>
       <a:lt1>
         <a:srgbClr val="FFFFFF"/>
       </a:lt1>
       <a:dk2>
-        <a:srgbClr val="158158"/>
+        <a:srgbClr val="434343"/>
       </a:dk2>
       <a:lt2>
-        <a:srgbClr val="F3F3F3"/>
+        <a:srgbClr val="999999"/>
       </a:lt2>
       <a:accent1>
-        <a:srgbClr val="058DC7"/>
+        <a:srgbClr val="003778"/>
       </a:accent1>
       <a:accent2>
-        <a:srgbClr val="50B432"/>
+        <a:srgbClr val="0094FF"/>
       </a:accent2>
       <a:accent3>
-        <a:srgbClr val="ED561B"/>
+        <a:srgbClr val="5B1DE7"/>
       </a:accent3>
       <a:accent4>
-        <a:srgbClr val="EDEF00"/>
+        <a:srgbClr val="12E2E2"/>
       </a:accent4>
       <a:accent5>
-        <a:srgbClr val="24CBE5"/>
+        <a:srgbClr val="FF00AA"/>
       </a:accent5>
       <a:accent6>
-        <a:srgbClr val="64E572"/>
+        <a:srgbClr val="ACDE1F"/>
       </a:accent6>
       <a:hlink>
-        <a:srgbClr val="2200CC"/>
+        <a:srgbClr val="0077CC"/>
       </a:hlink>
       <a:folHlink>
-        <a:srgbClr val="551A8B"/>
+        <a:srgbClr val="F06292"/>
       </a:folHlink>
     </a:clrScheme>
     <a:fontScheme name="Office">

</xml_diff>

<commit_message>
Update Data Sources from LFX 2026-09-09 (#303)
Update Data Sources from LFX

Signed-off-by: github-actions[bot] <41898282+github-actions[bot]@users.noreply.github.com>
</commit_message>
<xml_diff>
--- a/overview_deck/LF Energy High Level Overview.pptx
+++ b/overview_deck/LF Energy High Level Overview.pptx
@@ -25946,7 +25946,7 @@
             <a:tbl>
               <a:tblPr>
                 <a:noFill/>
-                <a:tableStyleId>{6E5ADE8E-6630-4EA3-99C8-5FA4D6AC2806}</a:tableStyleId>
+                <a:tableStyleId>{C15442DE-9166-4A00-B985-3162F5EA9497}</a:tableStyleId>
               </a:tblPr>
               <a:tblGrid>
                 <a:gridCol w="1695200"/>
@@ -26736,7 +26736,7 @@
             <a:tbl>
               <a:tblPr>
                 <a:noFill/>
-                <a:tableStyleId>{6E5ADE8E-6630-4EA3-99C8-5FA4D6AC2806}</a:tableStyleId>
+                <a:tableStyleId>{C15442DE-9166-4A00-B985-3162F5EA9497}</a:tableStyleId>
               </a:tblPr>
               <a:tblGrid>
                 <a:gridCol w="1695200"/>
@@ -27426,7 +27426,7 @@
             <a:tbl>
               <a:tblPr>
                 <a:noFill/>
-                <a:tableStyleId>{6E5ADE8E-6630-4EA3-99C8-5FA4D6AC2806}</a:tableStyleId>
+                <a:tableStyleId>{C15442DE-9166-4A00-B985-3162F5EA9497}</a:tableStyleId>
               </a:tblPr>
               <a:tblGrid>
                 <a:gridCol w="1695200"/>
@@ -28678,7 +28678,7 @@
             <a:tbl>
               <a:tblPr>
                 <a:noFill/>
-                <a:tableStyleId>{6E5ADE8E-6630-4EA3-99C8-5FA4D6AC2806}</a:tableStyleId>
+                <a:tableStyleId>{C15442DE-9166-4A00-B985-3162F5EA9497}</a:tableStyleId>
               </a:tblPr>
               <a:tblGrid>
                 <a:gridCol w="1695200"/>
@@ -29670,7 +29670,7 @@
             <a:tbl>
               <a:tblPr>
                 <a:noFill/>
-                <a:tableStyleId>{6E5ADE8E-6630-4EA3-99C8-5FA4D6AC2806}</a:tableStyleId>
+                <a:tableStyleId>{C15442DE-9166-4A00-B985-3162F5EA9497}</a:tableStyleId>
               </a:tblPr>
               <a:tblGrid>
                 <a:gridCol w="3048000"/>
@@ -33175,7 +33175,7 @@
             <a:tbl>
               <a:tblPr>
                 <a:noFill/>
-                <a:tableStyleId>{6E5ADE8E-6630-4EA3-99C8-5FA4D6AC2806}</a:tableStyleId>
+                <a:tableStyleId>{C15442DE-9166-4A00-B985-3162F5EA9497}</a:tableStyleId>
               </a:tblPr>
               <a:tblGrid>
                 <a:gridCol w="1828800"/>
@@ -34002,285 +34002,6 @@
 </file>
 
 <file path=ppt/theme/theme1.xml><?xml version="1.0" encoding="utf-8"?>
-<a:theme xmlns:a="http://schemas.openxmlformats.org/drawingml/2006/main" xmlns:r="http://schemas.openxmlformats.org/officeDocument/2006/relationships">
-  <a:themeElements>
-    <a:clrScheme name="Default">
-      <a:dk1>
-        <a:srgbClr val="000000"/>
-      </a:dk1>
-      <a:lt1>
-        <a:srgbClr val="FFFFFF"/>
-      </a:lt1>
-      <a:dk2>
-        <a:srgbClr val="158158"/>
-      </a:dk2>
-      <a:lt2>
-        <a:srgbClr val="F3F3F3"/>
-      </a:lt2>
-      <a:accent1>
-        <a:srgbClr val="058DC7"/>
-      </a:accent1>
-      <a:accent2>
-        <a:srgbClr val="50B432"/>
-      </a:accent2>
-      <a:accent3>
-        <a:srgbClr val="ED561B"/>
-      </a:accent3>
-      <a:accent4>
-        <a:srgbClr val="EDEF00"/>
-      </a:accent4>
-      <a:accent5>
-        <a:srgbClr val="24CBE5"/>
-      </a:accent5>
-      <a:accent6>
-        <a:srgbClr val="64E572"/>
-      </a:accent6>
-      <a:hlink>
-        <a:srgbClr val="2200CC"/>
-      </a:hlink>
-      <a:folHlink>
-        <a:srgbClr val="551A8B"/>
-      </a:folHlink>
-    </a:clrScheme>
-    <a:fontScheme name="Office">
-      <a:majorFont>
-        <a:latin typeface="Arial"/>
-        <a:ea typeface=""/>
-        <a:cs typeface=""/>
-        <a:font script="Jpan" typeface="ＭＳ Ｐゴシック"/>
-        <a:font script="Hang" typeface="맑은 고딕"/>
-        <a:font script="Hans" typeface="宋体"/>
-        <a:font script="Hant" typeface="新細明體"/>
-        <a:font script="Arab" typeface="Times New Roman"/>
-        <a:font script="Hebr" typeface="Times New Roman"/>
-        <a:font script="Thai" typeface="Angsana New"/>
-        <a:font script="Ethi" typeface="Nyala"/>
-        <a:font script="Beng" typeface="Vrinda"/>
-        <a:font script="Gujr" typeface="Shruti"/>
-        <a:font script="Khmr" typeface="MoolBoran"/>
-        <a:font script="Knda" typeface="Tunga"/>
-        <a:font script="Guru" typeface="Raavi"/>
-        <a:font script="Cans" typeface="Euphemia"/>
-        <a:font script="Cher" typeface="Plantagenet Cherokee"/>
-        <a:font script="Yiii" typeface="Microsoft Yi Baiti"/>
-        <a:font script="Tibt" typeface="Microsoft Himalaya"/>
-        <a:font script="Thaa" typeface="MV Boli"/>
-        <a:font script="Deva" typeface="Mangal"/>
-        <a:font script="Telu" typeface="Gautami"/>
-        <a:font script="Taml" typeface="Latha"/>
-        <a:font script="Syrc" typeface="Estrangelo Edessa"/>
-        <a:font script="Orya" typeface="Kalinga"/>
-        <a:font script="Mlym" typeface="Kartika"/>
-        <a:font script="Laoo" typeface="DokChampa"/>
-        <a:font script="Sinh" typeface="Iskoola Pota"/>
-        <a:font script="Mong" typeface="Mongolian Baiti"/>
-        <a:font script="Viet" typeface="Times New Roman"/>
-        <a:font script="Uigh" typeface="Microsoft Uighur"/>
-        <a:font script="Geor" typeface="Sylfaen"/>
-      </a:majorFont>
-      <a:minorFont>
-        <a:latin typeface="Arial"/>
-        <a:ea typeface=""/>
-        <a:cs typeface=""/>
-        <a:font script="Jpan" typeface="ＭＳ Ｐゴシック"/>
-        <a:font script="Hang" typeface="맑은 고딕"/>
-        <a:font script="Hans" typeface="宋体"/>
-        <a:font script="Hant" typeface="新細明體"/>
-        <a:font script="Arab" typeface="Arial"/>
-        <a:font script="Hebr" typeface="Arial"/>
-        <a:font script="Thai" typeface="Cordia New"/>
-        <a:font script="Ethi" typeface="Nyala"/>
-        <a:font script="Beng" typeface="Vrinda"/>
-        <a:font script="Gujr" typeface="Shruti"/>
-        <a:font script="Khmr" typeface="DaunPenh"/>
-        <a:font script="Knda" typeface="Tunga"/>
-        <a:font script="Guru" typeface="Raavi"/>
-        <a:font script="Cans" typeface="Euphemia"/>
-        <a:font script="Cher" typeface="Plantagenet Cherokee"/>
-        <a:font script="Yiii" typeface="Microsoft Yi Baiti"/>
-        <a:font script="Tibt" typeface="Microsoft Himalaya"/>
-        <a:font script="Thaa" typeface="MV Boli"/>
-        <a:font script="Deva" typeface="Mangal"/>
-        <a:font script="Telu" typeface="Gautami"/>
-        <a:font script="Taml" typeface="Latha"/>
-        <a:font script="Syrc" typeface="Estrangelo Edessa"/>
-        <a:font script="Orya" typeface="Kalinga"/>
-        <a:font script="Mlym" typeface="Kartika"/>
-        <a:font script="Laoo" typeface="DokChampa"/>
-        <a:font script="Sinh" typeface="Iskoola Pota"/>
-        <a:font script="Mong" typeface="Mongolian Baiti"/>
-        <a:font script="Viet" typeface="Arial"/>
-        <a:font script="Uigh" typeface="Microsoft Uighur"/>
-        <a:font script="Geor" typeface="Sylfaen"/>
-      </a:minorFont>
-    </a:fontScheme>
-    <a:fmtScheme name="Office">
-      <a:fillStyleLst>
-        <a:solidFill>
-          <a:schemeClr val="phClr"/>
-        </a:solidFill>
-        <a:gradFill rotWithShape="1">
-          <a:gsLst>
-            <a:gs pos="0">
-              <a:schemeClr val="phClr">
-                <a:tint val="50000"/>
-                <a:satMod val="300000"/>
-              </a:schemeClr>
-            </a:gs>
-            <a:gs pos="35000">
-              <a:schemeClr val="phClr">
-                <a:tint val="37000"/>
-                <a:satMod val="300000"/>
-              </a:schemeClr>
-            </a:gs>
-            <a:gs pos="100000">
-              <a:schemeClr val="phClr">
-                <a:tint val="15000"/>
-                <a:satMod val="350000"/>
-              </a:schemeClr>
-            </a:gs>
-          </a:gsLst>
-          <a:lin ang="16200000" scaled="1"/>
-        </a:gradFill>
-        <a:gradFill rotWithShape="1">
-          <a:gsLst>
-            <a:gs pos="0">
-              <a:schemeClr val="phClr">
-                <a:tint val="100000"/>
-                <a:shade val="100000"/>
-                <a:satMod val="130000"/>
-              </a:schemeClr>
-            </a:gs>
-            <a:gs pos="100000">
-              <a:schemeClr val="phClr">
-                <a:tint val="50000"/>
-                <a:shade val="100000"/>
-                <a:satMod val="350000"/>
-              </a:schemeClr>
-            </a:gs>
-          </a:gsLst>
-          <a:lin ang="16200000" scaled="0"/>
-        </a:gradFill>
-      </a:fillStyleLst>
-      <a:lnStyleLst>
-        <a:ln w="9525" cap="flat" cmpd="sng" algn="ctr">
-          <a:solidFill>
-            <a:schemeClr val="phClr">
-              <a:shade val="95000"/>
-              <a:satMod val="105000"/>
-            </a:schemeClr>
-          </a:solidFill>
-          <a:prstDash val="solid"/>
-        </a:ln>
-        <a:ln w="25400" cap="flat" cmpd="sng" algn="ctr">
-          <a:solidFill>
-            <a:schemeClr val="phClr"/>
-          </a:solidFill>
-          <a:prstDash val="solid"/>
-        </a:ln>
-        <a:ln w="38100" cap="flat" cmpd="sng" algn="ctr">
-          <a:solidFill>
-            <a:schemeClr val="phClr"/>
-          </a:solidFill>
-          <a:prstDash val="solid"/>
-        </a:ln>
-      </a:lnStyleLst>
-      <a:effectStyleLst>
-        <a:effectStyle>
-          <a:effectLst>
-            <a:outerShdw blurRad="40000" dist="20000" dir="5400000" rotWithShape="0">
-              <a:srgbClr val="000000">
-                <a:alpha val="38000"/>
-              </a:srgbClr>
-            </a:outerShdw>
-          </a:effectLst>
-        </a:effectStyle>
-        <a:effectStyle>
-          <a:effectLst>
-            <a:outerShdw blurRad="40000" dist="23000" dir="5400000" rotWithShape="0">
-              <a:srgbClr val="000000">
-                <a:alpha val="35000"/>
-              </a:srgbClr>
-            </a:outerShdw>
-          </a:effectLst>
-        </a:effectStyle>
-        <a:effectStyle>
-          <a:effectLst>
-            <a:outerShdw blurRad="40000" dist="23000" dir="5400000" rotWithShape="0">
-              <a:srgbClr val="000000">
-                <a:alpha val="35000"/>
-              </a:srgbClr>
-            </a:outerShdw>
-          </a:effectLst>
-          <a:scene3d>
-            <a:camera prst="orthographicFront">
-              <a:rot lat="0" lon="0" rev="0"/>
-            </a:camera>
-            <a:lightRig rig="threePt" dir="t">
-              <a:rot lat="0" lon="0" rev="1200000"/>
-            </a:lightRig>
-          </a:scene3d>
-          <a:sp3d>
-            <a:bevelT w="63500" h="25400"/>
-          </a:sp3d>
-        </a:effectStyle>
-      </a:effectStyleLst>
-      <a:bgFillStyleLst>
-        <a:solidFill>
-          <a:schemeClr val="phClr"/>
-        </a:solidFill>
-        <a:gradFill rotWithShape="1">
-          <a:gsLst>
-            <a:gs pos="0">
-              <a:schemeClr val="phClr">
-                <a:tint val="40000"/>
-                <a:satMod val="350000"/>
-              </a:schemeClr>
-            </a:gs>
-            <a:gs pos="40000">
-              <a:schemeClr val="phClr">
-                <a:tint val="45000"/>
-                <a:shade val="99000"/>
-                <a:satMod val="350000"/>
-              </a:schemeClr>
-            </a:gs>
-            <a:gs pos="100000">
-              <a:schemeClr val="phClr">
-                <a:shade val="20000"/>
-                <a:satMod val="255000"/>
-              </a:schemeClr>
-            </a:gs>
-          </a:gsLst>
-          <a:path path="circle">
-            <a:fillToRect l="50000" t="-80000" r="50000" b="180000"/>
-          </a:path>
-        </a:gradFill>
-        <a:gradFill rotWithShape="1">
-          <a:gsLst>
-            <a:gs pos="0">
-              <a:schemeClr val="phClr">
-                <a:tint val="80000"/>
-                <a:satMod val="300000"/>
-              </a:schemeClr>
-            </a:gs>
-            <a:gs pos="100000">
-              <a:schemeClr val="phClr">
-                <a:shade val="30000"/>
-                <a:satMod val="200000"/>
-              </a:schemeClr>
-            </a:gs>
-          </a:gsLst>
-          <a:path path="circle">
-            <a:fillToRect l="50000" t="50000" r="50000" b="50000"/>
-          </a:path>
-        </a:gradFill>
-      </a:bgFillStyleLst>
-    </a:fmtScheme>
-  </a:themeElements>
-</a:theme>
-</file>
-
-<file path=ppt/theme/theme2.xml><?xml version="1.0" encoding="utf-8"?>
 <a:theme xmlns:a="http://schemas.openxmlformats.org/drawingml/2006/main" xmlns:r="http://schemas.openxmlformats.org/officeDocument/2006/relationships" name="Simple Light">
   <a:themeElements>
     <a:clrScheme name="Simple Light">
@@ -34559,7 +34280,7 @@
 </a:theme>
 </file>
 
-<file path=ppt/theme/theme3.xml><?xml version="1.0" encoding="utf-8"?>
+<file path=ppt/theme/theme2.xml><?xml version="1.0" encoding="utf-8"?>
 <a:theme xmlns:a="http://schemas.openxmlformats.org/drawingml/2006/main" xmlns:r="http://schemas.openxmlformats.org/officeDocument/2006/relationships" name="LF Energy Theme 2023">
   <a:themeElements>
     <a:clrScheme name="Geometric">
@@ -34836,4 +34557,283 @@
     </a:fmtScheme>
   </a:themeElements>
 </a:theme>
+</file>
+
+<file path=ppt/theme/theme3.xml><?xml version="1.0" encoding="utf-8"?>
+<a:theme xmlns:a="http://schemas.openxmlformats.org/drawingml/2006/main" xmlns:r="http://schemas.openxmlformats.org/officeDocument/2006/relationships">
+  <a:themeElements>
+    <a:clrScheme name="Default">
+      <a:dk1>
+        <a:srgbClr val="000000"/>
+      </a:dk1>
+      <a:lt1>
+        <a:srgbClr val="FFFFFF"/>
+      </a:lt1>
+      <a:dk2>
+        <a:srgbClr val="158158"/>
+      </a:dk2>
+      <a:lt2>
+        <a:srgbClr val="F3F3F3"/>
+      </a:lt2>
+      <a:accent1>
+        <a:srgbClr val="058DC7"/>
+      </a:accent1>
+      <a:accent2>
+        <a:srgbClr val="50B432"/>
+      </a:accent2>
+      <a:accent3>
+        <a:srgbClr val="ED561B"/>
+      </a:accent3>
+      <a:accent4>
+        <a:srgbClr val="EDEF00"/>
+      </a:accent4>
+      <a:accent5>
+        <a:srgbClr val="24CBE5"/>
+      </a:accent5>
+      <a:accent6>
+        <a:srgbClr val="64E572"/>
+      </a:accent6>
+      <a:hlink>
+        <a:srgbClr val="2200CC"/>
+      </a:hlink>
+      <a:folHlink>
+        <a:srgbClr val="551A8B"/>
+      </a:folHlink>
+    </a:clrScheme>
+    <a:fontScheme name="Office">
+      <a:majorFont>
+        <a:latin typeface="Arial"/>
+        <a:ea typeface=""/>
+        <a:cs typeface=""/>
+        <a:font script="Jpan" typeface="ＭＳ Ｐゴシック"/>
+        <a:font script="Hang" typeface="맑은 고딕"/>
+        <a:font script="Hans" typeface="宋体"/>
+        <a:font script="Hant" typeface="新細明體"/>
+        <a:font script="Arab" typeface="Times New Roman"/>
+        <a:font script="Hebr" typeface="Times New Roman"/>
+        <a:font script="Thai" typeface="Angsana New"/>
+        <a:font script="Ethi" typeface="Nyala"/>
+        <a:font script="Beng" typeface="Vrinda"/>
+        <a:font script="Gujr" typeface="Shruti"/>
+        <a:font script="Khmr" typeface="MoolBoran"/>
+        <a:font script="Knda" typeface="Tunga"/>
+        <a:font script="Guru" typeface="Raavi"/>
+        <a:font script="Cans" typeface="Euphemia"/>
+        <a:font script="Cher" typeface="Plantagenet Cherokee"/>
+        <a:font script="Yiii" typeface="Microsoft Yi Baiti"/>
+        <a:font script="Tibt" typeface="Microsoft Himalaya"/>
+        <a:font script="Thaa" typeface="MV Boli"/>
+        <a:font script="Deva" typeface="Mangal"/>
+        <a:font script="Telu" typeface="Gautami"/>
+        <a:font script="Taml" typeface="Latha"/>
+        <a:font script="Syrc" typeface="Estrangelo Edessa"/>
+        <a:font script="Orya" typeface="Kalinga"/>
+        <a:font script="Mlym" typeface="Kartika"/>
+        <a:font script="Laoo" typeface="DokChampa"/>
+        <a:font script="Sinh" typeface="Iskoola Pota"/>
+        <a:font script="Mong" typeface="Mongolian Baiti"/>
+        <a:font script="Viet" typeface="Times New Roman"/>
+        <a:font script="Uigh" typeface="Microsoft Uighur"/>
+        <a:font script="Geor" typeface="Sylfaen"/>
+      </a:majorFont>
+      <a:minorFont>
+        <a:latin typeface="Arial"/>
+        <a:ea typeface=""/>
+        <a:cs typeface=""/>
+        <a:font script="Jpan" typeface="ＭＳ Ｐゴシック"/>
+        <a:font script="Hang" typeface="맑은 고딕"/>
+        <a:font script="Hans" typeface="宋体"/>
+        <a:font script="Hant" typeface="新細明體"/>
+        <a:font script="Arab" typeface="Arial"/>
+        <a:font script="Hebr" typeface="Arial"/>
+        <a:font script="Thai" typeface="Cordia New"/>
+        <a:font script="Ethi" typeface="Nyala"/>
+        <a:font script="Beng" typeface="Vrinda"/>
+        <a:font script="Gujr" typeface="Shruti"/>
+        <a:font script="Khmr" typeface="DaunPenh"/>
+        <a:font script="Knda" typeface="Tunga"/>
+        <a:font script="Guru" typeface="Raavi"/>
+        <a:font script="Cans" typeface="Euphemia"/>
+        <a:font script="Cher" typeface="Plantagenet Cherokee"/>
+        <a:font script="Yiii" typeface="Microsoft Yi Baiti"/>
+        <a:font script="Tibt" typeface="Microsoft Himalaya"/>
+        <a:font script="Thaa" typeface="MV Boli"/>
+        <a:font script="Deva" typeface="Mangal"/>
+        <a:font script="Telu" typeface="Gautami"/>
+        <a:font script="Taml" typeface="Latha"/>
+        <a:font script="Syrc" typeface="Estrangelo Edessa"/>
+        <a:font script="Orya" typeface="Kalinga"/>
+        <a:font script="Mlym" typeface="Kartika"/>
+        <a:font script="Laoo" typeface="DokChampa"/>
+        <a:font script="Sinh" typeface="Iskoola Pota"/>
+        <a:font script="Mong" typeface="Mongolian Baiti"/>
+        <a:font script="Viet" typeface="Arial"/>
+        <a:font script="Uigh" typeface="Microsoft Uighur"/>
+        <a:font script="Geor" typeface="Sylfaen"/>
+      </a:minorFont>
+    </a:fontScheme>
+    <a:fmtScheme name="Office">
+      <a:fillStyleLst>
+        <a:solidFill>
+          <a:schemeClr val="phClr"/>
+        </a:solidFill>
+        <a:gradFill rotWithShape="1">
+          <a:gsLst>
+            <a:gs pos="0">
+              <a:schemeClr val="phClr">
+                <a:tint val="50000"/>
+                <a:satMod val="300000"/>
+              </a:schemeClr>
+            </a:gs>
+            <a:gs pos="35000">
+              <a:schemeClr val="phClr">
+                <a:tint val="37000"/>
+                <a:satMod val="300000"/>
+              </a:schemeClr>
+            </a:gs>
+            <a:gs pos="100000">
+              <a:schemeClr val="phClr">
+                <a:tint val="15000"/>
+                <a:satMod val="350000"/>
+              </a:schemeClr>
+            </a:gs>
+          </a:gsLst>
+          <a:lin ang="16200000" scaled="1"/>
+        </a:gradFill>
+        <a:gradFill rotWithShape="1">
+          <a:gsLst>
+            <a:gs pos="0">
+              <a:schemeClr val="phClr">
+                <a:tint val="100000"/>
+                <a:shade val="100000"/>
+                <a:satMod val="130000"/>
+              </a:schemeClr>
+            </a:gs>
+            <a:gs pos="100000">
+              <a:schemeClr val="phClr">
+                <a:tint val="50000"/>
+                <a:shade val="100000"/>
+                <a:satMod val="350000"/>
+              </a:schemeClr>
+            </a:gs>
+          </a:gsLst>
+          <a:lin ang="16200000" scaled="0"/>
+        </a:gradFill>
+      </a:fillStyleLst>
+      <a:lnStyleLst>
+        <a:ln w="9525" cap="flat" cmpd="sng" algn="ctr">
+          <a:solidFill>
+            <a:schemeClr val="phClr">
+              <a:shade val="95000"/>
+              <a:satMod val="105000"/>
+            </a:schemeClr>
+          </a:solidFill>
+          <a:prstDash val="solid"/>
+        </a:ln>
+        <a:ln w="25400" cap="flat" cmpd="sng" algn="ctr">
+          <a:solidFill>
+            <a:schemeClr val="phClr"/>
+          </a:solidFill>
+          <a:prstDash val="solid"/>
+        </a:ln>
+        <a:ln w="38100" cap="flat" cmpd="sng" algn="ctr">
+          <a:solidFill>
+            <a:schemeClr val="phClr"/>
+          </a:solidFill>
+          <a:prstDash val="solid"/>
+        </a:ln>
+      </a:lnStyleLst>
+      <a:effectStyleLst>
+        <a:effectStyle>
+          <a:effectLst>
+            <a:outerShdw blurRad="40000" dist="20000" dir="5400000" rotWithShape="0">
+              <a:srgbClr val="000000">
+                <a:alpha val="38000"/>
+              </a:srgbClr>
+            </a:outerShdw>
+          </a:effectLst>
+        </a:effectStyle>
+        <a:effectStyle>
+          <a:effectLst>
+            <a:outerShdw blurRad="40000" dist="23000" dir="5400000" rotWithShape="0">
+              <a:srgbClr val="000000">
+                <a:alpha val="35000"/>
+              </a:srgbClr>
+            </a:outerShdw>
+          </a:effectLst>
+        </a:effectStyle>
+        <a:effectStyle>
+          <a:effectLst>
+            <a:outerShdw blurRad="40000" dist="23000" dir="5400000" rotWithShape="0">
+              <a:srgbClr val="000000">
+                <a:alpha val="35000"/>
+              </a:srgbClr>
+            </a:outerShdw>
+          </a:effectLst>
+          <a:scene3d>
+            <a:camera prst="orthographicFront">
+              <a:rot lat="0" lon="0" rev="0"/>
+            </a:camera>
+            <a:lightRig rig="threePt" dir="t">
+              <a:rot lat="0" lon="0" rev="1200000"/>
+            </a:lightRig>
+          </a:scene3d>
+          <a:sp3d>
+            <a:bevelT w="63500" h="25400"/>
+          </a:sp3d>
+        </a:effectStyle>
+      </a:effectStyleLst>
+      <a:bgFillStyleLst>
+        <a:solidFill>
+          <a:schemeClr val="phClr"/>
+        </a:solidFill>
+        <a:gradFill rotWithShape="1">
+          <a:gsLst>
+            <a:gs pos="0">
+              <a:schemeClr val="phClr">
+                <a:tint val="40000"/>
+                <a:satMod val="350000"/>
+              </a:schemeClr>
+            </a:gs>
+            <a:gs pos="40000">
+              <a:schemeClr val="phClr">
+                <a:tint val="45000"/>
+                <a:shade val="99000"/>
+                <a:satMod val="350000"/>
+              </a:schemeClr>
+            </a:gs>
+            <a:gs pos="100000">
+              <a:schemeClr val="phClr">
+                <a:shade val="20000"/>
+                <a:satMod val="255000"/>
+              </a:schemeClr>
+            </a:gs>
+          </a:gsLst>
+          <a:path path="circle">
+            <a:fillToRect l="50000" t="-80000" r="50000" b="180000"/>
+          </a:path>
+        </a:gradFill>
+        <a:gradFill rotWithShape="1">
+          <a:gsLst>
+            <a:gs pos="0">
+              <a:schemeClr val="phClr">
+                <a:tint val="80000"/>
+                <a:satMod val="300000"/>
+              </a:schemeClr>
+            </a:gs>
+            <a:gs pos="100000">
+              <a:schemeClr val="phClr">
+                <a:shade val="30000"/>
+                <a:satMod val="200000"/>
+              </a:schemeClr>
+            </a:gs>
+          </a:gsLst>
+          <a:path path="circle">
+            <a:fillToRect l="50000" t="50000" r="50000" b="50000"/>
+          </a:path>
+        </a:gradFill>
+      </a:bgFillStyleLst>
+    </a:fmtScheme>
+  </a:themeElements>
+</a:theme>
 </file>
</xml_diff>

<commit_message>
Update Data Sources from LFX 2026-09-10 (#304)
Update Data Sources from LFX

Signed-off-by: github-actions[bot] <41898282+github-actions[bot]@users.noreply.github.com>
</commit_message>
<xml_diff>
--- a/overview_deck/LF Energy High Level Overview.pptx
+++ b/overview_deck/LF Energy High Level Overview.pptx
@@ -25946,7 +25946,7 @@
             <a:tbl>
               <a:tblPr>
                 <a:noFill/>
-                <a:tableStyleId>{C15442DE-9166-4A00-B985-3162F5EA9497}</a:tableStyleId>
+                <a:tableStyleId>{A13EEE81-1922-41B9-9FB7-837E72EC13DA}</a:tableStyleId>
               </a:tblPr>
               <a:tblGrid>
                 <a:gridCol w="1695200"/>
@@ -26736,7 +26736,7 @@
             <a:tbl>
               <a:tblPr>
                 <a:noFill/>
-                <a:tableStyleId>{C15442DE-9166-4A00-B985-3162F5EA9497}</a:tableStyleId>
+                <a:tableStyleId>{A13EEE81-1922-41B9-9FB7-837E72EC13DA}</a:tableStyleId>
               </a:tblPr>
               <a:tblGrid>
                 <a:gridCol w="1695200"/>
@@ -27426,7 +27426,7 @@
             <a:tbl>
               <a:tblPr>
                 <a:noFill/>
-                <a:tableStyleId>{C15442DE-9166-4A00-B985-3162F5EA9497}</a:tableStyleId>
+                <a:tableStyleId>{A13EEE81-1922-41B9-9FB7-837E72EC13DA}</a:tableStyleId>
               </a:tblPr>
               <a:tblGrid>
                 <a:gridCol w="1695200"/>
@@ -28678,7 +28678,7 @@
             <a:tbl>
               <a:tblPr>
                 <a:noFill/>
-                <a:tableStyleId>{C15442DE-9166-4A00-B985-3162F5EA9497}</a:tableStyleId>
+                <a:tableStyleId>{A13EEE81-1922-41B9-9FB7-837E72EC13DA}</a:tableStyleId>
               </a:tblPr>
               <a:tblGrid>
                 <a:gridCol w="1695200"/>
@@ -29670,7 +29670,7 @@
             <a:tbl>
               <a:tblPr>
                 <a:noFill/>
-                <a:tableStyleId>{C15442DE-9166-4A00-B985-3162F5EA9497}</a:tableStyleId>
+                <a:tableStyleId>{A13EEE81-1922-41B9-9FB7-837E72EC13DA}</a:tableStyleId>
               </a:tblPr>
               <a:tblGrid>
                 <a:gridCol w="3048000"/>
@@ -33175,7 +33175,7 @@
             <a:tbl>
               <a:tblPr>
                 <a:noFill/>
-                <a:tableStyleId>{C15442DE-9166-4A00-B985-3162F5EA9497}</a:tableStyleId>
+                <a:tableStyleId>{A13EEE81-1922-41B9-9FB7-837E72EC13DA}</a:tableStyleId>
               </a:tblPr>
               <a:tblGrid>
                 <a:gridCol w="1828800"/>
@@ -34002,6 +34002,285 @@
 </file>
 
 <file path=ppt/theme/theme1.xml><?xml version="1.0" encoding="utf-8"?>
+<a:theme xmlns:a="http://schemas.openxmlformats.org/drawingml/2006/main" xmlns:r="http://schemas.openxmlformats.org/officeDocument/2006/relationships">
+  <a:themeElements>
+    <a:clrScheme name="Default">
+      <a:dk1>
+        <a:srgbClr val="000000"/>
+      </a:dk1>
+      <a:lt1>
+        <a:srgbClr val="FFFFFF"/>
+      </a:lt1>
+      <a:dk2>
+        <a:srgbClr val="158158"/>
+      </a:dk2>
+      <a:lt2>
+        <a:srgbClr val="F3F3F3"/>
+      </a:lt2>
+      <a:accent1>
+        <a:srgbClr val="058DC7"/>
+      </a:accent1>
+      <a:accent2>
+        <a:srgbClr val="50B432"/>
+      </a:accent2>
+      <a:accent3>
+        <a:srgbClr val="ED561B"/>
+      </a:accent3>
+      <a:accent4>
+        <a:srgbClr val="EDEF00"/>
+      </a:accent4>
+      <a:accent5>
+        <a:srgbClr val="24CBE5"/>
+      </a:accent5>
+      <a:accent6>
+        <a:srgbClr val="64E572"/>
+      </a:accent6>
+      <a:hlink>
+        <a:srgbClr val="2200CC"/>
+      </a:hlink>
+      <a:folHlink>
+        <a:srgbClr val="551A8B"/>
+      </a:folHlink>
+    </a:clrScheme>
+    <a:fontScheme name="Office">
+      <a:majorFont>
+        <a:latin typeface="Arial"/>
+        <a:ea typeface=""/>
+        <a:cs typeface=""/>
+        <a:font script="Jpan" typeface="ＭＳ Ｐゴシック"/>
+        <a:font script="Hang" typeface="맑은 고딕"/>
+        <a:font script="Hans" typeface="宋体"/>
+        <a:font script="Hant" typeface="新細明體"/>
+        <a:font script="Arab" typeface="Times New Roman"/>
+        <a:font script="Hebr" typeface="Times New Roman"/>
+        <a:font script="Thai" typeface="Angsana New"/>
+        <a:font script="Ethi" typeface="Nyala"/>
+        <a:font script="Beng" typeface="Vrinda"/>
+        <a:font script="Gujr" typeface="Shruti"/>
+        <a:font script="Khmr" typeface="MoolBoran"/>
+        <a:font script="Knda" typeface="Tunga"/>
+        <a:font script="Guru" typeface="Raavi"/>
+        <a:font script="Cans" typeface="Euphemia"/>
+        <a:font script="Cher" typeface="Plantagenet Cherokee"/>
+        <a:font script="Yiii" typeface="Microsoft Yi Baiti"/>
+        <a:font script="Tibt" typeface="Microsoft Himalaya"/>
+        <a:font script="Thaa" typeface="MV Boli"/>
+        <a:font script="Deva" typeface="Mangal"/>
+        <a:font script="Telu" typeface="Gautami"/>
+        <a:font script="Taml" typeface="Latha"/>
+        <a:font script="Syrc" typeface="Estrangelo Edessa"/>
+        <a:font script="Orya" typeface="Kalinga"/>
+        <a:font script="Mlym" typeface="Kartika"/>
+        <a:font script="Laoo" typeface="DokChampa"/>
+        <a:font script="Sinh" typeface="Iskoola Pota"/>
+        <a:font script="Mong" typeface="Mongolian Baiti"/>
+        <a:font script="Viet" typeface="Times New Roman"/>
+        <a:font script="Uigh" typeface="Microsoft Uighur"/>
+        <a:font script="Geor" typeface="Sylfaen"/>
+      </a:majorFont>
+      <a:minorFont>
+        <a:latin typeface="Arial"/>
+        <a:ea typeface=""/>
+        <a:cs typeface=""/>
+        <a:font script="Jpan" typeface="ＭＳ Ｐゴシック"/>
+        <a:font script="Hang" typeface="맑은 고딕"/>
+        <a:font script="Hans" typeface="宋体"/>
+        <a:font script="Hant" typeface="新細明體"/>
+        <a:font script="Arab" typeface="Arial"/>
+        <a:font script="Hebr" typeface="Arial"/>
+        <a:font script="Thai" typeface="Cordia New"/>
+        <a:font script="Ethi" typeface="Nyala"/>
+        <a:font script="Beng" typeface="Vrinda"/>
+        <a:font script="Gujr" typeface="Shruti"/>
+        <a:font script="Khmr" typeface="DaunPenh"/>
+        <a:font script="Knda" typeface="Tunga"/>
+        <a:font script="Guru" typeface="Raavi"/>
+        <a:font script="Cans" typeface="Euphemia"/>
+        <a:font script="Cher" typeface="Plantagenet Cherokee"/>
+        <a:font script="Yiii" typeface="Microsoft Yi Baiti"/>
+        <a:font script="Tibt" typeface="Microsoft Himalaya"/>
+        <a:font script="Thaa" typeface="MV Boli"/>
+        <a:font script="Deva" typeface="Mangal"/>
+        <a:font script="Telu" typeface="Gautami"/>
+        <a:font script="Taml" typeface="Latha"/>
+        <a:font script="Syrc" typeface="Estrangelo Edessa"/>
+        <a:font script="Orya" typeface="Kalinga"/>
+        <a:font script="Mlym" typeface="Kartika"/>
+        <a:font script="Laoo" typeface="DokChampa"/>
+        <a:font script="Sinh" typeface="Iskoola Pota"/>
+        <a:font script="Mong" typeface="Mongolian Baiti"/>
+        <a:font script="Viet" typeface="Arial"/>
+        <a:font script="Uigh" typeface="Microsoft Uighur"/>
+        <a:font script="Geor" typeface="Sylfaen"/>
+      </a:minorFont>
+    </a:fontScheme>
+    <a:fmtScheme name="Office">
+      <a:fillStyleLst>
+        <a:solidFill>
+          <a:schemeClr val="phClr"/>
+        </a:solidFill>
+        <a:gradFill rotWithShape="1">
+          <a:gsLst>
+            <a:gs pos="0">
+              <a:schemeClr val="phClr">
+                <a:tint val="50000"/>
+                <a:satMod val="300000"/>
+              </a:schemeClr>
+            </a:gs>
+            <a:gs pos="35000">
+              <a:schemeClr val="phClr">
+                <a:tint val="37000"/>
+                <a:satMod val="300000"/>
+              </a:schemeClr>
+            </a:gs>
+            <a:gs pos="100000">
+              <a:schemeClr val="phClr">
+                <a:tint val="15000"/>
+                <a:satMod val="350000"/>
+              </a:schemeClr>
+            </a:gs>
+          </a:gsLst>
+          <a:lin ang="16200000" scaled="1"/>
+        </a:gradFill>
+        <a:gradFill rotWithShape="1">
+          <a:gsLst>
+            <a:gs pos="0">
+              <a:schemeClr val="phClr">
+                <a:tint val="100000"/>
+                <a:shade val="100000"/>
+                <a:satMod val="130000"/>
+              </a:schemeClr>
+            </a:gs>
+            <a:gs pos="100000">
+              <a:schemeClr val="phClr">
+                <a:tint val="50000"/>
+                <a:shade val="100000"/>
+                <a:satMod val="350000"/>
+              </a:schemeClr>
+            </a:gs>
+          </a:gsLst>
+          <a:lin ang="16200000" scaled="0"/>
+        </a:gradFill>
+      </a:fillStyleLst>
+      <a:lnStyleLst>
+        <a:ln w="9525" cap="flat" cmpd="sng" algn="ctr">
+          <a:solidFill>
+            <a:schemeClr val="phClr">
+              <a:shade val="95000"/>
+              <a:satMod val="105000"/>
+            </a:schemeClr>
+          </a:solidFill>
+          <a:prstDash val="solid"/>
+        </a:ln>
+        <a:ln w="25400" cap="flat" cmpd="sng" algn="ctr">
+          <a:solidFill>
+            <a:schemeClr val="phClr"/>
+          </a:solidFill>
+          <a:prstDash val="solid"/>
+        </a:ln>
+        <a:ln w="38100" cap="flat" cmpd="sng" algn="ctr">
+          <a:solidFill>
+            <a:schemeClr val="phClr"/>
+          </a:solidFill>
+          <a:prstDash val="solid"/>
+        </a:ln>
+      </a:lnStyleLst>
+      <a:effectStyleLst>
+        <a:effectStyle>
+          <a:effectLst>
+            <a:outerShdw blurRad="40000" dist="20000" dir="5400000" rotWithShape="0">
+              <a:srgbClr val="000000">
+                <a:alpha val="38000"/>
+              </a:srgbClr>
+            </a:outerShdw>
+          </a:effectLst>
+        </a:effectStyle>
+        <a:effectStyle>
+          <a:effectLst>
+            <a:outerShdw blurRad="40000" dist="23000" dir="5400000" rotWithShape="0">
+              <a:srgbClr val="000000">
+                <a:alpha val="35000"/>
+              </a:srgbClr>
+            </a:outerShdw>
+          </a:effectLst>
+        </a:effectStyle>
+        <a:effectStyle>
+          <a:effectLst>
+            <a:outerShdw blurRad="40000" dist="23000" dir="5400000" rotWithShape="0">
+              <a:srgbClr val="000000">
+                <a:alpha val="35000"/>
+              </a:srgbClr>
+            </a:outerShdw>
+          </a:effectLst>
+          <a:scene3d>
+            <a:camera prst="orthographicFront">
+              <a:rot lat="0" lon="0" rev="0"/>
+            </a:camera>
+            <a:lightRig rig="threePt" dir="t">
+              <a:rot lat="0" lon="0" rev="1200000"/>
+            </a:lightRig>
+          </a:scene3d>
+          <a:sp3d>
+            <a:bevelT w="63500" h="25400"/>
+          </a:sp3d>
+        </a:effectStyle>
+      </a:effectStyleLst>
+      <a:bgFillStyleLst>
+        <a:solidFill>
+          <a:schemeClr val="phClr"/>
+        </a:solidFill>
+        <a:gradFill rotWithShape="1">
+          <a:gsLst>
+            <a:gs pos="0">
+              <a:schemeClr val="phClr">
+                <a:tint val="40000"/>
+                <a:satMod val="350000"/>
+              </a:schemeClr>
+            </a:gs>
+            <a:gs pos="40000">
+              <a:schemeClr val="phClr">
+                <a:tint val="45000"/>
+                <a:shade val="99000"/>
+                <a:satMod val="350000"/>
+              </a:schemeClr>
+            </a:gs>
+            <a:gs pos="100000">
+              <a:schemeClr val="phClr">
+                <a:shade val="20000"/>
+                <a:satMod val="255000"/>
+              </a:schemeClr>
+            </a:gs>
+          </a:gsLst>
+          <a:path path="circle">
+            <a:fillToRect l="50000" t="-80000" r="50000" b="180000"/>
+          </a:path>
+        </a:gradFill>
+        <a:gradFill rotWithShape="1">
+          <a:gsLst>
+            <a:gs pos="0">
+              <a:schemeClr val="phClr">
+                <a:tint val="80000"/>
+                <a:satMod val="300000"/>
+              </a:schemeClr>
+            </a:gs>
+            <a:gs pos="100000">
+              <a:schemeClr val="phClr">
+                <a:shade val="30000"/>
+                <a:satMod val="200000"/>
+              </a:schemeClr>
+            </a:gs>
+          </a:gsLst>
+          <a:path path="circle">
+            <a:fillToRect l="50000" t="50000" r="50000" b="50000"/>
+          </a:path>
+        </a:gradFill>
+      </a:bgFillStyleLst>
+    </a:fmtScheme>
+  </a:themeElements>
+</a:theme>
+</file>
+
+<file path=ppt/theme/theme2.xml><?xml version="1.0" encoding="utf-8"?>
 <a:theme xmlns:a="http://schemas.openxmlformats.org/drawingml/2006/main" xmlns:r="http://schemas.openxmlformats.org/officeDocument/2006/relationships" name="Simple Light">
   <a:themeElements>
     <a:clrScheme name="Simple Light">
@@ -34280,7 +34559,7 @@
 </a:theme>
 </file>
 
-<file path=ppt/theme/theme2.xml><?xml version="1.0" encoding="utf-8"?>
+<file path=ppt/theme/theme3.xml><?xml version="1.0" encoding="utf-8"?>
 <a:theme xmlns:a="http://schemas.openxmlformats.org/drawingml/2006/main" xmlns:r="http://schemas.openxmlformats.org/officeDocument/2006/relationships" name="LF Energy Theme 2023">
   <a:themeElements>
     <a:clrScheme name="Geometric">
@@ -34557,283 +34836,4 @@
     </a:fmtScheme>
   </a:themeElements>
 </a:theme>
-</file>
-
-<file path=ppt/theme/theme3.xml><?xml version="1.0" encoding="utf-8"?>
-<a:theme xmlns:a="http://schemas.openxmlformats.org/drawingml/2006/main" xmlns:r="http://schemas.openxmlformats.org/officeDocument/2006/relationships">
-  <a:themeElements>
-    <a:clrScheme name="Default">
-      <a:dk1>
-        <a:srgbClr val="000000"/>
-      </a:dk1>
-      <a:lt1>
-        <a:srgbClr val="FFFFFF"/>
-      </a:lt1>
-      <a:dk2>
-        <a:srgbClr val="158158"/>
-      </a:dk2>
-      <a:lt2>
-        <a:srgbClr val="F3F3F3"/>
-      </a:lt2>
-      <a:accent1>
-        <a:srgbClr val="058DC7"/>
-      </a:accent1>
-      <a:accent2>
-        <a:srgbClr val="50B432"/>
-      </a:accent2>
-      <a:accent3>
-        <a:srgbClr val="ED561B"/>
-      </a:accent3>
-      <a:accent4>
-        <a:srgbClr val="EDEF00"/>
-      </a:accent4>
-      <a:accent5>
-        <a:srgbClr val="24CBE5"/>
-      </a:accent5>
-      <a:accent6>
-        <a:srgbClr val="64E572"/>
-      </a:accent6>
-      <a:hlink>
-        <a:srgbClr val="2200CC"/>
-      </a:hlink>
-      <a:folHlink>
-        <a:srgbClr val="551A8B"/>
-      </a:folHlink>
-    </a:clrScheme>
-    <a:fontScheme name="Office">
-      <a:majorFont>
-        <a:latin typeface="Arial"/>
-        <a:ea typeface=""/>
-        <a:cs typeface=""/>
-        <a:font script="Jpan" typeface="ＭＳ Ｐゴシック"/>
-        <a:font script="Hang" typeface="맑은 고딕"/>
-        <a:font script="Hans" typeface="宋体"/>
-        <a:font script="Hant" typeface="新細明體"/>
-        <a:font script="Arab" typeface="Times New Roman"/>
-        <a:font script="Hebr" typeface="Times New Roman"/>
-        <a:font script="Thai" typeface="Angsana New"/>
-        <a:font script="Ethi" typeface="Nyala"/>
-        <a:font script="Beng" typeface="Vrinda"/>
-        <a:font script="Gujr" typeface="Shruti"/>
-        <a:font script="Khmr" typeface="MoolBoran"/>
-        <a:font script="Knda" typeface="Tunga"/>
-        <a:font script="Guru" typeface="Raavi"/>
-        <a:font script="Cans" typeface="Euphemia"/>
-        <a:font script="Cher" typeface="Plantagenet Cherokee"/>
-        <a:font script="Yiii" typeface="Microsoft Yi Baiti"/>
-        <a:font script="Tibt" typeface="Microsoft Himalaya"/>
-        <a:font script="Thaa" typeface="MV Boli"/>
-        <a:font script="Deva" typeface="Mangal"/>
-        <a:font script="Telu" typeface="Gautami"/>
-        <a:font script="Taml" typeface="Latha"/>
-        <a:font script="Syrc" typeface="Estrangelo Edessa"/>
-        <a:font script="Orya" typeface="Kalinga"/>
-        <a:font script="Mlym" typeface="Kartika"/>
-        <a:font script="Laoo" typeface="DokChampa"/>
-        <a:font script="Sinh" typeface="Iskoola Pota"/>
-        <a:font script="Mong" typeface="Mongolian Baiti"/>
-        <a:font script="Viet" typeface="Times New Roman"/>
-        <a:font script="Uigh" typeface="Microsoft Uighur"/>
-        <a:font script="Geor" typeface="Sylfaen"/>
-      </a:majorFont>
-      <a:minorFont>
-        <a:latin typeface="Arial"/>
-        <a:ea typeface=""/>
-        <a:cs typeface=""/>
-        <a:font script="Jpan" typeface="ＭＳ Ｐゴシック"/>
-        <a:font script="Hang" typeface="맑은 고딕"/>
-        <a:font script="Hans" typeface="宋体"/>
-        <a:font script="Hant" typeface="新細明體"/>
-        <a:font script="Arab" typeface="Arial"/>
-        <a:font script="Hebr" typeface="Arial"/>
-        <a:font script="Thai" typeface="Cordia New"/>
-        <a:font script="Ethi" typeface="Nyala"/>
-        <a:font script="Beng" typeface="Vrinda"/>
-        <a:font script="Gujr" typeface="Shruti"/>
-        <a:font script="Khmr" typeface="DaunPenh"/>
-        <a:font script="Knda" typeface="Tunga"/>
-        <a:font script="Guru" typeface="Raavi"/>
-        <a:font script="Cans" typeface="Euphemia"/>
-        <a:font script="Cher" typeface="Plantagenet Cherokee"/>
-        <a:font script="Yiii" typeface="Microsoft Yi Baiti"/>
-        <a:font script="Tibt" typeface="Microsoft Himalaya"/>
-        <a:font script="Thaa" typeface="MV Boli"/>
-        <a:font script="Deva" typeface="Mangal"/>
-        <a:font script="Telu" typeface="Gautami"/>
-        <a:font script="Taml" typeface="Latha"/>
-        <a:font script="Syrc" typeface="Estrangelo Edessa"/>
-        <a:font script="Orya" typeface="Kalinga"/>
-        <a:font script="Mlym" typeface="Kartika"/>
-        <a:font script="Laoo" typeface="DokChampa"/>
-        <a:font script="Sinh" typeface="Iskoola Pota"/>
-        <a:font script="Mong" typeface="Mongolian Baiti"/>
-        <a:font script="Viet" typeface="Arial"/>
-        <a:font script="Uigh" typeface="Microsoft Uighur"/>
-        <a:font script="Geor" typeface="Sylfaen"/>
-      </a:minorFont>
-    </a:fontScheme>
-    <a:fmtScheme name="Office">
-      <a:fillStyleLst>
-        <a:solidFill>
-          <a:schemeClr val="phClr"/>
-        </a:solidFill>
-        <a:gradFill rotWithShape="1">
-          <a:gsLst>
-            <a:gs pos="0">
-              <a:schemeClr val="phClr">
-                <a:tint val="50000"/>
-                <a:satMod val="300000"/>
-              </a:schemeClr>
-            </a:gs>
-            <a:gs pos="35000">
-              <a:schemeClr val="phClr">
-                <a:tint val="37000"/>
-                <a:satMod val="300000"/>
-              </a:schemeClr>
-            </a:gs>
-            <a:gs pos="100000">
-              <a:schemeClr val="phClr">
-                <a:tint val="15000"/>
-                <a:satMod val="350000"/>
-              </a:schemeClr>
-            </a:gs>
-          </a:gsLst>
-          <a:lin ang="16200000" scaled="1"/>
-        </a:gradFill>
-        <a:gradFill rotWithShape="1">
-          <a:gsLst>
-            <a:gs pos="0">
-              <a:schemeClr val="phClr">
-                <a:tint val="100000"/>
-                <a:shade val="100000"/>
-                <a:satMod val="130000"/>
-              </a:schemeClr>
-            </a:gs>
-            <a:gs pos="100000">
-              <a:schemeClr val="phClr">
-                <a:tint val="50000"/>
-                <a:shade val="100000"/>
-                <a:satMod val="350000"/>
-              </a:schemeClr>
-            </a:gs>
-          </a:gsLst>
-          <a:lin ang="16200000" scaled="0"/>
-        </a:gradFill>
-      </a:fillStyleLst>
-      <a:lnStyleLst>
-        <a:ln w="9525" cap="flat" cmpd="sng" algn="ctr">
-          <a:solidFill>
-            <a:schemeClr val="phClr">
-              <a:shade val="95000"/>
-              <a:satMod val="105000"/>
-            </a:schemeClr>
-          </a:solidFill>
-          <a:prstDash val="solid"/>
-        </a:ln>
-        <a:ln w="25400" cap="flat" cmpd="sng" algn="ctr">
-          <a:solidFill>
-            <a:schemeClr val="phClr"/>
-          </a:solidFill>
-          <a:prstDash val="solid"/>
-        </a:ln>
-        <a:ln w="38100" cap="flat" cmpd="sng" algn="ctr">
-          <a:solidFill>
-            <a:schemeClr val="phClr"/>
-          </a:solidFill>
-          <a:prstDash val="solid"/>
-        </a:ln>
-      </a:lnStyleLst>
-      <a:effectStyleLst>
-        <a:effectStyle>
-          <a:effectLst>
-            <a:outerShdw blurRad="40000" dist="20000" dir="5400000" rotWithShape="0">
-              <a:srgbClr val="000000">
-                <a:alpha val="38000"/>
-              </a:srgbClr>
-            </a:outerShdw>
-          </a:effectLst>
-        </a:effectStyle>
-        <a:effectStyle>
-          <a:effectLst>
-            <a:outerShdw blurRad="40000" dist="23000" dir="5400000" rotWithShape="0">
-              <a:srgbClr val="000000">
-                <a:alpha val="35000"/>
-              </a:srgbClr>
-            </a:outerShdw>
-          </a:effectLst>
-        </a:effectStyle>
-        <a:effectStyle>
-          <a:effectLst>
-            <a:outerShdw blurRad="40000" dist="23000" dir="5400000" rotWithShape="0">
-              <a:srgbClr val="000000">
-                <a:alpha val="35000"/>
-              </a:srgbClr>
-            </a:outerShdw>
-          </a:effectLst>
-          <a:scene3d>
-            <a:camera prst="orthographicFront">
-              <a:rot lat="0" lon="0" rev="0"/>
-            </a:camera>
-            <a:lightRig rig="threePt" dir="t">
-              <a:rot lat="0" lon="0" rev="1200000"/>
-            </a:lightRig>
-          </a:scene3d>
-          <a:sp3d>
-            <a:bevelT w="63500" h="25400"/>
-          </a:sp3d>
-        </a:effectStyle>
-      </a:effectStyleLst>
-      <a:bgFillStyleLst>
-        <a:solidFill>
-          <a:schemeClr val="phClr"/>
-        </a:solidFill>
-        <a:gradFill rotWithShape="1">
-          <a:gsLst>
-            <a:gs pos="0">
-              <a:schemeClr val="phClr">
-                <a:tint val="40000"/>
-                <a:satMod val="350000"/>
-              </a:schemeClr>
-            </a:gs>
-            <a:gs pos="40000">
-              <a:schemeClr val="phClr">
-                <a:tint val="45000"/>
-                <a:shade val="99000"/>
-                <a:satMod val="350000"/>
-              </a:schemeClr>
-            </a:gs>
-            <a:gs pos="100000">
-              <a:schemeClr val="phClr">
-                <a:shade val="20000"/>
-                <a:satMod val="255000"/>
-              </a:schemeClr>
-            </a:gs>
-          </a:gsLst>
-          <a:path path="circle">
-            <a:fillToRect l="50000" t="-80000" r="50000" b="180000"/>
-          </a:path>
-        </a:gradFill>
-        <a:gradFill rotWithShape="1">
-          <a:gsLst>
-            <a:gs pos="0">
-              <a:schemeClr val="phClr">
-                <a:tint val="80000"/>
-                <a:satMod val="300000"/>
-              </a:schemeClr>
-            </a:gs>
-            <a:gs pos="100000">
-              <a:schemeClr val="phClr">
-                <a:shade val="30000"/>
-                <a:satMod val="200000"/>
-              </a:schemeClr>
-            </a:gs>
-          </a:gsLst>
-          <a:path path="circle">
-            <a:fillToRect l="50000" t="50000" r="50000" b="50000"/>
-          </a:path>
-        </a:gradFill>
-      </a:bgFillStyleLst>
-    </a:fmtScheme>
-  </a:themeElements>
-</a:theme>
 </file>
</xml_diff>

<commit_message>
Update Data Sources from LFX 2026-09-11 (#305)
Update Data Sources from LFX

Signed-off-by: github-actions[bot] <41898282+github-actions[bot]@users.noreply.github.com>
</commit_message>
<xml_diff>
--- a/overview_deck/LF Energy High Level Overview.pptx
+++ b/overview_deck/LF Energy High Level Overview.pptx
@@ -25946,7 +25946,7 @@
             <a:tbl>
               <a:tblPr>
                 <a:noFill/>
-                <a:tableStyleId>{A13EEE81-1922-41B9-9FB7-837E72EC13DA}</a:tableStyleId>
+                <a:tableStyleId>{E5EA786B-85C8-454B-985C-FD49CA89BEF4}</a:tableStyleId>
               </a:tblPr>
               <a:tblGrid>
                 <a:gridCol w="1695200"/>
@@ -26736,7 +26736,7 @@
             <a:tbl>
               <a:tblPr>
                 <a:noFill/>
-                <a:tableStyleId>{A13EEE81-1922-41B9-9FB7-837E72EC13DA}</a:tableStyleId>
+                <a:tableStyleId>{E5EA786B-85C8-454B-985C-FD49CA89BEF4}</a:tableStyleId>
               </a:tblPr>
               <a:tblGrid>
                 <a:gridCol w="1695200"/>
@@ -27426,7 +27426,7 @@
             <a:tbl>
               <a:tblPr>
                 <a:noFill/>
-                <a:tableStyleId>{A13EEE81-1922-41B9-9FB7-837E72EC13DA}</a:tableStyleId>
+                <a:tableStyleId>{E5EA786B-85C8-454B-985C-FD49CA89BEF4}</a:tableStyleId>
               </a:tblPr>
               <a:tblGrid>
                 <a:gridCol w="1695200"/>
@@ -28678,7 +28678,7 @@
             <a:tbl>
               <a:tblPr>
                 <a:noFill/>
-                <a:tableStyleId>{A13EEE81-1922-41B9-9FB7-837E72EC13DA}</a:tableStyleId>
+                <a:tableStyleId>{E5EA786B-85C8-454B-985C-FD49CA89BEF4}</a:tableStyleId>
               </a:tblPr>
               <a:tblGrid>
                 <a:gridCol w="1695200"/>
@@ -29670,7 +29670,7 @@
             <a:tbl>
               <a:tblPr>
                 <a:noFill/>
-                <a:tableStyleId>{A13EEE81-1922-41B9-9FB7-837E72EC13DA}</a:tableStyleId>
+                <a:tableStyleId>{E5EA786B-85C8-454B-985C-FD49CA89BEF4}</a:tableStyleId>
               </a:tblPr>
               <a:tblGrid>
                 <a:gridCol w="3048000"/>
@@ -33175,7 +33175,7 @@
             <a:tbl>
               <a:tblPr>
                 <a:noFill/>
-                <a:tableStyleId>{A13EEE81-1922-41B9-9FB7-837E72EC13DA}</a:tableStyleId>
+                <a:tableStyleId>{E5EA786B-85C8-454B-985C-FD49CA89BEF4}</a:tableStyleId>
               </a:tblPr>
               <a:tblGrid>
                 <a:gridCol w="1828800"/>
@@ -34002,285 +34002,6 @@
 </file>
 
 <file path=ppt/theme/theme1.xml><?xml version="1.0" encoding="utf-8"?>
-<a:theme xmlns:a="http://schemas.openxmlformats.org/drawingml/2006/main" xmlns:r="http://schemas.openxmlformats.org/officeDocument/2006/relationships">
-  <a:themeElements>
-    <a:clrScheme name="Default">
-      <a:dk1>
-        <a:srgbClr val="000000"/>
-      </a:dk1>
-      <a:lt1>
-        <a:srgbClr val="FFFFFF"/>
-      </a:lt1>
-      <a:dk2>
-        <a:srgbClr val="158158"/>
-      </a:dk2>
-      <a:lt2>
-        <a:srgbClr val="F3F3F3"/>
-      </a:lt2>
-      <a:accent1>
-        <a:srgbClr val="058DC7"/>
-      </a:accent1>
-      <a:accent2>
-        <a:srgbClr val="50B432"/>
-      </a:accent2>
-      <a:accent3>
-        <a:srgbClr val="ED561B"/>
-      </a:accent3>
-      <a:accent4>
-        <a:srgbClr val="EDEF00"/>
-      </a:accent4>
-      <a:accent5>
-        <a:srgbClr val="24CBE5"/>
-      </a:accent5>
-      <a:accent6>
-        <a:srgbClr val="64E572"/>
-      </a:accent6>
-      <a:hlink>
-        <a:srgbClr val="2200CC"/>
-      </a:hlink>
-      <a:folHlink>
-        <a:srgbClr val="551A8B"/>
-      </a:folHlink>
-    </a:clrScheme>
-    <a:fontScheme name="Office">
-      <a:majorFont>
-        <a:latin typeface="Arial"/>
-        <a:ea typeface=""/>
-        <a:cs typeface=""/>
-        <a:font script="Jpan" typeface="ＭＳ Ｐゴシック"/>
-        <a:font script="Hang" typeface="맑은 고딕"/>
-        <a:font script="Hans" typeface="宋体"/>
-        <a:font script="Hant" typeface="新細明體"/>
-        <a:font script="Arab" typeface="Times New Roman"/>
-        <a:font script="Hebr" typeface="Times New Roman"/>
-        <a:font script="Thai" typeface="Angsana New"/>
-        <a:font script="Ethi" typeface="Nyala"/>
-        <a:font script="Beng" typeface="Vrinda"/>
-        <a:font script="Gujr" typeface="Shruti"/>
-        <a:font script="Khmr" typeface="MoolBoran"/>
-        <a:font script="Knda" typeface="Tunga"/>
-        <a:font script="Guru" typeface="Raavi"/>
-        <a:font script="Cans" typeface="Euphemia"/>
-        <a:font script="Cher" typeface="Plantagenet Cherokee"/>
-        <a:font script="Yiii" typeface="Microsoft Yi Baiti"/>
-        <a:font script="Tibt" typeface="Microsoft Himalaya"/>
-        <a:font script="Thaa" typeface="MV Boli"/>
-        <a:font script="Deva" typeface="Mangal"/>
-        <a:font script="Telu" typeface="Gautami"/>
-        <a:font script="Taml" typeface="Latha"/>
-        <a:font script="Syrc" typeface="Estrangelo Edessa"/>
-        <a:font script="Orya" typeface="Kalinga"/>
-        <a:font script="Mlym" typeface="Kartika"/>
-        <a:font script="Laoo" typeface="DokChampa"/>
-        <a:font script="Sinh" typeface="Iskoola Pota"/>
-        <a:font script="Mong" typeface="Mongolian Baiti"/>
-        <a:font script="Viet" typeface="Times New Roman"/>
-        <a:font script="Uigh" typeface="Microsoft Uighur"/>
-        <a:font script="Geor" typeface="Sylfaen"/>
-      </a:majorFont>
-      <a:minorFont>
-        <a:latin typeface="Arial"/>
-        <a:ea typeface=""/>
-        <a:cs typeface=""/>
-        <a:font script="Jpan" typeface="ＭＳ Ｐゴシック"/>
-        <a:font script="Hang" typeface="맑은 고딕"/>
-        <a:font script="Hans" typeface="宋体"/>
-        <a:font script="Hant" typeface="新細明體"/>
-        <a:font script="Arab" typeface="Arial"/>
-        <a:font script="Hebr" typeface="Arial"/>
-        <a:font script="Thai" typeface="Cordia New"/>
-        <a:font script="Ethi" typeface="Nyala"/>
-        <a:font script="Beng" typeface="Vrinda"/>
-        <a:font script="Gujr" typeface="Shruti"/>
-        <a:font script="Khmr" typeface="DaunPenh"/>
-        <a:font script="Knda" typeface="Tunga"/>
-        <a:font script="Guru" typeface="Raavi"/>
-        <a:font script="Cans" typeface="Euphemia"/>
-        <a:font script="Cher" typeface="Plantagenet Cherokee"/>
-        <a:font script="Yiii" typeface="Microsoft Yi Baiti"/>
-        <a:font script="Tibt" typeface="Microsoft Himalaya"/>
-        <a:font script="Thaa" typeface="MV Boli"/>
-        <a:font script="Deva" typeface="Mangal"/>
-        <a:font script="Telu" typeface="Gautami"/>
-        <a:font script="Taml" typeface="Latha"/>
-        <a:font script="Syrc" typeface="Estrangelo Edessa"/>
-        <a:font script="Orya" typeface="Kalinga"/>
-        <a:font script="Mlym" typeface="Kartika"/>
-        <a:font script="Laoo" typeface="DokChampa"/>
-        <a:font script="Sinh" typeface="Iskoola Pota"/>
-        <a:font script="Mong" typeface="Mongolian Baiti"/>
-        <a:font script="Viet" typeface="Arial"/>
-        <a:font script="Uigh" typeface="Microsoft Uighur"/>
-        <a:font script="Geor" typeface="Sylfaen"/>
-      </a:minorFont>
-    </a:fontScheme>
-    <a:fmtScheme name="Office">
-      <a:fillStyleLst>
-        <a:solidFill>
-          <a:schemeClr val="phClr"/>
-        </a:solidFill>
-        <a:gradFill rotWithShape="1">
-          <a:gsLst>
-            <a:gs pos="0">
-              <a:schemeClr val="phClr">
-                <a:tint val="50000"/>
-                <a:satMod val="300000"/>
-              </a:schemeClr>
-            </a:gs>
-            <a:gs pos="35000">
-              <a:schemeClr val="phClr">
-                <a:tint val="37000"/>
-                <a:satMod val="300000"/>
-              </a:schemeClr>
-            </a:gs>
-            <a:gs pos="100000">
-              <a:schemeClr val="phClr">
-                <a:tint val="15000"/>
-                <a:satMod val="350000"/>
-              </a:schemeClr>
-            </a:gs>
-          </a:gsLst>
-          <a:lin ang="16200000" scaled="1"/>
-        </a:gradFill>
-        <a:gradFill rotWithShape="1">
-          <a:gsLst>
-            <a:gs pos="0">
-              <a:schemeClr val="phClr">
-                <a:tint val="100000"/>
-                <a:shade val="100000"/>
-                <a:satMod val="130000"/>
-              </a:schemeClr>
-            </a:gs>
-            <a:gs pos="100000">
-              <a:schemeClr val="phClr">
-                <a:tint val="50000"/>
-                <a:shade val="100000"/>
-                <a:satMod val="350000"/>
-              </a:schemeClr>
-            </a:gs>
-          </a:gsLst>
-          <a:lin ang="16200000" scaled="0"/>
-        </a:gradFill>
-      </a:fillStyleLst>
-      <a:lnStyleLst>
-        <a:ln w="9525" cap="flat" cmpd="sng" algn="ctr">
-          <a:solidFill>
-            <a:schemeClr val="phClr">
-              <a:shade val="95000"/>
-              <a:satMod val="105000"/>
-            </a:schemeClr>
-          </a:solidFill>
-          <a:prstDash val="solid"/>
-        </a:ln>
-        <a:ln w="25400" cap="flat" cmpd="sng" algn="ctr">
-          <a:solidFill>
-            <a:schemeClr val="phClr"/>
-          </a:solidFill>
-          <a:prstDash val="solid"/>
-        </a:ln>
-        <a:ln w="38100" cap="flat" cmpd="sng" algn="ctr">
-          <a:solidFill>
-            <a:schemeClr val="phClr"/>
-          </a:solidFill>
-          <a:prstDash val="solid"/>
-        </a:ln>
-      </a:lnStyleLst>
-      <a:effectStyleLst>
-        <a:effectStyle>
-          <a:effectLst>
-            <a:outerShdw blurRad="40000" dist="20000" dir="5400000" rotWithShape="0">
-              <a:srgbClr val="000000">
-                <a:alpha val="38000"/>
-              </a:srgbClr>
-            </a:outerShdw>
-          </a:effectLst>
-        </a:effectStyle>
-        <a:effectStyle>
-          <a:effectLst>
-            <a:outerShdw blurRad="40000" dist="23000" dir="5400000" rotWithShape="0">
-              <a:srgbClr val="000000">
-                <a:alpha val="35000"/>
-              </a:srgbClr>
-            </a:outerShdw>
-          </a:effectLst>
-        </a:effectStyle>
-        <a:effectStyle>
-          <a:effectLst>
-            <a:outerShdw blurRad="40000" dist="23000" dir="5400000" rotWithShape="0">
-              <a:srgbClr val="000000">
-                <a:alpha val="35000"/>
-              </a:srgbClr>
-            </a:outerShdw>
-          </a:effectLst>
-          <a:scene3d>
-            <a:camera prst="orthographicFront">
-              <a:rot lat="0" lon="0" rev="0"/>
-            </a:camera>
-            <a:lightRig rig="threePt" dir="t">
-              <a:rot lat="0" lon="0" rev="1200000"/>
-            </a:lightRig>
-          </a:scene3d>
-          <a:sp3d>
-            <a:bevelT w="63500" h="25400"/>
-          </a:sp3d>
-        </a:effectStyle>
-      </a:effectStyleLst>
-      <a:bgFillStyleLst>
-        <a:solidFill>
-          <a:schemeClr val="phClr"/>
-        </a:solidFill>
-        <a:gradFill rotWithShape="1">
-          <a:gsLst>
-            <a:gs pos="0">
-              <a:schemeClr val="phClr">
-                <a:tint val="40000"/>
-                <a:satMod val="350000"/>
-              </a:schemeClr>
-            </a:gs>
-            <a:gs pos="40000">
-              <a:schemeClr val="phClr">
-                <a:tint val="45000"/>
-                <a:shade val="99000"/>
-                <a:satMod val="350000"/>
-              </a:schemeClr>
-            </a:gs>
-            <a:gs pos="100000">
-              <a:schemeClr val="phClr">
-                <a:shade val="20000"/>
-                <a:satMod val="255000"/>
-              </a:schemeClr>
-            </a:gs>
-          </a:gsLst>
-          <a:path path="circle">
-            <a:fillToRect l="50000" t="-80000" r="50000" b="180000"/>
-          </a:path>
-        </a:gradFill>
-        <a:gradFill rotWithShape="1">
-          <a:gsLst>
-            <a:gs pos="0">
-              <a:schemeClr val="phClr">
-                <a:tint val="80000"/>
-                <a:satMod val="300000"/>
-              </a:schemeClr>
-            </a:gs>
-            <a:gs pos="100000">
-              <a:schemeClr val="phClr">
-                <a:shade val="30000"/>
-                <a:satMod val="200000"/>
-              </a:schemeClr>
-            </a:gs>
-          </a:gsLst>
-          <a:path path="circle">
-            <a:fillToRect l="50000" t="50000" r="50000" b="50000"/>
-          </a:path>
-        </a:gradFill>
-      </a:bgFillStyleLst>
-    </a:fmtScheme>
-  </a:themeElements>
-</a:theme>
-</file>
-
-<file path=ppt/theme/theme2.xml><?xml version="1.0" encoding="utf-8"?>
 <a:theme xmlns:a="http://schemas.openxmlformats.org/drawingml/2006/main" xmlns:r="http://schemas.openxmlformats.org/officeDocument/2006/relationships" name="Simple Light">
   <a:themeElements>
     <a:clrScheme name="Simple Light">
@@ -34559,7 +34280,7 @@
 </a:theme>
 </file>
 
-<file path=ppt/theme/theme3.xml><?xml version="1.0" encoding="utf-8"?>
+<file path=ppt/theme/theme2.xml><?xml version="1.0" encoding="utf-8"?>
 <a:theme xmlns:a="http://schemas.openxmlformats.org/drawingml/2006/main" xmlns:r="http://schemas.openxmlformats.org/officeDocument/2006/relationships" name="LF Energy Theme 2023">
   <a:themeElements>
     <a:clrScheme name="Geometric">
@@ -34836,4 +34557,283 @@
     </a:fmtScheme>
   </a:themeElements>
 </a:theme>
+</file>
+
+<file path=ppt/theme/theme3.xml><?xml version="1.0" encoding="utf-8"?>
+<a:theme xmlns:a="http://schemas.openxmlformats.org/drawingml/2006/main" xmlns:r="http://schemas.openxmlformats.org/officeDocument/2006/relationships">
+  <a:themeElements>
+    <a:clrScheme name="Default">
+      <a:dk1>
+        <a:srgbClr val="000000"/>
+      </a:dk1>
+      <a:lt1>
+        <a:srgbClr val="FFFFFF"/>
+      </a:lt1>
+      <a:dk2>
+        <a:srgbClr val="158158"/>
+      </a:dk2>
+      <a:lt2>
+        <a:srgbClr val="F3F3F3"/>
+      </a:lt2>
+      <a:accent1>
+        <a:srgbClr val="058DC7"/>
+      </a:accent1>
+      <a:accent2>
+        <a:srgbClr val="50B432"/>
+      </a:accent2>
+      <a:accent3>
+        <a:srgbClr val="ED561B"/>
+      </a:accent3>
+      <a:accent4>
+        <a:srgbClr val="EDEF00"/>
+      </a:accent4>
+      <a:accent5>
+        <a:srgbClr val="24CBE5"/>
+      </a:accent5>
+      <a:accent6>
+        <a:srgbClr val="64E572"/>
+      </a:accent6>
+      <a:hlink>
+        <a:srgbClr val="2200CC"/>
+      </a:hlink>
+      <a:folHlink>
+        <a:srgbClr val="551A8B"/>
+      </a:folHlink>
+    </a:clrScheme>
+    <a:fontScheme name="Office">
+      <a:majorFont>
+        <a:latin typeface="Arial"/>
+        <a:ea typeface=""/>
+        <a:cs typeface=""/>
+        <a:font script="Jpan" typeface="ＭＳ Ｐゴシック"/>
+        <a:font script="Hang" typeface="맑은 고딕"/>
+        <a:font script="Hans" typeface="宋体"/>
+        <a:font script="Hant" typeface="新細明體"/>
+        <a:font script="Arab" typeface="Times New Roman"/>
+        <a:font script="Hebr" typeface="Times New Roman"/>
+        <a:font script="Thai" typeface="Angsana New"/>
+        <a:font script="Ethi" typeface="Nyala"/>
+        <a:font script="Beng" typeface="Vrinda"/>
+        <a:font script="Gujr" typeface="Shruti"/>
+        <a:font script="Khmr" typeface="MoolBoran"/>
+        <a:font script="Knda" typeface="Tunga"/>
+        <a:font script="Guru" typeface="Raavi"/>
+        <a:font script="Cans" typeface="Euphemia"/>
+        <a:font script="Cher" typeface="Plantagenet Cherokee"/>
+        <a:font script="Yiii" typeface="Microsoft Yi Baiti"/>
+        <a:font script="Tibt" typeface="Microsoft Himalaya"/>
+        <a:font script="Thaa" typeface="MV Boli"/>
+        <a:font script="Deva" typeface="Mangal"/>
+        <a:font script="Telu" typeface="Gautami"/>
+        <a:font script="Taml" typeface="Latha"/>
+        <a:font script="Syrc" typeface="Estrangelo Edessa"/>
+        <a:font script="Orya" typeface="Kalinga"/>
+        <a:font script="Mlym" typeface="Kartika"/>
+        <a:font script="Laoo" typeface="DokChampa"/>
+        <a:font script="Sinh" typeface="Iskoola Pota"/>
+        <a:font script="Mong" typeface="Mongolian Baiti"/>
+        <a:font script="Viet" typeface="Times New Roman"/>
+        <a:font script="Uigh" typeface="Microsoft Uighur"/>
+        <a:font script="Geor" typeface="Sylfaen"/>
+      </a:majorFont>
+      <a:minorFont>
+        <a:latin typeface="Arial"/>
+        <a:ea typeface=""/>
+        <a:cs typeface=""/>
+        <a:font script="Jpan" typeface="ＭＳ Ｐゴシック"/>
+        <a:font script="Hang" typeface="맑은 고딕"/>
+        <a:font script="Hans" typeface="宋体"/>
+        <a:font script="Hant" typeface="新細明體"/>
+        <a:font script="Arab" typeface="Arial"/>
+        <a:font script="Hebr" typeface="Arial"/>
+        <a:font script="Thai" typeface="Cordia New"/>
+        <a:font script="Ethi" typeface="Nyala"/>
+        <a:font script="Beng" typeface="Vrinda"/>
+        <a:font script="Gujr" typeface="Shruti"/>
+        <a:font script="Khmr" typeface="DaunPenh"/>
+        <a:font script="Knda" typeface="Tunga"/>
+        <a:font script="Guru" typeface="Raavi"/>
+        <a:font script="Cans" typeface="Euphemia"/>
+        <a:font script="Cher" typeface="Plantagenet Cherokee"/>
+        <a:font script="Yiii" typeface="Microsoft Yi Baiti"/>
+        <a:font script="Tibt" typeface="Microsoft Himalaya"/>
+        <a:font script="Thaa" typeface="MV Boli"/>
+        <a:font script="Deva" typeface="Mangal"/>
+        <a:font script="Telu" typeface="Gautami"/>
+        <a:font script="Taml" typeface="Latha"/>
+        <a:font script="Syrc" typeface="Estrangelo Edessa"/>
+        <a:font script="Orya" typeface="Kalinga"/>
+        <a:font script="Mlym" typeface="Kartika"/>
+        <a:font script="Laoo" typeface="DokChampa"/>
+        <a:font script="Sinh" typeface="Iskoola Pota"/>
+        <a:font script="Mong" typeface="Mongolian Baiti"/>
+        <a:font script="Viet" typeface="Arial"/>
+        <a:font script="Uigh" typeface="Microsoft Uighur"/>
+        <a:font script="Geor" typeface="Sylfaen"/>
+      </a:minorFont>
+    </a:fontScheme>
+    <a:fmtScheme name="Office">
+      <a:fillStyleLst>
+        <a:solidFill>
+          <a:schemeClr val="phClr"/>
+        </a:solidFill>
+        <a:gradFill rotWithShape="1">
+          <a:gsLst>
+            <a:gs pos="0">
+              <a:schemeClr val="phClr">
+                <a:tint val="50000"/>
+                <a:satMod val="300000"/>
+              </a:schemeClr>
+            </a:gs>
+            <a:gs pos="35000">
+              <a:schemeClr val="phClr">
+                <a:tint val="37000"/>
+                <a:satMod val="300000"/>
+              </a:schemeClr>
+            </a:gs>
+            <a:gs pos="100000">
+              <a:schemeClr val="phClr">
+                <a:tint val="15000"/>
+                <a:satMod val="350000"/>
+              </a:schemeClr>
+            </a:gs>
+          </a:gsLst>
+          <a:lin ang="16200000" scaled="1"/>
+        </a:gradFill>
+        <a:gradFill rotWithShape="1">
+          <a:gsLst>
+            <a:gs pos="0">
+              <a:schemeClr val="phClr">
+                <a:tint val="100000"/>
+                <a:shade val="100000"/>
+                <a:satMod val="130000"/>
+              </a:schemeClr>
+            </a:gs>
+            <a:gs pos="100000">
+              <a:schemeClr val="phClr">
+                <a:tint val="50000"/>
+                <a:shade val="100000"/>
+                <a:satMod val="350000"/>
+              </a:schemeClr>
+            </a:gs>
+          </a:gsLst>
+          <a:lin ang="16200000" scaled="0"/>
+        </a:gradFill>
+      </a:fillStyleLst>
+      <a:lnStyleLst>
+        <a:ln w="9525" cap="flat" cmpd="sng" algn="ctr">
+          <a:solidFill>
+            <a:schemeClr val="phClr">
+              <a:shade val="95000"/>
+              <a:satMod val="105000"/>
+            </a:schemeClr>
+          </a:solidFill>
+          <a:prstDash val="solid"/>
+        </a:ln>
+        <a:ln w="25400" cap="flat" cmpd="sng" algn="ctr">
+          <a:solidFill>
+            <a:schemeClr val="phClr"/>
+          </a:solidFill>
+          <a:prstDash val="solid"/>
+        </a:ln>
+        <a:ln w="38100" cap="flat" cmpd="sng" algn="ctr">
+          <a:solidFill>
+            <a:schemeClr val="phClr"/>
+          </a:solidFill>
+          <a:prstDash val="solid"/>
+        </a:ln>
+      </a:lnStyleLst>
+      <a:effectStyleLst>
+        <a:effectStyle>
+          <a:effectLst>
+            <a:outerShdw blurRad="40000" dist="20000" dir="5400000" rotWithShape="0">
+              <a:srgbClr val="000000">
+                <a:alpha val="38000"/>
+              </a:srgbClr>
+            </a:outerShdw>
+          </a:effectLst>
+        </a:effectStyle>
+        <a:effectStyle>
+          <a:effectLst>
+            <a:outerShdw blurRad="40000" dist="23000" dir="5400000" rotWithShape="0">
+              <a:srgbClr val="000000">
+                <a:alpha val="35000"/>
+              </a:srgbClr>
+            </a:outerShdw>
+          </a:effectLst>
+        </a:effectStyle>
+        <a:effectStyle>
+          <a:effectLst>
+            <a:outerShdw blurRad="40000" dist="23000" dir="5400000" rotWithShape="0">
+              <a:srgbClr val="000000">
+                <a:alpha val="35000"/>
+              </a:srgbClr>
+            </a:outerShdw>
+          </a:effectLst>
+          <a:scene3d>
+            <a:camera prst="orthographicFront">
+              <a:rot lat="0" lon="0" rev="0"/>
+            </a:camera>
+            <a:lightRig rig="threePt" dir="t">
+              <a:rot lat="0" lon="0" rev="1200000"/>
+            </a:lightRig>
+          </a:scene3d>
+          <a:sp3d>
+            <a:bevelT w="63500" h="25400"/>
+          </a:sp3d>
+        </a:effectStyle>
+      </a:effectStyleLst>
+      <a:bgFillStyleLst>
+        <a:solidFill>
+          <a:schemeClr val="phClr"/>
+        </a:solidFill>
+        <a:gradFill rotWithShape="1">
+          <a:gsLst>
+            <a:gs pos="0">
+              <a:schemeClr val="phClr">
+                <a:tint val="40000"/>
+                <a:satMod val="350000"/>
+              </a:schemeClr>
+            </a:gs>
+            <a:gs pos="40000">
+              <a:schemeClr val="phClr">
+                <a:tint val="45000"/>
+                <a:shade val="99000"/>
+                <a:satMod val="350000"/>
+              </a:schemeClr>
+            </a:gs>
+            <a:gs pos="100000">
+              <a:schemeClr val="phClr">
+                <a:shade val="20000"/>
+                <a:satMod val="255000"/>
+              </a:schemeClr>
+            </a:gs>
+          </a:gsLst>
+          <a:path path="circle">
+            <a:fillToRect l="50000" t="-80000" r="50000" b="180000"/>
+          </a:path>
+        </a:gradFill>
+        <a:gradFill rotWithShape="1">
+          <a:gsLst>
+            <a:gs pos="0">
+              <a:schemeClr val="phClr">
+                <a:tint val="80000"/>
+                <a:satMod val="300000"/>
+              </a:schemeClr>
+            </a:gs>
+            <a:gs pos="100000">
+              <a:schemeClr val="phClr">
+                <a:shade val="30000"/>
+                <a:satMod val="200000"/>
+              </a:schemeClr>
+            </a:gs>
+          </a:gsLst>
+          <a:path path="circle">
+            <a:fillToRect l="50000" t="50000" r="50000" b="50000"/>
+          </a:path>
+        </a:gradFill>
+      </a:bgFillStyleLst>
+    </a:fmtScheme>
+  </a:themeElements>
+</a:theme>
 </file>
</xml_diff>

<commit_message>
Update Data Sources from LFX 2026-09-12 (#306)
Update Data Sources from LFX

Signed-off-by: github-actions[bot] <41898282+github-actions[bot]@users.noreply.github.com>
</commit_message>
<xml_diff>
--- a/overview_deck/LF Energy High Level Overview.pptx
+++ b/overview_deck/LF Energy High Level Overview.pptx
@@ -25946,7 +25946,7 @@
             <a:tbl>
               <a:tblPr>
                 <a:noFill/>
-                <a:tableStyleId>{E5EA786B-85C8-454B-985C-FD49CA89BEF4}</a:tableStyleId>
+                <a:tableStyleId>{6308F22D-557F-4E92-9789-9B39D22F22B9}</a:tableStyleId>
               </a:tblPr>
               <a:tblGrid>
                 <a:gridCol w="1695200"/>
@@ -26736,7 +26736,7 @@
             <a:tbl>
               <a:tblPr>
                 <a:noFill/>
-                <a:tableStyleId>{E5EA786B-85C8-454B-985C-FD49CA89BEF4}</a:tableStyleId>
+                <a:tableStyleId>{6308F22D-557F-4E92-9789-9B39D22F22B9}</a:tableStyleId>
               </a:tblPr>
               <a:tblGrid>
                 <a:gridCol w="1695200"/>
@@ -27426,7 +27426,7 @@
             <a:tbl>
               <a:tblPr>
                 <a:noFill/>
-                <a:tableStyleId>{E5EA786B-85C8-454B-985C-FD49CA89BEF4}</a:tableStyleId>
+                <a:tableStyleId>{6308F22D-557F-4E92-9789-9B39D22F22B9}</a:tableStyleId>
               </a:tblPr>
               <a:tblGrid>
                 <a:gridCol w="1695200"/>
@@ -28678,7 +28678,7 @@
             <a:tbl>
               <a:tblPr>
                 <a:noFill/>
-                <a:tableStyleId>{E5EA786B-85C8-454B-985C-FD49CA89BEF4}</a:tableStyleId>
+                <a:tableStyleId>{6308F22D-557F-4E92-9789-9B39D22F22B9}</a:tableStyleId>
               </a:tblPr>
               <a:tblGrid>
                 <a:gridCol w="1695200"/>
@@ -29670,7 +29670,7 @@
             <a:tbl>
               <a:tblPr>
                 <a:noFill/>
-                <a:tableStyleId>{E5EA786B-85C8-454B-985C-FD49CA89BEF4}</a:tableStyleId>
+                <a:tableStyleId>{6308F22D-557F-4E92-9789-9B39D22F22B9}</a:tableStyleId>
               </a:tblPr>
               <a:tblGrid>
                 <a:gridCol w="3048000"/>
@@ -33175,7 +33175,7 @@
             <a:tbl>
               <a:tblPr>
                 <a:noFill/>
-                <a:tableStyleId>{E5EA786B-85C8-454B-985C-FD49CA89BEF4}</a:tableStyleId>
+                <a:tableStyleId>{6308F22D-557F-4E92-9789-9B39D22F22B9}</a:tableStyleId>
               </a:tblPr>
               <a:tblGrid>
                 <a:gridCol w="1828800"/>
@@ -34002,44 +34002,44 @@
 </file>
 
 <file path=ppt/theme/theme1.xml><?xml version="1.0" encoding="utf-8"?>
-<a:theme xmlns:a="http://schemas.openxmlformats.org/drawingml/2006/main" xmlns:r="http://schemas.openxmlformats.org/officeDocument/2006/relationships" name="Simple Light">
+<a:theme xmlns:a="http://schemas.openxmlformats.org/drawingml/2006/main" xmlns:r="http://schemas.openxmlformats.org/officeDocument/2006/relationships" name="LF Energy Theme 2023">
   <a:themeElements>
-    <a:clrScheme name="Simple Light">
+    <a:clrScheme name="Geometric">
       <a:dk1>
-        <a:srgbClr val="000000"/>
+        <a:srgbClr val="222222"/>
       </a:dk1>
       <a:lt1>
         <a:srgbClr val="FFFFFF"/>
       </a:lt1>
       <a:dk2>
-        <a:srgbClr val="595959"/>
+        <a:srgbClr val="434343"/>
       </a:dk2>
       <a:lt2>
-        <a:srgbClr val="EEEEEE"/>
+        <a:srgbClr val="999999"/>
       </a:lt2>
       <a:accent1>
-        <a:srgbClr val="4285F4"/>
+        <a:srgbClr val="003778"/>
       </a:accent1>
       <a:accent2>
-        <a:srgbClr val="212121"/>
+        <a:srgbClr val="0094FF"/>
       </a:accent2>
       <a:accent3>
-        <a:srgbClr val="78909C"/>
+        <a:srgbClr val="5B1DE7"/>
       </a:accent3>
       <a:accent4>
-        <a:srgbClr val="FFAB40"/>
+        <a:srgbClr val="12E2E2"/>
       </a:accent4>
       <a:accent5>
-        <a:srgbClr val="0097A7"/>
+        <a:srgbClr val="FF00AA"/>
       </a:accent5>
       <a:accent6>
-        <a:srgbClr val="EEFF41"/>
+        <a:srgbClr val="ACDE1F"/>
       </a:accent6>
       <a:hlink>
-        <a:srgbClr val="0097A7"/>
+        <a:srgbClr val="0077CC"/>
       </a:hlink>
       <a:folHlink>
-        <a:srgbClr val="0097A7"/>
+        <a:srgbClr val="F06292"/>
       </a:folHlink>
     </a:clrScheme>
     <a:fontScheme name="Office">
@@ -34281,44 +34281,44 @@
 </file>
 
 <file path=ppt/theme/theme2.xml><?xml version="1.0" encoding="utf-8"?>
-<a:theme xmlns:a="http://schemas.openxmlformats.org/drawingml/2006/main" xmlns:r="http://schemas.openxmlformats.org/officeDocument/2006/relationships" name="LF Energy Theme 2023">
+<a:theme xmlns:a="http://schemas.openxmlformats.org/drawingml/2006/main" xmlns:r="http://schemas.openxmlformats.org/officeDocument/2006/relationships" name="Simple Light">
   <a:themeElements>
-    <a:clrScheme name="Geometric">
+    <a:clrScheme name="Simple Light">
       <a:dk1>
-        <a:srgbClr val="222222"/>
+        <a:srgbClr val="000000"/>
       </a:dk1>
       <a:lt1>
         <a:srgbClr val="FFFFFF"/>
       </a:lt1>
       <a:dk2>
-        <a:srgbClr val="434343"/>
+        <a:srgbClr val="595959"/>
       </a:dk2>
       <a:lt2>
-        <a:srgbClr val="999999"/>
+        <a:srgbClr val="EEEEEE"/>
       </a:lt2>
       <a:accent1>
-        <a:srgbClr val="003778"/>
+        <a:srgbClr val="4285F4"/>
       </a:accent1>
       <a:accent2>
-        <a:srgbClr val="0094FF"/>
+        <a:srgbClr val="212121"/>
       </a:accent2>
       <a:accent3>
-        <a:srgbClr val="5B1DE7"/>
+        <a:srgbClr val="78909C"/>
       </a:accent3>
       <a:accent4>
-        <a:srgbClr val="12E2E2"/>
+        <a:srgbClr val="FFAB40"/>
       </a:accent4>
       <a:accent5>
-        <a:srgbClr val="FF00AA"/>
+        <a:srgbClr val="0097A7"/>
       </a:accent5>
       <a:accent6>
-        <a:srgbClr val="ACDE1F"/>
+        <a:srgbClr val="EEFF41"/>
       </a:accent6>
       <a:hlink>
-        <a:srgbClr val="0077CC"/>
+        <a:srgbClr val="0097A7"/>
       </a:hlink>
       <a:folHlink>
-        <a:srgbClr val="F06292"/>
+        <a:srgbClr val="0097A7"/>
       </a:folHlink>
     </a:clrScheme>
     <a:fontScheme name="Office">

</xml_diff>

<commit_message>
Update Data Sources from LFX 2026-09-13 (#307)
Update Data Sources from LFX

Signed-off-by: github-actions[bot] <41898282+github-actions[bot]@users.noreply.github.com>
</commit_message>
<xml_diff>
--- a/overview_deck/LF Energy High Level Overview.pptx
+++ b/overview_deck/LF Energy High Level Overview.pptx
@@ -25946,7 +25946,7 @@
             <a:tbl>
               <a:tblPr>
                 <a:noFill/>
-                <a:tableStyleId>{6308F22D-557F-4E92-9789-9B39D22F22B9}</a:tableStyleId>
+                <a:tableStyleId>{BF0CAEFB-12BF-4148-A3F1-FB1B6D2CC27C}</a:tableStyleId>
               </a:tblPr>
               <a:tblGrid>
                 <a:gridCol w="1695200"/>
@@ -26736,7 +26736,7 @@
             <a:tbl>
               <a:tblPr>
                 <a:noFill/>
-                <a:tableStyleId>{6308F22D-557F-4E92-9789-9B39D22F22B9}</a:tableStyleId>
+                <a:tableStyleId>{BF0CAEFB-12BF-4148-A3F1-FB1B6D2CC27C}</a:tableStyleId>
               </a:tblPr>
               <a:tblGrid>
                 <a:gridCol w="1695200"/>
@@ -27426,7 +27426,7 @@
             <a:tbl>
               <a:tblPr>
                 <a:noFill/>
-                <a:tableStyleId>{6308F22D-557F-4E92-9789-9B39D22F22B9}</a:tableStyleId>
+                <a:tableStyleId>{BF0CAEFB-12BF-4148-A3F1-FB1B6D2CC27C}</a:tableStyleId>
               </a:tblPr>
               <a:tblGrid>
                 <a:gridCol w="1695200"/>
@@ -28678,7 +28678,7 @@
             <a:tbl>
               <a:tblPr>
                 <a:noFill/>
-                <a:tableStyleId>{6308F22D-557F-4E92-9789-9B39D22F22B9}</a:tableStyleId>
+                <a:tableStyleId>{BF0CAEFB-12BF-4148-A3F1-FB1B6D2CC27C}</a:tableStyleId>
               </a:tblPr>
               <a:tblGrid>
                 <a:gridCol w="1695200"/>
@@ -29670,7 +29670,7 @@
             <a:tbl>
               <a:tblPr>
                 <a:noFill/>
-                <a:tableStyleId>{6308F22D-557F-4E92-9789-9B39D22F22B9}</a:tableStyleId>
+                <a:tableStyleId>{BF0CAEFB-12BF-4148-A3F1-FB1B6D2CC27C}</a:tableStyleId>
               </a:tblPr>
               <a:tblGrid>
                 <a:gridCol w="3048000"/>
@@ -33175,7 +33175,7 @@
             <a:tbl>
               <a:tblPr>
                 <a:noFill/>
-                <a:tableStyleId>{6308F22D-557F-4E92-9789-9B39D22F22B9}</a:tableStyleId>
+                <a:tableStyleId>{BF0CAEFB-12BF-4148-A3F1-FB1B6D2CC27C}</a:tableStyleId>
               </a:tblPr>
               <a:tblGrid>
                 <a:gridCol w="1828800"/>
@@ -34002,285 +34002,6 @@
 </file>
 
 <file path=ppt/theme/theme1.xml><?xml version="1.0" encoding="utf-8"?>
-<a:theme xmlns:a="http://schemas.openxmlformats.org/drawingml/2006/main" xmlns:r="http://schemas.openxmlformats.org/officeDocument/2006/relationships" name="LF Energy Theme 2023">
-  <a:themeElements>
-    <a:clrScheme name="Geometric">
-      <a:dk1>
-        <a:srgbClr val="222222"/>
-      </a:dk1>
-      <a:lt1>
-        <a:srgbClr val="FFFFFF"/>
-      </a:lt1>
-      <a:dk2>
-        <a:srgbClr val="434343"/>
-      </a:dk2>
-      <a:lt2>
-        <a:srgbClr val="999999"/>
-      </a:lt2>
-      <a:accent1>
-        <a:srgbClr val="003778"/>
-      </a:accent1>
-      <a:accent2>
-        <a:srgbClr val="0094FF"/>
-      </a:accent2>
-      <a:accent3>
-        <a:srgbClr val="5B1DE7"/>
-      </a:accent3>
-      <a:accent4>
-        <a:srgbClr val="12E2E2"/>
-      </a:accent4>
-      <a:accent5>
-        <a:srgbClr val="FF00AA"/>
-      </a:accent5>
-      <a:accent6>
-        <a:srgbClr val="ACDE1F"/>
-      </a:accent6>
-      <a:hlink>
-        <a:srgbClr val="0077CC"/>
-      </a:hlink>
-      <a:folHlink>
-        <a:srgbClr val="F06292"/>
-      </a:folHlink>
-    </a:clrScheme>
-    <a:fontScheme name="Office">
-      <a:majorFont>
-        <a:latin typeface="Arial"/>
-        <a:ea typeface=""/>
-        <a:cs typeface=""/>
-        <a:font script="Jpan" typeface="ＭＳ Ｐゴシック"/>
-        <a:font script="Hang" typeface="맑은 고딕"/>
-        <a:font script="Hans" typeface="宋体"/>
-        <a:font script="Hant" typeface="新細明體"/>
-        <a:font script="Arab" typeface="Times New Roman"/>
-        <a:font script="Hebr" typeface="Times New Roman"/>
-        <a:font script="Thai" typeface="Angsana New"/>
-        <a:font script="Ethi" typeface="Nyala"/>
-        <a:font script="Beng" typeface="Vrinda"/>
-        <a:font script="Gujr" typeface="Shruti"/>
-        <a:font script="Khmr" typeface="MoolBoran"/>
-        <a:font script="Knda" typeface="Tunga"/>
-        <a:font script="Guru" typeface="Raavi"/>
-        <a:font script="Cans" typeface="Euphemia"/>
-        <a:font script="Cher" typeface="Plantagenet Cherokee"/>
-        <a:font script="Yiii" typeface="Microsoft Yi Baiti"/>
-        <a:font script="Tibt" typeface="Microsoft Himalaya"/>
-        <a:font script="Thaa" typeface="MV Boli"/>
-        <a:font script="Deva" typeface="Mangal"/>
-        <a:font script="Telu" typeface="Gautami"/>
-        <a:font script="Taml" typeface="Latha"/>
-        <a:font script="Syrc" typeface="Estrangelo Edessa"/>
-        <a:font script="Orya" typeface="Kalinga"/>
-        <a:font script="Mlym" typeface="Kartika"/>
-        <a:font script="Laoo" typeface="DokChampa"/>
-        <a:font script="Sinh" typeface="Iskoola Pota"/>
-        <a:font script="Mong" typeface="Mongolian Baiti"/>
-        <a:font script="Viet" typeface="Times New Roman"/>
-        <a:font script="Uigh" typeface="Microsoft Uighur"/>
-        <a:font script="Geor" typeface="Sylfaen"/>
-      </a:majorFont>
-      <a:minorFont>
-        <a:latin typeface="Arial"/>
-        <a:ea typeface=""/>
-        <a:cs typeface=""/>
-        <a:font script="Jpan" typeface="ＭＳ Ｐゴシック"/>
-        <a:font script="Hang" typeface="맑은 고딕"/>
-        <a:font script="Hans" typeface="宋体"/>
-        <a:font script="Hant" typeface="新細明體"/>
-        <a:font script="Arab" typeface="Arial"/>
-        <a:font script="Hebr" typeface="Arial"/>
-        <a:font script="Thai" typeface="Cordia New"/>
-        <a:font script="Ethi" typeface="Nyala"/>
-        <a:font script="Beng" typeface="Vrinda"/>
-        <a:font script="Gujr" typeface="Shruti"/>
-        <a:font script="Khmr" typeface="DaunPenh"/>
-        <a:font script="Knda" typeface="Tunga"/>
-        <a:font script="Guru" typeface="Raavi"/>
-        <a:font script="Cans" typeface="Euphemia"/>
-        <a:font script="Cher" typeface="Plantagenet Cherokee"/>
-        <a:font script="Yiii" typeface="Microsoft Yi Baiti"/>
-        <a:font script="Tibt" typeface="Microsoft Himalaya"/>
-        <a:font script="Thaa" typeface="MV Boli"/>
-        <a:font script="Deva" typeface="Mangal"/>
-        <a:font script="Telu" typeface="Gautami"/>
-        <a:font script="Taml" typeface="Latha"/>
-        <a:font script="Syrc" typeface="Estrangelo Edessa"/>
-        <a:font script="Orya" typeface="Kalinga"/>
-        <a:font script="Mlym" typeface="Kartika"/>
-        <a:font script="Laoo" typeface="DokChampa"/>
-        <a:font script="Sinh" typeface="Iskoola Pota"/>
-        <a:font script="Mong" typeface="Mongolian Baiti"/>
-        <a:font script="Viet" typeface="Arial"/>
-        <a:font script="Uigh" typeface="Microsoft Uighur"/>
-        <a:font script="Geor" typeface="Sylfaen"/>
-      </a:minorFont>
-    </a:fontScheme>
-    <a:fmtScheme name="Office">
-      <a:fillStyleLst>
-        <a:solidFill>
-          <a:schemeClr val="phClr"/>
-        </a:solidFill>
-        <a:gradFill rotWithShape="1">
-          <a:gsLst>
-            <a:gs pos="0">
-              <a:schemeClr val="phClr">
-                <a:tint val="50000"/>
-                <a:satMod val="300000"/>
-              </a:schemeClr>
-            </a:gs>
-            <a:gs pos="35000">
-              <a:schemeClr val="phClr">
-                <a:tint val="37000"/>
-                <a:satMod val="300000"/>
-              </a:schemeClr>
-            </a:gs>
-            <a:gs pos="100000">
-              <a:schemeClr val="phClr">
-                <a:tint val="15000"/>
-                <a:satMod val="350000"/>
-              </a:schemeClr>
-            </a:gs>
-          </a:gsLst>
-          <a:lin ang="16200000" scaled="1"/>
-        </a:gradFill>
-        <a:gradFill rotWithShape="1">
-          <a:gsLst>
-            <a:gs pos="0">
-              <a:schemeClr val="phClr">
-                <a:tint val="100000"/>
-                <a:shade val="100000"/>
-                <a:satMod val="130000"/>
-              </a:schemeClr>
-            </a:gs>
-            <a:gs pos="100000">
-              <a:schemeClr val="phClr">
-                <a:tint val="50000"/>
-                <a:shade val="100000"/>
-                <a:satMod val="350000"/>
-              </a:schemeClr>
-            </a:gs>
-          </a:gsLst>
-          <a:lin ang="16200000" scaled="0"/>
-        </a:gradFill>
-      </a:fillStyleLst>
-      <a:lnStyleLst>
-        <a:ln w="9525" cap="flat" cmpd="sng" algn="ctr">
-          <a:solidFill>
-            <a:schemeClr val="phClr">
-              <a:shade val="95000"/>
-              <a:satMod val="105000"/>
-            </a:schemeClr>
-          </a:solidFill>
-          <a:prstDash val="solid"/>
-        </a:ln>
-        <a:ln w="25400" cap="flat" cmpd="sng" algn="ctr">
-          <a:solidFill>
-            <a:schemeClr val="phClr"/>
-          </a:solidFill>
-          <a:prstDash val="solid"/>
-        </a:ln>
-        <a:ln w="38100" cap="flat" cmpd="sng" algn="ctr">
-          <a:solidFill>
-            <a:schemeClr val="phClr"/>
-          </a:solidFill>
-          <a:prstDash val="solid"/>
-        </a:ln>
-      </a:lnStyleLst>
-      <a:effectStyleLst>
-        <a:effectStyle>
-          <a:effectLst>
-            <a:outerShdw blurRad="40000" dist="20000" dir="5400000" rotWithShape="0">
-              <a:srgbClr val="000000">
-                <a:alpha val="38000"/>
-              </a:srgbClr>
-            </a:outerShdw>
-          </a:effectLst>
-        </a:effectStyle>
-        <a:effectStyle>
-          <a:effectLst>
-            <a:outerShdw blurRad="40000" dist="23000" dir="5400000" rotWithShape="0">
-              <a:srgbClr val="000000">
-                <a:alpha val="35000"/>
-              </a:srgbClr>
-            </a:outerShdw>
-          </a:effectLst>
-        </a:effectStyle>
-        <a:effectStyle>
-          <a:effectLst>
-            <a:outerShdw blurRad="40000" dist="23000" dir="5400000" rotWithShape="0">
-              <a:srgbClr val="000000">
-                <a:alpha val="35000"/>
-              </a:srgbClr>
-            </a:outerShdw>
-          </a:effectLst>
-          <a:scene3d>
-            <a:camera prst="orthographicFront">
-              <a:rot lat="0" lon="0" rev="0"/>
-            </a:camera>
-            <a:lightRig rig="threePt" dir="t">
-              <a:rot lat="0" lon="0" rev="1200000"/>
-            </a:lightRig>
-          </a:scene3d>
-          <a:sp3d>
-            <a:bevelT w="63500" h="25400"/>
-          </a:sp3d>
-        </a:effectStyle>
-      </a:effectStyleLst>
-      <a:bgFillStyleLst>
-        <a:solidFill>
-          <a:schemeClr val="phClr"/>
-        </a:solidFill>
-        <a:gradFill rotWithShape="1">
-          <a:gsLst>
-            <a:gs pos="0">
-              <a:schemeClr val="phClr">
-                <a:tint val="40000"/>
-                <a:satMod val="350000"/>
-              </a:schemeClr>
-            </a:gs>
-            <a:gs pos="40000">
-              <a:schemeClr val="phClr">
-                <a:tint val="45000"/>
-                <a:shade val="99000"/>
-                <a:satMod val="350000"/>
-              </a:schemeClr>
-            </a:gs>
-            <a:gs pos="100000">
-              <a:schemeClr val="phClr">
-                <a:shade val="20000"/>
-                <a:satMod val="255000"/>
-              </a:schemeClr>
-            </a:gs>
-          </a:gsLst>
-          <a:path path="circle">
-            <a:fillToRect l="50000" t="-80000" r="50000" b="180000"/>
-          </a:path>
-        </a:gradFill>
-        <a:gradFill rotWithShape="1">
-          <a:gsLst>
-            <a:gs pos="0">
-              <a:schemeClr val="phClr">
-                <a:tint val="80000"/>
-                <a:satMod val="300000"/>
-              </a:schemeClr>
-            </a:gs>
-            <a:gs pos="100000">
-              <a:schemeClr val="phClr">
-                <a:shade val="30000"/>
-                <a:satMod val="200000"/>
-              </a:schemeClr>
-            </a:gs>
-          </a:gsLst>
-          <a:path path="circle">
-            <a:fillToRect l="50000" t="50000" r="50000" b="50000"/>
-          </a:path>
-        </a:gradFill>
-      </a:bgFillStyleLst>
-    </a:fmtScheme>
-  </a:themeElements>
-</a:theme>
-</file>
-
-<file path=ppt/theme/theme2.xml><?xml version="1.0" encoding="utf-8"?>
 <a:theme xmlns:a="http://schemas.openxmlformats.org/drawingml/2006/main" xmlns:r="http://schemas.openxmlformats.org/officeDocument/2006/relationships" name="Simple Light">
   <a:themeElements>
     <a:clrScheme name="Simple Light">
@@ -34559,7 +34280,7 @@
 </a:theme>
 </file>
 
-<file path=ppt/theme/theme3.xml><?xml version="1.0" encoding="utf-8"?>
+<file path=ppt/theme/theme2.xml><?xml version="1.0" encoding="utf-8"?>
 <a:theme xmlns:a="http://schemas.openxmlformats.org/drawingml/2006/main" xmlns:r="http://schemas.openxmlformats.org/officeDocument/2006/relationships">
   <a:themeElements>
     <a:clrScheme name="Default">
@@ -34836,4 +34557,283 @@
     </a:fmtScheme>
   </a:themeElements>
 </a:theme>
+</file>
+
+<file path=ppt/theme/theme3.xml><?xml version="1.0" encoding="utf-8"?>
+<a:theme xmlns:a="http://schemas.openxmlformats.org/drawingml/2006/main" xmlns:r="http://schemas.openxmlformats.org/officeDocument/2006/relationships" name="LF Energy Theme 2023">
+  <a:themeElements>
+    <a:clrScheme name="Geometric">
+      <a:dk1>
+        <a:srgbClr val="222222"/>
+      </a:dk1>
+      <a:lt1>
+        <a:srgbClr val="FFFFFF"/>
+      </a:lt1>
+      <a:dk2>
+        <a:srgbClr val="434343"/>
+      </a:dk2>
+      <a:lt2>
+        <a:srgbClr val="999999"/>
+      </a:lt2>
+      <a:accent1>
+        <a:srgbClr val="003778"/>
+      </a:accent1>
+      <a:accent2>
+        <a:srgbClr val="0094FF"/>
+      </a:accent2>
+      <a:accent3>
+        <a:srgbClr val="5B1DE7"/>
+      </a:accent3>
+      <a:accent4>
+        <a:srgbClr val="12E2E2"/>
+      </a:accent4>
+      <a:accent5>
+        <a:srgbClr val="FF00AA"/>
+      </a:accent5>
+      <a:accent6>
+        <a:srgbClr val="ACDE1F"/>
+      </a:accent6>
+      <a:hlink>
+        <a:srgbClr val="0077CC"/>
+      </a:hlink>
+      <a:folHlink>
+        <a:srgbClr val="F06292"/>
+      </a:folHlink>
+    </a:clrScheme>
+    <a:fontScheme name="Office">
+      <a:majorFont>
+        <a:latin typeface="Arial"/>
+        <a:ea typeface=""/>
+        <a:cs typeface=""/>
+        <a:font script="Jpan" typeface="ＭＳ Ｐゴシック"/>
+        <a:font script="Hang" typeface="맑은 고딕"/>
+        <a:font script="Hans" typeface="宋体"/>
+        <a:font script="Hant" typeface="新細明體"/>
+        <a:font script="Arab" typeface="Times New Roman"/>
+        <a:font script="Hebr" typeface="Times New Roman"/>
+        <a:font script="Thai" typeface="Angsana New"/>
+        <a:font script="Ethi" typeface="Nyala"/>
+        <a:font script="Beng" typeface="Vrinda"/>
+        <a:font script="Gujr" typeface="Shruti"/>
+        <a:font script="Khmr" typeface="MoolBoran"/>
+        <a:font script="Knda" typeface="Tunga"/>
+        <a:font script="Guru" typeface="Raavi"/>
+        <a:font script="Cans" typeface="Euphemia"/>
+        <a:font script="Cher" typeface="Plantagenet Cherokee"/>
+        <a:font script="Yiii" typeface="Microsoft Yi Baiti"/>
+        <a:font script="Tibt" typeface="Microsoft Himalaya"/>
+        <a:font script="Thaa" typeface="MV Boli"/>
+        <a:font script="Deva" typeface="Mangal"/>
+        <a:font script="Telu" typeface="Gautami"/>
+        <a:font script="Taml" typeface="Latha"/>
+        <a:font script="Syrc" typeface="Estrangelo Edessa"/>
+        <a:font script="Orya" typeface="Kalinga"/>
+        <a:font script="Mlym" typeface="Kartika"/>
+        <a:font script="Laoo" typeface="DokChampa"/>
+        <a:font script="Sinh" typeface="Iskoola Pota"/>
+        <a:font script="Mong" typeface="Mongolian Baiti"/>
+        <a:font script="Viet" typeface="Times New Roman"/>
+        <a:font script="Uigh" typeface="Microsoft Uighur"/>
+        <a:font script="Geor" typeface="Sylfaen"/>
+      </a:majorFont>
+      <a:minorFont>
+        <a:latin typeface="Arial"/>
+        <a:ea typeface=""/>
+        <a:cs typeface=""/>
+        <a:font script="Jpan" typeface="ＭＳ Ｐゴシック"/>
+        <a:font script="Hang" typeface="맑은 고딕"/>
+        <a:font script="Hans" typeface="宋体"/>
+        <a:font script="Hant" typeface="新細明體"/>
+        <a:font script="Arab" typeface="Arial"/>
+        <a:font script="Hebr" typeface="Arial"/>
+        <a:font script="Thai" typeface="Cordia New"/>
+        <a:font script="Ethi" typeface="Nyala"/>
+        <a:font script="Beng" typeface="Vrinda"/>
+        <a:font script="Gujr" typeface="Shruti"/>
+        <a:font script="Khmr" typeface="DaunPenh"/>
+        <a:font script="Knda" typeface="Tunga"/>
+        <a:font script="Guru" typeface="Raavi"/>
+        <a:font script="Cans" typeface="Euphemia"/>
+        <a:font script="Cher" typeface="Plantagenet Cherokee"/>
+        <a:font script="Yiii" typeface="Microsoft Yi Baiti"/>
+        <a:font script="Tibt" typeface="Microsoft Himalaya"/>
+        <a:font script="Thaa" typeface="MV Boli"/>
+        <a:font script="Deva" typeface="Mangal"/>
+        <a:font script="Telu" typeface="Gautami"/>
+        <a:font script="Taml" typeface="Latha"/>
+        <a:font script="Syrc" typeface="Estrangelo Edessa"/>
+        <a:font script="Orya" typeface="Kalinga"/>
+        <a:font script="Mlym" typeface="Kartika"/>
+        <a:font script="Laoo" typeface="DokChampa"/>
+        <a:font script="Sinh" typeface="Iskoola Pota"/>
+        <a:font script="Mong" typeface="Mongolian Baiti"/>
+        <a:font script="Viet" typeface="Arial"/>
+        <a:font script="Uigh" typeface="Microsoft Uighur"/>
+        <a:font script="Geor" typeface="Sylfaen"/>
+      </a:minorFont>
+    </a:fontScheme>
+    <a:fmtScheme name="Office">
+      <a:fillStyleLst>
+        <a:solidFill>
+          <a:schemeClr val="phClr"/>
+        </a:solidFill>
+        <a:gradFill rotWithShape="1">
+          <a:gsLst>
+            <a:gs pos="0">
+              <a:schemeClr val="phClr">
+                <a:tint val="50000"/>
+                <a:satMod val="300000"/>
+              </a:schemeClr>
+            </a:gs>
+            <a:gs pos="35000">
+              <a:schemeClr val="phClr">
+                <a:tint val="37000"/>
+                <a:satMod val="300000"/>
+              </a:schemeClr>
+            </a:gs>
+            <a:gs pos="100000">
+              <a:schemeClr val="phClr">
+                <a:tint val="15000"/>
+                <a:satMod val="350000"/>
+              </a:schemeClr>
+            </a:gs>
+          </a:gsLst>
+          <a:lin ang="16200000" scaled="1"/>
+        </a:gradFill>
+        <a:gradFill rotWithShape="1">
+          <a:gsLst>
+            <a:gs pos="0">
+              <a:schemeClr val="phClr">
+                <a:tint val="100000"/>
+                <a:shade val="100000"/>
+                <a:satMod val="130000"/>
+              </a:schemeClr>
+            </a:gs>
+            <a:gs pos="100000">
+              <a:schemeClr val="phClr">
+                <a:tint val="50000"/>
+                <a:shade val="100000"/>
+                <a:satMod val="350000"/>
+              </a:schemeClr>
+            </a:gs>
+          </a:gsLst>
+          <a:lin ang="16200000" scaled="0"/>
+        </a:gradFill>
+      </a:fillStyleLst>
+      <a:lnStyleLst>
+        <a:ln w="9525" cap="flat" cmpd="sng" algn="ctr">
+          <a:solidFill>
+            <a:schemeClr val="phClr">
+              <a:shade val="95000"/>
+              <a:satMod val="105000"/>
+            </a:schemeClr>
+          </a:solidFill>
+          <a:prstDash val="solid"/>
+        </a:ln>
+        <a:ln w="25400" cap="flat" cmpd="sng" algn="ctr">
+          <a:solidFill>
+            <a:schemeClr val="phClr"/>
+          </a:solidFill>
+          <a:prstDash val="solid"/>
+        </a:ln>
+        <a:ln w="38100" cap="flat" cmpd="sng" algn="ctr">
+          <a:solidFill>
+            <a:schemeClr val="phClr"/>
+          </a:solidFill>
+          <a:prstDash val="solid"/>
+        </a:ln>
+      </a:lnStyleLst>
+      <a:effectStyleLst>
+        <a:effectStyle>
+          <a:effectLst>
+            <a:outerShdw blurRad="40000" dist="20000" dir="5400000" rotWithShape="0">
+              <a:srgbClr val="000000">
+                <a:alpha val="38000"/>
+              </a:srgbClr>
+            </a:outerShdw>
+          </a:effectLst>
+        </a:effectStyle>
+        <a:effectStyle>
+          <a:effectLst>
+            <a:outerShdw blurRad="40000" dist="23000" dir="5400000" rotWithShape="0">
+              <a:srgbClr val="000000">
+                <a:alpha val="35000"/>
+              </a:srgbClr>
+            </a:outerShdw>
+          </a:effectLst>
+        </a:effectStyle>
+        <a:effectStyle>
+          <a:effectLst>
+            <a:outerShdw blurRad="40000" dist="23000" dir="5400000" rotWithShape="0">
+              <a:srgbClr val="000000">
+                <a:alpha val="35000"/>
+              </a:srgbClr>
+            </a:outerShdw>
+          </a:effectLst>
+          <a:scene3d>
+            <a:camera prst="orthographicFront">
+              <a:rot lat="0" lon="0" rev="0"/>
+            </a:camera>
+            <a:lightRig rig="threePt" dir="t">
+              <a:rot lat="0" lon="0" rev="1200000"/>
+            </a:lightRig>
+          </a:scene3d>
+          <a:sp3d>
+            <a:bevelT w="63500" h="25400"/>
+          </a:sp3d>
+        </a:effectStyle>
+      </a:effectStyleLst>
+      <a:bgFillStyleLst>
+        <a:solidFill>
+          <a:schemeClr val="phClr"/>
+        </a:solidFill>
+        <a:gradFill rotWithShape="1">
+          <a:gsLst>
+            <a:gs pos="0">
+              <a:schemeClr val="phClr">
+                <a:tint val="40000"/>
+                <a:satMod val="350000"/>
+              </a:schemeClr>
+            </a:gs>
+            <a:gs pos="40000">
+              <a:schemeClr val="phClr">
+                <a:tint val="45000"/>
+                <a:shade val="99000"/>
+                <a:satMod val="350000"/>
+              </a:schemeClr>
+            </a:gs>
+            <a:gs pos="100000">
+              <a:schemeClr val="phClr">
+                <a:shade val="20000"/>
+                <a:satMod val="255000"/>
+              </a:schemeClr>
+            </a:gs>
+          </a:gsLst>
+          <a:path path="circle">
+            <a:fillToRect l="50000" t="-80000" r="50000" b="180000"/>
+          </a:path>
+        </a:gradFill>
+        <a:gradFill rotWithShape="1">
+          <a:gsLst>
+            <a:gs pos="0">
+              <a:schemeClr val="phClr">
+                <a:tint val="80000"/>
+                <a:satMod val="300000"/>
+              </a:schemeClr>
+            </a:gs>
+            <a:gs pos="100000">
+              <a:schemeClr val="phClr">
+                <a:shade val="30000"/>
+                <a:satMod val="200000"/>
+              </a:schemeClr>
+            </a:gs>
+          </a:gsLst>
+          <a:path path="circle">
+            <a:fillToRect l="50000" t="50000" r="50000" b="50000"/>
+          </a:path>
+        </a:gradFill>
+      </a:bgFillStyleLst>
+    </a:fmtScheme>
+  </a:themeElements>
+</a:theme>
 </file>
</xml_diff>

<commit_message>
Update Data Sources from LFX 2026-09-14 (#308)
Update Data Sources from LFX

Signed-off-by: github-actions[bot] <41898282+github-actions[bot]@users.noreply.github.com>
</commit_message>
<xml_diff>
--- a/overview_deck/LF Energy High Level Overview.pptx
+++ b/overview_deck/LF Energy High Level Overview.pptx
@@ -25946,7 +25946,7 @@
             <a:tbl>
               <a:tblPr>
                 <a:noFill/>
-                <a:tableStyleId>{BF0CAEFB-12BF-4148-A3F1-FB1B6D2CC27C}</a:tableStyleId>
+                <a:tableStyleId>{5A47F3D6-3154-4157-A63C-3609D1A590BD}</a:tableStyleId>
               </a:tblPr>
               <a:tblGrid>
                 <a:gridCol w="1695200"/>
@@ -26736,7 +26736,7 @@
             <a:tbl>
               <a:tblPr>
                 <a:noFill/>
-                <a:tableStyleId>{BF0CAEFB-12BF-4148-A3F1-FB1B6D2CC27C}</a:tableStyleId>
+                <a:tableStyleId>{5A47F3D6-3154-4157-A63C-3609D1A590BD}</a:tableStyleId>
               </a:tblPr>
               <a:tblGrid>
                 <a:gridCol w="1695200"/>
@@ -27426,7 +27426,7 @@
             <a:tbl>
               <a:tblPr>
                 <a:noFill/>
-                <a:tableStyleId>{BF0CAEFB-12BF-4148-A3F1-FB1B6D2CC27C}</a:tableStyleId>
+                <a:tableStyleId>{5A47F3D6-3154-4157-A63C-3609D1A590BD}</a:tableStyleId>
               </a:tblPr>
               <a:tblGrid>
                 <a:gridCol w="1695200"/>
@@ -28678,7 +28678,7 @@
             <a:tbl>
               <a:tblPr>
                 <a:noFill/>
-                <a:tableStyleId>{BF0CAEFB-12BF-4148-A3F1-FB1B6D2CC27C}</a:tableStyleId>
+                <a:tableStyleId>{5A47F3D6-3154-4157-A63C-3609D1A590BD}</a:tableStyleId>
               </a:tblPr>
               <a:tblGrid>
                 <a:gridCol w="1695200"/>
@@ -29670,7 +29670,7 @@
             <a:tbl>
               <a:tblPr>
                 <a:noFill/>
-                <a:tableStyleId>{BF0CAEFB-12BF-4148-A3F1-FB1B6D2CC27C}</a:tableStyleId>
+                <a:tableStyleId>{5A47F3D6-3154-4157-A63C-3609D1A590BD}</a:tableStyleId>
               </a:tblPr>
               <a:tblGrid>
                 <a:gridCol w="3048000"/>
@@ -33175,7 +33175,7 @@
             <a:tbl>
               <a:tblPr>
                 <a:noFill/>
-                <a:tableStyleId>{BF0CAEFB-12BF-4148-A3F1-FB1B6D2CC27C}</a:tableStyleId>
+                <a:tableStyleId>{5A47F3D6-3154-4157-A63C-3609D1A590BD}</a:tableStyleId>
               </a:tblPr>
               <a:tblGrid>
                 <a:gridCol w="1828800"/>
@@ -34002,285 +34002,6 @@
 </file>
 
 <file path=ppt/theme/theme1.xml><?xml version="1.0" encoding="utf-8"?>
-<a:theme xmlns:a="http://schemas.openxmlformats.org/drawingml/2006/main" xmlns:r="http://schemas.openxmlformats.org/officeDocument/2006/relationships" name="Simple Light">
-  <a:themeElements>
-    <a:clrScheme name="Simple Light">
-      <a:dk1>
-        <a:srgbClr val="000000"/>
-      </a:dk1>
-      <a:lt1>
-        <a:srgbClr val="FFFFFF"/>
-      </a:lt1>
-      <a:dk2>
-        <a:srgbClr val="595959"/>
-      </a:dk2>
-      <a:lt2>
-        <a:srgbClr val="EEEEEE"/>
-      </a:lt2>
-      <a:accent1>
-        <a:srgbClr val="4285F4"/>
-      </a:accent1>
-      <a:accent2>
-        <a:srgbClr val="212121"/>
-      </a:accent2>
-      <a:accent3>
-        <a:srgbClr val="78909C"/>
-      </a:accent3>
-      <a:accent4>
-        <a:srgbClr val="FFAB40"/>
-      </a:accent4>
-      <a:accent5>
-        <a:srgbClr val="0097A7"/>
-      </a:accent5>
-      <a:accent6>
-        <a:srgbClr val="EEFF41"/>
-      </a:accent6>
-      <a:hlink>
-        <a:srgbClr val="0097A7"/>
-      </a:hlink>
-      <a:folHlink>
-        <a:srgbClr val="0097A7"/>
-      </a:folHlink>
-    </a:clrScheme>
-    <a:fontScheme name="Office">
-      <a:majorFont>
-        <a:latin typeface="Arial"/>
-        <a:ea typeface=""/>
-        <a:cs typeface=""/>
-        <a:font script="Jpan" typeface="ＭＳ Ｐゴシック"/>
-        <a:font script="Hang" typeface="맑은 고딕"/>
-        <a:font script="Hans" typeface="宋体"/>
-        <a:font script="Hant" typeface="新細明體"/>
-        <a:font script="Arab" typeface="Times New Roman"/>
-        <a:font script="Hebr" typeface="Times New Roman"/>
-        <a:font script="Thai" typeface="Angsana New"/>
-        <a:font script="Ethi" typeface="Nyala"/>
-        <a:font script="Beng" typeface="Vrinda"/>
-        <a:font script="Gujr" typeface="Shruti"/>
-        <a:font script="Khmr" typeface="MoolBoran"/>
-        <a:font script="Knda" typeface="Tunga"/>
-        <a:font script="Guru" typeface="Raavi"/>
-        <a:font script="Cans" typeface="Euphemia"/>
-        <a:font script="Cher" typeface="Plantagenet Cherokee"/>
-        <a:font script="Yiii" typeface="Microsoft Yi Baiti"/>
-        <a:font script="Tibt" typeface="Microsoft Himalaya"/>
-        <a:font script="Thaa" typeface="MV Boli"/>
-        <a:font script="Deva" typeface="Mangal"/>
-        <a:font script="Telu" typeface="Gautami"/>
-        <a:font script="Taml" typeface="Latha"/>
-        <a:font script="Syrc" typeface="Estrangelo Edessa"/>
-        <a:font script="Orya" typeface="Kalinga"/>
-        <a:font script="Mlym" typeface="Kartika"/>
-        <a:font script="Laoo" typeface="DokChampa"/>
-        <a:font script="Sinh" typeface="Iskoola Pota"/>
-        <a:font script="Mong" typeface="Mongolian Baiti"/>
-        <a:font script="Viet" typeface="Times New Roman"/>
-        <a:font script="Uigh" typeface="Microsoft Uighur"/>
-        <a:font script="Geor" typeface="Sylfaen"/>
-      </a:majorFont>
-      <a:minorFont>
-        <a:latin typeface="Arial"/>
-        <a:ea typeface=""/>
-        <a:cs typeface=""/>
-        <a:font script="Jpan" typeface="ＭＳ Ｐゴシック"/>
-        <a:font script="Hang" typeface="맑은 고딕"/>
-        <a:font script="Hans" typeface="宋体"/>
-        <a:font script="Hant" typeface="新細明體"/>
-        <a:font script="Arab" typeface="Arial"/>
-        <a:font script="Hebr" typeface="Arial"/>
-        <a:font script="Thai" typeface="Cordia New"/>
-        <a:font script="Ethi" typeface="Nyala"/>
-        <a:font script="Beng" typeface="Vrinda"/>
-        <a:font script="Gujr" typeface="Shruti"/>
-        <a:font script="Khmr" typeface="DaunPenh"/>
-        <a:font script="Knda" typeface="Tunga"/>
-        <a:font script="Guru" typeface="Raavi"/>
-        <a:font script="Cans" typeface="Euphemia"/>
-        <a:font script="Cher" typeface="Plantagenet Cherokee"/>
-        <a:font script="Yiii" typeface="Microsoft Yi Baiti"/>
-        <a:font script="Tibt" typeface="Microsoft Himalaya"/>
-        <a:font script="Thaa" typeface="MV Boli"/>
-        <a:font script="Deva" typeface="Mangal"/>
-        <a:font script="Telu" typeface="Gautami"/>
-        <a:font script="Taml" typeface="Latha"/>
-        <a:font script="Syrc" typeface="Estrangelo Edessa"/>
-        <a:font script="Orya" typeface="Kalinga"/>
-        <a:font script="Mlym" typeface="Kartika"/>
-        <a:font script="Laoo" typeface="DokChampa"/>
-        <a:font script="Sinh" typeface="Iskoola Pota"/>
-        <a:font script="Mong" typeface="Mongolian Baiti"/>
-        <a:font script="Viet" typeface="Arial"/>
-        <a:font script="Uigh" typeface="Microsoft Uighur"/>
-        <a:font script="Geor" typeface="Sylfaen"/>
-      </a:minorFont>
-    </a:fontScheme>
-    <a:fmtScheme name="Office">
-      <a:fillStyleLst>
-        <a:solidFill>
-          <a:schemeClr val="phClr"/>
-        </a:solidFill>
-        <a:gradFill rotWithShape="1">
-          <a:gsLst>
-            <a:gs pos="0">
-              <a:schemeClr val="phClr">
-                <a:tint val="50000"/>
-                <a:satMod val="300000"/>
-              </a:schemeClr>
-            </a:gs>
-            <a:gs pos="35000">
-              <a:schemeClr val="phClr">
-                <a:tint val="37000"/>
-                <a:satMod val="300000"/>
-              </a:schemeClr>
-            </a:gs>
-            <a:gs pos="100000">
-              <a:schemeClr val="phClr">
-                <a:tint val="15000"/>
-                <a:satMod val="350000"/>
-              </a:schemeClr>
-            </a:gs>
-          </a:gsLst>
-          <a:lin ang="16200000" scaled="1"/>
-        </a:gradFill>
-        <a:gradFill rotWithShape="1">
-          <a:gsLst>
-            <a:gs pos="0">
-              <a:schemeClr val="phClr">
-                <a:tint val="100000"/>
-                <a:shade val="100000"/>
-                <a:satMod val="130000"/>
-              </a:schemeClr>
-            </a:gs>
-            <a:gs pos="100000">
-              <a:schemeClr val="phClr">
-                <a:tint val="50000"/>
-                <a:shade val="100000"/>
-                <a:satMod val="350000"/>
-              </a:schemeClr>
-            </a:gs>
-          </a:gsLst>
-          <a:lin ang="16200000" scaled="0"/>
-        </a:gradFill>
-      </a:fillStyleLst>
-      <a:lnStyleLst>
-        <a:ln w="9525" cap="flat" cmpd="sng" algn="ctr">
-          <a:solidFill>
-            <a:schemeClr val="phClr">
-              <a:shade val="95000"/>
-              <a:satMod val="105000"/>
-            </a:schemeClr>
-          </a:solidFill>
-          <a:prstDash val="solid"/>
-        </a:ln>
-        <a:ln w="25400" cap="flat" cmpd="sng" algn="ctr">
-          <a:solidFill>
-            <a:schemeClr val="phClr"/>
-          </a:solidFill>
-          <a:prstDash val="solid"/>
-        </a:ln>
-        <a:ln w="38100" cap="flat" cmpd="sng" algn="ctr">
-          <a:solidFill>
-            <a:schemeClr val="phClr"/>
-          </a:solidFill>
-          <a:prstDash val="solid"/>
-        </a:ln>
-      </a:lnStyleLst>
-      <a:effectStyleLst>
-        <a:effectStyle>
-          <a:effectLst>
-            <a:outerShdw blurRad="40000" dist="20000" dir="5400000" rotWithShape="0">
-              <a:srgbClr val="000000">
-                <a:alpha val="38000"/>
-              </a:srgbClr>
-            </a:outerShdw>
-          </a:effectLst>
-        </a:effectStyle>
-        <a:effectStyle>
-          <a:effectLst>
-            <a:outerShdw blurRad="40000" dist="23000" dir="5400000" rotWithShape="0">
-              <a:srgbClr val="000000">
-                <a:alpha val="35000"/>
-              </a:srgbClr>
-            </a:outerShdw>
-          </a:effectLst>
-        </a:effectStyle>
-        <a:effectStyle>
-          <a:effectLst>
-            <a:outerShdw blurRad="40000" dist="23000" dir="5400000" rotWithShape="0">
-              <a:srgbClr val="000000">
-                <a:alpha val="35000"/>
-              </a:srgbClr>
-            </a:outerShdw>
-          </a:effectLst>
-          <a:scene3d>
-            <a:camera prst="orthographicFront">
-              <a:rot lat="0" lon="0" rev="0"/>
-            </a:camera>
-            <a:lightRig rig="threePt" dir="t">
-              <a:rot lat="0" lon="0" rev="1200000"/>
-            </a:lightRig>
-          </a:scene3d>
-          <a:sp3d>
-            <a:bevelT w="63500" h="25400"/>
-          </a:sp3d>
-        </a:effectStyle>
-      </a:effectStyleLst>
-      <a:bgFillStyleLst>
-        <a:solidFill>
-          <a:schemeClr val="phClr"/>
-        </a:solidFill>
-        <a:gradFill rotWithShape="1">
-          <a:gsLst>
-            <a:gs pos="0">
-              <a:schemeClr val="phClr">
-                <a:tint val="40000"/>
-                <a:satMod val="350000"/>
-              </a:schemeClr>
-            </a:gs>
-            <a:gs pos="40000">
-              <a:schemeClr val="phClr">
-                <a:tint val="45000"/>
-                <a:shade val="99000"/>
-                <a:satMod val="350000"/>
-              </a:schemeClr>
-            </a:gs>
-            <a:gs pos="100000">
-              <a:schemeClr val="phClr">
-                <a:shade val="20000"/>
-                <a:satMod val="255000"/>
-              </a:schemeClr>
-            </a:gs>
-          </a:gsLst>
-          <a:path path="circle">
-            <a:fillToRect l="50000" t="-80000" r="50000" b="180000"/>
-          </a:path>
-        </a:gradFill>
-        <a:gradFill rotWithShape="1">
-          <a:gsLst>
-            <a:gs pos="0">
-              <a:schemeClr val="phClr">
-                <a:tint val="80000"/>
-                <a:satMod val="300000"/>
-              </a:schemeClr>
-            </a:gs>
-            <a:gs pos="100000">
-              <a:schemeClr val="phClr">
-                <a:shade val="30000"/>
-                <a:satMod val="200000"/>
-              </a:schemeClr>
-            </a:gs>
-          </a:gsLst>
-          <a:path path="circle">
-            <a:fillToRect l="50000" t="50000" r="50000" b="50000"/>
-          </a:path>
-        </a:gradFill>
-      </a:bgFillStyleLst>
-    </a:fmtScheme>
-  </a:themeElements>
-</a:theme>
-</file>
-
-<file path=ppt/theme/theme2.xml><?xml version="1.0" encoding="utf-8"?>
 <a:theme xmlns:a="http://schemas.openxmlformats.org/drawingml/2006/main" xmlns:r="http://schemas.openxmlformats.org/officeDocument/2006/relationships">
   <a:themeElements>
     <a:clrScheme name="Default">
@@ -34559,7 +34280,7 @@
 </a:theme>
 </file>
 
-<file path=ppt/theme/theme3.xml><?xml version="1.0" encoding="utf-8"?>
+<file path=ppt/theme/theme2.xml><?xml version="1.0" encoding="utf-8"?>
 <a:theme xmlns:a="http://schemas.openxmlformats.org/drawingml/2006/main" xmlns:r="http://schemas.openxmlformats.org/officeDocument/2006/relationships" name="LF Energy Theme 2023">
   <a:themeElements>
     <a:clrScheme name="Geometric">
@@ -34836,4 +34557,283 @@
     </a:fmtScheme>
   </a:themeElements>
 </a:theme>
+</file>
+
+<file path=ppt/theme/theme3.xml><?xml version="1.0" encoding="utf-8"?>
+<a:theme xmlns:a="http://schemas.openxmlformats.org/drawingml/2006/main" xmlns:r="http://schemas.openxmlformats.org/officeDocument/2006/relationships" name="Simple Light">
+  <a:themeElements>
+    <a:clrScheme name="Simple Light">
+      <a:dk1>
+        <a:srgbClr val="000000"/>
+      </a:dk1>
+      <a:lt1>
+        <a:srgbClr val="FFFFFF"/>
+      </a:lt1>
+      <a:dk2>
+        <a:srgbClr val="595959"/>
+      </a:dk2>
+      <a:lt2>
+        <a:srgbClr val="EEEEEE"/>
+      </a:lt2>
+      <a:accent1>
+        <a:srgbClr val="4285F4"/>
+      </a:accent1>
+      <a:accent2>
+        <a:srgbClr val="212121"/>
+      </a:accent2>
+      <a:accent3>
+        <a:srgbClr val="78909C"/>
+      </a:accent3>
+      <a:accent4>
+        <a:srgbClr val="FFAB40"/>
+      </a:accent4>
+      <a:accent5>
+        <a:srgbClr val="0097A7"/>
+      </a:accent5>
+      <a:accent6>
+        <a:srgbClr val="EEFF41"/>
+      </a:accent6>
+      <a:hlink>
+        <a:srgbClr val="0097A7"/>
+      </a:hlink>
+      <a:folHlink>
+        <a:srgbClr val="0097A7"/>
+      </a:folHlink>
+    </a:clrScheme>
+    <a:fontScheme name="Office">
+      <a:majorFont>
+        <a:latin typeface="Arial"/>
+        <a:ea typeface=""/>
+        <a:cs typeface=""/>
+        <a:font script="Jpan" typeface="ＭＳ Ｐゴシック"/>
+        <a:font script="Hang" typeface="맑은 고딕"/>
+        <a:font script="Hans" typeface="宋体"/>
+        <a:font script="Hant" typeface="新細明體"/>
+        <a:font script="Arab" typeface="Times New Roman"/>
+        <a:font script="Hebr" typeface="Times New Roman"/>
+        <a:font script="Thai" typeface="Angsana New"/>
+        <a:font script="Ethi" typeface="Nyala"/>
+        <a:font script="Beng" typeface="Vrinda"/>
+        <a:font script="Gujr" typeface="Shruti"/>
+        <a:font script="Khmr" typeface="MoolBoran"/>
+        <a:font script="Knda" typeface="Tunga"/>
+        <a:font script="Guru" typeface="Raavi"/>
+        <a:font script="Cans" typeface="Euphemia"/>
+        <a:font script="Cher" typeface="Plantagenet Cherokee"/>
+        <a:font script="Yiii" typeface="Microsoft Yi Baiti"/>
+        <a:font script="Tibt" typeface="Microsoft Himalaya"/>
+        <a:font script="Thaa" typeface="MV Boli"/>
+        <a:font script="Deva" typeface="Mangal"/>
+        <a:font script="Telu" typeface="Gautami"/>
+        <a:font script="Taml" typeface="Latha"/>
+        <a:font script="Syrc" typeface="Estrangelo Edessa"/>
+        <a:font script="Orya" typeface="Kalinga"/>
+        <a:font script="Mlym" typeface="Kartika"/>
+        <a:font script="Laoo" typeface="DokChampa"/>
+        <a:font script="Sinh" typeface="Iskoola Pota"/>
+        <a:font script="Mong" typeface="Mongolian Baiti"/>
+        <a:font script="Viet" typeface="Times New Roman"/>
+        <a:font script="Uigh" typeface="Microsoft Uighur"/>
+        <a:font script="Geor" typeface="Sylfaen"/>
+      </a:majorFont>
+      <a:minorFont>
+        <a:latin typeface="Arial"/>
+        <a:ea typeface=""/>
+        <a:cs typeface=""/>
+        <a:font script="Jpan" typeface="ＭＳ Ｐゴシック"/>
+        <a:font script="Hang" typeface="맑은 고딕"/>
+        <a:font script="Hans" typeface="宋体"/>
+        <a:font script="Hant" typeface="新細明體"/>
+        <a:font script="Arab" typeface="Arial"/>
+        <a:font script="Hebr" typeface="Arial"/>
+        <a:font script="Thai" typeface="Cordia New"/>
+        <a:font script="Ethi" typeface="Nyala"/>
+        <a:font script="Beng" typeface="Vrinda"/>
+        <a:font script="Gujr" typeface="Shruti"/>
+        <a:font script="Khmr" typeface="DaunPenh"/>
+        <a:font script="Knda" typeface="Tunga"/>
+        <a:font script="Guru" typeface="Raavi"/>
+        <a:font script="Cans" typeface="Euphemia"/>
+        <a:font script="Cher" typeface="Plantagenet Cherokee"/>
+        <a:font script="Yiii" typeface="Microsoft Yi Baiti"/>
+        <a:font script="Tibt" typeface="Microsoft Himalaya"/>
+        <a:font script="Thaa" typeface="MV Boli"/>
+        <a:font script="Deva" typeface="Mangal"/>
+        <a:font script="Telu" typeface="Gautami"/>
+        <a:font script="Taml" typeface="Latha"/>
+        <a:font script="Syrc" typeface="Estrangelo Edessa"/>
+        <a:font script="Orya" typeface="Kalinga"/>
+        <a:font script="Mlym" typeface="Kartika"/>
+        <a:font script="Laoo" typeface="DokChampa"/>
+        <a:font script="Sinh" typeface="Iskoola Pota"/>
+        <a:font script="Mong" typeface="Mongolian Baiti"/>
+        <a:font script="Viet" typeface="Arial"/>
+        <a:font script="Uigh" typeface="Microsoft Uighur"/>
+        <a:font script="Geor" typeface="Sylfaen"/>
+      </a:minorFont>
+    </a:fontScheme>
+    <a:fmtScheme name="Office">
+      <a:fillStyleLst>
+        <a:solidFill>
+          <a:schemeClr val="phClr"/>
+        </a:solidFill>
+        <a:gradFill rotWithShape="1">
+          <a:gsLst>
+            <a:gs pos="0">
+              <a:schemeClr val="phClr">
+                <a:tint val="50000"/>
+                <a:satMod val="300000"/>
+              </a:schemeClr>
+            </a:gs>
+            <a:gs pos="35000">
+              <a:schemeClr val="phClr">
+                <a:tint val="37000"/>
+                <a:satMod val="300000"/>
+              </a:schemeClr>
+            </a:gs>
+            <a:gs pos="100000">
+              <a:schemeClr val="phClr">
+                <a:tint val="15000"/>
+                <a:satMod val="350000"/>
+              </a:schemeClr>
+            </a:gs>
+          </a:gsLst>
+          <a:lin ang="16200000" scaled="1"/>
+        </a:gradFill>
+        <a:gradFill rotWithShape="1">
+          <a:gsLst>
+            <a:gs pos="0">
+              <a:schemeClr val="phClr">
+                <a:tint val="100000"/>
+                <a:shade val="100000"/>
+                <a:satMod val="130000"/>
+              </a:schemeClr>
+            </a:gs>
+            <a:gs pos="100000">
+              <a:schemeClr val="phClr">
+                <a:tint val="50000"/>
+                <a:shade val="100000"/>
+                <a:satMod val="350000"/>
+              </a:schemeClr>
+            </a:gs>
+          </a:gsLst>
+          <a:lin ang="16200000" scaled="0"/>
+        </a:gradFill>
+      </a:fillStyleLst>
+      <a:lnStyleLst>
+        <a:ln w="9525" cap="flat" cmpd="sng" algn="ctr">
+          <a:solidFill>
+            <a:schemeClr val="phClr">
+              <a:shade val="95000"/>
+              <a:satMod val="105000"/>
+            </a:schemeClr>
+          </a:solidFill>
+          <a:prstDash val="solid"/>
+        </a:ln>
+        <a:ln w="25400" cap="flat" cmpd="sng" algn="ctr">
+          <a:solidFill>
+            <a:schemeClr val="phClr"/>
+          </a:solidFill>
+          <a:prstDash val="solid"/>
+        </a:ln>
+        <a:ln w="38100" cap="flat" cmpd="sng" algn="ctr">
+          <a:solidFill>
+            <a:schemeClr val="phClr"/>
+          </a:solidFill>
+          <a:prstDash val="solid"/>
+        </a:ln>
+      </a:lnStyleLst>
+      <a:effectStyleLst>
+        <a:effectStyle>
+          <a:effectLst>
+            <a:outerShdw blurRad="40000" dist="20000" dir="5400000" rotWithShape="0">
+              <a:srgbClr val="000000">
+                <a:alpha val="38000"/>
+              </a:srgbClr>
+            </a:outerShdw>
+          </a:effectLst>
+        </a:effectStyle>
+        <a:effectStyle>
+          <a:effectLst>
+            <a:outerShdw blurRad="40000" dist="23000" dir="5400000" rotWithShape="0">
+              <a:srgbClr val="000000">
+                <a:alpha val="35000"/>
+              </a:srgbClr>
+            </a:outerShdw>
+          </a:effectLst>
+        </a:effectStyle>
+        <a:effectStyle>
+          <a:effectLst>
+            <a:outerShdw blurRad="40000" dist="23000" dir="5400000" rotWithShape="0">
+              <a:srgbClr val="000000">
+                <a:alpha val="35000"/>
+              </a:srgbClr>
+            </a:outerShdw>
+          </a:effectLst>
+          <a:scene3d>
+            <a:camera prst="orthographicFront">
+              <a:rot lat="0" lon="0" rev="0"/>
+            </a:camera>
+            <a:lightRig rig="threePt" dir="t">
+              <a:rot lat="0" lon="0" rev="1200000"/>
+            </a:lightRig>
+          </a:scene3d>
+          <a:sp3d>
+            <a:bevelT w="63500" h="25400"/>
+          </a:sp3d>
+        </a:effectStyle>
+      </a:effectStyleLst>
+      <a:bgFillStyleLst>
+        <a:solidFill>
+          <a:schemeClr val="phClr"/>
+        </a:solidFill>
+        <a:gradFill rotWithShape="1">
+          <a:gsLst>
+            <a:gs pos="0">
+              <a:schemeClr val="phClr">
+                <a:tint val="40000"/>
+                <a:satMod val="350000"/>
+              </a:schemeClr>
+            </a:gs>
+            <a:gs pos="40000">
+              <a:schemeClr val="phClr">
+                <a:tint val="45000"/>
+                <a:shade val="99000"/>
+                <a:satMod val="350000"/>
+              </a:schemeClr>
+            </a:gs>
+            <a:gs pos="100000">
+              <a:schemeClr val="phClr">
+                <a:shade val="20000"/>
+                <a:satMod val="255000"/>
+              </a:schemeClr>
+            </a:gs>
+          </a:gsLst>
+          <a:path path="circle">
+            <a:fillToRect l="50000" t="-80000" r="50000" b="180000"/>
+          </a:path>
+        </a:gradFill>
+        <a:gradFill rotWithShape="1">
+          <a:gsLst>
+            <a:gs pos="0">
+              <a:schemeClr val="phClr">
+                <a:tint val="80000"/>
+                <a:satMod val="300000"/>
+              </a:schemeClr>
+            </a:gs>
+            <a:gs pos="100000">
+              <a:schemeClr val="phClr">
+                <a:shade val="30000"/>
+                <a:satMod val="200000"/>
+              </a:schemeClr>
+            </a:gs>
+          </a:gsLst>
+          <a:path path="circle">
+            <a:fillToRect l="50000" t="50000" r="50000" b="50000"/>
+          </a:path>
+        </a:gradFill>
+      </a:bgFillStyleLst>
+    </a:fmtScheme>
+  </a:themeElements>
+</a:theme>
 </file>
</xml_diff>

<commit_message>
Update Data Sources from LFX 2026-09-15 (#309)
Update Data Sources from LFX

Signed-off-by: github-actions[bot] <41898282+github-actions[bot]@users.noreply.github.com>
</commit_message>
<xml_diff>
--- a/overview_deck/LF Energy High Level Overview.pptx
+++ b/overview_deck/LF Energy High Level Overview.pptx
@@ -25946,7 +25946,7 @@
             <a:tbl>
               <a:tblPr>
                 <a:noFill/>
-                <a:tableStyleId>{5A47F3D6-3154-4157-A63C-3609D1A590BD}</a:tableStyleId>
+                <a:tableStyleId>{AC88F10A-30CC-4A48-90E0-F648FADE5769}</a:tableStyleId>
               </a:tblPr>
               <a:tblGrid>
                 <a:gridCol w="1695200"/>
@@ -26736,7 +26736,7 @@
             <a:tbl>
               <a:tblPr>
                 <a:noFill/>
-                <a:tableStyleId>{5A47F3D6-3154-4157-A63C-3609D1A590BD}</a:tableStyleId>
+                <a:tableStyleId>{AC88F10A-30CC-4A48-90E0-F648FADE5769}</a:tableStyleId>
               </a:tblPr>
               <a:tblGrid>
                 <a:gridCol w="1695200"/>
@@ -27426,7 +27426,7 @@
             <a:tbl>
               <a:tblPr>
                 <a:noFill/>
-                <a:tableStyleId>{5A47F3D6-3154-4157-A63C-3609D1A590BD}</a:tableStyleId>
+                <a:tableStyleId>{AC88F10A-30CC-4A48-90E0-F648FADE5769}</a:tableStyleId>
               </a:tblPr>
               <a:tblGrid>
                 <a:gridCol w="1695200"/>
@@ -28678,7 +28678,7 @@
             <a:tbl>
               <a:tblPr>
                 <a:noFill/>
-                <a:tableStyleId>{5A47F3D6-3154-4157-A63C-3609D1A590BD}</a:tableStyleId>
+                <a:tableStyleId>{AC88F10A-30CC-4A48-90E0-F648FADE5769}</a:tableStyleId>
               </a:tblPr>
               <a:tblGrid>
                 <a:gridCol w="1695200"/>
@@ -29670,7 +29670,7 @@
             <a:tbl>
               <a:tblPr>
                 <a:noFill/>
-                <a:tableStyleId>{5A47F3D6-3154-4157-A63C-3609D1A590BD}</a:tableStyleId>
+                <a:tableStyleId>{AC88F10A-30CC-4A48-90E0-F648FADE5769}</a:tableStyleId>
               </a:tblPr>
               <a:tblGrid>
                 <a:gridCol w="3048000"/>
@@ -33175,7 +33175,7 @@
             <a:tbl>
               <a:tblPr>
                 <a:noFill/>
-                <a:tableStyleId>{5A47F3D6-3154-4157-A63C-3609D1A590BD}</a:tableStyleId>
+                <a:tableStyleId>{AC88F10A-30CC-4A48-90E0-F648FADE5769}</a:tableStyleId>
               </a:tblPr>
               <a:tblGrid>
                 <a:gridCol w="1828800"/>
@@ -34002,6 +34002,285 @@
 </file>
 
 <file path=ppt/theme/theme1.xml><?xml version="1.0" encoding="utf-8"?>
+<a:theme xmlns:a="http://schemas.openxmlformats.org/drawingml/2006/main" xmlns:r="http://schemas.openxmlformats.org/officeDocument/2006/relationships" name="Simple Light">
+  <a:themeElements>
+    <a:clrScheme name="Simple Light">
+      <a:dk1>
+        <a:srgbClr val="000000"/>
+      </a:dk1>
+      <a:lt1>
+        <a:srgbClr val="FFFFFF"/>
+      </a:lt1>
+      <a:dk2>
+        <a:srgbClr val="595959"/>
+      </a:dk2>
+      <a:lt2>
+        <a:srgbClr val="EEEEEE"/>
+      </a:lt2>
+      <a:accent1>
+        <a:srgbClr val="4285F4"/>
+      </a:accent1>
+      <a:accent2>
+        <a:srgbClr val="212121"/>
+      </a:accent2>
+      <a:accent3>
+        <a:srgbClr val="78909C"/>
+      </a:accent3>
+      <a:accent4>
+        <a:srgbClr val="FFAB40"/>
+      </a:accent4>
+      <a:accent5>
+        <a:srgbClr val="0097A7"/>
+      </a:accent5>
+      <a:accent6>
+        <a:srgbClr val="EEFF41"/>
+      </a:accent6>
+      <a:hlink>
+        <a:srgbClr val="0097A7"/>
+      </a:hlink>
+      <a:folHlink>
+        <a:srgbClr val="0097A7"/>
+      </a:folHlink>
+    </a:clrScheme>
+    <a:fontScheme name="Office">
+      <a:majorFont>
+        <a:latin typeface="Arial"/>
+        <a:ea typeface=""/>
+        <a:cs typeface=""/>
+        <a:font script="Jpan" typeface="ＭＳ Ｐゴシック"/>
+        <a:font script="Hang" typeface="맑은 고딕"/>
+        <a:font script="Hans" typeface="宋体"/>
+        <a:font script="Hant" typeface="新細明體"/>
+        <a:font script="Arab" typeface="Times New Roman"/>
+        <a:font script="Hebr" typeface="Times New Roman"/>
+        <a:font script="Thai" typeface="Angsana New"/>
+        <a:font script="Ethi" typeface="Nyala"/>
+        <a:font script="Beng" typeface="Vrinda"/>
+        <a:font script="Gujr" typeface="Shruti"/>
+        <a:font script="Khmr" typeface="MoolBoran"/>
+        <a:font script="Knda" typeface="Tunga"/>
+        <a:font script="Guru" typeface="Raavi"/>
+        <a:font script="Cans" typeface="Euphemia"/>
+        <a:font script="Cher" typeface="Plantagenet Cherokee"/>
+        <a:font script="Yiii" typeface="Microsoft Yi Baiti"/>
+        <a:font script="Tibt" typeface="Microsoft Himalaya"/>
+        <a:font script="Thaa" typeface="MV Boli"/>
+        <a:font script="Deva" typeface="Mangal"/>
+        <a:font script="Telu" typeface="Gautami"/>
+        <a:font script="Taml" typeface="Latha"/>
+        <a:font script="Syrc" typeface="Estrangelo Edessa"/>
+        <a:font script="Orya" typeface="Kalinga"/>
+        <a:font script="Mlym" typeface="Kartika"/>
+        <a:font script="Laoo" typeface="DokChampa"/>
+        <a:font script="Sinh" typeface="Iskoola Pota"/>
+        <a:font script="Mong" typeface="Mongolian Baiti"/>
+        <a:font script="Viet" typeface="Times New Roman"/>
+        <a:font script="Uigh" typeface="Microsoft Uighur"/>
+        <a:font script="Geor" typeface="Sylfaen"/>
+      </a:majorFont>
+      <a:minorFont>
+        <a:latin typeface="Arial"/>
+        <a:ea typeface=""/>
+        <a:cs typeface=""/>
+        <a:font script="Jpan" typeface="ＭＳ Ｐゴシック"/>
+        <a:font script="Hang" typeface="맑은 고딕"/>
+        <a:font script="Hans" typeface="宋体"/>
+        <a:font script="Hant" typeface="新細明體"/>
+        <a:font script="Arab" typeface="Arial"/>
+        <a:font script="Hebr" typeface="Arial"/>
+        <a:font script="Thai" typeface="Cordia New"/>
+        <a:font script="Ethi" typeface="Nyala"/>
+        <a:font script="Beng" typeface="Vrinda"/>
+        <a:font script="Gujr" typeface="Shruti"/>
+        <a:font script="Khmr" typeface="DaunPenh"/>
+        <a:font script="Knda" typeface="Tunga"/>
+        <a:font script="Guru" typeface="Raavi"/>
+        <a:font script="Cans" typeface="Euphemia"/>
+        <a:font script="Cher" typeface="Plantagenet Cherokee"/>
+        <a:font script="Yiii" typeface="Microsoft Yi Baiti"/>
+        <a:font script="Tibt" typeface="Microsoft Himalaya"/>
+        <a:font script="Thaa" typeface="MV Boli"/>
+        <a:font script="Deva" typeface="Mangal"/>
+        <a:font script="Telu" typeface="Gautami"/>
+        <a:font script="Taml" typeface="Latha"/>
+        <a:font script="Syrc" typeface="Estrangelo Edessa"/>
+        <a:font script="Orya" typeface="Kalinga"/>
+        <a:font script="Mlym" typeface="Kartika"/>
+        <a:font script="Laoo" typeface="DokChampa"/>
+        <a:font script="Sinh" typeface="Iskoola Pota"/>
+        <a:font script="Mong" typeface="Mongolian Baiti"/>
+        <a:font script="Viet" typeface="Arial"/>
+        <a:font script="Uigh" typeface="Microsoft Uighur"/>
+        <a:font script="Geor" typeface="Sylfaen"/>
+      </a:minorFont>
+    </a:fontScheme>
+    <a:fmtScheme name="Office">
+      <a:fillStyleLst>
+        <a:solidFill>
+          <a:schemeClr val="phClr"/>
+        </a:solidFill>
+        <a:gradFill rotWithShape="1">
+          <a:gsLst>
+            <a:gs pos="0">
+              <a:schemeClr val="phClr">
+                <a:tint val="50000"/>
+                <a:satMod val="300000"/>
+              </a:schemeClr>
+            </a:gs>
+            <a:gs pos="35000">
+              <a:schemeClr val="phClr">
+                <a:tint val="37000"/>
+                <a:satMod val="300000"/>
+              </a:schemeClr>
+            </a:gs>
+            <a:gs pos="100000">
+              <a:schemeClr val="phClr">
+                <a:tint val="15000"/>
+                <a:satMod val="350000"/>
+              </a:schemeClr>
+            </a:gs>
+          </a:gsLst>
+          <a:lin ang="16200000" scaled="1"/>
+        </a:gradFill>
+        <a:gradFill rotWithShape="1">
+          <a:gsLst>
+            <a:gs pos="0">
+              <a:schemeClr val="phClr">
+                <a:tint val="100000"/>
+                <a:shade val="100000"/>
+                <a:satMod val="130000"/>
+              </a:schemeClr>
+            </a:gs>
+            <a:gs pos="100000">
+              <a:schemeClr val="phClr">
+                <a:tint val="50000"/>
+                <a:shade val="100000"/>
+                <a:satMod val="350000"/>
+              </a:schemeClr>
+            </a:gs>
+          </a:gsLst>
+          <a:lin ang="16200000" scaled="0"/>
+        </a:gradFill>
+      </a:fillStyleLst>
+      <a:lnStyleLst>
+        <a:ln w="9525" cap="flat" cmpd="sng" algn="ctr">
+          <a:solidFill>
+            <a:schemeClr val="phClr">
+              <a:shade val="95000"/>
+              <a:satMod val="105000"/>
+            </a:schemeClr>
+          </a:solidFill>
+          <a:prstDash val="solid"/>
+        </a:ln>
+        <a:ln w="25400" cap="flat" cmpd="sng" algn="ctr">
+          <a:solidFill>
+            <a:schemeClr val="phClr"/>
+          </a:solidFill>
+          <a:prstDash val="solid"/>
+        </a:ln>
+        <a:ln w="38100" cap="flat" cmpd="sng" algn="ctr">
+          <a:solidFill>
+            <a:schemeClr val="phClr"/>
+          </a:solidFill>
+          <a:prstDash val="solid"/>
+        </a:ln>
+      </a:lnStyleLst>
+      <a:effectStyleLst>
+        <a:effectStyle>
+          <a:effectLst>
+            <a:outerShdw blurRad="40000" dist="20000" dir="5400000" rotWithShape="0">
+              <a:srgbClr val="000000">
+                <a:alpha val="38000"/>
+              </a:srgbClr>
+            </a:outerShdw>
+          </a:effectLst>
+        </a:effectStyle>
+        <a:effectStyle>
+          <a:effectLst>
+            <a:outerShdw blurRad="40000" dist="23000" dir="5400000" rotWithShape="0">
+              <a:srgbClr val="000000">
+                <a:alpha val="35000"/>
+              </a:srgbClr>
+            </a:outerShdw>
+          </a:effectLst>
+        </a:effectStyle>
+        <a:effectStyle>
+          <a:effectLst>
+            <a:outerShdw blurRad="40000" dist="23000" dir="5400000" rotWithShape="0">
+              <a:srgbClr val="000000">
+                <a:alpha val="35000"/>
+              </a:srgbClr>
+            </a:outerShdw>
+          </a:effectLst>
+          <a:scene3d>
+            <a:camera prst="orthographicFront">
+              <a:rot lat="0" lon="0" rev="0"/>
+            </a:camera>
+            <a:lightRig rig="threePt" dir="t">
+              <a:rot lat="0" lon="0" rev="1200000"/>
+            </a:lightRig>
+          </a:scene3d>
+          <a:sp3d>
+            <a:bevelT w="63500" h="25400"/>
+          </a:sp3d>
+        </a:effectStyle>
+      </a:effectStyleLst>
+      <a:bgFillStyleLst>
+        <a:solidFill>
+          <a:schemeClr val="phClr"/>
+        </a:solidFill>
+        <a:gradFill rotWithShape="1">
+          <a:gsLst>
+            <a:gs pos="0">
+              <a:schemeClr val="phClr">
+                <a:tint val="40000"/>
+                <a:satMod val="350000"/>
+              </a:schemeClr>
+            </a:gs>
+            <a:gs pos="40000">
+              <a:schemeClr val="phClr">
+                <a:tint val="45000"/>
+                <a:shade val="99000"/>
+                <a:satMod val="350000"/>
+              </a:schemeClr>
+            </a:gs>
+            <a:gs pos="100000">
+              <a:schemeClr val="phClr">
+                <a:shade val="20000"/>
+                <a:satMod val="255000"/>
+              </a:schemeClr>
+            </a:gs>
+          </a:gsLst>
+          <a:path path="circle">
+            <a:fillToRect l="50000" t="-80000" r="50000" b="180000"/>
+          </a:path>
+        </a:gradFill>
+        <a:gradFill rotWithShape="1">
+          <a:gsLst>
+            <a:gs pos="0">
+              <a:schemeClr val="phClr">
+                <a:tint val="80000"/>
+                <a:satMod val="300000"/>
+              </a:schemeClr>
+            </a:gs>
+            <a:gs pos="100000">
+              <a:schemeClr val="phClr">
+                <a:shade val="30000"/>
+                <a:satMod val="200000"/>
+              </a:schemeClr>
+            </a:gs>
+          </a:gsLst>
+          <a:path path="circle">
+            <a:fillToRect l="50000" t="50000" r="50000" b="50000"/>
+          </a:path>
+        </a:gradFill>
+      </a:bgFillStyleLst>
+    </a:fmtScheme>
+  </a:themeElements>
+</a:theme>
+</file>
+
+<file path=ppt/theme/theme2.xml><?xml version="1.0" encoding="utf-8"?>
 <a:theme xmlns:a="http://schemas.openxmlformats.org/drawingml/2006/main" xmlns:r="http://schemas.openxmlformats.org/officeDocument/2006/relationships">
   <a:themeElements>
     <a:clrScheme name="Default">
@@ -34280,7 +34559,7 @@
 </a:theme>
 </file>
 
-<file path=ppt/theme/theme2.xml><?xml version="1.0" encoding="utf-8"?>
+<file path=ppt/theme/theme3.xml><?xml version="1.0" encoding="utf-8"?>
 <a:theme xmlns:a="http://schemas.openxmlformats.org/drawingml/2006/main" xmlns:r="http://schemas.openxmlformats.org/officeDocument/2006/relationships" name="LF Energy Theme 2023">
   <a:themeElements>
     <a:clrScheme name="Geometric">
@@ -34557,283 +34836,4 @@
     </a:fmtScheme>
   </a:themeElements>
 </a:theme>
-</file>
-
-<file path=ppt/theme/theme3.xml><?xml version="1.0" encoding="utf-8"?>
-<a:theme xmlns:a="http://schemas.openxmlformats.org/drawingml/2006/main" xmlns:r="http://schemas.openxmlformats.org/officeDocument/2006/relationships" name="Simple Light">
-  <a:themeElements>
-    <a:clrScheme name="Simple Light">
-      <a:dk1>
-        <a:srgbClr val="000000"/>
-      </a:dk1>
-      <a:lt1>
-        <a:srgbClr val="FFFFFF"/>
-      </a:lt1>
-      <a:dk2>
-        <a:srgbClr val="595959"/>
-      </a:dk2>
-      <a:lt2>
-        <a:srgbClr val="EEEEEE"/>
-      </a:lt2>
-      <a:accent1>
-        <a:srgbClr val="4285F4"/>
-      </a:accent1>
-      <a:accent2>
-        <a:srgbClr val="212121"/>
-      </a:accent2>
-      <a:accent3>
-        <a:srgbClr val="78909C"/>
-      </a:accent3>
-      <a:accent4>
-        <a:srgbClr val="FFAB40"/>
-      </a:accent4>
-      <a:accent5>
-        <a:srgbClr val="0097A7"/>
-      </a:accent5>
-      <a:accent6>
-        <a:srgbClr val="EEFF41"/>
-      </a:accent6>
-      <a:hlink>
-        <a:srgbClr val="0097A7"/>
-      </a:hlink>
-      <a:folHlink>
-        <a:srgbClr val="0097A7"/>
-      </a:folHlink>
-    </a:clrScheme>
-    <a:fontScheme name="Office">
-      <a:majorFont>
-        <a:latin typeface="Arial"/>
-        <a:ea typeface=""/>
-        <a:cs typeface=""/>
-        <a:font script="Jpan" typeface="ＭＳ Ｐゴシック"/>
-        <a:font script="Hang" typeface="맑은 고딕"/>
-        <a:font script="Hans" typeface="宋体"/>
-        <a:font script="Hant" typeface="新細明體"/>
-        <a:font script="Arab" typeface="Times New Roman"/>
-        <a:font script="Hebr" typeface="Times New Roman"/>
-        <a:font script="Thai" typeface="Angsana New"/>
-        <a:font script="Ethi" typeface="Nyala"/>
-        <a:font script="Beng" typeface="Vrinda"/>
-        <a:font script="Gujr" typeface="Shruti"/>
-        <a:font script="Khmr" typeface="MoolBoran"/>
-        <a:font script="Knda" typeface="Tunga"/>
-        <a:font script="Guru" typeface="Raavi"/>
-        <a:font script="Cans" typeface="Euphemia"/>
-        <a:font script="Cher" typeface="Plantagenet Cherokee"/>
-        <a:font script="Yiii" typeface="Microsoft Yi Baiti"/>
-        <a:font script="Tibt" typeface="Microsoft Himalaya"/>
-        <a:font script="Thaa" typeface="MV Boli"/>
-        <a:font script="Deva" typeface="Mangal"/>
-        <a:font script="Telu" typeface="Gautami"/>
-        <a:font script="Taml" typeface="Latha"/>
-        <a:font script="Syrc" typeface="Estrangelo Edessa"/>
-        <a:font script="Orya" typeface="Kalinga"/>
-        <a:font script="Mlym" typeface="Kartika"/>
-        <a:font script="Laoo" typeface="DokChampa"/>
-        <a:font script="Sinh" typeface="Iskoola Pota"/>
-        <a:font script="Mong" typeface="Mongolian Baiti"/>
-        <a:font script="Viet" typeface="Times New Roman"/>
-        <a:font script="Uigh" typeface="Microsoft Uighur"/>
-        <a:font script="Geor" typeface="Sylfaen"/>
-      </a:majorFont>
-      <a:minorFont>
-        <a:latin typeface="Arial"/>
-        <a:ea typeface=""/>
-        <a:cs typeface=""/>
-        <a:font script="Jpan" typeface="ＭＳ Ｐゴシック"/>
-        <a:font script="Hang" typeface="맑은 고딕"/>
-        <a:font script="Hans" typeface="宋体"/>
-        <a:font script="Hant" typeface="新細明體"/>
-        <a:font script="Arab" typeface="Arial"/>
-        <a:font script="Hebr" typeface="Arial"/>
-        <a:font script="Thai" typeface="Cordia New"/>
-        <a:font script="Ethi" typeface="Nyala"/>
-        <a:font script="Beng" typeface="Vrinda"/>
-        <a:font script="Gujr" typeface="Shruti"/>
-        <a:font script="Khmr" typeface="DaunPenh"/>
-        <a:font script="Knda" typeface="Tunga"/>
-        <a:font script="Guru" typeface="Raavi"/>
-        <a:font script="Cans" typeface="Euphemia"/>
-        <a:font script="Cher" typeface="Plantagenet Cherokee"/>
-        <a:font script="Yiii" typeface="Microsoft Yi Baiti"/>
-        <a:font script="Tibt" typeface="Microsoft Himalaya"/>
-        <a:font script="Thaa" typeface="MV Boli"/>
-        <a:font script="Deva" typeface="Mangal"/>
-        <a:font script="Telu" typeface="Gautami"/>
-        <a:font script="Taml" typeface="Latha"/>
-        <a:font script="Syrc" typeface="Estrangelo Edessa"/>
-        <a:font script="Orya" typeface="Kalinga"/>
-        <a:font script="Mlym" typeface="Kartika"/>
-        <a:font script="Laoo" typeface="DokChampa"/>
-        <a:font script="Sinh" typeface="Iskoola Pota"/>
-        <a:font script="Mong" typeface="Mongolian Baiti"/>
-        <a:font script="Viet" typeface="Arial"/>
-        <a:font script="Uigh" typeface="Microsoft Uighur"/>
-        <a:font script="Geor" typeface="Sylfaen"/>
-      </a:minorFont>
-    </a:fontScheme>
-    <a:fmtScheme name="Office">
-      <a:fillStyleLst>
-        <a:solidFill>
-          <a:schemeClr val="phClr"/>
-        </a:solidFill>
-        <a:gradFill rotWithShape="1">
-          <a:gsLst>
-            <a:gs pos="0">
-              <a:schemeClr val="phClr">
-                <a:tint val="50000"/>
-                <a:satMod val="300000"/>
-              </a:schemeClr>
-            </a:gs>
-            <a:gs pos="35000">
-              <a:schemeClr val="phClr">
-                <a:tint val="37000"/>
-                <a:satMod val="300000"/>
-              </a:schemeClr>
-            </a:gs>
-            <a:gs pos="100000">
-              <a:schemeClr val="phClr">
-                <a:tint val="15000"/>
-                <a:satMod val="350000"/>
-              </a:schemeClr>
-            </a:gs>
-          </a:gsLst>
-          <a:lin ang="16200000" scaled="1"/>
-        </a:gradFill>
-        <a:gradFill rotWithShape="1">
-          <a:gsLst>
-            <a:gs pos="0">
-              <a:schemeClr val="phClr">
-                <a:tint val="100000"/>
-                <a:shade val="100000"/>
-                <a:satMod val="130000"/>
-              </a:schemeClr>
-            </a:gs>
-            <a:gs pos="100000">
-              <a:schemeClr val="phClr">
-                <a:tint val="50000"/>
-                <a:shade val="100000"/>
-                <a:satMod val="350000"/>
-              </a:schemeClr>
-            </a:gs>
-          </a:gsLst>
-          <a:lin ang="16200000" scaled="0"/>
-        </a:gradFill>
-      </a:fillStyleLst>
-      <a:lnStyleLst>
-        <a:ln w="9525" cap="flat" cmpd="sng" algn="ctr">
-          <a:solidFill>
-            <a:schemeClr val="phClr">
-              <a:shade val="95000"/>
-              <a:satMod val="105000"/>
-            </a:schemeClr>
-          </a:solidFill>
-          <a:prstDash val="solid"/>
-        </a:ln>
-        <a:ln w="25400" cap="flat" cmpd="sng" algn="ctr">
-          <a:solidFill>
-            <a:schemeClr val="phClr"/>
-          </a:solidFill>
-          <a:prstDash val="solid"/>
-        </a:ln>
-        <a:ln w="38100" cap="flat" cmpd="sng" algn="ctr">
-          <a:solidFill>
-            <a:schemeClr val="phClr"/>
-          </a:solidFill>
-          <a:prstDash val="solid"/>
-        </a:ln>
-      </a:lnStyleLst>
-      <a:effectStyleLst>
-        <a:effectStyle>
-          <a:effectLst>
-            <a:outerShdw blurRad="40000" dist="20000" dir="5400000" rotWithShape="0">
-              <a:srgbClr val="000000">
-                <a:alpha val="38000"/>
-              </a:srgbClr>
-            </a:outerShdw>
-          </a:effectLst>
-        </a:effectStyle>
-        <a:effectStyle>
-          <a:effectLst>
-            <a:outerShdw blurRad="40000" dist="23000" dir="5400000" rotWithShape="0">
-              <a:srgbClr val="000000">
-                <a:alpha val="35000"/>
-              </a:srgbClr>
-            </a:outerShdw>
-          </a:effectLst>
-        </a:effectStyle>
-        <a:effectStyle>
-          <a:effectLst>
-            <a:outerShdw blurRad="40000" dist="23000" dir="5400000" rotWithShape="0">
-              <a:srgbClr val="000000">
-                <a:alpha val="35000"/>
-              </a:srgbClr>
-            </a:outerShdw>
-          </a:effectLst>
-          <a:scene3d>
-            <a:camera prst="orthographicFront">
-              <a:rot lat="0" lon="0" rev="0"/>
-            </a:camera>
-            <a:lightRig rig="threePt" dir="t">
-              <a:rot lat="0" lon="0" rev="1200000"/>
-            </a:lightRig>
-          </a:scene3d>
-          <a:sp3d>
-            <a:bevelT w="63500" h="25400"/>
-          </a:sp3d>
-        </a:effectStyle>
-      </a:effectStyleLst>
-      <a:bgFillStyleLst>
-        <a:solidFill>
-          <a:schemeClr val="phClr"/>
-        </a:solidFill>
-        <a:gradFill rotWithShape="1">
-          <a:gsLst>
-            <a:gs pos="0">
-              <a:schemeClr val="phClr">
-                <a:tint val="40000"/>
-                <a:satMod val="350000"/>
-              </a:schemeClr>
-            </a:gs>
-            <a:gs pos="40000">
-              <a:schemeClr val="phClr">
-                <a:tint val="45000"/>
-                <a:shade val="99000"/>
-                <a:satMod val="350000"/>
-              </a:schemeClr>
-            </a:gs>
-            <a:gs pos="100000">
-              <a:schemeClr val="phClr">
-                <a:shade val="20000"/>
-                <a:satMod val="255000"/>
-              </a:schemeClr>
-            </a:gs>
-          </a:gsLst>
-          <a:path path="circle">
-            <a:fillToRect l="50000" t="-80000" r="50000" b="180000"/>
-          </a:path>
-        </a:gradFill>
-        <a:gradFill rotWithShape="1">
-          <a:gsLst>
-            <a:gs pos="0">
-              <a:schemeClr val="phClr">
-                <a:tint val="80000"/>
-                <a:satMod val="300000"/>
-              </a:schemeClr>
-            </a:gs>
-            <a:gs pos="100000">
-              <a:schemeClr val="phClr">
-                <a:shade val="30000"/>
-                <a:satMod val="200000"/>
-              </a:schemeClr>
-            </a:gs>
-          </a:gsLst>
-          <a:path path="circle">
-            <a:fillToRect l="50000" t="50000" r="50000" b="50000"/>
-          </a:path>
-        </a:gradFill>
-      </a:bgFillStyleLst>
-    </a:fmtScheme>
-  </a:themeElements>
-</a:theme>
 </file>
</xml_diff>

<commit_message>
Update Data Sources from LFX 2026-09-16 (#310)
Update Data Sources from LFX

Signed-off-by: github-actions[bot] <41898282+github-actions[bot]@users.noreply.github.com>
</commit_message>
<xml_diff>
--- a/overview_deck/LF Energy High Level Overview.pptx
+++ b/overview_deck/LF Energy High Level Overview.pptx
@@ -25946,7 +25946,7 @@
             <a:tbl>
               <a:tblPr>
                 <a:noFill/>
-                <a:tableStyleId>{AC88F10A-30CC-4A48-90E0-F648FADE5769}</a:tableStyleId>
+                <a:tableStyleId>{17B6402E-12B4-4C7E-B380-1650E6779C8C}</a:tableStyleId>
               </a:tblPr>
               <a:tblGrid>
                 <a:gridCol w="1695200"/>
@@ -26736,7 +26736,7 @@
             <a:tbl>
               <a:tblPr>
                 <a:noFill/>
-                <a:tableStyleId>{AC88F10A-30CC-4A48-90E0-F648FADE5769}</a:tableStyleId>
+                <a:tableStyleId>{17B6402E-12B4-4C7E-B380-1650E6779C8C}</a:tableStyleId>
               </a:tblPr>
               <a:tblGrid>
                 <a:gridCol w="1695200"/>
@@ -27426,7 +27426,7 @@
             <a:tbl>
               <a:tblPr>
                 <a:noFill/>
-                <a:tableStyleId>{AC88F10A-30CC-4A48-90E0-F648FADE5769}</a:tableStyleId>
+                <a:tableStyleId>{17B6402E-12B4-4C7E-B380-1650E6779C8C}</a:tableStyleId>
               </a:tblPr>
               <a:tblGrid>
                 <a:gridCol w="1695200"/>
@@ -28678,7 +28678,7 @@
             <a:tbl>
               <a:tblPr>
                 <a:noFill/>
-                <a:tableStyleId>{AC88F10A-30CC-4A48-90E0-F648FADE5769}</a:tableStyleId>
+                <a:tableStyleId>{17B6402E-12B4-4C7E-B380-1650E6779C8C}</a:tableStyleId>
               </a:tblPr>
               <a:tblGrid>
                 <a:gridCol w="1695200"/>
@@ -29670,7 +29670,7 @@
             <a:tbl>
               <a:tblPr>
                 <a:noFill/>
-                <a:tableStyleId>{AC88F10A-30CC-4A48-90E0-F648FADE5769}</a:tableStyleId>
+                <a:tableStyleId>{17B6402E-12B4-4C7E-B380-1650E6779C8C}</a:tableStyleId>
               </a:tblPr>
               <a:tblGrid>
                 <a:gridCol w="3048000"/>
@@ -33175,7 +33175,7 @@
             <a:tbl>
               <a:tblPr>
                 <a:noFill/>
-                <a:tableStyleId>{AC88F10A-30CC-4A48-90E0-F648FADE5769}</a:tableStyleId>
+                <a:tableStyleId>{17B6402E-12B4-4C7E-B380-1650E6779C8C}</a:tableStyleId>
               </a:tblPr>
               <a:tblGrid>
                 <a:gridCol w="1828800"/>

</xml_diff>

<commit_message>
Update Data Sources from LFX 2026-09-17 (#311)
Update Data Sources from LFX

Signed-off-by: github-actions[bot] <41898282+github-actions[bot]@users.noreply.github.com>
</commit_message>
<xml_diff>
--- a/overview_deck/LF Energy High Level Overview.pptx
+++ b/overview_deck/LF Energy High Level Overview.pptx
@@ -25946,7 +25946,7 @@
             <a:tbl>
               <a:tblPr>
                 <a:noFill/>
-                <a:tableStyleId>{17B6402E-12B4-4C7E-B380-1650E6779C8C}</a:tableStyleId>
+                <a:tableStyleId>{3B29B9BE-CF87-4C62-9BA6-F7B6134BD6A9}</a:tableStyleId>
               </a:tblPr>
               <a:tblGrid>
                 <a:gridCol w="1695200"/>
@@ -26736,7 +26736,7 @@
             <a:tbl>
               <a:tblPr>
                 <a:noFill/>
-                <a:tableStyleId>{17B6402E-12B4-4C7E-B380-1650E6779C8C}</a:tableStyleId>
+                <a:tableStyleId>{3B29B9BE-CF87-4C62-9BA6-F7B6134BD6A9}</a:tableStyleId>
               </a:tblPr>
               <a:tblGrid>
                 <a:gridCol w="1695200"/>
@@ -27426,7 +27426,7 @@
             <a:tbl>
               <a:tblPr>
                 <a:noFill/>
-                <a:tableStyleId>{17B6402E-12B4-4C7E-B380-1650E6779C8C}</a:tableStyleId>
+                <a:tableStyleId>{3B29B9BE-CF87-4C62-9BA6-F7B6134BD6A9}</a:tableStyleId>
               </a:tblPr>
               <a:tblGrid>
                 <a:gridCol w="1695200"/>
@@ -28678,7 +28678,7 @@
             <a:tbl>
               <a:tblPr>
                 <a:noFill/>
-                <a:tableStyleId>{17B6402E-12B4-4C7E-B380-1650E6779C8C}</a:tableStyleId>
+                <a:tableStyleId>{3B29B9BE-CF87-4C62-9BA6-F7B6134BD6A9}</a:tableStyleId>
               </a:tblPr>
               <a:tblGrid>
                 <a:gridCol w="1695200"/>
@@ -29670,7 +29670,7 @@
             <a:tbl>
               <a:tblPr>
                 <a:noFill/>
-                <a:tableStyleId>{17B6402E-12B4-4C7E-B380-1650E6779C8C}</a:tableStyleId>
+                <a:tableStyleId>{3B29B9BE-CF87-4C62-9BA6-F7B6134BD6A9}</a:tableStyleId>
               </a:tblPr>
               <a:tblGrid>
                 <a:gridCol w="3048000"/>
@@ -33175,7 +33175,7 @@
             <a:tbl>
               <a:tblPr>
                 <a:noFill/>
-                <a:tableStyleId>{17B6402E-12B4-4C7E-B380-1650E6779C8C}</a:tableStyleId>
+                <a:tableStyleId>{3B29B9BE-CF87-4C62-9BA6-F7B6134BD6A9}</a:tableStyleId>
               </a:tblPr>
               <a:tblGrid>
                 <a:gridCol w="1828800"/>
@@ -34002,285 +34002,6 @@
 </file>
 
 <file path=ppt/theme/theme1.xml><?xml version="1.0" encoding="utf-8"?>
-<a:theme xmlns:a="http://schemas.openxmlformats.org/drawingml/2006/main" xmlns:r="http://schemas.openxmlformats.org/officeDocument/2006/relationships" name="Simple Light">
-  <a:themeElements>
-    <a:clrScheme name="Simple Light">
-      <a:dk1>
-        <a:srgbClr val="000000"/>
-      </a:dk1>
-      <a:lt1>
-        <a:srgbClr val="FFFFFF"/>
-      </a:lt1>
-      <a:dk2>
-        <a:srgbClr val="595959"/>
-      </a:dk2>
-      <a:lt2>
-        <a:srgbClr val="EEEEEE"/>
-      </a:lt2>
-      <a:accent1>
-        <a:srgbClr val="4285F4"/>
-      </a:accent1>
-      <a:accent2>
-        <a:srgbClr val="212121"/>
-      </a:accent2>
-      <a:accent3>
-        <a:srgbClr val="78909C"/>
-      </a:accent3>
-      <a:accent4>
-        <a:srgbClr val="FFAB40"/>
-      </a:accent4>
-      <a:accent5>
-        <a:srgbClr val="0097A7"/>
-      </a:accent5>
-      <a:accent6>
-        <a:srgbClr val="EEFF41"/>
-      </a:accent6>
-      <a:hlink>
-        <a:srgbClr val="0097A7"/>
-      </a:hlink>
-      <a:folHlink>
-        <a:srgbClr val="0097A7"/>
-      </a:folHlink>
-    </a:clrScheme>
-    <a:fontScheme name="Office">
-      <a:majorFont>
-        <a:latin typeface="Arial"/>
-        <a:ea typeface=""/>
-        <a:cs typeface=""/>
-        <a:font script="Jpan" typeface="ＭＳ Ｐゴシック"/>
-        <a:font script="Hang" typeface="맑은 고딕"/>
-        <a:font script="Hans" typeface="宋体"/>
-        <a:font script="Hant" typeface="新細明體"/>
-        <a:font script="Arab" typeface="Times New Roman"/>
-        <a:font script="Hebr" typeface="Times New Roman"/>
-        <a:font script="Thai" typeface="Angsana New"/>
-        <a:font script="Ethi" typeface="Nyala"/>
-        <a:font script="Beng" typeface="Vrinda"/>
-        <a:font script="Gujr" typeface="Shruti"/>
-        <a:font script="Khmr" typeface="MoolBoran"/>
-        <a:font script="Knda" typeface="Tunga"/>
-        <a:font script="Guru" typeface="Raavi"/>
-        <a:font script="Cans" typeface="Euphemia"/>
-        <a:font script="Cher" typeface="Plantagenet Cherokee"/>
-        <a:font script="Yiii" typeface="Microsoft Yi Baiti"/>
-        <a:font script="Tibt" typeface="Microsoft Himalaya"/>
-        <a:font script="Thaa" typeface="MV Boli"/>
-        <a:font script="Deva" typeface="Mangal"/>
-        <a:font script="Telu" typeface="Gautami"/>
-        <a:font script="Taml" typeface="Latha"/>
-        <a:font script="Syrc" typeface="Estrangelo Edessa"/>
-        <a:font script="Orya" typeface="Kalinga"/>
-        <a:font script="Mlym" typeface="Kartika"/>
-        <a:font script="Laoo" typeface="DokChampa"/>
-        <a:font script="Sinh" typeface="Iskoola Pota"/>
-        <a:font script="Mong" typeface="Mongolian Baiti"/>
-        <a:font script="Viet" typeface="Times New Roman"/>
-        <a:font script="Uigh" typeface="Microsoft Uighur"/>
-        <a:font script="Geor" typeface="Sylfaen"/>
-      </a:majorFont>
-      <a:minorFont>
-        <a:latin typeface="Arial"/>
-        <a:ea typeface=""/>
-        <a:cs typeface=""/>
-        <a:font script="Jpan" typeface="ＭＳ Ｐゴシック"/>
-        <a:font script="Hang" typeface="맑은 고딕"/>
-        <a:font script="Hans" typeface="宋体"/>
-        <a:font script="Hant" typeface="新細明體"/>
-        <a:font script="Arab" typeface="Arial"/>
-        <a:font script="Hebr" typeface="Arial"/>
-        <a:font script="Thai" typeface="Cordia New"/>
-        <a:font script="Ethi" typeface="Nyala"/>
-        <a:font script="Beng" typeface="Vrinda"/>
-        <a:font script="Gujr" typeface="Shruti"/>
-        <a:font script="Khmr" typeface="DaunPenh"/>
-        <a:font script="Knda" typeface="Tunga"/>
-        <a:font script="Guru" typeface="Raavi"/>
-        <a:font script="Cans" typeface="Euphemia"/>
-        <a:font script="Cher" typeface="Plantagenet Cherokee"/>
-        <a:font script="Yiii" typeface="Microsoft Yi Baiti"/>
-        <a:font script="Tibt" typeface="Microsoft Himalaya"/>
-        <a:font script="Thaa" typeface="MV Boli"/>
-        <a:font script="Deva" typeface="Mangal"/>
-        <a:font script="Telu" typeface="Gautami"/>
-        <a:font script="Taml" typeface="Latha"/>
-        <a:font script="Syrc" typeface="Estrangelo Edessa"/>
-        <a:font script="Orya" typeface="Kalinga"/>
-        <a:font script="Mlym" typeface="Kartika"/>
-        <a:font script="Laoo" typeface="DokChampa"/>
-        <a:font script="Sinh" typeface="Iskoola Pota"/>
-        <a:font script="Mong" typeface="Mongolian Baiti"/>
-        <a:font script="Viet" typeface="Arial"/>
-        <a:font script="Uigh" typeface="Microsoft Uighur"/>
-        <a:font script="Geor" typeface="Sylfaen"/>
-      </a:minorFont>
-    </a:fontScheme>
-    <a:fmtScheme name="Office">
-      <a:fillStyleLst>
-        <a:solidFill>
-          <a:schemeClr val="phClr"/>
-        </a:solidFill>
-        <a:gradFill rotWithShape="1">
-          <a:gsLst>
-            <a:gs pos="0">
-              <a:schemeClr val="phClr">
-                <a:tint val="50000"/>
-                <a:satMod val="300000"/>
-              </a:schemeClr>
-            </a:gs>
-            <a:gs pos="35000">
-              <a:schemeClr val="phClr">
-                <a:tint val="37000"/>
-                <a:satMod val="300000"/>
-              </a:schemeClr>
-            </a:gs>
-            <a:gs pos="100000">
-              <a:schemeClr val="phClr">
-                <a:tint val="15000"/>
-                <a:satMod val="350000"/>
-              </a:schemeClr>
-            </a:gs>
-          </a:gsLst>
-          <a:lin ang="16200000" scaled="1"/>
-        </a:gradFill>
-        <a:gradFill rotWithShape="1">
-          <a:gsLst>
-            <a:gs pos="0">
-              <a:schemeClr val="phClr">
-                <a:tint val="100000"/>
-                <a:shade val="100000"/>
-                <a:satMod val="130000"/>
-              </a:schemeClr>
-            </a:gs>
-            <a:gs pos="100000">
-              <a:schemeClr val="phClr">
-                <a:tint val="50000"/>
-                <a:shade val="100000"/>
-                <a:satMod val="350000"/>
-              </a:schemeClr>
-            </a:gs>
-          </a:gsLst>
-          <a:lin ang="16200000" scaled="0"/>
-        </a:gradFill>
-      </a:fillStyleLst>
-      <a:lnStyleLst>
-        <a:ln w="9525" cap="flat" cmpd="sng" algn="ctr">
-          <a:solidFill>
-            <a:schemeClr val="phClr">
-              <a:shade val="95000"/>
-              <a:satMod val="105000"/>
-            </a:schemeClr>
-          </a:solidFill>
-          <a:prstDash val="solid"/>
-        </a:ln>
-        <a:ln w="25400" cap="flat" cmpd="sng" algn="ctr">
-          <a:solidFill>
-            <a:schemeClr val="phClr"/>
-          </a:solidFill>
-          <a:prstDash val="solid"/>
-        </a:ln>
-        <a:ln w="38100" cap="flat" cmpd="sng" algn="ctr">
-          <a:solidFill>
-            <a:schemeClr val="phClr"/>
-          </a:solidFill>
-          <a:prstDash val="solid"/>
-        </a:ln>
-      </a:lnStyleLst>
-      <a:effectStyleLst>
-        <a:effectStyle>
-          <a:effectLst>
-            <a:outerShdw blurRad="40000" dist="20000" dir="5400000" rotWithShape="0">
-              <a:srgbClr val="000000">
-                <a:alpha val="38000"/>
-              </a:srgbClr>
-            </a:outerShdw>
-          </a:effectLst>
-        </a:effectStyle>
-        <a:effectStyle>
-          <a:effectLst>
-            <a:outerShdw blurRad="40000" dist="23000" dir="5400000" rotWithShape="0">
-              <a:srgbClr val="000000">
-                <a:alpha val="35000"/>
-              </a:srgbClr>
-            </a:outerShdw>
-          </a:effectLst>
-        </a:effectStyle>
-        <a:effectStyle>
-          <a:effectLst>
-            <a:outerShdw blurRad="40000" dist="23000" dir="5400000" rotWithShape="0">
-              <a:srgbClr val="000000">
-                <a:alpha val="35000"/>
-              </a:srgbClr>
-            </a:outerShdw>
-          </a:effectLst>
-          <a:scene3d>
-            <a:camera prst="orthographicFront">
-              <a:rot lat="0" lon="0" rev="0"/>
-            </a:camera>
-            <a:lightRig rig="threePt" dir="t">
-              <a:rot lat="0" lon="0" rev="1200000"/>
-            </a:lightRig>
-          </a:scene3d>
-          <a:sp3d>
-            <a:bevelT w="63500" h="25400"/>
-          </a:sp3d>
-        </a:effectStyle>
-      </a:effectStyleLst>
-      <a:bgFillStyleLst>
-        <a:solidFill>
-          <a:schemeClr val="phClr"/>
-        </a:solidFill>
-        <a:gradFill rotWithShape="1">
-          <a:gsLst>
-            <a:gs pos="0">
-              <a:schemeClr val="phClr">
-                <a:tint val="40000"/>
-                <a:satMod val="350000"/>
-              </a:schemeClr>
-            </a:gs>
-            <a:gs pos="40000">
-              <a:schemeClr val="phClr">
-                <a:tint val="45000"/>
-                <a:shade val="99000"/>
-                <a:satMod val="350000"/>
-              </a:schemeClr>
-            </a:gs>
-            <a:gs pos="100000">
-              <a:schemeClr val="phClr">
-                <a:shade val="20000"/>
-                <a:satMod val="255000"/>
-              </a:schemeClr>
-            </a:gs>
-          </a:gsLst>
-          <a:path path="circle">
-            <a:fillToRect l="50000" t="-80000" r="50000" b="180000"/>
-          </a:path>
-        </a:gradFill>
-        <a:gradFill rotWithShape="1">
-          <a:gsLst>
-            <a:gs pos="0">
-              <a:schemeClr val="phClr">
-                <a:tint val="80000"/>
-                <a:satMod val="300000"/>
-              </a:schemeClr>
-            </a:gs>
-            <a:gs pos="100000">
-              <a:schemeClr val="phClr">
-                <a:shade val="30000"/>
-                <a:satMod val="200000"/>
-              </a:schemeClr>
-            </a:gs>
-          </a:gsLst>
-          <a:path path="circle">
-            <a:fillToRect l="50000" t="50000" r="50000" b="50000"/>
-          </a:path>
-        </a:gradFill>
-      </a:bgFillStyleLst>
-    </a:fmtScheme>
-  </a:themeElements>
-</a:theme>
-</file>
-
-<file path=ppt/theme/theme2.xml><?xml version="1.0" encoding="utf-8"?>
 <a:theme xmlns:a="http://schemas.openxmlformats.org/drawingml/2006/main" xmlns:r="http://schemas.openxmlformats.org/officeDocument/2006/relationships">
   <a:themeElements>
     <a:clrScheme name="Default">
@@ -34559,7 +34280,7 @@
 </a:theme>
 </file>
 
-<file path=ppt/theme/theme3.xml><?xml version="1.0" encoding="utf-8"?>
+<file path=ppt/theme/theme2.xml><?xml version="1.0" encoding="utf-8"?>
 <a:theme xmlns:a="http://schemas.openxmlformats.org/drawingml/2006/main" xmlns:r="http://schemas.openxmlformats.org/officeDocument/2006/relationships" name="LF Energy Theme 2023">
   <a:themeElements>
     <a:clrScheme name="Geometric">
@@ -34836,4 +34557,283 @@
     </a:fmtScheme>
   </a:themeElements>
 </a:theme>
+</file>
+
+<file path=ppt/theme/theme3.xml><?xml version="1.0" encoding="utf-8"?>
+<a:theme xmlns:a="http://schemas.openxmlformats.org/drawingml/2006/main" xmlns:r="http://schemas.openxmlformats.org/officeDocument/2006/relationships" name="Simple Light">
+  <a:themeElements>
+    <a:clrScheme name="Simple Light">
+      <a:dk1>
+        <a:srgbClr val="000000"/>
+      </a:dk1>
+      <a:lt1>
+        <a:srgbClr val="FFFFFF"/>
+      </a:lt1>
+      <a:dk2>
+        <a:srgbClr val="595959"/>
+      </a:dk2>
+      <a:lt2>
+        <a:srgbClr val="EEEEEE"/>
+      </a:lt2>
+      <a:accent1>
+        <a:srgbClr val="4285F4"/>
+      </a:accent1>
+      <a:accent2>
+        <a:srgbClr val="212121"/>
+      </a:accent2>
+      <a:accent3>
+        <a:srgbClr val="78909C"/>
+      </a:accent3>
+      <a:accent4>
+        <a:srgbClr val="FFAB40"/>
+      </a:accent4>
+      <a:accent5>
+        <a:srgbClr val="0097A7"/>
+      </a:accent5>
+      <a:accent6>
+        <a:srgbClr val="EEFF41"/>
+      </a:accent6>
+      <a:hlink>
+        <a:srgbClr val="0097A7"/>
+      </a:hlink>
+      <a:folHlink>
+        <a:srgbClr val="0097A7"/>
+      </a:folHlink>
+    </a:clrScheme>
+    <a:fontScheme name="Office">
+      <a:majorFont>
+        <a:latin typeface="Arial"/>
+        <a:ea typeface=""/>
+        <a:cs typeface=""/>
+        <a:font script="Jpan" typeface="ＭＳ Ｐゴシック"/>
+        <a:font script="Hang" typeface="맑은 고딕"/>
+        <a:font script="Hans" typeface="宋体"/>
+        <a:font script="Hant" typeface="新細明體"/>
+        <a:font script="Arab" typeface="Times New Roman"/>
+        <a:font script="Hebr" typeface="Times New Roman"/>
+        <a:font script="Thai" typeface="Angsana New"/>
+        <a:font script="Ethi" typeface="Nyala"/>
+        <a:font script="Beng" typeface="Vrinda"/>
+        <a:font script="Gujr" typeface="Shruti"/>
+        <a:font script="Khmr" typeface="MoolBoran"/>
+        <a:font script="Knda" typeface="Tunga"/>
+        <a:font script="Guru" typeface="Raavi"/>
+        <a:font script="Cans" typeface="Euphemia"/>
+        <a:font script="Cher" typeface="Plantagenet Cherokee"/>
+        <a:font script="Yiii" typeface="Microsoft Yi Baiti"/>
+        <a:font script="Tibt" typeface="Microsoft Himalaya"/>
+        <a:font script="Thaa" typeface="MV Boli"/>
+        <a:font script="Deva" typeface="Mangal"/>
+        <a:font script="Telu" typeface="Gautami"/>
+        <a:font script="Taml" typeface="Latha"/>
+        <a:font script="Syrc" typeface="Estrangelo Edessa"/>
+        <a:font script="Orya" typeface="Kalinga"/>
+        <a:font script="Mlym" typeface="Kartika"/>
+        <a:font script="Laoo" typeface="DokChampa"/>
+        <a:font script="Sinh" typeface="Iskoola Pota"/>
+        <a:font script="Mong" typeface="Mongolian Baiti"/>
+        <a:font script="Viet" typeface="Times New Roman"/>
+        <a:font script="Uigh" typeface="Microsoft Uighur"/>
+        <a:font script="Geor" typeface="Sylfaen"/>
+      </a:majorFont>
+      <a:minorFont>
+        <a:latin typeface="Arial"/>
+        <a:ea typeface=""/>
+        <a:cs typeface=""/>
+        <a:font script="Jpan" typeface="ＭＳ Ｐゴシック"/>
+        <a:font script="Hang" typeface="맑은 고딕"/>
+        <a:font script="Hans" typeface="宋体"/>
+        <a:font script="Hant" typeface="新細明體"/>
+        <a:font script="Arab" typeface="Arial"/>
+        <a:font script="Hebr" typeface="Arial"/>
+        <a:font script="Thai" typeface="Cordia New"/>
+        <a:font script="Ethi" typeface="Nyala"/>
+        <a:font script="Beng" typeface="Vrinda"/>
+        <a:font script="Gujr" typeface="Shruti"/>
+        <a:font script="Khmr" typeface="DaunPenh"/>
+        <a:font script="Knda" typeface="Tunga"/>
+        <a:font script="Guru" typeface="Raavi"/>
+        <a:font script="Cans" typeface="Euphemia"/>
+        <a:font script="Cher" typeface="Plantagenet Cherokee"/>
+        <a:font script="Yiii" typeface="Microsoft Yi Baiti"/>
+        <a:font script="Tibt" typeface="Microsoft Himalaya"/>
+        <a:font script="Thaa" typeface="MV Boli"/>
+        <a:font script="Deva" typeface="Mangal"/>
+        <a:font script="Telu" typeface="Gautami"/>
+        <a:font script="Taml" typeface="Latha"/>
+        <a:font script="Syrc" typeface="Estrangelo Edessa"/>
+        <a:font script="Orya" typeface="Kalinga"/>
+        <a:font script="Mlym" typeface="Kartika"/>
+        <a:font script="Laoo" typeface="DokChampa"/>
+        <a:font script="Sinh" typeface="Iskoola Pota"/>
+        <a:font script="Mong" typeface="Mongolian Baiti"/>
+        <a:font script="Viet" typeface="Arial"/>
+        <a:font script="Uigh" typeface="Microsoft Uighur"/>
+        <a:font script="Geor" typeface="Sylfaen"/>
+      </a:minorFont>
+    </a:fontScheme>
+    <a:fmtScheme name="Office">
+      <a:fillStyleLst>
+        <a:solidFill>
+          <a:schemeClr val="phClr"/>
+        </a:solidFill>
+        <a:gradFill rotWithShape="1">
+          <a:gsLst>
+            <a:gs pos="0">
+              <a:schemeClr val="phClr">
+                <a:tint val="50000"/>
+                <a:satMod val="300000"/>
+              </a:schemeClr>
+            </a:gs>
+            <a:gs pos="35000">
+              <a:schemeClr val="phClr">
+                <a:tint val="37000"/>
+                <a:satMod val="300000"/>
+              </a:schemeClr>
+            </a:gs>
+            <a:gs pos="100000">
+              <a:schemeClr val="phClr">
+                <a:tint val="15000"/>
+                <a:satMod val="350000"/>
+              </a:schemeClr>
+            </a:gs>
+          </a:gsLst>
+          <a:lin ang="16200000" scaled="1"/>
+        </a:gradFill>
+        <a:gradFill rotWithShape="1">
+          <a:gsLst>
+            <a:gs pos="0">
+              <a:schemeClr val="phClr">
+                <a:tint val="100000"/>
+                <a:shade val="100000"/>
+                <a:satMod val="130000"/>
+              </a:schemeClr>
+            </a:gs>
+            <a:gs pos="100000">
+              <a:schemeClr val="phClr">
+                <a:tint val="50000"/>
+                <a:shade val="100000"/>
+                <a:satMod val="350000"/>
+              </a:schemeClr>
+            </a:gs>
+          </a:gsLst>
+          <a:lin ang="16200000" scaled="0"/>
+        </a:gradFill>
+      </a:fillStyleLst>
+      <a:lnStyleLst>
+        <a:ln w="9525" cap="flat" cmpd="sng" algn="ctr">
+          <a:solidFill>
+            <a:schemeClr val="phClr">
+              <a:shade val="95000"/>
+              <a:satMod val="105000"/>
+            </a:schemeClr>
+          </a:solidFill>
+          <a:prstDash val="solid"/>
+        </a:ln>
+        <a:ln w="25400" cap="flat" cmpd="sng" algn="ctr">
+          <a:solidFill>
+            <a:schemeClr val="phClr"/>
+          </a:solidFill>
+          <a:prstDash val="solid"/>
+        </a:ln>
+        <a:ln w="38100" cap="flat" cmpd="sng" algn="ctr">
+          <a:solidFill>
+            <a:schemeClr val="phClr"/>
+          </a:solidFill>
+          <a:prstDash val="solid"/>
+        </a:ln>
+      </a:lnStyleLst>
+      <a:effectStyleLst>
+        <a:effectStyle>
+          <a:effectLst>
+            <a:outerShdw blurRad="40000" dist="20000" dir="5400000" rotWithShape="0">
+              <a:srgbClr val="000000">
+                <a:alpha val="38000"/>
+              </a:srgbClr>
+            </a:outerShdw>
+          </a:effectLst>
+        </a:effectStyle>
+        <a:effectStyle>
+          <a:effectLst>
+            <a:outerShdw blurRad="40000" dist="23000" dir="5400000" rotWithShape="0">
+              <a:srgbClr val="000000">
+                <a:alpha val="35000"/>
+              </a:srgbClr>
+            </a:outerShdw>
+          </a:effectLst>
+        </a:effectStyle>
+        <a:effectStyle>
+          <a:effectLst>
+            <a:outerShdw blurRad="40000" dist="23000" dir="5400000" rotWithShape="0">
+              <a:srgbClr val="000000">
+                <a:alpha val="35000"/>
+              </a:srgbClr>
+            </a:outerShdw>
+          </a:effectLst>
+          <a:scene3d>
+            <a:camera prst="orthographicFront">
+              <a:rot lat="0" lon="0" rev="0"/>
+            </a:camera>
+            <a:lightRig rig="threePt" dir="t">
+              <a:rot lat="0" lon="0" rev="1200000"/>
+            </a:lightRig>
+          </a:scene3d>
+          <a:sp3d>
+            <a:bevelT w="63500" h="25400"/>
+          </a:sp3d>
+        </a:effectStyle>
+      </a:effectStyleLst>
+      <a:bgFillStyleLst>
+        <a:solidFill>
+          <a:schemeClr val="phClr"/>
+        </a:solidFill>
+        <a:gradFill rotWithShape="1">
+          <a:gsLst>
+            <a:gs pos="0">
+              <a:schemeClr val="phClr">
+                <a:tint val="40000"/>
+                <a:satMod val="350000"/>
+              </a:schemeClr>
+            </a:gs>
+            <a:gs pos="40000">
+              <a:schemeClr val="phClr">
+                <a:tint val="45000"/>
+                <a:shade val="99000"/>
+                <a:satMod val="350000"/>
+              </a:schemeClr>
+            </a:gs>
+            <a:gs pos="100000">
+              <a:schemeClr val="phClr">
+                <a:shade val="20000"/>
+                <a:satMod val="255000"/>
+              </a:schemeClr>
+            </a:gs>
+          </a:gsLst>
+          <a:path path="circle">
+            <a:fillToRect l="50000" t="-80000" r="50000" b="180000"/>
+          </a:path>
+        </a:gradFill>
+        <a:gradFill rotWithShape="1">
+          <a:gsLst>
+            <a:gs pos="0">
+              <a:schemeClr val="phClr">
+                <a:tint val="80000"/>
+                <a:satMod val="300000"/>
+              </a:schemeClr>
+            </a:gs>
+            <a:gs pos="100000">
+              <a:schemeClr val="phClr">
+                <a:shade val="30000"/>
+                <a:satMod val="200000"/>
+              </a:schemeClr>
+            </a:gs>
+          </a:gsLst>
+          <a:path path="circle">
+            <a:fillToRect l="50000" t="50000" r="50000" b="50000"/>
+          </a:path>
+        </a:gradFill>
+      </a:bgFillStyleLst>
+    </a:fmtScheme>
+  </a:themeElements>
+</a:theme>
 </file>
</xml_diff>

<commit_message>
Update Data Sources from LFX 2026-09-18 (#312)
Update Data Sources from LFX

Signed-off-by: github-actions[bot] <41898282+github-actions[bot]@users.noreply.github.com>
</commit_message>
<xml_diff>
--- a/overview_deck/LF Energy High Level Overview.pptx
+++ b/overview_deck/LF Energy High Level Overview.pptx
@@ -25946,7 +25946,7 @@
             <a:tbl>
               <a:tblPr>
                 <a:noFill/>
-                <a:tableStyleId>{3B29B9BE-CF87-4C62-9BA6-F7B6134BD6A9}</a:tableStyleId>
+                <a:tableStyleId>{6F6BE797-40FF-4D52-908A-4F3C3C9624B6}</a:tableStyleId>
               </a:tblPr>
               <a:tblGrid>
                 <a:gridCol w="1695200"/>
@@ -26736,7 +26736,7 @@
             <a:tbl>
               <a:tblPr>
                 <a:noFill/>
-                <a:tableStyleId>{3B29B9BE-CF87-4C62-9BA6-F7B6134BD6A9}</a:tableStyleId>
+                <a:tableStyleId>{6F6BE797-40FF-4D52-908A-4F3C3C9624B6}</a:tableStyleId>
               </a:tblPr>
               <a:tblGrid>
                 <a:gridCol w="1695200"/>
@@ -27426,7 +27426,7 @@
             <a:tbl>
               <a:tblPr>
                 <a:noFill/>
-                <a:tableStyleId>{3B29B9BE-CF87-4C62-9BA6-F7B6134BD6A9}</a:tableStyleId>
+                <a:tableStyleId>{6F6BE797-40FF-4D52-908A-4F3C3C9624B6}</a:tableStyleId>
               </a:tblPr>
               <a:tblGrid>
                 <a:gridCol w="1695200"/>
@@ -28678,7 +28678,7 @@
             <a:tbl>
               <a:tblPr>
                 <a:noFill/>
-                <a:tableStyleId>{3B29B9BE-CF87-4C62-9BA6-F7B6134BD6A9}</a:tableStyleId>
+                <a:tableStyleId>{6F6BE797-40FF-4D52-908A-4F3C3C9624B6}</a:tableStyleId>
               </a:tblPr>
               <a:tblGrid>
                 <a:gridCol w="1695200"/>
@@ -29670,7 +29670,7 @@
             <a:tbl>
               <a:tblPr>
                 <a:noFill/>
-                <a:tableStyleId>{3B29B9BE-CF87-4C62-9BA6-F7B6134BD6A9}</a:tableStyleId>
+                <a:tableStyleId>{6F6BE797-40FF-4D52-908A-4F3C3C9624B6}</a:tableStyleId>
               </a:tblPr>
               <a:tblGrid>
                 <a:gridCol w="3048000"/>
@@ -33175,7 +33175,7 @@
             <a:tbl>
               <a:tblPr>
                 <a:noFill/>
-                <a:tableStyleId>{3B29B9BE-CF87-4C62-9BA6-F7B6134BD6A9}</a:tableStyleId>
+                <a:tableStyleId>{6F6BE797-40FF-4D52-908A-4F3C3C9624B6}</a:tableStyleId>
               </a:tblPr>
               <a:tblGrid>
                 <a:gridCol w="1828800"/>
@@ -34002,6 +34002,285 @@
 </file>
 
 <file path=ppt/theme/theme1.xml><?xml version="1.0" encoding="utf-8"?>
+<a:theme xmlns:a="http://schemas.openxmlformats.org/drawingml/2006/main" xmlns:r="http://schemas.openxmlformats.org/officeDocument/2006/relationships" name="Simple Light">
+  <a:themeElements>
+    <a:clrScheme name="Simple Light">
+      <a:dk1>
+        <a:srgbClr val="000000"/>
+      </a:dk1>
+      <a:lt1>
+        <a:srgbClr val="FFFFFF"/>
+      </a:lt1>
+      <a:dk2>
+        <a:srgbClr val="595959"/>
+      </a:dk2>
+      <a:lt2>
+        <a:srgbClr val="EEEEEE"/>
+      </a:lt2>
+      <a:accent1>
+        <a:srgbClr val="4285F4"/>
+      </a:accent1>
+      <a:accent2>
+        <a:srgbClr val="212121"/>
+      </a:accent2>
+      <a:accent3>
+        <a:srgbClr val="78909C"/>
+      </a:accent3>
+      <a:accent4>
+        <a:srgbClr val="FFAB40"/>
+      </a:accent4>
+      <a:accent5>
+        <a:srgbClr val="0097A7"/>
+      </a:accent5>
+      <a:accent6>
+        <a:srgbClr val="EEFF41"/>
+      </a:accent6>
+      <a:hlink>
+        <a:srgbClr val="0097A7"/>
+      </a:hlink>
+      <a:folHlink>
+        <a:srgbClr val="0097A7"/>
+      </a:folHlink>
+    </a:clrScheme>
+    <a:fontScheme name="Office">
+      <a:majorFont>
+        <a:latin typeface="Arial"/>
+        <a:ea typeface=""/>
+        <a:cs typeface=""/>
+        <a:font script="Jpan" typeface="ＭＳ Ｐゴシック"/>
+        <a:font script="Hang" typeface="맑은 고딕"/>
+        <a:font script="Hans" typeface="宋体"/>
+        <a:font script="Hant" typeface="新細明體"/>
+        <a:font script="Arab" typeface="Times New Roman"/>
+        <a:font script="Hebr" typeface="Times New Roman"/>
+        <a:font script="Thai" typeface="Angsana New"/>
+        <a:font script="Ethi" typeface="Nyala"/>
+        <a:font script="Beng" typeface="Vrinda"/>
+        <a:font script="Gujr" typeface="Shruti"/>
+        <a:font script="Khmr" typeface="MoolBoran"/>
+        <a:font script="Knda" typeface="Tunga"/>
+        <a:font script="Guru" typeface="Raavi"/>
+        <a:font script="Cans" typeface="Euphemia"/>
+        <a:font script="Cher" typeface="Plantagenet Cherokee"/>
+        <a:font script="Yiii" typeface="Microsoft Yi Baiti"/>
+        <a:font script="Tibt" typeface="Microsoft Himalaya"/>
+        <a:font script="Thaa" typeface="MV Boli"/>
+        <a:font script="Deva" typeface="Mangal"/>
+        <a:font script="Telu" typeface="Gautami"/>
+        <a:font script="Taml" typeface="Latha"/>
+        <a:font script="Syrc" typeface="Estrangelo Edessa"/>
+        <a:font script="Orya" typeface="Kalinga"/>
+        <a:font script="Mlym" typeface="Kartika"/>
+        <a:font script="Laoo" typeface="DokChampa"/>
+        <a:font script="Sinh" typeface="Iskoola Pota"/>
+        <a:font script="Mong" typeface="Mongolian Baiti"/>
+        <a:font script="Viet" typeface="Times New Roman"/>
+        <a:font script="Uigh" typeface="Microsoft Uighur"/>
+        <a:font script="Geor" typeface="Sylfaen"/>
+      </a:majorFont>
+      <a:minorFont>
+        <a:latin typeface="Arial"/>
+        <a:ea typeface=""/>
+        <a:cs typeface=""/>
+        <a:font script="Jpan" typeface="ＭＳ Ｐゴシック"/>
+        <a:font script="Hang" typeface="맑은 고딕"/>
+        <a:font script="Hans" typeface="宋体"/>
+        <a:font script="Hant" typeface="新細明體"/>
+        <a:font script="Arab" typeface="Arial"/>
+        <a:font script="Hebr" typeface="Arial"/>
+        <a:font script="Thai" typeface="Cordia New"/>
+        <a:font script="Ethi" typeface="Nyala"/>
+        <a:font script="Beng" typeface="Vrinda"/>
+        <a:font script="Gujr" typeface="Shruti"/>
+        <a:font script="Khmr" typeface="DaunPenh"/>
+        <a:font script="Knda" typeface="Tunga"/>
+        <a:font script="Guru" typeface="Raavi"/>
+        <a:font script="Cans" typeface="Euphemia"/>
+        <a:font script="Cher" typeface="Plantagenet Cherokee"/>
+        <a:font script="Yiii" typeface="Microsoft Yi Baiti"/>
+        <a:font script="Tibt" typeface="Microsoft Himalaya"/>
+        <a:font script="Thaa" typeface="MV Boli"/>
+        <a:font script="Deva" typeface="Mangal"/>
+        <a:font script="Telu" typeface="Gautami"/>
+        <a:font script="Taml" typeface="Latha"/>
+        <a:font script="Syrc" typeface="Estrangelo Edessa"/>
+        <a:font script="Orya" typeface="Kalinga"/>
+        <a:font script="Mlym" typeface="Kartika"/>
+        <a:font script="Laoo" typeface="DokChampa"/>
+        <a:font script="Sinh" typeface="Iskoola Pota"/>
+        <a:font script="Mong" typeface="Mongolian Baiti"/>
+        <a:font script="Viet" typeface="Arial"/>
+        <a:font script="Uigh" typeface="Microsoft Uighur"/>
+        <a:font script="Geor" typeface="Sylfaen"/>
+      </a:minorFont>
+    </a:fontScheme>
+    <a:fmtScheme name="Office">
+      <a:fillStyleLst>
+        <a:solidFill>
+          <a:schemeClr val="phClr"/>
+        </a:solidFill>
+        <a:gradFill rotWithShape="1">
+          <a:gsLst>
+            <a:gs pos="0">
+              <a:schemeClr val="phClr">
+                <a:tint val="50000"/>
+                <a:satMod val="300000"/>
+              </a:schemeClr>
+            </a:gs>
+            <a:gs pos="35000">
+              <a:schemeClr val="phClr">
+                <a:tint val="37000"/>
+                <a:satMod val="300000"/>
+              </a:schemeClr>
+            </a:gs>
+            <a:gs pos="100000">
+              <a:schemeClr val="phClr">
+                <a:tint val="15000"/>
+                <a:satMod val="350000"/>
+              </a:schemeClr>
+            </a:gs>
+          </a:gsLst>
+          <a:lin ang="16200000" scaled="1"/>
+        </a:gradFill>
+        <a:gradFill rotWithShape="1">
+          <a:gsLst>
+            <a:gs pos="0">
+              <a:schemeClr val="phClr">
+                <a:tint val="100000"/>
+                <a:shade val="100000"/>
+                <a:satMod val="130000"/>
+              </a:schemeClr>
+            </a:gs>
+            <a:gs pos="100000">
+              <a:schemeClr val="phClr">
+                <a:tint val="50000"/>
+                <a:shade val="100000"/>
+                <a:satMod val="350000"/>
+              </a:schemeClr>
+            </a:gs>
+          </a:gsLst>
+          <a:lin ang="16200000" scaled="0"/>
+        </a:gradFill>
+      </a:fillStyleLst>
+      <a:lnStyleLst>
+        <a:ln w="9525" cap="flat" cmpd="sng" algn="ctr">
+          <a:solidFill>
+            <a:schemeClr val="phClr">
+              <a:shade val="95000"/>
+              <a:satMod val="105000"/>
+            </a:schemeClr>
+          </a:solidFill>
+          <a:prstDash val="solid"/>
+        </a:ln>
+        <a:ln w="25400" cap="flat" cmpd="sng" algn="ctr">
+          <a:solidFill>
+            <a:schemeClr val="phClr"/>
+          </a:solidFill>
+          <a:prstDash val="solid"/>
+        </a:ln>
+        <a:ln w="38100" cap="flat" cmpd="sng" algn="ctr">
+          <a:solidFill>
+            <a:schemeClr val="phClr"/>
+          </a:solidFill>
+          <a:prstDash val="solid"/>
+        </a:ln>
+      </a:lnStyleLst>
+      <a:effectStyleLst>
+        <a:effectStyle>
+          <a:effectLst>
+            <a:outerShdw blurRad="40000" dist="20000" dir="5400000" rotWithShape="0">
+              <a:srgbClr val="000000">
+                <a:alpha val="38000"/>
+              </a:srgbClr>
+            </a:outerShdw>
+          </a:effectLst>
+        </a:effectStyle>
+        <a:effectStyle>
+          <a:effectLst>
+            <a:outerShdw blurRad="40000" dist="23000" dir="5400000" rotWithShape="0">
+              <a:srgbClr val="000000">
+                <a:alpha val="35000"/>
+              </a:srgbClr>
+            </a:outerShdw>
+          </a:effectLst>
+        </a:effectStyle>
+        <a:effectStyle>
+          <a:effectLst>
+            <a:outerShdw blurRad="40000" dist="23000" dir="5400000" rotWithShape="0">
+              <a:srgbClr val="000000">
+                <a:alpha val="35000"/>
+              </a:srgbClr>
+            </a:outerShdw>
+          </a:effectLst>
+          <a:scene3d>
+            <a:camera prst="orthographicFront">
+              <a:rot lat="0" lon="0" rev="0"/>
+            </a:camera>
+            <a:lightRig rig="threePt" dir="t">
+              <a:rot lat="0" lon="0" rev="1200000"/>
+            </a:lightRig>
+          </a:scene3d>
+          <a:sp3d>
+            <a:bevelT w="63500" h="25400"/>
+          </a:sp3d>
+        </a:effectStyle>
+      </a:effectStyleLst>
+      <a:bgFillStyleLst>
+        <a:solidFill>
+          <a:schemeClr val="phClr"/>
+        </a:solidFill>
+        <a:gradFill rotWithShape="1">
+          <a:gsLst>
+            <a:gs pos="0">
+              <a:schemeClr val="phClr">
+                <a:tint val="40000"/>
+                <a:satMod val="350000"/>
+              </a:schemeClr>
+            </a:gs>
+            <a:gs pos="40000">
+              <a:schemeClr val="phClr">
+                <a:tint val="45000"/>
+                <a:shade val="99000"/>
+                <a:satMod val="350000"/>
+              </a:schemeClr>
+            </a:gs>
+            <a:gs pos="100000">
+              <a:schemeClr val="phClr">
+                <a:shade val="20000"/>
+                <a:satMod val="255000"/>
+              </a:schemeClr>
+            </a:gs>
+          </a:gsLst>
+          <a:path path="circle">
+            <a:fillToRect l="50000" t="-80000" r="50000" b="180000"/>
+          </a:path>
+        </a:gradFill>
+        <a:gradFill rotWithShape="1">
+          <a:gsLst>
+            <a:gs pos="0">
+              <a:schemeClr val="phClr">
+                <a:tint val="80000"/>
+                <a:satMod val="300000"/>
+              </a:schemeClr>
+            </a:gs>
+            <a:gs pos="100000">
+              <a:schemeClr val="phClr">
+                <a:shade val="30000"/>
+                <a:satMod val="200000"/>
+              </a:schemeClr>
+            </a:gs>
+          </a:gsLst>
+          <a:path path="circle">
+            <a:fillToRect l="50000" t="50000" r="50000" b="50000"/>
+          </a:path>
+        </a:gradFill>
+      </a:bgFillStyleLst>
+    </a:fmtScheme>
+  </a:themeElements>
+</a:theme>
+</file>
+
+<file path=ppt/theme/theme2.xml><?xml version="1.0" encoding="utf-8"?>
 <a:theme xmlns:a="http://schemas.openxmlformats.org/drawingml/2006/main" xmlns:r="http://schemas.openxmlformats.org/officeDocument/2006/relationships">
   <a:themeElements>
     <a:clrScheme name="Default">
@@ -34280,7 +34559,7 @@
 </a:theme>
 </file>
 
-<file path=ppt/theme/theme2.xml><?xml version="1.0" encoding="utf-8"?>
+<file path=ppt/theme/theme3.xml><?xml version="1.0" encoding="utf-8"?>
 <a:theme xmlns:a="http://schemas.openxmlformats.org/drawingml/2006/main" xmlns:r="http://schemas.openxmlformats.org/officeDocument/2006/relationships" name="LF Energy Theme 2023">
   <a:themeElements>
     <a:clrScheme name="Geometric">
@@ -34557,283 +34836,4 @@
     </a:fmtScheme>
   </a:themeElements>
 </a:theme>
-</file>
-
-<file path=ppt/theme/theme3.xml><?xml version="1.0" encoding="utf-8"?>
-<a:theme xmlns:a="http://schemas.openxmlformats.org/drawingml/2006/main" xmlns:r="http://schemas.openxmlformats.org/officeDocument/2006/relationships" name="Simple Light">
-  <a:themeElements>
-    <a:clrScheme name="Simple Light">
-      <a:dk1>
-        <a:srgbClr val="000000"/>
-      </a:dk1>
-      <a:lt1>
-        <a:srgbClr val="FFFFFF"/>
-      </a:lt1>
-      <a:dk2>
-        <a:srgbClr val="595959"/>
-      </a:dk2>
-      <a:lt2>
-        <a:srgbClr val="EEEEEE"/>
-      </a:lt2>
-      <a:accent1>
-        <a:srgbClr val="4285F4"/>
-      </a:accent1>
-      <a:accent2>
-        <a:srgbClr val="212121"/>
-      </a:accent2>
-      <a:accent3>
-        <a:srgbClr val="78909C"/>
-      </a:accent3>
-      <a:accent4>
-        <a:srgbClr val="FFAB40"/>
-      </a:accent4>
-      <a:accent5>
-        <a:srgbClr val="0097A7"/>
-      </a:accent5>
-      <a:accent6>
-        <a:srgbClr val="EEFF41"/>
-      </a:accent6>
-      <a:hlink>
-        <a:srgbClr val="0097A7"/>
-      </a:hlink>
-      <a:folHlink>
-        <a:srgbClr val="0097A7"/>
-      </a:folHlink>
-    </a:clrScheme>
-    <a:fontScheme name="Office">
-      <a:majorFont>
-        <a:latin typeface="Arial"/>
-        <a:ea typeface=""/>
-        <a:cs typeface=""/>
-        <a:font script="Jpan" typeface="ＭＳ Ｐゴシック"/>
-        <a:font script="Hang" typeface="맑은 고딕"/>
-        <a:font script="Hans" typeface="宋体"/>
-        <a:font script="Hant" typeface="新細明體"/>
-        <a:font script="Arab" typeface="Times New Roman"/>
-        <a:font script="Hebr" typeface="Times New Roman"/>
-        <a:font script="Thai" typeface="Angsana New"/>
-        <a:font script="Ethi" typeface="Nyala"/>
-        <a:font script="Beng" typeface="Vrinda"/>
-        <a:font script="Gujr" typeface="Shruti"/>
-        <a:font script="Khmr" typeface="MoolBoran"/>
-        <a:font script="Knda" typeface="Tunga"/>
-        <a:font script="Guru" typeface="Raavi"/>
-        <a:font script="Cans" typeface="Euphemia"/>
-        <a:font script="Cher" typeface="Plantagenet Cherokee"/>
-        <a:font script="Yiii" typeface="Microsoft Yi Baiti"/>
-        <a:font script="Tibt" typeface="Microsoft Himalaya"/>
-        <a:font script="Thaa" typeface="MV Boli"/>
-        <a:font script="Deva" typeface="Mangal"/>
-        <a:font script="Telu" typeface="Gautami"/>
-        <a:font script="Taml" typeface="Latha"/>
-        <a:font script="Syrc" typeface="Estrangelo Edessa"/>
-        <a:font script="Orya" typeface="Kalinga"/>
-        <a:font script="Mlym" typeface="Kartika"/>
-        <a:font script="Laoo" typeface="DokChampa"/>
-        <a:font script="Sinh" typeface="Iskoola Pota"/>
-        <a:font script="Mong" typeface="Mongolian Baiti"/>
-        <a:font script="Viet" typeface="Times New Roman"/>
-        <a:font script="Uigh" typeface="Microsoft Uighur"/>
-        <a:font script="Geor" typeface="Sylfaen"/>
-      </a:majorFont>
-      <a:minorFont>
-        <a:latin typeface="Arial"/>
-        <a:ea typeface=""/>
-        <a:cs typeface=""/>
-        <a:font script="Jpan" typeface="ＭＳ Ｐゴシック"/>
-        <a:font script="Hang" typeface="맑은 고딕"/>
-        <a:font script="Hans" typeface="宋体"/>
-        <a:font script="Hant" typeface="新細明體"/>
-        <a:font script="Arab" typeface="Arial"/>
-        <a:font script="Hebr" typeface="Arial"/>
-        <a:font script="Thai" typeface="Cordia New"/>
-        <a:font script="Ethi" typeface="Nyala"/>
-        <a:font script="Beng" typeface="Vrinda"/>
-        <a:font script="Gujr" typeface="Shruti"/>
-        <a:font script="Khmr" typeface="DaunPenh"/>
-        <a:font script="Knda" typeface="Tunga"/>
-        <a:font script="Guru" typeface="Raavi"/>
-        <a:font script="Cans" typeface="Euphemia"/>
-        <a:font script="Cher" typeface="Plantagenet Cherokee"/>
-        <a:font script="Yiii" typeface="Microsoft Yi Baiti"/>
-        <a:font script="Tibt" typeface="Microsoft Himalaya"/>
-        <a:font script="Thaa" typeface="MV Boli"/>
-        <a:font script="Deva" typeface="Mangal"/>
-        <a:font script="Telu" typeface="Gautami"/>
-        <a:font script="Taml" typeface="Latha"/>
-        <a:font script="Syrc" typeface="Estrangelo Edessa"/>
-        <a:font script="Orya" typeface="Kalinga"/>
-        <a:font script="Mlym" typeface="Kartika"/>
-        <a:font script="Laoo" typeface="DokChampa"/>
-        <a:font script="Sinh" typeface="Iskoola Pota"/>
-        <a:font script="Mong" typeface="Mongolian Baiti"/>
-        <a:font script="Viet" typeface="Arial"/>
-        <a:font script="Uigh" typeface="Microsoft Uighur"/>
-        <a:font script="Geor" typeface="Sylfaen"/>
-      </a:minorFont>
-    </a:fontScheme>
-    <a:fmtScheme name="Office">
-      <a:fillStyleLst>
-        <a:solidFill>
-          <a:schemeClr val="phClr"/>
-        </a:solidFill>
-        <a:gradFill rotWithShape="1">
-          <a:gsLst>
-            <a:gs pos="0">
-              <a:schemeClr val="phClr">
-                <a:tint val="50000"/>
-                <a:satMod val="300000"/>
-              </a:schemeClr>
-            </a:gs>
-            <a:gs pos="35000">
-              <a:schemeClr val="phClr">
-                <a:tint val="37000"/>
-                <a:satMod val="300000"/>
-              </a:schemeClr>
-            </a:gs>
-            <a:gs pos="100000">
-              <a:schemeClr val="phClr">
-                <a:tint val="15000"/>
-                <a:satMod val="350000"/>
-              </a:schemeClr>
-            </a:gs>
-          </a:gsLst>
-          <a:lin ang="16200000" scaled="1"/>
-        </a:gradFill>
-        <a:gradFill rotWithShape="1">
-          <a:gsLst>
-            <a:gs pos="0">
-              <a:schemeClr val="phClr">
-                <a:tint val="100000"/>
-                <a:shade val="100000"/>
-                <a:satMod val="130000"/>
-              </a:schemeClr>
-            </a:gs>
-            <a:gs pos="100000">
-              <a:schemeClr val="phClr">
-                <a:tint val="50000"/>
-                <a:shade val="100000"/>
-                <a:satMod val="350000"/>
-              </a:schemeClr>
-            </a:gs>
-          </a:gsLst>
-          <a:lin ang="16200000" scaled="0"/>
-        </a:gradFill>
-      </a:fillStyleLst>
-      <a:lnStyleLst>
-        <a:ln w="9525" cap="flat" cmpd="sng" algn="ctr">
-          <a:solidFill>
-            <a:schemeClr val="phClr">
-              <a:shade val="95000"/>
-              <a:satMod val="105000"/>
-            </a:schemeClr>
-          </a:solidFill>
-          <a:prstDash val="solid"/>
-        </a:ln>
-        <a:ln w="25400" cap="flat" cmpd="sng" algn="ctr">
-          <a:solidFill>
-            <a:schemeClr val="phClr"/>
-          </a:solidFill>
-          <a:prstDash val="solid"/>
-        </a:ln>
-        <a:ln w="38100" cap="flat" cmpd="sng" algn="ctr">
-          <a:solidFill>
-            <a:schemeClr val="phClr"/>
-          </a:solidFill>
-          <a:prstDash val="solid"/>
-        </a:ln>
-      </a:lnStyleLst>
-      <a:effectStyleLst>
-        <a:effectStyle>
-          <a:effectLst>
-            <a:outerShdw blurRad="40000" dist="20000" dir="5400000" rotWithShape="0">
-              <a:srgbClr val="000000">
-                <a:alpha val="38000"/>
-              </a:srgbClr>
-            </a:outerShdw>
-          </a:effectLst>
-        </a:effectStyle>
-        <a:effectStyle>
-          <a:effectLst>
-            <a:outerShdw blurRad="40000" dist="23000" dir="5400000" rotWithShape="0">
-              <a:srgbClr val="000000">
-                <a:alpha val="35000"/>
-              </a:srgbClr>
-            </a:outerShdw>
-          </a:effectLst>
-        </a:effectStyle>
-        <a:effectStyle>
-          <a:effectLst>
-            <a:outerShdw blurRad="40000" dist="23000" dir="5400000" rotWithShape="0">
-              <a:srgbClr val="000000">
-                <a:alpha val="35000"/>
-              </a:srgbClr>
-            </a:outerShdw>
-          </a:effectLst>
-          <a:scene3d>
-            <a:camera prst="orthographicFront">
-              <a:rot lat="0" lon="0" rev="0"/>
-            </a:camera>
-            <a:lightRig rig="threePt" dir="t">
-              <a:rot lat="0" lon="0" rev="1200000"/>
-            </a:lightRig>
-          </a:scene3d>
-          <a:sp3d>
-            <a:bevelT w="63500" h="25400"/>
-          </a:sp3d>
-        </a:effectStyle>
-      </a:effectStyleLst>
-      <a:bgFillStyleLst>
-        <a:solidFill>
-          <a:schemeClr val="phClr"/>
-        </a:solidFill>
-        <a:gradFill rotWithShape="1">
-          <a:gsLst>
-            <a:gs pos="0">
-              <a:schemeClr val="phClr">
-                <a:tint val="40000"/>
-                <a:satMod val="350000"/>
-              </a:schemeClr>
-            </a:gs>
-            <a:gs pos="40000">
-              <a:schemeClr val="phClr">
-                <a:tint val="45000"/>
-                <a:shade val="99000"/>
-                <a:satMod val="350000"/>
-              </a:schemeClr>
-            </a:gs>
-            <a:gs pos="100000">
-              <a:schemeClr val="phClr">
-                <a:shade val="20000"/>
-                <a:satMod val="255000"/>
-              </a:schemeClr>
-            </a:gs>
-          </a:gsLst>
-          <a:path path="circle">
-            <a:fillToRect l="50000" t="-80000" r="50000" b="180000"/>
-          </a:path>
-        </a:gradFill>
-        <a:gradFill rotWithShape="1">
-          <a:gsLst>
-            <a:gs pos="0">
-              <a:schemeClr val="phClr">
-                <a:tint val="80000"/>
-                <a:satMod val="300000"/>
-              </a:schemeClr>
-            </a:gs>
-            <a:gs pos="100000">
-              <a:schemeClr val="phClr">
-                <a:shade val="30000"/>
-                <a:satMod val="200000"/>
-              </a:schemeClr>
-            </a:gs>
-          </a:gsLst>
-          <a:path path="circle">
-            <a:fillToRect l="50000" t="50000" r="50000" b="50000"/>
-          </a:path>
-        </a:gradFill>
-      </a:bgFillStyleLst>
-    </a:fmtScheme>
-  </a:themeElements>
-</a:theme>
 </file>
</xml_diff>

<commit_message>
Update Data Sources from LFX 2026-09-19 (#313)
Update Data Sources from LFX

Signed-off-by: github-actions[bot] <41898282+github-actions[bot]@users.noreply.github.com>
</commit_message>
<xml_diff>
--- a/overview_deck/LF Energy High Level Overview.pptx
+++ b/overview_deck/LF Energy High Level Overview.pptx
@@ -25946,7 +25946,7 @@
             <a:tbl>
               <a:tblPr>
                 <a:noFill/>
-                <a:tableStyleId>{6F6BE797-40FF-4D52-908A-4F3C3C9624B6}</a:tableStyleId>
+                <a:tableStyleId>{9AB85FE2-414F-4E84-8712-44C0ECBA2227}</a:tableStyleId>
               </a:tblPr>
               <a:tblGrid>
                 <a:gridCol w="1695200"/>
@@ -26736,7 +26736,7 @@
             <a:tbl>
               <a:tblPr>
                 <a:noFill/>
-                <a:tableStyleId>{6F6BE797-40FF-4D52-908A-4F3C3C9624B6}</a:tableStyleId>
+                <a:tableStyleId>{9AB85FE2-414F-4E84-8712-44C0ECBA2227}</a:tableStyleId>
               </a:tblPr>
               <a:tblGrid>
                 <a:gridCol w="1695200"/>
@@ -27426,7 +27426,7 @@
             <a:tbl>
               <a:tblPr>
                 <a:noFill/>
-                <a:tableStyleId>{6F6BE797-40FF-4D52-908A-4F3C3C9624B6}</a:tableStyleId>
+                <a:tableStyleId>{9AB85FE2-414F-4E84-8712-44C0ECBA2227}</a:tableStyleId>
               </a:tblPr>
               <a:tblGrid>
                 <a:gridCol w="1695200"/>
@@ -28678,7 +28678,7 @@
             <a:tbl>
               <a:tblPr>
                 <a:noFill/>
-                <a:tableStyleId>{6F6BE797-40FF-4D52-908A-4F3C3C9624B6}</a:tableStyleId>
+                <a:tableStyleId>{9AB85FE2-414F-4E84-8712-44C0ECBA2227}</a:tableStyleId>
               </a:tblPr>
               <a:tblGrid>
                 <a:gridCol w="1695200"/>
@@ -29670,7 +29670,7 @@
             <a:tbl>
               <a:tblPr>
                 <a:noFill/>
-                <a:tableStyleId>{6F6BE797-40FF-4D52-908A-4F3C3C9624B6}</a:tableStyleId>
+                <a:tableStyleId>{9AB85FE2-414F-4E84-8712-44C0ECBA2227}</a:tableStyleId>
               </a:tblPr>
               <a:tblGrid>
                 <a:gridCol w="3048000"/>
@@ -33175,7 +33175,7 @@
             <a:tbl>
               <a:tblPr>
                 <a:noFill/>
-                <a:tableStyleId>{6F6BE797-40FF-4D52-908A-4F3C3C9624B6}</a:tableStyleId>
+                <a:tableStyleId>{9AB85FE2-414F-4E84-8712-44C0ECBA2227}</a:tableStyleId>
               </a:tblPr>
               <a:tblGrid>
                 <a:gridCol w="1828800"/>
@@ -34002,9 +34002,9 @@
 </file>
 
 <file path=ppt/theme/theme1.xml><?xml version="1.0" encoding="utf-8"?>
-<a:theme xmlns:a="http://schemas.openxmlformats.org/drawingml/2006/main" xmlns:r="http://schemas.openxmlformats.org/officeDocument/2006/relationships" name="Simple Light">
+<a:theme xmlns:a="http://schemas.openxmlformats.org/drawingml/2006/main" xmlns:r="http://schemas.openxmlformats.org/officeDocument/2006/relationships">
   <a:themeElements>
-    <a:clrScheme name="Simple Light">
+    <a:clrScheme name="Default">
       <a:dk1>
         <a:srgbClr val="000000"/>
       </a:dk1>
@@ -34012,34 +34012,34 @@
         <a:srgbClr val="FFFFFF"/>
       </a:lt1>
       <a:dk2>
-        <a:srgbClr val="595959"/>
+        <a:srgbClr val="158158"/>
       </a:dk2>
       <a:lt2>
-        <a:srgbClr val="EEEEEE"/>
+        <a:srgbClr val="F3F3F3"/>
       </a:lt2>
       <a:accent1>
-        <a:srgbClr val="4285F4"/>
+        <a:srgbClr val="058DC7"/>
       </a:accent1>
       <a:accent2>
-        <a:srgbClr val="212121"/>
+        <a:srgbClr val="50B432"/>
       </a:accent2>
       <a:accent3>
-        <a:srgbClr val="78909C"/>
+        <a:srgbClr val="ED561B"/>
       </a:accent3>
       <a:accent4>
-        <a:srgbClr val="FFAB40"/>
+        <a:srgbClr val="EDEF00"/>
       </a:accent4>
       <a:accent5>
-        <a:srgbClr val="0097A7"/>
+        <a:srgbClr val="24CBE5"/>
       </a:accent5>
       <a:accent6>
-        <a:srgbClr val="EEFF41"/>
+        <a:srgbClr val="64E572"/>
       </a:accent6>
       <a:hlink>
-        <a:srgbClr val="0097A7"/>
+        <a:srgbClr val="2200CC"/>
       </a:hlink>
       <a:folHlink>
-        <a:srgbClr val="0097A7"/>
+        <a:srgbClr val="551A8B"/>
       </a:folHlink>
     </a:clrScheme>
     <a:fontScheme name="Office">
@@ -34281,9 +34281,9 @@
 </file>
 
 <file path=ppt/theme/theme2.xml><?xml version="1.0" encoding="utf-8"?>
-<a:theme xmlns:a="http://schemas.openxmlformats.org/drawingml/2006/main" xmlns:r="http://schemas.openxmlformats.org/officeDocument/2006/relationships">
+<a:theme xmlns:a="http://schemas.openxmlformats.org/drawingml/2006/main" xmlns:r="http://schemas.openxmlformats.org/officeDocument/2006/relationships" name="Simple Light">
   <a:themeElements>
-    <a:clrScheme name="Default">
+    <a:clrScheme name="Simple Light">
       <a:dk1>
         <a:srgbClr val="000000"/>
       </a:dk1>
@@ -34291,34 +34291,34 @@
         <a:srgbClr val="FFFFFF"/>
       </a:lt1>
       <a:dk2>
-        <a:srgbClr val="158158"/>
+        <a:srgbClr val="595959"/>
       </a:dk2>
       <a:lt2>
-        <a:srgbClr val="F3F3F3"/>
+        <a:srgbClr val="EEEEEE"/>
       </a:lt2>
       <a:accent1>
-        <a:srgbClr val="058DC7"/>
+        <a:srgbClr val="4285F4"/>
       </a:accent1>
       <a:accent2>
-        <a:srgbClr val="50B432"/>
+        <a:srgbClr val="212121"/>
       </a:accent2>
       <a:accent3>
-        <a:srgbClr val="ED561B"/>
+        <a:srgbClr val="78909C"/>
       </a:accent3>
       <a:accent4>
-        <a:srgbClr val="EDEF00"/>
+        <a:srgbClr val="FFAB40"/>
       </a:accent4>
       <a:accent5>
-        <a:srgbClr val="24CBE5"/>
+        <a:srgbClr val="0097A7"/>
       </a:accent5>
       <a:accent6>
-        <a:srgbClr val="64E572"/>
+        <a:srgbClr val="EEFF41"/>
       </a:accent6>
       <a:hlink>
-        <a:srgbClr val="2200CC"/>
+        <a:srgbClr val="0097A7"/>
       </a:hlink>
       <a:folHlink>
-        <a:srgbClr val="551A8B"/>
+        <a:srgbClr val="0097A7"/>
       </a:folHlink>
     </a:clrScheme>
     <a:fontScheme name="Office">

</xml_diff>

<commit_message>
Update Data Sources from LFX 2026-09-20 (#314)
Update Data Sources from LFX

Signed-off-by: github-actions[bot] <41898282+github-actions[bot]@users.noreply.github.com>
</commit_message>
<xml_diff>
--- a/overview_deck/LF Energy High Level Overview.pptx
+++ b/overview_deck/LF Energy High Level Overview.pptx
@@ -25946,7 +25946,7 @@
             <a:tbl>
               <a:tblPr>
                 <a:noFill/>
-                <a:tableStyleId>{9AB85FE2-414F-4E84-8712-44C0ECBA2227}</a:tableStyleId>
+                <a:tableStyleId>{9FB09A23-FCEA-4C31-B3F2-6E79EF3182D4}</a:tableStyleId>
               </a:tblPr>
               <a:tblGrid>
                 <a:gridCol w="1695200"/>
@@ -26736,7 +26736,7 @@
             <a:tbl>
               <a:tblPr>
                 <a:noFill/>
-                <a:tableStyleId>{9AB85FE2-414F-4E84-8712-44C0ECBA2227}</a:tableStyleId>
+                <a:tableStyleId>{9FB09A23-FCEA-4C31-B3F2-6E79EF3182D4}</a:tableStyleId>
               </a:tblPr>
               <a:tblGrid>
                 <a:gridCol w="1695200"/>
@@ -27426,7 +27426,7 @@
             <a:tbl>
               <a:tblPr>
                 <a:noFill/>
-                <a:tableStyleId>{9AB85FE2-414F-4E84-8712-44C0ECBA2227}</a:tableStyleId>
+                <a:tableStyleId>{9FB09A23-FCEA-4C31-B3F2-6E79EF3182D4}</a:tableStyleId>
               </a:tblPr>
               <a:tblGrid>
                 <a:gridCol w="1695200"/>
@@ -28678,7 +28678,7 @@
             <a:tbl>
               <a:tblPr>
                 <a:noFill/>
-                <a:tableStyleId>{9AB85FE2-414F-4E84-8712-44C0ECBA2227}</a:tableStyleId>
+                <a:tableStyleId>{9FB09A23-FCEA-4C31-B3F2-6E79EF3182D4}</a:tableStyleId>
               </a:tblPr>
               <a:tblGrid>
                 <a:gridCol w="1695200"/>
@@ -29670,7 +29670,7 @@
             <a:tbl>
               <a:tblPr>
                 <a:noFill/>
-                <a:tableStyleId>{9AB85FE2-414F-4E84-8712-44C0ECBA2227}</a:tableStyleId>
+                <a:tableStyleId>{9FB09A23-FCEA-4C31-B3F2-6E79EF3182D4}</a:tableStyleId>
               </a:tblPr>
               <a:tblGrid>
                 <a:gridCol w="3048000"/>
@@ -33175,7 +33175,7 @@
             <a:tbl>
               <a:tblPr>
                 <a:noFill/>
-                <a:tableStyleId>{9AB85FE2-414F-4E84-8712-44C0ECBA2227}</a:tableStyleId>
+                <a:tableStyleId>{9FB09A23-FCEA-4C31-B3F2-6E79EF3182D4}</a:tableStyleId>
               </a:tblPr>
               <a:tblGrid>
                 <a:gridCol w="1828800"/>
@@ -34002,285 +34002,6 @@
 </file>
 
 <file path=ppt/theme/theme1.xml><?xml version="1.0" encoding="utf-8"?>
-<a:theme xmlns:a="http://schemas.openxmlformats.org/drawingml/2006/main" xmlns:r="http://schemas.openxmlformats.org/officeDocument/2006/relationships">
-  <a:themeElements>
-    <a:clrScheme name="Default">
-      <a:dk1>
-        <a:srgbClr val="000000"/>
-      </a:dk1>
-      <a:lt1>
-        <a:srgbClr val="FFFFFF"/>
-      </a:lt1>
-      <a:dk2>
-        <a:srgbClr val="158158"/>
-      </a:dk2>
-      <a:lt2>
-        <a:srgbClr val="F3F3F3"/>
-      </a:lt2>
-      <a:accent1>
-        <a:srgbClr val="058DC7"/>
-      </a:accent1>
-      <a:accent2>
-        <a:srgbClr val="50B432"/>
-      </a:accent2>
-      <a:accent3>
-        <a:srgbClr val="ED561B"/>
-      </a:accent3>
-      <a:accent4>
-        <a:srgbClr val="EDEF00"/>
-      </a:accent4>
-      <a:accent5>
-        <a:srgbClr val="24CBE5"/>
-      </a:accent5>
-      <a:accent6>
-        <a:srgbClr val="64E572"/>
-      </a:accent6>
-      <a:hlink>
-        <a:srgbClr val="2200CC"/>
-      </a:hlink>
-      <a:folHlink>
-        <a:srgbClr val="551A8B"/>
-      </a:folHlink>
-    </a:clrScheme>
-    <a:fontScheme name="Office">
-      <a:majorFont>
-        <a:latin typeface="Arial"/>
-        <a:ea typeface=""/>
-        <a:cs typeface=""/>
-        <a:font script="Jpan" typeface="ＭＳ Ｐゴシック"/>
-        <a:font script="Hang" typeface="맑은 고딕"/>
-        <a:font script="Hans" typeface="宋体"/>
-        <a:font script="Hant" typeface="新細明體"/>
-        <a:font script="Arab" typeface="Times New Roman"/>
-        <a:font script="Hebr" typeface="Times New Roman"/>
-        <a:font script="Thai" typeface="Angsana New"/>
-        <a:font script="Ethi" typeface="Nyala"/>
-        <a:font script="Beng" typeface="Vrinda"/>
-        <a:font script="Gujr" typeface="Shruti"/>
-        <a:font script="Khmr" typeface="MoolBoran"/>
-        <a:font script="Knda" typeface="Tunga"/>
-        <a:font script="Guru" typeface="Raavi"/>
-        <a:font script="Cans" typeface="Euphemia"/>
-        <a:font script="Cher" typeface="Plantagenet Cherokee"/>
-        <a:font script="Yiii" typeface="Microsoft Yi Baiti"/>
-        <a:font script="Tibt" typeface="Microsoft Himalaya"/>
-        <a:font script="Thaa" typeface="MV Boli"/>
-        <a:font script="Deva" typeface="Mangal"/>
-        <a:font script="Telu" typeface="Gautami"/>
-        <a:font script="Taml" typeface="Latha"/>
-        <a:font script="Syrc" typeface="Estrangelo Edessa"/>
-        <a:font script="Orya" typeface="Kalinga"/>
-        <a:font script="Mlym" typeface="Kartika"/>
-        <a:font script="Laoo" typeface="DokChampa"/>
-        <a:font script="Sinh" typeface="Iskoola Pota"/>
-        <a:font script="Mong" typeface="Mongolian Baiti"/>
-        <a:font script="Viet" typeface="Times New Roman"/>
-        <a:font script="Uigh" typeface="Microsoft Uighur"/>
-        <a:font script="Geor" typeface="Sylfaen"/>
-      </a:majorFont>
-      <a:minorFont>
-        <a:latin typeface="Arial"/>
-        <a:ea typeface=""/>
-        <a:cs typeface=""/>
-        <a:font script="Jpan" typeface="ＭＳ Ｐゴシック"/>
-        <a:font script="Hang" typeface="맑은 고딕"/>
-        <a:font script="Hans" typeface="宋体"/>
-        <a:font script="Hant" typeface="新細明體"/>
-        <a:font script="Arab" typeface="Arial"/>
-        <a:font script="Hebr" typeface="Arial"/>
-        <a:font script="Thai" typeface="Cordia New"/>
-        <a:font script="Ethi" typeface="Nyala"/>
-        <a:font script="Beng" typeface="Vrinda"/>
-        <a:font script="Gujr" typeface="Shruti"/>
-        <a:font script="Khmr" typeface="DaunPenh"/>
-        <a:font script="Knda" typeface="Tunga"/>
-        <a:font script="Guru" typeface="Raavi"/>
-        <a:font script="Cans" typeface="Euphemia"/>
-        <a:font script="Cher" typeface="Plantagenet Cherokee"/>
-        <a:font script="Yiii" typeface="Microsoft Yi Baiti"/>
-        <a:font script="Tibt" typeface="Microsoft Himalaya"/>
-        <a:font script="Thaa" typeface="MV Boli"/>
-        <a:font script="Deva" typeface="Mangal"/>
-        <a:font script="Telu" typeface="Gautami"/>
-        <a:font script="Taml" typeface="Latha"/>
-        <a:font script="Syrc" typeface="Estrangelo Edessa"/>
-        <a:font script="Orya" typeface="Kalinga"/>
-        <a:font script="Mlym" typeface="Kartika"/>
-        <a:font script="Laoo" typeface="DokChampa"/>
-        <a:font script="Sinh" typeface="Iskoola Pota"/>
-        <a:font script="Mong" typeface="Mongolian Baiti"/>
-        <a:font script="Viet" typeface="Arial"/>
-        <a:font script="Uigh" typeface="Microsoft Uighur"/>
-        <a:font script="Geor" typeface="Sylfaen"/>
-      </a:minorFont>
-    </a:fontScheme>
-    <a:fmtScheme name="Office">
-      <a:fillStyleLst>
-        <a:solidFill>
-          <a:schemeClr val="phClr"/>
-        </a:solidFill>
-        <a:gradFill rotWithShape="1">
-          <a:gsLst>
-            <a:gs pos="0">
-              <a:schemeClr val="phClr">
-                <a:tint val="50000"/>
-                <a:satMod val="300000"/>
-              </a:schemeClr>
-            </a:gs>
-            <a:gs pos="35000">
-              <a:schemeClr val="phClr">
-                <a:tint val="37000"/>
-                <a:satMod val="300000"/>
-              </a:schemeClr>
-            </a:gs>
-            <a:gs pos="100000">
-              <a:schemeClr val="phClr">
-                <a:tint val="15000"/>
-                <a:satMod val="350000"/>
-              </a:schemeClr>
-            </a:gs>
-          </a:gsLst>
-          <a:lin ang="16200000" scaled="1"/>
-        </a:gradFill>
-        <a:gradFill rotWithShape="1">
-          <a:gsLst>
-            <a:gs pos="0">
-              <a:schemeClr val="phClr">
-                <a:tint val="100000"/>
-                <a:shade val="100000"/>
-                <a:satMod val="130000"/>
-              </a:schemeClr>
-            </a:gs>
-            <a:gs pos="100000">
-              <a:schemeClr val="phClr">
-                <a:tint val="50000"/>
-                <a:shade val="100000"/>
-                <a:satMod val="350000"/>
-              </a:schemeClr>
-            </a:gs>
-          </a:gsLst>
-          <a:lin ang="16200000" scaled="0"/>
-        </a:gradFill>
-      </a:fillStyleLst>
-      <a:lnStyleLst>
-        <a:ln w="9525" cap="flat" cmpd="sng" algn="ctr">
-          <a:solidFill>
-            <a:schemeClr val="phClr">
-              <a:shade val="95000"/>
-              <a:satMod val="105000"/>
-            </a:schemeClr>
-          </a:solidFill>
-          <a:prstDash val="solid"/>
-        </a:ln>
-        <a:ln w="25400" cap="flat" cmpd="sng" algn="ctr">
-          <a:solidFill>
-            <a:schemeClr val="phClr"/>
-          </a:solidFill>
-          <a:prstDash val="solid"/>
-        </a:ln>
-        <a:ln w="38100" cap="flat" cmpd="sng" algn="ctr">
-          <a:solidFill>
-            <a:schemeClr val="phClr"/>
-          </a:solidFill>
-          <a:prstDash val="solid"/>
-        </a:ln>
-      </a:lnStyleLst>
-      <a:effectStyleLst>
-        <a:effectStyle>
-          <a:effectLst>
-            <a:outerShdw blurRad="40000" dist="20000" dir="5400000" rotWithShape="0">
-              <a:srgbClr val="000000">
-                <a:alpha val="38000"/>
-              </a:srgbClr>
-            </a:outerShdw>
-          </a:effectLst>
-        </a:effectStyle>
-        <a:effectStyle>
-          <a:effectLst>
-            <a:outerShdw blurRad="40000" dist="23000" dir="5400000" rotWithShape="0">
-              <a:srgbClr val="000000">
-                <a:alpha val="35000"/>
-              </a:srgbClr>
-            </a:outerShdw>
-          </a:effectLst>
-        </a:effectStyle>
-        <a:effectStyle>
-          <a:effectLst>
-            <a:outerShdw blurRad="40000" dist="23000" dir="5400000" rotWithShape="0">
-              <a:srgbClr val="000000">
-                <a:alpha val="35000"/>
-              </a:srgbClr>
-            </a:outerShdw>
-          </a:effectLst>
-          <a:scene3d>
-            <a:camera prst="orthographicFront">
-              <a:rot lat="0" lon="0" rev="0"/>
-            </a:camera>
-            <a:lightRig rig="threePt" dir="t">
-              <a:rot lat="0" lon="0" rev="1200000"/>
-            </a:lightRig>
-          </a:scene3d>
-          <a:sp3d>
-            <a:bevelT w="63500" h="25400"/>
-          </a:sp3d>
-        </a:effectStyle>
-      </a:effectStyleLst>
-      <a:bgFillStyleLst>
-        <a:solidFill>
-          <a:schemeClr val="phClr"/>
-        </a:solidFill>
-        <a:gradFill rotWithShape="1">
-          <a:gsLst>
-            <a:gs pos="0">
-              <a:schemeClr val="phClr">
-                <a:tint val="40000"/>
-                <a:satMod val="350000"/>
-              </a:schemeClr>
-            </a:gs>
-            <a:gs pos="40000">
-              <a:schemeClr val="phClr">
-                <a:tint val="45000"/>
-                <a:shade val="99000"/>
-                <a:satMod val="350000"/>
-              </a:schemeClr>
-            </a:gs>
-            <a:gs pos="100000">
-              <a:schemeClr val="phClr">
-                <a:shade val="20000"/>
-                <a:satMod val="255000"/>
-              </a:schemeClr>
-            </a:gs>
-          </a:gsLst>
-          <a:path path="circle">
-            <a:fillToRect l="50000" t="-80000" r="50000" b="180000"/>
-          </a:path>
-        </a:gradFill>
-        <a:gradFill rotWithShape="1">
-          <a:gsLst>
-            <a:gs pos="0">
-              <a:schemeClr val="phClr">
-                <a:tint val="80000"/>
-                <a:satMod val="300000"/>
-              </a:schemeClr>
-            </a:gs>
-            <a:gs pos="100000">
-              <a:schemeClr val="phClr">
-                <a:shade val="30000"/>
-                <a:satMod val="200000"/>
-              </a:schemeClr>
-            </a:gs>
-          </a:gsLst>
-          <a:path path="circle">
-            <a:fillToRect l="50000" t="50000" r="50000" b="50000"/>
-          </a:path>
-        </a:gradFill>
-      </a:bgFillStyleLst>
-    </a:fmtScheme>
-  </a:themeElements>
-</a:theme>
-</file>
-
-<file path=ppt/theme/theme2.xml><?xml version="1.0" encoding="utf-8"?>
 <a:theme xmlns:a="http://schemas.openxmlformats.org/drawingml/2006/main" xmlns:r="http://schemas.openxmlformats.org/officeDocument/2006/relationships" name="Simple Light">
   <a:themeElements>
     <a:clrScheme name="Simple Light">
@@ -34559,7 +34280,7 @@
 </a:theme>
 </file>
 
-<file path=ppt/theme/theme3.xml><?xml version="1.0" encoding="utf-8"?>
+<file path=ppt/theme/theme2.xml><?xml version="1.0" encoding="utf-8"?>
 <a:theme xmlns:a="http://schemas.openxmlformats.org/drawingml/2006/main" xmlns:r="http://schemas.openxmlformats.org/officeDocument/2006/relationships" name="LF Energy Theme 2023">
   <a:themeElements>
     <a:clrScheme name="Geometric">
@@ -34836,4 +34557,283 @@
     </a:fmtScheme>
   </a:themeElements>
 </a:theme>
+</file>
+
+<file path=ppt/theme/theme3.xml><?xml version="1.0" encoding="utf-8"?>
+<a:theme xmlns:a="http://schemas.openxmlformats.org/drawingml/2006/main" xmlns:r="http://schemas.openxmlformats.org/officeDocument/2006/relationships">
+  <a:themeElements>
+    <a:clrScheme name="Default">
+      <a:dk1>
+        <a:srgbClr val="000000"/>
+      </a:dk1>
+      <a:lt1>
+        <a:srgbClr val="FFFFFF"/>
+      </a:lt1>
+      <a:dk2>
+        <a:srgbClr val="158158"/>
+      </a:dk2>
+      <a:lt2>
+        <a:srgbClr val="F3F3F3"/>
+      </a:lt2>
+      <a:accent1>
+        <a:srgbClr val="058DC7"/>
+      </a:accent1>
+      <a:accent2>
+        <a:srgbClr val="50B432"/>
+      </a:accent2>
+      <a:accent3>
+        <a:srgbClr val="ED561B"/>
+      </a:accent3>
+      <a:accent4>
+        <a:srgbClr val="EDEF00"/>
+      </a:accent4>
+      <a:accent5>
+        <a:srgbClr val="24CBE5"/>
+      </a:accent5>
+      <a:accent6>
+        <a:srgbClr val="64E572"/>
+      </a:accent6>
+      <a:hlink>
+        <a:srgbClr val="2200CC"/>
+      </a:hlink>
+      <a:folHlink>
+        <a:srgbClr val="551A8B"/>
+      </a:folHlink>
+    </a:clrScheme>
+    <a:fontScheme name="Office">
+      <a:majorFont>
+        <a:latin typeface="Arial"/>
+        <a:ea typeface=""/>
+        <a:cs typeface=""/>
+        <a:font script="Jpan" typeface="ＭＳ Ｐゴシック"/>
+        <a:font script="Hang" typeface="맑은 고딕"/>
+        <a:font script="Hans" typeface="宋体"/>
+        <a:font script="Hant" typeface="新細明體"/>
+        <a:font script="Arab" typeface="Times New Roman"/>
+        <a:font script="Hebr" typeface="Times New Roman"/>
+        <a:font script="Thai" typeface="Angsana New"/>
+        <a:font script="Ethi" typeface="Nyala"/>
+        <a:font script="Beng" typeface="Vrinda"/>
+        <a:font script="Gujr" typeface="Shruti"/>
+        <a:font script="Khmr" typeface="MoolBoran"/>
+        <a:font script="Knda" typeface="Tunga"/>
+        <a:font script="Guru" typeface="Raavi"/>
+        <a:font script="Cans" typeface="Euphemia"/>
+        <a:font script="Cher" typeface="Plantagenet Cherokee"/>
+        <a:font script="Yiii" typeface="Microsoft Yi Baiti"/>
+        <a:font script="Tibt" typeface="Microsoft Himalaya"/>
+        <a:font script="Thaa" typeface="MV Boli"/>
+        <a:font script="Deva" typeface="Mangal"/>
+        <a:font script="Telu" typeface="Gautami"/>
+        <a:font script="Taml" typeface="Latha"/>
+        <a:font script="Syrc" typeface="Estrangelo Edessa"/>
+        <a:font script="Orya" typeface="Kalinga"/>
+        <a:font script="Mlym" typeface="Kartika"/>
+        <a:font script="Laoo" typeface="DokChampa"/>
+        <a:font script="Sinh" typeface="Iskoola Pota"/>
+        <a:font script="Mong" typeface="Mongolian Baiti"/>
+        <a:font script="Viet" typeface="Times New Roman"/>
+        <a:font script="Uigh" typeface="Microsoft Uighur"/>
+        <a:font script="Geor" typeface="Sylfaen"/>
+      </a:majorFont>
+      <a:minorFont>
+        <a:latin typeface="Arial"/>
+        <a:ea typeface=""/>
+        <a:cs typeface=""/>
+        <a:font script="Jpan" typeface="ＭＳ Ｐゴシック"/>
+        <a:font script="Hang" typeface="맑은 고딕"/>
+        <a:font script="Hans" typeface="宋体"/>
+        <a:font script="Hant" typeface="新細明體"/>
+        <a:font script="Arab" typeface="Arial"/>
+        <a:font script="Hebr" typeface="Arial"/>
+        <a:font script="Thai" typeface="Cordia New"/>
+        <a:font script="Ethi" typeface="Nyala"/>
+        <a:font script="Beng" typeface="Vrinda"/>
+        <a:font script="Gujr" typeface="Shruti"/>
+        <a:font script="Khmr" typeface="DaunPenh"/>
+        <a:font script="Knda" typeface="Tunga"/>
+        <a:font script="Guru" typeface="Raavi"/>
+        <a:font script="Cans" typeface="Euphemia"/>
+        <a:font script="Cher" typeface="Plantagenet Cherokee"/>
+        <a:font script="Yiii" typeface="Microsoft Yi Baiti"/>
+        <a:font script="Tibt" typeface="Microsoft Himalaya"/>
+        <a:font script="Thaa" typeface="MV Boli"/>
+        <a:font script="Deva" typeface="Mangal"/>
+        <a:font script="Telu" typeface="Gautami"/>
+        <a:font script="Taml" typeface="Latha"/>
+        <a:font script="Syrc" typeface="Estrangelo Edessa"/>
+        <a:font script="Orya" typeface="Kalinga"/>
+        <a:font script="Mlym" typeface="Kartika"/>
+        <a:font script="Laoo" typeface="DokChampa"/>
+        <a:font script="Sinh" typeface="Iskoola Pota"/>
+        <a:font script="Mong" typeface="Mongolian Baiti"/>
+        <a:font script="Viet" typeface="Arial"/>
+        <a:font script="Uigh" typeface="Microsoft Uighur"/>
+        <a:font script="Geor" typeface="Sylfaen"/>
+      </a:minorFont>
+    </a:fontScheme>
+    <a:fmtScheme name="Office">
+      <a:fillStyleLst>
+        <a:solidFill>
+          <a:schemeClr val="phClr"/>
+        </a:solidFill>
+        <a:gradFill rotWithShape="1">
+          <a:gsLst>
+            <a:gs pos="0">
+              <a:schemeClr val="phClr">
+                <a:tint val="50000"/>
+                <a:satMod val="300000"/>
+              </a:schemeClr>
+            </a:gs>
+            <a:gs pos="35000">
+              <a:schemeClr val="phClr">
+                <a:tint val="37000"/>
+                <a:satMod val="300000"/>
+              </a:schemeClr>
+            </a:gs>
+            <a:gs pos="100000">
+              <a:schemeClr val="phClr">
+                <a:tint val="15000"/>
+                <a:satMod val="350000"/>
+              </a:schemeClr>
+            </a:gs>
+          </a:gsLst>
+          <a:lin ang="16200000" scaled="1"/>
+        </a:gradFill>
+        <a:gradFill rotWithShape="1">
+          <a:gsLst>
+            <a:gs pos="0">
+              <a:schemeClr val="phClr">
+                <a:tint val="100000"/>
+                <a:shade val="100000"/>
+                <a:satMod val="130000"/>
+              </a:schemeClr>
+            </a:gs>
+            <a:gs pos="100000">
+              <a:schemeClr val="phClr">
+                <a:tint val="50000"/>
+                <a:shade val="100000"/>
+                <a:satMod val="350000"/>
+              </a:schemeClr>
+            </a:gs>
+          </a:gsLst>
+          <a:lin ang="16200000" scaled="0"/>
+        </a:gradFill>
+      </a:fillStyleLst>
+      <a:lnStyleLst>
+        <a:ln w="9525" cap="flat" cmpd="sng" algn="ctr">
+          <a:solidFill>
+            <a:schemeClr val="phClr">
+              <a:shade val="95000"/>
+              <a:satMod val="105000"/>
+            </a:schemeClr>
+          </a:solidFill>
+          <a:prstDash val="solid"/>
+        </a:ln>
+        <a:ln w="25400" cap="flat" cmpd="sng" algn="ctr">
+          <a:solidFill>
+            <a:schemeClr val="phClr"/>
+          </a:solidFill>
+          <a:prstDash val="solid"/>
+        </a:ln>
+        <a:ln w="38100" cap="flat" cmpd="sng" algn="ctr">
+          <a:solidFill>
+            <a:schemeClr val="phClr"/>
+          </a:solidFill>
+          <a:prstDash val="solid"/>
+        </a:ln>
+      </a:lnStyleLst>
+      <a:effectStyleLst>
+        <a:effectStyle>
+          <a:effectLst>
+            <a:outerShdw blurRad="40000" dist="20000" dir="5400000" rotWithShape="0">
+              <a:srgbClr val="000000">
+                <a:alpha val="38000"/>
+              </a:srgbClr>
+            </a:outerShdw>
+          </a:effectLst>
+        </a:effectStyle>
+        <a:effectStyle>
+          <a:effectLst>
+            <a:outerShdw blurRad="40000" dist="23000" dir="5400000" rotWithShape="0">
+              <a:srgbClr val="000000">
+                <a:alpha val="35000"/>
+              </a:srgbClr>
+            </a:outerShdw>
+          </a:effectLst>
+        </a:effectStyle>
+        <a:effectStyle>
+          <a:effectLst>
+            <a:outerShdw blurRad="40000" dist="23000" dir="5400000" rotWithShape="0">
+              <a:srgbClr val="000000">
+                <a:alpha val="35000"/>
+              </a:srgbClr>
+            </a:outerShdw>
+          </a:effectLst>
+          <a:scene3d>
+            <a:camera prst="orthographicFront">
+              <a:rot lat="0" lon="0" rev="0"/>
+            </a:camera>
+            <a:lightRig rig="threePt" dir="t">
+              <a:rot lat="0" lon="0" rev="1200000"/>
+            </a:lightRig>
+          </a:scene3d>
+          <a:sp3d>
+            <a:bevelT w="63500" h="25400"/>
+          </a:sp3d>
+        </a:effectStyle>
+      </a:effectStyleLst>
+      <a:bgFillStyleLst>
+        <a:solidFill>
+          <a:schemeClr val="phClr"/>
+        </a:solidFill>
+        <a:gradFill rotWithShape="1">
+          <a:gsLst>
+            <a:gs pos="0">
+              <a:schemeClr val="phClr">
+                <a:tint val="40000"/>
+                <a:satMod val="350000"/>
+              </a:schemeClr>
+            </a:gs>
+            <a:gs pos="40000">
+              <a:schemeClr val="phClr">
+                <a:tint val="45000"/>
+                <a:shade val="99000"/>
+                <a:satMod val="350000"/>
+              </a:schemeClr>
+            </a:gs>
+            <a:gs pos="100000">
+              <a:schemeClr val="phClr">
+                <a:shade val="20000"/>
+                <a:satMod val="255000"/>
+              </a:schemeClr>
+            </a:gs>
+          </a:gsLst>
+          <a:path path="circle">
+            <a:fillToRect l="50000" t="-80000" r="50000" b="180000"/>
+          </a:path>
+        </a:gradFill>
+        <a:gradFill rotWithShape="1">
+          <a:gsLst>
+            <a:gs pos="0">
+              <a:schemeClr val="phClr">
+                <a:tint val="80000"/>
+                <a:satMod val="300000"/>
+              </a:schemeClr>
+            </a:gs>
+            <a:gs pos="100000">
+              <a:schemeClr val="phClr">
+                <a:shade val="30000"/>
+                <a:satMod val="200000"/>
+              </a:schemeClr>
+            </a:gs>
+          </a:gsLst>
+          <a:path path="circle">
+            <a:fillToRect l="50000" t="50000" r="50000" b="50000"/>
+          </a:path>
+        </a:gradFill>
+      </a:bgFillStyleLst>
+    </a:fmtScheme>
+  </a:themeElements>
+</a:theme>
 </file>
</xml_diff>

<commit_message>
Update Data Sources from LFX 2026-09-21 (#315)
Update Data Sources from LFX

Signed-off-by: github-actions[bot] <41898282+github-actions[bot]@users.noreply.github.com>
</commit_message>
<xml_diff>
--- a/overview_deck/LF Energy High Level Overview.pptx
+++ b/overview_deck/LF Energy High Level Overview.pptx
@@ -25946,7 +25946,7 @@
             <a:tbl>
               <a:tblPr>
                 <a:noFill/>
-                <a:tableStyleId>{9FB09A23-FCEA-4C31-B3F2-6E79EF3182D4}</a:tableStyleId>
+                <a:tableStyleId>{C476F285-F301-4CAC-AD0B-A05D897E2BFC}</a:tableStyleId>
               </a:tblPr>
               <a:tblGrid>
                 <a:gridCol w="1695200"/>
@@ -26736,7 +26736,7 @@
             <a:tbl>
               <a:tblPr>
                 <a:noFill/>
-                <a:tableStyleId>{9FB09A23-FCEA-4C31-B3F2-6E79EF3182D4}</a:tableStyleId>
+                <a:tableStyleId>{C476F285-F301-4CAC-AD0B-A05D897E2BFC}</a:tableStyleId>
               </a:tblPr>
               <a:tblGrid>
                 <a:gridCol w="1695200"/>
@@ -27426,7 +27426,7 @@
             <a:tbl>
               <a:tblPr>
                 <a:noFill/>
-                <a:tableStyleId>{9FB09A23-FCEA-4C31-B3F2-6E79EF3182D4}</a:tableStyleId>
+                <a:tableStyleId>{C476F285-F301-4CAC-AD0B-A05D897E2BFC}</a:tableStyleId>
               </a:tblPr>
               <a:tblGrid>
                 <a:gridCol w="1695200"/>
@@ -28678,7 +28678,7 @@
             <a:tbl>
               <a:tblPr>
                 <a:noFill/>
-                <a:tableStyleId>{9FB09A23-FCEA-4C31-B3F2-6E79EF3182D4}</a:tableStyleId>
+                <a:tableStyleId>{C476F285-F301-4CAC-AD0B-A05D897E2BFC}</a:tableStyleId>
               </a:tblPr>
               <a:tblGrid>
                 <a:gridCol w="1695200"/>
@@ -29670,7 +29670,7 @@
             <a:tbl>
               <a:tblPr>
                 <a:noFill/>
-                <a:tableStyleId>{9FB09A23-FCEA-4C31-B3F2-6E79EF3182D4}</a:tableStyleId>
+                <a:tableStyleId>{C476F285-F301-4CAC-AD0B-A05D897E2BFC}</a:tableStyleId>
               </a:tblPr>
               <a:tblGrid>
                 <a:gridCol w="3048000"/>
@@ -33175,7 +33175,7 @@
             <a:tbl>
               <a:tblPr>
                 <a:noFill/>
-                <a:tableStyleId>{9FB09A23-FCEA-4C31-B3F2-6E79EF3182D4}</a:tableStyleId>
+                <a:tableStyleId>{C476F285-F301-4CAC-AD0B-A05D897E2BFC}</a:tableStyleId>
               </a:tblPr>
               <a:tblGrid>
                 <a:gridCol w="1828800"/>
@@ -34002,6 +34002,285 @@
 </file>
 
 <file path=ppt/theme/theme1.xml><?xml version="1.0" encoding="utf-8"?>
+<a:theme xmlns:a="http://schemas.openxmlformats.org/drawingml/2006/main" xmlns:r="http://schemas.openxmlformats.org/officeDocument/2006/relationships">
+  <a:themeElements>
+    <a:clrScheme name="Default">
+      <a:dk1>
+        <a:srgbClr val="000000"/>
+      </a:dk1>
+      <a:lt1>
+        <a:srgbClr val="FFFFFF"/>
+      </a:lt1>
+      <a:dk2>
+        <a:srgbClr val="158158"/>
+      </a:dk2>
+      <a:lt2>
+        <a:srgbClr val="F3F3F3"/>
+      </a:lt2>
+      <a:accent1>
+        <a:srgbClr val="058DC7"/>
+      </a:accent1>
+      <a:accent2>
+        <a:srgbClr val="50B432"/>
+      </a:accent2>
+      <a:accent3>
+        <a:srgbClr val="ED561B"/>
+      </a:accent3>
+      <a:accent4>
+        <a:srgbClr val="EDEF00"/>
+      </a:accent4>
+      <a:accent5>
+        <a:srgbClr val="24CBE5"/>
+      </a:accent5>
+      <a:accent6>
+        <a:srgbClr val="64E572"/>
+      </a:accent6>
+      <a:hlink>
+        <a:srgbClr val="2200CC"/>
+      </a:hlink>
+      <a:folHlink>
+        <a:srgbClr val="551A8B"/>
+      </a:folHlink>
+    </a:clrScheme>
+    <a:fontScheme name="Office">
+      <a:majorFont>
+        <a:latin typeface="Arial"/>
+        <a:ea typeface=""/>
+        <a:cs typeface=""/>
+        <a:font script="Jpan" typeface="ＭＳ Ｐゴシック"/>
+        <a:font script="Hang" typeface="맑은 고딕"/>
+        <a:font script="Hans" typeface="宋体"/>
+        <a:font script="Hant" typeface="新細明體"/>
+        <a:font script="Arab" typeface="Times New Roman"/>
+        <a:font script="Hebr" typeface="Times New Roman"/>
+        <a:font script="Thai" typeface="Angsana New"/>
+        <a:font script="Ethi" typeface="Nyala"/>
+        <a:font script="Beng" typeface="Vrinda"/>
+        <a:font script="Gujr" typeface="Shruti"/>
+        <a:font script="Khmr" typeface="MoolBoran"/>
+        <a:font script="Knda" typeface="Tunga"/>
+        <a:font script="Guru" typeface="Raavi"/>
+        <a:font script="Cans" typeface="Euphemia"/>
+        <a:font script="Cher" typeface="Plantagenet Cherokee"/>
+        <a:font script="Yiii" typeface="Microsoft Yi Baiti"/>
+        <a:font script="Tibt" typeface="Microsoft Himalaya"/>
+        <a:font script="Thaa" typeface="MV Boli"/>
+        <a:font script="Deva" typeface="Mangal"/>
+        <a:font script="Telu" typeface="Gautami"/>
+        <a:font script="Taml" typeface="Latha"/>
+        <a:font script="Syrc" typeface="Estrangelo Edessa"/>
+        <a:font script="Orya" typeface="Kalinga"/>
+        <a:font script="Mlym" typeface="Kartika"/>
+        <a:font script="Laoo" typeface="DokChampa"/>
+        <a:font script="Sinh" typeface="Iskoola Pota"/>
+        <a:font script="Mong" typeface="Mongolian Baiti"/>
+        <a:font script="Viet" typeface="Times New Roman"/>
+        <a:font script="Uigh" typeface="Microsoft Uighur"/>
+        <a:font script="Geor" typeface="Sylfaen"/>
+      </a:majorFont>
+      <a:minorFont>
+        <a:latin typeface="Arial"/>
+        <a:ea typeface=""/>
+        <a:cs typeface=""/>
+        <a:font script="Jpan" typeface="ＭＳ Ｐゴシック"/>
+        <a:font script="Hang" typeface="맑은 고딕"/>
+        <a:font script="Hans" typeface="宋体"/>
+        <a:font script="Hant" typeface="新細明體"/>
+        <a:font script="Arab" typeface="Arial"/>
+        <a:font script="Hebr" typeface="Arial"/>
+        <a:font script="Thai" typeface="Cordia New"/>
+        <a:font script="Ethi" typeface="Nyala"/>
+        <a:font script="Beng" typeface="Vrinda"/>
+        <a:font script="Gujr" typeface="Shruti"/>
+        <a:font script="Khmr" typeface="DaunPenh"/>
+        <a:font script="Knda" typeface="Tunga"/>
+        <a:font script="Guru" typeface="Raavi"/>
+        <a:font script="Cans" typeface="Euphemia"/>
+        <a:font script="Cher" typeface="Plantagenet Cherokee"/>
+        <a:font script="Yiii" typeface="Microsoft Yi Baiti"/>
+        <a:font script="Tibt" typeface="Microsoft Himalaya"/>
+        <a:font script="Thaa" typeface="MV Boli"/>
+        <a:font script="Deva" typeface="Mangal"/>
+        <a:font script="Telu" typeface="Gautami"/>
+        <a:font script="Taml" typeface="Latha"/>
+        <a:font script="Syrc" typeface="Estrangelo Edessa"/>
+        <a:font script="Orya" typeface="Kalinga"/>
+        <a:font script="Mlym" typeface="Kartika"/>
+        <a:font script="Laoo" typeface="DokChampa"/>
+        <a:font script="Sinh" typeface="Iskoola Pota"/>
+        <a:font script="Mong" typeface="Mongolian Baiti"/>
+        <a:font script="Viet" typeface="Arial"/>
+        <a:font script="Uigh" typeface="Microsoft Uighur"/>
+        <a:font script="Geor" typeface="Sylfaen"/>
+      </a:minorFont>
+    </a:fontScheme>
+    <a:fmtScheme name="Office">
+      <a:fillStyleLst>
+        <a:solidFill>
+          <a:schemeClr val="phClr"/>
+        </a:solidFill>
+        <a:gradFill rotWithShape="1">
+          <a:gsLst>
+            <a:gs pos="0">
+              <a:schemeClr val="phClr">
+                <a:tint val="50000"/>
+                <a:satMod val="300000"/>
+              </a:schemeClr>
+            </a:gs>
+            <a:gs pos="35000">
+              <a:schemeClr val="phClr">
+                <a:tint val="37000"/>
+                <a:satMod val="300000"/>
+              </a:schemeClr>
+            </a:gs>
+            <a:gs pos="100000">
+              <a:schemeClr val="phClr">
+                <a:tint val="15000"/>
+                <a:satMod val="350000"/>
+              </a:schemeClr>
+            </a:gs>
+          </a:gsLst>
+          <a:lin ang="16200000" scaled="1"/>
+        </a:gradFill>
+        <a:gradFill rotWithShape="1">
+          <a:gsLst>
+            <a:gs pos="0">
+              <a:schemeClr val="phClr">
+                <a:tint val="100000"/>
+                <a:shade val="100000"/>
+                <a:satMod val="130000"/>
+              </a:schemeClr>
+            </a:gs>
+            <a:gs pos="100000">
+              <a:schemeClr val="phClr">
+                <a:tint val="50000"/>
+                <a:shade val="100000"/>
+                <a:satMod val="350000"/>
+              </a:schemeClr>
+            </a:gs>
+          </a:gsLst>
+          <a:lin ang="16200000" scaled="0"/>
+        </a:gradFill>
+      </a:fillStyleLst>
+      <a:lnStyleLst>
+        <a:ln w="9525" cap="flat" cmpd="sng" algn="ctr">
+          <a:solidFill>
+            <a:schemeClr val="phClr">
+              <a:shade val="95000"/>
+              <a:satMod val="105000"/>
+            </a:schemeClr>
+          </a:solidFill>
+          <a:prstDash val="solid"/>
+        </a:ln>
+        <a:ln w="25400" cap="flat" cmpd="sng" algn="ctr">
+          <a:solidFill>
+            <a:schemeClr val="phClr"/>
+          </a:solidFill>
+          <a:prstDash val="solid"/>
+        </a:ln>
+        <a:ln w="38100" cap="flat" cmpd="sng" algn="ctr">
+          <a:solidFill>
+            <a:schemeClr val="phClr"/>
+          </a:solidFill>
+          <a:prstDash val="solid"/>
+        </a:ln>
+      </a:lnStyleLst>
+      <a:effectStyleLst>
+        <a:effectStyle>
+          <a:effectLst>
+            <a:outerShdw blurRad="40000" dist="20000" dir="5400000" rotWithShape="0">
+              <a:srgbClr val="000000">
+                <a:alpha val="38000"/>
+              </a:srgbClr>
+            </a:outerShdw>
+          </a:effectLst>
+        </a:effectStyle>
+        <a:effectStyle>
+          <a:effectLst>
+            <a:outerShdw blurRad="40000" dist="23000" dir="5400000" rotWithShape="0">
+              <a:srgbClr val="000000">
+                <a:alpha val="35000"/>
+              </a:srgbClr>
+            </a:outerShdw>
+          </a:effectLst>
+        </a:effectStyle>
+        <a:effectStyle>
+          <a:effectLst>
+            <a:outerShdw blurRad="40000" dist="23000" dir="5400000" rotWithShape="0">
+              <a:srgbClr val="000000">
+                <a:alpha val="35000"/>
+              </a:srgbClr>
+            </a:outerShdw>
+          </a:effectLst>
+          <a:scene3d>
+            <a:camera prst="orthographicFront">
+              <a:rot lat="0" lon="0" rev="0"/>
+            </a:camera>
+            <a:lightRig rig="threePt" dir="t">
+              <a:rot lat="0" lon="0" rev="1200000"/>
+            </a:lightRig>
+          </a:scene3d>
+          <a:sp3d>
+            <a:bevelT w="63500" h="25400"/>
+          </a:sp3d>
+        </a:effectStyle>
+      </a:effectStyleLst>
+      <a:bgFillStyleLst>
+        <a:solidFill>
+          <a:schemeClr val="phClr"/>
+        </a:solidFill>
+        <a:gradFill rotWithShape="1">
+          <a:gsLst>
+            <a:gs pos="0">
+              <a:schemeClr val="phClr">
+                <a:tint val="40000"/>
+                <a:satMod val="350000"/>
+              </a:schemeClr>
+            </a:gs>
+            <a:gs pos="40000">
+              <a:schemeClr val="phClr">
+                <a:tint val="45000"/>
+                <a:shade val="99000"/>
+                <a:satMod val="350000"/>
+              </a:schemeClr>
+            </a:gs>
+            <a:gs pos="100000">
+              <a:schemeClr val="phClr">
+                <a:shade val="20000"/>
+                <a:satMod val="255000"/>
+              </a:schemeClr>
+            </a:gs>
+          </a:gsLst>
+          <a:path path="circle">
+            <a:fillToRect l="50000" t="-80000" r="50000" b="180000"/>
+          </a:path>
+        </a:gradFill>
+        <a:gradFill rotWithShape="1">
+          <a:gsLst>
+            <a:gs pos="0">
+              <a:schemeClr val="phClr">
+                <a:tint val="80000"/>
+                <a:satMod val="300000"/>
+              </a:schemeClr>
+            </a:gs>
+            <a:gs pos="100000">
+              <a:schemeClr val="phClr">
+                <a:shade val="30000"/>
+                <a:satMod val="200000"/>
+              </a:schemeClr>
+            </a:gs>
+          </a:gsLst>
+          <a:path path="circle">
+            <a:fillToRect l="50000" t="50000" r="50000" b="50000"/>
+          </a:path>
+        </a:gradFill>
+      </a:bgFillStyleLst>
+    </a:fmtScheme>
+  </a:themeElements>
+</a:theme>
+</file>
+
+<file path=ppt/theme/theme2.xml><?xml version="1.0" encoding="utf-8"?>
 <a:theme xmlns:a="http://schemas.openxmlformats.org/drawingml/2006/main" xmlns:r="http://schemas.openxmlformats.org/officeDocument/2006/relationships" name="Simple Light">
   <a:themeElements>
     <a:clrScheme name="Simple Light">
@@ -34280,7 +34559,7 @@
 </a:theme>
 </file>
 
-<file path=ppt/theme/theme2.xml><?xml version="1.0" encoding="utf-8"?>
+<file path=ppt/theme/theme3.xml><?xml version="1.0" encoding="utf-8"?>
 <a:theme xmlns:a="http://schemas.openxmlformats.org/drawingml/2006/main" xmlns:r="http://schemas.openxmlformats.org/officeDocument/2006/relationships" name="LF Energy Theme 2023">
   <a:themeElements>
     <a:clrScheme name="Geometric">
@@ -34557,283 +34836,4 @@
     </a:fmtScheme>
   </a:themeElements>
 </a:theme>
-</file>
-
-<file path=ppt/theme/theme3.xml><?xml version="1.0" encoding="utf-8"?>
-<a:theme xmlns:a="http://schemas.openxmlformats.org/drawingml/2006/main" xmlns:r="http://schemas.openxmlformats.org/officeDocument/2006/relationships">
-  <a:themeElements>
-    <a:clrScheme name="Default">
-      <a:dk1>
-        <a:srgbClr val="000000"/>
-      </a:dk1>
-      <a:lt1>
-        <a:srgbClr val="FFFFFF"/>
-      </a:lt1>
-      <a:dk2>
-        <a:srgbClr val="158158"/>
-      </a:dk2>
-      <a:lt2>
-        <a:srgbClr val="F3F3F3"/>
-      </a:lt2>
-      <a:accent1>
-        <a:srgbClr val="058DC7"/>
-      </a:accent1>
-      <a:accent2>
-        <a:srgbClr val="50B432"/>
-      </a:accent2>
-      <a:accent3>
-        <a:srgbClr val="ED561B"/>
-      </a:accent3>
-      <a:accent4>
-        <a:srgbClr val="EDEF00"/>
-      </a:accent4>
-      <a:accent5>
-        <a:srgbClr val="24CBE5"/>
-      </a:accent5>
-      <a:accent6>
-        <a:srgbClr val="64E572"/>
-      </a:accent6>
-      <a:hlink>
-        <a:srgbClr val="2200CC"/>
-      </a:hlink>
-      <a:folHlink>
-        <a:srgbClr val="551A8B"/>
-      </a:folHlink>
-    </a:clrScheme>
-    <a:fontScheme name="Office">
-      <a:majorFont>
-        <a:latin typeface="Arial"/>
-        <a:ea typeface=""/>
-        <a:cs typeface=""/>
-        <a:font script="Jpan" typeface="ＭＳ Ｐゴシック"/>
-        <a:font script="Hang" typeface="맑은 고딕"/>
-        <a:font script="Hans" typeface="宋体"/>
-        <a:font script="Hant" typeface="新細明體"/>
-        <a:font script="Arab" typeface="Times New Roman"/>
-        <a:font script="Hebr" typeface="Times New Roman"/>
-        <a:font script="Thai" typeface="Angsana New"/>
-        <a:font script="Ethi" typeface="Nyala"/>
-        <a:font script="Beng" typeface="Vrinda"/>
-        <a:font script="Gujr" typeface="Shruti"/>
-        <a:font script="Khmr" typeface="MoolBoran"/>
-        <a:font script="Knda" typeface="Tunga"/>
-        <a:font script="Guru" typeface="Raavi"/>
-        <a:font script="Cans" typeface="Euphemia"/>
-        <a:font script="Cher" typeface="Plantagenet Cherokee"/>
-        <a:font script="Yiii" typeface="Microsoft Yi Baiti"/>
-        <a:font script="Tibt" typeface="Microsoft Himalaya"/>
-        <a:font script="Thaa" typeface="MV Boli"/>
-        <a:font script="Deva" typeface="Mangal"/>
-        <a:font script="Telu" typeface="Gautami"/>
-        <a:font script="Taml" typeface="Latha"/>
-        <a:font script="Syrc" typeface="Estrangelo Edessa"/>
-        <a:font script="Orya" typeface="Kalinga"/>
-        <a:font script="Mlym" typeface="Kartika"/>
-        <a:font script="Laoo" typeface="DokChampa"/>
-        <a:font script="Sinh" typeface="Iskoola Pota"/>
-        <a:font script="Mong" typeface="Mongolian Baiti"/>
-        <a:font script="Viet" typeface="Times New Roman"/>
-        <a:font script="Uigh" typeface="Microsoft Uighur"/>
-        <a:font script="Geor" typeface="Sylfaen"/>
-      </a:majorFont>
-      <a:minorFont>
-        <a:latin typeface="Arial"/>
-        <a:ea typeface=""/>
-        <a:cs typeface=""/>
-        <a:font script="Jpan" typeface="ＭＳ Ｐゴシック"/>
-        <a:font script="Hang" typeface="맑은 고딕"/>
-        <a:font script="Hans" typeface="宋体"/>
-        <a:font script="Hant" typeface="新細明體"/>
-        <a:font script="Arab" typeface="Arial"/>
-        <a:font script="Hebr" typeface="Arial"/>
-        <a:font script="Thai" typeface="Cordia New"/>
-        <a:font script="Ethi" typeface="Nyala"/>
-        <a:font script="Beng" typeface="Vrinda"/>
-        <a:font script="Gujr" typeface="Shruti"/>
-        <a:font script="Khmr" typeface="DaunPenh"/>
-        <a:font script="Knda" typeface="Tunga"/>
-        <a:font script="Guru" typeface="Raavi"/>
-        <a:font script="Cans" typeface="Euphemia"/>
-        <a:font script="Cher" typeface="Plantagenet Cherokee"/>
-        <a:font script="Yiii" typeface="Microsoft Yi Baiti"/>
-        <a:font script="Tibt" typeface="Microsoft Himalaya"/>
-        <a:font script="Thaa" typeface="MV Boli"/>
-        <a:font script="Deva" typeface="Mangal"/>
-        <a:font script="Telu" typeface="Gautami"/>
-        <a:font script="Taml" typeface="Latha"/>
-        <a:font script="Syrc" typeface="Estrangelo Edessa"/>
-        <a:font script="Orya" typeface="Kalinga"/>
-        <a:font script="Mlym" typeface="Kartika"/>
-        <a:font script="Laoo" typeface="DokChampa"/>
-        <a:font script="Sinh" typeface="Iskoola Pota"/>
-        <a:font script="Mong" typeface="Mongolian Baiti"/>
-        <a:font script="Viet" typeface="Arial"/>
-        <a:font script="Uigh" typeface="Microsoft Uighur"/>
-        <a:font script="Geor" typeface="Sylfaen"/>
-      </a:minorFont>
-    </a:fontScheme>
-    <a:fmtScheme name="Office">
-      <a:fillStyleLst>
-        <a:solidFill>
-          <a:schemeClr val="phClr"/>
-        </a:solidFill>
-        <a:gradFill rotWithShape="1">
-          <a:gsLst>
-            <a:gs pos="0">
-              <a:schemeClr val="phClr">
-                <a:tint val="50000"/>
-                <a:satMod val="300000"/>
-              </a:schemeClr>
-            </a:gs>
-            <a:gs pos="35000">
-              <a:schemeClr val="phClr">
-                <a:tint val="37000"/>
-                <a:satMod val="300000"/>
-              </a:schemeClr>
-            </a:gs>
-            <a:gs pos="100000">
-              <a:schemeClr val="phClr">
-                <a:tint val="15000"/>
-                <a:satMod val="350000"/>
-              </a:schemeClr>
-            </a:gs>
-          </a:gsLst>
-          <a:lin ang="16200000" scaled="1"/>
-        </a:gradFill>
-        <a:gradFill rotWithShape="1">
-          <a:gsLst>
-            <a:gs pos="0">
-              <a:schemeClr val="phClr">
-                <a:tint val="100000"/>
-                <a:shade val="100000"/>
-                <a:satMod val="130000"/>
-              </a:schemeClr>
-            </a:gs>
-            <a:gs pos="100000">
-              <a:schemeClr val="phClr">
-                <a:tint val="50000"/>
-                <a:shade val="100000"/>
-                <a:satMod val="350000"/>
-              </a:schemeClr>
-            </a:gs>
-          </a:gsLst>
-          <a:lin ang="16200000" scaled="0"/>
-        </a:gradFill>
-      </a:fillStyleLst>
-      <a:lnStyleLst>
-        <a:ln w="9525" cap="flat" cmpd="sng" algn="ctr">
-          <a:solidFill>
-            <a:schemeClr val="phClr">
-              <a:shade val="95000"/>
-              <a:satMod val="105000"/>
-            </a:schemeClr>
-          </a:solidFill>
-          <a:prstDash val="solid"/>
-        </a:ln>
-        <a:ln w="25400" cap="flat" cmpd="sng" algn="ctr">
-          <a:solidFill>
-            <a:schemeClr val="phClr"/>
-          </a:solidFill>
-          <a:prstDash val="solid"/>
-        </a:ln>
-        <a:ln w="38100" cap="flat" cmpd="sng" algn="ctr">
-          <a:solidFill>
-            <a:schemeClr val="phClr"/>
-          </a:solidFill>
-          <a:prstDash val="solid"/>
-        </a:ln>
-      </a:lnStyleLst>
-      <a:effectStyleLst>
-        <a:effectStyle>
-          <a:effectLst>
-            <a:outerShdw blurRad="40000" dist="20000" dir="5400000" rotWithShape="0">
-              <a:srgbClr val="000000">
-                <a:alpha val="38000"/>
-              </a:srgbClr>
-            </a:outerShdw>
-          </a:effectLst>
-        </a:effectStyle>
-        <a:effectStyle>
-          <a:effectLst>
-            <a:outerShdw blurRad="40000" dist="23000" dir="5400000" rotWithShape="0">
-              <a:srgbClr val="000000">
-                <a:alpha val="35000"/>
-              </a:srgbClr>
-            </a:outerShdw>
-          </a:effectLst>
-        </a:effectStyle>
-        <a:effectStyle>
-          <a:effectLst>
-            <a:outerShdw blurRad="40000" dist="23000" dir="5400000" rotWithShape="0">
-              <a:srgbClr val="000000">
-                <a:alpha val="35000"/>
-              </a:srgbClr>
-            </a:outerShdw>
-          </a:effectLst>
-          <a:scene3d>
-            <a:camera prst="orthographicFront">
-              <a:rot lat="0" lon="0" rev="0"/>
-            </a:camera>
-            <a:lightRig rig="threePt" dir="t">
-              <a:rot lat="0" lon="0" rev="1200000"/>
-            </a:lightRig>
-          </a:scene3d>
-          <a:sp3d>
-            <a:bevelT w="63500" h="25400"/>
-          </a:sp3d>
-        </a:effectStyle>
-      </a:effectStyleLst>
-      <a:bgFillStyleLst>
-        <a:solidFill>
-          <a:schemeClr val="phClr"/>
-        </a:solidFill>
-        <a:gradFill rotWithShape="1">
-          <a:gsLst>
-            <a:gs pos="0">
-              <a:schemeClr val="phClr">
-                <a:tint val="40000"/>
-                <a:satMod val="350000"/>
-              </a:schemeClr>
-            </a:gs>
-            <a:gs pos="40000">
-              <a:schemeClr val="phClr">
-                <a:tint val="45000"/>
-                <a:shade val="99000"/>
-                <a:satMod val="350000"/>
-              </a:schemeClr>
-            </a:gs>
-            <a:gs pos="100000">
-              <a:schemeClr val="phClr">
-                <a:shade val="20000"/>
-                <a:satMod val="255000"/>
-              </a:schemeClr>
-            </a:gs>
-          </a:gsLst>
-          <a:path path="circle">
-            <a:fillToRect l="50000" t="-80000" r="50000" b="180000"/>
-          </a:path>
-        </a:gradFill>
-        <a:gradFill rotWithShape="1">
-          <a:gsLst>
-            <a:gs pos="0">
-              <a:schemeClr val="phClr">
-                <a:tint val="80000"/>
-                <a:satMod val="300000"/>
-              </a:schemeClr>
-            </a:gs>
-            <a:gs pos="100000">
-              <a:schemeClr val="phClr">
-                <a:shade val="30000"/>
-                <a:satMod val="200000"/>
-              </a:schemeClr>
-            </a:gs>
-          </a:gsLst>
-          <a:path path="circle">
-            <a:fillToRect l="50000" t="50000" r="50000" b="50000"/>
-          </a:path>
-        </a:gradFill>
-      </a:bgFillStyleLst>
-    </a:fmtScheme>
-  </a:themeElements>
-</a:theme>
 </file>
</xml_diff>

<commit_message>
Update Data Sources from LFX 2026-09-22 (#316)
Update Data Sources from LFX

Signed-off-by: github-actions[bot] <41898282+github-actions[bot]@users.noreply.github.com>
</commit_message>
<xml_diff>
--- a/overview_deck/LF Energy High Level Overview.pptx
+++ b/overview_deck/LF Energy High Level Overview.pptx
@@ -25946,7 +25946,7 @@
             <a:tbl>
               <a:tblPr>
                 <a:noFill/>
-                <a:tableStyleId>{C476F285-F301-4CAC-AD0B-A05D897E2BFC}</a:tableStyleId>
+                <a:tableStyleId>{01B5DCE9-D4DA-48A5-8472-9EA3772926F4}</a:tableStyleId>
               </a:tblPr>
               <a:tblGrid>
                 <a:gridCol w="1695200"/>
@@ -26736,7 +26736,7 @@
             <a:tbl>
               <a:tblPr>
                 <a:noFill/>
-                <a:tableStyleId>{C476F285-F301-4CAC-AD0B-A05D897E2BFC}</a:tableStyleId>
+                <a:tableStyleId>{01B5DCE9-D4DA-48A5-8472-9EA3772926F4}</a:tableStyleId>
               </a:tblPr>
               <a:tblGrid>
                 <a:gridCol w="1695200"/>
@@ -27426,7 +27426,7 @@
             <a:tbl>
               <a:tblPr>
                 <a:noFill/>
-                <a:tableStyleId>{C476F285-F301-4CAC-AD0B-A05D897E2BFC}</a:tableStyleId>
+                <a:tableStyleId>{01B5DCE9-D4DA-48A5-8472-9EA3772926F4}</a:tableStyleId>
               </a:tblPr>
               <a:tblGrid>
                 <a:gridCol w="1695200"/>
@@ -28678,7 +28678,7 @@
             <a:tbl>
               <a:tblPr>
                 <a:noFill/>
-                <a:tableStyleId>{C476F285-F301-4CAC-AD0B-A05D897E2BFC}</a:tableStyleId>
+                <a:tableStyleId>{01B5DCE9-D4DA-48A5-8472-9EA3772926F4}</a:tableStyleId>
               </a:tblPr>
               <a:tblGrid>
                 <a:gridCol w="1695200"/>
@@ -29670,7 +29670,7 @@
             <a:tbl>
               <a:tblPr>
                 <a:noFill/>
-                <a:tableStyleId>{C476F285-F301-4CAC-AD0B-A05D897E2BFC}</a:tableStyleId>
+                <a:tableStyleId>{01B5DCE9-D4DA-48A5-8472-9EA3772926F4}</a:tableStyleId>
               </a:tblPr>
               <a:tblGrid>
                 <a:gridCol w="3048000"/>
@@ -33175,7 +33175,7 @@
             <a:tbl>
               <a:tblPr>
                 <a:noFill/>
-                <a:tableStyleId>{C476F285-F301-4CAC-AD0B-A05D897E2BFC}</a:tableStyleId>
+                <a:tableStyleId>{01B5DCE9-D4DA-48A5-8472-9EA3772926F4}</a:tableStyleId>
               </a:tblPr>
               <a:tblGrid>
                 <a:gridCol w="1828800"/>
@@ -34002,9 +34002,9 @@
 </file>
 
 <file path=ppt/theme/theme1.xml><?xml version="1.0" encoding="utf-8"?>
-<a:theme xmlns:a="http://schemas.openxmlformats.org/drawingml/2006/main" xmlns:r="http://schemas.openxmlformats.org/officeDocument/2006/relationships">
+<a:theme xmlns:a="http://schemas.openxmlformats.org/drawingml/2006/main" xmlns:r="http://schemas.openxmlformats.org/officeDocument/2006/relationships" name="Simple Light">
   <a:themeElements>
-    <a:clrScheme name="Default">
+    <a:clrScheme name="Simple Light">
       <a:dk1>
         <a:srgbClr val="000000"/>
       </a:dk1>
@@ -34012,34 +34012,34 @@
         <a:srgbClr val="FFFFFF"/>
       </a:lt1>
       <a:dk2>
-        <a:srgbClr val="158158"/>
+        <a:srgbClr val="595959"/>
       </a:dk2>
       <a:lt2>
-        <a:srgbClr val="F3F3F3"/>
+        <a:srgbClr val="EEEEEE"/>
       </a:lt2>
       <a:accent1>
-        <a:srgbClr val="058DC7"/>
+        <a:srgbClr val="4285F4"/>
       </a:accent1>
       <a:accent2>
-        <a:srgbClr val="50B432"/>
+        <a:srgbClr val="212121"/>
       </a:accent2>
       <a:accent3>
-        <a:srgbClr val="ED561B"/>
+        <a:srgbClr val="78909C"/>
       </a:accent3>
       <a:accent4>
-        <a:srgbClr val="EDEF00"/>
+        <a:srgbClr val="FFAB40"/>
       </a:accent4>
       <a:accent5>
-        <a:srgbClr val="24CBE5"/>
+        <a:srgbClr val="0097A7"/>
       </a:accent5>
       <a:accent6>
-        <a:srgbClr val="64E572"/>
+        <a:srgbClr val="EEFF41"/>
       </a:accent6>
       <a:hlink>
-        <a:srgbClr val="2200CC"/>
+        <a:srgbClr val="0097A7"/>
       </a:hlink>
       <a:folHlink>
-        <a:srgbClr val="551A8B"/>
+        <a:srgbClr val="0097A7"/>
       </a:folHlink>
     </a:clrScheme>
     <a:fontScheme name="Office">
@@ -34281,9 +34281,9 @@
 </file>
 
 <file path=ppt/theme/theme2.xml><?xml version="1.0" encoding="utf-8"?>
-<a:theme xmlns:a="http://schemas.openxmlformats.org/drawingml/2006/main" xmlns:r="http://schemas.openxmlformats.org/officeDocument/2006/relationships" name="Simple Light">
+<a:theme xmlns:a="http://schemas.openxmlformats.org/drawingml/2006/main" xmlns:r="http://schemas.openxmlformats.org/officeDocument/2006/relationships">
   <a:themeElements>
-    <a:clrScheme name="Simple Light">
+    <a:clrScheme name="Default">
       <a:dk1>
         <a:srgbClr val="000000"/>
       </a:dk1>
@@ -34291,34 +34291,34 @@
         <a:srgbClr val="FFFFFF"/>
       </a:lt1>
       <a:dk2>
-        <a:srgbClr val="595959"/>
+        <a:srgbClr val="158158"/>
       </a:dk2>
       <a:lt2>
-        <a:srgbClr val="EEEEEE"/>
+        <a:srgbClr val="F3F3F3"/>
       </a:lt2>
       <a:accent1>
-        <a:srgbClr val="4285F4"/>
+        <a:srgbClr val="058DC7"/>
       </a:accent1>
       <a:accent2>
-        <a:srgbClr val="212121"/>
+        <a:srgbClr val="50B432"/>
       </a:accent2>
       <a:accent3>
-        <a:srgbClr val="78909C"/>
+        <a:srgbClr val="ED561B"/>
       </a:accent3>
       <a:accent4>
-        <a:srgbClr val="FFAB40"/>
+        <a:srgbClr val="EDEF00"/>
       </a:accent4>
       <a:accent5>
-        <a:srgbClr val="0097A7"/>
+        <a:srgbClr val="24CBE5"/>
       </a:accent5>
       <a:accent6>
-        <a:srgbClr val="EEFF41"/>
+        <a:srgbClr val="64E572"/>
       </a:accent6>
       <a:hlink>
-        <a:srgbClr val="0097A7"/>
+        <a:srgbClr val="2200CC"/>
       </a:hlink>
       <a:folHlink>
-        <a:srgbClr val="0097A7"/>
+        <a:srgbClr val="551A8B"/>
       </a:folHlink>
     </a:clrScheme>
     <a:fontScheme name="Office">

</xml_diff>

<commit_message>
Update Data Sources from LFX 2026-09-23 (#318)
Update Data Sources from LFX

Signed-off-by: github-actions[bot] <41898282+github-actions[bot]@users.noreply.github.com>
Co-authored-by: jmertic <296737+jmertic@users.noreply.github.com>
</commit_message>
<xml_diff>
--- a/overview_deck/LF Energy High Level Overview.pptx
+++ b/overview_deck/LF Energy High Level Overview.pptx
@@ -25946,7 +25946,7 @@
             <a:tbl>
               <a:tblPr>
                 <a:noFill/>
-                <a:tableStyleId>{01B5DCE9-D4DA-48A5-8472-9EA3772926F4}</a:tableStyleId>
+                <a:tableStyleId>{7CC5F54F-E92F-4192-BD72-CC22CBD5DBAC}</a:tableStyleId>
               </a:tblPr>
               <a:tblGrid>
                 <a:gridCol w="1695200"/>
@@ -26736,7 +26736,7 @@
             <a:tbl>
               <a:tblPr>
                 <a:noFill/>
-                <a:tableStyleId>{01B5DCE9-D4DA-48A5-8472-9EA3772926F4}</a:tableStyleId>
+                <a:tableStyleId>{7CC5F54F-E92F-4192-BD72-CC22CBD5DBAC}</a:tableStyleId>
               </a:tblPr>
               <a:tblGrid>
                 <a:gridCol w="1695200"/>
@@ -27426,7 +27426,7 @@
             <a:tbl>
               <a:tblPr>
                 <a:noFill/>
-                <a:tableStyleId>{01B5DCE9-D4DA-48A5-8472-9EA3772926F4}</a:tableStyleId>
+                <a:tableStyleId>{7CC5F54F-E92F-4192-BD72-CC22CBD5DBAC}</a:tableStyleId>
               </a:tblPr>
               <a:tblGrid>
                 <a:gridCol w="1695200"/>
@@ -28678,7 +28678,7 @@
             <a:tbl>
               <a:tblPr>
                 <a:noFill/>
-                <a:tableStyleId>{01B5DCE9-D4DA-48A5-8472-9EA3772926F4}</a:tableStyleId>
+                <a:tableStyleId>{7CC5F54F-E92F-4192-BD72-CC22CBD5DBAC}</a:tableStyleId>
               </a:tblPr>
               <a:tblGrid>
                 <a:gridCol w="1695200"/>
@@ -29670,7 +29670,7 @@
             <a:tbl>
               <a:tblPr>
                 <a:noFill/>
-                <a:tableStyleId>{01B5DCE9-D4DA-48A5-8472-9EA3772926F4}</a:tableStyleId>
+                <a:tableStyleId>{7CC5F54F-E92F-4192-BD72-CC22CBD5DBAC}</a:tableStyleId>
               </a:tblPr>
               <a:tblGrid>
                 <a:gridCol w="3048000"/>
@@ -33175,7 +33175,7 @@
             <a:tbl>
               <a:tblPr>
                 <a:noFill/>
-                <a:tableStyleId>{01B5DCE9-D4DA-48A5-8472-9EA3772926F4}</a:tableStyleId>
+                <a:tableStyleId>{7CC5F54F-E92F-4192-BD72-CC22CBD5DBAC}</a:tableStyleId>
               </a:tblPr>
               <a:tblGrid>
                 <a:gridCol w="1828800"/>
@@ -34002,9 +34002,9 @@
 </file>
 
 <file path=ppt/theme/theme1.xml><?xml version="1.0" encoding="utf-8"?>
-<a:theme xmlns:a="http://schemas.openxmlformats.org/drawingml/2006/main" xmlns:r="http://schemas.openxmlformats.org/officeDocument/2006/relationships" name="Simple Light">
+<a:theme xmlns:a="http://schemas.openxmlformats.org/drawingml/2006/main" xmlns:r="http://schemas.openxmlformats.org/officeDocument/2006/relationships">
   <a:themeElements>
-    <a:clrScheme name="Simple Light">
+    <a:clrScheme name="Default">
       <a:dk1>
         <a:srgbClr val="000000"/>
       </a:dk1>
@@ -34012,34 +34012,34 @@
         <a:srgbClr val="FFFFFF"/>
       </a:lt1>
       <a:dk2>
-        <a:srgbClr val="595959"/>
+        <a:srgbClr val="158158"/>
       </a:dk2>
       <a:lt2>
-        <a:srgbClr val="EEEEEE"/>
+        <a:srgbClr val="F3F3F3"/>
       </a:lt2>
       <a:accent1>
-        <a:srgbClr val="4285F4"/>
+        <a:srgbClr val="058DC7"/>
       </a:accent1>
       <a:accent2>
-        <a:srgbClr val="212121"/>
+        <a:srgbClr val="50B432"/>
       </a:accent2>
       <a:accent3>
-        <a:srgbClr val="78909C"/>
+        <a:srgbClr val="ED561B"/>
       </a:accent3>
       <a:accent4>
-        <a:srgbClr val="FFAB40"/>
+        <a:srgbClr val="EDEF00"/>
       </a:accent4>
       <a:accent5>
-        <a:srgbClr val="0097A7"/>
+        <a:srgbClr val="24CBE5"/>
       </a:accent5>
       <a:accent6>
-        <a:srgbClr val="EEFF41"/>
+        <a:srgbClr val="64E572"/>
       </a:accent6>
       <a:hlink>
-        <a:srgbClr val="0097A7"/>
+        <a:srgbClr val="2200CC"/>
       </a:hlink>
       <a:folHlink>
-        <a:srgbClr val="0097A7"/>
+        <a:srgbClr val="551A8B"/>
       </a:folHlink>
     </a:clrScheme>
     <a:fontScheme name="Office">
@@ -34281,9 +34281,9 @@
 </file>
 
 <file path=ppt/theme/theme2.xml><?xml version="1.0" encoding="utf-8"?>
-<a:theme xmlns:a="http://schemas.openxmlformats.org/drawingml/2006/main" xmlns:r="http://schemas.openxmlformats.org/officeDocument/2006/relationships">
+<a:theme xmlns:a="http://schemas.openxmlformats.org/drawingml/2006/main" xmlns:r="http://schemas.openxmlformats.org/officeDocument/2006/relationships" name="Simple Light">
   <a:themeElements>
-    <a:clrScheme name="Default">
+    <a:clrScheme name="Simple Light">
       <a:dk1>
         <a:srgbClr val="000000"/>
       </a:dk1>
@@ -34291,34 +34291,34 @@
         <a:srgbClr val="FFFFFF"/>
       </a:lt1>
       <a:dk2>
-        <a:srgbClr val="158158"/>
+        <a:srgbClr val="595959"/>
       </a:dk2>
       <a:lt2>
-        <a:srgbClr val="F3F3F3"/>
+        <a:srgbClr val="EEEEEE"/>
       </a:lt2>
       <a:accent1>
-        <a:srgbClr val="058DC7"/>
+        <a:srgbClr val="4285F4"/>
       </a:accent1>
       <a:accent2>
-        <a:srgbClr val="50B432"/>
+        <a:srgbClr val="212121"/>
       </a:accent2>
       <a:accent3>
-        <a:srgbClr val="ED561B"/>
+        <a:srgbClr val="78909C"/>
       </a:accent3>
       <a:accent4>
-        <a:srgbClr val="EDEF00"/>
+        <a:srgbClr val="FFAB40"/>
       </a:accent4>
       <a:accent5>
-        <a:srgbClr val="24CBE5"/>
+        <a:srgbClr val="0097A7"/>
       </a:accent5>
       <a:accent6>
-        <a:srgbClr val="64E572"/>
+        <a:srgbClr val="EEFF41"/>
       </a:accent6>
       <a:hlink>
-        <a:srgbClr val="2200CC"/>
+        <a:srgbClr val="0097A7"/>
       </a:hlink>
       <a:folHlink>
-        <a:srgbClr val="551A8B"/>
+        <a:srgbClr val="0097A7"/>
       </a:folHlink>
     </a:clrScheme>
     <a:fontScheme name="Office">

</xml_diff>

<commit_message>
Update Data Sources from LFX 2026-09-23 (#319)
Update Data Sources from LFX

Signed-off-by: github-actions[bot] <41898282+github-actions[bot]@users.noreply.github.com>
Co-authored-by: jmertic <296737+jmertic@users.noreply.github.com>
</commit_message>
<xml_diff>
--- a/overview_deck/LF Energy High Level Overview.pptx
+++ b/overview_deck/LF Energy High Level Overview.pptx
@@ -25946,7 +25946,7 @@
             <a:tbl>
               <a:tblPr>
                 <a:noFill/>
-                <a:tableStyleId>{7CC5F54F-E92F-4192-BD72-CC22CBD5DBAC}</a:tableStyleId>
+                <a:tableStyleId>{ACEB87D9-4107-43B8-90F2-9AF94FFA6626}</a:tableStyleId>
               </a:tblPr>
               <a:tblGrid>
                 <a:gridCol w="1695200"/>
@@ -26736,7 +26736,7 @@
             <a:tbl>
               <a:tblPr>
                 <a:noFill/>
-                <a:tableStyleId>{7CC5F54F-E92F-4192-BD72-CC22CBD5DBAC}</a:tableStyleId>
+                <a:tableStyleId>{ACEB87D9-4107-43B8-90F2-9AF94FFA6626}</a:tableStyleId>
               </a:tblPr>
               <a:tblGrid>
                 <a:gridCol w="1695200"/>
@@ -27426,7 +27426,7 @@
             <a:tbl>
               <a:tblPr>
                 <a:noFill/>
-                <a:tableStyleId>{7CC5F54F-E92F-4192-BD72-CC22CBD5DBAC}</a:tableStyleId>
+                <a:tableStyleId>{ACEB87D9-4107-43B8-90F2-9AF94FFA6626}</a:tableStyleId>
               </a:tblPr>
               <a:tblGrid>
                 <a:gridCol w="1695200"/>
@@ -28678,7 +28678,7 @@
             <a:tbl>
               <a:tblPr>
                 <a:noFill/>
-                <a:tableStyleId>{7CC5F54F-E92F-4192-BD72-CC22CBD5DBAC}</a:tableStyleId>
+                <a:tableStyleId>{ACEB87D9-4107-43B8-90F2-9AF94FFA6626}</a:tableStyleId>
               </a:tblPr>
               <a:tblGrid>
                 <a:gridCol w="1695200"/>
@@ -29670,7 +29670,7 @@
             <a:tbl>
               <a:tblPr>
                 <a:noFill/>
-                <a:tableStyleId>{7CC5F54F-E92F-4192-BD72-CC22CBD5DBAC}</a:tableStyleId>
+                <a:tableStyleId>{ACEB87D9-4107-43B8-90F2-9AF94FFA6626}</a:tableStyleId>
               </a:tblPr>
               <a:tblGrid>
                 <a:gridCol w="3048000"/>
@@ -33175,7 +33175,7 @@
             <a:tbl>
               <a:tblPr>
                 <a:noFill/>
-                <a:tableStyleId>{7CC5F54F-E92F-4192-BD72-CC22CBD5DBAC}</a:tableStyleId>
+                <a:tableStyleId>{ACEB87D9-4107-43B8-90F2-9AF94FFA6626}</a:tableStyleId>
               </a:tblPr>
               <a:tblGrid>
                 <a:gridCol w="1828800"/>
@@ -34281,6 +34281,285 @@
 </file>
 
 <file path=ppt/theme/theme2.xml><?xml version="1.0" encoding="utf-8"?>
+<a:theme xmlns:a="http://schemas.openxmlformats.org/drawingml/2006/main" xmlns:r="http://schemas.openxmlformats.org/officeDocument/2006/relationships" name="LF Energy Theme 2023">
+  <a:themeElements>
+    <a:clrScheme name="Geometric">
+      <a:dk1>
+        <a:srgbClr val="222222"/>
+      </a:dk1>
+      <a:lt1>
+        <a:srgbClr val="FFFFFF"/>
+      </a:lt1>
+      <a:dk2>
+        <a:srgbClr val="434343"/>
+      </a:dk2>
+      <a:lt2>
+        <a:srgbClr val="999999"/>
+      </a:lt2>
+      <a:accent1>
+        <a:srgbClr val="003778"/>
+      </a:accent1>
+      <a:accent2>
+        <a:srgbClr val="0094FF"/>
+      </a:accent2>
+      <a:accent3>
+        <a:srgbClr val="5B1DE7"/>
+      </a:accent3>
+      <a:accent4>
+        <a:srgbClr val="12E2E2"/>
+      </a:accent4>
+      <a:accent5>
+        <a:srgbClr val="FF00AA"/>
+      </a:accent5>
+      <a:accent6>
+        <a:srgbClr val="ACDE1F"/>
+      </a:accent6>
+      <a:hlink>
+        <a:srgbClr val="0077CC"/>
+      </a:hlink>
+      <a:folHlink>
+        <a:srgbClr val="F06292"/>
+      </a:folHlink>
+    </a:clrScheme>
+    <a:fontScheme name="Office">
+      <a:majorFont>
+        <a:latin typeface="Arial"/>
+        <a:ea typeface=""/>
+        <a:cs typeface=""/>
+        <a:font script="Jpan" typeface="ＭＳ Ｐゴシック"/>
+        <a:font script="Hang" typeface="맑은 고딕"/>
+        <a:font script="Hans" typeface="宋体"/>
+        <a:font script="Hant" typeface="新細明體"/>
+        <a:font script="Arab" typeface="Times New Roman"/>
+        <a:font script="Hebr" typeface="Times New Roman"/>
+        <a:font script="Thai" typeface="Angsana New"/>
+        <a:font script="Ethi" typeface="Nyala"/>
+        <a:font script="Beng" typeface="Vrinda"/>
+        <a:font script="Gujr" typeface="Shruti"/>
+        <a:font script="Khmr" typeface="MoolBoran"/>
+        <a:font script="Knda" typeface="Tunga"/>
+        <a:font script="Guru" typeface="Raavi"/>
+        <a:font script="Cans" typeface="Euphemia"/>
+        <a:font script="Cher" typeface="Plantagenet Cherokee"/>
+        <a:font script="Yiii" typeface="Microsoft Yi Baiti"/>
+        <a:font script="Tibt" typeface="Microsoft Himalaya"/>
+        <a:font script="Thaa" typeface="MV Boli"/>
+        <a:font script="Deva" typeface="Mangal"/>
+        <a:font script="Telu" typeface="Gautami"/>
+        <a:font script="Taml" typeface="Latha"/>
+        <a:font script="Syrc" typeface="Estrangelo Edessa"/>
+        <a:font script="Orya" typeface="Kalinga"/>
+        <a:font script="Mlym" typeface="Kartika"/>
+        <a:font script="Laoo" typeface="DokChampa"/>
+        <a:font script="Sinh" typeface="Iskoola Pota"/>
+        <a:font script="Mong" typeface="Mongolian Baiti"/>
+        <a:font script="Viet" typeface="Times New Roman"/>
+        <a:font script="Uigh" typeface="Microsoft Uighur"/>
+        <a:font script="Geor" typeface="Sylfaen"/>
+      </a:majorFont>
+      <a:minorFont>
+        <a:latin typeface="Arial"/>
+        <a:ea typeface=""/>
+        <a:cs typeface=""/>
+        <a:font script="Jpan" typeface="ＭＳ Ｐゴシック"/>
+        <a:font script="Hang" typeface="맑은 고딕"/>
+        <a:font script="Hans" typeface="宋体"/>
+        <a:font script="Hant" typeface="新細明體"/>
+        <a:font script="Arab" typeface="Arial"/>
+        <a:font script="Hebr" typeface="Arial"/>
+        <a:font script="Thai" typeface="Cordia New"/>
+        <a:font script="Ethi" typeface="Nyala"/>
+        <a:font script="Beng" typeface="Vrinda"/>
+        <a:font script="Gujr" typeface="Shruti"/>
+        <a:font script="Khmr" typeface="DaunPenh"/>
+        <a:font script="Knda" typeface="Tunga"/>
+        <a:font script="Guru" typeface="Raavi"/>
+        <a:font script="Cans" typeface="Euphemia"/>
+        <a:font script="Cher" typeface="Plantagenet Cherokee"/>
+        <a:font script="Yiii" typeface="Microsoft Yi Baiti"/>
+        <a:font script="Tibt" typeface="Microsoft Himalaya"/>
+        <a:font script="Thaa" typeface="MV Boli"/>
+        <a:font script="Deva" typeface="Mangal"/>
+        <a:font script="Telu" typeface="Gautami"/>
+        <a:font script="Taml" typeface="Latha"/>
+        <a:font script="Syrc" typeface="Estrangelo Edessa"/>
+        <a:font script="Orya" typeface="Kalinga"/>
+        <a:font script="Mlym" typeface="Kartika"/>
+        <a:font script="Laoo" typeface="DokChampa"/>
+        <a:font script="Sinh" typeface="Iskoola Pota"/>
+        <a:font script="Mong" typeface="Mongolian Baiti"/>
+        <a:font script="Viet" typeface="Arial"/>
+        <a:font script="Uigh" typeface="Microsoft Uighur"/>
+        <a:font script="Geor" typeface="Sylfaen"/>
+      </a:minorFont>
+    </a:fontScheme>
+    <a:fmtScheme name="Office">
+      <a:fillStyleLst>
+        <a:solidFill>
+          <a:schemeClr val="phClr"/>
+        </a:solidFill>
+        <a:gradFill rotWithShape="1">
+          <a:gsLst>
+            <a:gs pos="0">
+              <a:schemeClr val="phClr">
+                <a:tint val="50000"/>
+                <a:satMod val="300000"/>
+              </a:schemeClr>
+            </a:gs>
+            <a:gs pos="35000">
+              <a:schemeClr val="phClr">
+                <a:tint val="37000"/>
+                <a:satMod val="300000"/>
+              </a:schemeClr>
+            </a:gs>
+            <a:gs pos="100000">
+              <a:schemeClr val="phClr">
+                <a:tint val="15000"/>
+                <a:satMod val="350000"/>
+              </a:schemeClr>
+            </a:gs>
+          </a:gsLst>
+          <a:lin ang="16200000" scaled="1"/>
+        </a:gradFill>
+        <a:gradFill rotWithShape="1">
+          <a:gsLst>
+            <a:gs pos="0">
+              <a:schemeClr val="phClr">
+                <a:tint val="100000"/>
+                <a:shade val="100000"/>
+                <a:satMod val="130000"/>
+              </a:schemeClr>
+            </a:gs>
+            <a:gs pos="100000">
+              <a:schemeClr val="phClr">
+                <a:tint val="50000"/>
+                <a:shade val="100000"/>
+                <a:satMod val="350000"/>
+              </a:schemeClr>
+            </a:gs>
+          </a:gsLst>
+          <a:lin ang="16200000" scaled="0"/>
+        </a:gradFill>
+      </a:fillStyleLst>
+      <a:lnStyleLst>
+        <a:ln w="9525" cap="flat" cmpd="sng" algn="ctr">
+          <a:solidFill>
+            <a:schemeClr val="phClr">
+              <a:shade val="95000"/>
+              <a:satMod val="105000"/>
+            </a:schemeClr>
+          </a:solidFill>
+          <a:prstDash val="solid"/>
+        </a:ln>
+        <a:ln w="25400" cap="flat" cmpd="sng" algn="ctr">
+          <a:solidFill>
+            <a:schemeClr val="phClr"/>
+          </a:solidFill>
+          <a:prstDash val="solid"/>
+        </a:ln>
+        <a:ln w="38100" cap="flat" cmpd="sng" algn="ctr">
+          <a:solidFill>
+            <a:schemeClr val="phClr"/>
+          </a:solidFill>
+          <a:prstDash val="solid"/>
+        </a:ln>
+      </a:lnStyleLst>
+      <a:effectStyleLst>
+        <a:effectStyle>
+          <a:effectLst>
+            <a:outerShdw blurRad="40000" dist="20000" dir="5400000" rotWithShape="0">
+              <a:srgbClr val="000000">
+                <a:alpha val="38000"/>
+              </a:srgbClr>
+            </a:outerShdw>
+          </a:effectLst>
+        </a:effectStyle>
+        <a:effectStyle>
+          <a:effectLst>
+            <a:outerShdw blurRad="40000" dist="23000" dir="5400000" rotWithShape="0">
+              <a:srgbClr val="000000">
+                <a:alpha val="35000"/>
+              </a:srgbClr>
+            </a:outerShdw>
+          </a:effectLst>
+        </a:effectStyle>
+        <a:effectStyle>
+          <a:effectLst>
+            <a:outerShdw blurRad="40000" dist="23000" dir="5400000" rotWithShape="0">
+              <a:srgbClr val="000000">
+                <a:alpha val="35000"/>
+              </a:srgbClr>
+            </a:outerShdw>
+          </a:effectLst>
+          <a:scene3d>
+            <a:camera prst="orthographicFront">
+              <a:rot lat="0" lon="0" rev="0"/>
+            </a:camera>
+            <a:lightRig rig="threePt" dir="t">
+              <a:rot lat="0" lon="0" rev="1200000"/>
+            </a:lightRig>
+          </a:scene3d>
+          <a:sp3d>
+            <a:bevelT w="63500" h="25400"/>
+          </a:sp3d>
+        </a:effectStyle>
+      </a:effectStyleLst>
+      <a:bgFillStyleLst>
+        <a:solidFill>
+          <a:schemeClr val="phClr"/>
+        </a:solidFill>
+        <a:gradFill rotWithShape="1">
+          <a:gsLst>
+            <a:gs pos="0">
+              <a:schemeClr val="phClr">
+                <a:tint val="40000"/>
+                <a:satMod val="350000"/>
+              </a:schemeClr>
+            </a:gs>
+            <a:gs pos="40000">
+              <a:schemeClr val="phClr">
+                <a:tint val="45000"/>
+                <a:shade val="99000"/>
+                <a:satMod val="350000"/>
+              </a:schemeClr>
+            </a:gs>
+            <a:gs pos="100000">
+              <a:schemeClr val="phClr">
+                <a:shade val="20000"/>
+                <a:satMod val="255000"/>
+              </a:schemeClr>
+            </a:gs>
+          </a:gsLst>
+          <a:path path="circle">
+            <a:fillToRect l="50000" t="-80000" r="50000" b="180000"/>
+          </a:path>
+        </a:gradFill>
+        <a:gradFill rotWithShape="1">
+          <a:gsLst>
+            <a:gs pos="0">
+              <a:schemeClr val="phClr">
+                <a:tint val="80000"/>
+                <a:satMod val="300000"/>
+              </a:schemeClr>
+            </a:gs>
+            <a:gs pos="100000">
+              <a:schemeClr val="phClr">
+                <a:shade val="30000"/>
+                <a:satMod val="200000"/>
+              </a:schemeClr>
+            </a:gs>
+          </a:gsLst>
+          <a:path path="circle">
+            <a:fillToRect l="50000" t="50000" r="50000" b="50000"/>
+          </a:path>
+        </a:gradFill>
+      </a:bgFillStyleLst>
+    </a:fmtScheme>
+  </a:themeElements>
+</a:theme>
+</file>
+
+<file path=ppt/theme/theme3.xml><?xml version="1.0" encoding="utf-8"?>
 <a:theme xmlns:a="http://schemas.openxmlformats.org/drawingml/2006/main" xmlns:r="http://schemas.openxmlformats.org/officeDocument/2006/relationships" name="Simple Light">
   <a:themeElements>
     <a:clrScheme name="Simple Light">
@@ -34557,283 +34836,4 @@
     </a:fmtScheme>
   </a:themeElements>
 </a:theme>
-</file>
-
-<file path=ppt/theme/theme3.xml><?xml version="1.0" encoding="utf-8"?>
-<a:theme xmlns:a="http://schemas.openxmlformats.org/drawingml/2006/main" xmlns:r="http://schemas.openxmlformats.org/officeDocument/2006/relationships" name="LF Energy Theme 2023">
-  <a:themeElements>
-    <a:clrScheme name="Geometric">
-      <a:dk1>
-        <a:srgbClr val="222222"/>
-      </a:dk1>
-      <a:lt1>
-        <a:srgbClr val="FFFFFF"/>
-      </a:lt1>
-      <a:dk2>
-        <a:srgbClr val="434343"/>
-      </a:dk2>
-      <a:lt2>
-        <a:srgbClr val="999999"/>
-      </a:lt2>
-      <a:accent1>
-        <a:srgbClr val="003778"/>
-      </a:accent1>
-      <a:accent2>
-        <a:srgbClr val="0094FF"/>
-      </a:accent2>
-      <a:accent3>
-        <a:srgbClr val="5B1DE7"/>
-      </a:accent3>
-      <a:accent4>
-        <a:srgbClr val="12E2E2"/>
-      </a:accent4>
-      <a:accent5>
-        <a:srgbClr val="FF00AA"/>
-      </a:accent5>
-      <a:accent6>
-        <a:srgbClr val="ACDE1F"/>
-      </a:accent6>
-      <a:hlink>
-        <a:srgbClr val="0077CC"/>
-      </a:hlink>
-      <a:folHlink>
-        <a:srgbClr val="F06292"/>
-      </a:folHlink>
-    </a:clrScheme>
-    <a:fontScheme name="Office">
-      <a:majorFont>
-        <a:latin typeface="Arial"/>
-        <a:ea typeface=""/>
-        <a:cs typeface=""/>
-        <a:font script="Jpan" typeface="ＭＳ Ｐゴシック"/>
-        <a:font script="Hang" typeface="맑은 고딕"/>
-        <a:font script="Hans" typeface="宋体"/>
-        <a:font script="Hant" typeface="新細明體"/>
-        <a:font script="Arab" typeface="Times New Roman"/>
-        <a:font script="Hebr" typeface="Times New Roman"/>
-        <a:font script="Thai" typeface="Angsana New"/>
-        <a:font script="Ethi" typeface="Nyala"/>
-        <a:font script="Beng" typeface="Vrinda"/>
-        <a:font script="Gujr" typeface="Shruti"/>
-        <a:font script="Khmr" typeface="MoolBoran"/>
-        <a:font script="Knda" typeface="Tunga"/>
-        <a:font script="Guru" typeface="Raavi"/>
-        <a:font script="Cans" typeface="Euphemia"/>
-        <a:font script="Cher" typeface="Plantagenet Cherokee"/>
-        <a:font script="Yiii" typeface="Microsoft Yi Baiti"/>
-        <a:font script="Tibt" typeface="Microsoft Himalaya"/>
-        <a:font script="Thaa" typeface="MV Boli"/>
-        <a:font script="Deva" typeface="Mangal"/>
-        <a:font script="Telu" typeface="Gautami"/>
-        <a:font script="Taml" typeface="Latha"/>
-        <a:font script="Syrc" typeface="Estrangelo Edessa"/>
-        <a:font script="Orya" typeface="Kalinga"/>
-        <a:font script="Mlym" typeface="Kartika"/>
-        <a:font script="Laoo" typeface="DokChampa"/>
-        <a:font script="Sinh" typeface="Iskoola Pota"/>
-        <a:font script="Mong" typeface="Mongolian Baiti"/>
-        <a:font script="Viet" typeface="Times New Roman"/>
-        <a:font script="Uigh" typeface="Microsoft Uighur"/>
-        <a:font script="Geor" typeface="Sylfaen"/>
-      </a:majorFont>
-      <a:minorFont>
-        <a:latin typeface="Arial"/>
-        <a:ea typeface=""/>
-        <a:cs typeface=""/>
-        <a:font script="Jpan" typeface="ＭＳ Ｐゴシック"/>
-        <a:font script="Hang" typeface="맑은 고딕"/>
-        <a:font script="Hans" typeface="宋体"/>
-        <a:font script="Hant" typeface="新細明體"/>
-        <a:font script="Arab" typeface="Arial"/>
-        <a:font script="Hebr" typeface="Arial"/>
-        <a:font script="Thai" typeface="Cordia New"/>
-        <a:font script="Ethi" typeface="Nyala"/>
-        <a:font script="Beng" typeface="Vrinda"/>
-        <a:font script="Gujr" typeface="Shruti"/>
-        <a:font script="Khmr" typeface="DaunPenh"/>
-        <a:font script="Knda" typeface="Tunga"/>
-        <a:font script="Guru" typeface="Raavi"/>
-        <a:font script="Cans" typeface="Euphemia"/>
-        <a:font script="Cher" typeface="Plantagenet Cherokee"/>
-        <a:font script="Yiii" typeface="Microsoft Yi Baiti"/>
-        <a:font script="Tibt" typeface="Microsoft Himalaya"/>
-        <a:font script="Thaa" typeface="MV Boli"/>
-        <a:font script="Deva" typeface="Mangal"/>
-        <a:font script="Telu" typeface="Gautami"/>
-        <a:font script="Taml" typeface="Latha"/>
-        <a:font script="Syrc" typeface="Estrangelo Edessa"/>
-        <a:font script="Orya" typeface="Kalinga"/>
-        <a:font script="Mlym" typeface="Kartika"/>
-        <a:font script="Laoo" typeface="DokChampa"/>
-        <a:font script="Sinh" typeface="Iskoola Pota"/>
-        <a:font script="Mong" typeface="Mongolian Baiti"/>
-        <a:font script="Viet" typeface="Arial"/>
-        <a:font script="Uigh" typeface="Microsoft Uighur"/>
-        <a:font script="Geor" typeface="Sylfaen"/>
-      </a:minorFont>
-    </a:fontScheme>
-    <a:fmtScheme name="Office">
-      <a:fillStyleLst>
-        <a:solidFill>
-          <a:schemeClr val="phClr"/>
-        </a:solidFill>
-        <a:gradFill rotWithShape="1">
-          <a:gsLst>
-            <a:gs pos="0">
-              <a:schemeClr val="phClr">
-                <a:tint val="50000"/>
-                <a:satMod val="300000"/>
-              </a:schemeClr>
-            </a:gs>
-            <a:gs pos="35000">
-              <a:schemeClr val="phClr">
-                <a:tint val="37000"/>
-                <a:satMod val="300000"/>
-              </a:schemeClr>
-            </a:gs>
-            <a:gs pos="100000">
-              <a:schemeClr val="phClr">
-                <a:tint val="15000"/>
-                <a:satMod val="350000"/>
-              </a:schemeClr>
-            </a:gs>
-          </a:gsLst>
-          <a:lin ang="16200000" scaled="1"/>
-        </a:gradFill>
-        <a:gradFill rotWithShape="1">
-          <a:gsLst>
-            <a:gs pos="0">
-              <a:schemeClr val="phClr">
-                <a:tint val="100000"/>
-                <a:shade val="100000"/>
-                <a:satMod val="130000"/>
-              </a:schemeClr>
-            </a:gs>
-            <a:gs pos="100000">
-              <a:schemeClr val="phClr">
-                <a:tint val="50000"/>
-                <a:shade val="100000"/>
-                <a:satMod val="350000"/>
-              </a:schemeClr>
-            </a:gs>
-          </a:gsLst>
-          <a:lin ang="16200000" scaled="0"/>
-        </a:gradFill>
-      </a:fillStyleLst>
-      <a:lnStyleLst>
-        <a:ln w="9525" cap="flat" cmpd="sng" algn="ctr">
-          <a:solidFill>
-            <a:schemeClr val="phClr">
-              <a:shade val="95000"/>
-              <a:satMod val="105000"/>
-            </a:schemeClr>
-          </a:solidFill>
-          <a:prstDash val="solid"/>
-        </a:ln>
-        <a:ln w="25400" cap="flat" cmpd="sng" algn="ctr">
-          <a:solidFill>
-            <a:schemeClr val="phClr"/>
-          </a:solidFill>
-          <a:prstDash val="solid"/>
-        </a:ln>
-        <a:ln w="38100" cap="flat" cmpd="sng" algn="ctr">
-          <a:solidFill>
-            <a:schemeClr val="phClr"/>
-          </a:solidFill>
-          <a:prstDash val="solid"/>
-        </a:ln>
-      </a:lnStyleLst>
-      <a:effectStyleLst>
-        <a:effectStyle>
-          <a:effectLst>
-            <a:outerShdw blurRad="40000" dist="20000" dir="5400000" rotWithShape="0">
-              <a:srgbClr val="000000">
-                <a:alpha val="38000"/>
-              </a:srgbClr>
-            </a:outerShdw>
-          </a:effectLst>
-        </a:effectStyle>
-        <a:effectStyle>
-          <a:effectLst>
-            <a:outerShdw blurRad="40000" dist="23000" dir="5400000" rotWithShape="0">
-              <a:srgbClr val="000000">
-                <a:alpha val="35000"/>
-              </a:srgbClr>
-            </a:outerShdw>
-          </a:effectLst>
-        </a:effectStyle>
-        <a:effectStyle>
-          <a:effectLst>
-            <a:outerShdw blurRad="40000" dist="23000" dir="5400000" rotWithShape="0">
-              <a:srgbClr val="000000">
-                <a:alpha val="35000"/>
-              </a:srgbClr>
-            </a:outerShdw>
-          </a:effectLst>
-          <a:scene3d>
-            <a:camera prst="orthographicFront">
-              <a:rot lat="0" lon="0" rev="0"/>
-            </a:camera>
-            <a:lightRig rig="threePt" dir="t">
-              <a:rot lat="0" lon="0" rev="1200000"/>
-            </a:lightRig>
-          </a:scene3d>
-          <a:sp3d>
-            <a:bevelT w="63500" h="25400"/>
-          </a:sp3d>
-        </a:effectStyle>
-      </a:effectStyleLst>
-      <a:bgFillStyleLst>
-        <a:solidFill>
-          <a:schemeClr val="phClr"/>
-        </a:solidFill>
-        <a:gradFill rotWithShape="1">
-          <a:gsLst>
-            <a:gs pos="0">
-              <a:schemeClr val="phClr">
-                <a:tint val="40000"/>
-                <a:satMod val="350000"/>
-              </a:schemeClr>
-            </a:gs>
-            <a:gs pos="40000">
-              <a:schemeClr val="phClr">
-                <a:tint val="45000"/>
-                <a:shade val="99000"/>
-                <a:satMod val="350000"/>
-              </a:schemeClr>
-            </a:gs>
-            <a:gs pos="100000">
-              <a:schemeClr val="phClr">
-                <a:shade val="20000"/>
-                <a:satMod val="255000"/>
-              </a:schemeClr>
-            </a:gs>
-          </a:gsLst>
-          <a:path path="circle">
-            <a:fillToRect l="50000" t="-80000" r="50000" b="180000"/>
-          </a:path>
-        </a:gradFill>
-        <a:gradFill rotWithShape="1">
-          <a:gsLst>
-            <a:gs pos="0">
-              <a:schemeClr val="phClr">
-                <a:tint val="80000"/>
-                <a:satMod val="300000"/>
-              </a:schemeClr>
-            </a:gs>
-            <a:gs pos="100000">
-              <a:schemeClr val="phClr">
-                <a:shade val="30000"/>
-                <a:satMod val="200000"/>
-              </a:schemeClr>
-            </a:gs>
-          </a:gsLst>
-          <a:path path="circle">
-            <a:fillToRect l="50000" t="50000" r="50000" b="50000"/>
-          </a:path>
-        </a:gradFill>
-      </a:bgFillStyleLst>
-    </a:fmtScheme>
-  </a:themeElements>
-</a:theme>
 </file>
</xml_diff>

<commit_message>
Update Data Sources from LFX 2026-09-24 (#321)
Update Data Sources from LFX

Signed-off-by: github-actions[bot] <41898282+github-actions[bot]@users.noreply.github.com>
Co-authored-by: jmertic <296737+jmertic@users.noreply.github.com>
</commit_message>
<xml_diff>
--- a/overview_deck/LF Energy High Level Overview.pptx
+++ b/overview_deck/LF Energy High Level Overview.pptx
@@ -25946,7 +25946,7 @@
             <a:tbl>
               <a:tblPr>
                 <a:noFill/>
-                <a:tableStyleId>{ACEB87D9-4107-43B8-90F2-9AF94FFA6626}</a:tableStyleId>
+                <a:tableStyleId>{46FB34A5-4B60-4FBC-8409-2246B4C90E89}</a:tableStyleId>
               </a:tblPr>
               <a:tblGrid>
                 <a:gridCol w="1695200"/>
@@ -26736,7 +26736,7 @@
             <a:tbl>
               <a:tblPr>
                 <a:noFill/>
-                <a:tableStyleId>{ACEB87D9-4107-43B8-90F2-9AF94FFA6626}</a:tableStyleId>
+                <a:tableStyleId>{46FB34A5-4B60-4FBC-8409-2246B4C90E89}</a:tableStyleId>
               </a:tblPr>
               <a:tblGrid>
                 <a:gridCol w="1695200"/>
@@ -27426,7 +27426,7 @@
             <a:tbl>
               <a:tblPr>
                 <a:noFill/>
-                <a:tableStyleId>{ACEB87D9-4107-43B8-90F2-9AF94FFA6626}</a:tableStyleId>
+                <a:tableStyleId>{46FB34A5-4B60-4FBC-8409-2246B4C90E89}</a:tableStyleId>
               </a:tblPr>
               <a:tblGrid>
                 <a:gridCol w="1695200"/>
@@ -28678,7 +28678,7 @@
             <a:tbl>
               <a:tblPr>
                 <a:noFill/>
-                <a:tableStyleId>{ACEB87D9-4107-43B8-90F2-9AF94FFA6626}</a:tableStyleId>
+                <a:tableStyleId>{46FB34A5-4B60-4FBC-8409-2246B4C90E89}</a:tableStyleId>
               </a:tblPr>
               <a:tblGrid>
                 <a:gridCol w="1695200"/>
@@ -29670,7 +29670,7 @@
             <a:tbl>
               <a:tblPr>
                 <a:noFill/>
-                <a:tableStyleId>{ACEB87D9-4107-43B8-90F2-9AF94FFA6626}</a:tableStyleId>
+                <a:tableStyleId>{46FB34A5-4B60-4FBC-8409-2246B4C90E89}</a:tableStyleId>
               </a:tblPr>
               <a:tblGrid>
                 <a:gridCol w="3048000"/>
@@ -33175,7 +33175,7 @@
             <a:tbl>
               <a:tblPr>
                 <a:noFill/>
-                <a:tableStyleId>{ACEB87D9-4107-43B8-90F2-9AF94FFA6626}</a:tableStyleId>
+                <a:tableStyleId>{46FB34A5-4B60-4FBC-8409-2246B4C90E89}</a:tableStyleId>
               </a:tblPr>
               <a:tblGrid>
                 <a:gridCol w="1828800"/>
@@ -34002,285 +34002,6 @@
 </file>
 
 <file path=ppt/theme/theme1.xml><?xml version="1.0" encoding="utf-8"?>
-<a:theme xmlns:a="http://schemas.openxmlformats.org/drawingml/2006/main" xmlns:r="http://schemas.openxmlformats.org/officeDocument/2006/relationships">
-  <a:themeElements>
-    <a:clrScheme name="Default">
-      <a:dk1>
-        <a:srgbClr val="000000"/>
-      </a:dk1>
-      <a:lt1>
-        <a:srgbClr val="FFFFFF"/>
-      </a:lt1>
-      <a:dk2>
-        <a:srgbClr val="158158"/>
-      </a:dk2>
-      <a:lt2>
-        <a:srgbClr val="F3F3F3"/>
-      </a:lt2>
-      <a:accent1>
-        <a:srgbClr val="058DC7"/>
-      </a:accent1>
-      <a:accent2>
-        <a:srgbClr val="50B432"/>
-      </a:accent2>
-      <a:accent3>
-        <a:srgbClr val="ED561B"/>
-      </a:accent3>
-      <a:accent4>
-        <a:srgbClr val="EDEF00"/>
-      </a:accent4>
-      <a:accent5>
-        <a:srgbClr val="24CBE5"/>
-      </a:accent5>
-      <a:accent6>
-        <a:srgbClr val="64E572"/>
-      </a:accent6>
-      <a:hlink>
-        <a:srgbClr val="2200CC"/>
-      </a:hlink>
-      <a:folHlink>
-        <a:srgbClr val="551A8B"/>
-      </a:folHlink>
-    </a:clrScheme>
-    <a:fontScheme name="Office">
-      <a:majorFont>
-        <a:latin typeface="Arial"/>
-        <a:ea typeface=""/>
-        <a:cs typeface=""/>
-        <a:font script="Jpan" typeface="ＭＳ Ｐゴシック"/>
-        <a:font script="Hang" typeface="맑은 고딕"/>
-        <a:font script="Hans" typeface="宋体"/>
-        <a:font script="Hant" typeface="新細明體"/>
-        <a:font script="Arab" typeface="Times New Roman"/>
-        <a:font script="Hebr" typeface="Times New Roman"/>
-        <a:font script="Thai" typeface="Angsana New"/>
-        <a:font script="Ethi" typeface="Nyala"/>
-        <a:font script="Beng" typeface="Vrinda"/>
-        <a:font script="Gujr" typeface="Shruti"/>
-        <a:font script="Khmr" typeface="MoolBoran"/>
-        <a:font script="Knda" typeface="Tunga"/>
-        <a:font script="Guru" typeface="Raavi"/>
-        <a:font script="Cans" typeface="Euphemia"/>
-        <a:font script="Cher" typeface="Plantagenet Cherokee"/>
-        <a:font script="Yiii" typeface="Microsoft Yi Baiti"/>
-        <a:font script="Tibt" typeface="Microsoft Himalaya"/>
-        <a:font script="Thaa" typeface="MV Boli"/>
-        <a:font script="Deva" typeface="Mangal"/>
-        <a:font script="Telu" typeface="Gautami"/>
-        <a:font script="Taml" typeface="Latha"/>
-        <a:font script="Syrc" typeface="Estrangelo Edessa"/>
-        <a:font script="Orya" typeface="Kalinga"/>
-        <a:font script="Mlym" typeface="Kartika"/>
-        <a:font script="Laoo" typeface="DokChampa"/>
-        <a:font script="Sinh" typeface="Iskoola Pota"/>
-        <a:font script="Mong" typeface="Mongolian Baiti"/>
-        <a:font script="Viet" typeface="Times New Roman"/>
-        <a:font script="Uigh" typeface="Microsoft Uighur"/>
-        <a:font script="Geor" typeface="Sylfaen"/>
-      </a:majorFont>
-      <a:minorFont>
-        <a:latin typeface="Arial"/>
-        <a:ea typeface=""/>
-        <a:cs typeface=""/>
-        <a:font script="Jpan" typeface="ＭＳ Ｐゴシック"/>
-        <a:font script="Hang" typeface="맑은 고딕"/>
-        <a:font script="Hans" typeface="宋体"/>
-        <a:font script="Hant" typeface="新細明體"/>
-        <a:font script="Arab" typeface="Arial"/>
-        <a:font script="Hebr" typeface="Arial"/>
-        <a:font script="Thai" typeface="Cordia New"/>
-        <a:font script="Ethi" typeface="Nyala"/>
-        <a:font script="Beng" typeface="Vrinda"/>
-        <a:font script="Gujr" typeface="Shruti"/>
-        <a:font script="Khmr" typeface="DaunPenh"/>
-        <a:font script="Knda" typeface="Tunga"/>
-        <a:font script="Guru" typeface="Raavi"/>
-        <a:font script="Cans" typeface="Euphemia"/>
-        <a:font script="Cher" typeface="Plantagenet Cherokee"/>
-        <a:font script="Yiii" typeface="Microsoft Yi Baiti"/>
-        <a:font script="Tibt" typeface="Microsoft Himalaya"/>
-        <a:font script="Thaa" typeface="MV Boli"/>
-        <a:font script="Deva" typeface="Mangal"/>
-        <a:font script="Telu" typeface="Gautami"/>
-        <a:font script="Taml" typeface="Latha"/>
-        <a:font script="Syrc" typeface="Estrangelo Edessa"/>
-        <a:font script="Orya" typeface="Kalinga"/>
-        <a:font script="Mlym" typeface="Kartika"/>
-        <a:font script="Laoo" typeface="DokChampa"/>
-        <a:font script="Sinh" typeface="Iskoola Pota"/>
-        <a:font script="Mong" typeface="Mongolian Baiti"/>
-        <a:font script="Viet" typeface="Arial"/>
-        <a:font script="Uigh" typeface="Microsoft Uighur"/>
-        <a:font script="Geor" typeface="Sylfaen"/>
-      </a:minorFont>
-    </a:fontScheme>
-    <a:fmtScheme name="Office">
-      <a:fillStyleLst>
-        <a:solidFill>
-          <a:schemeClr val="phClr"/>
-        </a:solidFill>
-        <a:gradFill rotWithShape="1">
-          <a:gsLst>
-            <a:gs pos="0">
-              <a:schemeClr val="phClr">
-                <a:tint val="50000"/>
-                <a:satMod val="300000"/>
-              </a:schemeClr>
-            </a:gs>
-            <a:gs pos="35000">
-              <a:schemeClr val="phClr">
-                <a:tint val="37000"/>
-                <a:satMod val="300000"/>
-              </a:schemeClr>
-            </a:gs>
-            <a:gs pos="100000">
-              <a:schemeClr val="phClr">
-                <a:tint val="15000"/>
-                <a:satMod val="350000"/>
-              </a:schemeClr>
-            </a:gs>
-          </a:gsLst>
-          <a:lin ang="16200000" scaled="1"/>
-        </a:gradFill>
-        <a:gradFill rotWithShape="1">
-          <a:gsLst>
-            <a:gs pos="0">
-              <a:schemeClr val="phClr">
-                <a:tint val="100000"/>
-                <a:shade val="100000"/>
-                <a:satMod val="130000"/>
-              </a:schemeClr>
-            </a:gs>
-            <a:gs pos="100000">
-              <a:schemeClr val="phClr">
-                <a:tint val="50000"/>
-                <a:shade val="100000"/>
-                <a:satMod val="350000"/>
-              </a:schemeClr>
-            </a:gs>
-          </a:gsLst>
-          <a:lin ang="16200000" scaled="0"/>
-        </a:gradFill>
-      </a:fillStyleLst>
-      <a:lnStyleLst>
-        <a:ln w="9525" cap="flat" cmpd="sng" algn="ctr">
-          <a:solidFill>
-            <a:schemeClr val="phClr">
-              <a:shade val="95000"/>
-              <a:satMod val="105000"/>
-            </a:schemeClr>
-          </a:solidFill>
-          <a:prstDash val="solid"/>
-        </a:ln>
-        <a:ln w="25400" cap="flat" cmpd="sng" algn="ctr">
-          <a:solidFill>
-            <a:schemeClr val="phClr"/>
-          </a:solidFill>
-          <a:prstDash val="solid"/>
-        </a:ln>
-        <a:ln w="38100" cap="flat" cmpd="sng" algn="ctr">
-          <a:solidFill>
-            <a:schemeClr val="phClr"/>
-          </a:solidFill>
-          <a:prstDash val="solid"/>
-        </a:ln>
-      </a:lnStyleLst>
-      <a:effectStyleLst>
-        <a:effectStyle>
-          <a:effectLst>
-            <a:outerShdw blurRad="40000" dist="20000" dir="5400000" rotWithShape="0">
-              <a:srgbClr val="000000">
-                <a:alpha val="38000"/>
-              </a:srgbClr>
-            </a:outerShdw>
-          </a:effectLst>
-        </a:effectStyle>
-        <a:effectStyle>
-          <a:effectLst>
-            <a:outerShdw blurRad="40000" dist="23000" dir="5400000" rotWithShape="0">
-              <a:srgbClr val="000000">
-                <a:alpha val="35000"/>
-              </a:srgbClr>
-            </a:outerShdw>
-          </a:effectLst>
-        </a:effectStyle>
-        <a:effectStyle>
-          <a:effectLst>
-            <a:outerShdw blurRad="40000" dist="23000" dir="5400000" rotWithShape="0">
-              <a:srgbClr val="000000">
-                <a:alpha val="35000"/>
-              </a:srgbClr>
-            </a:outerShdw>
-          </a:effectLst>
-          <a:scene3d>
-            <a:camera prst="orthographicFront">
-              <a:rot lat="0" lon="0" rev="0"/>
-            </a:camera>
-            <a:lightRig rig="threePt" dir="t">
-              <a:rot lat="0" lon="0" rev="1200000"/>
-            </a:lightRig>
-          </a:scene3d>
-          <a:sp3d>
-            <a:bevelT w="63500" h="25400"/>
-          </a:sp3d>
-        </a:effectStyle>
-      </a:effectStyleLst>
-      <a:bgFillStyleLst>
-        <a:solidFill>
-          <a:schemeClr val="phClr"/>
-        </a:solidFill>
-        <a:gradFill rotWithShape="1">
-          <a:gsLst>
-            <a:gs pos="0">
-              <a:schemeClr val="phClr">
-                <a:tint val="40000"/>
-                <a:satMod val="350000"/>
-              </a:schemeClr>
-            </a:gs>
-            <a:gs pos="40000">
-              <a:schemeClr val="phClr">
-                <a:tint val="45000"/>
-                <a:shade val="99000"/>
-                <a:satMod val="350000"/>
-              </a:schemeClr>
-            </a:gs>
-            <a:gs pos="100000">
-              <a:schemeClr val="phClr">
-                <a:shade val="20000"/>
-                <a:satMod val="255000"/>
-              </a:schemeClr>
-            </a:gs>
-          </a:gsLst>
-          <a:path path="circle">
-            <a:fillToRect l="50000" t="-80000" r="50000" b="180000"/>
-          </a:path>
-        </a:gradFill>
-        <a:gradFill rotWithShape="1">
-          <a:gsLst>
-            <a:gs pos="0">
-              <a:schemeClr val="phClr">
-                <a:tint val="80000"/>
-                <a:satMod val="300000"/>
-              </a:schemeClr>
-            </a:gs>
-            <a:gs pos="100000">
-              <a:schemeClr val="phClr">
-                <a:shade val="30000"/>
-                <a:satMod val="200000"/>
-              </a:schemeClr>
-            </a:gs>
-          </a:gsLst>
-          <a:path path="circle">
-            <a:fillToRect l="50000" t="50000" r="50000" b="50000"/>
-          </a:path>
-        </a:gradFill>
-      </a:bgFillStyleLst>
-    </a:fmtScheme>
-  </a:themeElements>
-</a:theme>
-</file>
-
-<file path=ppt/theme/theme2.xml><?xml version="1.0" encoding="utf-8"?>
 <a:theme xmlns:a="http://schemas.openxmlformats.org/drawingml/2006/main" xmlns:r="http://schemas.openxmlformats.org/officeDocument/2006/relationships" name="LF Energy Theme 2023">
   <a:themeElements>
     <a:clrScheme name="Geometric">
@@ -34559,7 +34280,7 @@
 </a:theme>
 </file>
 
-<file path=ppt/theme/theme3.xml><?xml version="1.0" encoding="utf-8"?>
+<file path=ppt/theme/theme2.xml><?xml version="1.0" encoding="utf-8"?>
 <a:theme xmlns:a="http://schemas.openxmlformats.org/drawingml/2006/main" xmlns:r="http://schemas.openxmlformats.org/officeDocument/2006/relationships" name="Simple Light">
   <a:themeElements>
     <a:clrScheme name="Simple Light">
@@ -34836,4 +34557,283 @@
     </a:fmtScheme>
   </a:themeElements>
 </a:theme>
+</file>
+
+<file path=ppt/theme/theme3.xml><?xml version="1.0" encoding="utf-8"?>
+<a:theme xmlns:a="http://schemas.openxmlformats.org/drawingml/2006/main" xmlns:r="http://schemas.openxmlformats.org/officeDocument/2006/relationships">
+  <a:themeElements>
+    <a:clrScheme name="Default">
+      <a:dk1>
+        <a:srgbClr val="000000"/>
+      </a:dk1>
+      <a:lt1>
+        <a:srgbClr val="FFFFFF"/>
+      </a:lt1>
+      <a:dk2>
+        <a:srgbClr val="158158"/>
+      </a:dk2>
+      <a:lt2>
+        <a:srgbClr val="F3F3F3"/>
+      </a:lt2>
+      <a:accent1>
+        <a:srgbClr val="058DC7"/>
+      </a:accent1>
+      <a:accent2>
+        <a:srgbClr val="50B432"/>
+      </a:accent2>
+      <a:accent3>
+        <a:srgbClr val="ED561B"/>
+      </a:accent3>
+      <a:accent4>
+        <a:srgbClr val="EDEF00"/>
+      </a:accent4>
+      <a:accent5>
+        <a:srgbClr val="24CBE5"/>
+      </a:accent5>
+      <a:accent6>
+        <a:srgbClr val="64E572"/>
+      </a:accent6>
+      <a:hlink>
+        <a:srgbClr val="2200CC"/>
+      </a:hlink>
+      <a:folHlink>
+        <a:srgbClr val="551A8B"/>
+      </a:folHlink>
+    </a:clrScheme>
+    <a:fontScheme name="Office">
+      <a:majorFont>
+        <a:latin typeface="Arial"/>
+        <a:ea typeface=""/>
+        <a:cs typeface=""/>
+        <a:font script="Jpan" typeface="ＭＳ Ｐゴシック"/>
+        <a:font script="Hang" typeface="맑은 고딕"/>
+        <a:font script="Hans" typeface="宋体"/>
+        <a:font script="Hant" typeface="新細明體"/>
+        <a:font script="Arab" typeface="Times New Roman"/>
+        <a:font script="Hebr" typeface="Times New Roman"/>
+        <a:font script="Thai" typeface="Angsana New"/>
+        <a:font script="Ethi" typeface="Nyala"/>
+        <a:font script="Beng" typeface="Vrinda"/>
+        <a:font script="Gujr" typeface="Shruti"/>
+        <a:font script="Khmr" typeface="MoolBoran"/>
+        <a:font script="Knda" typeface="Tunga"/>
+        <a:font script="Guru" typeface="Raavi"/>
+        <a:font script="Cans" typeface="Euphemia"/>
+        <a:font script="Cher" typeface="Plantagenet Cherokee"/>
+        <a:font script="Yiii" typeface="Microsoft Yi Baiti"/>
+        <a:font script="Tibt" typeface="Microsoft Himalaya"/>
+        <a:font script="Thaa" typeface="MV Boli"/>
+        <a:font script="Deva" typeface="Mangal"/>
+        <a:font script="Telu" typeface="Gautami"/>
+        <a:font script="Taml" typeface="Latha"/>
+        <a:font script="Syrc" typeface="Estrangelo Edessa"/>
+        <a:font script="Orya" typeface="Kalinga"/>
+        <a:font script="Mlym" typeface="Kartika"/>
+        <a:font script="Laoo" typeface="DokChampa"/>
+        <a:font script="Sinh" typeface="Iskoola Pota"/>
+        <a:font script="Mong" typeface="Mongolian Baiti"/>
+        <a:font script="Viet" typeface="Times New Roman"/>
+        <a:font script="Uigh" typeface="Microsoft Uighur"/>
+        <a:font script="Geor" typeface="Sylfaen"/>
+      </a:majorFont>
+      <a:minorFont>
+        <a:latin typeface="Arial"/>
+        <a:ea typeface=""/>
+        <a:cs typeface=""/>
+        <a:font script="Jpan" typeface="ＭＳ Ｐゴシック"/>
+        <a:font script="Hang" typeface="맑은 고딕"/>
+        <a:font script="Hans" typeface="宋体"/>
+        <a:font script="Hant" typeface="新細明體"/>
+        <a:font script="Arab" typeface="Arial"/>
+        <a:font script="Hebr" typeface="Arial"/>
+        <a:font script="Thai" typeface="Cordia New"/>
+        <a:font script="Ethi" typeface="Nyala"/>
+        <a:font script="Beng" typeface="Vrinda"/>
+        <a:font script="Gujr" typeface="Shruti"/>
+        <a:font script="Khmr" typeface="DaunPenh"/>
+        <a:font script="Knda" typeface="Tunga"/>
+        <a:font script="Guru" typeface="Raavi"/>
+        <a:font script="Cans" typeface="Euphemia"/>
+        <a:font script="Cher" typeface="Plantagenet Cherokee"/>
+        <a:font script="Yiii" typeface="Microsoft Yi Baiti"/>
+        <a:font script="Tibt" typeface="Microsoft Himalaya"/>
+        <a:font script="Thaa" typeface="MV Boli"/>
+        <a:font script="Deva" typeface="Mangal"/>
+        <a:font script="Telu" typeface="Gautami"/>
+        <a:font script="Taml" typeface="Latha"/>
+        <a:font script="Syrc" typeface="Estrangelo Edessa"/>
+        <a:font script="Orya" typeface="Kalinga"/>
+        <a:font script="Mlym" typeface="Kartika"/>
+        <a:font script="Laoo" typeface="DokChampa"/>
+        <a:font script="Sinh" typeface="Iskoola Pota"/>
+        <a:font script="Mong" typeface="Mongolian Baiti"/>
+        <a:font script="Viet" typeface="Arial"/>
+        <a:font script="Uigh" typeface="Microsoft Uighur"/>
+        <a:font script="Geor" typeface="Sylfaen"/>
+      </a:minorFont>
+    </a:fontScheme>
+    <a:fmtScheme name="Office">
+      <a:fillStyleLst>
+        <a:solidFill>
+          <a:schemeClr val="phClr"/>
+        </a:solidFill>
+        <a:gradFill rotWithShape="1">
+          <a:gsLst>
+            <a:gs pos="0">
+              <a:schemeClr val="phClr">
+                <a:tint val="50000"/>
+                <a:satMod val="300000"/>
+              </a:schemeClr>
+            </a:gs>
+            <a:gs pos="35000">
+              <a:schemeClr val="phClr">
+                <a:tint val="37000"/>
+                <a:satMod val="300000"/>
+              </a:schemeClr>
+            </a:gs>
+            <a:gs pos="100000">
+              <a:schemeClr val="phClr">
+                <a:tint val="15000"/>
+                <a:satMod val="350000"/>
+              </a:schemeClr>
+            </a:gs>
+          </a:gsLst>
+          <a:lin ang="16200000" scaled="1"/>
+        </a:gradFill>
+        <a:gradFill rotWithShape="1">
+          <a:gsLst>
+            <a:gs pos="0">
+              <a:schemeClr val="phClr">
+                <a:tint val="100000"/>
+                <a:shade val="100000"/>
+                <a:satMod val="130000"/>
+              </a:schemeClr>
+            </a:gs>
+            <a:gs pos="100000">
+              <a:schemeClr val="phClr">
+                <a:tint val="50000"/>
+                <a:shade val="100000"/>
+                <a:satMod val="350000"/>
+              </a:schemeClr>
+            </a:gs>
+          </a:gsLst>
+          <a:lin ang="16200000" scaled="0"/>
+        </a:gradFill>
+      </a:fillStyleLst>
+      <a:lnStyleLst>
+        <a:ln w="9525" cap="flat" cmpd="sng" algn="ctr">
+          <a:solidFill>
+            <a:schemeClr val="phClr">
+              <a:shade val="95000"/>
+              <a:satMod val="105000"/>
+            </a:schemeClr>
+          </a:solidFill>
+          <a:prstDash val="solid"/>
+        </a:ln>
+        <a:ln w="25400" cap="flat" cmpd="sng" algn="ctr">
+          <a:solidFill>
+            <a:schemeClr val="phClr"/>
+          </a:solidFill>
+          <a:prstDash val="solid"/>
+        </a:ln>
+        <a:ln w="38100" cap="flat" cmpd="sng" algn="ctr">
+          <a:solidFill>
+            <a:schemeClr val="phClr"/>
+          </a:solidFill>
+          <a:prstDash val="solid"/>
+        </a:ln>
+      </a:lnStyleLst>
+      <a:effectStyleLst>
+        <a:effectStyle>
+          <a:effectLst>
+            <a:outerShdw blurRad="40000" dist="20000" dir="5400000" rotWithShape="0">
+              <a:srgbClr val="000000">
+                <a:alpha val="38000"/>
+              </a:srgbClr>
+            </a:outerShdw>
+          </a:effectLst>
+        </a:effectStyle>
+        <a:effectStyle>
+          <a:effectLst>
+            <a:outerShdw blurRad="40000" dist="23000" dir="5400000" rotWithShape="0">
+              <a:srgbClr val="000000">
+                <a:alpha val="35000"/>
+              </a:srgbClr>
+            </a:outerShdw>
+          </a:effectLst>
+        </a:effectStyle>
+        <a:effectStyle>
+          <a:effectLst>
+            <a:outerShdw blurRad="40000" dist="23000" dir="5400000" rotWithShape="0">
+              <a:srgbClr val="000000">
+                <a:alpha val="35000"/>
+              </a:srgbClr>
+            </a:outerShdw>
+          </a:effectLst>
+          <a:scene3d>
+            <a:camera prst="orthographicFront">
+              <a:rot lat="0" lon="0" rev="0"/>
+            </a:camera>
+            <a:lightRig rig="threePt" dir="t">
+              <a:rot lat="0" lon="0" rev="1200000"/>
+            </a:lightRig>
+          </a:scene3d>
+          <a:sp3d>
+            <a:bevelT w="63500" h="25400"/>
+          </a:sp3d>
+        </a:effectStyle>
+      </a:effectStyleLst>
+      <a:bgFillStyleLst>
+        <a:solidFill>
+          <a:schemeClr val="phClr"/>
+        </a:solidFill>
+        <a:gradFill rotWithShape="1">
+          <a:gsLst>
+            <a:gs pos="0">
+              <a:schemeClr val="phClr">
+                <a:tint val="40000"/>
+                <a:satMod val="350000"/>
+              </a:schemeClr>
+            </a:gs>
+            <a:gs pos="40000">
+              <a:schemeClr val="phClr">
+                <a:tint val="45000"/>
+                <a:shade val="99000"/>
+                <a:satMod val="350000"/>
+              </a:schemeClr>
+            </a:gs>
+            <a:gs pos="100000">
+              <a:schemeClr val="phClr">
+                <a:shade val="20000"/>
+                <a:satMod val="255000"/>
+              </a:schemeClr>
+            </a:gs>
+          </a:gsLst>
+          <a:path path="circle">
+            <a:fillToRect l="50000" t="-80000" r="50000" b="180000"/>
+          </a:path>
+        </a:gradFill>
+        <a:gradFill rotWithShape="1">
+          <a:gsLst>
+            <a:gs pos="0">
+              <a:schemeClr val="phClr">
+                <a:tint val="80000"/>
+                <a:satMod val="300000"/>
+              </a:schemeClr>
+            </a:gs>
+            <a:gs pos="100000">
+              <a:schemeClr val="phClr">
+                <a:shade val="30000"/>
+                <a:satMod val="200000"/>
+              </a:schemeClr>
+            </a:gs>
+          </a:gsLst>
+          <a:path path="circle">
+            <a:fillToRect l="50000" t="50000" r="50000" b="50000"/>
+          </a:path>
+        </a:gradFill>
+      </a:bgFillStyleLst>
+    </a:fmtScheme>
+  </a:themeElements>
+</a:theme>
 </file>
</xml_diff>

<commit_message>
Update Data Sources from LFX 2026-09-25 (#322)
Update Data Sources from LFX

Signed-off-by: github-actions[bot] <41898282+github-actions[bot]@users.noreply.github.com>
Co-authored-by: jmertic <296737+jmertic@users.noreply.github.com>
</commit_message>
<xml_diff>
--- a/overview_deck/LF Energy High Level Overview.pptx
+++ b/overview_deck/LF Energy High Level Overview.pptx
@@ -25946,7 +25946,7 @@
             <a:tbl>
               <a:tblPr>
                 <a:noFill/>
-                <a:tableStyleId>{46FB34A5-4B60-4FBC-8409-2246B4C90E89}</a:tableStyleId>
+                <a:tableStyleId>{E47D844C-8A1E-49F3-8C7D-FF5C5254FA68}</a:tableStyleId>
               </a:tblPr>
               <a:tblGrid>
                 <a:gridCol w="1695200"/>
@@ -26736,7 +26736,7 @@
             <a:tbl>
               <a:tblPr>
                 <a:noFill/>
-                <a:tableStyleId>{46FB34A5-4B60-4FBC-8409-2246B4C90E89}</a:tableStyleId>
+                <a:tableStyleId>{E47D844C-8A1E-49F3-8C7D-FF5C5254FA68}</a:tableStyleId>
               </a:tblPr>
               <a:tblGrid>
                 <a:gridCol w="1695200"/>
@@ -27426,7 +27426,7 @@
             <a:tbl>
               <a:tblPr>
                 <a:noFill/>
-                <a:tableStyleId>{46FB34A5-4B60-4FBC-8409-2246B4C90E89}</a:tableStyleId>
+                <a:tableStyleId>{E47D844C-8A1E-49F3-8C7D-FF5C5254FA68}</a:tableStyleId>
               </a:tblPr>
               <a:tblGrid>
                 <a:gridCol w="1695200"/>
@@ -28678,7 +28678,7 @@
             <a:tbl>
               <a:tblPr>
                 <a:noFill/>
-                <a:tableStyleId>{46FB34A5-4B60-4FBC-8409-2246B4C90E89}</a:tableStyleId>
+                <a:tableStyleId>{E47D844C-8A1E-49F3-8C7D-FF5C5254FA68}</a:tableStyleId>
               </a:tblPr>
               <a:tblGrid>
                 <a:gridCol w="1695200"/>
@@ -29670,7 +29670,7 @@
             <a:tbl>
               <a:tblPr>
                 <a:noFill/>
-                <a:tableStyleId>{46FB34A5-4B60-4FBC-8409-2246B4C90E89}</a:tableStyleId>
+                <a:tableStyleId>{E47D844C-8A1E-49F3-8C7D-FF5C5254FA68}</a:tableStyleId>
               </a:tblPr>
               <a:tblGrid>
                 <a:gridCol w="3048000"/>
@@ -33175,7 +33175,7 @@
             <a:tbl>
               <a:tblPr>
                 <a:noFill/>
-                <a:tableStyleId>{46FB34A5-4B60-4FBC-8409-2246B4C90E89}</a:tableStyleId>
+                <a:tableStyleId>{E47D844C-8A1E-49F3-8C7D-FF5C5254FA68}</a:tableStyleId>
               </a:tblPr>
               <a:tblGrid>
                 <a:gridCol w="1828800"/>
@@ -34002,6 +34002,285 @@
 </file>
 
 <file path=ppt/theme/theme1.xml><?xml version="1.0" encoding="utf-8"?>
+<a:theme xmlns:a="http://schemas.openxmlformats.org/drawingml/2006/main" xmlns:r="http://schemas.openxmlformats.org/officeDocument/2006/relationships">
+  <a:themeElements>
+    <a:clrScheme name="Default">
+      <a:dk1>
+        <a:srgbClr val="000000"/>
+      </a:dk1>
+      <a:lt1>
+        <a:srgbClr val="FFFFFF"/>
+      </a:lt1>
+      <a:dk2>
+        <a:srgbClr val="158158"/>
+      </a:dk2>
+      <a:lt2>
+        <a:srgbClr val="F3F3F3"/>
+      </a:lt2>
+      <a:accent1>
+        <a:srgbClr val="058DC7"/>
+      </a:accent1>
+      <a:accent2>
+        <a:srgbClr val="50B432"/>
+      </a:accent2>
+      <a:accent3>
+        <a:srgbClr val="ED561B"/>
+      </a:accent3>
+      <a:accent4>
+        <a:srgbClr val="EDEF00"/>
+      </a:accent4>
+      <a:accent5>
+        <a:srgbClr val="24CBE5"/>
+      </a:accent5>
+      <a:accent6>
+        <a:srgbClr val="64E572"/>
+      </a:accent6>
+      <a:hlink>
+        <a:srgbClr val="2200CC"/>
+      </a:hlink>
+      <a:folHlink>
+        <a:srgbClr val="551A8B"/>
+      </a:folHlink>
+    </a:clrScheme>
+    <a:fontScheme name="Office">
+      <a:majorFont>
+        <a:latin typeface="Arial"/>
+        <a:ea typeface=""/>
+        <a:cs typeface=""/>
+        <a:font script="Jpan" typeface="ＭＳ Ｐゴシック"/>
+        <a:font script="Hang" typeface="맑은 고딕"/>
+        <a:font script="Hans" typeface="宋体"/>
+        <a:font script="Hant" typeface="新細明體"/>
+        <a:font script="Arab" typeface="Times New Roman"/>
+        <a:font script="Hebr" typeface="Times New Roman"/>
+        <a:font script="Thai" typeface="Angsana New"/>
+        <a:font script="Ethi" typeface="Nyala"/>
+        <a:font script="Beng" typeface="Vrinda"/>
+        <a:font script="Gujr" typeface="Shruti"/>
+        <a:font script="Khmr" typeface="MoolBoran"/>
+        <a:font script="Knda" typeface="Tunga"/>
+        <a:font script="Guru" typeface="Raavi"/>
+        <a:font script="Cans" typeface="Euphemia"/>
+        <a:font script="Cher" typeface="Plantagenet Cherokee"/>
+        <a:font script="Yiii" typeface="Microsoft Yi Baiti"/>
+        <a:font script="Tibt" typeface="Microsoft Himalaya"/>
+        <a:font script="Thaa" typeface="MV Boli"/>
+        <a:font script="Deva" typeface="Mangal"/>
+        <a:font script="Telu" typeface="Gautami"/>
+        <a:font script="Taml" typeface="Latha"/>
+        <a:font script="Syrc" typeface="Estrangelo Edessa"/>
+        <a:font script="Orya" typeface="Kalinga"/>
+        <a:font script="Mlym" typeface="Kartika"/>
+        <a:font script="Laoo" typeface="DokChampa"/>
+        <a:font script="Sinh" typeface="Iskoola Pota"/>
+        <a:font script="Mong" typeface="Mongolian Baiti"/>
+        <a:font script="Viet" typeface="Times New Roman"/>
+        <a:font script="Uigh" typeface="Microsoft Uighur"/>
+        <a:font script="Geor" typeface="Sylfaen"/>
+      </a:majorFont>
+      <a:minorFont>
+        <a:latin typeface="Arial"/>
+        <a:ea typeface=""/>
+        <a:cs typeface=""/>
+        <a:font script="Jpan" typeface="ＭＳ Ｐゴシック"/>
+        <a:font script="Hang" typeface="맑은 고딕"/>
+        <a:font script="Hans" typeface="宋体"/>
+        <a:font script="Hant" typeface="新細明體"/>
+        <a:font script="Arab" typeface="Arial"/>
+        <a:font script="Hebr" typeface="Arial"/>
+        <a:font script="Thai" typeface="Cordia New"/>
+        <a:font script="Ethi" typeface="Nyala"/>
+        <a:font script="Beng" typeface="Vrinda"/>
+        <a:font script="Gujr" typeface="Shruti"/>
+        <a:font script="Khmr" typeface="DaunPenh"/>
+        <a:font script="Knda" typeface="Tunga"/>
+        <a:font script="Guru" typeface="Raavi"/>
+        <a:font script="Cans" typeface="Euphemia"/>
+        <a:font script="Cher" typeface="Plantagenet Cherokee"/>
+        <a:font script="Yiii" typeface="Microsoft Yi Baiti"/>
+        <a:font script="Tibt" typeface="Microsoft Himalaya"/>
+        <a:font script="Thaa" typeface="MV Boli"/>
+        <a:font script="Deva" typeface="Mangal"/>
+        <a:font script="Telu" typeface="Gautami"/>
+        <a:font script="Taml" typeface="Latha"/>
+        <a:font script="Syrc" typeface="Estrangelo Edessa"/>
+        <a:font script="Orya" typeface="Kalinga"/>
+        <a:font script="Mlym" typeface="Kartika"/>
+        <a:font script="Laoo" typeface="DokChampa"/>
+        <a:font script="Sinh" typeface="Iskoola Pota"/>
+        <a:font script="Mong" typeface="Mongolian Baiti"/>
+        <a:font script="Viet" typeface="Arial"/>
+        <a:font script="Uigh" typeface="Microsoft Uighur"/>
+        <a:font script="Geor" typeface="Sylfaen"/>
+      </a:minorFont>
+    </a:fontScheme>
+    <a:fmtScheme name="Office">
+      <a:fillStyleLst>
+        <a:solidFill>
+          <a:schemeClr val="phClr"/>
+        </a:solidFill>
+        <a:gradFill rotWithShape="1">
+          <a:gsLst>
+            <a:gs pos="0">
+              <a:schemeClr val="phClr">
+                <a:tint val="50000"/>
+                <a:satMod val="300000"/>
+              </a:schemeClr>
+            </a:gs>
+            <a:gs pos="35000">
+              <a:schemeClr val="phClr">
+                <a:tint val="37000"/>
+                <a:satMod val="300000"/>
+              </a:schemeClr>
+            </a:gs>
+            <a:gs pos="100000">
+              <a:schemeClr val="phClr">
+                <a:tint val="15000"/>
+                <a:satMod val="350000"/>
+              </a:schemeClr>
+            </a:gs>
+          </a:gsLst>
+          <a:lin ang="16200000" scaled="1"/>
+        </a:gradFill>
+        <a:gradFill rotWithShape="1">
+          <a:gsLst>
+            <a:gs pos="0">
+              <a:schemeClr val="phClr">
+                <a:tint val="100000"/>
+                <a:shade val="100000"/>
+                <a:satMod val="130000"/>
+              </a:schemeClr>
+            </a:gs>
+            <a:gs pos="100000">
+              <a:schemeClr val="phClr">
+                <a:tint val="50000"/>
+                <a:shade val="100000"/>
+                <a:satMod val="350000"/>
+              </a:schemeClr>
+            </a:gs>
+          </a:gsLst>
+          <a:lin ang="16200000" scaled="0"/>
+        </a:gradFill>
+      </a:fillStyleLst>
+      <a:lnStyleLst>
+        <a:ln w="9525" cap="flat" cmpd="sng" algn="ctr">
+          <a:solidFill>
+            <a:schemeClr val="phClr">
+              <a:shade val="95000"/>
+              <a:satMod val="105000"/>
+            </a:schemeClr>
+          </a:solidFill>
+          <a:prstDash val="solid"/>
+        </a:ln>
+        <a:ln w="25400" cap="flat" cmpd="sng" algn="ctr">
+          <a:solidFill>
+            <a:schemeClr val="phClr"/>
+          </a:solidFill>
+          <a:prstDash val="solid"/>
+        </a:ln>
+        <a:ln w="38100" cap="flat" cmpd="sng" algn="ctr">
+          <a:solidFill>
+            <a:schemeClr val="phClr"/>
+          </a:solidFill>
+          <a:prstDash val="solid"/>
+        </a:ln>
+      </a:lnStyleLst>
+      <a:effectStyleLst>
+        <a:effectStyle>
+          <a:effectLst>
+            <a:outerShdw blurRad="40000" dist="20000" dir="5400000" rotWithShape="0">
+              <a:srgbClr val="000000">
+                <a:alpha val="38000"/>
+              </a:srgbClr>
+            </a:outerShdw>
+          </a:effectLst>
+        </a:effectStyle>
+        <a:effectStyle>
+          <a:effectLst>
+            <a:outerShdw blurRad="40000" dist="23000" dir="5400000" rotWithShape="0">
+              <a:srgbClr val="000000">
+                <a:alpha val="35000"/>
+              </a:srgbClr>
+            </a:outerShdw>
+          </a:effectLst>
+        </a:effectStyle>
+        <a:effectStyle>
+          <a:effectLst>
+            <a:outerShdw blurRad="40000" dist="23000" dir="5400000" rotWithShape="0">
+              <a:srgbClr val="000000">
+                <a:alpha val="35000"/>
+              </a:srgbClr>
+            </a:outerShdw>
+          </a:effectLst>
+          <a:scene3d>
+            <a:camera prst="orthographicFront">
+              <a:rot lat="0" lon="0" rev="0"/>
+            </a:camera>
+            <a:lightRig rig="threePt" dir="t">
+              <a:rot lat="0" lon="0" rev="1200000"/>
+            </a:lightRig>
+          </a:scene3d>
+          <a:sp3d>
+            <a:bevelT w="63500" h="25400"/>
+          </a:sp3d>
+        </a:effectStyle>
+      </a:effectStyleLst>
+      <a:bgFillStyleLst>
+        <a:solidFill>
+          <a:schemeClr val="phClr"/>
+        </a:solidFill>
+        <a:gradFill rotWithShape="1">
+          <a:gsLst>
+            <a:gs pos="0">
+              <a:schemeClr val="phClr">
+                <a:tint val="40000"/>
+                <a:satMod val="350000"/>
+              </a:schemeClr>
+            </a:gs>
+            <a:gs pos="40000">
+              <a:schemeClr val="phClr">
+                <a:tint val="45000"/>
+                <a:shade val="99000"/>
+                <a:satMod val="350000"/>
+              </a:schemeClr>
+            </a:gs>
+            <a:gs pos="100000">
+              <a:schemeClr val="phClr">
+                <a:shade val="20000"/>
+                <a:satMod val="255000"/>
+              </a:schemeClr>
+            </a:gs>
+          </a:gsLst>
+          <a:path path="circle">
+            <a:fillToRect l="50000" t="-80000" r="50000" b="180000"/>
+          </a:path>
+        </a:gradFill>
+        <a:gradFill rotWithShape="1">
+          <a:gsLst>
+            <a:gs pos="0">
+              <a:schemeClr val="phClr">
+                <a:tint val="80000"/>
+                <a:satMod val="300000"/>
+              </a:schemeClr>
+            </a:gs>
+            <a:gs pos="100000">
+              <a:schemeClr val="phClr">
+                <a:shade val="30000"/>
+                <a:satMod val="200000"/>
+              </a:schemeClr>
+            </a:gs>
+          </a:gsLst>
+          <a:path path="circle">
+            <a:fillToRect l="50000" t="50000" r="50000" b="50000"/>
+          </a:path>
+        </a:gradFill>
+      </a:bgFillStyleLst>
+    </a:fmtScheme>
+  </a:themeElements>
+</a:theme>
+</file>
+
+<file path=ppt/theme/theme2.xml><?xml version="1.0" encoding="utf-8"?>
 <a:theme xmlns:a="http://schemas.openxmlformats.org/drawingml/2006/main" xmlns:r="http://schemas.openxmlformats.org/officeDocument/2006/relationships" name="LF Energy Theme 2023">
   <a:themeElements>
     <a:clrScheme name="Geometric">
@@ -34280,7 +34559,7 @@
 </a:theme>
 </file>
 
-<file path=ppt/theme/theme2.xml><?xml version="1.0" encoding="utf-8"?>
+<file path=ppt/theme/theme3.xml><?xml version="1.0" encoding="utf-8"?>
 <a:theme xmlns:a="http://schemas.openxmlformats.org/drawingml/2006/main" xmlns:r="http://schemas.openxmlformats.org/officeDocument/2006/relationships" name="Simple Light">
   <a:themeElements>
     <a:clrScheme name="Simple Light">
@@ -34557,283 +34836,4 @@
     </a:fmtScheme>
   </a:themeElements>
 </a:theme>
-</file>
-
-<file path=ppt/theme/theme3.xml><?xml version="1.0" encoding="utf-8"?>
-<a:theme xmlns:a="http://schemas.openxmlformats.org/drawingml/2006/main" xmlns:r="http://schemas.openxmlformats.org/officeDocument/2006/relationships">
-  <a:themeElements>
-    <a:clrScheme name="Default">
-      <a:dk1>
-        <a:srgbClr val="000000"/>
-      </a:dk1>
-      <a:lt1>
-        <a:srgbClr val="FFFFFF"/>
-      </a:lt1>
-      <a:dk2>
-        <a:srgbClr val="158158"/>
-      </a:dk2>
-      <a:lt2>
-        <a:srgbClr val="F3F3F3"/>
-      </a:lt2>
-      <a:accent1>
-        <a:srgbClr val="058DC7"/>
-      </a:accent1>
-      <a:accent2>
-        <a:srgbClr val="50B432"/>
-      </a:accent2>
-      <a:accent3>
-        <a:srgbClr val="ED561B"/>
-      </a:accent3>
-      <a:accent4>
-        <a:srgbClr val="EDEF00"/>
-      </a:accent4>
-      <a:accent5>
-        <a:srgbClr val="24CBE5"/>
-      </a:accent5>
-      <a:accent6>
-        <a:srgbClr val="64E572"/>
-      </a:accent6>
-      <a:hlink>
-        <a:srgbClr val="2200CC"/>
-      </a:hlink>
-      <a:folHlink>
-        <a:srgbClr val="551A8B"/>
-      </a:folHlink>
-    </a:clrScheme>
-    <a:fontScheme name="Office">
-      <a:majorFont>
-        <a:latin typeface="Arial"/>
-        <a:ea typeface=""/>
-        <a:cs typeface=""/>
-        <a:font script="Jpan" typeface="ＭＳ Ｐゴシック"/>
-        <a:font script="Hang" typeface="맑은 고딕"/>
-        <a:font script="Hans" typeface="宋体"/>
-        <a:font script="Hant" typeface="新細明體"/>
-        <a:font script="Arab" typeface="Times New Roman"/>
-        <a:font script="Hebr" typeface="Times New Roman"/>
-        <a:font script="Thai" typeface="Angsana New"/>
-        <a:font script="Ethi" typeface="Nyala"/>
-        <a:font script="Beng" typeface="Vrinda"/>
-        <a:font script="Gujr" typeface="Shruti"/>
-        <a:font script="Khmr" typeface="MoolBoran"/>
-        <a:font script="Knda" typeface="Tunga"/>
-        <a:font script="Guru" typeface="Raavi"/>
-        <a:font script="Cans" typeface="Euphemia"/>
-        <a:font script="Cher" typeface="Plantagenet Cherokee"/>
-        <a:font script="Yiii" typeface="Microsoft Yi Baiti"/>
-        <a:font script="Tibt" typeface="Microsoft Himalaya"/>
-        <a:font script="Thaa" typeface="MV Boli"/>
-        <a:font script="Deva" typeface="Mangal"/>
-        <a:font script="Telu" typeface="Gautami"/>
-        <a:font script="Taml" typeface="Latha"/>
-        <a:font script="Syrc" typeface="Estrangelo Edessa"/>
-        <a:font script="Orya" typeface="Kalinga"/>
-        <a:font script="Mlym" typeface="Kartika"/>
-        <a:font script="Laoo" typeface="DokChampa"/>
-        <a:font script="Sinh" typeface="Iskoola Pota"/>
-        <a:font script="Mong" typeface="Mongolian Baiti"/>
-        <a:font script="Viet" typeface="Times New Roman"/>
-        <a:font script="Uigh" typeface="Microsoft Uighur"/>
-        <a:font script="Geor" typeface="Sylfaen"/>
-      </a:majorFont>
-      <a:minorFont>
-        <a:latin typeface="Arial"/>
-        <a:ea typeface=""/>
-        <a:cs typeface=""/>
-        <a:font script="Jpan" typeface="ＭＳ Ｐゴシック"/>
-        <a:font script="Hang" typeface="맑은 고딕"/>
-        <a:font script="Hans" typeface="宋体"/>
-        <a:font script="Hant" typeface="新細明體"/>
-        <a:font script="Arab" typeface="Arial"/>
-        <a:font script="Hebr" typeface="Arial"/>
-        <a:font script="Thai" typeface="Cordia New"/>
-        <a:font script="Ethi" typeface="Nyala"/>
-        <a:font script="Beng" typeface="Vrinda"/>
-        <a:font script="Gujr" typeface="Shruti"/>
-        <a:font script="Khmr" typeface="DaunPenh"/>
-        <a:font script="Knda" typeface="Tunga"/>
-        <a:font script="Guru" typeface="Raavi"/>
-        <a:font script="Cans" typeface="Euphemia"/>
-        <a:font script="Cher" typeface="Plantagenet Cherokee"/>
-        <a:font script="Yiii" typeface="Microsoft Yi Baiti"/>
-        <a:font script="Tibt" typeface="Microsoft Himalaya"/>
-        <a:font script="Thaa" typeface="MV Boli"/>
-        <a:font script="Deva" typeface="Mangal"/>
-        <a:font script="Telu" typeface="Gautami"/>
-        <a:font script="Taml" typeface="Latha"/>
-        <a:font script="Syrc" typeface="Estrangelo Edessa"/>
-        <a:font script="Orya" typeface="Kalinga"/>
-        <a:font script="Mlym" typeface="Kartika"/>
-        <a:font script="Laoo" typeface="DokChampa"/>
-        <a:font script="Sinh" typeface="Iskoola Pota"/>
-        <a:font script="Mong" typeface="Mongolian Baiti"/>
-        <a:font script="Viet" typeface="Arial"/>
-        <a:font script="Uigh" typeface="Microsoft Uighur"/>
-        <a:font script="Geor" typeface="Sylfaen"/>
-      </a:minorFont>
-    </a:fontScheme>
-    <a:fmtScheme name="Office">
-      <a:fillStyleLst>
-        <a:solidFill>
-          <a:schemeClr val="phClr"/>
-        </a:solidFill>
-        <a:gradFill rotWithShape="1">
-          <a:gsLst>
-            <a:gs pos="0">
-              <a:schemeClr val="phClr">
-                <a:tint val="50000"/>
-                <a:satMod val="300000"/>
-              </a:schemeClr>
-            </a:gs>
-            <a:gs pos="35000">
-              <a:schemeClr val="phClr">
-                <a:tint val="37000"/>
-                <a:satMod val="300000"/>
-              </a:schemeClr>
-            </a:gs>
-            <a:gs pos="100000">
-              <a:schemeClr val="phClr">
-                <a:tint val="15000"/>
-                <a:satMod val="350000"/>
-              </a:schemeClr>
-            </a:gs>
-          </a:gsLst>
-          <a:lin ang="16200000" scaled="1"/>
-        </a:gradFill>
-        <a:gradFill rotWithShape="1">
-          <a:gsLst>
-            <a:gs pos="0">
-              <a:schemeClr val="phClr">
-                <a:tint val="100000"/>
-                <a:shade val="100000"/>
-                <a:satMod val="130000"/>
-              </a:schemeClr>
-            </a:gs>
-            <a:gs pos="100000">
-              <a:schemeClr val="phClr">
-                <a:tint val="50000"/>
-                <a:shade val="100000"/>
-                <a:satMod val="350000"/>
-              </a:schemeClr>
-            </a:gs>
-          </a:gsLst>
-          <a:lin ang="16200000" scaled="0"/>
-        </a:gradFill>
-      </a:fillStyleLst>
-      <a:lnStyleLst>
-        <a:ln w="9525" cap="flat" cmpd="sng" algn="ctr">
-          <a:solidFill>
-            <a:schemeClr val="phClr">
-              <a:shade val="95000"/>
-              <a:satMod val="105000"/>
-            </a:schemeClr>
-          </a:solidFill>
-          <a:prstDash val="solid"/>
-        </a:ln>
-        <a:ln w="25400" cap="flat" cmpd="sng" algn="ctr">
-          <a:solidFill>
-            <a:schemeClr val="phClr"/>
-          </a:solidFill>
-          <a:prstDash val="solid"/>
-        </a:ln>
-        <a:ln w="38100" cap="flat" cmpd="sng" algn="ctr">
-          <a:solidFill>
-            <a:schemeClr val="phClr"/>
-          </a:solidFill>
-          <a:prstDash val="solid"/>
-        </a:ln>
-      </a:lnStyleLst>
-      <a:effectStyleLst>
-        <a:effectStyle>
-          <a:effectLst>
-            <a:outerShdw blurRad="40000" dist="20000" dir="5400000" rotWithShape="0">
-              <a:srgbClr val="000000">
-                <a:alpha val="38000"/>
-              </a:srgbClr>
-            </a:outerShdw>
-          </a:effectLst>
-        </a:effectStyle>
-        <a:effectStyle>
-          <a:effectLst>
-            <a:outerShdw blurRad="40000" dist="23000" dir="5400000" rotWithShape="0">
-              <a:srgbClr val="000000">
-                <a:alpha val="35000"/>
-              </a:srgbClr>
-            </a:outerShdw>
-          </a:effectLst>
-        </a:effectStyle>
-        <a:effectStyle>
-          <a:effectLst>
-            <a:outerShdw blurRad="40000" dist="23000" dir="5400000" rotWithShape="0">
-              <a:srgbClr val="000000">
-                <a:alpha val="35000"/>
-              </a:srgbClr>
-            </a:outerShdw>
-          </a:effectLst>
-          <a:scene3d>
-            <a:camera prst="orthographicFront">
-              <a:rot lat="0" lon="0" rev="0"/>
-            </a:camera>
-            <a:lightRig rig="threePt" dir="t">
-              <a:rot lat="0" lon="0" rev="1200000"/>
-            </a:lightRig>
-          </a:scene3d>
-          <a:sp3d>
-            <a:bevelT w="63500" h="25400"/>
-          </a:sp3d>
-        </a:effectStyle>
-      </a:effectStyleLst>
-      <a:bgFillStyleLst>
-        <a:solidFill>
-          <a:schemeClr val="phClr"/>
-        </a:solidFill>
-        <a:gradFill rotWithShape="1">
-          <a:gsLst>
-            <a:gs pos="0">
-              <a:schemeClr val="phClr">
-                <a:tint val="40000"/>
-                <a:satMod val="350000"/>
-              </a:schemeClr>
-            </a:gs>
-            <a:gs pos="40000">
-              <a:schemeClr val="phClr">
-                <a:tint val="45000"/>
-                <a:shade val="99000"/>
-                <a:satMod val="350000"/>
-              </a:schemeClr>
-            </a:gs>
-            <a:gs pos="100000">
-              <a:schemeClr val="phClr">
-                <a:shade val="20000"/>
-                <a:satMod val="255000"/>
-              </a:schemeClr>
-            </a:gs>
-          </a:gsLst>
-          <a:path path="circle">
-            <a:fillToRect l="50000" t="-80000" r="50000" b="180000"/>
-          </a:path>
-        </a:gradFill>
-        <a:gradFill rotWithShape="1">
-          <a:gsLst>
-            <a:gs pos="0">
-              <a:schemeClr val="phClr">
-                <a:tint val="80000"/>
-                <a:satMod val="300000"/>
-              </a:schemeClr>
-            </a:gs>
-            <a:gs pos="100000">
-              <a:schemeClr val="phClr">
-                <a:shade val="30000"/>
-                <a:satMod val="200000"/>
-              </a:schemeClr>
-            </a:gs>
-          </a:gsLst>
-          <a:path path="circle">
-            <a:fillToRect l="50000" t="50000" r="50000" b="50000"/>
-          </a:path>
-        </a:gradFill>
-      </a:bgFillStyleLst>
-    </a:fmtScheme>
-  </a:themeElements>
-</a:theme>
 </file>
</xml_diff>

<commit_message>
Update Data Sources from LFX 2026-09-26 (#323)
Update Data Sources from LFX

Signed-off-by: github-actions[bot] <41898282+github-actions[bot]@users.noreply.github.com>
Co-authored-by: jmertic <296737+jmertic@users.noreply.github.com>
</commit_message>
<xml_diff>
--- a/overview_deck/LF Energy High Level Overview.pptx
+++ b/overview_deck/LF Energy High Level Overview.pptx
@@ -25946,7 +25946,7 @@
             <a:tbl>
               <a:tblPr>
                 <a:noFill/>
-                <a:tableStyleId>{E47D844C-8A1E-49F3-8C7D-FF5C5254FA68}</a:tableStyleId>
+                <a:tableStyleId>{72677059-7A92-4BBF-B04D-53B70365A6EE}</a:tableStyleId>
               </a:tblPr>
               <a:tblGrid>
                 <a:gridCol w="1695200"/>
@@ -26736,7 +26736,7 @@
             <a:tbl>
               <a:tblPr>
                 <a:noFill/>
-                <a:tableStyleId>{E47D844C-8A1E-49F3-8C7D-FF5C5254FA68}</a:tableStyleId>
+                <a:tableStyleId>{72677059-7A92-4BBF-B04D-53B70365A6EE}</a:tableStyleId>
               </a:tblPr>
               <a:tblGrid>
                 <a:gridCol w="1695200"/>
@@ -27426,7 +27426,7 @@
             <a:tbl>
               <a:tblPr>
                 <a:noFill/>
-                <a:tableStyleId>{E47D844C-8A1E-49F3-8C7D-FF5C5254FA68}</a:tableStyleId>
+                <a:tableStyleId>{72677059-7A92-4BBF-B04D-53B70365A6EE}</a:tableStyleId>
               </a:tblPr>
               <a:tblGrid>
                 <a:gridCol w="1695200"/>
@@ -28678,7 +28678,7 @@
             <a:tbl>
               <a:tblPr>
                 <a:noFill/>
-                <a:tableStyleId>{E47D844C-8A1E-49F3-8C7D-FF5C5254FA68}</a:tableStyleId>
+                <a:tableStyleId>{72677059-7A92-4BBF-B04D-53B70365A6EE}</a:tableStyleId>
               </a:tblPr>
               <a:tblGrid>
                 <a:gridCol w="1695200"/>
@@ -29670,7 +29670,7 @@
             <a:tbl>
               <a:tblPr>
                 <a:noFill/>
-                <a:tableStyleId>{E47D844C-8A1E-49F3-8C7D-FF5C5254FA68}</a:tableStyleId>
+                <a:tableStyleId>{72677059-7A92-4BBF-B04D-53B70365A6EE}</a:tableStyleId>
               </a:tblPr>
               <a:tblGrid>
                 <a:gridCol w="3048000"/>
@@ -33175,7 +33175,7 @@
             <a:tbl>
               <a:tblPr>
                 <a:noFill/>
-                <a:tableStyleId>{E47D844C-8A1E-49F3-8C7D-FF5C5254FA68}</a:tableStyleId>
+                <a:tableStyleId>{72677059-7A92-4BBF-B04D-53B70365A6EE}</a:tableStyleId>
               </a:tblPr>
               <a:tblGrid>
                 <a:gridCol w="1828800"/>
@@ -34002,44 +34002,44 @@
 </file>
 
 <file path=ppt/theme/theme1.xml><?xml version="1.0" encoding="utf-8"?>
-<a:theme xmlns:a="http://schemas.openxmlformats.org/drawingml/2006/main" xmlns:r="http://schemas.openxmlformats.org/officeDocument/2006/relationships">
+<a:theme xmlns:a="http://schemas.openxmlformats.org/drawingml/2006/main" xmlns:r="http://schemas.openxmlformats.org/officeDocument/2006/relationships" name="LF Energy Theme 2023">
   <a:themeElements>
-    <a:clrScheme name="Default">
+    <a:clrScheme name="Geometric">
       <a:dk1>
-        <a:srgbClr val="000000"/>
+        <a:srgbClr val="222222"/>
       </a:dk1>
       <a:lt1>
         <a:srgbClr val="FFFFFF"/>
       </a:lt1>
       <a:dk2>
-        <a:srgbClr val="158158"/>
+        <a:srgbClr val="434343"/>
       </a:dk2>
       <a:lt2>
-        <a:srgbClr val="F3F3F3"/>
+        <a:srgbClr val="999999"/>
       </a:lt2>
       <a:accent1>
-        <a:srgbClr val="058DC7"/>
+        <a:srgbClr val="003778"/>
       </a:accent1>
       <a:accent2>
-        <a:srgbClr val="50B432"/>
+        <a:srgbClr val="0094FF"/>
       </a:accent2>
       <a:accent3>
-        <a:srgbClr val="ED561B"/>
+        <a:srgbClr val="5B1DE7"/>
       </a:accent3>
       <a:accent4>
-        <a:srgbClr val="EDEF00"/>
+        <a:srgbClr val="12E2E2"/>
       </a:accent4>
       <a:accent5>
-        <a:srgbClr val="24CBE5"/>
+        <a:srgbClr val="FF00AA"/>
       </a:accent5>
       <a:accent6>
-        <a:srgbClr val="64E572"/>
+        <a:srgbClr val="ACDE1F"/>
       </a:accent6>
       <a:hlink>
-        <a:srgbClr val="2200CC"/>
+        <a:srgbClr val="0077CC"/>
       </a:hlink>
       <a:folHlink>
-        <a:srgbClr val="551A8B"/>
+        <a:srgbClr val="F06292"/>
       </a:folHlink>
     </a:clrScheme>
     <a:fontScheme name="Office">
@@ -34281,44 +34281,44 @@
 </file>
 
 <file path=ppt/theme/theme2.xml><?xml version="1.0" encoding="utf-8"?>
-<a:theme xmlns:a="http://schemas.openxmlformats.org/drawingml/2006/main" xmlns:r="http://schemas.openxmlformats.org/officeDocument/2006/relationships" name="LF Energy Theme 2023">
+<a:theme xmlns:a="http://schemas.openxmlformats.org/drawingml/2006/main" xmlns:r="http://schemas.openxmlformats.org/officeDocument/2006/relationships">
   <a:themeElements>
-    <a:clrScheme name="Geometric">
+    <a:clrScheme name="Default">
       <a:dk1>
-        <a:srgbClr val="222222"/>
+        <a:srgbClr val="000000"/>
       </a:dk1>
       <a:lt1>
         <a:srgbClr val="FFFFFF"/>
       </a:lt1>
       <a:dk2>
-        <a:srgbClr val="434343"/>
+        <a:srgbClr val="158158"/>
       </a:dk2>
       <a:lt2>
-        <a:srgbClr val="999999"/>
+        <a:srgbClr val="F3F3F3"/>
       </a:lt2>
       <a:accent1>
-        <a:srgbClr val="003778"/>
+        <a:srgbClr val="058DC7"/>
       </a:accent1>
       <a:accent2>
-        <a:srgbClr val="0094FF"/>
+        <a:srgbClr val="50B432"/>
       </a:accent2>
       <a:accent3>
-        <a:srgbClr val="5B1DE7"/>
+        <a:srgbClr val="ED561B"/>
       </a:accent3>
       <a:accent4>
-        <a:srgbClr val="12E2E2"/>
+        <a:srgbClr val="EDEF00"/>
       </a:accent4>
       <a:accent5>
-        <a:srgbClr val="FF00AA"/>
+        <a:srgbClr val="24CBE5"/>
       </a:accent5>
       <a:accent6>
-        <a:srgbClr val="ACDE1F"/>
+        <a:srgbClr val="64E572"/>
       </a:accent6>
       <a:hlink>
-        <a:srgbClr val="0077CC"/>
+        <a:srgbClr val="2200CC"/>
       </a:hlink>
       <a:folHlink>
-        <a:srgbClr val="F06292"/>
+        <a:srgbClr val="551A8B"/>
       </a:folHlink>
     </a:clrScheme>
     <a:fontScheme name="Office">

</xml_diff>

<commit_message>
Update Data Sources from LFX 2026-09-27 (#324)
Update Data Sources from LFX

Signed-off-by: github-actions[bot] <41898282+github-actions[bot]@users.noreply.github.com>
Co-authored-by: jmertic <296737+jmertic@users.noreply.github.com>
</commit_message>
<xml_diff>
--- a/overview_deck/LF Energy High Level Overview.pptx
+++ b/overview_deck/LF Energy High Level Overview.pptx
@@ -25946,7 +25946,7 @@
             <a:tbl>
               <a:tblPr>
                 <a:noFill/>
-                <a:tableStyleId>{72677059-7A92-4BBF-B04D-53B70365A6EE}</a:tableStyleId>
+                <a:tableStyleId>{14DBEEAE-F8F0-4AC9-9054-6F6D57077E99}</a:tableStyleId>
               </a:tblPr>
               <a:tblGrid>
                 <a:gridCol w="1695200"/>
@@ -26736,7 +26736,7 @@
             <a:tbl>
               <a:tblPr>
                 <a:noFill/>
-                <a:tableStyleId>{72677059-7A92-4BBF-B04D-53B70365A6EE}</a:tableStyleId>
+                <a:tableStyleId>{14DBEEAE-F8F0-4AC9-9054-6F6D57077E99}</a:tableStyleId>
               </a:tblPr>
               <a:tblGrid>
                 <a:gridCol w="1695200"/>
@@ -27426,7 +27426,7 @@
             <a:tbl>
               <a:tblPr>
                 <a:noFill/>
-                <a:tableStyleId>{72677059-7A92-4BBF-B04D-53B70365A6EE}</a:tableStyleId>
+                <a:tableStyleId>{14DBEEAE-F8F0-4AC9-9054-6F6D57077E99}</a:tableStyleId>
               </a:tblPr>
               <a:tblGrid>
                 <a:gridCol w="1695200"/>
@@ -28678,7 +28678,7 @@
             <a:tbl>
               <a:tblPr>
                 <a:noFill/>
-                <a:tableStyleId>{72677059-7A92-4BBF-B04D-53B70365A6EE}</a:tableStyleId>
+                <a:tableStyleId>{14DBEEAE-F8F0-4AC9-9054-6F6D57077E99}</a:tableStyleId>
               </a:tblPr>
               <a:tblGrid>
                 <a:gridCol w="1695200"/>
@@ -29670,7 +29670,7 @@
             <a:tbl>
               <a:tblPr>
                 <a:noFill/>
-                <a:tableStyleId>{72677059-7A92-4BBF-B04D-53B70365A6EE}</a:tableStyleId>
+                <a:tableStyleId>{14DBEEAE-F8F0-4AC9-9054-6F6D57077E99}</a:tableStyleId>
               </a:tblPr>
               <a:tblGrid>
                 <a:gridCol w="3048000"/>
@@ -33175,7 +33175,7 @@
             <a:tbl>
               <a:tblPr>
                 <a:noFill/>
-                <a:tableStyleId>{72677059-7A92-4BBF-B04D-53B70365A6EE}</a:tableStyleId>
+                <a:tableStyleId>{14DBEEAE-F8F0-4AC9-9054-6F6D57077E99}</a:tableStyleId>
               </a:tblPr>
               <a:tblGrid>
                 <a:gridCol w="1828800"/>
@@ -34002,6 +34002,285 @@
 </file>
 
 <file path=ppt/theme/theme1.xml><?xml version="1.0" encoding="utf-8"?>
+<a:theme xmlns:a="http://schemas.openxmlformats.org/drawingml/2006/main" xmlns:r="http://schemas.openxmlformats.org/officeDocument/2006/relationships" name="Simple Light">
+  <a:themeElements>
+    <a:clrScheme name="Simple Light">
+      <a:dk1>
+        <a:srgbClr val="000000"/>
+      </a:dk1>
+      <a:lt1>
+        <a:srgbClr val="FFFFFF"/>
+      </a:lt1>
+      <a:dk2>
+        <a:srgbClr val="595959"/>
+      </a:dk2>
+      <a:lt2>
+        <a:srgbClr val="EEEEEE"/>
+      </a:lt2>
+      <a:accent1>
+        <a:srgbClr val="4285F4"/>
+      </a:accent1>
+      <a:accent2>
+        <a:srgbClr val="212121"/>
+      </a:accent2>
+      <a:accent3>
+        <a:srgbClr val="78909C"/>
+      </a:accent3>
+      <a:accent4>
+        <a:srgbClr val="FFAB40"/>
+      </a:accent4>
+      <a:accent5>
+        <a:srgbClr val="0097A7"/>
+      </a:accent5>
+      <a:accent6>
+        <a:srgbClr val="EEFF41"/>
+      </a:accent6>
+      <a:hlink>
+        <a:srgbClr val="0097A7"/>
+      </a:hlink>
+      <a:folHlink>
+        <a:srgbClr val="0097A7"/>
+      </a:folHlink>
+    </a:clrScheme>
+    <a:fontScheme name="Office">
+      <a:majorFont>
+        <a:latin typeface="Arial"/>
+        <a:ea typeface=""/>
+        <a:cs typeface=""/>
+        <a:font script="Jpan" typeface="ＭＳ Ｐゴシック"/>
+        <a:font script="Hang" typeface="맑은 고딕"/>
+        <a:font script="Hans" typeface="宋体"/>
+        <a:font script="Hant" typeface="新細明體"/>
+        <a:font script="Arab" typeface="Times New Roman"/>
+        <a:font script="Hebr" typeface="Times New Roman"/>
+        <a:font script="Thai" typeface="Angsana New"/>
+        <a:font script="Ethi" typeface="Nyala"/>
+        <a:font script="Beng" typeface="Vrinda"/>
+        <a:font script="Gujr" typeface="Shruti"/>
+        <a:font script="Khmr" typeface="MoolBoran"/>
+        <a:font script="Knda" typeface="Tunga"/>
+        <a:font script="Guru" typeface="Raavi"/>
+        <a:font script="Cans" typeface="Euphemia"/>
+        <a:font script="Cher" typeface="Plantagenet Cherokee"/>
+        <a:font script="Yiii" typeface="Microsoft Yi Baiti"/>
+        <a:font script="Tibt" typeface="Microsoft Himalaya"/>
+        <a:font script="Thaa" typeface="MV Boli"/>
+        <a:font script="Deva" typeface="Mangal"/>
+        <a:font script="Telu" typeface="Gautami"/>
+        <a:font script="Taml" typeface="Latha"/>
+        <a:font script="Syrc" typeface="Estrangelo Edessa"/>
+        <a:font script="Orya" typeface="Kalinga"/>
+        <a:font script="Mlym" typeface="Kartika"/>
+        <a:font script="Laoo" typeface="DokChampa"/>
+        <a:font script="Sinh" typeface="Iskoola Pota"/>
+        <a:font script="Mong" typeface="Mongolian Baiti"/>
+        <a:font script="Viet" typeface="Times New Roman"/>
+        <a:font script="Uigh" typeface="Microsoft Uighur"/>
+        <a:font script="Geor" typeface="Sylfaen"/>
+      </a:majorFont>
+      <a:minorFont>
+        <a:latin typeface="Arial"/>
+        <a:ea typeface=""/>
+        <a:cs typeface=""/>
+        <a:font script="Jpan" typeface="ＭＳ Ｐゴシック"/>
+        <a:font script="Hang" typeface="맑은 고딕"/>
+        <a:font script="Hans" typeface="宋体"/>
+        <a:font script="Hant" typeface="新細明體"/>
+        <a:font script="Arab" typeface="Arial"/>
+        <a:font script="Hebr" typeface="Arial"/>
+        <a:font script="Thai" typeface="Cordia New"/>
+        <a:font script="Ethi" typeface="Nyala"/>
+        <a:font script="Beng" typeface="Vrinda"/>
+        <a:font script="Gujr" typeface="Shruti"/>
+        <a:font script="Khmr" typeface="DaunPenh"/>
+        <a:font script="Knda" typeface="Tunga"/>
+        <a:font script="Guru" typeface="Raavi"/>
+        <a:font script="Cans" typeface="Euphemia"/>
+        <a:font script="Cher" typeface="Plantagenet Cherokee"/>
+        <a:font script="Yiii" typeface="Microsoft Yi Baiti"/>
+        <a:font script="Tibt" typeface="Microsoft Himalaya"/>
+        <a:font script="Thaa" typeface="MV Boli"/>
+        <a:font script="Deva" typeface="Mangal"/>
+        <a:font script="Telu" typeface="Gautami"/>
+        <a:font script="Taml" typeface="Latha"/>
+        <a:font script="Syrc" typeface="Estrangelo Edessa"/>
+        <a:font script="Orya" typeface="Kalinga"/>
+        <a:font script="Mlym" typeface="Kartika"/>
+        <a:font script="Laoo" typeface="DokChampa"/>
+        <a:font script="Sinh" typeface="Iskoola Pota"/>
+        <a:font script="Mong" typeface="Mongolian Baiti"/>
+        <a:font script="Viet" typeface="Arial"/>
+        <a:font script="Uigh" typeface="Microsoft Uighur"/>
+        <a:font script="Geor" typeface="Sylfaen"/>
+      </a:minorFont>
+    </a:fontScheme>
+    <a:fmtScheme name="Office">
+      <a:fillStyleLst>
+        <a:solidFill>
+          <a:schemeClr val="phClr"/>
+        </a:solidFill>
+        <a:gradFill rotWithShape="1">
+          <a:gsLst>
+            <a:gs pos="0">
+              <a:schemeClr val="phClr">
+                <a:tint val="50000"/>
+                <a:satMod val="300000"/>
+              </a:schemeClr>
+            </a:gs>
+            <a:gs pos="35000">
+              <a:schemeClr val="phClr">
+                <a:tint val="37000"/>
+                <a:satMod val="300000"/>
+              </a:schemeClr>
+            </a:gs>
+            <a:gs pos="100000">
+              <a:schemeClr val="phClr">
+                <a:tint val="15000"/>
+                <a:satMod val="350000"/>
+              </a:schemeClr>
+            </a:gs>
+          </a:gsLst>
+          <a:lin ang="16200000" scaled="1"/>
+        </a:gradFill>
+        <a:gradFill rotWithShape="1">
+          <a:gsLst>
+            <a:gs pos="0">
+              <a:schemeClr val="phClr">
+                <a:tint val="100000"/>
+                <a:shade val="100000"/>
+                <a:satMod val="130000"/>
+              </a:schemeClr>
+            </a:gs>
+            <a:gs pos="100000">
+              <a:schemeClr val="phClr">
+                <a:tint val="50000"/>
+                <a:shade val="100000"/>
+                <a:satMod val="350000"/>
+              </a:schemeClr>
+            </a:gs>
+          </a:gsLst>
+          <a:lin ang="16200000" scaled="0"/>
+        </a:gradFill>
+      </a:fillStyleLst>
+      <a:lnStyleLst>
+        <a:ln w="9525" cap="flat" cmpd="sng" algn="ctr">
+          <a:solidFill>
+            <a:schemeClr val="phClr">
+              <a:shade val="95000"/>
+              <a:satMod val="105000"/>
+            </a:schemeClr>
+          </a:solidFill>
+          <a:prstDash val="solid"/>
+        </a:ln>
+        <a:ln w="25400" cap="flat" cmpd="sng" algn="ctr">
+          <a:solidFill>
+            <a:schemeClr val="phClr"/>
+          </a:solidFill>
+          <a:prstDash val="solid"/>
+        </a:ln>
+        <a:ln w="38100" cap="flat" cmpd="sng" algn="ctr">
+          <a:solidFill>
+            <a:schemeClr val="phClr"/>
+          </a:solidFill>
+          <a:prstDash val="solid"/>
+        </a:ln>
+      </a:lnStyleLst>
+      <a:effectStyleLst>
+        <a:effectStyle>
+          <a:effectLst>
+            <a:outerShdw blurRad="40000" dist="20000" dir="5400000" rotWithShape="0">
+              <a:srgbClr val="000000">
+                <a:alpha val="38000"/>
+              </a:srgbClr>
+            </a:outerShdw>
+          </a:effectLst>
+        </a:effectStyle>
+        <a:effectStyle>
+          <a:effectLst>
+            <a:outerShdw blurRad="40000" dist="23000" dir="5400000" rotWithShape="0">
+              <a:srgbClr val="000000">
+                <a:alpha val="35000"/>
+              </a:srgbClr>
+            </a:outerShdw>
+          </a:effectLst>
+        </a:effectStyle>
+        <a:effectStyle>
+          <a:effectLst>
+            <a:outerShdw blurRad="40000" dist="23000" dir="5400000" rotWithShape="0">
+              <a:srgbClr val="000000">
+                <a:alpha val="35000"/>
+              </a:srgbClr>
+            </a:outerShdw>
+          </a:effectLst>
+          <a:scene3d>
+            <a:camera prst="orthographicFront">
+              <a:rot lat="0" lon="0" rev="0"/>
+            </a:camera>
+            <a:lightRig rig="threePt" dir="t">
+              <a:rot lat="0" lon="0" rev="1200000"/>
+            </a:lightRig>
+          </a:scene3d>
+          <a:sp3d>
+            <a:bevelT w="63500" h="25400"/>
+          </a:sp3d>
+        </a:effectStyle>
+      </a:effectStyleLst>
+      <a:bgFillStyleLst>
+        <a:solidFill>
+          <a:schemeClr val="phClr"/>
+        </a:solidFill>
+        <a:gradFill rotWithShape="1">
+          <a:gsLst>
+            <a:gs pos="0">
+              <a:schemeClr val="phClr">
+                <a:tint val="40000"/>
+                <a:satMod val="350000"/>
+              </a:schemeClr>
+            </a:gs>
+            <a:gs pos="40000">
+              <a:schemeClr val="phClr">
+                <a:tint val="45000"/>
+                <a:shade val="99000"/>
+                <a:satMod val="350000"/>
+              </a:schemeClr>
+            </a:gs>
+            <a:gs pos="100000">
+              <a:schemeClr val="phClr">
+                <a:shade val="20000"/>
+                <a:satMod val="255000"/>
+              </a:schemeClr>
+            </a:gs>
+          </a:gsLst>
+          <a:path path="circle">
+            <a:fillToRect l="50000" t="-80000" r="50000" b="180000"/>
+          </a:path>
+        </a:gradFill>
+        <a:gradFill rotWithShape="1">
+          <a:gsLst>
+            <a:gs pos="0">
+              <a:schemeClr val="phClr">
+                <a:tint val="80000"/>
+                <a:satMod val="300000"/>
+              </a:schemeClr>
+            </a:gs>
+            <a:gs pos="100000">
+              <a:schemeClr val="phClr">
+                <a:shade val="30000"/>
+                <a:satMod val="200000"/>
+              </a:schemeClr>
+            </a:gs>
+          </a:gsLst>
+          <a:path path="circle">
+            <a:fillToRect l="50000" t="50000" r="50000" b="50000"/>
+          </a:path>
+        </a:gradFill>
+      </a:bgFillStyleLst>
+    </a:fmtScheme>
+  </a:themeElements>
+</a:theme>
+</file>
+
+<file path=ppt/theme/theme2.xml><?xml version="1.0" encoding="utf-8"?>
 <a:theme xmlns:a="http://schemas.openxmlformats.org/drawingml/2006/main" xmlns:r="http://schemas.openxmlformats.org/officeDocument/2006/relationships" name="LF Energy Theme 2023">
   <a:themeElements>
     <a:clrScheme name="Geometric">
@@ -34280,7 +34559,7 @@
 </a:theme>
 </file>
 
-<file path=ppt/theme/theme2.xml><?xml version="1.0" encoding="utf-8"?>
+<file path=ppt/theme/theme3.xml><?xml version="1.0" encoding="utf-8"?>
 <a:theme xmlns:a="http://schemas.openxmlformats.org/drawingml/2006/main" xmlns:r="http://schemas.openxmlformats.org/officeDocument/2006/relationships">
   <a:themeElements>
     <a:clrScheme name="Default">
@@ -34557,283 +34836,4 @@
     </a:fmtScheme>
   </a:themeElements>
 </a:theme>
-</file>
-
-<file path=ppt/theme/theme3.xml><?xml version="1.0" encoding="utf-8"?>
-<a:theme xmlns:a="http://schemas.openxmlformats.org/drawingml/2006/main" xmlns:r="http://schemas.openxmlformats.org/officeDocument/2006/relationships" name="Simple Light">
-  <a:themeElements>
-    <a:clrScheme name="Simple Light">
-      <a:dk1>
-        <a:srgbClr val="000000"/>
-      </a:dk1>
-      <a:lt1>
-        <a:srgbClr val="FFFFFF"/>
-      </a:lt1>
-      <a:dk2>
-        <a:srgbClr val="595959"/>
-      </a:dk2>
-      <a:lt2>
-        <a:srgbClr val="EEEEEE"/>
-      </a:lt2>
-      <a:accent1>
-        <a:srgbClr val="4285F4"/>
-      </a:accent1>
-      <a:accent2>
-        <a:srgbClr val="212121"/>
-      </a:accent2>
-      <a:accent3>
-        <a:srgbClr val="78909C"/>
-      </a:accent3>
-      <a:accent4>
-        <a:srgbClr val="FFAB40"/>
-      </a:accent4>
-      <a:accent5>
-        <a:srgbClr val="0097A7"/>
-      </a:accent5>
-      <a:accent6>
-        <a:srgbClr val="EEFF41"/>
-      </a:accent6>
-      <a:hlink>
-        <a:srgbClr val="0097A7"/>
-      </a:hlink>
-      <a:folHlink>
-        <a:srgbClr val="0097A7"/>
-      </a:folHlink>
-    </a:clrScheme>
-    <a:fontScheme name="Office">
-      <a:majorFont>
-        <a:latin typeface="Arial"/>
-        <a:ea typeface=""/>
-        <a:cs typeface=""/>
-        <a:font script="Jpan" typeface="ＭＳ Ｐゴシック"/>
-        <a:font script="Hang" typeface="맑은 고딕"/>
-        <a:font script="Hans" typeface="宋体"/>
-        <a:font script="Hant" typeface="新細明體"/>
-        <a:font script="Arab" typeface="Times New Roman"/>
-        <a:font script="Hebr" typeface="Times New Roman"/>
-        <a:font script="Thai" typeface="Angsana New"/>
-        <a:font script="Ethi" typeface="Nyala"/>
-        <a:font script="Beng" typeface="Vrinda"/>
-        <a:font script="Gujr" typeface="Shruti"/>
-        <a:font script="Khmr" typeface="MoolBoran"/>
-        <a:font script="Knda" typeface="Tunga"/>
-        <a:font script="Guru" typeface="Raavi"/>
-        <a:font script="Cans" typeface="Euphemia"/>
-        <a:font script="Cher" typeface="Plantagenet Cherokee"/>
-        <a:font script="Yiii" typeface="Microsoft Yi Baiti"/>
-        <a:font script="Tibt" typeface="Microsoft Himalaya"/>
-        <a:font script="Thaa" typeface="MV Boli"/>
-        <a:font script="Deva" typeface="Mangal"/>
-        <a:font script="Telu" typeface="Gautami"/>
-        <a:font script="Taml" typeface="Latha"/>
-        <a:font script="Syrc" typeface="Estrangelo Edessa"/>
-        <a:font script="Orya" typeface="Kalinga"/>
-        <a:font script="Mlym" typeface="Kartika"/>
-        <a:font script="Laoo" typeface="DokChampa"/>
-        <a:font script="Sinh" typeface="Iskoola Pota"/>
-        <a:font script="Mong" typeface="Mongolian Baiti"/>
-        <a:font script="Viet" typeface="Times New Roman"/>
-        <a:font script="Uigh" typeface="Microsoft Uighur"/>
-        <a:font script="Geor" typeface="Sylfaen"/>
-      </a:majorFont>
-      <a:minorFont>
-        <a:latin typeface="Arial"/>
-        <a:ea typeface=""/>
-        <a:cs typeface=""/>
-        <a:font script="Jpan" typeface="ＭＳ Ｐゴシック"/>
-        <a:font script="Hang" typeface="맑은 고딕"/>
-        <a:font script="Hans" typeface="宋体"/>
-        <a:font script="Hant" typeface="新細明體"/>
-        <a:font script="Arab" typeface="Arial"/>
-        <a:font script="Hebr" typeface="Arial"/>
-        <a:font script="Thai" typeface="Cordia New"/>
-        <a:font script="Ethi" typeface="Nyala"/>
-        <a:font script="Beng" typeface="Vrinda"/>
-        <a:font script="Gujr" typeface="Shruti"/>
-        <a:font script="Khmr" typeface="DaunPenh"/>
-        <a:font script="Knda" typeface="Tunga"/>
-        <a:font script="Guru" typeface="Raavi"/>
-        <a:font script="Cans" typeface="Euphemia"/>
-        <a:font script="Cher" typeface="Plantagenet Cherokee"/>
-        <a:font script="Yiii" typeface="Microsoft Yi Baiti"/>
-        <a:font script="Tibt" typeface="Microsoft Himalaya"/>
-        <a:font script="Thaa" typeface="MV Boli"/>
-        <a:font script="Deva" typeface="Mangal"/>
-        <a:font script="Telu" typeface="Gautami"/>
-        <a:font script="Taml" typeface="Latha"/>
-        <a:font script="Syrc" typeface="Estrangelo Edessa"/>
-        <a:font script="Orya" typeface="Kalinga"/>
-        <a:font script="Mlym" typeface="Kartika"/>
-        <a:font script="Laoo" typeface="DokChampa"/>
-        <a:font script="Sinh" typeface="Iskoola Pota"/>
-        <a:font script="Mong" typeface="Mongolian Baiti"/>
-        <a:font script="Viet" typeface="Arial"/>
-        <a:font script="Uigh" typeface="Microsoft Uighur"/>
-        <a:font script="Geor" typeface="Sylfaen"/>
-      </a:minorFont>
-    </a:fontScheme>
-    <a:fmtScheme name="Office">
-      <a:fillStyleLst>
-        <a:solidFill>
-          <a:schemeClr val="phClr"/>
-        </a:solidFill>
-        <a:gradFill rotWithShape="1">
-          <a:gsLst>
-            <a:gs pos="0">
-              <a:schemeClr val="phClr">
-                <a:tint val="50000"/>
-                <a:satMod val="300000"/>
-              </a:schemeClr>
-            </a:gs>
-            <a:gs pos="35000">
-              <a:schemeClr val="phClr">
-                <a:tint val="37000"/>
-                <a:satMod val="300000"/>
-              </a:schemeClr>
-            </a:gs>
-            <a:gs pos="100000">
-              <a:schemeClr val="phClr">
-                <a:tint val="15000"/>
-                <a:satMod val="350000"/>
-              </a:schemeClr>
-            </a:gs>
-          </a:gsLst>
-          <a:lin ang="16200000" scaled="1"/>
-        </a:gradFill>
-        <a:gradFill rotWithShape="1">
-          <a:gsLst>
-            <a:gs pos="0">
-              <a:schemeClr val="phClr">
-                <a:tint val="100000"/>
-                <a:shade val="100000"/>
-                <a:satMod val="130000"/>
-              </a:schemeClr>
-            </a:gs>
-            <a:gs pos="100000">
-              <a:schemeClr val="phClr">
-                <a:tint val="50000"/>
-                <a:shade val="100000"/>
-                <a:satMod val="350000"/>
-              </a:schemeClr>
-            </a:gs>
-          </a:gsLst>
-          <a:lin ang="16200000" scaled="0"/>
-        </a:gradFill>
-      </a:fillStyleLst>
-      <a:lnStyleLst>
-        <a:ln w="9525" cap="flat" cmpd="sng" algn="ctr">
-          <a:solidFill>
-            <a:schemeClr val="phClr">
-              <a:shade val="95000"/>
-              <a:satMod val="105000"/>
-            </a:schemeClr>
-          </a:solidFill>
-          <a:prstDash val="solid"/>
-        </a:ln>
-        <a:ln w="25400" cap="flat" cmpd="sng" algn="ctr">
-          <a:solidFill>
-            <a:schemeClr val="phClr"/>
-          </a:solidFill>
-          <a:prstDash val="solid"/>
-        </a:ln>
-        <a:ln w="38100" cap="flat" cmpd="sng" algn="ctr">
-          <a:solidFill>
-            <a:schemeClr val="phClr"/>
-          </a:solidFill>
-          <a:prstDash val="solid"/>
-        </a:ln>
-      </a:lnStyleLst>
-      <a:effectStyleLst>
-        <a:effectStyle>
-          <a:effectLst>
-            <a:outerShdw blurRad="40000" dist="20000" dir="5400000" rotWithShape="0">
-              <a:srgbClr val="000000">
-                <a:alpha val="38000"/>
-              </a:srgbClr>
-            </a:outerShdw>
-          </a:effectLst>
-        </a:effectStyle>
-        <a:effectStyle>
-          <a:effectLst>
-            <a:outerShdw blurRad="40000" dist="23000" dir="5400000" rotWithShape="0">
-              <a:srgbClr val="000000">
-                <a:alpha val="35000"/>
-              </a:srgbClr>
-            </a:outerShdw>
-          </a:effectLst>
-        </a:effectStyle>
-        <a:effectStyle>
-          <a:effectLst>
-            <a:outerShdw blurRad="40000" dist="23000" dir="5400000" rotWithShape="0">
-              <a:srgbClr val="000000">
-                <a:alpha val="35000"/>
-              </a:srgbClr>
-            </a:outerShdw>
-          </a:effectLst>
-          <a:scene3d>
-            <a:camera prst="orthographicFront">
-              <a:rot lat="0" lon="0" rev="0"/>
-            </a:camera>
-            <a:lightRig rig="threePt" dir="t">
-              <a:rot lat="0" lon="0" rev="1200000"/>
-            </a:lightRig>
-          </a:scene3d>
-          <a:sp3d>
-            <a:bevelT w="63500" h="25400"/>
-          </a:sp3d>
-        </a:effectStyle>
-      </a:effectStyleLst>
-      <a:bgFillStyleLst>
-        <a:solidFill>
-          <a:schemeClr val="phClr"/>
-        </a:solidFill>
-        <a:gradFill rotWithShape="1">
-          <a:gsLst>
-            <a:gs pos="0">
-              <a:schemeClr val="phClr">
-                <a:tint val="40000"/>
-                <a:satMod val="350000"/>
-              </a:schemeClr>
-            </a:gs>
-            <a:gs pos="40000">
-              <a:schemeClr val="phClr">
-                <a:tint val="45000"/>
-                <a:shade val="99000"/>
-                <a:satMod val="350000"/>
-              </a:schemeClr>
-            </a:gs>
-            <a:gs pos="100000">
-              <a:schemeClr val="phClr">
-                <a:shade val="20000"/>
-                <a:satMod val="255000"/>
-              </a:schemeClr>
-            </a:gs>
-          </a:gsLst>
-          <a:path path="circle">
-            <a:fillToRect l="50000" t="-80000" r="50000" b="180000"/>
-          </a:path>
-        </a:gradFill>
-        <a:gradFill rotWithShape="1">
-          <a:gsLst>
-            <a:gs pos="0">
-              <a:schemeClr val="phClr">
-                <a:tint val="80000"/>
-                <a:satMod val="300000"/>
-              </a:schemeClr>
-            </a:gs>
-            <a:gs pos="100000">
-              <a:schemeClr val="phClr">
-                <a:shade val="30000"/>
-                <a:satMod val="200000"/>
-              </a:schemeClr>
-            </a:gs>
-          </a:gsLst>
-          <a:path path="circle">
-            <a:fillToRect l="50000" t="50000" r="50000" b="50000"/>
-          </a:path>
-        </a:gradFill>
-      </a:bgFillStyleLst>
-    </a:fmtScheme>
-  </a:themeElements>
-</a:theme>
 </file>
</xml_diff>

<commit_message>
Update Data Sources from LFX 2026-09-28 (#325)
Update Data Sources from LFX

Signed-off-by: github-actions[bot] <41898282+github-actions[bot]@users.noreply.github.com>
Co-authored-by: jmertic <296737+jmertic@users.noreply.github.com>
</commit_message>
<xml_diff>
--- a/overview_deck/LF Energy High Level Overview.pptx
+++ b/overview_deck/LF Energy High Level Overview.pptx
@@ -25946,7 +25946,7 @@
             <a:tbl>
               <a:tblPr>
                 <a:noFill/>
-                <a:tableStyleId>{14DBEEAE-F8F0-4AC9-9054-6F6D57077E99}</a:tableStyleId>
+                <a:tableStyleId>{092B7193-83F5-4ECA-8596-39049E5EAF51}</a:tableStyleId>
               </a:tblPr>
               <a:tblGrid>
                 <a:gridCol w="1695200"/>
@@ -26736,7 +26736,7 @@
             <a:tbl>
               <a:tblPr>
                 <a:noFill/>
-                <a:tableStyleId>{14DBEEAE-F8F0-4AC9-9054-6F6D57077E99}</a:tableStyleId>
+                <a:tableStyleId>{092B7193-83F5-4ECA-8596-39049E5EAF51}</a:tableStyleId>
               </a:tblPr>
               <a:tblGrid>
                 <a:gridCol w="1695200"/>
@@ -27426,7 +27426,7 @@
             <a:tbl>
               <a:tblPr>
                 <a:noFill/>
-                <a:tableStyleId>{14DBEEAE-F8F0-4AC9-9054-6F6D57077E99}</a:tableStyleId>
+                <a:tableStyleId>{092B7193-83F5-4ECA-8596-39049E5EAF51}</a:tableStyleId>
               </a:tblPr>
               <a:tblGrid>
                 <a:gridCol w="1695200"/>
@@ -28678,7 +28678,7 @@
             <a:tbl>
               <a:tblPr>
                 <a:noFill/>
-                <a:tableStyleId>{14DBEEAE-F8F0-4AC9-9054-6F6D57077E99}</a:tableStyleId>
+                <a:tableStyleId>{092B7193-83F5-4ECA-8596-39049E5EAF51}</a:tableStyleId>
               </a:tblPr>
               <a:tblGrid>
                 <a:gridCol w="1695200"/>
@@ -29670,7 +29670,7 @@
             <a:tbl>
               <a:tblPr>
                 <a:noFill/>
-                <a:tableStyleId>{14DBEEAE-F8F0-4AC9-9054-6F6D57077E99}</a:tableStyleId>
+                <a:tableStyleId>{092B7193-83F5-4ECA-8596-39049E5EAF51}</a:tableStyleId>
               </a:tblPr>
               <a:tblGrid>
                 <a:gridCol w="3048000"/>
@@ -33175,7 +33175,7 @@
             <a:tbl>
               <a:tblPr>
                 <a:noFill/>
-                <a:tableStyleId>{14DBEEAE-F8F0-4AC9-9054-6F6D57077E99}</a:tableStyleId>
+                <a:tableStyleId>{092B7193-83F5-4ECA-8596-39049E5EAF51}</a:tableStyleId>
               </a:tblPr>
               <a:tblGrid>
                 <a:gridCol w="1828800"/>
@@ -34002,44 +34002,44 @@
 </file>
 
 <file path=ppt/theme/theme1.xml><?xml version="1.0" encoding="utf-8"?>
-<a:theme xmlns:a="http://schemas.openxmlformats.org/drawingml/2006/main" xmlns:r="http://schemas.openxmlformats.org/officeDocument/2006/relationships" name="Simple Light">
+<a:theme xmlns:a="http://schemas.openxmlformats.org/drawingml/2006/main" xmlns:r="http://schemas.openxmlformats.org/officeDocument/2006/relationships" name="LF Energy Theme 2023">
   <a:themeElements>
-    <a:clrScheme name="Simple Light">
+    <a:clrScheme name="Geometric">
       <a:dk1>
-        <a:srgbClr val="000000"/>
+        <a:srgbClr val="222222"/>
       </a:dk1>
       <a:lt1>
         <a:srgbClr val="FFFFFF"/>
       </a:lt1>
       <a:dk2>
-        <a:srgbClr val="595959"/>
+        <a:srgbClr val="434343"/>
       </a:dk2>
       <a:lt2>
-        <a:srgbClr val="EEEEEE"/>
+        <a:srgbClr val="999999"/>
       </a:lt2>
       <a:accent1>
-        <a:srgbClr val="4285F4"/>
+        <a:srgbClr val="003778"/>
       </a:accent1>
       <a:accent2>
-        <a:srgbClr val="212121"/>
+        <a:srgbClr val="0094FF"/>
       </a:accent2>
       <a:accent3>
-        <a:srgbClr val="78909C"/>
+        <a:srgbClr val="5B1DE7"/>
       </a:accent3>
       <a:accent4>
-        <a:srgbClr val="FFAB40"/>
+        <a:srgbClr val="12E2E2"/>
       </a:accent4>
       <a:accent5>
-        <a:srgbClr val="0097A7"/>
+        <a:srgbClr val="FF00AA"/>
       </a:accent5>
       <a:accent6>
-        <a:srgbClr val="EEFF41"/>
+        <a:srgbClr val="ACDE1F"/>
       </a:accent6>
       <a:hlink>
-        <a:srgbClr val="0097A7"/>
+        <a:srgbClr val="0077CC"/>
       </a:hlink>
       <a:folHlink>
-        <a:srgbClr val="0097A7"/>
+        <a:srgbClr val="F06292"/>
       </a:folHlink>
     </a:clrScheme>
     <a:fontScheme name="Office">
@@ -34281,44 +34281,44 @@
 </file>
 
 <file path=ppt/theme/theme2.xml><?xml version="1.0" encoding="utf-8"?>
-<a:theme xmlns:a="http://schemas.openxmlformats.org/drawingml/2006/main" xmlns:r="http://schemas.openxmlformats.org/officeDocument/2006/relationships" name="LF Energy Theme 2023">
+<a:theme xmlns:a="http://schemas.openxmlformats.org/drawingml/2006/main" xmlns:r="http://schemas.openxmlformats.org/officeDocument/2006/relationships" name="Simple Light">
   <a:themeElements>
-    <a:clrScheme name="Geometric">
+    <a:clrScheme name="Simple Light">
       <a:dk1>
-        <a:srgbClr val="222222"/>
+        <a:srgbClr val="000000"/>
       </a:dk1>
       <a:lt1>
         <a:srgbClr val="FFFFFF"/>
       </a:lt1>
       <a:dk2>
-        <a:srgbClr val="434343"/>
+        <a:srgbClr val="595959"/>
       </a:dk2>
       <a:lt2>
-        <a:srgbClr val="999999"/>
+        <a:srgbClr val="EEEEEE"/>
       </a:lt2>
       <a:accent1>
-        <a:srgbClr val="003778"/>
+        <a:srgbClr val="4285F4"/>
       </a:accent1>
       <a:accent2>
-        <a:srgbClr val="0094FF"/>
+        <a:srgbClr val="212121"/>
       </a:accent2>
       <a:accent3>
-        <a:srgbClr val="5B1DE7"/>
+        <a:srgbClr val="78909C"/>
       </a:accent3>
       <a:accent4>
-        <a:srgbClr val="12E2E2"/>
+        <a:srgbClr val="FFAB40"/>
       </a:accent4>
       <a:accent5>
-        <a:srgbClr val="FF00AA"/>
+        <a:srgbClr val="0097A7"/>
       </a:accent5>
       <a:accent6>
-        <a:srgbClr val="ACDE1F"/>
+        <a:srgbClr val="EEFF41"/>
       </a:accent6>
       <a:hlink>
-        <a:srgbClr val="0077CC"/>
+        <a:srgbClr val="0097A7"/>
       </a:hlink>
       <a:folHlink>
-        <a:srgbClr val="F06292"/>
+        <a:srgbClr val="0097A7"/>
       </a:folHlink>
     </a:clrScheme>
     <a:fontScheme name="Office">

</xml_diff>

<commit_message>
Update Data Sources from LFX 2026-09-29 (#326)
Update Data Sources from LFX

Signed-off-by: github-actions[bot] <41898282+github-actions[bot]@users.noreply.github.com>
Co-authored-by: jmertic <296737+jmertic@users.noreply.github.com>
</commit_message>
<xml_diff>
--- a/overview_deck/LF Energy High Level Overview.pptx
+++ b/overview_deck/LF Energy High Level Overview.pptx
@@ -25946,7 +25946,7 @@
             <a:tbl>
               <a:tblPr>
                 <a:noFill/>
-                <a:tableStyleId>{092B7193-83F5-4ECA-8596-39049E5EAF51}</a:tableStyleId>
+                <a:tableStyleId>{D820BAAE-F54A-48C1-9342-180BDB6B4065}</a:tableStyleId>
               </a:tblPr>
               <a:tblGrid>
                 <a:gridCol w="1695200"/>
@@ -26736,7 +26736,7 @@
             <a:tbl>
               <a:tblPr>
                 <a:noFill/>
-                <a:tableStyleId>{092B7193-83F5-4ECA-8596-39049E5EAF51}</a:tableStyleId>
+                <a:tableStyleId>{D820BAAE-F54A-48C1-9342-180BDB6B4065}</a:tableStyleId>
               </a:tblPr>
               <a:tblGrid>
                 <a:gridCol w="1695200"/>
@@ -27426,7 +27426,7 @@
             <a:tbl>
               <a:tblPr>
                 <a:noFill/>
-                <a:tableStyleId>{092B7193-83F5-4ECA-8596-39049E5EAF51}</a:tableStyleId>
+                <a:tableStyleId>{D820BAAE-F54A-48C1-9342-180BDB6B4065}</a:tableStyleId>
               </a:tblPr>
               <a:tblGrid>
                 <a:gridCol w="1695200"/>
@@ -28678,7 +28678,7 @@
             <a:tbl>
               <a:tblPr>
                 <a:noFill/>
-                <a:tableStyleId>{092B7193-83F5-4ECA-8596-39049E5EAF51}</a:tableStyleId>
+                <a:tableStyleId>{D820BAAE-F54A-48C1-9342-180BDB6B4065}</a:tableStyleId>
               </a:tblPr>
               <a:tblGrid>
                 <a:gridCol w="1695200"/>
@@ -29670,7 +29670,7 @@
             <a:tbl>
               <a:tblPr>
                 <a:noFill/>
-                <a:tableStyleId>{092B7193-83F5-4ECA-8596-39049E5EAF51}</a:tableStyleId>
+                <a:tableStyleId>{D820BAAE-F54A-48C1-9342-180BDB6B4065}</a:tableStyleId>
               </a:tblPr>
               <a:tblGrid>
                 <a:gridCol w="3048000"/>
@@ -33175,7 +33175,7 @@
             <a:tbl>
               <a:tblPr>
                 <a:noFill/>
-                <a:tableStyleId>{092B7193-83F5-4ECA-8596-39049E5EAF51}</a:tableStyleId>
+                <a:tableStyleId>{D820BAAE-F54A-48C1-9342-180BDB6B4065}</a:tableStyleId>
               </a:tblPr>
               <a:tblGrid>
                 <a:gridCol w="1828800"/>
@@ -34002,44 +34002,44 @@
 </file>
 
 <file path=ppt/theme/theme1.xml><?xml version="1.0" encoding="utf-8"?>
-<a:theme xmlns:a="http://schemas.openxmlformats.org/drawingml/2006/main" xmlns:r="http://schemas.openxmlformats.org/officeDocument/2006/relationships" name="LF Energy Theme 2023">
+<a:theme xmlns:a="http://schemas.openxmlformats.org/drawingml/2006/main" xmlns:r="http://schemas.openxmlformats.org/officeDocument/2006/relationships">
   <a:themeElements>
-    <a:clrScheme name="Geometric">
+    <a:clrScheme name="Default">
       <a:dk1>
-        <a:srgbClr val="222222"/>
+        <a:srgbClr val="000000"/>
       </a:dk1>
       <a:lt1>
         <a:srgbClr val="FFFFFF"/>
       </a:lt1>
       <a:dk2>
-        <a:srgbClr val="434343"/>
+        <a:srgbClr val="158158"/>
       </a:dk2>
       <a:lt2>
-        <a:srgbClr val="999999"/>
+        <a:srgbClr val="F3F3F3"/>
       </a:lt2>
       <a:accent1>
-        <a:srgbClr val="003778"/>
+        <a:srgbClr val="058DC7"/>
       </a:accent1>
       <a:accent2>
-        <a:srgbClr val="0094FF"/>
+        <a:srgbClr val="50B432"/>
       </a:accent2>
       <a:accent3>
-        <a:srgbClr val="5B1DE7"/>
+        <a:srgbClr val="ED561B"/>
       </a:accent3>
       <a:accent4>
-        <a:srgbClr val="12E2E2"/>
+        <a:srgbClr val="EDEF00"/>
       </a:accent4>
       <a:accent5>
-        <a:srgbClr val="FF00AA"/>
+        <a:srgbClr val="24CBE5"/>
       </a:accent5>
       <a:accent6>
-        <a:srgbClr val="ACDE1F"/>
+        <a:srgbClr val="64E572"/>
       </a:accent6>
       <a:hlink>
-        <a:srgbClr val="0077CC"/>
+        <a:srgbClr val="2200CC"/>
       </a:hlink>
       <a:folHlink>
-        <a:srgbClr val="F06292"/>
+        <a:srgbClr val="551A8B"/>
       </a:folHlink>
     </a:clrScheme>
     <a:fontScheme name="Office">
@@ -34560,44 +34560,44 @@
 </file>
 
 <file path=ppt/theme/theme3.xml><?xml version="1.0" encoding="utf-8"?>
-<a:theme xmlns:a="http://schemas.openxmlformats.org/drawingml/2006/main" xmlns:r="http://schemas.openxmlformats.org/officeDocument/2006/relationships">
+<a:theme xmlns:a="http://schemas.openxmlformats.org/drawingml/2006/main" xmlns:r="http://schemas.openxmlformats.org/officeDocument/2006/relationships" name="LF Energy Theme 2023">
   <a:themeElements>
-    <a:clrScheme name="Default">
+    <a:clrScheme name="Geometric">
       <a:dk1>
-        <a:srgbClr val="000000"/>
+        <a:srgbClr val="222222"/>
       </a:dk1>
       <a:lt1>
         <a:srgbClr val="FFFFFF"/>
       </a:lt1>
       <a:dk2>
-        <a:srgbClr val="158158"/>
+        <a:srgbClr val="434343"/>
       </a:dk2>
       <a:lt2>
-        <a:srgbClr val="F3F3F3"/>
+        <a:srgbClr val="999999"/>
       </a:lt2>
       <a:accent1>
-        <a:srgbClr val="058DC7"/>
+        <a:srgbClr val="003778"/>
       </a:accent1>
       <a:accent2>
-        <a:srgbClr val="50B432"/>
+        <a:srgbClr val="0094FF"/>
       </a:accent2>
       <a:accent3>
-        <a:srgbClr val="ED561B"/>
+        <a:srgbClr val="5B1DE7"/>
       </a:accent3>
       <a:accent4>
-        <a:srgbClr val="EDEF00"/>
+        <a:srgbClr val="12E2E2"/>
       </a:accent4>
       <a:accent5>
-        <a:srgbClr val="24CBE5"/>
+        <a:srgbClr val="FF00AA"/>
       </a:accent5>
       <a:accent6>
-        <a:srgbClr val="64E572"/>
+        <a:srgbClr val="ACDE1F"/>
       </a:accent6>
       <a:hlink>
-        <a:srgbClr val="2200CC"/>
+        <a:srgbClr val="0077CC"/>
       </a:hlink>
       <a:folHlink>
-        <a:srgbClr val="551A8B"/>
+        <a:srgbClr val="F06292"/>
       </a:folHlink>
     </a:clrScheme>
     <a:fontScheme name="Office">

</xml_diff>

<commit_message>
Update Data Sources from LFX 2026-09-30 (#327)
Update Data Sources from LFX

Signed-off-by: github-actions[bot] <41898282+github-actions[bot]@users.noreply.github.com>
Co-authored-by: jmertic <296737+jmertic@users.noreply.github.com>
</commit_message>
<xml_diff>
--- a/overview_deck/LF Energy High Level Overview.pptx
+++ b/overview_deck/LF Energy High Level Overview.pptx
@@ -25946,7 +25946,7 @@
             <a:tbl>
               <a:tblPr>
                 <a:noFill/>
-                <a:tableStyleId>{D820BAAE-F54A-48C1-9342-180BDB6B4065}</a:tableStyleId>
+                <a:tableStyleId>{B8743240-F8DD-4BA2-B61A-FE88CBEDEB5A}</a:tableStyleId>
               </a:tblPr>
               <a:tblGrid>
                 <a:gridCol w="1695200"/>
@@ -26736,7 +26736,7 @@
             <a:tbl>
               <a:tblPr>
                 <a:noFill/>
-                <a:tableStyleId>{D820BAAE-F54A-48C1-9342-180BDB6B4065}</a:tableStyleId>
+                <a:tableStyleId>{B8743240-F8DD-4BA2-B61A-FE88CBEDEB5A}</a:tableStyleId>
               </a:tblPr>
               <a:tblGrid>
                 <a:gridCol w="1695200"/>
@@ -27426,7 +27426,7 @@
             <a:tbl>
               <a:tblPr>
                 <a:noFill/>
-                <a:tableStyleId>{D820BAAE-F54A-48C1-9342-180BDB6B4065}</a:tableStyleId>
+                <a:tableStyleId>{B8743240-F8DD-4BA2-B61A-FE88CBEDEB5A}</a:tableStyleId>
               </a:tblPr>
               <a:tblGrid>
                 <a:gridCol w="1695200"/>
@@ -28678,7 +28678,7 @@
             <a:tbl>
               <a:tblPr>
                 <a:noFill/>
-                <a:tableStyleId>{D820BAAE-F54A-48C1-9342-180BDB6B4065}</a:tableStyleId>
+                <a:tableStyleId>{B8743240-F8DD-4BA2-B61A-FE88CBEDEB5A}</a:tableStyleId>
               </a:tblPr>
               <a:tblGrid>
                 <a:gridCol w="1695200"/>
@@ -29670,7 +29670,7 @@
             <a:tbl>
               <a:tblPr>
                 <a:noFill/>
-                <a:tableStyleId>{D820BAAE-F54A-48C1-9342-180BDB6B4065}</a:tableStyleId>
+                <a:tableStyleId>{B8743240-F8DD-4BA2-B61A-FE88CBEDEB5A}</a:tableStyleId>
               </a:tblPr>
               <a:tblGrid>
                 <a:gridCol w="3048000"/>
@@ -33175,7 +33175,7 @@
             <a:tbl>
               <a:tblPr>
                 <a:noFill/>
-                <a:tableStyleId>{D820BAAE-F54A-48C1-9342-180BDB6B4065}</a:tableStyleId>
+                <a:tableStyleId>{B8743240-F8DD-4BA2-B61A-FE88CBEDEB5A}</a:tableStyleId>
               </a:tblPr>
               <a:tblGrid>
                 <a:gridCol w="1828800"/>
@@ -34002,9 +34002,9 @@
 </file>
 
 <file path=ppt/theme/theme1.xml><?xml version="1.0" encoding="utf-8"?>
-<a:theme xmlns:a="http://schemas.openxmlformats.org/drawingml/2006/main" xmlns:r="http://schemas.openxmlformats.org/officeDocument/2006/relationships">
+<a:theme xmlns:a="http://schemas.openxmlformats.org/drawingml/2006/main" xmlns:r="http://schemas.openxmlformats.org/officeDocument/2006/relationships" name="Simple Light">
   <a:themeElements>
-    <a:clrScheme name="Default">
+    <a:clrScheme name="Simple Light">
       <a:dk1>
         <a:srgbClr val="000000"/>
       </a:dk1>
@@ -34012,34 +34012,34 @@
         <a:srgbClr val="FFFFFF"/>
       </a:lt1>
       <a:dk2>
-        <a:srgbClr val="158158"/>
+        <a:srgbClr val="595959"/>
       </a:dk2>
       <a:lt2>
-        <a:srgbClr val="F3F3F3"/>
+        <a:srgbClr val="EEEEEE"/>
       </a:lt2>
       <a:accent1>
-        <a:srgbClr val="058DC7"/>
+        <a:srgbClr val="4285F4"/>
       </a:accent1>
       <a:accent2>
-        <a:srgbClr val="50B432"/>
+        <a:srgbClr val="212121"/>
       </a:accent2>
       <a:accent3>
-        <a:srgbClr val="ED561B"/>
+        <a:srgbClr val="78909C"/>
       </a:accent3>
       <a:accent4>
-        <a:srgbClr val="EDEF00"/>
+        <a:srgbClr val="FFAB40"/>
       </a:accent4>
       <a:accent5>
-        <a:srgbClr val="24CBE5"/>
+        <a:srgbClr val="0097A7"/>
       </a:accent5>
       <a:accent6>
-        <a:srgbClr val="64E572"/>
+        <a:srgbClr val="EEFF41"/>
       </a:accent6>
       <a:hlink>
-        <a:srgbClr val="2200CC"/>
+        <a:srgbClr val="0097A7"/>
       </a:hlink>
       <a:folHlink>
-        <a:srgbClr val="551A8B"/>
+        <a:srgbClr val="0097A7"/>
       </a:folHlink>
     </a:clrScheme>
     <a:fontScheme name="Office">
@@ -34281,9 +34281,9 @@
 </file>
 
 <file path=ppt/theme/theme2.xml><?xml version="1.0" encoding="utf-8"?>
-<a:theme xmlns:a="http://schemas.openxmlformats.org/drawingml/2006/main" xmlns:r="http://schemas.openxmlformats.org/officeDocument/2006/relationships" name="Simple Light">
+<a:theme xmlns:a="http://schemas.openxmlformats.org/drawingml/2006/main" xmlns:r="http://schemas.openxmlformats.org/officeDocument/2006/relationships">
   <a:themeElements>
-    <a:clrScheme name="Simple Light">
+    <a:clrScheme name="Default">
       <a:dk1>
         <a:srgbClr val="000000"/>
       </a:dk1>
@@ -34291,34 +34291,34 @@
         <a:srgbClr val="FFFFFF"/>
       </a:lt1>
       <a:dk2>
-        <a:srgbClr val="595959"/>
+        <a:srgbClr val="158158"/>
       </a:dk2>
       <a:lt2>
-        <a:srgbClr val="EEEEEE"/>
+        <a:srgbClr val="F3F3F3"/>
       </a:lt2>
       <a:accent1>
-        <a:srgbClr val="4285F4"/>
+        <a:srgbClr val="058DC7"/>
       </a:accent1>
       <a:accent2>
-        <a:srgbClr val="212121"/>
+        <a:srgbClr val="50B432"/>
       </a:accent2>
       <a:accent3>
-        <a:srgbClr val="78909C"/>
+        <a:srgbClr val="ED561B"/>
       </a:accent3>
       <a:accent4>
-        <a:srgbClr val="FFAB40"/>
+        <a:srgbClr val="EDEF00"/>
       </a:accent4>
       <a:accent5>
-        <a:srgbClr val="0097A7"/>
+        <a:srgbClr val="24CBE5"/>
       </a:accent5>
       <a:accent6>
-        <a:srgbClr val="EEFF41"/>
+        <a:srgbClr val="64E572"/>
       </a:accent6>
       <a:hlink>
-        <a:srgbClr val="0097A7"/>
+        <a:srgbClr val="2200CC"/>
       </a:hlink>
       <a:folHlink>
-        <a:srgbClr val="0097A7"/>
+        <a:srgbClr val="551A8B"/>
       </a:folHlink>
     </a:clrScheme>
     <a:fontScheme name="Office">

</xml_diff>

<commit_message>
Update Data Sources from LFX 2026-10-01 (#328)
Update Data Sources from LFX

Signed-off-by: github-actions[bot] <41898282+github-actions[bot]@users.noreply.github.com>
Co-authored-by: jmertic <296737+jmertic@users.noreply.github.com>
</commit_message>
<xml_diff>
--- a/overview_deck/LF Energy High Level Overview.pptx
+++ b/overview_deck/LF Energy High Level Overview.pptx
@@ -25946,7 +25946,7 @@
             <a:tbl>
               <a:tblPr>
                 <a:noFill/>
-                <a:tableStyleId>{B8743240-F8DD-4BA2-B61A-FE88CBEDEB5A}</a:tableStyleId>
+                <a:tableStyleId>{BC4E7B9E-0B1C-4749-AB4E-4EF5DEE3867A}</a:tableStyleId>
               </a:tblPr>
               <a:tblGrid>
                 <a:gridCol w="1695200"/>
@@ -26736,7 +26736,7 @@
             <a:tbl>
               <a:tblPr>
                 <a:noFill/>
-                <a:tableStyleId>{B8743240-F8DD-4BA2-B61A-FE88CBEDEB5A}</a:tableStyleId>
+                <a:tableStyleId>{BC4E7B9E-0B1C-4749-AB4E-4EF5DEE3867A}</a:tableStyleId>
               </a:tblPr>
               <a:tblGrid>
                 <a:gridCol w="1695200"/>
@@ -27426,7 +27426,7 @@
             <a:tbl>
               <a:tblPr>
                 <a:noFill/>
-                <a:tableStyleId>{B8743240-F8DD-4BA2-B61A-FE88CBEDEB5A}</a:tableStyleId>
+                <a:tableStyleId>{BC4E7B9E-0B1C-4749-AB4E-4EF5DEE3867A}</a:tableStyleId>
               </a:tblPr>
               <a:tblGrid>
                 <a:gridCol w="1695200"/>
@@ -28678,7 +28678,7 @@
             <a:tbl>
               <a:tblPr>
                 <a:noFill/>
-                <a:tableStyleId>{B8743240-F8DD-4BA2-B61A-FE88CBEDEB5A}</a:tableStyleId>
+                <a:tableStyleId>{BC4E7B9E-0B1C-4749-AB4E-4EF5DEE3867A}</a:tableStyleId>
               </a:tblPr>
               <a:tblGrid>
                 <a:gridCol w="1695200"/>
@@ -29670,7 +29670,7 @@
             <a:tbl>
               <a:tblPr>
                 <a:noFill/>
-                <a:tableStyleId>{B8743240-F8DD-4BA2-B61A-FE88CBEDEB5A}</a:tableStyleId>
+                <a:tableStyleId>{BC4E7B9E-0B1C-4749-AB4E-4EF5DEE3867A}</a:tableStyleId>
               </a:tblPr>
               <a:tblGrid>
                 <a:gridCol w="3048000"/>
@@ -33175,7 +33175,7 @@
             <a:tbl>
               <a:tblPr>
                 <a:noFill/>
-                <a:tableStyleId>{B8743240-F8DD-4BA2-B61A-FE88CBEDEB5A}</a:tableStyleId>
+                <a:tableStyleId>{BC4E7B9E-0B1C-4749-AB4E-4EF5DEE3867A}</a:tableStyleId>
               </a:tblPr>
               <a:tblGrid>
                 <a:gridCol w="1828800"/>
@@ -34002,44 +34002,44 @@
 </file>
 
 <file path=ppt/theme/theme1.xml><?xml version="1.0" encoding="utf-8"?>
-<a:theme xmlns:a="http://schemas.openxmlformats.org/drawingml/2006/main" xmlns:r="http://schemas.openxmlformats.org/officeDocument/2006/relationships" name="Simple Light">
+<a:theme xmlns:a="http://schemas.openxmlformats.org/drawingml/2006/main" xmlns:r="http://schemas.openxmlformats.org/officeDocument/2006/relationships" name="LF Energy Theme 2023">
   <a:themeElements>
-    <a:clrScheme name="Simple Light">
+    <a:clrScheme name="Geometric">
       <a:dk1>
-        <a:srgbClr val="000000"/>
+        <a:srgbClr val="222222"/>
       </a:dk1>
       <a:lt1>
         <a:srgbClr val="FFFFFF"/>
       </a:lt1>
       <a:dk2>
-        <a:srgbClr val="595959"/>
+        <a:srgbClr val="434343"/>
       </a:dk2>
       <a:lt2>
-        <a:srgbClr val="EEEEEE"/>
+        <a:srgbClr val="999999"/>
       </a:lt2>
       <a:accent1>
-        <a:srgbClr val="4285F4"/>
+        <a:srgbClr val="003778"/>
       </a:accent1>
       <a:accent2>
-        <a:srgbClr val="212121"/>
+        <a:srgbClr val="0094FF"/>
       </a:accent2>
       <a:accent3>
-        <a:srgbClr val="78909C"/>
+        <a:srgbClr val="5B1DE7"/>
       </a:accent3>
       <a:accent4>
-        <a:srgbClr val="FFAB40"/>
+        <a:srgbClr val="12E2E2"/>
       </a:accent4>
       <a:accent5>
-        <a:srgbClr val="0097A7"/>
+        <a:srgbClr val="FF00AA"/>
       </a:accent5>
       <a:accent6>
-        <a:srgbClr val="EEFF41"/>
+        <a:srgbClr val="ACDE1F"/>
       </a:accent6>
       <a:hlink>
-        <a:srgbClr val="0097A7"/>
+        <a:srgbClr val="0077CC"/>
       </a:hlink>
       <a:folHlink>
-        <a:srgbClr val="0097A7"/>
+        <a:srgbClr val="F06292"/>
       </a:folHlink>
     </a:clrScheme>
     <a:fontScheme name="Office">
@@ -34560,44 +34560,44 @@
 </file>
 
 <file path=ppt/theme/theme3.xml><?xml version="1.0" encoding="utf-8"?>
-<a:theme xmlns:a="http://schemas.openxmlformats.org/drawingml/2006/main" xmlns:r="http://schemas.openxmlformats.org/officeDocument/2006/relationships" name="LF Energy Theme 2023">
+<a:theme xmlns:a="http://schemas.openxmlformats.org/drawingml/2006/main" xmlns:r="http://schemas.openxmlformats.org/officeDocument/2006/relationships" name="Simple Light">
   <a:themeElements>
-    <a:clrScheme name="Geometric">
+    <a:clrScheme name="Simple Light">
       <a:dk1>
-        <a:srgbClr val="222222"/>
+        <a:srgbClr val="000000"/>
       </a:dk1>
       <a:lt1>
         <a:srgbClr val="FFFFFF"/>
       </a:lt1>
       <a:dk2>
-        <a:srgbClr val="434343"/>
+        <a:srgbClr val="595959"/>
       </a:dk2>
       <a:lt2>
-        <a:srgbClr val="999999"/>
+        <a:srgbClr val="EEEEEE"/>
       </a:lt2>
       <a:accent1>
-        <a:srgbClr val="003778"/>
+        <a:srgbClr val="4285F4"/>
       </a:accent1>
       <a:accent2>
-        <a:srgbClr val="0094FF"/>
+        <a:srgbClr val="212121"/>
       </a:accent2>
       <a:accent3>
-        <a:srgbClr val="5B1DE7"/>
+        <a:srgbClr val="78909C"/>
       </a:accent3>
       <a:accent4>
-        <a:srgbClr val="12E2E2"/>
+        <a:srgbClr val="FFAB40"/>
       </a:accent4>
       <a:accent5>
-        <a:srgbClr val="FF00AA"/>
+        <a:srgbClr val="0097A7"/>
       </a:accent5>
       <a:accent6>
-        <a:srgbClr val="ACDE1F"/>
+        <a:srgbClr val="EEFF41"/>
       </a:accent6>
       <a:hlink>
-        <a:srgbClr val="0077CC"/>
+        <a:srgbClr val="0097A7"/>
       </a:hlink>
       <a:folHlink>
-        <a:srgbClr val="F06292"/>
+        <a:srgbClr val="0097A7"/>
       </a:folHlink>
     </a:clrScheme>
     <a:fontScheme name="Office">

</xml_diff>

<commit_message>
Update Data Sources from LFX 2026-10-02 (#329)
Update Data Sources from LFX

Signed-off-by: github-actions[bot] <41898282+github-actions[bot]@users.noreply.github.com>
Co-authored-by: jmertic <296737+jmertic@users.noreply.github.com>
</commit_message>
<xml_diff>
--- a/overview_deck/LF Energy High Level Overview.pptx
+++ b/overview_deck/LF Energy High Level Overview.pptx
@@ -25946,7 +25946,7 @@
             <a:tbl>
               <a:tblPr>
                 <a:noFill/>
-                <a:tableStyleId>{BC4E7B9E-0B1C-4749-AB4E-4EF5DEE3867A}</a:tableStyleId>
+                <a:tableStyleId>{70D67422-12BF-4A30-8481-A135D1477BF2}</a:tableStyleId>
               </a:tblPr>
               <a:tblGrid>
                 <a:gridCol w="1695200"/>
@@ -26736,7 +26736,7 @@
             <a:tbl>
               <a:tblPr>
                 <a:noFill/>
-                <a:tableStyleId>{BC4E7B9E-0B1C-4749-AB4E-4EF5DEE3867A}</a:tableStyleId>
+                <a:tableStyleId>{70D67422-12BF-4A30-8481-A135D1477BF2}</a:tableStyleId>
               </a:tblPr>
               <a:tblGrid>
                 <a:gridCol w="1695200"/>
@@ -27426,7 +27426,7 @@
             <a:tbl>
               <a:tblPr>
                 <a:noFill/>
-                <a:tableStyleId>{BC4E7B9E-0B1C-4749-AB4E-4EF5DEE3867A}</a:tableStyleId>
+                <a:tableStyleId>{70D67422-12BF-4A30-8481-A135D1477BF2}</a:tableStyleId>
               </a:tblPr>
               <a:tblGrid>
                 <a:gridCol w="1695200"/>
@@ -28678,7 +28678,7 @@
             <a:tbl>
               <a:tblPr>
                 <a:noFill/>
-                <a:tableStyleId>{BC4E7B9E-0B1C-4749-AB4E-4EF5DEE3867A}</a:tableStyleId>
+                <a:tableStyleId>{70D67422-12BF-4A30-8481-A135D1477BF2}</a:tableStyleId>
               </a:tblPr>
               <a:tblGrid>
                 <a:gridCol w="1695200"/>
@@ -29670,7 +29670,7 @@
             <a:tbl>
               <a:tblPr>
                 <a:noFill/>
-                <a:tableStyleId>{BC4E7B9E-0B1C-4749-AB4E-4EF5DEE3867A}</a:tableStyleId>
+                <a:tableStyleId>{70D67422-12BF-4A30-8481-A135D1477BF2}</a:tableStyleId>
               </a:tblPr>
               <a:tblGrid>
                 <a:gridCol w="3048000"/>
@@ -33175,7 +33175,7 @@
             <a:tbl>
               <a:tblPr>
                 <a:noFill/>
-                <a:tableStyleId>{BC4E7B9E-0B1C-4749-AB4E-4EF5DEE3867A}</a:tableStyleId>
+                <a:tableStyleId>{70D67422-12BF-4A30-8481-A135D1477BF2}</a:tableStyleId>
               </a:tblPr>
               <a:tblGrid>
                 <a:gridCol w="1828800"/>
@@ -34002,285 +34002,6 @@
 </file>
 
 <file path=ppt/theme/theme1.xml><?xml version="1.0" encoding="utf-8"?>
-<a:theme xmlns:a="http://schemas.openxmlformats.org/drawingml/2006/main" xmlns:r="http://schemas.openxmlformats.org/officeDocument/2006/relationships" name="LF Energy Theme 2023">
-  <a:themeElements>
-    <a:clrScheme name="Geometric">
-      <a:dk1>
-        <a:srgbClr val="222222"/>
-      </a:dk1>
-      <a:lt1>
-        <a:srgbClr val="FFFFFF"/>
-      </a:lt1>
-      <a:dk2>
-        <a:srgbClr val="434343"/>
-      </a:dk2>
-      <a:lt2>
-        <a:srgbClr val="999999"/>
-      </a:lt2>
-      <a:accent1>
-        <a:srgbClr val="003778"/>
-      </a:accent1>
-      <a:accent2>
-        <a:srgbClr val="0094FF"/>
-      </a:accent2>
-      <a:accent3>
-        <a:srgbClr val="5B1DE7"/>
-      </a:accent3>
-      <a:accent4>
-        <a:srgbClr val="12E2E2"/>
-      </a:accent4>
-      <a:accent5>
-        <a:srgbClr val="FF00AA"/>
-      </a:accent5>
-      <a:accent6>
-        <a:srgbClr val="ACDE1F"/>
-      </a:accent6>
-      <a:hlink>
-        <a:srgbClr val="0077CC"/>
-      </a:hlink>
-      <a:folHlink>
-        <a:srgbClr val="F06292"/>
-      </a:folHlink>
-    </a:clrScheme>
-    <a:fontScheme name="Office">
-      <a:majorFont>
-        <a:latin typeface="Arial"/>
-        <a:ea typeface=""/>
-        <a:cs typeface=""/>
-        <a:font script="Jpan" typeface="ＭＳ Ｐゴシック"/>
-        <a:font script="Hang" typeface="맑은 고딕"/>
-        <a:font script="Hans" typeface="宋体"/>
-        <a:font script="Hant" typeface="新細明體"/>
-        <a:font script="Arab" typeface="Times New Roman"/>
-        <a:font script="Hebr" typeface="Times New Roman"/>
-        <a:font script="Thai" typeface="Angsana New"/>
-        <a:font script="Ethi" typeface="Nyala"/>
-        <a:font script="Beng" typeface="Vrinda"/>
-        <a:font script="Gujr" typeface="Shruti"/>
-        <a:font script="Khmr" typeface="MoolBoran"/>
-        <a:font script="Knda" typeface="Tunga"/>
-        <a:font script="Guru" typeface="Raavi"/>
-        <a:font script="Cans" typeface="Euphemia"/>
-        <a:font script="Cher" typeface="Plantagenet Cherokee"/>
-        <a:font script="Yiii" typeface="Microsoft Yi Baiti"/>
-        <a:font script="Tibt" typeface="Microsoft Himalaya"/>
-        <a:font script="Thaa" typeface="MV Boli"/>
-        <a:font script="Deva" typeface="Mangal"/>
-        <a:font script="Telu" typeface="Gautami"/>
-        <a:font script="Taml" typeface="Latha"/>
-        <a:font script="Syrc" typeface="Estrangelo Edessa"/>
-        <a:font script="Orya" typeface="Kalinga"/>
-        <a:font script="Mlym" typeface="Kartika"/>
-        <a:font script="Laoo" typeface="DokChampa"/>
-        <a:font script="Sinh" typeface="Iskoola Pota"/>
-        <a:font script="Mong" typeface="Mongolian Baiti"/>
-        <a:font script="Viet" typeface="Times New Roman"/>
-        <a:font script="Uigh" typeface="Microsoft Uighur"/>
-        <a:font script="Geor" typeface="Sylfaen"/>
-      </a:majorFont>
-      <a:minorFont>
-        <a:latin typeface="Arial"/>
-        <a:ea typeface=""/>
-        <a:cs typeface=""/>
-        <a:font script="Jpan" typeface="ＭＳ Ｐゴシック"/>
-        <a:font script="Hang" typeface="맑은 고딕"/>
-        <a:font script="Hans" typeface="宋体"/>
-        <a:font script="Hant" typeface="新細明體"/>
-        <a:font script="Arab" typeface="Arial"/>
-        <a:font script="Hebr" typeface="Arial"/>
-        <a:font script="Thai" typeface="Cordia New"/>
-        <a:font script="Ethi" typeface="Nyala"/>
-        <a:font script="Beng" typeface="Vrinda"/>
-        <a:font script="Gujr" typeface="Shruti"/>
-        <a:font script="Khmr" typeface="DaunPenh"/>
-        <a:font script="Knda" typeface="Tunga"/>
-        <a:font script="Guru" typeface="Raavi"/>
-        <a:font script="Cans" typeface="Euphemia"/>
-        <a:font script="Cher" typeface="Plantagenet Cherokee"/>
-        <a:font script="Yiii" typeface="Microsoft Yi Baiti"/>
-        <a:font script="Tibt" typeface="Microsoft Himalaya"/>
-        <a:font script="Thaa" typeface="MV Boli"/>
-        <a:font script="Deva" typeface="Mangal"/>
-        <a:font script="Telu" typeface="Gautami"/>
-        <a:font script="Taml" typeface="Latha"/>
-        <a:font script="Syrc" typeface="Estrangelo Edessa"/>
-        <a:font script="Orya" typeface="Kalinga"/>
-        <a:font script="Mlym" typeface="Kartika"/>
-        <a:font script="Laoo" typeface="DokChampa"/>
-        <a:font script="Sinh" typeface="Iskoola Pota"/>
-        <a:font script="Mong" typeface="Mongolian Baiti"/>
-        <a:font script="Viet" typeface="Arial"/>
-        <a:font script="Uigh" typeface="Microsoft Uighur"/>
-        <a:font script="Geor" typeface="Sylfaen"/>
-      </a:minorFont>
-    </a:fontScheme>
-    <a:fmtScheme name="Office">
-      <a:fillStyleLst>
-        <a:solidFill>
-          <a:schemeClr val="phClr"/>
-        </a:solidFill>
-        <a:gradFill rotWithShape="1">
-          <a:gsLst>
-            <a:gs pos="0">
-              <a:schemeClr val="phClr">
-                <a:tint val="50000"/>
-                <a:satMod val="300000"/>
-              </a:schemeClr>
-            </a:gs>
-            <a:gs pos="35000">
-              <a:schemeClr val="phClr">
-                <a:tint val="37000"/>
-                <a:satMod val="300000"/>
-              </a:schemeClr>
-            </a:gs>
-            <a:gs pos="100000">
-              <a:schemeClr val="phClr">
-                <a:tint val="15000"/>
-                <a:satMod val="350000"/>
-              </a:schemeClr>
-            </a:gs>
-          </a:gsLst>
-          <a:lin ang="16200000" scaled="1"/>
-        </a:gradFill>
-        <a:gradFill rotWithShape="1">
-          <a:gsLst>
-            <a:gs pos="0">
-              <a:schemeClr val="phClr">
-                <a:tint val="100000"/>
-                <a:shade val="100000"/>
-                <a:satMod val="130000"/>
-              </a:schemeClr>
-            </a:gs>
-            <a:gs pos="100000">
-              <a:schemeClr val="phClr">
-                <a:tint val="50000"/>
-                <a:shade val="100000"/>
-                <a:satMod val="350000"/>
-              </a:schemeClr>
-            </a:gs>
-          </a:gsLst>
-          <a:lin ang="16200000" scaled="0"/>
-        </a:gradFill>
-      </a:fillStyleLst>
-      <a:lnStyleLst>
-        <a:ln w="9525" cap="flat" cmpd="sng" algn="ctr">
-          <a:solidFill>
-            <a:schemeClr val="phClr">
-              <a:shade val="95000"/>
-              <a:satMod val="105000"/>
-            </a:schemeClr>
-          </a:solidFill>
-          <a:prstDash val="solid"/>
-        </a:ln>
-        <a:ln w="25400" cap="flat" cmpd="sng" algn="ctr">
-          <a:solidFill>
-            <a:schemeClr val="phClr"/>
-          </a:solidFill>
-          <a:prstDash val="solid"/>
-        </a:ln>
-        <a:ln w="38100" cap="flat" cmpd="sng" algn="ctr">
-          <a:solidFill>
-            <a:schemeClr val="phClr"/>
-          </a:solidFill>
-          <a:prstDash val="solid"/>
-        </a:ln>
-      </a:lnStyleLst>
-      <a:effectStyleLst>
-        <a:effectStyle>
-          <a:effectLst>
-            <a:outerShdw blurRad="40000" dist="20000" dir="5400000" rotWithShape="0">
-              <a:srgbClr val="000000">
-                <a:alpha val="38000"/>
-              </a:srgbClr>
-            </a:outerShdw>
-          </a:effectLst>
-        </a:effectStyle>
-        <a:effectStyle>
-          <a:effectLst>
-            <a:outerShdw blurRad="40000" dist="23000" dir="5400000" rotWithShape="0">
-              <a:srgbClr val="000000">
-                <a:alpha val="35000"/>
-              </a:srgbClr>
-            </a:outerShdw>
-          </a:effectLst>
-        </a:effectStyle>
-        <a:effectStyle>
-          <a:effectLst>
-            <a:outerShdw blurRad="40000" dist="23000" dir="5400000" rotWithShape="0">
-              <a:srgbClr val="000000">
-                <a:alpha val="35000"/>
-              </a:srgbClr>
-            </a:outerShdw>
-          </a:effectLst>
-          <a:scene3d>
-            <a:camera prst="orthographicFront">
-              <a:rot lat="0" lon="0" rev="0"/>
-            </a:camera>
-            <a:lightRig rig="threePt" dir="t">
-              <a:rot lat="0" lon="0" rev="1200000"/>
-            </a:lightRig>
-          </a:scene3d>
-          <a:sp3d>
-            <a:bevelT w="63500" h="25400"/>
-          </a:sp3d>
-        </a:effectStyle>
-      </a:effectStyleLst>
-      <a:bgFillStyleLst>
-        <a:solidFill>
-          <a:schemeClr val="phClr"/>
-        </a:solidFill>
-        <a:gradFill rotWithShape="1">
-          <a:gsLst>
-            <a:gs pos="0">
-              <a:schemeClr val="phClr">
-                <a:tint val="40000"/>
-                <a:satMod val="350000"/>
-              </a:schemeClr>
-            </a:gs>
-            <a:gs pos="40000">
-              <a:schemeClr val="phClr">
-                <a:tint val="45000"/>
-                <a:shade val="99000"/>
-                <a:satMod val="350000"/>
-              </a:schemeClr>
-            </a:gs>
-            <a:gs pos="100000">
-              <a:schemeClr val="phClr">
-                <a:shade val="20000"/>
-                <a:satMod val="255000"/>
-              </a:schemeClr>
-            </a:gs>
-          </a:gsLst>
-          <a:path path="circle">
-            <a:fillToRect l="50000" t="-80000" r="50000" b="180000"/>
-          </a:path>
-        </a:gradFill>
-        <a:gradFill rotWithShape="1">
-          <a:gsLst>
-            <a:gs pos="0">
-              <a:schemeClr val="phClr">
-                <a:tint val="80000"/>
-                <a:satMod val="300000"/>
-              </a:schemeClr>
-            </a:gs>
-            <a:gs pos="100000">
-              <a:schemeClr val="phClr">
-                <a:shade val="30000"/>
-                <a:satMod val="200000"/>
-              </a:schemeClr>
-            </a:gs>
-          </a:gsLst>
-          <a:path path="circle">
-            <a:fillToRect l="50000" t="50000" r="50000" b="50000"/>
-          </a:path>
-        </a:gradFill>
-      </a:bgFillStyleLst>
-    </a:fmtScheme>
-  </a:themeElements>
-</a:theme>
-</file>
-
-<file path=ppt/theme/theme2.xml><?xml version="1.0" encoding="utf-8"?>
 <a:theme xmlns:a="http://schemas.openxmlformats.org/drawingml/2006/main" xmlns:r="http://schemas.openxmlformats.org/officeDocument/2006/relationships">
   <a:themeElements>
     <a:clrScheme name="Default">
@@ -34559,7 +34280,7 @@
 </a:theme>
 </file>
 
-<file path=ppt/theme/theme3.xml><?xml version="1.0" encoding="utf-8"?>
+<file path=ppt/theme/theme2.xml><?xml version="1.0" encoding="utf-8"?>
 <a:theme xmlns:a="http://schemas.openxmlformats.org/drawingml/2006/main" xmlns:r="http://schemas.openxmlformats.org/officeDocument/2006/relationships" name="Simple Light">
   <a:themeElements>
     <a:clrScheme name="Simple Light">
@@ -34836,4 +34557,283 @@
     </a:fmtScheme>
   </a:themeElements>
 </a:theme>
+</file>
+
+<file path=ppt/theme/theme3.xml><?xml version="1.0" encoding="utf-8"?>
+<a:theme xmlns:a="http://schemas.openxmlformats.org/drawingml/2006/main" xmlns:r="http://schemas.openxmlformats.org/officeDocument/2006/relationships" name="LF Energy Theme 2023">
+  <a:themeElements>
+    <a:clrScheme name="Geometric">
+      <a:dk1>
+        <a:srgbClr val="222222"/>
+      </a:dk1>
+      <a:lt1>
+        <a:srgbClr val="FFFFFF"/>
+      </a:lt1>
+      <a:dk2>
+        <a:srgbClr val="434343"/>
+      </a:dk2>
+      <a:lt2>
+        <a:srgbClr val="999999"/>
+      </a:lt2>
+      <a:accent1>
+        <a:srgbClr val="003778"/>
+      </a:accent1>
+      <a:accent2>
+        <a:srgbClr val="0094FF"/>
+      </a:accent2>
+      <a:accent3>
+        <a:srgbClr val="5B1DE7"/>
+      </a:accent3>
+      <a:accent4>
+        <a:srgbClr val="12E2E2"/>
+      </a:accent4>
+      <a:accent5>
+        <a:srgbClr val="FF00AA"/>
+      </a:accent5>
+      <a:accent6>
+        <a:srgbClr val="ACDE1F"/>
+      </a:accent6>
+      <a:hlink>
+        <a:srgbClr val="0077CC"/>
+      </a:hlink>
+      <a:folHlink>
+        <a:srgbClr val="F06292"/>
+      </a:folHlink>
+    </a:clrScheme>
+    <a:fontScheme name="Office">
+      <a:majorFont>
+        <a:latin typeface="Arial"/>
+        <a:ea typeface=""/>
+        <a:cs typeface=""/>
+        <a:font script="Jpan" typeface="ＭＳ Ｐゴシック"/>
+        <a:font script="Hang" typeface="맑은 고딕"/>
+        <a:font script="Hans" typeface="宋体"/>
+        <a:font script="Hant" typeface="新細明體"/>
+        <a:font script="Arab" typeface="Times New Roman"/>
+        <a:font script="Hebr" typeface="Times New Roman"/>
+        <a:font script="Thai" typeface="Angsana New"/>
+        <a:font script="Ethi" typeface="Nyala"/>
+        <a:font script="Beng" typeface="Vrinda"/>
+        <a:font script="Gujr" typeface="Shruti"/>
+        <a:font script="Khmr" typeface="MoolBoran"/>
+        <a:font script="Knda" typeface="Tunga"/>
+        <a:font script="Guru" typeface="Raavi"/>
+        <a:font script="Cans" typeface="Euphemia"/>
+        <a:font script="Cher" typeface="Plantagenet Cherokee"/>
+        <a:font script="Yiii" typeface="Microsoft Yi Baiti"/>
+        <a:font script="Tibt" typeface="Microsoft Himalaya"/>
+        <a:font script="Thaa" typeface="MV Boli"/>
+        <a:font script="Deva" typeface="Mangal"/>
+        <a:font script="Telu" typeface="Gautami"/>
+        <a:font script="Taml" typeface="Latha"/>
+        <a:font script="Syrc" typeface="Estrangelo Edessa"/>
+        <a:font script="Orya" typeface="Kalinga"/>
+        <a:font script="Mlym" typeface="Kartika"/>
+        <a:font script="Laoo" typeface="DokChampa"/>
+        <a:font script="Sinh" typeface="Iskoola Pota"/>
+        <a:font script="Mong" typeface="Mongolian Baiti"/>
+        <a:font script="Viet" typeface="Times New Roman"/>
+        <a:font script="Uigh" typeface="Microsoft Uighur"/>
+        <a:font script="Geor" typeface="Sylfaen"/>
+      </a:majorFont>
+      <a:minorFont>
+        <a:latin typeface="Arial"/>
+        <a:ea typeface=""/>
+        <a:cs typeface=""/>
+        <a:font script="Jpan" typeface="ＭＳ Ｐゴシック"/>
+        <a:font script="Hang" typeface="맑은 고딕"/>
+        <a:font script="Hans" typeface="宋体"/>
+        <a:font script="Hant" typeface="新細明體"/>
+        <a:font script="Arab" typeface="Arial"/>
+        <a:font script="Hebr" typeface="Arial"/>
+        <a:font script="Thai" typeface="Cordia New"/>
+        <a:font script="Ethi" typeface="Nyala"/>
+        <a:font script="Beng" typeface="Vrinda"/>
+        <a:font script="Gujr" typeface="Shruti"/>
+        <a:font script="Khmr" typeface="DaunPenh"/>
+        <a:font script="Knda" typeface="Tunga"/>
+        <a:font script="Guru" typeface="Raavi"/>
+        <a:font script="Cans" typeface="Euphemia"/>
+        <a:font script="Cher" typeface="Plantagenet Cherokee"/>
+        <a:font script="Yiii" typeface="Microsoft Yi Baiti"/>
+        <a:font script="Tibt" typeface="Microsoft Himalaya"/>
+        <a:font script="Thaa" typeface="MV Boli"/>
+        <a:font script="Deva" typeface="Mangal"/>
+        <a:font script="Telu" typeface="Gautami"/>
+        <a:font script="Taml" typeface="Latha"/>
+        <a:font script="Syrc" typeface="Estrangelo Edessa"/>
+        <a:font script="Orya" typeface="Kalinga"/>
+        <a:font script="Mlym" typeface="Kartika"/>
+        <a:font script="Laoo" typeface="DokChampa"/>
+        <a:font script="Sinh" typeface="Iskoola Pota"/>
+        <a:font script="Mong" typeface="Mongolian Baiti"/>
+        <a:font script="Viet" typeface="Arial"/>
+        <a:font script="Uigh" typeface="Microsoft Uighur"/>
+        <a:font script="Geor" typeface="Sylfaen"/>
+      </a:minorFont>
+    </a:fontScheme>
+    <a:fmtScheme name="Office">
+      <a:fillStyleLst>
+        <a:solidFill>
+          <a:schemeClr val="phClr"/>
+        </a:solidFill>
+        <a:gradFill rotWithShape="1">
+          <a:gsLst>
+            <a:gs pos="0">
+              <a:schemeClr val="phClr">
+                <a:tint val="50000"/>
+                <a:satMod val="300000"/>
+              </a:schemeClr>
+            </a:gs>
+            <a:gs pos="35000">
+              <a:schemeClr val="phClr">
+                <a:tint val="37000"/>
+                <a:satMod val="300000"/>
+              </a:schemeClr>
+            </a:gs>
+            <a:gs pos="100000">
+              <a:schemeClr val="phClr">
+                <a:tint val="15000"/>
+                <a:satMod val="350000"/>
+              </a:schemeClr>
+            </a:gs>
+          </a:gsLst>
+          <a:lin ang="16200000" scaled="1"/>
+        </a:gradFill>
+        <a:gradFill rotWithShape="1">
+          <a:gsLst>
+            <a:gs pos="0">
+              <a:schemeClr val="phClr">
+                <a:tint val="100000"/>
+                <a:shade val="100000"/>
+                <a:satMod val="130000"/>
+              </a:schemeClr>
+            </a:gs>
+            <a:gs pos="100000">
+              <a:schemeClr val="phClr">
+                <a:tint val="50000"/>
+                <a:shade val="100000"/>
+                <a:satMod val="350000"/>
+              </a:schemeClr>
+            </a:gs>
+          </a:gsLst>
+          <a:lin ang="16200000" scaled="0"/>
+        </a:gradFill>
+      </a:fillStyleLst>
+      <a:lnStyleLst>
+        <a:ln w="9525" cap="flat" cmpd="sng" algn="ctr">
+          <a:solidFill>
+            <a:schemeClr val="phClr">
+              <a:shade val="95000"/>
+              <a:satMod val="105000"/>
+            </a:schemeClr>
+          </a:solidFill>
+          <a:prstDash val="solid"/>
+        </a:ln>
+        <a:ln w="25400" cap="flat" cmpd="sng" algn="ctr">
+          <a:solidFill>
+            <a:schemeClr val="phClr"/>
+          </a:solidFill>
+          <a:prstDash val="solid"/>
+        </a:ln>
+        <a:ln w="38100" cap="flat" cmpd="sng" algn="ctr">
+          <a:solidFill>
+            <a:schemeClr val="phClr"/>
+          </a:solidFill>
+          <a:prstDash val="solid"/>
+        </a:ln>
+      </a:lnStyleLst>
+      <a:effectStyleLst>
+        <a:effectStyle>
+          <a:effectLst>
+            <a:outerShdw blurRad="40000" dist="20000" dir="5400000" rotWithShape="0">
+              <a:srgbClr val="000000">
+                <a:alpha val="38000"/>
+              </a:srgbClr>
+            </a:outerShdw>
+          </a:effectLst>
+        </a:effectStyle>
+        <a:effectStyle>
+          <a:effectLst>
+            <a:outerShdw blurRad="40000" dist="23000" dir="5400000" rotWithShape="0">
+              <a:srgbClr val="000000">
+                <a:alpha val="35000"/>
+              </a:srgbClr>
+            </a:outerShdw>
+          </a:effectLst>
+        </a:effectStyle>
+        <a:effectStyle>
+          <a:effectLst>
+            <a:outerShdw blurRad="40000" dist="23000" dir="5400000" rotWithShape="0">
+              <a:srgbClr val="000000">
+                <a:alpha val="35000"/>
+              </a:srgbClr>
+            </a:outerShdw>
+          </a:effectLst>
+          <a:scene3d>
+            <a:camera prst="orthographicFront">
+              <a:rot lat="0" lon="0" rev="0"/>
+            </a:camera>
+            <a:lightRig rig="threePt" dir="t">
+              <a:rot lat="0" lon="0" rev="1200000"/>
+            </a:lightRig>
+          </a:scene3d>
+          <a:sp3d>
+            <a:bevelT w="63500" h="25400"/>
+          </a:sp3d>
+        </a:effectStyle>
+      </a:effectStyleLst>
+      <a:bgFillStyleLst>
+        <a:solidFill>
+          <a:schemeClr val="phClr"/>
+        </a:solidFill>
+        <a:gradFill rotWithShape="1">
+          <a:gsLst>
+            <a:gs pos="0">
+              <a:schemeClr val="phClr">
+                <a:tint val="40000"/>
+                <a:satMod val="350000"/>
+              </a:schemeClr>
+            </a:gs>
+            <a:gs pos="40000">
+              <a:schemeClr val="phClr">
+                <a:tint val="45000"/>
+                <a:shade val="99000"/>
+                <a:satMod val="350000"/>
+              </a:schemeClr>
+            </a:gs>
+            <a:gs pos="100000">
+              <a:schemeClr val="phClr">
+                <a:shade val="20000"/>
+                <a:satMod val="255000"/>
+              </a:schemeClr>
+            </a:gs>
+          </a:gsLst>
+          <a:path path="circle">
+            <a:fillToRect l="50000" t="-80000" r="50000" b="180000"/>
+          </a:path>
+        </a:gradFill>
+        <a:gradFill rotWithShape="1">
+          <a:gsLst>
+            <a:gs pos="0">
+              <a:schemeClr val="phClr">
+                <a:tint val="80000"/>
+                <a:satMod val="300000"/>
+              </a:schemeClr>
+            </a:gs>
+            <a:gs pos="100000">
+              <a:schemeClr val="phClr">
+                <a:shade val="30000"/>
+                <a:satMod val="200000"/>
+              </a:schemeClr>
+            </a:gs>
+          </a:gsLst>
+          <a:path path="circle">
+            <a:fillToRect l="50000" t="50000" r="50000" b="50000"/>
+          </a:path>
+        </a:gradFill>
+      </a:bgFillStyleLst>
+    </a:fmtScheme>
+  </a:themeElements>
+</a:theme>
 </file>
</xml_diff>

<commit_message>
Update Data Sources from LFX 2026-10-03 (#330)
Update Data Sources from LFX

Signed-off-by: github-actions[bot] <41898282+github-actions[bot]@users.noreply.github.com>
Co-authored-by: jmertic <296737+jmertic@users.noreply.github.com>
</commit_message>
<xml_diff>
--- a/overview_deck/LF Energy High Level Overview.pptx
+++ b/overview_deck/LF Energy High Level Overview.pptx
@@ -25946,7 +25946,7 @@
             <a:tbl>
               <a:tblPr>
                 <a:noFill/>
-                <a:tableStyleId>{70D67422-12BF-4A30-8481-A135D1477BF2}</a:tableStyleId>
+                <a:tableStyleId>{F13E99C8-6A7F-4B43-8AF4-D22E1CCAE3BF}</a:tableStyleId>
               </a:tblPr>
               <a:tblGrid>
                 <a:gridCol w="1695200"/>
@@ -26736,7 +26736,7 @@
             <a:tbl>
               <a:tblPr>
                 <a:noFill/>
-                <a:tableStyleId>{70D67422-12BF-4A30-8481-A135D1477BF2}</a:tableStyleId>
+                <a:tableStyleId>{F13E99C8-6A7F-4B43-8AF4-D22E1CCAE3BF}</a:tableStyleId>
               </a:tblPr>
               <a:tblGrid>
                 <a:gridCol w="1695200"/>
@@ -27426,7 +27426,7 @@
             <a:tbl>
               <a:tblPr>
                 <a:noFill/>
-                <a:tableStyleId>{70D67422-12BF-4A30-8481-A135D1477BF2}</a:tableStyleId>
+                <a:tableStyleId>{F13E99C8-6A7F-4B43-8AF4-D22E1CCAE3BF}</a:tableStyleId>
               </a:tblPr>
               <a:tblGrid>
                 <a:gridCol w="1695200"/>
@@ -28678,7 +28678,7 @@
             <a:tbl>
               <a:tblPr>
                 <a:noFill/>
-                <a:tableStyleId>{70D67422-12BF-4A30-8481-A135D1477BF2}</a:tableStyleId>
+                <a:tableStyleId>{F13E99C8-6A7F-4B43-8AF4-D22E1CCAE3BF}</a:tableStyleId>
               </a:tblPr>
               <a:tblGrid>
                 <a:gridCol w="1695200"/>
@@ -29670,7 +29670,7 @@
             <a:tbl>
               <a:tblPr>
                 <a:noFill/>
-                <a:tableStyleId>{70D67422-12BF-4A30-8481-A135D1477BF2}</a:tableStyleId>
+                <a:tableStyleId>{F13E99C8-6A7F-4B43-8AF4-D22E1CCAE3BF}</a:tableStyleId>
               </a:tblPr>
               <a:tblGrid>
                 <a:gridCol w="3048000"/>
@@ -33175,7 +33175,7 @@
             <a:tbl>
               <a:tblPr>
                 <a:noFill/>
-                <a:tableStyleId>{70D67422-12BF-4A30-8481-A135D1477BF2}</a:tableStyleId>
+                <a:tableStyleId>{F13E99C8-6A7F-4B43-8AF4-D22E1CCAE3BF}</a:tableStyleId>
               </a:tblPr>
               <a:tblGrid>
                 <a:gridCol w="1828800"/>
@@ -34281,6 +34281,285 @@
 </file>
 
 <file path=ppt/theme/theme2.xml><?xml version="1.0" encoding="utf-8"?>
+<a:theme xmlns:a="http://schemas.openxmlformats.org/drawingml/2006/main" xmlns:r="http://schemas.openxmlformats.org/officeDocument/2006/relationships" name="LF Energy Theme 2023">
+  <a:themeElements>
+    <a:clrScheme name="Geometric">
+      <a:dk1>
+        <a:srgbClr val="222222"/>
+      </a:dk1>
+      <a:lt1>
+        <a:srgbClr val="FFFFFF"/>
+      </a:lt1>
+      <a:dk2>
+        <a:srgbClr val="434343"/>
+      </a:dk2>
+      <a:lt2>
+        <a:srgbClr val="999999"/>
+      </a:lt2>
+      <a:accent1>
+        <a:srgbClr val="003778"/>
+      </a:accent1>
+      <a:accent2>
+        <a:srgbClr val="0094FF"/>
+      </a:accent2>
+      <a:accent3>
+        <a:srgbClr val="5B1DE7"/>
+      </a:accent3>
+      <a:accent4>
+        <a:srgbClr val="12E2E2"/>
+      </a:accent4>
+      <a:accent5>
+        <a:srgbClr val="FF00AA"/>
+      </a:accent5>
+      <a:accent6>
+        <a:srgbClr val="ACDE1F"/>
+      </a:accent6>
+      <a:hlink>
+        <a:srgbClr val="0077CC"/>
+      </a:hlink>
+      <a:folHlink>
+        <a:srgbClr val="F06292"/>
+      </a:folHlink>
+    </a:clrScheme>
+    <a:fontScheme name="Office">
+      <a:majorFont>
+        <a:latin typeface="Arial"/>
+        <a:ea typeface=""/>
+        <a:cs typeface=""/>
+        <a:font script="Jpan" typeface="ＭＳ Ｐゴシック"/>
+        <a:font script="Hang" typeface="맑은 고딕"/>
+        <a:font script="Hans" typeface="宋体"/>
+        <a:font script="Hant" typeface="新細明體"/>
+        <a:font script="Arab" typeface="Times New Roman"/>
+        <a:font script="Hebr" typeface="Times New Roman"/>
+        <a:font script="Thai" typeface="Angsana New"/>
+        <a:font script="Ethi" typeface="Nyala"/>
+        <a:font script="Beng" typeface="Vrinda"/>
+        <a:font script="Gujr" typeface="Shruti"/>
+        <a:font script="Khmr" typeface="MoolBoran"/>
+        <a:font script="Knda" typeface="Tunga"/>
+        <a:font script="Guru" typeface="Raavi"/>
+        <a:font script="Cans" typeface="Euphemia"/>
+        <a:font script="Cher" typeface="Plantagenet Cherokee"/>
+        <a:font script="Yiii" typeface="Microsoft Yi Baiti"/>
+        <a:font script="Tibt" typeface="Microsoft Himalaya"/>
+        <a:font script="Thaa" typeface="MV Boli"/>
+        <a:font script="Deva" typeface="Mangal"/>
+        <a:font script="Telu" typeface="Gautami"/>
+        <a:font script="Taml" typeface="Latha"/>
+        <a:font script="Syrc" typeface="Estrangelo Edessa"/>
+        <a:font script="Orya" typeface="Kalinga"/>
+        <a:font script="Mlym" typeface="Kartika"/>
+        <a:font script="Laoo" typeface="DokChampa"/>
+        <a:font script="Sinh" typeface="Iskoola Pota"/>
+        <a:font script="Mong" typeface="Mongolian Baiti"/>
+        <a:font script="Viet" typeface="Times New Roman"/>
+        <a:font script="Uigh" typeface="Microsoft Uighur"/>
+        <a:font script="Geor" typeface="Sylfaen"/>
+      </a:majorFont>
+      <a:minorFont>
+        <a:latin typeface="Arial"/>
+        <a:ea typeface=""/>
+        <a:cs typeface=""/>
+        <a:font script="Jpan" typeface="ＭＳ Ｐゴシック"/>
+        <a:font script="Hang" typeface="맑은 고딕"/>
+        <a:font script="Hans" typeface="宋体"/>
+        <a:font script="Hant" typeface="新細明體"/>
+        <a:font script="Arab" typeface="Arial"/>
+        <a:font script="Hebr" typeface="Arial"/>
+        <a:font script="Thai" typeface="Cordia New"/>
+        <a:font script="Ethi" typeface="Nyala"/>
+        <a:font script="Beng" typeface="Vrinda"/>
+        <a:font script="Gujr" typeface="Shruti"/>
+        <a:font script="Khmr" typeface="DaunPenh"/>
+        <a:font script="Knda" typeface="Tunga"/>
+        <a:font script="Guru" typeface="Raavi"/>
+        <a:font script="Cans" typeface="Euphemia"/>
+        <a:font script="Cher" typeface="Plantagenet Cherokee"/>
+        <a:font script="Yiii" typeface="Microsoft Yi Baiti"/>
+        <a:font script="Tibt" typeface="Microsoft Himalaya"/>
+        <a:font script="Thaa" typeface="MV Boli"/>
+        <a:font script="Deva" typeface="Mangal"/>
+        <a:font script="Telu" typeface="Gautami"/>
+        <a:font script="Taml" typeface="Latha"/>
+        <a:font script="Syrc" typeface="Estrangelo Edessa"/>
+        <a:font script="Orya" typeface="Kalinga"/>
+        <a:font script="Mlym" typeface="Kartika"/>
+        <a:font script="Laoo" typeface="DokChampa"/>
+        <a:font script="Sinh" typeface="Iskoola Pota"/>
+        <a:font script="Mong" typeface="Mongolian Baiti"/>
+        <a:font script="Viet" typeface="Arial"/>
+        <a:font script="Uigh" typeface="Microsoft Uighur"/>
+        <a:font script="Geor" typeface="Sylfaen"/>
+      </a:minorFont>
+    </a:fontScheme>
+    <a:fmtScheme name="Office">
+      <a:fillStyleLst>
+        <a:solidFill>
+          <a:schemeClr val="phClr"/>
+        </a:solidFill>
+        <a:gradFill rotWithShape="1">
+          <a:gsLst>
+            <a:gs pos="0">
+              <a:schemeClr val="phClr">
+                <a:tint val="50000"/>
+                <a:satMod val="300000"/>
+              </a:schemeClr>
+            </a:gs>
+            <a:gs pos="35000">
+              <a:schemeClr val="phClr">
+                <a:tint val="37000"/>
+                <a:satMod val="300000"/>
+              </a:schemeClr>
+            </a:gs>
+            <a:gs pos="100000">
+              <a:schemeClr val="phClr">
+                <a:tint val="15000"/>
+                <a:satMod val="350000"/>
+              </a:schemeClr>
+            </a:gs>
+          </a:gsLst>
+          <a:lin ang="16200000" scaled="1"/>
+        </a:gradFill>
+        <a:gradFill rotWithShape="1">
+          <a:gsLst>
+            <a:gs pos="0">
+              <a:schemeClr val="phClr">
+                <a:tint val="100000"/>
+                <a:shade val="100000"/>
+                <a:satMod val="130000"/>
+              </a:schemeClr>
+            </a:gs>
+            <a:gs pos="100000">
+              <a:schemeClr val="phClr">
+                <a:tint val="50000"/>
+                <a:shade val="100000"/>
+                <a:satMod val="350000"/>
+              </a:schemeClr>
+            </a:gs>
+          </a:gsLst>
+          <a:lin ang="16200000" scaled="0"/>
+        </a:gradFill>
+      </a:fillStyleLst>
+      <a:lnStyleLst>
+        <a:ln w="9525" cap="flat" cmpd="sng" algn="ctr">
+          <a:solidFill>
+            <a:schemeClr val="phClr">
+              <a:shade val="95000"/>
+              <a:satMod val="105000"/>
+            </a:schemeClr>
+          </a:solidFill>
+          <a:prstDash val="solid"/>
+        </a:ln>
+        <a:ln w="25400" cap="flat" cmpd="sng" algn="ctr">
+          <a:solidFill>
+            <a:schemeClr val="phClr"/>
+          </a:solidFill>
+          <a:prstDash val="solid"/>
+        </a:ln>
+        <a:ln w="38100" cap="flat" cmpd="sng" algn="ctr">
+          <a:solidFill>
+            <a:schemeClr val="phClr"/>
+          </a:solidFill>
+          <a:prstDash val="solid"/>
+        </a:ln>
+      </a:lnStyleLst>
+      <a:effectStyleLst>
+        <a:effectStyle>
+          <a:effectLst>
+            <a:outerShdw blurRad="40000" dist="20000" dir="5400000" rotWithShape="0">
+              <a:srgbClr val="000000">
+                <a:alpha val="38000"/>
+              </a:srgbClr>
+            </a:outerShdw>
+          </a:effectLst>
+        </a:effectStyle>
+        <a:effectStyle>
+          <a:effectLst>
+            <a:outerShdw blurRad="40000" dist="23000" dir="5400000" rotWithShape="0">
+              <a:srgbClr val="000000">
+                <a:alpha val="35000"/>
+              </a:srgbClr>
+            </a:outerShdw>
+          </a:effectLst>
+        </a:effectStyle>
+        <a:effectStyle>
+          <a:effectLst>
+            <a:outerShdw blurRad="40000" dist="23000" dir="5400000" rotWithShape="0">
+              <a:srgbClr val="000000">
+                <a:alpha val="35000"/>
+              </a:srgbClr>
+            </a:outerShdw>
+          </a:effectLst>
+          <a:scene3d>
+            <a:camera prst="orthographicFront">
+              <a:rot lat="0" lon="0" rev="0"/>
+            </a:camera>
+            <a:lightRig rig="threePt" dir="t">
+              <a:rot lat="0" lon="0" rev="1200000"/>
+            </a:lightRig>
+          </a:scene3d>
+          <a:sp3d>
+            <a:bevelT w="63500" h="25400"/>
+          </a:sp3d>
+        </a:effectStyle>
+      </a:effectStyleLst>
+      <a:bgFillStyleLst>
+        <a:solidFill>
+          <a:schemeClr val="phClr"/>
+        </a:solidFill>
+        <a:gradFill rotWithShape="1">
+          <a:gsLst>
+            <a:gs pos="0">
+              <a:schemeClr val="phClr">
+                <a:tint val="40000"/>
+                <a:satMod val="350000"/>
+              </a:schemeClr>
+            </a:gs>
+            <a:gs pos="40000">
+              <a:schemeClr val="phClr">
+                <a:tint val="45000"/>
+                <a:shade val="99000"/>
+                <a:satMod val="350000"/>
+              </a:schemeClr>
+            </a:gs>
+            <a:gs pos="100000">
+              <a:schemeClr val="phClr">
+                <a:shade val="20000"/>
+                <a:satMod val="255000"/>
+              </a:schemeClr>
+            </a:gs>
+          </a:gsLst>
+          <a:path path="circle">
+            <a:fillToRect l="50000" t="-80000" r="50000" b="180000"/>
+          </a:path>
+        </a:gradFill>
+        <a:gradFill rotWithShape="1">
+          <a:gsLst>
+            <a:gs pos="0">
+              <a:schemeClr val="phClr">
+                <a:tint val="80000"/>
+                <a:satMod val="300000"/>
+              </a:schemeClr>
+            </a:gs>
+            <a:gs pos="100000">
+              <a:schemeClr val="phClr">
+                <a:shade val="30000"/>
+                <a:satMod val="200000"/>
+              </a:schemeClr>
+            </a:gs>
+          </a:gsLst>
+          <a:path path="circle">
+            <a:fillToRect l="50000" t="50000" r="50000" b="50000"/>
+          </a:path>
+        </a:gradFill>
+      </a:bgFillStyleLst>
+    </a:fmtScheme>
+  </a:themeElements>
+</a:theme>
+</file>
+
+<file path=ppt/theme/theme3.xml><?xml version="1.0" encoding="utf-8"?>
 <a:theme xmlns:a="http://schemas.openxmlformats.org/drawingml/2006/main" xmlns:r="http://schemas.openxmlformats.org/officeDocument/2006/relationships" name="Simple Light">
   <a:themeElements>
     <a:clrScheme name="Simple Light">
@@ -34557,283 +34836,4 @@
     </a:fmtScheme>
   </a:themeElements>
 </a:theme>
-</file>
-
-<file path=ppt/theme/theme3.xml><?xml version="1.0" encoding="utf-8"?>
-<a:theme xmlns:a="http://schemas.openxmlformats.org/drawingml/2006/main" xmlns:r="http://schemas.openxmlformats.org/officeDocument/2006/relationships" name="LF Energy Theme 2023">
-  <a:themeElements>
-    <a:clrScheme name="Geometric">
-      <a:dk1>
-        <a:srgbClr val="222222"/>
-      </a:dk1>
-      <a:lt1>
-        <a:srgbClr val="FFFFFF"/>
-      </a:lt1>
-      <a:dk2>
-        <a:srgbClr val="434343"/>
-      </a:dk2>
-      <a:lt2>
-        <a:srgbClr val="999999"/>
-      </a:lt2>
-      <a:accent1>
-        <a:srgbClr val="003778"/>
-      </a:accent1>
-      <a:accent2>
-        <a:srgbClr val="0094FF"/>
-      </a:accent2>
-      <a:accent3>
-        <a:srgbClr val="5B1DE7"/>
-      </a:accent3>
-      <a:accent4>
-        <a:srgbClr val="12E2E2"/>
-      </a:accent4>
-      <a:accent5>
-        <a:srgbClr val="FF00AA"/>
-      </a:accent5>
-      <a:accent6>
-        <a:srgbClr val="ACDE1F"/>
-      </a:accent6>
-      <a:hlink>
-        <a:srgbClr val="0077CC"/>
-      </a:hlink>
-      <a:folHlink>
-        <a:srgbClr val="F06292"/>
-      </a:folHlink>
-    </a:clrScheme>
-    <a:fontScheme name="Office">
-      <a:majorFont>
-        <a:latin typeface="Arial"/>
-        <a:ea typeface=""/>
-        <a:cs typeface=""/>
-        <a:font script="Jpan" typeface="ＭＳ Ｐゴシック"/>
-        <a:font script="Hang" typeface="맑은 고딕"/>
-        <a:font script="Hans" typeface="宋体"/>
-        <a:font script="Hant" typeface="新細明體"/>
-        <a:font script="Arab" typeface="Times New Roman"/>
-        <a:font script="Hebr" typeface="Times New Roman"/>
-        <a:font script="Thai" typeface="Angsana New"/>
-        <a:font script="Ethi" typeface="Nyala"/>
-        <a:font script="Beng" typeface="Vrinda"/>
-        <a:font script="Gujr" typeface="Shruti"/>
-        <a:font script="Khmr" typeface="MoolBoran"/>
-        <a:font script="Knda" typeface="Tunga"/>
-        <a:font script="Guru" typeface="Raavi"/>
-        <a:font script="Cans" typeface="Euphemia"/>
-        <a:font script="Cher" typeface="Plantagenet Cherokee"/>
-        <a:font script="Yiii" typeface="Microsoft Yi Baiti"/>
-        <a:font script="Tibt" typeface="Microsoft Himalaya"/>
-        <a:font script="Thaa" typeface="MV Boli"/>
-        <a:font script="Deva" typeface="Mangal"/>
-        <a:font script="Telu" typeface="Gautami"/>
-        <a:font script="Taml" typeface="Latha"/>
-        <a:font script="Syrc" typeface="Estrangelo Edessa"/>
-        <a:font script="Orya" typeface="Kalinga"/>
-        <a:font script="Mlym" typeface="Kartika"/>
-        <a:font script="Laoo" typeface="DokChampa"/>
-        <a:font script="Sinh" typeface="Iskoola Pota"/>
-        <a:font script="Mong" typeface="Mongolian Baiti"/>
-        <a:font script="Viet" typeface="Times New Roman"/>
-        <a:font script="Uigh" typeface="Microsoft Uighur"/>
-        <a:font script="Geor" typeface="Sylfaen"/>
-      </a:majorFont>
-      <a:minorFont>
-        <a:latin typeface="Arial"/>
-        <a:ea typeface=""/>
-        <a:cs typeface=""/>
-        <a:font script="Jpan" typeface="ＭＳ Ｐゴシック"/>
-        <a:font script="Hang" typeface="맑은 고딕"/>
-        <a:font script="Hans" typeface="宋体"/>
-        <a:font script="Hant" typeface="新細明體"/>
-        <a:font script="Arab" typeface="Arial"/>
-        <a:font script="Hebr" typeface="Arial"/>
-        <a:font script="Thai" typeface="Cordia New"/>
-        <a:font script="Ethi" typeface="Nyala"/>
-        <a:font script="Beng" typeface="Vrinda"/>
-        <a:font script="Gujr" typeface="Shruti"/>
-        <a:font script="Khmr" typeface="DaunPenh"/>
-        <a:font script="Knda" typeface="Tunga"/>
-        <a:font script="Guru" typeface="Raavi"/>
-        <a:font script="Cans" typeface="Euphemia"/>
-        <a:font script="Cher" typeface="Plantagenet Cherokee"/>
-        <a:font script="Yiii" typeface="Microsoft Yi Baiti"/>
-        <a:font script="Tibt" typeface="Microsoft Himalaya"/>
-        <a:font script="Thaa" typeface="MV Boli"/>
-        <a:font script="Deva" typeface="Mangal"/>
-        <a:font script="Telu" typeface="Gautami"/>
-        <a:font script="Taml" typeface="Latha"/>
-        <a:font script="Syrc" typeface="Estrangelo Edessa"/>
-        <a:font script="Orya" typeface="Kalinga"/>
-        <a:font script="Mlym" typeface="Kartika"/>
-        <a:font script="Laoo" typeface="DokChampa"/>
-        <a:font script="Sinh" typeface="Iskoola Pota"/>
-        <a:font script="Mong" typeface="Mongolian Baiti"/>
-        <a:font script="Viet" typeface="Arial"/>
-        <a:font script="Uigh" typeface="Microsoft Uighur"/>
-        <a:font script="Geor" typeface="Sylfaen"/>
-      </a:minorFont>
-    </a:fontScheme>
-    <a:fmtScheme name="Office">
-      <a:fillStyleLst>
-        <a:solidFill>
-          <a:schemeClr val="phClr"/>
-        </a:solidFill>
-        <a:gradFill rotWithShape="1">
-          <a:gsLst>
-            <a:gs pos="0">
-              <a:schemeClr val="phClr">
-                <a:tint val="50000"/>
-                <a:satMod val="300000"/>
-              </a:schemeClr>
-            </a:gs>
-            <a:gs pos="35000">
-              <a:schemeClr val="phClr">
-                <a:tint val="37000"/>
-                <a:satMod val="300000"/>
-              </a:schemeClr>
-            </a:gs>
-            <a:gs pos="100000">
-              <a:schemeClr val="phClr">
-                <a:tint val="15000"/>
-                <a:satMod val="350000"/>
-              </a:schemeClr>
-            </a:gs>
-          </a:gsLst>
-          <a:lin ang="16200000" scaled="1"/>
-        </a:gradFill>
-        <a:gradFill rotWithShape="1">
-          <a:gsLst>
-            <a:gs pos="0">
-              <a:schemeClr val="phClr">
-                <a:tint val="100000"/>
-                <a:shade val="100000"/>
-                <a:satMod val="130000"/>
-              </a:schemeClr>
-            </a:gs>
-            <a:gs pos="100000">
-              <a:schemeClr val="phClr">
-                <a:tint val="50000"/>
-                <a:shade val="100000"/>
-                <a:satMod val="350000"/>
-              </a:schemeClr>
-            </a:gs>
-          </a:gsLst>
-          <a:lin ang="16200000" scaled="0"/>
-        </a:gradFill>
-      </a:fillStyleLst>
-      <a:lnStyleLst>
-        <a:ln w="9525" cap="flat" cmpd="sng" algn="ctr">
-          <a:solidFill>
-            <a:schemeClr val="phClr">
-              <a:shade val="95000"/>
-              <a:satMod val="105000"/>
-            </a:schemeClr>
-          </a:solidFill>
-          <a:prstDash val="solid"/>
-        </a:ln>
-        <a:ln w="25400" cap="flat" cmpd="sng" algn="ctr">
-          <a:solidFill>
-            <a:schemeClr val="phClr"/>
-          </a:solidFill>
-          <a:prstDash val="solid"/>
-        </a:ln>
-        <a:ln w="38100" cap="flat" cmpd="sng" algn="ctr">
-          <a:solidFill>
-            <a:schemeClr val="phClr"/>
-          </a:solidFill>
-          <a:prstDash val="solid"/>
-        </a:ln>
-      </a:lnStyleLst>
-      <a:effectStyleLst>
-        <a:effectStyle>
-          <a:effectLst>
-            <a:outerShdw blurRad="40000" dist="20000" dir="5400000" rotWithShape="0">
-              <a:srgbClr val="000000">
-                <a:alpha val="38000"/>
-              </a:srgbClr>
-            </a:outerShdw>
-          </a:effectLst>
-        </a:effectStyle>
-        <a:effectStyle>
-          <a:effectLst>
-            <a:outerShdw blurRad="40000" dist="23000" dir="5400000" rotWithShape="0">
-              <a:srgbClr val="000000">
-                <a:alpha val="35000"/>
-              </a:srgbClr>
-            </a:outerShdw>
-          </a:effectLst>
-        </a:effectStyle>
-        <a:effectStyle>
-          <a:effectLst>
-            <a:outerShdw blurRad="40000" dist="23000" dir="5400000" rotWithShape="0">
-              <a:srgbClr val="000000">
-                <a:alpha val="35000"/>
-              </a:srgbClr>
-            </a:outerShdw>
-          </a:effectLst>
-          <a:scene3d>
-            <a:camera prst="orthographicFront">
-              <a:rot lat="0" lon="0" rev="0"/>
-            </a:camera>
-            <a:lightRig rig="threePt" dir="t">
-              <a:rot lat="0" lon="0" rev="1200000"/>
-            </a:lightRig>
-          </a:scene3d>
-          <a:sp3d>
-            <a:bevelT w="63500" h="25400"/>
-          </a:sp3d>
-        </a:effectStyle>
-      </a:effectStyleLst>
-      <a:bgFillStyleLst>
-        <a:solidFill>
-          <a:schemeClr val="phClr"/>
-        </a:solidFill>
-        <a:gradFill rotWithShape="1">
-          <a:gsLst>
-            <a:gs pos="0">
-              <a:schemeClr val="phClr">
-                <a:tint val="40000"/>
-                <a:satMod val="350000"/>
-              </a:schemeClr>
-            </a:gs>
-            <a:gs pos="40000">
-              <a:schemeClr val="phClr">
-                <a:tint val="45000"/>
-                <a:shade val="99000"/>
-                <a:satMod val="350000"/>
-              </a:schemeClr>
-            </a:gs>
-            <a:gs pos="100000">
-              <a:schemeClr val="phClr">
-                <a:shade val="20000"/>
-                <a:satMod val="255000"/>
-              </a:schemeClr>
-            </a:gs>
-          </a:gsLst>
-          <a:path path="circle">
-            <a:fillToRect l="50000" t="-80000" r="50000" b="180000"/>
-          </a:path>
-        </a:gradFill>
-        <a:gradFill rotWithShape="1">
-          <a:gsLst>
-            <a:gs pos="0">
-              <a:schemeClr val="phClr">
-                <a:tint val="80000"/>
-                <a:satMod val="300000"/>
-              </a:schemeClr>
-            </a:gs>
-            <a:gs pos="100000">
-              <a:schemeClr val="phClr">
-                <a:shade val="30000"/>
-                <a:satMod val="200000"/>
-              </a:schemeClr>
-            </a:gs>
-          </a:gsLst>
-          <a:path path="circle">
-            <a:fillToRect l="50000" t="50000" r="50000" b="50000"/>
-          </a:path>
-        </a:gradFill>
-      </a:bgFillStyleLst>
-    </a:fmtScheme>
-  </a:themeElements>
-</a:theme>
 </file>
</xml_diff>

<commit_message>
Update Data Sources from LFX 2026-10-04 (#331)
Update Data Sources from LFX

Signed-off-by: github-actions[bot] <41898282+github-actions[bot]@users.noreply.github.com>
Co-authored-by: jmertic <296737+jmertic@users.noreply.github.com>
</commit_message>
<xml_diff>
--- a/overview_deck/LF Energy High Level Overview.pptx
+++ b/overview_deck/LF Energy High Level Overview.pptx
@@ -25946,7 +25946,7 @@
             <a:tbl>
               <a:tblPr>
                 <a:noFill/>
-                <a:tableStyleId>{F13E99C8-6A7F-4B43-8AF4-D22E1CCAE3BF}</a:tableStyleId>
+                <a:tableStyleId>{91043335-9176-4132-B228-1DF7EC033154}</a:tableStyleId>
               </a:tblPr>
               <a:tblGrid>
                 <a:gridCol w="1695200"/>
@@ -26736,7 +26736,7 @@
             <a:tbl>
               <a:tblPr>
                 <a:noFill/>
-                <a:tableStyleId>{F13E99C8-6A7F-4B43-8AF4-D22E1CCAE3BF}</a:tableStyleId>
+                <a:tableStyleId>{91043335-9176-4132-B228-1DF7EC033154}</a:tableStyleId>
               </a:tblPr>
               <a:tblGrid>
                 <a:gridCol w="1695200"/>
@@ -27426,7 +27426,7 @@
             <a:tbl>
               <a:tblPr>
                 <a:noFill/>
-                <a:tableStyleId>{F13E99C8-6A7F-4B43-8AF4-D22E1CCAE3BF}</a:tableStyleId>
+                <a:tableStyleId>{91043335-9176-4132-B228-1DF7EC033154}</a:tableStyleId>
               </a:tblPr>
               <a:tblGrid>
                 <a:gridCol w="1695200"/>
@@ -28678,7 +28678,7 @@
             <a:tbl>
               <a:tblPr>
                 <a:noFill/>
-                <a:tableStyleId>{F13E99C8-6A7F-4B43-8AF4-D22E1CCAE3BF}</a:tableStyleId>
+                <a:tableStyleId>{91043335-9176-4132-B228-1DF7EC033154}</a:tableStyleId>
               </a:tblPr>
               <a:tblGrid>
                 <a:gridCol w="1695200"/>
@@ -29670,7 +29670,7 @@
             <a:tbl>
               <a:tblPr>
                 <a:noFill/>
-                <a:tableStyleId>{F13E99C8-6A7F-4B43-8AF4-D22E1CCAE3BF}</a:tableStyleId>
+                <a:tableStyleId>{91043335-9176-4132-B228-1DF7EC033154}</a:tableStyleId>
               </a:tblPr>
               <a:tblGrid>
                 <a:gridCol w="3048000"/>
@@ -33175,7 +33175,7 @@
             <a:tbl>
               <a:tblPr>
                 <a:noFill/>
-                <a:tableStyleId>{F13E99C8-6A7F-4B43-8AF4-D22E1CCAE3BF}</a:tableStyleId>
+                <a:tableStyleId>{91043335-9176-4132-B228-1DF7EC033154}</a:tableStyleId>
               </a:tblPr>
               <a:tblGrid>
                 <a:gridCol w="1828800"/>
@@ -34002,9 +34002,9 @@
 </file>
 
 <file path=ppt/theme/theme1.xml><?xml version="1.0" encoding="utf-8"?>
-<a:theme xmlns:a="http://schemas.openxmlformats.org/drawingml/2006/main" xmlns:r="http://schemas.openxmlformats.org/officeDocument/2006/relationships">
+<a:theme xmlns:a="http://schemas.openxmlformats.org/drawingml/2006/main" xmlns:r="http://schemas.openxmlformats.org/officeDocument/2006/relationships" name="Simple Light">
   <a:themeElements>
-    <a:clrScheme name="Default">
+    <a:clrScheme name="Simple Light">
       <a:dk1>
         <a:srgbClr val="000000"/>
       </a:dk1>
@@ -34012,34 +34012,34 @@
         <a:srgbClr val="FFFFFF"/>
       </a:lt1>
       <a:dk2>
-        <a:srgbClr val="158158"/>
+        <a:srgbClr val="595959"/>
       </a:dk2>
       <a:lt2>
-        <a:srgbClr val="F3F3F3"/>
+        <a:srgbClr val="EEEEEE"/>
       </a:lt2>
       <a:accent1>
-        <a:srgbClr val="058DC7"/>
+        <a:srgbClr val="4285F4"/>
       </a:accent1>
       <a:accent2>
-        <a:srgbClr val="50B432"/>
+        <a:srgbClr val="212121"/>
       </a:accent2>
       <a:accent3>
-        <a:srgbClr val="ED561B"/>
+        <a:srgbClr val="78909C"/>
       </a:accent3>
       <a:accent4>
-        <a:srgbClr val="EDEF00"/>
+        <a:srgbClr val="FFAB40"/>
       </a:accent4>
       <a:accent5>
-        <a:srgbClr val="24CBE5"/>
+        <a:srgbClr val="0097A7"/>
       </a:accent5>
       <a:accent6>
-        <a:srgbClr val="64E572"/>
+        <a:srgbClr val="EEFF41"/>
       </a:accent6>
       <a:hlink>
-        <a:srgbClr val="2200CC"/>
+        <a:srgbClr val="0097A7"/>
       </a:hlink>
       <a:folHlink>
-        <a:srgbClr val="551A8B"/>
+        <a:srgbClr val="0097A7"/>
       </a:folHlink>
     </a:clrScheme>
     <a:fontScheme name="Office">
@@ -34560,9 +34560,9 @@
 </file>
 
 <file path=ppt/theme/theme3.xml><?xml version="1.0" encoding="utf-8"?>
-<a:theme xmlns:a="http://schemas.openxmlformats.org/drawingml/2006/main" xmlns:r="http://schemas.openxmlformats.org/officeDocument/2006/relationships" name="Simple Light">
+<a:theme xmlns:a="http://schemas.openxmlformats.org/drawingml/2006/main" xmlns:r="http://schemas.openxmlformats.org/officeDocument/2006/relationships">
   <a:themeElements>
-    <a:clrScheme name="Simple Light">
+    <a:clrScheme name="Default">
       <a:dk1>
         <a:srgbClr val="000000"/>
       </a:dk1>
@@ -34570,34 +34570,34 @@
         <a:srgbClr val="FFFFFF"/>
       </a:lt1>
       <a:dk2>
-        <a:srgbClr val="595959"/>
+        <a:srgbClr val="158158"/>
       </a:dk2>
       <a:lt2>
-        <a:srgbClr val="EEEEEE"/>
+        <a:srgbClr val="F3F3F3"/>
       </a:lt2>
       <a:accent1>
-        <a:srgbClr val="4285F4"/>
+        <a:srgbClr val="058DC7"/>
       </a:accent1>
       <a:accent2>
-        <a:srgbClr val="212121"/>
+        <a:srgbClr val="50B432"/>
       </a:accent2>
       <a:accent3>
-        <a:srgbClr val="78909C"/>
+        <a:srgbClr val="ED561B"/>
       </a:accent3>
       <a:accent4>
-        <a:srgbClr val="FFAB40"/>
+        <a:srgbClr val="EDEF00"/>
       </a:accent4>
       <a:accent5>
-        <a:srgbClr val="0097A7"/>
+        <a:srgbClr val="24CBE5"/>
       </a:accent5>
       <a:accent6>
-        <a:srgbClr val="EEFF41"/>
+        <a:srgbClr val="64E572"/>
       </a:accent6>
       <a:hlink>
-        <a:srgbClr val="0097A7"/>
+        <a:srgbClr val="2200CC"/>
       </a:hlink>
       <a:folHlink>
-        <a:srgbClr val="0097A7"/>
+        <a:srgbClr val="551A8B"/>
       </a:folHlink>
     </a:clrScheme>
     <a:fontScheme name="Office">

</xml_diff>

<commit_message>
Update Data Sources from LFX 2026-10-05 (#332)
Update Data Sources from LFX

Signed-off-by: github-actions[bot] <41898282+github-actions[bot]@users.noreply.github.com>
Co-authored-by: jmertic <296737+jmertic@users.noreply.github.com>
</commit_message>
<xml_diff>
--- a/overview_deck/LF Energy High Level Overview.pptx
+++ b/overview_deck/LF Energy High Level Overview.pptx
@@ -25946,7 +25946,7 @@
             <a:tbl>
               <a:tblPr>
                 <a:noFill/>
-                <a:tableStyleId>{91043335-9176-4132-B228-1DF7EC033154}</a:tableStyleId>
+                <a:tableStyleId>{81AE8075-4DFA-4ACD-903E-96CCAC7EE2F4}</a:tableStyleId>
               </a:tblPr>
               <a:tblGrid>
                 <a:gridCol w="1695200"/>
@@ -26736,7 +26736,7 @@
             <a:tbl>
               <a:tblPr>
                 <a:noFill/>
-                <a:tableStyleId>{91043335-9176-4132-B228-1DF7EC033154}</a:tableStyleId>
+                <a:tableStyleId>{81AE8075-4DFA-4ACD-903E-96CCAC7EE2F4}</a:tableStyleId>
               </a:tblPr>
               <a:tblGrid>
                 <a:gridCol w="1695200"/>
@@ -27426,7 +27426,7 @@
             <a:tbl>
               <a:tblPr>
                 <a:noFill/>
-                <a:tableStyleId>{91043335-9176-4132-B228-1DF7EC033154}</a:tableStyleId>
+                <a:tableStyleId>{81AE8075-4DFA-4ACD-903E-96CCAC7EE2F4}</a:tableStyleId>
               </a:tblPr>
               <a:tblGrid>
                 <a:gridCol w="1695200"/>
@@ -28678,7 +28678,7 @@
             <a:tbl>
               <a:tblPr>
                 <a:noFill/>
-                <a:tableStyleId>{91043335-9176-4132-B228-1DF7EC033154}</a:tableStyleId>
+                <a:tableStyleId>{81AE8075-4DFA-4ACD-903E-96CCAC7EE2F4}</a:tableStyleId>
               </a:tblPr>
               <a:tblGrid>
                 <a:gridCol w="1695200"/>
@@ -29670,7 +29670,7 @@
             <a:tbl>
               <a:tblPr>
                 <a:noFill/>
-                <a:tableStyleId>{91043335-9176-4132-B228-1DF7EC033154}</a:tableStyleId>
+                <a:tableStyleId>{81AE8075-4DFA-4ACD-903E-96CCAC7EE2F4}</a:tableStyleId>
               </a:tblPr>
               <a:tblGrid>
                 <a:gridCol w="3048000"/>
@@ -33175,7 +33175,7 @@
             <a:tbl>
               <a:tblPr>
                 <a:noFill/>
-                <a:tableStyleId>{91043335-9176-4132-B228-1DF7EC033154}</a:tableStyleId>
+                <a:tableStyleId>{81AE8075-4DFA-4ACD-903E-96CCAC7EE2F4}</a:tableStyleId>
               </a:tblPr>
               <a:tblGrid>
                 <a:gridCol w="1828800"/>
@@ -34002,285 +34002,6 @@
 </file>
 
 <file path=ppt/theme/theme1.xml><?xml version="1.0" encoding="utf-8"?>
-<a:theme xmlns:a="http://schemas.openxmlformats.org/drawingml/2006/main" xmlns:r="http://schemas.openxmlformats.org/officeDocument/2006/relationships" name="Simple Light">
-  <a:themeElements>
-    <a:clrScheme name="Simple Light">
-      <a:dk1>
-        <a:srgbClr val="000000"/>
-      </a:dk1>
-      <a:lt1>
-        <a:srgbClr val="FFFFFF"/>
-      </a:lt1>
-      <a:dk2>
-        <a:srgbClr val="595959"/>
-      </a:dk2>
-      <a:lt2>
-        <a:srgbClr val="EEEEEE"/>
-      </a:lt2>
-      <a:accent1>
-        <a:srgbClr val="4285F4"/>
-      </a:accent1>
-      <a:accent2>
-        <a:srgbClr val="212121"/>
-      </a:accent2>
-      <a:accent3>
-        <a:srgbClr val="78909C"/>
-      </a:accent3>
-      <a:accent4>
-        <a:srgbClr val="FFAB40"/>
-      </a:accent4>
-      <a:accent5>
-        <a:srgbClr val="0097A7"/>
-      </a:accent5>
-      <a:accent6>
-        <a:srgbClr val="EEFF41"/>
-      </a:accent6>
-      <a:hlink>
-        <a:srgbClr val="0097A7"/>
-      </a:hlink>
-      <a:folHlink>
-        <a:srgbClr val="0097A7"/>
-      </a:folHlink>
-    </a:clrScheme>
-    <a:fontScheme name="Office">
-      <a:majorFont>
-        <a:latin typeface="Arial"/>
-        <a:ea typeface=""/>
-        <a:cs typeface=""/>
-        <a:font script="Jpan" typeface="ＭＳ Ｐゴシック"/>
-        <a:font script="Hang" typeface="맑은 고딕"/>
-        <a:font script="Hans" typeface="宋体"/>
-        <a:font script="Hant" typeface="新細明體"/>
-        <a:font script="Arab" typeface="Times New Roman"/>
-        <a:font script="Hebr" typeface="Times New Roman"/>
-        <a:font script="Thai" typeface="Angsana New"/>
-        <a:font script="Ethi" typeface="Nyala"/>
-        <a:font script="Beng" typeface="Vrinda"/>
-        <a:font script="Gujr" typeface="Shruti"/>
-        <a:font script="Khmr" typeface="MoolBoran"/>
-        <a:font script="Knda" typeface="Tunga"/>
-        <a:font script="Guru" typeface="Raavi"/>
-        <a:font script="Cans" typeface="Euphemia"/>
-        <a:font script="Cher" typeface="Plantagenet Cherokee"/>
-        <a:font script="Yiii" typeface="Microsoft Yi Baiti"/>
-        <a:font script="Tibt" typeface="Microsoft Himalaya"/>
-        <a:font script="Thaa" typeface="MV Boli"/>
-        <a:font script="Deva" typeface="Mangal"/>
-        <a:font script="Telu" typeface="Gautami"/>
-        <a:font script="Taml" typeface="Latha"/>
-        <a:font script="Syrc" typeface="Estrangelo Edessa"/>
-        <a:font script="Orya" typeface="Kalinga"/>
-        <a:font script="Mlym" typeface="Kartika"/>
-        <a:font script="Laoo" typeface="DokChampa"/>
-        <a:font script="Sinh" typeface="Iskoola Pota"/>
-        <a:font script="Mong" typeface="Mongolian Baiti"/>
-        <a:font script="Viet" typeface="Times New Roman"/>
-        <a:font script="Uigh" typeface="Microsoft Uighur"/>
-        <a:font script="Geor" typeface="Sylfaen"/>
-      </a:majorFont>
-      <a:minorFont>
-        <a:latin typeface="Arial"/>
-        <a:ea typeface=""/>
-        <a:cs typeface=""/>
-        <a:font script="Jpan" typeface="ＭＳ Ｐゴシック"/>
-        <a:font script="Hang" typeface="맑은 고딕"/>
-        <a:font script="Hans" typeface="宋体"/>
-        <a:font script="Hant" typeface="新細明體"/>
-        <a:font script="Arab" typeface="Arial"/>
-        <a:font script="Hebr" typeface="Arial"/>
-        <a:font script="Thai" typeface="Cordia New"/>
-        <a:font script="Ethi" typeface="Nyala"/>
-        <a:font script="Beng" typeface="Vrinda"/>
-        <a:font script="Gujr" typeface="Shruti"/>
-        <a:font script="Khmr" typeface="DaunPenh"/>
-        <a:font script="Knda" typeface="Tunga"/>
-        <a:font script="Guru" typeface="Raavi"/>
-        <a:font script="Cans" typeface="Euphemia"/>
-        <a:font script="Cher" typeface="Plantagenet Cherokee"/>
-        <a:font script="Yiii" typeface="Microsoft Yi Baiti"/>
-        <a:font script="Tibt" typeface="Microsoft Himalaya"/>
-        <a:font script="Thaa" typeface="MV Boli"/>
-        <a:font script="Deva" typeface="Mangal"/>
-        <a:font script="Telu" typeface="Gautami"/>
-        <a:font script="Taml" typeface="Latha"/>
-        <a:font script="Syrc" typeface="Estrangelo Edessa"/>
-        <a:font script="Orya" typeface="Kalinga"/>
-        <a:font script="Mlym" typeface="Kartika"/>
-        <a:font script="Laoo" typeface="DokChampa"/>
-        <a:font script="Sinh" typeface="Iskoola Pota"/>
-        <a:font script="Mong" typeface="Mongolian Baiti"/>
-        <a:font script="Viet" typeface="Arial"/>
-        <a:font script="Uigh" typeface="Microsoft Uighur"/>
-        <a:font script="Geor" typeface="Sylfaen"/>
-      </a:minorFont>
-    </a:fontScheme>
-    <a:fmtScheme name="Office">
-      <a:fillStyleLst>
-        <a:solidFill>
-          <a:schemeClr val="phClr"/>
-        </a:solidFill>
-        <a:gradFill rotWithShape="1">
-          <a:gsLst>
-            <a:gs pos="0">
-              <a:schemeClr val="phClr">
-                <a:tint val="50000"/>
-                <a:satMod val="300000"/>
-              </a:schemeClr>
-            </a:gs>
-            <a:gs pos="35000">
-              <a:schemeClr val="phClr">
-                <a:tint val="37000"/>
-                <a:satMod val="300000"/>
-              </a:schemeClr>
-            </a:gs>
-            <a:gs pos="100000">
-              <a:schemeClr val="phClr">
-                <a:tint val="15000"/>
-                <a:satMod val="350000"/>
-              </a:schemeClr>
-            </a:gs>
-          </a:gsLst>
-          <a:lin ang="16200000" scaled="1"/>
-        </a:gradFill>
-        <a:gradFill rotWithShape="1">
-          <a:gsLst>
-            <a:gs pos="0">
-              <a:schemeClr val="phClr">
-                <a:tint val="100000"/>
-                <a:shade val="100000"/>
-                <a:satMod val="130000"/>
-              </a:schemeClr>
-            </a:gs>
-            <a:gs pos="100000">
-              <a:schemeClr val="phClr">
-                <a:tint val="50000"/>
-                <a:shade val="100000"/>
-                <a:satMod val="350000"/>
-              </a:schemeClr>
-            </a:gs>
-          </a:gsLst>
-          <a:lin ang="16200000" scaled="0"/>
-        </a:gradFill>
-      </a:fillStyleLst>
-      <a:lnStyleLst>
-        <a:ln w="9525" cap="flat" cmpd="sng" algn="ctr">
-          <a:solidFill>
-            <a:schemeClr val="phClr">
-              <a:shade val="95000"/>
-              <a:satMod val="105000"/>
-            </a:schemeClr>
-          </a:solidFill>
-          <a:prstDash val="solid"/>
-        </a:ln>
-        <a:ln w="25400" cap="flat" cmpd="sng" algn="ctr">
-          <a:solidFill>
-            <a:schemeClr val="phClr"/>
-          </a:solidFill>
-          <a:prstDash val="solid"/>
-        </a:ln>
-        <a:ln w="38100" cap="flat" cmpd="sng" algn="ctr">
-          <a:solidFill>
-            <a:schemeClr val="phClr"/>
-          </a:solidFill>
-          <a:prstDash val="solid"/>
-        </a:ln>
-      </a:lnStyleLst>
-      <a:effectStyleLst>
-        <a:effectStyle>
-          <a:effectLst>
-            <a:outerShdw blurRad="40000" dist="20000" dir="5400000" rotWithShape="0">
-              <a:srgbClr val="000000">
-                <a:alpha val="38000"/>
-              </a:srgbClr>
-            </a:outerShdw>
-          </a:effectLst>
-        </a:effectStyle>
-        <a:effectStyle>
-          <a:effectLst>
-            <a:outerShdw blurRad="40000" dist="23000" dir="5400000" rotWithShape="0">
-              <a:srgbClr val="000000">
-                <a:alpha val="35000"/>
-              </a:srgbClr>
-            </a:outerShdw>
-          </a:effectLst>
-        </a:effectStyle>
-        <a:effectStyle>
-          <a:effectLst>
-            <a:outerShdw blurRad="40000" dist="23000" dir="5400000" rotWithShape="0">
-              <a:srgbClr val="000000">
-                <a:alpha val="35000"/>
-              </a:srgbClr>
-            </a:outerShdw>
-          </a:effectLst>
-          <a:scene3d>
-            <a:camera prst="orthographicFront">
-              <a:rot lat="0" lon="0" rev="0"/>
-            </a:camera>
-            <a:lightRig rig="threePt" dir="t">
-              <a:rot lat="0" lon="0" rev="1200000"/>
-            </a:lightRig>
-          </a:scene3d>
-          <a:sp3d>
-            <a:bevelT w="63500" h="25400"/>
-          </a:sp3d>
-        </a:effectStyle>
-      </a:effectStyleLst>
-      <a:bgFillStyleLst>
-        <a:solidFill>
-          <a:schemeClr val="phClr"/>
-        </a:solidFill>
-        <a:gradFill rotWithShape="1">
-          <a:gsLst>
-            <a:gs pos="0">
-              <a:schemeClr val="phClr">
-                <a:tint val="40000"/>
-                <a:satMod val="350000"/>
-              </a:schemeClr>
-            </a:gs>
-            <a:gs pos="40000">
-              <a:schemeClr val="phClr">
-                <a:tint val="45000"/>
-                <a:shade val="99000"/>
-                <a:satMod val="350000"/>
-              </a:schemeClr>
-            </a:gs>
-            <a:gs pos="100000">
-              <a:schemeClr val="phClr">
-                <a:shade val="20000"/>
-                <a:satMod val="255000"/>
-              </a:schemeClr>
-            </a:gs>
-          </a:gsLst>
-          <a:path path="circle">
-            <a:fillToRect l="50000" t="-80000" r="50000" b="180000"/>
-          </a:path>
-        </a:gradFill>
-        <a:gradFill rotWithShape="1">
-          <a:gsLst>
-            <a:gs pos="0">
-              <a:schemeClr val="phClr">
-                <a:tint val="80000"/>
-                <a:satMod val="300000"/>
-              </a:schemeClr>
-            </a:gs>
-            <a:gs pos="100000">
-              <a:schemeClr val="phClr">
-                <a:shade val="30000"/>
-                <a:satMod val="200000"/>
-              </a:schemeClr>
-            </a:gs>
-          </a:gsLst>
-          <a:path path="circle">
-            <a:fillToRect l="50000" t="50000" r="50000" b="50000"/>
-          </a:path>
-        </a:gradFill>
-      </a:bgFillStyleLst>
-    </a:fmtScheme>
-  </a:themeElements>
-</a:theme>
-</file>
-
-<file path=ppt/theme/theme2.xml><?xml version="1.0" encoding="utf-8"?>
 <a:theme xmlns:a="http://schemas.openxmlformats.org/drawingml/2006/main" xmlns:r="http://schemas.openxmlformats.org/officeDocument/2006/relationships" name="LF Energy Theme 2023">
   <a:themeElements>
     <a:clrScheme name="Geometric">
@@ -34559,7 +34280,7 @@
 </a:theme>
 </file>
 
-<file path=ppt/theme/theme3.xml><?xml version="1.0" encoding="utf-8"?>
+<file path=ppt/theme/theme2.xml><?xml version="1.0" encoding="utf-8"?>
 <a:theme xmlns:a="http://schemas.openxmlformats.org/drawingml/2006/main" xmlns:r="http://schemas.openxmlformats.org/officeDocument/2006/relationships">
   <a:themeElements>
     <a:clrScheme name="Default">
@@ -34836,4 +34557,283 @@
     </a:fmtScheme>
   </a:themeElements>
 </a:theme>
+</file>
+
+<file path=ppt/theme/theme3.xml><?xml version="1.0" encoding="utf-8"?>
+<a:theme xmlns:a="http://schemas.openxmlformats.org/drawingml/2006/main" xmlns:r="http://schemas.openxmlformats.org/officeDocument/2006/relationships" name="Simple Light">
+  <a:themeElements>
+    <a:clrScheme name="Simple Light">
+      <a:dk1>
+        <a:srgbClr val="000000"/>
+      </a:dk1>
+      <a:lt1>
+        <a:srgbClr val="FFFFFF"/>
+      </a:lt1>
+      <a:dk2>
+        <a:srgbClr val="595959"/>
+      </a:dk2>
+      <a:lt2>
+        <a:srgbClr val="EEEEEE"/>
+      </a:lt2>
+      <a:accent1>
+        <a:srgbClr val="4285F4"/>
+      </a:accent1>
+      <a:accent2>
+        <a:srgbClr val="212121"/>
+      </a:accent2>
+      <a:accent3>
+        <a:srgbClr val="78909C"/>
+      </a:accent3>
+      <a:accent4>
+        <a:srgbClr val="FFAB40"/>
+      </a:accent4>
+      <a:accent5>
+        <a:srgbClr val="0097A7"/>
+      </a:accent5>
+      <a:accent6>
+        <a:srgbClr val="EEFF41"/>
+      </a:accent6>
+      <a:hlink>
+        <a:srgbClr val="0097A7"/>
+      </a:hlink>
+      <a:folHlink>
+        <a:srgbClr val="0097A7"/>
+      </a:folHlink>
+    </a:clrScheme>
+    <a:fontScheme name="Office">
+      <a:majorFont>
+        <a:latin typeface="Arial"/>
+        <a:ea typeface=""/>
+        <a:cs typeface=""/>
+        <a:font script="Jpan" typeface="ＭＳ Ｐゴシック"/>
+        <a:font script="Hang" typeface="맑은 고딕"/>
+        <a:font script="Hans" typeface="宋体"/>
+        <a:font script="Hant" typeface="新細明體"/>
+        <a:font script="Arab" typeface="Times New Roman"/>
+        <a:font script="Hebr" typeface="Times New Roman"/>
+        <a:font script="Thai" typeface="Angsana New"/>
+        <a:font script="Ethi" typeface="Nyala"/>
+        <a:font script="Beng" typeface="Vrinda"/>
+        <a:font script="Gujr" typeface="Shruti"/>
+        <a:font script="Khmr" typeface="MoolBoran"/>
+        <a:font script="Knda" typeface="Tunga"/>
+        <a:font script="Guru" typeface="Raavi"/>
+        <a:font script="Cans" typeface="Euphemia"/>
+        <a:font script="Cher" typeface="Plantagenet Cherokee"/>
+        <a:font script="Yiii" typeface="Microsoft Yi Baiti"/>
+        <a:font script="Tibt" typeface="Microsoft Himalaya"/>
+        <a:font script="Thaa" typeface="MV Boli"/>
+        <a:font script="Deva" typeface="Mangal"/>
+        <a:font script="Telu" typeface="Gautami"/>
+        <a:font script="Taml" typeface="Latha"/>
+        <a:font script="Syrc" typeface="Estrangelo Edessa"/>
+        <a:font script="Orya" typeface="Kalinga"/>
+        <a:font script="Mlym" typeface="Kartika"/>
+        <a:font script="Laoo" typeface="DokChampa"/>
+        <a:font script="Sinh" typeface="Iskoola Pota"/>
+        <a:font script="Mong" typeface="Mongolian Baiti"/>
+        <a:font script="Viet" typeface="Times New Roman"/>
+        <a:font script="Uigh" typeface="Microsoft Uighur"/>
+        <a:font script="Geor" typeface="Sylfaen"/>
+      </a:majorFont>
+      <a:minorFont>
+        <a:latin typeface="Arial"/>
+        <a:ea typeface=""/>
+        <a:cs typeface=""/>
+        <a:font script="Jpan" typeface="ＭＳ Ｐゴシック"/>
+        <a:font script="Hang" typeface="맑은 고딕"/>
+        <a:font script="Hans" typeface="宋体"/>
+        <a:font script="Hant" typeface="新細明體"/>
+        <a:font script="Arab" typeface="Arial"/>
+        <a:font script="Hebr" typeface="Arial"/>
+        <a:font script="Thai" typeface="Cordia New"/>
+        <a:font script="Ethi" typeface="Nyala"/>
+        <a:font script="Beng" typeface="Vrinda"/>
+        <a:font script="Gujr" typeface="Shruti"/>
+        <a:font script="Khmr" typeface="DaunPenh"/>
+        <a:font script="Knda" typeface="Tunga"/>
+        <a:font script="Guru" typeface="Raavi"/>
+        <a:font script="Cans" typeface="Euphemia"/>
+        <a:font script="Cher" typeface="Plantagenet Cherokee"/>
+        <a:font script="Yiii" typeface="Microsoft Yi Baiti"/>
+        <a:font script="Tibt" typeface="Microsoft Himalaya"/>
+        <a:font script="Thaa" typeface="MV Boli"/>
+        <a:font script="Deva" typeface="Mangal"/>
+        <a:font script="Telu" typeface="Gautami"/>
+        <a:font script="Taml" typeface="Latha"/>
+        <a:font script="Syrc" typeface="Estrangelo Edessa"/>
+        <a:font script="Orya" typeface="Kalinga"/>
+        <a:font script="Mlym" typeface="Kartika"/>
+        <a:font script="Laoo" typeface="DokChampa"/>
+        <a:font script="Sinh" typeface="Iskoola Pota"/>
+        <a:font script="Mong" typeface="Mongolian Baiti"/>
+        <a:font script="Viet" typeface="Arial"/>
+        <a:font script="Uigh" typeface="Microsoft Uighur"/>
+        <a:font script="Geor" typeface="Sylfaen"/>
+      </a:minorFont>
+    </a:fontScheme>
+    <a:fmtScheme name="Office">
+      <a:fillStyleLst>
+        <a:solidFill>
+          <a:schemeClr val="phClr"/>
+        </a:solidFill>
+        <a:gradFill rotWithShape="1">
+          <a:gsLst>
+            <a:gs pos="0">
+              <a:schemeClr val="phClr">
+                <a:tint val="50000"/>
+                <a:satMod val="300000"/>
+              </a:schemeClr>
+            </a:gs>
+            <a:gs pos="35000">
+              <a:schemeClr val="phClr">
+                <a:tint val="37000"/>
+                <a:satMod val="300000"/>
+              </a:schemeClr>
+            </a:gs>
+            <a:gs pos="100000">
+              <a:schemeClr val="phClr">
+                <a:tint val="15000"/>
+                <a:satMod val="350000"/>
+              </a:schemeClr>
+            </a:gs>
+          </a:gsLst>
+          <a:lin ang="16200000" scaled="1"/>
+        </a:gradFill>
+        <a:gradFill rotWithShape="1">
+          <a:gsLst>
+            <a:gs pos="0">
+              <a:schemeClr val="phClr">
+                <a:tint val="100000"/>
+                <a:shade val="100000"/>
+                <a:satMod val="130000"/>
+              </a:schemeClr>
+            </a:gs>
+            <a:gs pos="100000">
+              <a:schemeClr val="phClr">
+                <a:tint val="50000"/>
+                <a:shade val="100000"/>
+                <a:satMod val="350000"/>
+              </a:schemeClr>
+            </a:gs>
+          </a:gsLst>
+          <a:lin ang="16200000" scaled="0"/>
+        </a:gradFill>
+      </a:fillStyleLst>
+      <a:lnStyleLst>
+        <a:ln w="9525" cap="flat" cmpd="sng" algn="ctr">
+          <a:solidFill>
+            <a:schemeClr val="phClr">
+              <a:shade val="95000"/>
+              <a:satMod val="105000"/>
+            </a:schemeClr>
+          </a:solidFill>
+          <a:prstDash val="solid"/>
+        </a:ln>
+        <a:ln w="25400" cap="flat" cmpd="sng" algn="ctr">
+          <a:solidFill>
+            <a:schemeClr val="phClr"/>
+          </a:solidFill>
+          <a:prstDash val="solid"/>
+        </a:ln>
+        <a:ln w="38100" cap="flat" cmpd="sng" algn="ctr">
+          <a:solidFill>
+            <a:schemeClr val="phClr"/>
+          </a:solidFill>
+          <a:prstDash val="solid"/>
+        </a:ln>
+      </a:lnStyleLst>
+      <a:effectStyleLst>
+        <a:effectStyle>
+          <a:effectLst>
+            <a:outerShdw blurRad="40000" dist="20000" dir="5400000" rotWithShape="0">
+              <a:srgbClr val="000000">
+                <a:alpha val="38000"/>
+              </a:srgbClr>
+            </a:outerShdw>
+          </a:effectLst>
+        </a:effectStyle>
+        <a:effectStyle>
+          <a:effectLst>
+            <a:outerShdw blurRad="40000" dist="23000" dir="5400000" rotWithShape="0">
+              <a:srgbClr val="000000">
+                <a:alpha val="35000"/>
+              </a:srgbClr>
+            </a:outerShdw>
+          </a:effectLst>
+        </a:effectStyle>
+        <a:effectStyle>
+          <a:effectLst>
+            <a:outerShdw blurRad="40000" dist="23000" dir="5400000" rotWithShape="0">
+              <a:srgbClr val="000000">
+                <a:alpha val="35000"/>
+              </a:srgbClr>
+            </a:outerShdw>
+          </a:effectLst>
+          <a:scene3d>
+            <a:camera prst="orthographicFront">
+              <a:rot lat="0" lon="0" rev="0"/>
+            </a:camera>
+            <a:lightRig rig="threePt" dir="t">
+              <a:rot lat="0" lon="0" rev="1200000"/>
+            </a:lightRig>
+          </a:scene3d>
+          <a:sp3d>
+            <a:bevelT w="63500" h="25400"/>
+          </a:sp3d>
+        </a:effectStyle>
+      </a:effectStyleLst>
+      <a:bgFillStyleLst>
+        <a:solidFill>
+          <a:schemeClr val="phClr"/>
+        </a:solidFill>
+        <a:gradFill rotWithShape="1">
+          <a:gsLst>
+            <a:gs pos="0">
+              <a:schemeClr val="phClr">
+                <a:tint val="40000"/>
+                <a:satMod val="350000"/>
+              </a:schemeClr>
+            </a:gs>
+            <a:gs pos="40000">
+              <a:schemeClr val="phClr">
+                <a:tint val="45000"/>
+                <a:shade val="99000"/>
+                <a:satMod val="350000"/>
+              </a:schemeClr>
+            </a:gs>
+            <a:gs pos="100000">
+              <a:schemeClr val="phClr">
+                <a:shade val="20000"/>
+                <a:satMod val="255000"/>
+              </a:schemeClr>
+            </a:gs>
+          </a:gsLst>
+          <a:path path="circle">
+            <a:fillToRect l="50000" t="-80000" r="50000" b="180000"/>
+          </a:path>
+        </a:gradFill>
+        <a:gradFill rotWithShape="1">
+          <a:gsLst>
+            <a:gs pos="0">
+              <a:schemeClr val="phClr">
+                <a:tint val="80000"/>
+                <a:satMod val="300000"/>
+              </a:schemeClr>
+            </a:gs>
+            <a:gs pos="100000">
+              <a:schemeClr val="phClr">
+                <a:shade val="30000"/>
+                <a:satMod val="200000"/>
+              </a:schemeClr>
+            </a:gs>
+          </a:gsLst>
+          <a:path path="circle">
+            <a:fillToRect l="50000" t="50000" r="50000" b="50000"/>
+          </a:path>
+        </a:gradFill>
+      </a:bgFillStyleLst>
+    </a:fmtScheme>
+  </a:themeElements>
+</a:theme>
 </file>
</xml_diff>

<commit_message>
Update Data Sources from LFX 2026-10-06 (#333)
Update Data Sources from LFX

Signed-off-by: github-actions[bot] <41898282+github-actions[bot]@users.noreply.github.com>
Co-authored-by: jmertic <296737+jmertic@users.noreply.github.com>
</commit_message>
<xml_diff>
--- a/overview_deck/LF Energy High Level Overview.pptx
+++ b/overview_deck/LF Energy High Level Overview.pptx
@@ -25946,7 +25946,7 @@
             <a:tbl>
               <a:tblPr>
                 <a:noFill/>
-                <a:tableStyleId>{81AE8075-4DFA-4ACD-903E-96CCAC7EE2F4}</a:tableStyleId>
+                <a:tableStyleId>{011720FC-AB45-42A0-9109-98BCBCCE134F}</a:tableStyleId>
               </a:tblPr>
               <a:tblGrid>
                 <a:gridCol w="1695200"/>
@@ -26736,7 +26736,7 @@
             <a:tbl>
               <a:tblPr>
                 <a:noFill/>
-                <a:tableStyleId>{81AE8075-4DFA-4ACD-903E-96CCAC7EE2F4}</a:tableStyleId>
+                <a:tableStyleId>{011720FC-AB45-42A0-9109-98BCBCCE134F}</a:tableStyleId>
               </a:tblPr>
               <a:tblGrid>
                 <a:gridCol w="1695200"/>
@@ -27426,7 +27426,7 @@
             <a:tbl>
               <a:tblPr>
                 <a:noFill/>
-                <a:tableStyleId>{81AE8075-4DFA-4ACD-903E-96CCAC7EE2F4}</a:tableStyleId>
+                <a:tableStyleId>{011720FC-AB45-42A0-9109-98BCBCCE134F}</a:tableStyleId>
               </a:tblPr>
               <a:tblGrid>
                 <a:gridCol w="1695200"/>
@@ -28678,7 +28678,7 @@
             <a:tbl>
               <a:tblPr>
                 <a:noFill/>
-                <a:tableStyleId>{81AE8075-4DFA-4ACD-903E-96CCAC7EE2F4}</a:tableStyleId>
+                <a:tableStyleId>{011720FC-AB45-42A0-9109-98BCBCCE134F}</a:tableStyleId>
               </a:tblPr>
               <a:tblGrid>
                 <a:gridCol w="1695200"/>
@@ -29670,7 +29670,7 @@
             <a:tbl>
               <a:tblPr>
                 <a:noFill/>
-                <a:tableStyleId>{81AE8075-4DFA-4ACD-903E-96CCAC7EE2F4}</a:tableStyleId>
+                <a:tableStyleId>{011720FC-AB45-42A0-9109-98BCBCCE134F}</a:tableStyleId>
               </a:tblPr>
               <a:tblGrid>
                 <a:gridCol w="3048000"/>
@@ -33175,7 +33175,7 @@
             <a:tbl>
               <a:tblPr>
                 <a:noFill/>
-                <a:tableStyleId>{81AE8075-4DFA-4ACD-903E-96CCAC7EE2F4}</a:tableStyleId>
+                <a:tableStyleId>{011720FC-AB45-42A0-9109-98BCBCCE134F}</a:tableStyleId>
               </a:tblPr>
               <a:tblGrid>
                 <a:gridCol w="1828800"/>
@@ -34002,285 +34002,6 @@
 </file>
 
 <file path=ppt/theme/theme1.xml><?xml version="1.0" encoding="utf-8"?>
-<a:theme xmlns:a="http://schemas.openxmlformats.org/drawingml/2006/main" xmlns:r="http://schemas.openxmlformats.org/officeDocument/2006/relationships" name="LF Energy Theme 2023">
-  <a:themeElements>
-    <a:clrScheme name="Geometric">
-      <a:dk1>
-        <a:srgbClr val="222222"/>
-      </a:dk1>
-      <a:lt1>
-        <a:srgbClr val="FFFFFF"/>
-      </a:lt1>
-      <a:dk2>
-        <a:srgbClr val="434343"/>
-      </a:dk2>
-      <a:lt2>
-        <a:srgbClr val="999999"/>
-      </a:lt2>
-      <a:accent1>
-        <a:srgbClr val="003778"/>
-      </a:accent1>
-      <a:accent2>
-        <a:srgbClr val="0094FF"/>
-      </a:accent2>
-      <a:accent3>
-        <a:srgbClr val="5B1DE7"/>
-      </a:accent3>
-      <a:accent4>
-        <a:srgbClr val="12E2E2"/>
-      </a:accent4>
-      <a:accent5>
-        <a:srgbClr val="FF00AA"/>
-      </a:accent5>
-      <a:accent6>
-        <a:srgbClr val="ACDE1F"/>
-      </a:accent6>
-      <a:hlink>
-        <a:srgbClr val="0077CC"/>
-      </a:hlink>
-      <a:folHlink>
-        <a:srgbClr val="F06292"/>
-      </a:folHlink>
-    </a:clrScheme>
-    <a:fontScheme name="Office">
-      <a:majorFont>
-        <a:latin typeface="Arial"/>
-        <a:ea typeface=""/>
-        <a:cs typeface=""/>
-        <a:font script="Jpan" typeface="ＭＳ Ｐゴシック"/>
-        <a:font script="Hang" typeface="맑은 고딕"/>
-        <a:font script="Hans" typeface="宋体"/>
-        <a:font script="Hant" typeface="新細明體"/>
-        <a:font script="Arab" typeface="Times New Roman"/>
-        <a:font script="Hebr" typeface="Times New Roman"/>
-        <a:font script="Thai" typeface="Angsana New"/>
-        <a:font script="Ethi" typeface="Nyala"/>
-        <a:font script="Beng" typeface="Vrinda"/>
-        <a:font script="Gujr" typeface="Shruti"/>
-        <a:font script="Khmr" typeface="MoolBoran"/>
-        <a:font script="Knda" typeface="Tunga"/>
-        <a:font script="Guru" typeface="Raavi"/>
-        <a:font script="Cans" typeface="Euphemia"/>
-        <a:font script="Cher" typeface="Plantagenet Cherokee"/>
-        <a:font script="Yiii" typeface="Microsoft Yi Baiti"/>
-        <a:font script="Tibt" typeface="Microsoft Himalaya"/>
-        <a:font script="Thaa" typeface="MV Boli"/>
-        <a:font script="Deva" typeface="Mangal"/>
-        <a:font script="Telu" typeface="Gautami"/>
-        <a:font script="Taml" typeface="Latha"/>
-        <a:font script="Syrc" typeface="Estrangelo Edessa"/>
-        <a:font script="Orya" typeface="Kalinga"/>
-        <a:font script="Mlym" typeface="Kartika"/>
-        <a:font script="Laoo" typeface="DokChampa"/>
-        <a:font script="Sinh" typeface="Iskoola Pota"/>
-        <a:font script="Mong" typeface="Mongolian Baiti"/>
-        <a:font script="Viet" typeface="Times New Roman"/>
-        <a:font script="Uigh" typeface="Microsoft Uighur"/>
-        <a:font script="Geor" typeface="Sylfaen"/>
-      </a:majorFont>
-      <a:minorFont>
-        <a:latin typeface="Arial"/>
-        <a:ea typeface=""/>
-        <a:cs typeface=""/>
-        <a:font script="Jpan" typeface="ＭＳ Ｐゴシック"/>
-        <a:font script="Hang" typeface="맑은 고딕"/>
-        <a:font script="Hans" typeface="宋体"/>
-        <a:font script="Hant" typeface="新細明體"/>
-        <a:font script="Arab" typeface="Arial"/>
-        <a:font script="Hebr" typeface="Arial"/>
-        <a:font script="Thai" typeface="Cordia New"/>
-        <a:font script="Ethi" typeface="Nyala"/>
-        <a:font script="Beng" typeface="Vrinda"/>
-        <a:font script="Gujr" typeface="Shruti"/>
-        <a:font script="Khmr" typeface="DaunPenh"/>
-        <a:font script="Knda" typeface="Tunga"/>
-        <a:font script="Guru" typeface="Raavi"/>
-        <a:font script="Cans" typeface="Euphemia"/>
-        <a:font script="Cher" typeface="Plantagenet Cherokee"/>
-        <a:font script="Yiii" typeface="Microsoft Yi Baiti"/>
-        <a:font script="Tibt" typeface="Microsoft Himalaya"/>
-        <a:font script="Thaa" typeface="MV Boli"/>
-        <a:font script="Deva" typeface="Mangal"/>
-        <a:font script="Telu" typeface="Gautami"/>
-        <a:font script="Taml" typeface="Latha"/>
-        <a:font script="Syrc" typeface="Estrangelo Edessa"/>
-        <a:font script="Orya" typeface="Kalinga"/>
-        <a:font script="Mlym" typeface="Kartika"/>
-        <a:font script="Laoo" typeface="DokChampa"/>
-        <a:font script="Sinh" typeface="Iskoola Pota"/>
-        <a:font script="Mong" typeface="Mongolian Baiti"/>
-        <a:font script="Viet" typeface="Arial"/>
-        <a:font script="Uigh" typeface="Microsoft Uighur"/>
-        <a:font script="Geor" typeface="Sylfaen"/>
-      </a:minorFont>
-    </a:fontScheme>
-    <a:fmtScheme name="Office">
-      <a:fillStyleLst>
-        <a:solidFill>
-          <a:schemeClr val="phClr"/>
-        </a:solidFill>
-        <a:gradFill rotWithShape="1">
-          <a:gsLst>
-            <a:gs pos="0">
-              <a:schemeClr val="phClr">
-                <a:tint val="50000"/>
-                <a:satMod val="300000"/>
-              </a:schemeClr>
-            </a:gs>
-            <a:gs pos="35000">
-              <a:schemeClr val="phClr">
-                <a:tint val="37000"/>
-                <a:satMod val="300000"/>
-              </a:schemeClr>
-            </a:gs>
-            <a:gs pos="100000">
-              <a:schemeClr val="phClr">
-                <a:tint val="15000"/>
-                <a:satMod val="350000"/>
-              </a:schemeClr>
-            </a:gs>
-          </a:gsLst>
-          <a:lin ang="16200000" scaled="1"/>
-        </a:gradFill>
-        <a:gradFill rotWithShape="1">
-          <a:gsLst>
-            <a:gs pos="0">
-              <a:schemeClr val="phClr">
-                <a:tint val="100000"/>
-                <a:shade val="100000"/>
-                <a:satMod val="130000"/>
-              </a:schemeClr>
-            </a:gs>
-            <a:gs pos="100000">
-              <a:schemeClr val="phClr">
-                <a:tint val="50000"/>
-                <a:shade val="100000"/>
-                <a:satMod val="350000"/>
-              </a:schemeClr>
-            </a:gs>
-          </a:gsLst>
-          <a:lin ang="16200000" scaled="0"/>
-        </a:gradFill>
-      </a:fillStyleLst>
-      <a:lnStyleLst>
-        <a:ln w="9525" cap="flat" cmpd="sng" algn="ctr">
-          <a:solidFill>
-            <a:schemeClr val="phClr">
-              <a:shade val="95000"/>
-              <a:satMod val="105000"/>
-            </a:schemeClr>
-          </a:solidFill>
-          <a:prstDash val="solid"/>
-        </a:ln>
-        <a:ln w="25400" cap="flat" cmpd="sng" algn="ctr">
-          <a:solidFill>
-            <a:schemeClr val="phClr"/>
-          </a:solidFill>
-          <a:prstDash val="solid"/>
-        </a:ln>
-        <a:ln w="38100" cap="flat" cmpd="sng" algn="ctr">
-          <a:solidFill>
-            <a:schemeClr val="phClr"/>
-          </a:solidFill>
-          <a:prstDash val="solid"/>
-        </a:ln>
-      </a:lnStyleLst>
-      <a:effectStyleLst>
-        <a:effectStyle>
-          <a:effectLst>
-            <a:outerShdw blurRad="40000" dist="20000" dir="5400000" rotWithShape="0">
-              <a:srgbClr val="000000">
-                <a:alpha val="38000"/>
-              </a:srgbClr>
-            </a:outerShdw>
-          </a:effectLst>
-        </a:effectStyle>
-        <a:effectStyle>
-          <a:effectLst>
-            <a:outerShdw blurRad="40000" dist="23000" dir="5400000" rotWithShape="0">
-              <a:srgbClr val="000000">
-                <a:alpha val="35000"/>
-              </a:srgbClr>
-            </a:outerShdw>
-          </a:effectLst>
-        </a:effectStyle>
-        <a:effectStyle>
-          <a:effectLst>
-            <a:outerShdw blurRad="40000" dist="23000" dir="5400000" rotWithShape="0">
-              <a:srgbClr val="000000">
-                <a:alpha val="35000"/>
-              </a:srgbClr>
-            </a:outerShdw>
-          </a:effectLst>
-          <a:scene3d>
-            <a:camera prst="orthographicFront">
-              <a:rot lat="0" lon="0" rev="0"/>
-            </a:camera>
-            <a:lightRig rig="threePt" dir="t">
-              <a:rot lat="0" lon="0" rev="1200000"/>
-            </a:lightRig>
-          </a:scene3d>
-          <a:sp3d>
-            <a:bevelT w="63500" h="25400"/>
-          </a:sp3d>
-        </a:effectStyle>
-      </a:effectStyleLst>
-      <a:bgFillStyleLst>
-        <a:solidFill>
-          <a:schemeClr val="phClr"/>
-        </a:solidFill>
-        <a:gradFill rotWithShape="1">
-          <a:gsLst>
-            <a:gs pos="0">
-              <a:schemeClr val="phClr">
-                <a:tint val="40000"/>
-                <a:satMod val="350000"/>
-              </a:schemeClr>
-            </a:gs>
-            <a:gs pos="40000">
-              <a:schemeClr val="phClr">
-                <a:tint val="45000"/>
-                <a:shade val="99000"/>
-                <a:satMod val="350000"/>
-              </a:schemeClr>
-            </a:gs>
-            <a:gs pos="100000">
-              <a:schemeClr val="phClr">
-                <a:shade val="20000"/>
-                <a:satMod val="255000"/>
-              </a:schemeClr>
-            </a:gs>
-          </a:gsLst>
-          <a:path path="circle">
-            <a:fillToRect l="50000" t="-80000" r="50000" b="180000"/>
-          </a:path>
-        </a:gradFill>
-        <a:gradFill rotWithShape="1">
-          <a:gsLst>
-            <a:gs pos="0">
-              <a:schemeClr val="phClr">
-                <a:tint val="80000"/>
-                <a:satMod val="300000"/>
-              </a:schemeClr>
-            </a:gs>
-            <a:gs pos="100000">
-              <a:schemeClr val="phClr">
-                <a:shade val="30000"/>
-                <a:satMod val="200000"/>
-              </a:schemeClr>
-            </a:gs>
-          </a:gsLst>
-          <a:path path="circle">
-            <a:fillToRect l="50000" t="50000" r="50000" b="50000"/>
-          </a:path>
-        </a:gradFill>
-      </a:bgFillStyleLst>
-    </a:fmtScheme>
-  </a:themeElements>
-</a:theme>
-</file>
-
-<file path=ppt/theme/theme2.xml><?xml version="1.0" encoding="utf-8"?>
 <a:theme xmlns:a="http://schemas.openxmlformats.org/drawingml/2006/main" xmlns:r="http://schemas.openxmlformats.org/officeDocument/2006/relationships">
   <a:themeElements>
     <a:clrScheme name="Default">
@@ -34559,7 +34280,7 @@
 </a:theme>
 </file>
 
-<file path=ppt/theme/theme3.xml><?xml version="1.0" encoding="utf-8"?>
+<file path=ppt/theme/theme2.xml><?xml version="1.0" encoding="utf-8"?>
 <a:theme xmlns:a="http://schemas.openxmlformats.org/drawingml/2006/main" xmlns:r="http://schemas.openxmlformats.org/officeDocument/2006/relationships" name="Simple Light">
   <a:themeElements>
     <a:clrScheme name="Simple Light">
@@ -34836,4 +34557,283 @@
     </a:fmtScheme>
   </a:themeElements>
 </a:theme>
+</file>
+
+<file path=ppt/theme/theme3.xml><?xml version="1.0" encoding="utf-8"?>
+<a:theme xmlns:a="http://schemas.openxmlformats.org/drawingml/2006/main" xmlns:r="http://schemas.openxmlformats.org/officeDocument/2006/relationships" name="LF Energy Theme 2023">
+  <a:themeElements>
+    <a:clrScheme name="Geometric">
+      <a:dk1>
+        <a:srgbClr val="222222"/>
+      </a:dk1>
+      <a:lt1>
+        <a:srgbClr val="FFFFFF"/>
+      </a:lt1>
+      <a:dk2>
+        <a:srgbClr val="434343"/>
+      </a:dk2>
+      <a:lt2>
+        <a:srgbClr val="999999"/>
+      </a:lt2>
+      <a:accent1>
+        <a:srgbClr val="003778"/>
+      </a:accent1>
+      <a:accent2>
+        <a:srgbClr val="0094FF"/>
+      </a:accent2>
+      <a:accent3>
+        <a:srgbClr val="5B1DE7"/>
+      </a:accent3>
+      <a:accent4>
+        <a:srgbClr val="12E2E2"/>
+      </a:accent4>
+      <a:accent5>
+        <a:srgbClr val="FF00AA"/>
+      </a:accent5>
+      <a:accent6>
+        <a:srgbClr val="ACDE1F"/>
+      </a:accent6>
+      <a:hlink>
+        <a:srgbClr val="0077CC"/>
+      </a:hlink>
+      <a:folHlink>
+        <a:srgbClr val="F06292"/>
+      </a:folHlink>
+    </a:clrScheme>
+    <a:fontScheme name="Office">
+      <a:majorFont>
+        <a:latin typeface="Arial"/>
+        <a:ea typeface=""/>
+        <a:cs typeface=""/>
+        <a:font script="Jpan" typeface="ＭＳ Ｐゴシック"/>
+        <a:font script="Hang" typeface="맑은 고딕"/>
+        <a:font script="Hans" typeface="宋体"/>
+        <a:font script="Hant" typeface="新細明體"/>
+        <a:font script="Arab" typeface="Times New Roman"/>
+        <a:font script="Hebr" typeface="Times New Roman"/>
+        <a:font script="Thai" typeface="Angsana New"/>
+        <a:font script="Ethi" typeface="Nyala"/>
+        <a:font script="Beng" typeface="Vrinda"/>
+        <a:font script="Gujr" typeface="Shruti"/>
+        <a:font script="Khmr" typeface="MoolBoran"/>
+        <a:font script="Knda" typeface="Tunga"/>
+        <a:font script="Guru" typeface="Raavi"/>
+        <a:font script="Cans" typeface="Euphemia"/>
+        <a:font script="Cher" typeface="Plantagenet Cherokee"/>
+        <a:font script="Yiii" typeface="Microsoft Yi Baiti"/>
+        <a:font script="Tibt" typeface="Microsoft Himalaya"/>
+        <a:font script="Thaa" typeface="MV Boli"/>
+        <a:font script="Deva" typeface="Mangal"/>
+        <a:font script="Telu" typeface="Gautami"/>
+        <a:font script="Taml" typeface="Latha"/>
+        <a:font script="Syrc" typeface="Estrangelo Edessa"/>
+        <a:font script="Orya" typeface="Kalinga"/>
+        <a:font script="Mlym" typeface="Kartika"/>
+        <a:font script="Laoo" typeface="DokChampa"/>
+        <a:font script="Sinh" typeface="Iskoola Pota"/>
+        <a:font script="Mong" typeface="Mongolian Baiti"/>
+        <a:font script="Viet" typeface="Times New Roman"/>
+        <a:font script="Uigh" typeface="Microsoft Uighur"/>
+        <a:font script="Geor" typeface="Sylfaen"/>
+      </a:majorFont>
+      <a:minorFont>
+        <a:latin typeface="Arial"/>
+        <a:ea typeface=""/>
+        <a:cs typeface=""/>
+        <a:font script="Jpan" typeface="ＭＳ Ｐゴシック"/>
+        <a:font script="Hang" typeface="맑은 고딕"/>
+        <a:font script="Hans" typeface="宋体"/>
+        <a:font script="Hant" typeface="新細明體"/>
+        <a:font script="Arab" typeface="Arial"/>
+        <a:font script="Hebr" typeface="Arial"/>
+        <a:font script="Thai" typeface="Cordia New"/>
+        <a:font script="Ethi" typeface="Nyala"/>
+        <a:font script="Beng" typeface="Vrinda"/>
+        <a:font script="Gujr" typeface="Shruti"/>
+        <a:font script="Khmr" typeface="DaunPenh"/>
+        <a:font script="Knda" typeface="Tunga"/>
+        <a:font script="Guru" typeface="Raavi"/>
+        <a:font script="Cans" typeface="Euphemia"/>
+        <a:font script="Cher" typeface="Plantagenet Cherokee"/>
+        <a:font script="Yiii" typeface="Microsoft Yi Baiti"/>
+        <a:font script="Tibt" typeface="Microsoft Himalaya"/>
+        <a:font script="Thaa" typeface="MV Boli"/>
+        <a:font script="Deva" typeface="Mangal"/>
+        <a:font script="Telu" typeface="Gautami"/>
+        <a:font script="Taml" typeface="Latha"/>
+        <a:font script="Syrc" typeface="Estrangelo Edessa"/>
+        <a:font script="Orya" typeface="Kalinga"/>
+        <a:font script="Mlym" typeface="Kartika"/>
+        <a:font script="Laoo" typeface="DokChampa"/>
+        <a:font script="Sinh" typeface="Iskoola Pota"/>
+        <a:font script="Mong" typeface="Mongolian Baiti"/>
+        <a:font script="Viet" typeface="Arial"/>
+        <a:font script="Uigh" typeface="Microsoft Uighur"/>
+        <a:font script="Geor" typeface="Sylfaen"/>
+      </a:minorFont>
+    </a:fontScheme>
+    <a:fmtScheme name="Office">
+      <a:fillStyleLst>
+        <a:solidFill>
+          <a:schemeClr val="phClr"/>
+        </a:solidFill>
+        <a:gradFill rotWithShape="1">
+          <a:gsLst>
+            <a:gs pos="0">
+              <a:schemeClr val="phClr">
+                <a:tint val="50000"/>
+                <a:satMod val="300000"/>
+              </a:schemeClr>
+            </a:gs>
+            <a:gs pos="35000">
+              <a:schemeClr val="phClr">
+                <a:tint val="37000"/>
+                <a:satMod val="300000"/>
+              </a:schemeClr>
+            </a:gs>
+            <a:gs pos="100000">
+              <a:schemeClr val="phClr">
+                <a:tint val="15000"/>
+                <a:satMod val="350000"/>
+              </a:schemeClr>
+            </a:gs>
+          </a:gsLst>
+          <a:lin ang="16200000" scaled="1"/>
+        </a:gradFill>
+        <a:gradFill rotWithShape="1">
+          <a:gsLst>
+            <a:gs pos="0">
+              <a:schemeClr val="phClr">
+                <a:tint val="100000"/>
+                <a:shade val="100000"/>
+                <a:satMod val="130000"/>
+              </a:schemeClr>
+            </a:gs>
+            <a:gs pos="100000">
+              <a:schemeClr val="phClr">
+                <a:tint val="50000"/>
+                <a:shade val="100000"/>
+                <a:satMod val="350000"/>
+              </a:schemeClr>
+            </a:gs>
+          </a:gsLst>
+          <a:lin ang="16200000" scaled="0"/>
+        </a:gradFill>
+      </a:fillStyleLst>
+      <a:lnStyleLst>
+        <a:ln w="9525" cap="flat" cmpd="sng" algn="ctr">
+          <a:solidFill>
+            <a:schemeClr val="phClr">
+              <a:shade val="95000"/>
+              <a:satMod val="105000"/>
+            </a:schemeClr>
+          </a:solidFill>
+          <a:prstDash val="solid"/>
+        </a:ln>
+        <a:ln w="25400" cap="flat" cmpd="sng" algn="ctr">
+          <a:solidFill>
+            <a:schemeClr val="phClr"/>
+          </a:solidFill>
+          <a:prstDash val="solid"/>
+        </a:ln>
+        <a:ln w="38100" cap="flat" cmpd="sng" algn="ctr">
+          <a:solidFill>
+            <a:schemeClr val="phClr"/>
+          </a:solidFill>
+          <a:prstDash val="solid"/>
+        </a:ln>
+      </a:lnStyleLst>
+      <a:effectStyleLst>
+        <a:effectStyle>
+          <a:effectLst>
+            <a:outerShdw blurRad="40000" dist="20000" dir="5400000" rotWithShape="0">
+              <a:srgbClr val="000000">
+                <a:alpha val="38000"/>
+              </a:srgbClr>
+            </a:outerShdw>
+          </a:effectLst>
+        </a:effectStyle>
+        <a:effectStyle>
+          <a:effectLst>
+            <a:outerShdw blurRad="40000" dist="23000" dir="5400000" rotWithShape="0">
+              <a:srgbClr val="000000">
+                <a:alpha val="35000"/>
+              </a:srgbClr>
+            </a:outerShdw>
+          </a:effectLst>
+        </a:effectStyle>
+        <a:effectStyle>
+          <a:effectLst>
+            <a:outerShdw blurRad="40000" dist="23000" dir="5400000" rotWithShape="0">
+              <a:srgbClr val="000000">
+                <a:alpha val="35000"/>
+              </a:srgbClr>
+            </a:outerShdw>
+          </a:effectLst>
+          <a:scene3d>
+            <a:camera prst="orthographicFront">
+              <a:rot lat="0" lon="0" rev="0"/>
+            </a:camera>
+            <a:lightRig rig="threePt" dir="t">
+              <a:rot lat="0" lon="0" rev="1200000"/>
+            </a:lightRig>
+          </a:scene3d>
+          <a:sp3d>
+            <a:bevelT w="63500" h="25400"/>
+          </a:sp3d>
+        </a:effectStyle>
+      </a:effectStyleLst>
+      <a:bgFillStyleLst>
+        <a:solidFill>
+          <a:schemeClr val="phClr"/>
+        </a:solidFill>
+        <a:gradFill rotWithShape="1">
+          <a:gsLst>
+            <a:gs pos="0">
+              <a:schemeClr val="phClr">
+                <a:tint val="40000"/>
+                <a:satMod val="350000"/>
+              </a:schemeClr>
+            </a:gs>
+            <a:gs pos="40000">
+              <a:schemeClr val="phClr">
+                <a:tint val="45000"/>
+                <a:shade val="99000"/>
+                <a:satMod val="350000"/>
+              </a:schemeClr>
+            </a:gs>
+            <a:gs pos="100000">
+              <a:schemeClr val="phClr">
+                <a:shade val="20000"/>
+                <a:satMod val="255000"/>
+              </a:schemeClr>
+            </a:gs>
+          </a:gsLst>
+          <a:path path="circle">
+            <a:fillToRect l="50000" t="-80000" r="50000" b="180000"/>
+          </a:path>
+        </a:gradFill>
+        <a:gradFill rotWithShape="1">
+          <a:gsLst>
+            <a:gs pos="0">
+              <a:schemeClr val="phClr">
+                <a:tint val="80000"/>
+                <a:satMod val="300000"/>
+              </a:schemeClr>
+            </a:gs>
+            <a:gs pos="100000">
+              <a:schemeClr val="phClr">
+                <a:shade val="30000"/>
+                <a:satMod val="200000"/>
+              </a:schemeClr>
+            </a:gs>
+          </a:gsLst>
+          <a:path path="circle">
+            <a:fillToRect l="50000" t="50000" r="50000" b="50000"/>
+          </a:path>
+        </a:gradFill>
+      </a:bgFillStyleLst>
+    </a:fmtScheme>
+  </a:themeElements>
+</a:theme>
 </file>
</xml_diff>

<commit_message>
Update Data Sources from LFX 2026-10-07 (#334)
Update Data Sources from LFX

Signed-off-by: github-actions[bot] <41898282+github-actions[bot]@users.noreply.github.com>
Co-authored-by: jmertic <296737+jmertic@users.noreply.github.com>
</commit_message>
<xml_diff>
--- a/overview_deck/LF Energy High Level Overview.pptx
+++ b/overview_deck/LF Energy High Level Overview.pptx
@@ -25946,7 +25946,7 @@
             <a:tbl>
               <a:tblPr>
                 <a:noFill/>
-                <a:tableStyleId>{011720FC-AB45-42A0-9109-98BCBCCE134F}</a:tableStyleId>
+                <a:tableStyleId>{2F9B6A7E-5B52-426F-B42D-F4C25D8069FC}</a:tableStyleId>
               </a:tblPr>
               <a:tblGrid>
                 <a:gridCol w="1695200"/>
@@ -26736,7 +26736,7 @@
             <a:tbl>
               <a:tblPr>
                 <a:noFill/>
-                <a:tableStyleId>{011720FC-AB45-42A0-9109-98BCBCCE134F}</a:tableStyleId>
+                <a:tableStyleId>{2F9B6A7E-5B52-426F-B42D-F4C25D8069FC}</a:tableStyleId>
               </a:tblPr>
               <a:tblGrid>
                 <a:gridCol w="1695200"/>
@@ -27426,7 +27426,7 @@
             <a:tbl>
               <a:tblPr>
                 <a:noFill/>
-                <a:tableStyleId>{011720FC-AB45-42A0-9109-98BCBCCE134F}</a:tableStyleId>
+                <a:tableStyleId>{2F9B6A7E-5B52-426F-B42D-F4C25D8069FC}</a:tableStyleId>
               </a:tblPr>
               <a:tblGrid>
                 <a:gridCol w="1695200"/>
@@ -28678,7 +28678,7 @@
             <a:tbl>
               <a:tblPr>
                 <a:noFill/>
-                <a:tableStyleId>{011720FC-AB45-42A0-9109-98BCBCCE134F}</a:tableStyleId>
+                <a:tableStyleId>{2F9B6A7E-5B52-426F-B42D-F4C25D8069FC}</a:tableStyleId>
               </a:tblPr>
               <a:tblGrid>
                 <a:gridCol w="1695200"/>
@@ -29670,7 +29670,7 @@
             <a:tbl>
               <a:tblPr>
                 <a:noFill/>
-                <a:tableStyleId>{011720FC-AB45-42A0-9109-98BCBCCE134F}</a:tableStyleId>
+                <a:tableStyleId>{2F9B6A7E-5B52-426F-B42D-F4C25D8069FC}</a:tableStyleId>
               </a:tblPr>
               <a:tblGrid>
                 <a:gridCol w="3048000"/>
@@ -33175,7 +33175,7 @@
             <a:tbl>
               <a:tblPr>
                 <a:noFill/>
-                <a:tableStyleId>{011720FC-AB45-42A0-9109-98BCBCCE134F}</a:tableStyleId>
+                <a:tableStyleId>{2F9B6A7E-5B52-426F-B42D-F4C25D8069FC}</a:tableStyleId>
               </a:tblPr>
               <a:tblGrid>
                 <a:gridCol w="1828800"/>
@@ -34281,6 +34281,285 @@
 </file>
 
 <file path=ppt/theme/theme2.xml><?xml version="1.0" encoding="utf-8"?>
+<a:theme xmlns:a="http://schemas.openxmlformats.org/drawingml/2006/main" xmlns:r="http://schemas.openxmlformats.org/officeDocument/2006/relationships" name="LF Energy Theme 2023">
+  <a:themeElements>
+    <a:clrScheme name="Geometric">
+      <a:dk1>
+        <a:srgbClr val="222222"/>
+      </a:dk1>
+      <a:lt1>
+        <a:srgbClr val="FFFFFF"/>
+      </a:lt1>
+      <a:dk2>
+        <a:srgbClr val="434343"/>
+      </a:dk2>
+      <a:lt2>
+        <a:srgbClr val="999999"/>
+      </a:lt2>
+      <a:accent1>
+        <a:srgbClr val="003778"/>
+      </a:accent1>
+      <a:accent2>
+        <a:srgbClr val="0094FF"/>
+      </a:accent2>
+      <a:accent3>
+        <a:srgbClr val="5B1DE7"/>
+      </a:accent3>
+      <a:accent4>
+        <a:srgbClr val="12E2E2"/>
+      </a:accent4>
+      <a:accent5>
+        <a:srgbClr val="FF00AA"/>
+      </a:accent5>
+      <a:accent6>
+        <a:srgbClr val="ACDE1F"/>
+      </a:accent6>
+      <a:hlink>
+        <a:srgbClr val="0077CC"/>
+      </a:hlink>
+      <a:folHlink>
+        <a:srgbClr val="F06292"/>
+      </a:folHlink>
+    </a:clrScheme>
+    <a:fontScheme name="Office">
+      <a:majorFont>
+        <a:latin typeface="Arial"/>
+        <a:ea typeface=""/>
+        <a:cs typeface=""/>
+        <a:font script="Jpan" typeface="ＭＳ Ｐゴシック"/>
+        <a:font script="Hang" typeface="맑은 고딕"/>
+        <a:font script="Hans" typeface="宋体"/>
+        <a:font script="Hant" typeface="新細明體"/>
+        <a:font script="Arab" typeface="Times New Roman"/>
+        <a:font script="Hebr" typeface="Times New Roman"/>
+        <a:font script="Thai" typeface="Angsana New"/>
+        <a:font script="Ethi" typeface="Nyala"/>
+        <a:font script="Beng" typeface="Vrinda"/>
+        <a:font script="Gujr" typeface="Shruti"/>
+        <a:font script="Khmr" typeface="MoolBoran"/>
+        <a:font script="Knda" typeface="Tunga"/>
+        <a:font script="Guru" typeface="Raavi"/>
+        <a:font script="Cans" typeface="Euphemia"/>
+        <a:font script="Cher" typeface="Plantagenet Cherokee"/>
+        <a:font script="Yiii" typeface="Microsoft Yi Baiti"/>
+        <a:font script="Tibt" typeface="Microsoft Himalaya"/>
+        <a:font script="Thaa" typeface="MV Boli"/>
+        <a:font script="Deva" typeface="Mangal"/>
+        <a:font script="Telu" typeface="Gautami"/>
+        <a:font script="Taml" typeface="Latha"/>
+        <a:font script="Syrc" typeface="Estrangelo Edessa"/>
+        <a:font script="Orya" typeface="Kalinga"/>
+        <a:font script="Mlym" typeface="Kartika"/>
+        <a:font script="Laoo" typeface="DokChampa"/>
+        <a:font script="Sinh" typeface="Iskoola Pota"/>
+        <a:font script="Mong" typeface="Mongolian Baiti"/>
+        <a:font script="Viet" typeface="Times New Roman"/>
+        <a:font script="Uigh" typeface="Microsoft Uighur"/>
+        <a:font script="Geor" typeface="Sylfaen"/>
+      </a:majorFont>
+      <a:minorFont>
+        <a:latin typeface="Arial"/>
+        <a:ea typeface=""/>
+        <a:cs typeface=""/>
+        <a:font script="Jpan" typeface="ＭＳ Ｐゴシック"/>
+        <a:font script="Hang" typeface="맑은 고딕"/>
+        <a:font script="Hans" typeface="宋体"/>
+        <a:font script="Hant" typeface="新細明體"/>
+        <a:font script="Arab" typeface="Arial"/>
+        <a:font script="Hebr" typeface="Arial"/>
+        <a:font script="Thai" typeface="Cordia New"/>
+        <a:font script="Ethi" typeface="Nyala"/>
+        <a:font script="Beng" typeface="Vrinda"/>
+        <a:font script="Gujr" typeface="Shruti"/>
+        <a:font script="Khmr" typeface="DaunPenh"/>
+        <a:font script="Knda" typeface="Tunga"/>
+        <a:font script="Guru" typeface="Raavi"/>
+        <a:font script="Cans" typeface="Euphemia"/>
+        <a:font script="Cher" typeface="Plantagenet Cherokee"/>
+        <a:font script="Yiii" typeface="Microsoft Yi Baiti"/>
+        <a:font script="Tibt" typeface="Microsoft Himalaya"/>
+        <a:font script="Thaa" typeface="MV Boli"/>
+        <a:font script="Deva" typeface="Mangal"/>
+        <a:font script="Telu" typeface="Gautami"/>
+        <a:font script="Taml" typeface="Latha"/>
+        <a:font script="Syrc" typeface="Estrangelo Edessa"/>
+        <a:font script="Orya" typeface="Kalinga"/>
+        <a:font script="Mlym" typeface="Kartika"/>
+        <a:font script="Laoo" typeface="DokChampa"/>
+        <a:font script="Sinh" typeface="Iskoola Pota"/>
+        <a:font script="Mong" typeface="Mongolian Baiti"/>
+        <a:font script="Viet" typeface="Arial"/>
+        <a:font script="Uigh" typeface="Microsoft Uighur"/>
+        <a:font script="Geor" typeface="Sylfaen"/>
+      </a:minorFont>
+    </a:fontScheme>
+    <a:fmtScheme name="Office">
+      <a:fillStyleLst>
+        <a:solidFill>
+          <a:schemeClr val="phClr"/>
+        </a:solidFill>
+        <a:gradFill rotWithShape="1">
+          <a:gsLst>
+            <a:gs pos="0">
+              <a:schemeClr val="phClr">
+                <a:tint val="50000"/>
+                <a:satMod val="300000"/>
+              </a:schemeClr>
+            </a:gs>
+            <a:gs pos="35000">
+              <a:schemeClr val="phClr">
+                <a:tint val="37000"/>
+                <a:satMod val="300000"/>
+              </a:schemeClr>
+            </a:gs>
+            <a:gs pos="100000">
+              <a:schemeClr val="phClr">
+                <a:tint val="15000"/>
+                <a:satMod val="350000"/>
+              </a:schemeClr>
+            </a:gs>
+          </a:gsLst>
+          <a:lin ang="16200000" scaled="1"/>
+        </a:gradFill>
+        <a:gradFill rotWithShape="1">
+          <a:gsLst>
+            <a:gs pos="0">
+              <a:schemeClr val="phClr">
+                <a:tint val="100000"/>
+                <a:shade val="100000"/>
+                <a:satMod val="130000"/>
+              </a:schemeClr>
+            </a:gs>
+            <a:gs pos="100000">
+              <a:schemeClr val="phClr">
+                <a:tint val="50000"/>
+                <a:shade val="100000"/>
+                <a:satMod val="350000"/>
+              </a:schemeClr>
+            </a:gs>
+          </a:gsLst>
+          <a:lin ang="16200000" scaled="0"/>
+        </a:gradFill>
+      </a:fillStyleLst>
+      <a:lnStyleLst>
+        <a:ln w="9525" cap="flat" cmpd="sng" algn="ctr">
+          <a:solidFill>
+            <a:schemeClr val="phClr">
+              <a:shade val="95000"/>
+              <a:satMod val="105000"/>
+            </a:schemeClr>
+          </a:solidFill>
+          <a:prstDash val="solid"/>
+        </a:ln>
+        <a:ln w="25400" cap="flat" cmpd="sng" algn="ctr">
+          <a:solidFill>
+            <a:schemeClr val="phClr"/>
+          </a:solidFill>
+          <a:prstDash val="solid"/>
+        </a:ln>
+        <a:ln w="38100" cap="flat" cmpd="sng" algn="ctr">
+          <a:solidFill>
+            <a:schemeClr val="phClr"/>
+          </a:solidFill>
+          <a:prstDash val="solid"/>
+        </a:ln>
+      </a:lnStyleLst>
+      <a:effectStyleLst>
+        <a:effectStyle>
+          <a:effectLst>
+            <a:outerShdw blurRad="40000" dist="20000" dir="5400000" rotWithShape="0">
+              <a:srgbClr val="000000">
+                <a:alpha val="38000"/>
+              </a:srgbClr>
+            </a:outerShdw>
+          </a:effectLst>
+        </a:effectStyle>
+        <a:effectStyle>
+          <a:effectLst>
+            <a:outerShdw blurRad="40000" dist="23000" dir="5400000" rotWithShape="0">
+              <a:srgbClr val="000000">
+                <a:alpha val="35000"/>
+              </a:srgbClr>
+            </a:outerShdw>
+          </a:effectLst>
+        </a:effectStyle>
+        <a:effectStyle>
+          <a:effectLst>
+            <a:outerShdw blurRad="40000" dist="23000" dir="5400000" rotWithShape="0">
+              <a:srgbClr val="000000">
+                <a:alpha val="35000"/>
+              </a:srgbClr>
+            </a:outerShdw>
+          </a:effectLst>
+          <a:scene3d>
+            <a:camera prst="orthographicFront">
+              <a:rot lat="0" lon="0" rev="0"/>
+            </a:camera>
+            <a:lightRig rig="threePt" dir="t">
+              <a:rot lat="0" lon="0" rev="1200000"/>
+            </a:lightRig>
+          </a:scene3d>
+          <a:sp3d>
+            <a:bevelT w="63500" h="25400"/>
+          </a:sp3d>
+        </a:effectStyle>
+      </a:effectStyleLst>
+      <a:bgFillStyleLst>
+        <a:solidFill>
+          <a:schemeClr val="phClr"/>
+        </a:solidFill>
+        <a:gradFill rotWithShape="1">
+          <a:gsLst>
+            <a:gs pos="0">
+              <a:schemeClr val="phClr">
+                <a:tint val="40000"/>
+                <a:satMod val="350000"/>
+              </a:schemeClr>
+            </a:gs>
+            <a:gs pos="40000">
+              <a:schemeClr val="phClr">
+                <a:tint val="45000"/>
+                <a:shade val="99000"/>
+                <a:satMod val="350000"/>
+              </a:schemeClr>
+            </a:gs>
+            <a:gs pos="100000">
+              <a:schemeClr val="phClr">
+                <a:shade val="20000"/>
+                <a:satMod val="255000"/>
+              </a:schemeClr>
+            </a:gs>
+          </a:gsLst>
+          <a:path path="circle">
+            <a:fillToRect l="50000" t="-80000" r="50000" b="180000"/>
+          </a:path>
+        </a:gradFill>
+        <a:gradFill rotWithShape="1">
+          <a:gsLst>
+            <a:gs pos="0">
+              <a:schemeClr val="phClr">
+                <a:tint val="80000"/>
+                <a:satMod val="300000"/>
+              </a:schemeClr>
+            </a:gs>
+            <a:gs pos="100000">
+              <a:schemeClr val="phClr">
+                <a:shade val="30000"/>
+                <a:satMod val="200000"/>
+              </a:schemeClr>
+            </a:gs>
+          </a:gsLst>
+          <a:path path="circle">
+            <a:fillToRect l="50000" t="50000" r="50000" b="50000"/>
+          </a:path>
+        </a:gradFill>
+      </a:bgFillStyleLst>
+    </a:fmtScheme>
+  </a:themeElements>
+</a:theme>
+</file>
+
+<file path=ppt/theme/theme3.xml><?xml version="1.0" encoding="utf-8"?>
 <a:theme xmlns:a="http://schemas.openxmlformats.org/drawingml/2006/main" xmlns:r="http://schemas.openxmlformats.org/officeDocument/2006/relationships" name="Simple Light">
   <a:themeElements>
     <a:clrScheme name="Simple Light">
@@ -34557,283 +34836,4 @@
     </a:fmtScheme>
   </a:themeElements>
 </a:theme>
-</file>
-
-<file path=ppt/theme/theme3.xml><?xml version="1.0" encoding="utf-8"?>
-<a:theme xmlns:a="http://schemas.openxmlformats.org/drawingml/2006/main" xmlns:r="http://schemas.openxmlformats.org/officeDocument/2006/relationships" name="LF Energy Theme 2023">
-  <a:themeElements>
-    <a:clrScheme name="Geometric">
-      <a:dk1>
-        <a:srgbClr val="222222"/>
-      </a:dk1>
-      <a:lt1>
-        <a:srgbClr val="FFFFFF"/>
-      </a:lt1>
-      <a:dk2>
-        <a:srgbClr val="434343"/>
-      </a:dk2>
-      <a:lt2>
-        <a:srgbClr val="999999"/>
-      </a:lt2>
-      <a:accent1>
-        <a:srgbClr val="003778"/>
-      </a:accent1>
-      <a:accent2>
-        <a:srgbClr val="0094FF"/>
-      </a:accent2>
-      <a:accent3>
-        <a:srgbClr val="5B1DE7"/>
-      </a:accent3>
-      <a:accent4>
-        <a:srgbClr val="12E2E2"/>
-      </a:accent4>
-      <a:accent5>
-        <a:srgbClr val="FF00AA"/>
-      </a:accent5>
-      <a:accent6>
-        <a:srgbClr val="ACDE1F"/>
-      </a:accent6>
-      <a:hlink>
-        <a:srgbClr val="0077CC"/>
-      </a:hlink>
-      <a:folHlink>
-        <a:srgbClr val="F06292"/>
-      </a:folHlink>
-    </a:clrScheme>
-    <a:fontScheme name="Office">
-      <a:majorFont>
-        <a:latin typeface="Arial"/>
-        <a:ea typeface=""/>
-        <a:cs typeface=""/>
-        <a:font script="Jpan" typeface="ＭＳ Ｐゴシック"/>
-        <a:font script="Hang" typeface="맑은 고딕"/>
-        <a:font script="Hans" typeface="宋体"/>
-        <a:font script="Hant" typeface="新細明體"/>
-        <a:font script="Arab" typeface="Times New Roman"/>
-        <a:font script="Hebr" typeface="Times New Roman"/>
-        <a:font script="Thai" typeface="Angsana New"/>
-        <a:font script="Ethi" typeface="Nyala"/>
-        <a:font script="Beng" typeface="Vrinda"/>
-        <a:font script="Gujr" typeface="Shruti"/>
-        <a:font script="Khmr" typeface="MoolBoran"/>
-        <a:font script="Knda" typeface="Tunga"/>
-        <a:font script="Guru" typeface="Raavi"/>
-        <a:font script="Cans" typeface="Euphemia"/>
-        <a:font script="Cher" typeface="Plantagenet Cherokee"/>
-        <a:font script="Yiii" typeface="Microsoft Yi Baiti"/>
-        <a:font script="Tibt" typeface="Microsoft Himalaya"/>
-        <a:font script="Thaa" typeface="MV Boli"/>
-        <a:font script="Deva" typeface="Mangal"/>
-        <a:font script="Telu" typeface="Gautami"/>
-        <a:font script="Taml" typeface="Latha"/>
-        <a:font script="Syrc" typeface="Estrangelo Edessa"/>
-        <a:font script="Orya" typeface="Kalinga"/>
-        <a:font script="Mlym" typeface="Kartika"/>
-        <a:font script="Laoo" typeface="DokChampa"/>
-        <a:font script="Sinh" typeface="Iskoola Pota"/>
-        <a:font script="Mong" typeface="Mongolian Baiti"/>
-        <a:font script="Viet" typeface="Times New Roman"/>
-        <a:font script="Uigh" typeface="Microsoft Uighur"/>
-        <a:font script="Geor" typeface="Sylfaen"/>
-      </a:majorFont>
-      <a:minorFont>
-        <a:latin typeface="Arial"/>
-        <a:ea typeface=""/>
-        <a:cs typeface=""/>
-        <a:font script="Jpan" typeface="ＭＳ Ｐゴシック"/>
-        <a:font script="Hang" typeface="맑은 고딕"/>
-        <a:font script="Hans" typeface="宋体"/>
-        <a:font script="Hant" typeface="新細明體"/>
-        <a:font script="Arab" typeface="Arial"/>
-        <a:font script="Hebr" typeface="Arial"/>
-        <a:font script="Thai" typeface="Cordia New"/>
-        <a:font script="Ethi" typeface="Nyala"/>
-        <a:font script="Beng" typeface="Vrinda"/>
-        <a:font script="Gujr" typeface="Shruti"/>
-        <a:font script="Khmr" typeface="DaunPenh"/>
-        <a:font script="Knda" typeface="Tunga"/>
-        <a:font script="Guru" typeface="Raavi"/>
-        <a:font script="Cans" typeface="Euphemia"/>
-        <a:font script="Cher" typeface="Plantagenet Cherokee"/>
-        <a:font script="Yiii" typeface="Microsoft Yi Baiti"/>
-        <a:font script="Tibt" typeface="Microsoft Himalaya"/>
-        <a:font script="Thaa" typeface="MV Boli"/>
-        <a:font script="Deva" typeface="Mangal"/>
-        <a:font script="Telu" typeface="Gautami"/>
-        <a:font script="Taml" typeface="Latha"/>
-        <a:font script="Syrc" typeface="Estrangelo Edessa"/>
-        <a:font script="Orya" typeface="Kalinga"/>
-        <a:font script="Mlym" typeface="Kartika"/>
-        <a:font script="Laoo" typeface="DokChampa"/>
-        <a:font script="Sinh" typeface="Iskoola Pota"/>
-        <a:font script="Mong" typeface="Mongolian Baiti"/>
-        <a:font script="Viet" typeface="Arial"/>
-        <a:font script="Uigh" typeface="Microsoft Uighur"/>
-        <a:font script="Geor" typeface="Sylfaen"/>
-      </a:minorFont>
-    </a:fontScheme>
-    <a:fmtScheme name="Office">
-      <a:fillStyleLst>
-        <a:solidFill>
-          <a:schemeClr val="phClr"/>
-        </a:solidFill>
-        <a:gradFill rotWithShape="1">
-          <a:gsLst>
-            <a:gs pos="0">
-              <a:schemeClr val="phClr">
-                <a:tint val="50000"/>
-                <a:satMod val="300000"/>
-              </a:schemeClr>
-            </a:gs>
-            <a:gs pos="35000">
-              <a:schemeClr val="phClr">
-                <a:tint val="37000"/>
-                <a:satMod val="300000"/>
-              </a:schemeClr>
-            </a:gs>
-            <a:gs pos="100000">
-              <a:schemeClr val="phClr">
-                <a:tint val="15000"/>
-                <a:satMod val="350000"/>
-              </a:schemeClr>
-            </a:gs>
-          </a:gsLst>
-          <a:lin ang="16200000" scaled="1"/>
-        </a:gradFill>
-        <a:gradFill rotWithShape="1">
-          <a:gsLst>
-            <a:gs pos="0">
-              <a:schemeClr val="phClr">
-                <a:tint val="100000"/>
-                <a:shade val="100000"/>
-                <a:satMod val="130000"/>
-              </a:schemeClr>
-            </a:gs>
-            <a:gs pos="100000">
-              <a:schemeClr val="phClr">
-                <a:tint val="50000"/>
-                <a:shade val="100000"/>
-                <a:satMod val="350000"/>
-              </a:schemeClr>
-            </a:gs>
-          </a:gsLst>
-          <a:lin ang="16200000" scaled="0"/>
-        </a:gradFill>
-      </a:fillStyleLst>
-      <a:lnStyleLst>
-        <a:ln w="9525" cap="flat" cmpd="sng" algn="ctr">
-          <a:solidFill>
-            <a:schemeClr val="phClr">
-              <a:shade val="95000"/>
-              <a:satMod val="105000"/>
-            </a:schemeClr>
-          </a:solidFill>
-          <a:prstDash val="solid"/>
-        </a:ln>
-        <a:ln w="25400" cap="flat" cmpd="sng" algn="ctr">
-          <a:solidFill>
-            <a:schemeClr val="phClr"/>
-          </a:solidFill>
-          <a:prstDash val="solid"/>
-        </a:ln>
-        <a:ln w="38100" cap="flat" cmpd="sng" algn="ctr">
-          <a:solidFill>
-            <a:schemeClr val="phClr"/>
-          </a:solidFill>
-          <a:prstDash val="solid"/>
-        </a:ln>
-      </a:lnStyleLst>
-      <a:effectStyleLst>
-        <a:effectStyle>
-          <a:effectLst>
-            <a:outerShdw blurRad="40000" dist="20000" dir="5400000" rotWithShape="0">
-              <a:srgbClr val="000000">
-                <a:alpha val="38000"/>
-              </a:srgbClr>
-            </a:outerShdw>
-          </a:effectLst>
-        </a:effectStyle>
-        <a:effectStyle>
-          <a:effectLst>
-            <a:outerShdw blurRad="40000" dist="23000" dir="5400000" rotWithShape="0">
-              <a:srgbClr val="000000">
-                <a:alpha val="35000"/>
-              </a:srgbClr>
-            </a:outerShdw>
-          </a:effectLst>
-        </a:effectStyle>
-        <a:effectStyle>
-          <a:effectLst>
-            <a:outerShdw blurRad="40000" dist="23000" dir="5400000" rotWithShape="0">
-              <a:srgbClr val="000000">
-                <a:alpha val="35000"/>
-              </a:srgbClr>
-            </a:outerShdw>
-          </a:effectLst>
-          <a:scene3d>
-            <a:camera prst="orthographicFront">
-              <a:rot lat="0" lon="0" rev="0"/>
-            </a:camera>
-            <a:lightRig rig="threePt" dir="t">
-              <a:rot lat="0" lon="0" rev="1200000"/>
-            </a:lightRig>
-          </a:scene3d>
-          <a:sp3d>
-            <a:bevelT w="63500" h="25400"/>
-          </a:sp3d>
-        </a:effectStyle>
-      </a:effectStyleLst>
-      <a:bgFillStyleLst>
-        <a:solidFill>
-          <a:schemeClr val="phClr"/>
-        </a:solidFill>
-        <a:gradFill rotWithShape="1">
-          <a:gsLst>
-            <a:gs pos="0">
-              <a:schemeClr val="phClr">
-                <a:tint val="40000"/>
-                <a:satMod val="350000"/>
-              </a:schemeClr>
-            </a:gs>
-            <a:gs pos="40000">
-              <a:schemeClr val="phClr">
-                <a:tint val="45000"/>
-                <a:shade val="99000"/>
-                <a:satMod val="350000"/>
-              </a:schemeClr>
-            </a:gs>
-            <a:gs pos="100000">
-              <a:schemeClr val="phClr">
-                <a:shade val="20000"/>
-                <a:satMod val="255000"/>
-              </a:schemeClr>
-            </a:gs>
-          </a:gsLst>
-          <a:path path="circle">
-            <a:fillToRect l="50000" t="-80000" r="50000" b="180000"/>
-          </a:path>
-        </a:gradFill>
-        <a:gradFill rotWithShape="1">
-          <a:gsLst>
-            <a:gs pos="0">
-              <a:schemeClr val="phClr">
-                <a:tint val="80000"/>
-                <a:satMod val="300000"/>
-              </a:schemeClr>
-            </a:gs>
-            <a:gs pos="100000">
-              <a:schemeClr val="phClr">
-                <a:shade val="30000"/>
-                <a:satMod val="200000"/>
-              </a:schemeClr>
-            </a:gs>
-          </a:gsLst>
-          <a:path path="circle">
-            <a:fillToRect l="50000" t="50000" r="50000" b="50000"/>
-          </a:path>
-        </a:gradFill>
-      </a:bgFillStyleLst>
-    </a:fmtScheme>
-  </a:themeElements>
-</a:theme>
 </file>
</xml_diff>

<commit_message>
Update Data Sources from LFX 2026-10-08 (#335)
Update Data Sources from LFX

Signed-off-by: github-actions[bot] <41898282+github-actions[bot]@users.noreply.github.com>
Co-authored-by: jmertic <296737+jmertic@users.noreply.github.com>
</commit_message>
<xml_diff>
--- a/overview_deck/LF Energy High Level Overview.pptx
+++ b/overview_deck/LF Energy High Level Overview.pptx
@@ -25946,7 +25946,7 @@
             <a:tbl>
               <a:tblPr>
                 <a:noFill/>
-                <a:tableStyleId>{2F9B6A7E-5B52-426F-B42D-F4C25D8069FC}</a:tableStyleId>
+                <a:tableStyleId>{4F273D73-CA74-481C-B65D-EC0597166CD5}</a:tableStyleId>
               </a:tblPr>
               <a:tblGrid>
                 <a:gridCol w="1695200"/>
@@ -26736,7 +26736,7 @@
             <a:tbl>
               <a:tblPr>
                 <a:noFill/>
-                <a:tableStyleId>{2F9B6A7E-5B52-426F-B42D-F4C25D8069FC}</a:tableStyleId>
+                <a:tableStyleId>{4F273D73-CA74-481C-B65D-EC0597166CD5}</a:tableStyleId>
               </a:tblPr>
               <a:tblGrid>
                 <a:gridCol w="1695200"/>
@@ -27426,7 +27426,7 @@
             <a:tbl>
               <a:tblPr>
                 <a:noFill/>
-                <a:tableStyleId>{2F9B6A7E-5B52-426F-B42D-F4C25D8069FC}</a:tableStyleId>
+                <a:tableStyleId>{4F273D73-CA74-481C-B65D-EC0597166CD5}</a:tableStyleId>
               </a:tblPr>
               <a:tblGrid>
                 <a:gridCol w="1695200"/>
@@ -28678,7 +28678,7 @@
             <a:tbl>
               <a:tblPr>
                 <a:noFill/>
-                <a:tableStyleId>{2F9B6A7E-5B52-426F-B42D-F4C25D8069FC}</a:tableStyleId>
+                <a:tableStyleId>{4F273D73-CA74-481C-B65D-EC0597166CD5}</a:tableStyleId>
               </a:tblPr>
               <a:tblGrid>
                 <a:gridCol w="1695200"/>
@@ -29670,7 +29670,7 @@
             <a:tbl>
               <a:tblPr>
                 <a:noFill/>
-                <a:tableStyleId>{2F9B6A7E-5B52-426F-B42D-F4C25D8069FC}</a:tableStyleId>
+                <a:tableStyleId>{4F273D73-CA74-481C-B65D-EC0597166CD5}</a:tableStyleId>
               </a:tblPr>
               <a:tblGrid>
                 <a:gridCol w="3048000"/>
@@ -33175,7 +33175,7 @@
             <a:tbl>
               <a:tblPr>
                 <a:noFill/>
-                <a:tableStyleId>{2F9B6A7E-5B52-426F-B42D-F4C25D8069FC}</a:tableStyleId>
+                <a:tableStyleId>{4F273D73-CA74-481C-B65D-EC0597166CD5}</a:tableStyleId>
               </a:tblPr>
               <a:tblGrid>
                 <a:gridCol w="1828800"/>
@@ -34281,6 +34281,285 @@
 </file>
 
 <file path=ppt/theme/theme2.xml><?xml version="1.0" encoding="utf-8"?>
+<a:theme xmlns:a="http://schemas.openxmlformats.org/drawingml/2006/main" xmlns:r="http://schemas.openxmlformats.org/officeDocument/2006/relationships" name="Simple Light">
+  <a:themeElements>
+    <a:clrScheme name="Simple Light">
+      <a:dk1>
+        <a:srgbClr val="000000"/>
+      </a:dk1>
+      <a:lt1>
+        <a:srgbClr val="FFFFFF"/>
+      </a:lt1>
+      <a:dk2>
+        <a:srgbClr val="595959"/>
+      </a:dk2>
+      <a:lt2>
+        <a:srgbClr val="EEEEEE"/>
+      </a:lt2>
+      <a:accent1>
+        <a:srgbClr val="4285F4"/>
+      </a:accent1>
+      <a:accent2>
+        <a:srgbClr val="212121"/>
+      </a:accent2>
+      <a:accent3>
+        <a:srgbClr val="78909C"/>
+      </a:accent3>
+      <a:accent4>
+        <a:srgbClr val="FFAB40"/>
+      </a:accent4>
+      <a:accent5>
+        <a:srgbClr val="0097A7"/>
+      </a:accent5>
+      <a:accent6>
+        <a:srgbClr val="EEFF41"/>
+      </a:accent6>
+      <a:hlink>
+        <a:srgbClr val="0097A7"/>
+      </a:hlink>
+      <a:folHlink>
+        <a:srgbClr val="0097A7"/>
+      </a:folHlink>
+    </a:clrScheme>
+    <a:fontScheme name="Office">
+      <a:majorFont>
+        <a:latin typeface="Arial"/>
+        <a:ea typeface=""/>
+        <a:cs typeface=""/>
+        <a:font script="Jpan" typeface="ＭＳ Ｐゴシック"/>
+        <a:font script="Hang" typeface="맑은 고딕"/>
+        <a:font script="Hans" typeface="宋体"/>
+        <a:font script="Hant" typeface="新細明體"/>
+        <a:font script="Arab" typeface="Times New Roman"/>
+        <a:font script="Hebr" typeface="Times New Roman"/>
+        <a:font script="Thai" typeface="Angsana New"/>
+        <a:font script="Ethi" typeface="Nyala"/>
+        <a:font script="Beng" typeface="Vrinda"/>
+        <a:font script="Gujr" typeface="Shruti"/>
+        <a:font script="Khmr" typeface="MoolBoran"/>
+        <a:font script="Knda" typeface="Tunga"/>
+        <a:font script="Guru" typeface="Raavi"/>
+        <a:font script="Cans" typeface="Euphemia"/>
+        <a:font script="Cher" typeface="Plantagenet Cherokee"/>
+        <a:font script="Yiii" typeface="Microsoft Yi Baiti"/>
+        <a:font script="Tibt" typeface="Microsoft Himalaya"/>
+        <a:font script="Thaa" typeface="MV Boli"/>
+        <a:font script="Deva" typeface="Mangal"/>
+        <a:font script="Telu" typeface="Gautami"/>
+        <a:font script="Taml" typeface="Latha"/>
+        <a:font script="Syrc" typeface="Estrangelo Edessa"/>
+        <a:font script="Orya" typeface="Kalinga"/>
+        <a:font script="Mlym" typeface="Kartika"/>
+        <a:font script="Laoo" typeface="DokChampa"/>
+        <a:font script="Sinh" typeface="Iskoola Pota"/>
+        <a:font script="Mong" typeface="Mongolian Baiti"/>
+        <a:font script="Viet" typeface="Times New Roman"/>
+        <a:font script="Uigh" typeface="Microsoft Uighur"/>
+        <a:font script="Geor" typeface="Sylfaen"/>
+      </a:majorFont>
+      <a:minorFont>
+        <a:latin typeface="Arial"/>
+        <a:ea typeface=""/>
+        <a:cs typeface=""/>
+        <a:font script="Jpan" typeface="ＭＳ Ｐゴシック"/>
+        <a:font script="Hang" typeface="맑은 고딕"/>
+        <a:font script="Hans" typeface="宋体"/>
+        <a:font script="Hant" typeface="新細明體"/>
+        <a:font script="Arab" typeface="Arial"/>
+        <a:font script="Hebr" typeface="Arial"/>
+        <a:font script="Thai" typeface="Cordia New"/>
+        <a:font script="Ethi" typeface="Nyala"/>
+        <a:font script="Beng" typeface="Vrinda"/>
+        <a:font script="Gujr" typeface="Shruti"/>
+        <a:font script="Khmr" typeface="DaunPenh"/>
+        <a:font script="Knda" typeface="Tunga"/>
+        <a:font script="Guru" typeface="Raavi"/>
+        <a:font script="Cans" typeface="Euphemia"/>
+        <a:font script="Cher" typeface="Plantagenet Cherokee"/>
+        <a:font script="Yiii" typeface="Microsoft Yi Baiti"/>
+        <a:font script="Tibt" typeface="Microsoft Himalaya"/>
+        <a:font script="Thaa" typeface="MV Boli"/>
+        <a:font script="Deva" typeface="Mangal"/>
+        <a:font script="Telu" typeface="Gautami"/>
+        <a:font script="Taml" typeface="Latha"/>
+        <a:font script="Syrc" typeface="Estrangelo Edessa"/>
+        <a:font script="Orya" typeface="Kalinga"/>
+        <a:font script="Mlym" typeface="Kartika"/>
+        <a:font script="Laoo" typeface="DokChampa"/>
+        <a:font script="Sinh" typeface="Iskoola Pota"/>
+        <a:font script="Mong" typeface="Mongolian Baiti"/>
+        <a:font script="Viet" typeface="Arial"/>
+        <a:font script="Uigh" typeface="Microsoft Uighur"/>
+        <a:font script="Geor" typeface="Sylfaen"/>
+      </a:minorFont>
+    </a:fontScheme>
+    <a:fmtScheme name="Office">
+      <a:fillStyleLst>
+        <a:solidFill>
+          <a:schemeClr val="phClr"/>
+        </a:solidFill>
+        <a:gradFill rotWithShape="1">
+          <a:gsLst>
+            <a:gs pos="0">
+              <a:schemeClr val="phClr">
+                <a:tint val="50000"/>
+                <a:satMod val="300000"/>
+              </a:schemeClr>
+            </a:gs>
+            <a:gs pos="35000">
+              <a:schemeClr val="phClr">
+                <a:tint val="37000"/>
+                <a:satMod val="300000"/>
+              </a:schemeClr>
+            </a:gs>
+            <a:gs pos="100000">
+              <a:schemeClr val="phClr">
+                <a:tint val="15000"/>
+                <a:satMod val="350000"/>
+              </a:schemeClr>
+            </a:gs>
+          </a:gsLst>
+          <a:lin ang="16200000" scaled="1"/>
+        </a:gradFill>
+        <a:gradFill rotWithShape="1">
+          <a:gsLst>
+            <a:gs pos="0">
+              <a:schemeClr val="phClr">
+                <a:tint val="100000"/>
+                <a:shade val="100000"/>
+                <a:satMod val="130000"/>
+              </a:schemeClr>
+            </a:gs>
+            <a:gs pos="100000">
+              <a:schemeClr val="phClr">
+                <a:tint val="50000"/>
+                <a:shade val="100000"/>
+                <a:satMod val="350000"/>
+              </a:schemeClr>
+            </a:gs>
+          </a:gsLst>
+          <a:lin ang="16200000" scaled="0"/>
+        </a:gradFill>
+      </a:fillStyleLst>
+      <a:lnStyleLst>
+        <a:ln w="9525" cap="flat" cmpd="sng" algn="ctr">
+          <a:solidFill>
+            <a:schemeClr val="phClr">
+              <a:shade val="95000"/>
+              <a:satMod val="105000"/>
+            </a:schemeClr>
+          </a:solidFill>
+          <a:prstDash val="solid"/>
+        </a:ln>
+        <a:ln w="25400" cap="flat" cmpd="sng" algn="ctr">
+          <a:solidFill>
+            <a:schemeClr val="phClr"/>
+          </a:solidFill>
+          <a:prstDash val="solid"/>
+        </a:ln>
+        <a:ln w="38100" cap="flat" cmpd="sng" algn="ctr">
+          <a:solidFill>
+            <a:schemeClr val="phClr"/>
+          </a:solidFill>
+          <a:prstDash val="solid"/>
+        </a:ln>
+      </a:lnStyleLst>
+      <a:effectStyleLst>
+        <a:effectStyle>
+          <a:effectLst>
+            <a:outerShdw blurRad="40000" dist="20000" dir="5400000" rotWithShape="0">
+              <a:srgbClr val="000000">
+                <a:alpha val="38000"/>
+              </a:srgbClr>
+            </a:outerShdw>
+          </a:effectLst>
+        </a:effectStyle>
+        <a:effectStyle>
+          <a:effectLst>
+            <a:outerShdw blurRad="40000" dist="23000" dir="5400000" rotWithShape="0">
+              <a:srgbClr val="000000">
+                <a:alpha val="35000"/>
+              </a:srgbClr>
+            </a:outerShdw>
+          </a:effectLst>
+        </a:effectStyle>
+        <a:effectStyle>
+          <a:effectLst>
+            <a:outerShdw blurRad="40000" dist="23000" dir="5400000" rotWithShape="0">
+              <a:srgbClr val="000000">
+                <a:alpha val="35000"/>
+              </a:srgbClr>
+            </a:outerShdw>
+          </a:effectLst>
+          <a:scene3d>
+            <a:camera prst="orthographicFront">
+              <a:rot lat="0" lon="0" rev="0"/>
+            </a:camera>
+            <a:lightRig rig="threePt" dir="t">
+              <a:rot lat="0" lon="0" rev="1200000"/>
+            </a:lightRig>
+          </a:scene3d>
+          <a:sp3d>
+            <a:bevelT w="63500" h="25400"/>
+          </a:sp3d>
+        </a:effectStyle>
+      </a:effectStyleLst>
+      <a:bgFillStyleLst>
+        <a:solidFill>
+          <a:schemeClr val="phClr"/>
+        </a:solidFill>
+        <a:gradFill rotWithShape="1">
+          <a:gsLst>
+            <a:gs pos="0">
+              <a:schemeClr val="phClr">
+                <a:tint val="40000"/>
+                <a:satMod val="350000"/>
+              </a:schemeClr>
+            </a:gs>
+            <a:gs pos="40000">
+              <a:schemeClr val="phClr">
+                <a:tint val="45000"/>
+                <a:shade val="99000"/>
+                <a:satMod val="350000"/>
+              </a:schemeClr>
+            </a:gs>
+            <a:gs pos="100000">
+              <a:schemeClr val="phClr">
+                <a:shade val="20000"/>
+                <a:satMod val="255000"/>
+              </a:schemeClr>
+            </a:gs>
+          </a:gsLst>
+          <a:path path="circle">
+            <a:fillToRect l="50000" t="-80000" r="50000" b="180000"/>
+          </a:path>
+        </a:gradFill>
+        <a:gradFill rotWithShape="1">
+          <a:gsLst>
+            <a:gs pos="0">
+              <a:schemeClr val="phClr">
+                <a:tint val="80000"/>
+                <a:satMod val="300000"/>
+              </a:schemeClr>
+            </a:gs>
+            <a:gs pos="100000">
+              <a:schemeClr val="phClr">
+                <a:shade val="30000"/>
+                <a:satMod val="200000"/>
+              </a:schemeClr>
+            </a:gs>
+          </a:gsLst>
+          <a:path path="circle">
+            <a:fillToRect l="50000" t="50000" r="50000" b="50000"/>
+          </a:path>
+        </a:gradFill>
+      </a:bgFillStyleLst>
+    </a:fmtScheme>
+  </a:themeElements>
+</a:theme>
+</file>
+
+<file path=ppt/theme/theme3.xml><?xml version="1.0" encoding="utf-8"?>
 <a:theme xmlns:a="http://schemas.openxmlformats.org/drawingml/2006/main" xmlns:r="http://schemas.openxmlformats.org/officeDocument/2006/relationships" name="LF Energy Theme 2023">
   <a:themeElements>
     <a:clrScheme name="Geometric">
@@ -34557,283 +34836,4 @@
     </a:fmtScheme>
   </a:themeElements>
 </a:theme>
-</file>
-
-<file path=ppt/theme/theme3.xml><?xml version="1.0" encoding="utf-8"?>
-<a:theme xmlns:a="http://schemas.openxmlformats.org/drawingml/2006/main" xmlns:r="http://schemas.openxmlformats.org/officeDocument/2006/relationships" name="Simple Light">
-  <a:themeElements>
-    <a:clrScheme name="Simple Light">
-      <a:dk1>
-        <a:srgbClr val="000000"/>
-      </a:dk1>
-      <a:lt1>
-        <a:srgbClr val="FFFFFF"/>
-      </a:lt1>
-      <a:dk2>
-        <a:srgbClr val="595959"/>
-      </a:dk2>
-      <a:lt2>
-        <a:srgbClr val="EEEEEE"/>
-      </a:lt2>
-      <a:accent1>
-        <a:srgbClr val="4285F4"/>
-      </a:accent1>
-      <a:accent2>
-        <a:srgbClr val="212121"/>
-      </a:accent2>
-      <a:accent3>
-        <a:srgbClr val="78909C"/>
-      </a:accent3>
-      <a:accent4>
-        <a:srgbClr val="FFAB40"/>
-      </a:accent4>
-      <a:accent5>
-        <a:srgbClr val="0097A7"/>
-      </a:accent5>
-      <a:accent6>
-        <a:srgbClr val="EEFF41"/>
-      </a:accent6>
-      <a:hlink>
-        <a:srgbClr val="0097A7"/>
-      </a:hlink>
-      <a:folHlink>
-        <a:srgbClr val="0097A7"/>
-      </a:folHlink>
-    </a:clrScheme>
-    <a:fontScheme name="Office">
-      <a:majorFont>
-        <a:latin typeface="Arial"/>
-        <a:ea typeface=""/>
-        <a:cs typeface=""/>
-        <a:font script="Jpan" typeface="ＭＳ Ｐゴシック"/>
-        <a:font script="Hang" typeface="맑은 고딕"/>
-        <a:font script="Hans" typeface="宋体"/>
-        <a:font script="Hant" typeface="新細明體"/>
-        <a:font script="Arab" typeface="Times New Roman"/>
-        <a:font script="Hebr" typeface="Times New Roman"/>
-        <a:font script="Thai" typeface="Angsana New"/>
-        <a:font script="Ethi" typeface="Nyala"/>
-        <a:font script="Beng" typeface="Vrinda"/>
-        <a:font script="Gujr" typeface="Shruti"/>
-        <a:font script="Khmr" typeface="MoolBoran"/>
-        <a:font script="Knda" typeface="Tunga"/>
-        <a:font script="Guru" typeface="Raavi"/>
-        <a:font script="Cans" typeface="Euphemia"/>
-        <a:font script="Cher" typeface="Plantagenet Cherokee"/>
-        <a:font script="Yiii" typeface="Microsoft Yi Baiti"/>
-        <a:font script="Tibt" typeface="Microsoft Himalaya"/>
-        <a:font script="Thaa" typeface="MV Boli"/>
-        <a:font script="Deva" typeface="Mangal"/>
-        <a:font script="Telu" typeface="Gautami"/>
-        <a:font script="Taml" typeface="Latha"/>
-        <a:font script="Syrc" typeface="Estrangelo Edessa"/>
-        <a:font script="Orya" typeface="Kalinga"/>
-        <a:font script="Mlym" typeface="Kartika"/>
-        <a:font script="Laoo" typeface="DokChampa"/>
-        <a:font script="Sinh" typeface="Iskoola Pota"/>
-        <a:font script="Mong" typeface="Mongolian Baiti"/>
-        <a:font script="Viet" typeface="Times New Roman"/>
-        <a:font script="Uigh" typeface="Microsoft Uighur"/>
-        <a:font script="Geor" typeface="Sylfaen"/>
-      </a:majorFont>
-      <a:minorFont>
-        <a:latin typeface="Arial"/>
-        <a:ea typeface=""/>
-        <a:cs typeface=""/>
-        <a:font script="Jpan" typeface="ＭＳ Ｐゴシック"/>
-        <a:font script="Hang" typeface="맑은 고딕"/>
-        <a:font script="Hans" typeface="宋体"/>
-        <a:font script="Hant" typeface="新細明體"/>
-        <a:font script="Arab" typeface="Arial"/>
-        <a:font script="Hebr" typeface="Arial"/>
-        <a:font script="Thai" typeface="Cordia New"/>
-        <a:font script="Ethi" typeface="Nyala"/>
-        <a:font script="Beng" typeface="Vrinda"/>
-        <a:font script="Gujr" typeface="Shruti"/>
-        <a:font script="Khmr" typeface="DaunPenh"/>
-        <a:font script="Knda" typeface="Tunga"/>
-        <a:font script="Guru" typeface="Raavi"/>
-        <a:font script="Cans" typeface="Euphemia"/>
-        <a:font script="Cher" typeface="Plantagenet Cherokee"/>
-        <a:font script="Yiii" typeface="Microsoft Yi Baiti"/>
-        <a:font script="Tibt" typeface="Microsoft Himalaya"/>
-        <a:font script="Thaa" typeface="MV Boli"/>
-        <a:font script="Deva" typeface="Mangal"/>
-        <a:font script="Telu" typeface="Gautami"/>
-        <a:font script="Taml" typeface="Latha"/>
-        <a:font script="Syrc" typeface="Estrangelo Edessa"/>
-        <a:font script="Orya" typeface="Kalinga"/>
-        <a:font script="Mlym" typeface="Kartika"/>
-        <a:font script="Laoo" typeface="DokChampa"/>
-        <a:font script="Sinh" typeface="Iskoola Pota"/>
-        <a:font script="Mong" typeface="Mongolian Baiti"/>
-        <a:font script="Viet" typeface="Arial"/>
-        <a:font script="Uigh" typeface="Microsoft Uighur"/>
-        <a:font script="Geor" typeface="Sylfaen"/>
-      </a:minorFont>
-    </a:fontScheme>
-    <a:fmtScheme name="Office">
-      <a:fillStyleLst>
-        <a:solidFill>
-          <a:schemeClr val="phClr"/>
-        </a:solidFill>
-        <a:gradFill rotWithShape="1">
-          <a:gsLst>
-            <a:gs pos="0">
-              <a:schemeClr val="phClr">
-                <a:tint val="50000"/>
-                <a:satMod val="300000"/>
-              </a:schemeClr>
-            </a:gs>
-            <a:gs pos="35000">
-              <a:schemeClr val="phClr">
-                <a:tint val="37000"/>
-                <a:satMod val="300000"/>
-              </a:schemeClr>
-            </a:gs>
-            <a:gs pos="100000">
-              <a:schemeClr val="phClr">
-                <a:tint val="15000"/>
-                <a:satMod val="350000"/>
-              </a:schemeClr>
-            </a:gs>
-          </a:gsLst>
-          <a:lin ang="16200000" scaled="1"/>
-        </a:gradFill>
-        <a:gradFill rotWithShape="1">
-          <a:gsLst>
-            <a:gs pos="0">
-              <a:schemeClr val="phClr">
-                <a:tint val="100000"/>
-                <a:shade val="100000"/>
-                <a:satMod val="130000"/>
-              </a:schemeClr>
-            </a:gs>
-            <a:gs pos="100000">
-              <a:schemeClr val="phClr">
-                <a:tint val="50000"/>
-                <a:shade val="100000"/>
-                <a:satMod val="350000"/>
-              </a:schemeClr>
-            </a:gs>
-          </a:gsLst>
-          <a:lin ang="16200000" scaled="0"/>
-        </a:gradFill>
-      </a:fillStyleLst>
-      <a:lnStyleLst>
-        <a:ln w="9525" cap="flat" cmpd="sng" algn="ctr">
-          <a:solidFill>
-            <a:schemeClr val="phClr">
-              <a:shade val="95000"/>
-              <a:satMod val="105000"/>
-            </a:schemeClr>
-          </a:solidFill>
-          <a:prstDash val="solid"/>
-        </a:ln>
-        <a:ln w="25400" cap="flat" cmpd="sng" algn="ctr">
-          <a:solidFill>
-            <a:schemeClr val="phClr"/>
-          </a:solidFill>
-          <a:prstDash val="solid"/>
-        </a:ln>
-        <a:ln w="38100" cap="flat" cmpd="sng" algn="ctr">
-          <a:solidFill>
-            <a:schemeClr val="phClr"/>
-          </a:solidFill>
-          <a:prstDash val="solid"/>
-        </a:ln>
-      </a:lnStyleLst>
-      <a:effectStyleLst>
-        <a:effectStyle>
-          <a:effectLst>
-            <a:outerShdw blurRad="40000" dist="20000" dir="5400000" rotWithShape="0">
-              <a:srgbClr val="000000">
-                <a:alpha val="38000"/>
-              </a:srgbClr>
-            </a:outerShdw>
-          </a:effectLst>
-        </a:effectStyle>
-        <a:effectStyle>
-          <a:effectLst>
-            <a:outerShdw blurRad="40000" dist="23000" dir="5400000" rotWithShape="0">
-              <a:srgbClr val="000000">
-                <a:alpha val="35000"/>
-              </a:srgbClr>
-            </a:outerShdw>
-          </a:effectLst>
-        </a:effectStyle>
-        <a:effectStyle>
-          <a:effectLst>
-            <a:outerShdw blurRad="40000" dist="23000" dir="5400000" rotWithShape="0">
-              <a:srgbClr val="000000">
-                <a:alpha val="35000"/>
-              </a:srgbClr>
-            </a:outerShdw>
-          </a:effectLst>
-          <a:scene3d>
-            <a:camera prst="orthographicFront">
-              <a:rot lat="0" lon="0" rev="0"/>
-            </a:camera>
-            <a:lightRig rig="threePt" dir="t">
-              <a:rot lat="0" lon="0" rev="1200000"/>
-            </a:lightRig>
-          </a:scene3d>
-          <a:sp3d>
-            <a:bevelT w="63500" h="25400"/>
-          </a:sp3d>
-        </a:effectStyle>
-      </a:effectStyleLst>
-      <a:bgFillStyleLst>
-        <a:solidFill>
-          <a:schemeClr val="phClr"/>
-        </a:solidFill>
-        <a:gradFill rotWithShape="1">
-          <a:gsLst>
-            <a:gs pos="0">
-              <a:schemeClr val="phClr">
-                <a:tint val="40000"/>
-                <a:satMod val="350000"/>
-              </a:schemeClr>
-            </a:gs>
-            <a:gs pos="40000">
-              <a:schemeClr val="phClr">
-                <a:tint val="45000"/>
-                <a:shade val="99000"/>
-                <a:satMod val="350000"/>
-              </a:schemeClr>
-            </a:gs>
-            <a:gs pos="100000">
-              <a:schemeClr val="phClr">
-                <a:shade val="20000"/>
-                <a:satMod val="255000"/>
-              </a:schemeClr>
-            </a:gs>
-          </a:gsLst>
-          <a:path path="circle">
-            <a:fillToRect l="50000" t="-80000" r="50000" b="180000"/>
-          </a:path>
-        </a:gradFill>
-        <a:gradFill rotWithShape="1">
-          <a:gsLst>
-            <a:gs pos="0">
-              <a:schemeClr val="phClr">
-                <a:tint val="80000"/>
-                <a:satMod val="300000"/>
-              </a:schemeClr>
-            </a:gs>
-            <a:gs pos="100000">
-              <a:schemeClr val="phClr">
-                <a:shade val="30000"/>
-                <a:satMod val="200000"/>
-              </a:schemeClr>
-            </a:gs>
-          </a:gsLst>
-          <a:path path="circle">
-            <a:fillToRect l="50000" t="50000" r="50000" b="50000"/>
-          </a:path>
-        </a:gradFill>
-      </a:bgFillStyleLst>
-    </a:fmtScheme>
-  </a:themeElements>
-</a:theme>
 </file>
</xml_diff>

<commit_message>
Update Data Sources from LFX 2026-10-09 (#336)
Update Data Sources from LFX

Signed-off-by: github-actions[bot] <41898282+github-actions[bot]@users.noreply.github.com>
Co-authored-by: jmertic <296737+jmertic@users.noreply.github.com>
</commit_message>
<xml_diff>
--- a/overview_deck/LF Energy High Level Overview.pptx
+++ b/overview_deck/LF Energy High Level Overview.pptx
@@ -25946,7 +25946,7 @@
             <a:tbl>
               <a:tblPr>
                 <a:noFill/>
-                <a:tableStyleId>{4F273D73-CA74-481C-B65D-EC0597166CD5}</a:tableStyleId>
+                <a:tableStyleId>{C4A8FF48-090B-4E13-9691-8B75080533AB}</a:tableStyleId>
               </a:tblPr>
               <a:tblGrid>
                 <a:gridCol w="1695200"/>
@@ -26736,7 +26736,7 @@
             <a:tbl>
               <a:tblPr>
                 <a:noFill/>
-                <a:tableStyleId>{4F273D73-CA74-481C-B65D-EC0597166CD5}</a:tableStyleId>
+                <a:tableStyleId>{C4A8FF48-090B-4E13-9691-8B75080533AB}</a:tableStyleId>
               </a:tblPr>
               <a:tblGrid>
                 <a:gridCol w="1695200"/>
@@ -27426,7 +27426,7 @@
             <a:tbl>
               <a:tblPr>
                 <a:noFill/>
-                <a:tableStyleId>{4F273D73-CA74-481C-B65D-EC0597166CD5}</a:tableStyleId>
+                <a:tableStyleId>{C4A8FF48-090B-4E13-9691-8B75080533AB}</a:tableStyleId>
               </a:tblPr>
               <a:tblGrid>
                 <a:gridCol w="1695200"/>
@@ -28678,7 +28678,7 @@
             <a:tbl>
               <a:tblPr>
                 <a:noFill/>
-                <a:tableStyleId>{4F273D73-CA74-481C-B65D-EC0597166CD5}</a:tableStyleId>
+                <a:tableStyleId>{C4A8FF48-090B-4E13-9691-8B75080533AB}</a:tableStyleId>
               </a:tblPr>
               <a:tblGrid>
                 <a:gridCol w="1695200"/>
@@ -29670,7 +29670,7 @@
             <a:tbl>
               <a:tblPr>
                 <a:noFill/>
-                <a:tableStyleId>{4F273D73-CA74-481C-B65D-EC0597166CD5}</a:tableStyleId>
+                <a:tableStyleId>{C4A8FF48-090B-4E13-9691-8B75080533AB}</a:tableStyleId>
               </a:tblPr>
               <a:tblGrid>
                 <a:gridCol w="3048000"/>
@@ -33175,7 +33175,7 @@
             <a:tbl>
               <a:tblPr>
                 <a:noFill/>
-                <a:tableStyleId>{4F273D73-CA74-481C-B65D-EC0597166CD5}</a:tableStyleId>
+                <a:tableStyleId>{C4A8FF48-090B-4E13-9691-8B75080533AB}</a:tableStyleId>
               </a:tblPr>
               <a:tblGrid>
                 <a:gridCol w="1828800"/>
@@ -34281,6 +34281,285 @@
 </file>
 
 <file path=ppt/theme/theme2.xml><?xml version="1.0" encoding="utf-8"?>
+<a:theme xmlns:a="http://schemas.openxmlformats.org/drawingml/2006/main" xmlns:r="http://schemas.openxmlformats.org/officeDocument/2006/relationships" name="LF Energy Theme 2023">
+  <a:themeElements>
+    <a:clrScheme name="Geometric">
+      <a:dk1>
+        <a:srgbClr val="222222"/>
+      </a:dk1>
+      <a:lt1>
+        <a:srgbClr val="FFFFFF"/>
+      </a:lt1>
+      <a:dk2>
+        <a:srgbClr val="434343"/>
+      </a:dk2>
+      <a:lt2>
+        <a:srgbClr val="999999"/>
+      </a:lt2>
+      <a:accent1>
+        <a:srgbClr val="003778"/>
+      </a:accent1>
+      <a:accent2>
+        <a:srgbClr val="0094FF"/>
+      </a:accent2>
+      <a:accent3>
+        <a:srgbClr val="5B1DE7"/>
+      </a:accent3>
+      <a:accent4>
+        <a:srgbClr val="12E2E2"/>
+      </a:accent4>
+      <a:accent5>
+        <a:srgbClr val="FF00AA"/>
+      </a:accent5>
+      <a:accent6>
+        <a:srgbClr val="ACDE1F"/>
+      </a:accent6>
+      <a:hlink>
+        <a:srgbClr val="0077CC"/>
+      </a:hlink>
+      <a:folHlink>
+        <a:srgbClr val="F06292"/>
+      </a:folHlink>
+    </a:clrScheme>
+    <a:fontScheme name="Office">
+      <a:majorFont>
+        <a:latin typeface="Arial"/>
+        <a:ea typeface=""/>
+        <a:cs typeface=""/>
+        <a:font script="Jpan" typeface="ＭＳ Ｐゴシック"/>
+        <a:font script="Hang" typeface="맑은 고딕"/>
+        <a:font script="Hans" typeface="宋体"/>
+        <a:font script="Hant" typeface="新細明體"/>
+        <a:font script="Arab" typeface="Times New Roman"/>
+        <a:font script="Hebr" typeface="Times New Roman"/>
+        <a:font script="Thai" typeface="Angsana New"/>
+        <a:font script="Ethi" typeface="Nyala"/>
+        <a:font script="Beng" typeface="Vrinda"/>
+        <a:font script="Gujr" typeface="Shruti"/>
+        <a:font script="Khmr" typeface="MoolBoran"/>
+        <a:font script="Knda" typeface="Tunga"/>
+        <a:font script="Guru" typeface="Raavi"/>
+        <a:font script="Cans" typeface="Euphemia"/>
+        <a:font script="Cher" typeface="Plantagenet Cherokee"/>
+        <a:font script="Yiii" typeface="Microsoft Yi Baiti"/>
+        <a:font script="Tibt" typeface="Microsoft Himalaya"/>
+        <a:font script="Thaa" typeface="MV Boli"/>
+        <a:font script="Deva" typeface="Mangal"/>
+        <a:font script="Telu" typeface="Gautami"/>
+        <a:font script="Taml" typeface="Latha"/>
+        <a:font script="Syrc" typeface="Estrangelo Edessa"/>
+        <a:font script="Orya" typeface="Kalinga"/>
+        <a:font script="Mlym" typeface="Kartika"/>
+        <a:font script="Laoo" typeface="DokChampa"/>
+        <a:font script="Sinh" typeface="Iskoola Pota"/>
+        <a:font script="Mong" typeface="Mongolian Baiti"/>
+        <a:font script="Viet" typeface="Times New Roman"/>
+        <a:font script="Uigh" typeface="Microsoft Uighur"/>
+        <a:font script="Geor" typeface="Sylfaen"/>
+      </a:majorFont>
+      <a:minorFont>
+        <a:latin typeface="Arial"/>
+        <a:ea typeface=""/>
+        <a:cs typeface=""/>
+        <a:font script="Jpan" typeface="ＭＳ Ｐゴシック"/>
+        <a:font script="Hang" typeface="맑은 고딕"/>
+        <a:font script="Hans" typeface="宋体"/>
+        <a:font script="Hant" typeface="新細明體"/>
+        <a:font script="Arab" typeface="Arial"/>
+        <a:font script="Hebr" typeface="Arial"/>
+        <a:font script="Thai" typeface="Cordia New"/>
+        <a:font script="Ethi" typeface="Nyala"/>
+        <a:font script="Beng" typeface="Vrinda"/>
+        <a:font script="Gujr" typeface="Shruti"/>
+        <a:font script="Khmr" typeface="DaunPenh"/>
+        <a:font script="Knda" typeface="Tunga"/>
+        <a:font script="Guru" typeface="Raavi"/>
+        <a:font script="Cans" typeface="Euphemia"/>
+        <a:font script="Cher" typeface="Plantagenet Cherokee"/>
+        <a:font script="Yiii" typeface="Microsoft Yi Baiti"/>
+        <a:font script="Tibt" typeface="Microsoft Himalaya"/>
+        <a:font script="Thaa" typeface="MV Boli"/>
+        <a:font script="Deva" typeface="Mangal"/>
+        <a:font script="Telu" typeface="Gautami"/>
+        <a:font script="Taml" typeface="Latha"/>
+        <a:font script="Syrc" typeface="Estrangelo Edessa"/>
+        <a:font script="Orya" typeface="Kalinga"/>
+        <a:font script="Mlym" typeface="Kartika"/>
+        <a:font script="Laoo" typeface="DokChampa"/>
+        <a:font script="Sinh" typeface="Iskoola Pota"/>
+        <a:font script="Mong" typeface="Mongolian Baiti"/>
+        <a:font script="Viet" typeface="Arial"/>
+        <a:font script="Uigh" typeface="Microsoft Uighur"/>
+        <a:font script="Geor" typeface="Sylfaen"/>
+      </a:minorFont>
+    </a:fontScheme>
+    <a:fmtScheme name="Office">
+      <a:fillStyleLst>
+        <a:solidFill>
+          <a:schemeClr val="phClr"/>
+        </a:solidFill>
+        <a:gradFill rotWithShape="1">
+          <a:gsLst>
+            <a:gs pos="0">
+              <a:schemeClr val="phClr">
+                <a:tint val="50000"/>
+                <a:satMod val="300000"/>
+              </a:schemeClr>
+            </a:gs>
+            <a:gs pos="35000">
+              <a:schemeClr val="phClr">
+                <a:tint val="37000"/>
+                <a:satMod val="300000"/>
+              </a:schemeClr>
+            </a:gs>
+            <a:gs pos="100000">
+              <a:schemeClr val="phClr">
+                <a:tint val="15000"/>
+                <a:satMod val="350000"/>
+              </a:schemeClr>
+            </a:gs>
+          </a:gsLst>
+          <a:lin ang="16200000" scaled="1"/>
+        </a:gradFill>
+        <a:gradFill rotWithShape="1">
+          <a:gsLst>
+            <a:gs pos="0">
+              <a:schemeClr val="phClr">
+                <a:tint val="100000"/>
+                <a:shade val="100000"/>
+                <a:satMod val="130000"/>
+              </a:schemeClr>
+            </a:gs>
+            <a:gs pos="100000">
+              <a:schemeClr val="phClr">
+                <a:tint val="50000"/>
+                <a:shade val="100000"/>
+                <a:satMod val="350000"/>
+              </a:schemeClr>
+            </a:gs>
+          </a:gsLst>
+          <a:lin ang="16200000" scaled="0"/>
+        </a:gradFill>
+      </a:fillStyleLst>
+      <a:lnStyleLst>
+        <a:ln w="9525" cap="flat" cmpd="sng" algn="ctr">
+          <a:solidFill>
+            <a:schemeClr val="phClr">
+              <a:shade val="95000"/>
+              <a:satMod val="105000"/>
+            </a:schemeClr>
+          </a:solidFill>
+          <a:prstDash val="solid"/>
+        </a:ln>
+        <a:ln w="25400" cap="flat" cmpd="sng" algn="ctr">
+          <a:solidFill>
+            <a:schemeClr val="phClr"/>
+          </a:solidFill>
+          <a:prstDash val="solid"/>
+        </a:ln>
+        <a:ln w="38100" cap="flat" cmpd="sng" algn="ctr">
+          <a:solidFill>
+            <a:schemeClr val="phClr"/>
+          </a:solidFill>
+          <a:prstDash val="solid"/>
+        </a:ln>
+      </a:lnStyleLst>
+      <a:effectStyleLst>
+        <a:effectStyle>
+          <a:effectLst>
+            <a:outerShdw blurRad="40000" dist="20000" dir="5400000" rotWithShape="0">
+              <a:srgbClr val="000000">
+                <a:alpha val="38000"/>
+              </a:srgbClr>
+            </a:outerShdw>
+          </a:effectLst>
+        </a:effectStyle>
+        <a:effectStyle>
+          <a:effectLst>
+            <a:outerShdw blurRad="40000" dist="23000" dir="5400000" rotWithShape="0">
+              <a:srgbClr val="000000">
+                <a:alpha val="35000"/>
+              </a:srgbClr>
+            </a:outerShdw>
+          </a:effectLst>
+        </a:effectStyle>
+        <a:effectStyle>
+          <a:effectLst>
+            <a:outerShdw blurRad="40000" dist="23000" dir="5400000" rotWithShape="0">
+              <a:srgbClr val="000000">
+                <a:alpha val="35000"/>
+              </a:srgbClr>
+            </a:outerShdw>
+          </a:effectLst>
+          <a:scene3d>
+            <a:camera prst="orthographicFront">
+              <a:rot lat="0" lon="0" rev="0"/>
+            </a:camera>
+            <a:lightRig rig="threePt" dir="t">
+              <a:rot lat="0" lon="0" rev="1200000"/>
+            </a:lightRig>
+          </a:scene3d>
+          <a:sp3d>
+            <a:bevelT w="63500" h="25400"/>
+          </a:sp3d>
+        </a:effectStyle>
+      </a:effectStyleLst>
+      <a:bgFillStyleLst>
+        <a:solidFill>
+          <a:schemeClr val="phClr"/>
+        </a:solidFill>
+        <a:gradFill rotWithShape="1">
+          <a:gsLst>
+            <a:gs pos="0">
+              <a:schemeClr val="phClr">
+                <a:tint val="40000"/>
+                <a:satMod val="350000"/>
+              </a:schemeClr>
+            </a:gs>
+            <a:gs pos="40000">
+              <a:schemeClr val="phClr">
+                <a:tint val="45000"/>
+                <a:shade val="99000"/>
+                <a:satMod val="350000"/>
+              </a:schemeClr>
+            </a:gs>
+            <a:gs pos="100000">
+              <a:schemeClr val="phClr">
+                <a:shade val="20000"/>
+                <a:satMod val="255000"/>
+              </a:schemeClr>
+            </a:gs>
+          </a:gsLst>
+          <a:path path="circle">
+            <a:fillToRect l="50000" t="-80000" r="50000" b="180000"/>
+          </a:path>
+        </a:gradFill>
+        <a:gradFill rotWithShape="1">
+          <a:gsLst>
+            <a:gs pos="0">
+              <a:schemeClr val="phClr">
+                <a:tint val="80000"/>
+                <a:satMod val="300000"/>
+              </a:schemeClr>
+            </a:gs>
+            <a:gs pos="100000">
+              <a:schemeClr val="phClr">
+                <a:shade val="30000"/>
+                <a:satMod val="200000"/>
+              </a:schemeClr>
+            </a:gs>
+          </a:gsLst>
+          <a:path path="circle">
+            <a:fillToRect l="50000" t="50000" r="50000" b="50000"/>
+          </a:path>
+        </a:gradFill>
+      </a:bgFillStyleLst>
+    </a:fmtScheme>
+  </a:themeElements>
+</a:theme>
+</file>
+
+<file path=ppt/theme/theme3.xml><?xml version="1.0" encoding="utf-8"?>
 <a:theme xmlns:a="http://schemas.openxmlformats.org/drawingml/2006/main" xmlns:r="http://schemas.openxmlformats.org/officeDocument/2006/relationships" name="Simple Light">
   <a:themeElements>
     <a:clrScheme name="Simple Light">
@@ -34557,283 +34836,4 @@
     </a:fmtScheme>
   </a:themeElements>
 </a:theme>
-</file>
-
-<file path=ppt/theme/theme3.xml><?xml version="1.0" encoding="utf-8"?>
-<a:theme xmlns:a="http://schemas.openxmlformats.org/drawingml/2006/main" xmlns:r="http://schemas.openxmlformats.org/officeDocument/2006/relationships" name="LF Energy Theme 2023">
-  <a:themeElements>
-    <a:clrScheme name="Geometric">
-      <a:dk1>
-        <a:srgbClr val="222222"/>
-      </a:dk1>
-      <a:lt1>
-        <a:srgbClr val="FFFFFF"/>
-      </a:lt1>
-      <a:dk2>
-        <a:srgbClr val="434343"/>
-      </a:dk2>
-      <a:lt2>
-        <a:srgbClr val="999999"/>
-      </a:lt2>
-      <a:accent1>
-        <a:srgbClr val="003778"/>
-      </a:accent1>
-      <a:accent2>
-        <a:srgbClr val="0094FF"/>
-      </a:accent2>
-      <a:accent3>
-        <a:srgbClr val="5B1DE7"/>
-      </a:accent3>
-      <a:accent4>
-        <a:srgbClr val="12E2E2"/>
-      </a:accent4>
-      <a:accent5>
-        <a:srgbClr val="FF00AA"/>
-      </a:accent5>
-      <a:accent6>
-        <a:srgbClr val="ACDE1F"/>
-      </a:accent6>
-      <a:hlink>
-        <a:srgbClr val="0077CC"/>
-      </a:hlink>
-      <a:folHlink>
-        <a:srgbClr val="F06292"/>
-      </a:folHlink>
-    </a:clrScheme>
-    <a:fontScheme name="Office">
-      <a:majorFont>
-        <a:latin typeface="Arial"/>
-        <a:ea typeface=""/>
-        <a:cs typeface=""/>
-        <a:font script="Jpan" typeface="ＭＳ Ｐゴシック"/>
-        <a:font script="Hang" typeface="맑은 고딕"/>
-        <a:font script="Hans" typeface="宋体"/>
-        <a:font script="Hant" typeface="新細明體"/>
-        <a:font script="Arab" typeface="Times New Roman"/>
-        <a:font script="Hebr" typeface="Times New Roman"/>
-        <a:font script="Thai" typeface="Angsana New"/>
-        <a:font script="Ethi" typeface="Nyala"/>
-        <a:font script="Beng" typeface="Vrinda"/>
-        <a:font script="Gujr" typeface="Shruti"/>
-        <a:font script="Khmr" typeface="MoolBoran"/>
-        <a:font script="Knda" typeface="Tunga"/>
-        <a:font script="Guru" typeface="Raavi"/>
-        <a:font script="Cans" typeface="Euphemia"/>
-        <a:font script="Cher" typeface="Plantagenet Cherokee"/>
-        <a:font script="Yiii" typeface="Microsoft Yi Baiti"/>
-        <a:font script="Tibt" typeface="Microsoft Himalaya"/>
-        <a:font script="Thaa" typeface="MV Boli"/>
-        <a:font script="Deva" typeface="Mangal"/>
-        <a:font script="Telu" typeface="Gautami"/>
-        <a:font script="Taml" typeface="Latha"/>
-        <a:font script="Syrc" typeface="Estrangelo Edessa"/>
-        <a:font script="Orya" typeface="Kalinga"/>
-        <a:font script="Mlym" typeface="Kartika"/>
-        <a:font script="Laoo" typeface="DokChampa"/>
-        <a:font script="Sinh" typeface="Iskoola Pota"/>
-        <a:font script="Mong" typeface="Mongolian Baiti"/>
-        <a:font script="Viet" typeface="Times New Roman"/>
-        <a:font script="Uigh" typeface="Microsoft Uighur"/>
-        <a:font script="Geor" typeface="Sylfaen"/>
-      </a:majorFont>
-      <a:minorFont>
-        <a:latin typeface="Arial"/>
-        <a:ea typeface=""/>
-        <a:cs typeface=""/>
-        <a:font script="Jpan" typeface="ＭＳ Ｐゴシック"/>
-        <a:font script="Hang" typeface="맑은 고딕"/>
-        <a:font script="Hans" typeface="宋体"/>
-        <a:font script="Hant" typeface="新細明體"/>
-        <a:font script="Arab" typeface="Arial"/>
-        <a:font script="Hebr" typeface="Arial"/>
-        <a:font script="Thai" typeface="Cordia New"/>
-        <a:font script="Ethi" typeface="Nyala"/>
-        <a:font script="Beng" typeface="Vrinda"/>
-        <a:font script="Gujr" typeface="Shruti"/>
-        <a:font script="Khmr" typeface="DaunPenh"/>
-        <a:font script="Knda" typeface="Tunga"/>
-        <a:font script="Guru" typeface="Raavi"/>
-        <a:font script="Cans" typeface="Euphemia"/>
-        <a:font script="Cher" typeface="Plantagenet Cherokee"/>
-        <a:font script="Yiii" typeface="Microsoft Yi Baiti"/>
-        <a:font script="Tibt" typeface="Microsoft Himalaya"/>
-        <a:font script="Thaa" typeface="MV Boli"/>
-        <a:font script="Deva" typeface="Mangal"/>
-        <a:font script="Telu" typeface="Gautami"/>
-        <a:font script="Taml" typeface="Latha"/>
-        <a:font script="Syrc" typeface="Estrangelo Edessa"/>
-        <a:font script="Orya" typeface="Kalinga"/>
-        <a:font script="Mlym" typeface="Kartika"/>
-        <a:font script="Laoo" typeface="DokChampa"/>
-        <a:font script="Sinh" typeface="Iskoola Pota"/>
-        <a:font script="Mong" typeface="Mongolian Baiti"/>
-        <a:font script="Viet" typeface="Arial"/>
-        <a:font script="Uigh" typeface="Microsoft Uighur"/>
-        <a:font script="Geor" typeface="Sylfaen"/>
-      </a:minorFont>
-    </a:fontScheme>
-    <a:fmtScheme name="Office">
-      <a:fillStyleLst>
-        <a:solidFill>
-          <a:schemeClr val="phClr"/>
-        </a:solidFill>
-        <a:gradFill rotWithShape="1">
-          <a:gsLst>
-            <a:gs pos="0">
-              <a:schemeClr val="phClr">
-                <a:tint val="50000"/>
-                <a:satMod val="300000"/>
-              </a:schemeClr>
-            </a:gs>
-            <a:gs pos="35000">
-              <a:schemeClr val="phClr">
-                <a:tint val="37000"/>
-                <a:satMod val="300000"/>
-              </a:schemeClr>
-            </a:gs>
-            <a:gs pos="100000">
-              <a:schemeClr val="phClr">
-                <a:tint val="15000"/>
-                <a:satMod val="350000"/>
-              </a:schemeClr>
-            </a:gs>
-          </a:gsLst>
-          <a:lin ang="16200000" scaled="1"/>
-        </a:gradFill>
-        <a:gradFill rotWithShape="1">
-          <a:gsLst>
-            <a:gs pos="0">
-              <a:schemeClr val="phClr">
-                <a:tint val="100000"/>
-                <a:shade val="100000"/>
-                <a:satMod val="130000"/>
-              </a:schemeClr>
-            </a:gs>
-            <a:gs pos="100000">
-              <a:schemeClr val="phClr">
-                <a:tint val="50000"/>
-                <a:shade val="100000"/>
-                <a:satMod val="350000"/>
-              </a:schemeClr>
-            </a:gs>
-          </a:gsLst>
-          <a:lin ang="16200000" scaled="0"/>
-        </a:gradFill>
-      </a:fillStyleLst>
-      <a:lnStyleLst>
-        <a:ln w="9525" cap="flat" cmpd="sng" algn="ctr">
-          <a:solidFill>
-            <a:schemeClr val="phClr">
-              <a:shade val="95000"/>
-              <a:satMod val="105000"/>
-            </a:schemeClr>
-          </a:solidFill>
-          <a:prstDash val="solid"/>
-        </a:ln>
-        <a:ln w="25400" cap="flat" cmpd="sng" algn="ctr">
-          <a:solidFill>
-            <a:schemeClr val="phClr"/>
-          </a:solidFill>
-          <a:prstDash val="solid"/>
-        </a:ln>
-        <a:ln w="38100" cap="flat" cmpd="sng" algn="ctr">
-          <a:solidFill>
-            <a:schemeClr val="phClr"/>
-          </a:solidFill>
-          <a:prstDash val="solid"/>
-        </a:ln>
-      </a:lnStyleLst>
-      <a:effectStyleLst>
-        <a:effectStyle>
-          <a:effectLst>
-            <a:outerShdw blurRad="40000" dist="20000" dir="5400000" rotWithShape="0">
-              <a:srgbClr val="000000">
-                <a:alpha val="38000"/>
-              </a:srgbClr>
-            </a:outerShdw>
-          </a:effectLst>
-        </a:effectStyle>
-        <a:effectStyle>
-          <a:effectLst>
-            <a:outerShdw blurRad="40000" dist="23000" dir="5400000" rotWithShape="0">
-              <a:srgbClr val="000000">
-                <a:alpha val="35000"/>
-              </a:srgbClr>
-            </a:outerShdw>
-          </a:effectLst>
-        </a:effectStyle>
-        <a:effectStyle>
-          <a:effectLst>
-            <a:outerShdw blurRad="40000" dist="23000" dir="5400000" rotWithShape="0">
-              <a:srgbClr val="000000">
-                <a:alpha val="35000"/>
-              </a:srgbClr>
-            </a:outerShdw>
-          </a:effectLst>
-          <a:scene3d>
-            <a:camera prst="orthographicFront">
-              <a:rot lat="0" lon="0" rev="0"/>
-            </a:camera>
-            <a:lightRig rig="threePt" dir="t">
-              <a:rot lat="0" lon="0" rev="1200000"/>
-            </a:lightRig>
-          </a:scene3d>
-          <a:sp3d>
-            <a:bevelT w="63500" h="25400"/>
-          </a:sp3d>
-        </a:effectStyle>
-      </a:effectStyleLst>
-      <a:bgFillStyleLst>
-        <a:solidFill>
-          <a:schemeClr val="phClr"/>
-        </a:solidFill>
-        <a:gradFill rotWithShape="1">
-          <a:gsLst>
-            <a:gs pos="0">
-              <a:schemeClr val="phClr">
-                <a:tint val="40000"/>
-                <a:satMod val="350000"/>
-              </a:schemeClr>
-            </a:gs>
-            <a:gs pos="40000">
-              <a:schemeClr val="phClr">
-                <a:tint val="45000"/>
-                <a:shade val="99000"/>
-                <a:satMod val="350000"/>
-              </a:schemeClr>
-            </a:gs>
-            <a:gs pos="100000">
-              <a:schemeClr val="phClr">
-                <a:shade val="20000"/>
-                <a:satMod val="255000"/>
-              </a:schemeClr>
-            </a:gs>
-          </a:gsLst>
-          <a:path path="circle">
-            <a:fillToRect l="50000" t="-80000" r="50000" b="180000"/>
-          </a:path>
-        </a:gradFill>
-        <a:gradFill rotWithShape="1">
-          <a:gsLst>
-            <a:gs pos="0">
-              <a:schemeClr val="phClr">
-                <a:tint val="80000"/>
-                <a:satMod val="300000"/>
-              </a:schemeClr>
-            </a:gs>
-            <a:gs pos="100000">
-              <a:schemeClr val="phClr">
-                <a:shade val="30000"/>
-                <a:satMod val="200000"/>
-              </a:schemeClr>
-            </a:gs>
-          </a:gsLst>
-          <a:path path="circle">
-            <a:fillToRect l="50000" t="50000" r="50000" b="50000"/>
-          </a:path>
-        </a:gradFill>
-      </a:bgFillStyleLst>
-    </a:fmtScheme>
-  </a:themeElements>
-</a:theme>
 </file>
</xml_diff>

<commit_message>
Update Data Sources from LFX 2026-10-10 (#337)
Update Data Sources from LFX

Signed-off-by: github-actions[bot] <41898282+github-actions[bot]@users.noreply.github.com>
Co-authored-by: jmertic <296737+jmertic@users.noreply.github.com>
</commit_message>
<xml_diff>
--- a/overview_deck/LF Energy High Level Overview.pptx
+++ b/overview_deck/LF Energy High Level Overview.pptx
@@ -25946,7 +25946,7 @@
             <a:tbl>
               <a:tblPr>
                 <a:noFill/>
-                <a:tableStyleId>{C4A8FF48-090B-4E13-9691-8B75080533AB}</a:tableStyleId>
+                <a:tableStyleId>{44648D14-18A2-4DC2-9F42-4DE9688B70E6}</a:tableStyleId>
               </a:tblPr>
               <a:tblGrid>
                 <a:gridCol w="1695200"/>
@@ -26736,7 +26736,7 @@
             <a:tbl>
               <a:tblPr>
                 <a:noFill/>
-                <a:tableStyleId>{C4A8FF48-090B-4E13-9691-8B75080533AB}</a:tableStyleId>
+                <a:tableStyleId>{44648D14-18A2-4DC2-9F42-4DE9688B70E6}</a:tableStyleId>
               </a:tblPr>
               <a:tblGrid>
                 <a:gridCol w="1695200"/>
@@ -27426,7 +27426,7 @@
             <a:tbl>
               <a:tblPr>
                 <a:noFill/>
-                <a:tableStyleId>{C4A8FF48-090B-4E13-9691-8B75080533AB}</a:tableStyleId>
+                <a:tableStyleId>{44648D14-18A2-4DC2-9F42-4DE9688B70E6}</a:tableStyleId>
               </a:tblPr>
               <a:tblGrid>
                 <a:gridCol w="1695200"/>
@@ -28678,7 +28678,7 @@
             <a:tbl>
               <a:tblPr>
                 <a:noFill/>
-                <a:tableStyleId>{C4A8FF48-090B-4E13-9691-8B75080533AB}</a:tableStyleId>
+                <a:tableStyleId>{44648D14-18A2-4DC2-9F42-4DE9688B70E6}</a:tableStyleId>
               </a:tblPr>
               <a:tblGrid>
                 <a:gridCol w="1695200"/>
@@ -29670,7 +29670,7 @@
             <a:tbl>
               <a:tblPr>
                 <a:noFill/>
-                <a:tableStyleId>{C4A8FF48-090B-4E13-9691-8B75080533AB}</a:tableStyleId>
+                <a:tableStyleId>{44648D14-18A2-4DC2-9F42-4DE9688B70E6}</a:tableStyleId>
               </a:tblPr>
               <a:tblGrid>
                 <a:gridCol w="3048000"/>
@@ -33175,7 +33175,7 @@
             <a:tbl>
               <a:tblPr>
                 <a:noFill/>
-                <a:tableStyleId>{C4A8FF48-090B-4E13-9691-8B75080533AB}</a:tableStyleId>
+                <a:tableStyleId>{44648D14-18A2-4DC2-9F42-4DE9688B70E6}</a:tableStyleId>
               </a:tblPr>
               <a:tblGrid>
                 <a:gridCol w="1828800"/>
@@ -34002,6 +34002,285 @@
 </file>
 
 <file path=ppt/theme/theme1.xml><?xml version="1.0" encoding="utf-8"?>
+<a:theme xmlns:a="http://schemas.openxmlformats.org/drawingml/2006/main" xmlns:r="http://schemas.openxmlformats.org/officeDocument/2006/relationships" name="Simple Light">
+  <a:themeElements>
+    <a:clrScheme name="Simple Light">
+      <a:dk1>
+        <a:srgbClr val="000000"/>
+      </a:dk1>
+      <a:lt1>
+        <a:srgbClr val="FFFFFF"/>
+      </a:lt1>
+      <a:dk2>
+        <a:srgbClr val="595959"/>
+      </a:dk2>
+      <a:lt2>
+        <a:srgbClr val="EEEEEE"/>
+      </a:lt2>
+      <a:accent1>
+        <a:srgbClr val="4285F4"/>
+      </a:accent1>
+      <a:accent2>
+        <a:srgbClr val="212121"/>
+      </a:accent2>
+      <a:accent3>
+        <a:srgbClr val="78909C"/>
+      </a:accent3>
+      <a:accent4>
+        <a:srgbClr val="FFAB40"/>
+      </a:accent4>
+      <a:accent5>
+        <a:srgbClr val="0097A7"/>
+      </a:accent5>
+      <a:accent6>
+        <a:srgbClr val="EEFF41"/>
+      </a:accent6>
+      <a:hlink>
+        <a:srgbClr val="0097A7"/>
+      </a:hlink>
+      <a:folHlink>
+        <a:srgbClr val="0097A7"/>
+      </a:folHlink>
+    </a:clrScheme>
+    <a:fontScheme name="Office">
+      <a:majorFont>
+        <a:latin typeface="Arial"/>
+        <a:ea typeface=""/>
+        <a:cs typeface=""/>
+        <a:font script="Jpan" typeface="ＭＳ Ｐゴシック"/>
+        <a:font script="Hang" typeface="맑은 고딕"/>
+        <a:font script="Hans" typeface="宋体"/>
+        <a:font script="Hant" typeface="新細明體"/>
+        <a:font script="Arab" typeface="Times New Roman"/>
+        <a:font script="Hebr" typeface="Times New Roman"/>
+        <a:font script="Thai" typeface="Angsana New"/>
+        <a:font script="Ethi" typeface="Nyala"/>
+        <a:font script="Beng" typeface="Vrinda"/>
+        <a:font script="Gujr" typeface="Shruti"/>
+        <a:font script="Khmr" typeface="MoolBoran"/>
+        <a:font script="Knda" typeface="Tunga"/>
+        <a:font script="Guru" typeface="Raavi"/>
+        <a:font script="Cans" typeface="Euphemia"/>
+        <a:font script="Cher" typeface="Plantagenet Cherokee"/>
+        <a:font script="Yiii" typeface="Microsoft Yi Baiti"/>
+        <a:font script="Tibt" typeface="Microsoft Himalaya"/>
+        <a:font script="Thaa" typeface="MV Boli"/>
+        <a:font script="Deva" typeface="Mangal"/>
+        <a:font script="Telu" typeface="Gautami"/>
+        <a:font script="Taml" typeface="Latha"/>
+        <a:font script="Syrc" typeface="Estrangelo Edessa"/>
+        <a:font script="Orya" typeface="Kalinga"/>
+        <a:font script="Mlym" typeface="Kartika"/>
+        <a:font script="Laoo" typeface="DokChampa"/>
+        <a:font script="Sinh" typeface="Iskoola Pota"/>
+        <a:font script="Mong" typeface="Mongolian Baiti"/>
+        <a:font script="Viet" typeface="Times New Roman"/>
+        <a:font script="Uigh" typeface="Microsoft Uighur"/>
+        <a:font script="Geor" typeface="Sylfaen"/>
+      </a:majorFont>
+      <a:minorFont>
+        <a:latin typeface="Arial"/>
+        <a:ea typeface=""/>
+        <a:cs typeface=""/>
+        <a:font script="Jpan" typeface="ＭＳ Ｐゴシック"/>
+        <a:font script="Hang" typeface="맑은 고딕"/>
+        <a:font script="Hans" typeface="宋体"/>
+        <a:font script="Hant" typeface="新細明體"/>
+        <a:font script="Arab" typeface="Arial"/>
+        <a:font script="Hebr" typeface="Arial"/>
+        <a:font script="Thai" typeface="Cordia New"/>
+        <a:font script="Ethi" typeface="Nyala"/>
+        <a:font script="Beng" typeface="Vrinda"/>
+        <a:font script="Gujr" typeface="Shruti"/>
+        <a:font script="Khmr" typeface="DaunPenh"/>
+        <a:font script="Knda" typeface="Tunga"/>
+        <a:font script="Guru" typeface="Raavi"/>
+        <a:font script="Cans" typeface="Euphemia"/>
+        <a:font script="Cher" typeface="Plantagenet Cherokee"/>
+        <a:font script="Yiii" typeface="Microsoft Yi Baiti"/>
+        <a:font script="Tibt" typeface="Microsoft Himalaya"/>
+        <a:font script="Thaa" typeface="MV Boli"/>
+        <a:font script="Deva" typeface="Mangal"/>
+        <a:font script="Telu" typeface="Gautami"/>
+        <a:font script="Taml" typeface="Latha"/>
+        <a:font script="Syrc" typeface="Estrangelo Edessa"/>
+        <a:font script="Orya" typeface="Kalinga"/>
+        <a:font script="Mlym" typeface="Kartika"/>
+        <a:font script="Laoo" typeface="DokChampa"/>
+        <a:font script="Sinh" typeface="Iskoola Pota"/>
+        <a:font script="Mong" typeface="Mongolian Baiti"/>
+        <a:font script="Viet" typeface="Arial"/>
+        <a:font script="Uigh" typeface="Microsoft Uighur"/>
+        <a:font script="Geor" typeface="Sylfaen"/>
+      </a:minorFont>
+    </a:fontScheme>
+    <a:fmtScheme name="Office">
+      <a:fillStyleLst>
+        <a:solidFill>
+          <a:schemeClr val="phClr"/>
+        </a:solidFill>
+        <a:gradFill rotWithShape="1">
+          <a:gsLst>
+            <a:gs pos="0">
+              <a:schemeClr val="phClr">
+                <a:tint val="50000"/>
+                <a:satMod val="300000"/>
+              </a:schemeClr>
+            </a:gs>
+            <a:gs pos="35000">
+              <a:schemeClr val="phClr">
+                <a:tint val="37000"/>
+                <a:satMod val="300000"/>
+              </a:schemeClr>
+            </a:gs>
+            <a:gs pos="100000">
+              <a:schemeClr val="phClr">
+                <a:tint val="15000"/>
+                <a:satMod val="350000"/>
+              </a:schemeClr>
+            </a:gs>
+          </a:gsLst>
+          <a:lin ang="16200000" scaled="1"/>
+        </a:gradFill>
+        <a:gradFill rotWithShape="1">
+          <a:gsLst>
+            <a:gs pos="0">
+              <a:schemeClr val="phClr">
+                <a:tint val="100000"/>
+                <a:shade val="100000"/>
+                <a:satMod val="130000"/>
+              </a:schemeClr>
+            </a:gs>
+            <a:gs pos="100000">
+              <a:schemeClr val="phClr">
+                <a:tint val="50000"/>
+                <a:shade val="100000"/>
+                <a:satMod val="350000"/>
+              </a:schemeClr>
+            </a:gs>
+          </a:gsLst>
+          <a:lin ang="16200000" scaled="0"/>
+        </a:gradFill>
+      </a:fillStyleLst>
+      <a:lnStyleLst>
+        <a:ln w="9525" cap="flat" cmpd="sng" algn="ctr">
+          <a:solidFill>
+            <a:schemeClr val="phClr">
+              <a:shade val="95000"/>
+              <a:satMod val="105000"/>
+            </a:schemeClr>
+          </a:solidFill>
+          <a:prstDash val="solid"/>
+        </a:ln>
+        <a:ln w="25400" cap="flat" cmpd="sng" algn="ctr">
+          <a:solidFill>
+            <a:schemeClr val="phClr"/>
+          </a:solidFill>
+          <a:prstDash val="solid"/>
+        </a:ln>
+        <a:ln w="38100" cap="flat" cmpd="sng" algn="ctr">
+          <a:solidFill>
+            <a:schemeClr val="phClr"/>
+          </a:solidFill>
+          <a:prstDash val="solid"/>
+        </a:ln>
+      </a:lnStyleLst>
+      <a:effectStyleLst>
+        <a:effectStyle>
+          <a:effectLst>
+            <a:outerShdw blurRad="40000" dist="20000" dir="5400000" rotWithShape="0">
+              <a:srgbClr val="000000">
+                <a:alpha val="38000"/>
+              </a:srgbClr>
+            </a:outerShdw>
+          </a:effectLst>
+        </a:effectStyle>
+        <a:effectStyle>
+          <a:effectLst>
+            <a:outerShdw blurRad="40000" dist="23000" dir="5400000" rotWithShape="0">
+              <a:srgbClr val="000000">
+                <a:alpha val="35000"/>
+              </a:srgbClr>
+            </a:outerShdw>
+          </a:effectLst>
+        </a:effectStyle>
+        <a:effectStyle>
+          <a:effectLst>
+            <a:outerShdw blurRad="40000" dist="23000" dir="5400000" rotWithShape="0">
+              <a:srgbClr val="000000">
+                <a:alpha val="35000"/>
+              </a:srgbClr>
+            </a:outerShdw>
+          </a:effectLst>
+          <a:scene3d>
+            <a:camera prst="orthographicFront">
+              <a:rot lat="0" lon="0" rev="0"/>
+            </a:camera>
+            <a:lightRig rig="threePt" dir="t">
+              <a:rot lat="0" lon="0" rev="1200000"/>
+            </a:lightRig>
+          </a:scene3d>
+          <a:sp3d>
+            <a:bevelT w="63500" h="25400"/>
+          </a:sp3d>
+        </a:effectStyle>
+      </a:effectStyleLst>
+      <a:bgFillStyleLst>
+        <a:solidFill>
+          <a:schemeClr val="phClr"/>
+        </a:solidFill>
+        <a:gradFill rotWithShape="1">
+          <a:gsLst>
+            <a:gs pos="0">
+              <a:schemeClr val="phClr">
+                <a:tint val="40000"/>
+                <a:satMod val="350000"/>
+              </a:schemeClr>
+            </a:gs>
+            <a:gs pos="40000">
+              <a:schemeClr val="phClr">
+                <a:tint val="45000"/>
+                <a:shade val="99000"/>
+                <a:satMod val="350000"/>
+              </a:schemeClr>
+            </a:gs>
+            <a:gs pos="100000">
+              <a:schemeClr val="phClr">
+                <a:shade val="20000"/>
+                <a:satMod val="255000"/>
+              </a:schemeClr>
+            </a:gs>
+          </a:gsLst>
+          <a:path path="circle">
+            <a:fillToRect l="50000" t="-80000" r="50000" b="180000"/>
+          </a:path>
+        </a:gradFill>
+        <a:gradFill rotWithShape="1">
+          <a:gsLst>
+            <a:gs pos="0">
+              <a:schemeClr val="phClr">
+                <a:tint val="80000"/>
+                <a:satMod val="300000"/>
+              </a:schemeClr>
+            </a:gs>
+            <a:gs pos="100000">
+              <a:schemeClr val="phClr">
+                <a:shade val="30000"/>
+                <a:satMod val="200000"/>
+              </a:schemeClr>
+            </a:gs>
+          </a:gsLst>
+          <a:path path="circle">
+            <a:fillToRect l="50000" t="50000" r="50000" b="50000"/>
+          </a:path>
+        </a:gradFill>
+      </a:bgFillStyleLst>
+    </a:fmtScheme>
+  </a:themeElements>
+</a:theme>
+</file>
+
+<file path=ppt/theme/theme2.xml><?xml version="1.0" encoding="utf-8"?>
 <a:theme xmlns:a="http://schemas.openxmlformats.org/drawingml/2006/main" xmlns:r="http://schemas.openxmlformats.org/officeDocument/2006/relationships">
   <a:themeElements>
     <a:clrScheme name="Default">
@@ -34280,7 +34559,7 @@
 </a:theme>
 </file>
 
-<file path=ppt/theme/theme2.xml><?xml version="1.0" encoding="utf-8"?>
+<file path=ppt/theme/theme3.xml><?xml version="1.0" encoding="utf-8"?>
 <a:theme xmlns:a="http://schemas.openxmlformats.org/drawingml/2006/main" xmlns:r="http://schemas.openxmlformats.org/officeDocument/2006/relationships" name="LF Energy Theme 2023">
   <a:themeElements>
     <a:clrScheme name="Geometric">
@@ -34557,283 +34836,4 @@
     </a:fmtScheme>
   </a:themeElements>
 </a:theme>
-</file>
-
-<file path=ppt/theme/theme3.xml><?xml version="1.0" encoding="utf-8"?>
-<a:theme xmlns:a="http://schemas.openxmlformats.org/drawingml/2006/main" xmlns:r="http://schemas.openxmlformats.org/officeDocument/2006/relationships" name="Simple Light">
-  <a:themeElements>
-    <a:clrScheme name="Simple Light">
-      <a:dk1>
-        <a:srgbClr val="000000"/>
-      </a:dk1>
-      <a:lt1>
-        <a:srgbClr val="FFFFFF"/>
-      </a:lt1>
-      <a:dk2>
-        <a:srgbClr val="595959"/>
-      </a:dk2>
-      <a:lt2>
-        <a:srgbClr val="EEEEEE"/>
-      </a:lt2>
-      <a:accent1>
-        <a:srgbClr val="4285F4"/>
-      </a:accent1>
-      <a:accent2>
-        <a:srgbClr val="212121"/>
-      </a:accent2>
-      <a:accent3>
-        <a:srgbClr val="78909C"/>
-      </a:accent3>
-      <a:accent4>
-        <a:srgbClr val="FFAB40"/>
-      </a:accent4>
-      <a:accent5>
-        <a:srgbClr val="0097A7"/>
-      </a:accent5>
-      <a:accent6>
-        <a:srgbClr val="EEFF41"/>
-      </a:accent6>
-      <a:hlink>
-        <a:srgbClr val="0097A7"/>
-      </a:hlink>
-      <a:folHlink>
-        <a:srgbClr val="0097A7"/>
-      </a:folHlink>
-    </a:clrScheme>
-    <a:fontScheme name="Office">
-      <a:majorFont>
-        <a:latin typeface="Arial"/>
-        <a:ea typeface=""/>
-        <a:cs typeface=""/>
-        <a:font script="Jpan" typeface="ＭＳ Ｐゴシック"/>
-        <a:font script="Hang" typeface="맑은 고딕"/>
-        <a:font script="Hans" typeface="宋体"/>
-        <a:font script="Hant" typeface="新細明體"/>
-        <a:font script="Arab" typeface="Times New Roman"/>
-        <a:font script="Hebr" typeface="Times New Roman"/>
-        <a:font script="Thai" typeface="Angsana New"/>
-        <a:font script="Ethi" typeface="Nyala"/>
-        <a:font script="Beng" typeface="Vrinda"/>
-        <a:font script="Gujr" typeface="Shruti"/>
-        <a:font script="Khmr" typeface="MoolBoran"/>
-        <a:font script="Knda" typeface="Tunga"/>
-        <a:font script="Guru" typeface="Raavi"/>
-        <a:font script="Cans" typeface="Euphemia"/>
-        <a:font script="Cher" typeface="Plantagenet Cherokee"/>
-        <a:font script="Yiii" typeface="Microsoft Yi Baiti"/>
-        <a:font script="Tibt" typeface="Microsoft Himalaya"/>
-        <a:font script="Thaa" typeface="MV Boli"/>
-        <a:font script="Deva" typeface="Mangal"/>
-        <a:font script="Telu" typeface="Gautami"/>
-        <a:font script="Taml" typeface="Latha"/>
-        <a:font script="Syrc" typeface="Estrangelo Edessa"/>
-        <a:font script="Orya" typeface="Kalinga"/>
-        <a:font script="Mlym" typeface="Kartika"/>
-        <a:font script="Laoo" typeface="DokChampa"/>
-        <a:font script="Sinh" typeface="Iskoola Pota"/>
-        <a:font script="Mong" typeface="Mongolian Baiti"/>
-        <a:font script="Viet" typeface="Times New Roman"/>
-        <a:font script="Uigh" typeface="Microsoft Uighur"/>
-        <a:font script="Geor" typeface="Sylfaen"/>
-      </a:majorFont>
-      <a:minorFont>
-        <a:latin typeface="Arial"/>
-        <a:ea typeface=""/>
-        <a:cs typeface=""/>
-        <a:font script="Jpan" typeface="ＭＳ Ｐゴシック"/>
-        <a:font script="Hang" typeface="맑은 고딕"/>
-        <a:font script="Hans" typeface="宋体"/>
-        <a:font script="Hant" typeface="新細明體"/>
-        <a:font script="Arab" typeface="Arial"/>
-        <a:font script="Hebr" typeface="Arial"/>
-        <a:font script="Thai" typeface="Cordia New"/>
-        <a:font script="Ethi" typeface="Nyala"/>
-        <a:font script="Beng" typeface="Vrinda"/>
-        <a:font script="Gujr" typeface="Shruti"/>
-        <a:font script="Khmr" typeface="DaunPenh"/>
-        <a:font script="Knda" typeface="Tunga"/>
-        <a:font script="Guru" typeface="Raavi"/>
-        <a:font script="Cans" typeface="Euphemia"/>
-        <a:font script="Cher" typeface="Plantagenet Cherokee"/>
-        <a:font script="Yiii" typeface="Microsoft Yi Baiti"/>
-        <a:font script="Tibt" typeface="Microsoft Himalaya"/>
-        <a:font script="Thaa" typeface="MV Boli"/>
-        <a:font script="Deva" typeface="Mangal"/>
-        <a:font script="Telu" typeface="Gautami"/>
-        <a:font script="Taml" typeface="Latha"/>
-        <a:font script="Syrc" typeface="Estrangelo Edessa"/>
-        <a:font script="Orya" typeface="Kalinga"/>
-        <a:font script="Mlym" typeface="Kartika"/>
-        <a:font script="Laoo" typeface="DokChampa"/>
-        <a:font script="Sinh" typeface="Iskoola Pota"/>
-        <a:font script="Mong" typeface="Mongolian Baiti"/>
-        <a:font script="Viet" typeface="Arial"/>
-        <a:font script="Uigh" typeface="Microsoft Uighur"/>
-        <a:font script="Geor" typeface="Sylfaen"/>
-      </a:minorFont>
-    </a:fontScheme>
-    <a:fmtScheme name="Office">
-      <a:fillStyleLst>
-        <a:solidFill>
-          <a:schemeClr val="phClr"/>
-        </a:solidFill>
-        <a:gradFill rotWithShape="1">
-          <a:gsLst>
-            <a:gs pos="0">
-              <a:schemeClr val="phClr">
-                <a:tint val="50000"/>
-                <a:satMod val="300000"/>
-              </a:schemeClr>
-            </a:gs>
-            <a:gs pos="35000">
-              <a:schemeClr val="phClr">
-                <a:tint val="37000"/>
-                <a:satMod val="300000"/>
-              </a:schemeClr>
-            </a:gs>
-            <a:gs pos="100000">
-              <a:schemeClr val="phClr">
-                <a:tint val="15000"/>
-                <a:satMod val="350000"/>
-              </a:schemeClr>
-            </a:gs>
-          </a:gsLst>
-          <a:lin ang="16200000" scaled="1"/>
-        </a:gradFill>
-        <a:gradFill rotWithShape="1">
-          <a:gsLst>
-            <a:gs pos="0">
-              <a:schemeClr val="phClr">
-                <a:tint val="100000"/>
-                <a:shade val="100000"/>
-                <a:satMod val="130000"/>
-              </a:schemeClr>
-            </a:gs>
-            <a:gs pos="100000">
-              <a:schemeClr val="phClr">
-                <a:tint val="50000"/>
-                <a:shade val="100000"/>
-                <a:satMod val="350000"/>
-              </a:schemeClr>
-            </a:gs>
-          </a:gsLst>
-          <a:lin ang="16200000" scaled="0"/>
-        </a:gradFill>
-      </a:fillStyleLst>
-      <a:lnStyleLst>
-        <a:ln w="9525" cap="flat" cmpd="sng" algn="ctr">
-          <a:solidFill>
-            <a:schemeClr val="phClr">
-              <a:shade val="95000"/>
-              <a:satMod val="105000"/>
-            </a:schemeClr>
-          </a:solidFill>
-          <a:prstDash val="solid"/>
-        </a:ln>
-        <a:ln w="25400" cap="flat" cmpd="sng" algn="ctr">
-          <a:solidFill>
-            <a:schemeClr val="phClr"/>
-          </a:solidFill>
-          <a:prstDash val="solid"/>
-        </a:ln>
-        <a:ln w="38100" cap="flat" cmpd="sng" algn="ctr">
-          <a:solidFill>
-            <a:schemeClr val="phClr"/>
-          </a:solidFill>
-          <a:prstDash val="solid"/>
-        </a:ln>
-      </a:lnStyleLst>
-      <a:effectStyleLst>
-        <a:effectStyle>
-          <a:effectLst>
-            <a:outerShdw blurRad="40000" dist="20000" dir="5400000" rotWithShape="0">
-              <a:srgbClr val="000000">
-                <a:alpha val="38000"/>
-              </a:srgbClr>
-            </a:outerShdw>
-          </a:effectLst>
-        </a:effectStyle>
-        <a:effectStyle>
-          <a:effectLst>
-            <a:outerShdw blurRad="40000" dist="23000" dir="5400000" rotWithShape="0">
-              <a:srgbClr val="000000">
-                <a:alpha val="35000"/>
-              </a:srgbClr>
-            </a:outerShdw>
-          </a:effectLst>
-        </a:effectStyle>
-        <a:effectStyle>
-          <a:effectLst>
-            <a:outerShdw blurRad="40000" dist="23000" dir="5400000" rotWithShape="0">
-              <a:srgbClr val="000000">
-                <a:alpha val="35000"/>
-              </a:srgbClr>
-            </a:outerShdw>
-          </a:effectLst>
-          <a:scene3d>
-            <a:camera prst="orthographicFront">
-              <a:rot lat="0" lon="0" rev="0"/>
-            </a:camera>
-            <a:lightRig rig="threePt" dir="t">
-              <a:rot lat="0" lon="0" rev="1200000"/>
-            </a:lightRig>
-          </a:scene3d>
-          <a:sp3d>
-            <a:bevelT w="63500" h="25400"/>
-          </a:sp3d>
-        </a:effectStyle>
-      </a:effectStyleLst>
-      <a:bgFillStyleLst>
-        <a:solidFill>
-          <a:schemeClr val="phClr"/>
-        </a:solidFill>
-        <a:gradFill rotWithShape="1">
-          <a:gsLst>
-            <a:gs pos="0">
-              <a:schemeClr val="phClr">
-                <a:tint val="40000"/>
-                <a:satMod val="350000"/>
-              </a:schemeClr>
-            </a:gs>
-            <a:gs pos="40000">
-              <a:schemeClr val="phClr">
-                <a:tint val="45000"/>
-                <a:shade val="99000"/>
-                <a:satMod val="350000"/>
-              </a:schemeClr>
-            </a:gs>
-            <a:gs pos="100000">
-              <a:schemeClr val="phClr">
-                <a:shade val="20000"/>
-                <a:satMod val="255000"/>
-              </a:schemeClr>
-            </a:gs>
-          </a:gsLst>
-          <a:path path="circle">
-            <a:fillToRect l="50000" t="-80000" r="50000" b="180000"/>
-          </a:path>
-        </a:gradFill>
-        <a:gradFill rotWithShape="1">
-          <a:gsLst>
-            <a:gs pos="0">
-              <a:schemeClr val="phClr">
-                <a:tint val="80000"/>
-                <a:satMod val="300000"/>
-              </a:schemeClr>
-            </a:gs>
-            <a:gs pos="100000">
-              <a:schemeClr val="phClr">
-                <a:shade val="30000"/>
-                <a:satMod val="200000"/>
-              </a:schemeClr>
-            </a:gs>
-          </a:gsLst>
-          <a:path path="circle">
-            <a:fillToRect l="50000" t="50000" r="50000" b="50000"/>
-          </a:path>
-        </a:gradFill>
-      </a:bgFillStyleLst>
-    </a:fmtScheme>
-  </a:themeElements>
-</a:theme>
 </file>
</xml_diff>

<commit_message>
Update Data Sources from LFX 2026-10-11 (#338)
Update Data Sources from LFX

Signed-off-by: github-actions[bot] <41898282+github-actions[bot]@users.noreply.github.com>
Co-authored-by: jmertic <296737+jmertic@users.noreply.github.com>
</commit_message>
<xml_diff>
--- a/overview_deck/LF Energy High Level Overview.pptx
+++ b/overview_deck/LF Energy High Level Overview.pptx
@@ -11034,10 +11034,10 @@
                 <a:solidFill>
                   <a:srgbClr val="696464"/>
                 </a:solidFill>
-                <a:latin typeface="Roboto Slab Thin"/>
-                <a:ea typeface="Roboto Slab Thin"/>
-                <a:cs typeface="Roboto Slab Thin"/>
-                <a:sym typeface="Roboto Slab Thin"/>
+                <a:latin typeface="Roboto Slab"/>
+                <a:ea typeface="Roboto Slab"/>
+                <a:cs typeface="Roboto Slab"/>
+                <a:sym typeface="Roboto Slab"/>
               </a:rPr>
               <a:t>Stats from the last 90 days</a:t>
             </a:r>
@@ -11045,10 +11045,10 @@
               <a:solidFill>
                 <a:srgbClr val="696464"/>
               </a:solidFill>
-              <a:latin typeface="Roboto Slab Thin"/>
-              <a:ea typeface="Roboto Slab Thin"/>
-              <a:cs typeface="Roboto Slab Thin"/>
-              <a:sym typeface="Roboto Slab Thin"/>
+              <a:latin typeface="Roboto Slab"/>
+              <a:ea typeface="Roboto Slab"/>
+              <a:cs typeface="Roboto Slab"/>
+              <a:sym typeface="Roboto Slab"/>
             </a:endParaRPr>
           </a:p>
         </p:txBody>
@@ -20534,18 +20534,18 @@
             </a:pPr>
             <a:r>
               <a:rPr lang="en" sz="1600">
-                <a:latin typeface="Roboto Slab Light"/>
-                <a:ea typeface="Roboto Slab Light"/>
-                <a:cs typeface="Roboto Slab Light"/>
-                <a:sym typeface="Roboto Slab Light"/>
+                <a:latin typeface="Roboto Slab"/>
+                <a:ea typeface="Roboto Slab"/>
+                <a:cs typeface="Roboto Slab"/>
+                <a:sym typeface="Roboto Slab"/>
               </a:rPr>
               <a:t>Current Working Groups include</a:t>
             </a:r>
             <a:endParaRPr sz="1600">
-              <a:latin typeface="Roboto Slab Light"/>
-              <a:ea typeface="Roboto Slab Light"/>
-              <a:cs typeface="Roboto Slab Light"/>
-              <a:sym typeface="Roboto Slab Light"/>
+              <a:latin typeface="Roboto Slab"/>
+              <a:ea typeface="Roboto Slab"/>
+              <a:cs typeface="Roboto Slab"/>
+              <a:sym typeface="Roboto Slab"/>
             </a:endParaRPr>
           </a:p>
         </p:txBody>
@@ -23877,16 +23877,16 @@
                 <a:schemeClr val="dk1"/>
               </a:buClr>
               <a:buSzPts val="3000"/>
-              <a:buFont typeface="Roboto Slab Light"/>
+              <a:buFont typeface="Roboto Slab"/>
               <a:buNone/>
               <a:defRPr b="0" i="0" sz="3000" u="none" cap="none" strike="noStrike">
                 <a:solidFill>
                   <a:schemeClr val="dk1"/>
                 </a:solidFill>
-                <a:latin typeface="Roboto Slab Light"/>
-                <a:ea typeface="Roboto Slab Light"/>
-                <a:cs typeface="Roboto Slab Light"/>
-                <a:sym typeface="Roboto Slab Light"/>
+                <a:latin typeface="Roboto Slab"/>
+                <a:ea typeface="Roboto Slab"/>
+                <a:cs typeface="Roboto Slab"/>
+                <a:sym typeface="Roboto Slab"/>
               </a:defRPr>
             </a:lvl1pPr>
             <a:lvl2pPr lvl="1" marR="0" rtl="0" algn="l">
@@ -24141,16 +24141,16 @@
                 <a:schemeClr val="dk2"/>
               </a:buClr>
               <a:buSzPts val="1800"/>
-              <a:buFont typeface="Roboto Slab Light"/>
+              <a:buFont typeface="Roboto Slab"/>
               <a:buChar char="●"/>
               <a:defRPr i="0" sz="1800" u="none" cap="none" strike="noStrike">
                 <a:solidFill>
                   <a:schemeClr val="dk2"/>
                 </a:solidFill>
-                <a:latin typeface="Roboto Slab Light"/>
-                <a:ea typeface="Roboto Slab Light"/>
-                <a:cs typeface="Roboto Slab Light"/>
-                <a:sym typeface="Roboto Slab Light"/>
+                <a:latin typeface="Roboto Slab"/>
+                <a:ea typeface="Roboto Slab"/>
+                <a:cs typeface="Roboto Slab"/>
+                <a:sym typeface="Roboto Slab"/>
               </a:defRPr>
             </a:lvl1pPr>
             <a:lvl2pPr indent="-317500" lvl="1" marL="914400" marR="0" rtl="0" algn="l">
@@ -24167,16 +24167,16 @@
                 <a:schemeClr val="dk2"/>
               </a:buClr>
               <a:buSzPts val="1400"/>
-              <a:buFont typeface="Roboto Slab Light"/>
+              <a:buFont typeface="Roboto Slab"/>
               <a:buChar char="○"/>
               <a:defRPr i="0" sz="1400" u="none" cap="none" strike="noStrike">
                 <a:solidFill>
                   <a:schemeClr val="dk2"/>
                 </a:solidFill>
-                <a:latin typeface="Roboto Slab Light"/>
-                <a:ea typeface="Roboto Slab Light"/>
-                <a:cs typeface="Roboto Slab Light"/>
-                <a:sym typeface="Roboto Slab Light"/>
+                <a:latin typeface="Roboto Slab"/>
+                <a:ea typeface="Roboto Slab"/>
+                <a:cs typeface="Roboto Slab"/>
+                <a:sym typeface="Roboto Slab"/>
               </a:defRPr>
             </a:lvl2pPr>
             <a:lvl3pPr indent="-317500" lvl="2" marL="1371600" marR="0" rtl="0" algn="l">
@@ -24193,16 +24193,16 @@
                 <a:schemeClr val="dk2"/>
               </a:buClr>
               <a:buSzPts val="1400"/>
-              <a:buFont typeface="Roboto Slab Light"/>
+              <a:buFont typeface="Roboto Slab"/>
               <a:buChar char="■"/>
               <a:defRPr i="0" sz="1400" u="none" cap="none" strike="noStrike">
                 <a:solidFill>
                   <a:schemeClr val="dk2"/>
                 </a:solidFill>
-                <a:latin typeface="Roboto Slab Light"/>
-                <a:ea typeface="Roboto Slab Light"/>
-                <a:cs typeface="Roboto Slab Light"/>
-                <a:sym typeface="Roboto Slab Light"/>
+                <a:latin typeface="Roboto Slab"/>
+                <a:ea typeface="Roboto Slab"/>
+                <a:cs typeface="Roboto Slab"/>
+                <a:sym typeface="Roboto Slab"/>
               </a:defRPr>
             </a:lvl3pPr>
             <a:lvl4pPr indent="-317500" lvl="3" marL="1828800" marR="0" rtl="0" algn="l">
@@ -24219,16 +24219,16 @@
                 <a:schemeClr val="dk2"/>
               </a:buClr>
               <a:buSzPts val="1400"/>
-              <a:buFont typeface="Roboto Slab Light"/>
+              <a:buFont typeface="Roboto Slab"/>
               <a:buChar char="●"/>
               <a:defRPr i="0" sz="1400" u="none" cap="none" strike="noStrike">
                 <a:solidFill>
                   <a:schemeClr val="dk2"/>
                 </a:solidFill>
-                <a:latin typeface="Roboto Slab Light"/>
-                <a:ea typeface="Roboto Slab Light"/>
-                <a:cs typeface="Roboto Slab Light"/>
-                <a:sym typeface="Roboto Slab Light"/>
+                <a:latin typeface="Roboto Slab"/>
+                <a:ea typeface="Roboto Slab"/>
+                <a:cs typeface="Roboto Slab"/>
+                <a:sym typeface="Roboto Slab"/>
               </a:defRPr>
             </a:lvl4pPr>
             <a:lvl5pPr indent="-317500" lvl="4" marL="2286000" marR="0" rtl="0" algn="l">
@@ -24245,16 +24245,16 @@
                 <a:schemeClr val="dk2"/>
               </a:buClr>
               <a:buSzPts val="1400"/>
-              <a:buFont typeface="Roboto Slab Light"/>
+              <a:buFont typeface="Roboto Slab"/>
               <a:buChar char="○"/>
               <a:defRPr i="0" sz="1400" u="none" cap="none" strike="noStrike">
                 <a:solidFill>
                   <a:schemeClr val="dk2"/>
                 </a:solidFill>
-                <a:latin typeface="Roboto Slab Light"/>
-                <a:ea typeface="Roboto Slab Light"/>
-                <a:cs typeface="Roboto Slab Light"/>
-                <a:sym typeface="Roboto Slab Light"/>
+                <a:latin typeface="Roboto Slab"/>
+                <a:ea typeface="Roboto Slab"/>
+                <a:cs typeface="Roboto Slab"/>
+                <a:sym typeface="Roboto Slab"/>
               </a:defRPr>
             </a:lvl5pPr>
             <a:lvl6pPr indent="-317500" lvl="5" marL="2743200" marR="0" rtl="0" algn="l">
@@ -24271,16 +24271,16 @@
                 <a:schemeClr val="dk2"/>
               </a:buClr>
               <a:buSzPts val="1400"/>
-              <a:buFont typeface="Roboto Slab Light"/>
+              <a:buFont typeface="Roboto Slab"/>
               <a:buChar char="■"/>
               <a:defRPr i="0" sz="1400" u="none" cap="none" strike="noStrike">
                 <a:solidFill>
                   <a:schemeClr val="dk2"/>
                 </a:solidFill>
-                <a:latin typeface="Roboto Slab Light"/>
-                <a:ea typeface="Roboto Slab Light"/>
-                <a:cs typeface="Roboto Slab Light"/>
-                <a:sym typeface="Roboto Slab Light"/>
+                <a:latin typeface="Roboto Slab"/>
+                <a:ea typeface="Roboto Slab"/>
+                <a:cs typeface="Roboto Slab"/>
+                <a:sym typeface="Roboto Slab"/>
               </a:defRPr>
             </a:lvl6pPr>
             <a:lvl7pPr indent="-317500" lvl="6" marL="3200400" marR="0" rtl="0" algn="l">
@@ -24297,16 +24297,16 @@
                 <a:schemeClr val="dk2"/>
               </a:buClr>
               <a:buSzPts val="1400"/>
-              <a:buFont typeface="Roboto Slab Light"/>
+              <a:buFont typeface="Roboto Slab"/>
               <a:buChar char="●"/>
               <a:defRPr i="0" sz="1400" u="none" cap="none" strike="noStrike">
                 <a:solidFill>
                   <a:schemeClr val="dk2"/>
                 </a:solidFill>
-                <a:latin typeface="Roboto Slab Light"/>
-                <a:ea typeface="Roboto Slab Light"/>
-                <a:cs typeface="Roboto Slab Light"/>
-                <a:sym typeface="Roboto Slab Light"/>
+                <a:latin typeface="Roboto Slab"/>
+                <a:ea typeface="Roboto Slab"/>
+                <a:cs typeface="Roboto Slab"/>
+                <a:sym typeface="Roboto Slab"/>
               </a:defRPr>
             </a:lvl7pPr>
             <a:lvl8pPr indent="-317500" lvl="7" marL="3657600" marR="0" rtl="0" algn="l">
@@ -24323,16 +24323,16 @@
                 <a:schemeClr val="dk2"/>
               </a:buClr>
               <a:buSzPts val="1400"/>
-              <a:buFont typeface="Roboto Slab Light"/>
+              <a:buFont typeface="Roboto Slab"/>
               <a:buChar char="○"/>
               <a:defRPr i="0" sz="1400" u="none" cap="none" strike="noStrike">
                 <a:solidFill>
                   <a:schemeClr val="dk2"/>
                 </a:solidFill>
-                <a:latin typeface="Roboto Slab Light"/>
-                <a:ea typeface="Roboto Slab Light"/>
-                <a:cs typeface="Roboto Slab Light"/>
-                <a:sym typeface="Roboto Slab Light"/>
+                <a:latin typeface="Roboto Slab"/>
+                <a:ea typeface="Roboto Slab"/>
+                <a:cs typeface="Roboto Slab"/>
+                <a:sym typeface="Roboto Slab"/>
               </a:defRPr>
             </a:lvl8pPr>
             <a:lvl9pPr indent="-317500" lvl="8" marL="4114800" marR="0" rtl="0" algn="l">
@@ -24349,16 +24349,16 @@
                 <a:schemeClr val="dk2"/>
               </a:buClr>
               <a:buSzPts val="1400"/>
-              <a:buFont typeface="Roboto Slab Light"/>
+              <a:buFont typeface="Roboto Slab"/>
               <a:buChar char="■"/>
               <a:defRPr i="0" sz="1400" u="none" cap="none" strike="noStrike">
                 <a:solidFill>
                   <a:schemeClr val="dk2"/>
                 </a:solidFill>
-                <a:latin typeface="Roboto Slab Light"/>
-                <a:ea typeface="Roboto Slab Light"/>
-                <a:cs typeface="Roboto Slab Light"/>
-                <a:sym typeface="Roboto Slab Light"/>
+                <a:latin typeface="Roboto Slab"/>
+                <a:ea typeface="Roboto Slab"/>
+                <a:cs typeface="Roboto Slab"/>
+                <a:sym typeface="Roboto Slab"/>
               </a:defRPr>
             </a:lvl9pPr>
           </a:lstStyle>
@@ -25946,7 +25946,7 @@
             <a:tbl>
               <a:tblPr>
                 <a:noFill/>
-                <a:tableStyleId>{44648D14-18A2-4DC2-9F42-4DE9688B70E6}</a:tableStyleId>
+                <a:tableStyleId>{6B021650-3F1B-4908-8C9A-BF79F1FA1910}</a:tableStyleId>
               </a:tblPr>
               <a:tblGrid>
                 <a:gridCol w="1695200"/>
@@ -26736,7 +26736,7 @@
             <a:tbl>
               <a:tblPr>
                 <a:noFill/>
-                <a:tableStyleId>{44648D14-18A2-4DC2-9F42-4DE9688B70E6}</a:tableStyleId>
+                <a:tableStyleId>{6B021650-3F1B-4908-8C9A-BF79F1FA1910}</a:tableStyleId>
               </a:tblPr>
               <a:tblGrid>
                 <a:gridCol w="1695200"/>
@@ -27426,7 +27426,7 @@
             <a:tbl>
               <a:tblPr>
                 <a:noFill/>
-                <a:tableStyleId>{44648D14-18A2-4DC2-9F42-4DE9688B70E6}</a:tableStyleId>
+                <a:tableStyleId>{6B021650-3F1B-4908-8C9A-BF79F1FA1910}</a:tableStyleId>
               </a:tblPr>
               <a:tblGrid>
                 <a:gridCol w="1695200"/>
@@ -28678,7 +28678,7 @@
             <a:tbl>
               <a:tblPr>
                 <a:noFill/>
-                <a:tableStyleId>{44648D14-18A2-4DC2-9F42-4DE9688B70E6}</a:tableStyleId>
+                <a:tableStyleId>{6B021650-3F1B-4908-8C9A-BF79F1FA1910}</a:tableStyleId>
               </a:tblPr>
               <a:tblGrid>
                 <a:gridCol w="1695200"/>
@@ -29670,7 +29670,7 @@
             <a:tbl>
               <a:tblPr>
                 <a:noFill/>
-                <a:tableStyleId>{44648D14-18A2-4DC2-9F42-4DE9688B70E6}</a:tableStyleId>
+                <a:tableStyleId>{6B021650-3F1B-4908-8C9A-BF79F1FA1910}</a:tableStyleId>
               </a:tblPr>
               <a:tblGrid>
                 <a:gridCol w="3048000"/>
@@ -31539,10 +31539,10 @@
                 <a:t/>
               </a:r>
               <a:endParaRPr>
-                <a:latin typeface="Roboto Slab Light"/>
-                <a:ea typeface="Roboto Slab Light"/>
-                <a:cs typeface="Roboto Slab Light"/>
-                <a:sym typeface="Roboto Slab Light"/>
+                <a:latin typeface="Roboto Slab"/>
+                <a:ea typeface="Roboto Slab"/>
+                <a:cs typeface="Roboto Slab"/>
+                <a:sym typeface="Roboto Slab"/>
               </a:endParaRPr>
             </a:p>
             <a:p>
@@ -31557,18 +31557,18 @@
               </a:pPr>
               <a:r>
                 <a:rPr lang="en" sz="1050">
-                  <a:latin typeface="Roboto Slab Light"/>
-                  <a:ea typeface="Roboto Slab Light"/>
-                  <a:cs typeface="Roboto Slab Light"/>
-                  <a:sym typeface="Roboto Slab Light"/>
+                  <a:latin typeface="Roboto Slab"/>
+                  <a:ea typeface="Roboto Slab"/>
+                  <a:cs typeface="Roboto Slab"/>
+                  <a:sym typeface="Roboto Slab"/>
                 </a:rPr>
                 <a:t>Early-stage research and prototypes</a:t>
               </a:r>
               <a:endParaRPr sz="1050">
-                <a:latin typeface="Roboto Slab Light"/>
-                <a:ea typeface="Roboto Slab Light"/>
-                <a:cs typeface="Roboto Slab Light"/>
-                <a:sym typeface="Roboto Slab Light"/>
+                <a:latin typeface="Roboto Slab"/>
+                <a:ea typeface="Roboto Slab"/>
+                <a:cs typeface="Roboto Slab"/>
+                <a:sym typeface="Roboto Slab"/>
               </a:endParaRPr>
             </a:p>
           </p:txBody>
@@ -31680,10 +31680,10 @@
                 <a:t/>
               </a:r>
               <a:endParaRPr>
-                <a:latin typeface="Roboto Slab Light"/>
-                <a:ea typeface="Roboto Slab Light"/>
-                <a:cs typeface="Roboto Slab Light"/>
-                <a:sym typeface="Roboto Slab Light"/>
+                <a:latin typeface="Roboto Slab"/>
+                <a:ea typeface="Roboto Slab"/>
+                <a:cs typeface="Roboto Slab"/>
+                <a:sym typeface="Roboto Slab"/>
               </a:endParaRPr>
             </a:p>
             <a:p>
@@ -31698,18 +31698,18 @@
               </a:pPr>
               <a:r>
                 <a:rPr lang="en" sz="1050">
-                  <a:latin typeface="Roboto Slab Light"/>
-                  <a:ea typeface="Roboto Slab Light"/>
-                  <a:cs typeface="Roboto Slab Light"/>
-                  <a:sym typeface="Roboto Slab Light"/>
+                  <a:latin typeface="Roboto Slab"/>
+                  <a:ea typeface="Roboto Slab"/>
+                  <a:cs typeface="Roboto Slab"/>
+                  <a:sym typeface="Roboto Slab"/>
                 </a:rPr>
                 <a:t>Advocacy for investor-owned electric companies</a:t>
               </a:r>
               <a:endParaRPr sz="1050">
-                <a:latin typeface="Roboto Slab Light"/>
-                <a:ea typeface="Roboto Slab Light"/>
-                <a:cs typeface="Roboto Slab Light"/>
-                <a:sym typeface="Roboto Slab Light"/>
+                <a:latin typeface="Roboto Slab"/>
+                <a:ea typeface="Roboto Slab"/>
+                <a:cs typeface="Roboto Slab"/>
+                <a:sym typeface="Roboto Slab"/>
               </a:endParaRPr>
             </a:p>
           </p:txBody>
@@ -31821,10 +31821,10 @@
                 <a:t/>
               </a:r>
               <a:endParaRPr>
-                <a:latin typeface="Roboto Slab Light"/>
-                <a:ea typeface="Roboto Slab Light"/>
-                <a:cs typeface="Roboto Slab Light"/>
-                <a:sym typeface="Roboto Slab Light"/>
+                <a:latin typeface="Roboto Slab"/>
+                <a:ea typeface="Roboto Slab"/>
+                <a:cs typeface="Roboto Slab"/>
+                <a:sym typeface="Roboto Slab"/>
               </a:endParaRPr>
             </a:p>
             <a:p>
@@ -31839,18 +31839,18 @@
               </a:pPr>
               <a:r>
                 <a:rPr lang="en" sz="1050">
-                  <a:latin typeface="Roboto Slab Light"/>
-                  <a:ea typeface="Roboto Slab Light"/>
-                  <a:cs typeface="Roboto Slab Light"/>
-                  <a:sym typeface="Roboto Slab Light"/>
+                  <a:latin typeface="Roboto Slab"/>
+                  <a:ea typeface="Roboto Slab"/>
+                  <a:cs typeface="Roboto Slab"/>
+                  <a:sym typeface="Roboto Slab"/>
                 </a:rPr>
                 <a:t>Publications, conferences</a:t>
               </a:r>
               <a:endParaRPr sz="1050">
-                <a:latin typeface="Roboto Slab Light"/>
-                <a:ea typeface="Roboto Slab Light"/>
-                <a:cs typeface="Roboto Slab Light"/>
-                <a:sym typeface="Roboto Slab Light"/>
+                <a:latin typeface="Roboto Slab"/>
+                <a:ea typeface="Roboto Slab"/>
+                <a:cs typeface="Roboto Slab"/>
+                <a:sym typeface="Roboto Slab"/>
               </a:endParaRPr>
             </a:p>
           </p:txBody>
@@ -31962,10 +31962,10 @@
                 <a:t/>
               </a:r>
               <a:endParaRPr>
-                <a:latin typeface="Roboto Slab Light"/>
-                <a:ea typeface="Roboto Slab Light"/>
-                <a:cs typeface="Roboto Slab Light"/>
-                <a:sym typeface="Roboto Slab Light"/>
+                <a:latin typeface="Roboto Slab"/>
+                <a:ea typeface="Roboto Slab"/>
+                <a:cs typeface="Roboto Slab"/>
+                <a:sym typeface="Roboto Slab"/>
               </a:endParaRPr>
             </a:p>
             <a:p>
@@ -31980,18 +31980,18 @@
               </a:pPr>
               <a:r>
                 <a:rPr lang="en" sz="1050">
-                  <a:latin typeface="Roboto Slab Light"/>
-                  <a:ea typeface="Roboto Slab Light"/>
-                  <a:cs typeface="Roboto Slab Light"/>
-                  <a:sym typeface="Roboto Slab Light"/>
+                  <a:latin typeface="Roboto Slab"/>
+                  <a:ea typeface="Roboto Slab"/>
+                  <a:cs typeface="Roboto Slab"/>
+                  <a:sym typeface="Roboto Slab"/>
                 </a:rPr>
                 <a:t>Publications, conferences, standards</a:t>
               </a:r>
               <a:endParaRPr sz="1050">
-                <a:latin typeface="Roboto Slab Light"/>
-                <a:ea typeface="Roboto Slab Light"/>
-                <a:cs typeface="Roboto Slab Light"/>
-                <a:sym typeface="Roboto Slab Light"/>
+                <a:latin typeface="Roboto Slab"/>
+                <a:ea typeface="Roboto Slab"/>
+                <a:cs typeface="Roboto Slab"/>
+                <a:sym typeface="Roboto Slab"/>
               </a:endParaRPr>
             </a:p>
           </p:txBody>
@@ -32539,10 +32539,10 @@
                 <a:solidFill>
                   <a:schemeClr val="dk2"/>
                 </a:solidFill>
-                <a:latin typeface="Roboto Slab Light"/>
-                <a:ea typeface="Roboto Slab Light"/>
-                <a:cs typeface="Roboto Slab Light"/>
-                <a:sym typeface="Roboto Slab Light"/>
+                <a:latin typeface="Roboto Slab"/>
+                <a:ea typeface="Roboto Slab"/>
+                <a:cs typeface="Roboto Slab"/>
+                <a:sym typeface="Roboto Slab"/>
               </a:rPr>
               <a:t>“Driven by the needs of the energy transition, our digitalization roadmap is becoming titanic. While traditional software development models are failing to keep pace, being a strategic member of LF Energy has enabled us to pave the way for open source collaborations that meet our challenges.”</a:t>
             </a:r>
@@ -32550,10 +32550,10 @@
               <a:solidFill>
                 <a:schemeClr val="dk2"/>
               </a:solidFill>
-              <a:latin typeface="Roboto Slab Light"/>
-              <a:ea typeface="Roboto Slab Light"/>
-              <a:cs typeface="Roboto Slab Light"/>
-              <a:sym typeface="Roboto Slab Light"/>
+              <a:latin typeface="Roboto Slab"/>
+              <a:ea typeface="Roboto Slab"/>
+              <a:cs typeface="Roboto Slab"/>
+              <a:sym typeface="Roboto Slab"/>
             </a:endParaRPr>
           </a:p>
         </p:txBody>
@@ -32665,10 +32665,10 @@
                 <a:solidFill>
                   <a:schemeClr val="dk2"/>
                 </a:solidFill>
-                <a:latin typeface="Roboto Slab Light"/>
-                <a:ea typeface="Roboto Slab Light"/>
-                <a:cs typeface="Roboto Slab Light"/>
-                <a:sym typeface="Roboto Slab Light"/>
+                <a:latin typeface="Roboto Slab"/>
+                <a:ea typeface="Roboto Slab"/>
+                <a:cs typeface="Roboto Slab"/>
+                <a:sym typeface="Roboto Slab"/>
               </a:rPr>
               <a:t>“Joining the LF Energy ecosystem will help Hydro-Québec in its innovation process to better respond to the energy transition, while sharing its know-how and expertise with the energy market and helping to decarbonize it.”</a:t>
             </a:r>
@@ -32676,10 +32676,10 @@
               <a:solidFill>
                 <a:schemeClr val="dk2"/>
               </a:solidFill>
-              <a:latin typeface="Roboto Slab Light"/>
-              <a:ea typeface="Roboto Slab Light"/>
-              <a:cs typeface="Roboto Slab Light"/>
-              <a:sym typeface="Roboto Slab Light"/>
+              <a:latin typeface="Roboto Slab"/>
+              <a:ea typeface="Roboto Slab"/>
+              <a:cs typeface="Roboto Slab"/>
+              <a:sym typeface="Roboto Slab"/>
             </a:endParaRPr>
           </a:p>
         </p:txBody>
@@ -32751,10 +32751,10 @@
                 <a:solidFill>
                   <a:schemeClr val="dk2"/>
                 </a:solidFill>
-                <a:latin typeface="Roboto Slab Light"/>
-                <a:ea typeface="Roboto Slab Light"/>
-                <a:cs typeface="Roboto Slab Light"/>
-                <a:sym typeface="Roboto Slab Light"/>
+                <a:latin typeface="Roboto Slab"/>
+                <a:ea typeface="Roboto Slab"/>
+                <a:cs typeface="Roboto Slab"/>
+                <a:sym typeface="Roboto Slab"/>
               </a:rPr>
               <a:t>“Collaboration and partnerships are central to our digital strategy. As a member of LF Energy, we can expand our open source efforts, leverage the Linux Foundation's expertise in Open Source, and share knowledge and resources across the industry and academia for a greater collective impact.”</a:t>
             </a:r>
@@ -32762,10 +32762,10 @@
               <a:solidFill>
                 <a:schemeClr val="dk2"/>
               </a:solidFill>
-              <a:latin typeface="Roboto Slab Light"/>
-              <a:ea typeface="Roboto Slab Light"/>
-              <a:cs typeface="Roboto Slab Light"/>
-              <a:sym typeface="Roboto Slab Light"/>
+              <a:latin typeface="Roboto Slab"/>
+              <a:ea typeface="Roboto Slab"/>
+              <a:cs typeface="Roboto Slab"/>
+              <a:sym typeface="Roboto Slab"/>
             </a:endParaRPr>
           </a:p>
         </p:txBody>
@@ -32864,10 +32864,10 @@
                 <a:solidFill>
                   <a:schemeClr val="dk2"/>
                 </a:solidFill>
-                <a:latin typeface="Roboto Slab Light"/>
-                <a:ea typeface="Roboto Slab Light"/>
-                <a:cs typeface="Roboto Slab Light"/>
-                <a:sym typeface="Roboto Slab Light"/>
+                <a:latin typeface="Roboto Slab"/>
+                <a:ea typeface="Roboto Slab"/>
+                <a:cs typeface="Roboto Slab"/>
+                <a:sym typeface="Roboto Slab"/>
               </a:rPr>
               <a:t>“LF Energy has been a huge benefit in supporting the EVerest community with knowledge of open source best practices, legal and marketing support, as well as many exciting networking opportunities in the energy industry.”</a:t>
             </a:r>
@@ -32875,10 +32875,10 @@
               <a:solidFill>
                 <a:schemeClr val="dk2"/>
               </a:solidFill>
-              <a:latin typeface="Roboto Slab Light"/>
-              <a:ea typeface="Roboto Slab Light"/>
-              <a:cs typeface="Roboto Slab Light"/>
-              <a:sym typeface="Roboto Slab Light"/>
+              <a:latin typeface="Roboto Slab"/>
+              <a:ea typeface="Roboto Slab"/>
+              <a:cs typeface="Roboto Slab"/>
+              <a:sym typeface="Roboto Slab"/>
             </a:endParaRPr>
           </a:p>
         </p:txBody>
@@ -32950,10 +32950,10 @@
                 <a:solidFill>
                   <a:schemeClr val="dk2"/>
                 </a:solidFill>
-                <a:latin typeface="Roboto Slab Light"/>
-                <a:ea typeface="Roboto Slab Light"/>
-                <a:cs typeface="Roboto Slab Light"/>
-                <a:sym typeface="Roboto Slab Light"/>
+                <a:latin typeface="Roboto Slab"/>
+                <a:ea typeface="Roboto Slab"/>
+                <a:cs typeface="Roboto Slab"/>
+                <a:sym typeface="Roboto Slab"/>
               </a:rPr>
               <a:t>“We’re seeing not only from inside but also from people wanting to work for Shell that they want to work in an open source way, they want to work with tools like that, be a part of a community like LF Energy.”</a:t>
             </a:r>
@@ -32961,10 +32961,10 @@
               <a:solidFill>
                 <a:schemeClr val="dk2"/>
               </a:solidFill>
-              <a:latin typeface="Roboto Slab Light"/>
-              <a:ea typeface="Roboto Slab Light"/>
-              <a:cs typeface="Roboto Slab Light"/>
-              <a:sym typeface="Roboto Slab Light"/>
+              <a:latin typeface="Roboto Slab"/>
+              <a:ea typeface="Roboto Slab"/>
+              <a:cs typeface="Roboto Slab"/>
+              <a:sym typeface="Roboto Slab"/>
             </a:endParaRPr>
           </a:p>
         </p:txBody>
@@ -33008,10 +33008,10 @@
                 <a:solidFill>
                   <a:schemeClr val="dk2"/>
                 </a:solidFill>
-                <a:latin typeface="Roboto Slab Light"/>
-                <a:ea typeface="Roboto Slab Light"/>
-                <a:cs typeface="Roboto Slab Light"/>
-                <a:sym typeface="Roboto Slab Light"/>
+                <a:latin typeface="Roboto Slab"/>
+                <a:ea typeface="Roboto Slab"/>
+                <a:cs typeface="Roboto Slab"/>
+                <a:sym typeface="Roboto Slab"/>
               </a:rPr>
               <a:t>“Simply utilizing open source is not enough. We are committed to actively contributing back, sharing our code with the world, and fostering the growth of the open source landscape. This is why Welotec has joined LF Energy.”</a:t>
             </a:r>
@@ -33019,10 +33019,10 @@
               <a:solidFill>
                 <a:schemeClr val="dk2"/>
               </a:solidFill>
-              <a:latin typeface="Roboto Slab Light"/>
-              <a:ea typeface="Roboto Slab Light"/>
-              <a:cs typeface="Roboto Slab Light"/>
-              <a:sym typeface="Roboto Slab Light"/>
+              <a:latin typeface="Roboto Slab"/>
+              <a:ea typeface="Roboto Slab"/>
+              <a:cs typeface="Roboto Slab"/>
+              <a:sym typeface="Roboto Slab"/>
             </a:endParaRPr>
           </a:p>
         </p:txBody>
@@ -33175,7 +33175,7 @@
             <a:tbl>
               <a:tblPr>
                 <a:noFill/>
-                <a:tableStyleId>{44648D14-18A2-4DC2-9F42-4DE9688B70E6}</a:tableStyleId>
+                <a:tableStyleId>{6B021650-3F1B-4908-8C9A-BF79F1FA1910}</a:tableStyleId>
               </a:tblPr>
               <a:tblGrid>
                 <a:gridCol w="1828800"/>
@@ -34002,6 +34002,285 @@
 </file>
 
 <file path=ppt/theme/theme1.xml><?xml version="1.0" encoding="utf-8"?>
+<a:theme xmlns:a="http://schemas.openxmlformats.org/drawingml/2006/main" xmlns:r="http://schemas.openxmlformats.org/officeDocument/2006/relationships" name="LF Energy Theme 2023">
+  <a:themeElements>
+    <a:clrScheme name="Geometric">
+      <a:dk1>
+        <a:srgbClr val="222222"/>
+      </a:dk1>
+      <a:lt1>
+        <a:srgbClr val="FFFFFF"/>
+      </a:lt1>
+      <a:dk2>
+        <a:srgbClr val="434343"/>
+      </a:dk2>
+      <a:lt2>
+        <a:srgbClr val="999999"/>
+      </a:lt2>
+      <a:accent1>
+        <a:srgbClr val="003778"/>
+      </a:accent1>
+      <a:accent2>
+        <a:srgbClr val="0094FF"/>
+      </a:accent2>
+      <a:accent3>
+        <a:srgbClr val="5B1DE7"/>
+      </a:accent3>
+      <a:accent4>
+        <a:srgbClr val="12E2E2"/>
+      </a:accent4>
+      <a:accent5>
+        <a:srgbClr val="FF00AA"/>
+      </a:accent5>
+      <a:accent6>
+        <a:srgbClr val="ACDE1F"/>
+      </a:accent6>
+      <a:hlink>
+        <a:srgbClr val="0077CC"/>
+      </a:hlink>
+      <a:folHlink>
+        <a:srgbClr val="F06292"/>
+      </a:folHlink>
+    </a:clrScheme>
+    <a:fontScheme name="Office">
+      <a:majorFont>
+        <a:latin typeface="Arial"/>
+        <a:ea typeface=""/>
+        <a:cs typeface=""/>
+        <a:font script="Jpan" typeface="ＭＳ Ｐゴシック"/>
+        <a:font script="Hang" typeface="맑은 고딕"/>
+        <a:font script="Hans" typeface="宋体"/>
+        <a:font script="Hant" typeface="新細明體"/>
+        <a:font script="Arab" typeface="Times New Roman"/>
+        <a:font script="Hebr" typeface="Times New Roman"/>
+        <a:font script="Thai" typeface="Angsana New"/>
+        <a:font script="Ethi" typeface="Nyala"/>
+        <a:font script="Beng" typeface="Vrinda"/>
+        <a:font script="Gujr" typeface="Shruti"/>
+        <a:font script="Khmr" typeface="MoolBoran"/>
+        <a:font script="Knda" typeface="Tunga"/>
+        <a:font script="Guru" typeface="Raavi"/>
+        <a:font script="Cans" typeface="Euphemia"/>
+        <a:font script="Cher" typeface="Plantagenet Cherokee"/>
+        <a:font script="Yiii" typeface="Microsoft Yi Baiti"/>
+        <a:font script="Tibt" typeface="Microsoft Himalaya"/>
+        <a:font script="Thaa" typeface="MV Boli"/>
+        <a:font script="Deva" typeface="Mangal"/>
+        <a:font script="Telu" typeface="Gautami"/>
+        <a:font script="Taml" typeface="Latha"/>
+        <a:font script="Syrc" typeface="Estrangelo Edessa"/>
+        <a:font script="Orya" typeface="Kalinga"/>
+        <a:font script="Mlym" typeface="Kartika"/>
+        <a:font script="Laoo" typeface="DokChampa"/>
+        <a:font script="Sinh" typeface="Iskoola Pota"/>
+        <a:font script="Mong" typeface="Mongolian Baiti"/>
+        <a:font script="Viet" typeface="Times New Roman"/>
+        <a:font script="Uigh" typeface="Microsoft Uighur"/>
+        <a:font script="Geor" typeface="Sylfaen"/>
+      </a:majorFont>
+      <a:minorFont>
+        <a:latin typeface="Arial"/>
+        <a:ea typeface=""/>
+        <a:cs typeface=""/>
+        <a:font script="Jpan" typeface="ＭＳ Ｐゴシック"/>
+        <a:font script="Hang" typeface="맑은 고딕"/>
+        <a:font script="Hans" typeface="宋体"/>
+        <a:font script="Hant" typeface="新細明體"/>
+        <a:font script="Arab" typeface="Arial"/>
+        <a:font script="Hebr" typeface="Arial"/>
+        <a:font script="Thai" typeface="Cordia New"/>
+        <a:font script="Ethi" typeface="Nyala"/>
+        <a:font script="Beng" typeface="Vrinda"/>
+        <a:font script="Gujr" typeface="Shruti"/>
+        <a:font script="Khmr" typeface="DaunPenh"/>
+        <a:font script="Knda" typeface="Tunga"/>
+        <a:font script="Guru" typeface="Raavi"/>
+        <a:font script="Cans" typeface="Euphemia"/>
+        <a:font script="Cher" typeface="Plantagenet Cherokee"/>
+        <a:font script="Yiii" typeface="Microsoft Yi Baiti"/>
+        <a:font script="Tibt" typeface="Microsoft Himalaya"/>
+        <a:font script="Thaa" typeface="MV Boli"/>
+        <a:font script="Deva" typeface="Mangal"/>
+        <a:font script="Telu" typeface="Gautami"/>
+        <a:font script="Taml" typeface="Latha"/>
+        <a:font script="Syrc" typeface="Estrangelo Edessa"/>
+        <a:font script="Orya" typeface="Kalinga"/>
+        <a:font script="Mlym" typeface="Kartika"/>
+        <a:font script="Laoo" typeface="DokChampa"/>
+        <a:font script="Sinh" typeface="Iskoola Pota"/>
+        <a:font script="Mong" typeface="Mongolian Baiti"/>
+        <a:font script="Viet" typeface="Arial"/>
+        <a:font script="Uigh" typeface="Microsoft Uighur"/>
+        <a:font script="Geor" typeface="Sylfaen"/>
+      </a:minorFont>
+    </a:fontScheme>
+    <a:fmtScheme name="Office">
+      <a:fillStyleLst>
+        <a:solidFill>
+          <a:schemeClr val="phClr"/>
+        </a:solidFill>
+        <a:gradFill rotWithShape="1">
+          <a:gsLst>
+            <a:gs pos="0">
+              <a:schemeClr val="phClr">
+                <a:tint val="50000"/>
+                <a:satMod val="300000"/>
+              </a:schemeClr>
+            </a:gs>
+            <a:gs pos="35000">
+              <a:schemeClr val="phClr">
+                <a:tint val="37000"/>
+                <a:satMod val="300000"/>
+              </a:schemeClr>
+            </a:gs>
+            <a:gs pos="100000">
+              <a:schemeClr val="phClr">
+                <a:tint val="15000"/>
+                <a:satMod val="350000"/>
+              </a:schemeClr>
+            </a:gs>
+          </a:gsLst>
+          <a:lin ang="16200000" scaled="1"/>
+        </a:gradFill>
+        <a:gradFill rotWithShape="1">
+          <a:gsLst>
+            <a:gs pos="0">
+              <a:schemeClr val="phClr">
+                <a:tint val="100000"/>
+                <a:shade val="100000"/>
+                <a:satMod val="130000"/>
+              </a:schemeClr>
+            </a:gs>
+            <a:gs pos="100000">
+              <a:schemeClr val="phClr">
+                <a:tint val="50000"/>
+                <a:shade val="100000"/>
+                <a:satMod val="350000"/>
+              </a:schemeClr>
+            </a:gs>
+          </a:gsLst>
+          <a:lin ang="16200000" scaled="0"/>
+        </a:gradFill>
+      </a:fillStyleLst>
+      <a:lnStyleLst>
+        <a:ln w="9525" cap="flat" cmpd="sng" algn="ctr">
+          <a:solidFill>
+            <a:schemeClr val="phClr">
+              <a:shade val="95000"/>
+              <a:satMod val="105000"/>
+            </a:schemeClr>
+          </a:solidFill>
+          <a:prstDash val="solid"/>
+        </a:ln>
+        <a:ln w="25400" cap="flat" cmpd="sng" algn="ctr">
+          <a:solidFill>
+            <a:schemeClr val="phClr"/>
+          </a:solidFill>
+          <a:prstDash val="solid"/>
+        </a:ln>
+        <a:ln w="38100" cap="flat" cmpd="sng" algn="ctr">
+          <a:solidFill>
+            <a:schemeClr val="phClr"/>
+          </a:solidFill>
+          <a:prstDash val="solid"/>
+        </a:ln>
+      </a:lnStyleLst>
+      <a:effectStyleLst>
+        <a:effectStyle>
+          <a:effectLst>
+            <a:outerShdw blurRad="40000" dist="20000" dir="5400000" rotWithShape="0">
+              <a:srgbClr val="000000">
+                <a:alpha val="38000"/>
+              </a:srgbClr>
+            </a:outerShdw>
+          </a:effectLst>
+        </a:effectStyle>
+        <a:effectStyle>
+          <a:effectLst>
+            <a:outerShdw blurRad="40000" dist="23000" dir="5400000" rotWithShape="0">
+              <a:srgbClr val="000000">
+                <a:alpha val="35000"/>
+              </a:srgbClr>
+            </a:outerShdw>
+          </a:effectLst>
+        </a:effectStyle>
+        <a:effectStyle>
+          <a:effectLst>
+            <a:outerShdw blurRad="40000" dist="23000" dir="5400000" rotWithShape="0">
+              <a:srgbClr val="000000">
+                <a:alpha val="35000"/>
+              </a:srgbClr>
+            </a:outerShdw>
+          </a:effectLst>
+          <a:scene3d>
+            <a:camera prst="orthographicFront">
+              <a:rot lat="0" lon="0" rev="0"/>
+            </a:camera>
+            <a:lightRig rig="threePt" dir="t">
+              <a:rot lat="0" lon="0" rev="1200000"/>
+            </a:lightRig>
+          </a:scene3d>
+          <a:sp3d>
+            <a:bevelT w="63500" h="25400"/>
+          </a:sp3d>
+        </a:effectStyle>
+      </a:effectStyleLst>
+      <a:bgFillStyleLst>
+        <a:solidFill>
+          <a:schemeClr val="phClr"/>
+        </a:solidFill>
+        <a:gradFill rotWithShape="1">
+          <a:gsLst>
+            <a:gs pos="0">
+              <a:schemeClr val="phClr">
+                <a:tint val="40000"/>
+                <a:satMod val="350000"/>
+              </a:schemeClr>
+            </a:gs>
+            <a:gs pos="40000">
+              <a:schemeClr val="phClr">
+                <a:tint val="45000"/>
+                <a:shade val="99000"/>
+                <a:satMod val="350000"/>
+              </a:schemeClr>
+            </a:gs>
+            <a:gs pos="100000">
+              <a:schemeClr val="phClr">
+                <a:shade val="20000"/>
+                <a:satMod val="255000"/>
+              </a:schemeClr>
+            </a:gs>
+          </a:gsLst>
+          <a:path path="circle">
+            <a:fillToRect l="50000" t="-80000" r="50000" b="180000"/>
+          </a:path>
+        </a:gradFill>
+        <a:gradFill rotWithShape="1">
+          <a:gsLst>
+            <a:gs pos="0">
+              <a:schemeClr val="phClr">
+                <a:tint val="80000"/>
+                <a:satMod val="300000"/>
+              </a:schemeClr>
+            </a:gs>
+            <a:gs pos="100000">
+              <a:schemeClr val="phClr">
+                <a:shade val="30000"/>
+                <a:satMod val="200000"/>
+              </a:schemeClr>
+            </a:gs>
+          </a:gsLst>
+          <a:path path="circle">
+            <a:fillToRect l="50000" t="50000" r="50000" b="50000"/>
+          </a:path>
+        </a:gradFill>
+      </a:bgFillStyleLst>
+    </a:fmtScheme>
+  </a:themeElements>
+</a:theme>
+</file>
+
+<file path=ppt/theme/theme2.xml><?xml version="1.0" encoding="utf-8"?>
 <a:theme xmlns:a="http://schemas.openxmlformats.org/drawingml/2006/main" xmlns:r="http://schemas.openxmlformats.org/officeDocument/2006/relationships" name="Simple Light">
   <a:themeElements>
     <a:clrScheme name="Simple Light">
@@ -34280,7 +34559,7 @@
 </a:theme>
 </file>
 
-<file path=ppt/theme/theme2.xml><?xml version="1.0" encoding="utf-8"?>
+<file path=ppt/theme/theme3.xml><?xml version="1.0" encoding="utf-8"?>
 <a:theme xmlns:a="http://schemas.openxmlformats.org/drawingml/2006/main" xmlns:r="http://schemas.openxmlformats.org/officeDocument/2006/relationships">
   <a:themeElements>
     <a:clrScheme name="Default">
@@ -34557,283 +34836,4 @@
     </a:fmtScheme>
   </a:themeElements>
 </a:theme>
-</file>
-
-<file path=ppt/theme/theme3.xml><?xml version="1.0" encoding="utf-8"?>
-<a:theme xmlns:a="http://schemas.openxmlformats.org/drawingml/2006/main" xmlns:r="http://schemas.openxmlformats.org/officeDocument/2006/relationships" name="LF Energy Theme 2023">
-  <a:themeElements>
-    <a:clrScheme name="Geometric">
-      <a:dk1>
-        <a:srgbClr val="222222"/>
-      </a:dk1>
-      <a:lt1>
-        <a:srgbClr val="FFFFFF"/>
-      </a:lt1>
-      <a:dk2>
-        <a:srgbClr val="434343"/>
-      </a:dk2>
-      <a:lt2>
-        <a:srgbClr val="999999"/>
-      </a:lt2>
-      <a:accent1>
-        <a:srgbClr val="003778"/>
-      </a:accent1>
-      <a:accent2>
-        <a:srgbClr val="0094FF"/>
-      </a:accent2>
-      <a:accent3>
-        <a:srgbClr val="5B1DE7"/>
-      </a:accent3>
-      <a:accent4>
-        <a:srgbClr val="12E2E2"/>
-      </a:accent4>
-      <a:accent5>
-        <a:srgbClr val="FF00AA"/>
-      </a:accent5>
-      <a:accent6>
-        <a:srgbClr val="ACDE1F"/>
-      </a:accent6>
-      <a:hlink>
-        <a:srgbClr val="0077CC"/>
-      </a:hlink>
-      <a:folHlink>
-        <a:srgbClr val="F06292"/>
-      </a:folHlink>
-    </a:clrScheme>
-    <a:fontScheme name="Office">
-      <a:majorFont>
-        <a:latin typeface="Arial"/>
-        <a:ea typeface=""/>
-        <a:cs typeface=""/>
-        <a:font script="Jpan" typeface="ＭＳ Ｐゴシック"/>
-        <a:font script="Hang" typeface="맑은 고딕"/>
-        <a:font script="Hans" typeface="宋体"/>
-        <a:font script="Hant" typeface="新細明體"/>
-        <a:font script="Arab" typeface="Times New Roman"/>
-        <a:font script="Hebr" typeface="Times New Roman"/>
-        <a:font script="Thai" typeface="Angsana New"/>
-        <a:font script="Ethi" typeface="Nyala"/>
-        <a:font script="Beng" typeface="Vrinda"/>
-        <a:font script="Gujr" typeface="Shruti"/>
-        <a:font script="Khmr" typeface="MoolBoran"/>
-        <a:font script="Knda" typeface="Tunga"/>
-        <a:font script="Guru" typeface="Raavi"/>
-        <a:font script="Cans" typeface="Euphemia"/>
-        <a:font script="Cher" typeface="Plantagenet Cherokee"/>
-        <a:font script="Yiii" typeface="Microsoft Yi Baiti"/>
-        <a:font script="Tibt" typeface="Microsoft Himalaya"/>
-        <a:font script="Thaa" typeface="MV Boli"/>
-        <a:font script="Deva" typeface="Mangal"/>
-        <a:font script="Telu" typeface="Gautami"/>
-        <a:font script="Taml" typeface="Latha"/>
-        <a:font script="Syrc" typeface="Estrangelo Edessa"/>
-        <a:font script="Orya" typeface="Kalinga"/>
-        <a:font script="Mlym" typeface="Kartika"/>
-        <a:font script="Laoo" typeface="DokChampa"/>
-        <a:font script="Sinh" typeface="Iskoola Pota"/>
-        <a:font script="Mong" typeface="Mongolian Baiti"/>
-        <a:font script="Viet" typeface="Times New Roman"/>
-        <a:font script="Uigh" typeface="Microsoft Uighur"/>
-        <a:font script="Geor" typeface="Sylfaen"/>
-      </a:majorFont>
-      <a:minorFont>
-        <a:latin typeface="Arial"/>
-        <a:ea typeface=""/>
-        <a:cs typeface=""/>
-        <a:font script="Jpan" typeface="ＭＳ Ｐゴシック"/>
-        <a:font script="Hang" typeface="맑은 고딕"/>
-        <a:font script="Hans" typeface="宋体"/>
-        <a:font script="Hant" typeface="新細明體"/>
-        <a:font script="Arab" typeface="Arial"/>
-        <a:font script="Hebr" typeface="Arial"/>
-        <a:font script="Thai" typeface="Cordia New"/>
-        <a:font script="Ethi" typeface="Nyala"/>
-        <a:font script="Beng" typeface="Vrinda"/>
-        <a:font script="Gujr" typeface="Shruti"/>
-        <a:font script="Khmr" typeface="DaunPenh"/>
-        <a:font script="Knda" typeface="Tunga"/>
-        <a:font script="Guru" typeface="Raavi"/>
-        <a:font script="Cans" typeface="Euphemia"/>
-        <a:font script="Cher" typeface="Plantagenet Cherokee"/>
-        <a:font script="Yiii" typeface="Microsoft Yi Baiti"/>
-        <a:font script="Tibt" typeface="Microsoft Himalaya"/>
-        <a:font script="Thaa" typeface="MV Boli"/>
-        <a:font script="Deva" typeface="Mangal"/>
-        <a:font script="Telu" typeface="Gautami"/>
-        <a:font script="Taml" typeface="Latha"/>
-        <a:font script="Syrc" typeface="Estrangelo Edessa"/>
-        <a:font script="Orya" typeface="Kalinga"/>
-        <a:font script="Mlym" typeface="Kartika"/>
-        <a:font script="Laoo" typeface="DokChampa"/>
-        <a:font script="Sinh" typeface="Iskoola Pota"/>
-        <a:font script="Mong" typeface="Mongolian Baiti"/>
-        <a:font script="Viet" typeface="Arial"/>
-        <a:font script="Uigh" typeface="Microsoft Uighur"/>
-        <a:font script="Geor" typeface="Sylfaen"/>
-      </a:minorFont>
-    </a:fontScheme>
-    <a:fmtScheme name="Office">
-      <a:fillStyleLst>
-        <a:solidFill>
-          <a:schemeClr val="phClr"/>
-        </a:solidFill>
-        <a:gradFill rotWithShape="1">
-          <a:gsLst>
-            <a:gs pos="0">
-              <a:schemeClr val="phClr">
-                <a:tint val="50000"/>
-                <a:satMod val="300000"/>
-              </a:schemeClr>
-            </a:gs>
-            <a:gs pos="35000">
-              <a:schemeClr val="phClr">
-                <a:tint val="37000"/>
-                <a:satMod val="300000"/>
-              </a:schemeClr>
-            </a:gs>
-            <a:gs pos="100000">
-              <a:schemeClr val="phClr">
-                <a:tint val="15000"/>
-                <a:satMod val="350000"/>
-              </a:schemeClr>
-            </a:gs>
-          </a:gsLst>
-          <a:lin ang="16200000" scaled="1"/>
-        </a:gradFill>
-        <a:gradFill rotWithShape="1">
-          <a:gsLst>
-            <a:gs pos="0">
-              <a:schemeClr val="phClr">
-                <a:tint val="100000"/>
-                <a:shade val="100000"/>
-                <a:satMod val="130000"/>
-              </a:schemeClr>
-            </a:gs>
-            <a:gs pos="100000">
-              <a:schemeClr val="phClr">
-                <a:tint val="50000"/>
-                <a:shade val="100000"/>
-                <a:satMod val="350000"/>
-              </a:schemeClr>
-            </a:gs>
-          </a:gsLst>
-          <a:lin ang="16200000" scaled="0"/>
-        </a:gradFill>
-      </a:fillStyleLst>
-      <a:lnStyleLst>
-        <a:ln w="9525" cap="flat" cmpd="sng" algn="ctr">
-          <a:solidFill>
-            <a:schemeClr val="phClr">
-              <a:shade val="95000"/>
-              <a:satMod val="105000"/>
-            </a:schemeClr>
-          </a:solidFill>
-          <a:prstDash val="solid"/>
-        </a:ln>
-        <a:ln w="25400" cap="flat" cmpd="sng" algn="ctr">
-          <a:solidFill>
-            <a:schemeClr val="phClr"/>
-          </a:solidFill>
-          <a:prstDash val="solid"/>
-        </a:ln>
-        <a:ln w="38100" cap="flat" cmpd="sng" algn="ctr">
-          <a:solidFill>
-            <a:schemeClr val="phClr"/>
-          </a:solidFill>
-          <a:prstDash val="solid"/>
-        </a:ln>
-      </a:lnStyleLst>
-      <a:effectStyleLst>
-        <a:effectStyle>
-          <a:effectLst>
-            <a:outerShdw blurRad="40000" dist="20000" dir="5400000" rotWithShape="0">
-              <a:srgbClr val="000000">
-                <a:alpha val="38000"/>
-              </a:srgbClr>
-            </a:outerShdw>
-          </a:effectLst>
-        </a:effectStyle>
-        <a:effectStyle>
-          <a:effectLst>
-            <a:outerShdw blurRad="40000" dist="23000" dir="5400000" rotWithShape="0">
-              <a:srgbClr val="000000">
-                <a:alpha val="35000"/>
-              </a:srgbClr>
-            </a:outerShdw>
-          </a:effectLst>
-        </a:effectStyle>
-        <a:effectStyle>
-          <a:effectLst>
-            <a:outerShdw blurRad="40000" dist="23000" dir="5400000" rotWithShape="0">
-              <a:srgbClr val="000000">
-                <a:alpha val="35000"/>
-              </a:srgbClr>
-            </a:outerShdw>
-          </a:effectLst>
-          <a:scene3d>
-            <a:camera prst="orthographicFront">
-              <a:rot lat="0" lon="0" rev="0"/>
-            </a:camera>
-            <a:lightRig rig="threePt" dir="t">
-              <a:rot lat="0" lon="0" rev="1200000"/>
-            </a:lightRig>
-          </a:scene3d>
-          <a:sp3d>
-            <a:bevelT w="63500" h="25400"/>
-          </a:sp3d>
-        </a:effectStyle>
-      </a:effectStyleLst>
-      <a:bgFillStyleLst>
-        <a:solidFill>
-          <a:schemeClr val="phClr"/>
-        </a:solidFill>
-        <a:gradFill rotWithShape="1">
-          <a:gsLst>
-            <a:gs pos="0">
-              <a:schemeClr val="phClr">
-                <a:tint val="40000"/>
-                <a:satMod val="350000"/>
-              </a:schemeClr>
-            </a:gs>
-            <a:gs pos="40000">
-              <a:schemeClr val="phClr">
-                <a:tint val="45000"/>
-                <a:shade val="99000"/>
-                <a:satMod val="350000"/>
-              </a:schemeClr>
-            </a:gs>
-            <a:gs pos="100000">
-              <a:schemeClr val="phClr">
-                <a:shade val="20000"/>
-                <a:satMod val="255000"/>
-              </a:schemeClr>
-            </a:gs>
-          </a:gsLst>
-          <a:path path="circle">
-            <a:fillToRect l="50000" t="-80000" r="50000" b="180000"/>
-          </a:path>
-        </a:gradFill>
-        <a:gradFill rotWithShape="1">
-          <a:gsLst>
-            <a:gs pos="0">
-              <a:schemeClr val="phClr">
-                <a:tint val="80000"/>
-                <a:satMod val="300000"/>
-              </a:schemeClr>
-            </a:gs>
-            <a:gs pos="100000">
-              <a:schemeClr val="phClr">
-                <a:shade val="30000"/>
-                <a:satMod val="200000"/>
-              </a:schemeClr>
-            </a:gs>
-          </a:gsLst>
-          <a:path path="circle">
-            <a:fillToRect l="50000" t="50000" r="50000" b="50000"/>
-          </a:path>
-        </a:gradFill>
-      </a:bgFillStyleLst>
-    </a:fmtScheme>
-  </a:themeElements>
-</a:theme>
 </file>
</xml_diff>

<commit_message>
Update Data Sources from LFX 2026-10-12 (#339)
Update Data Sources from LFX

Signed-off-by: github-actions[bot] <41898282+github-actions[bot]@users.noreply.github.com>
Co-authored-by: jmertic <296737+jmertic@users.noreply.github.com>
</commit_message>
<xml_diff>
--- a/overview_deck/LF Energy High Level Overview.pptx
+++ b/overview_deck/LF Energy High Level Overview.pptx
@@ -11034,10 +11034,10 @@
                 <a:solidFill>
                   <a:srgbClr val="696464"/>
                 </a:solidFill>
-                <a:latin typeface="Roboto Slab"/>
-                <a:ea typeface="Roboto Slab"/>
-                <a:cs typeface="Roboto Slab"/>
-                <a:sym typeface="Roboto Slab"/>
+                <a:latin typeface="Roboto Slab Thin"/>
+                <a:ea typeface="Roboto Slab Thin"/>
+                <a:cs typeface="Roboto Slab Thin"/>
+                <a:sym typeface="Roboto Slab Thin"/>
               </a:rPr>
               <a:t>Stats from the last 90 days</a:t>
             </a:r>
@@ -11045,10 +11045,10 @@
               <a:solidFill>
                 <a:srgbClr val="696464"/>
               </a:solidFill>
-              <a:latin typeface="Roboto Slab"/>
-              <a:ea typeface="Roboto Slab"/>
-              <a:cs typeface="Roboto Slab"/>
-              <a:sym typeface="Roboto Slab"/>
+              <a:latin typeface="Roboto Slab Thin"/>
+              <a:ea typeface="Roboto Slab Thin"/>
+              <a:cs typeface="Roboto Slab Thin"/>
+              <a:sym typeface="Roboto Slab Thin"/>
             </a:endParaRPr>
           </a:p>
         </p:txBody>
@@ -20534,18 +20534,18 @@
             </a:pPr>
             <a:r>
               <a:rPr lang="en" sz="1600">
-                <a:latin typeface="Roboto Slab"/>
-                <a:ea typeface="Roboto Slab"/>
-                <a:cs typeface="Roboto Slab"/>
-                <a:sym typeface="Roboto Slab"/>
+                <a:latin typeface="Roboto Slab Light"/>
+                <a:ea typeface="Roboto Slab Light"/>
+                <a:cs typeface="Roboto Slab Light"/>
+                <a:sym typeface="Roboto Slab Light"/>
               </a:rPr>
               <a:t>Current Working Groups include</a:t>
             </a:r>
             <a:endParaRPr sz="1600">
-              <a:latin typeface="Roboto Slab"/>
-              <a:ea typeface="Roboto Slab"/>
-              <a:cs typeface="Roboto Slab"/>
-              <a:sym typeface="Roboto Slab"/>
+              <a:latin typeface="Roboto Slab Light"/>
+              <a:ea typeface="Roboto Slab Light"/>
+              <a:cs typeface="Roboto Slab Light"/>
+              <a:sym typeface="Roboto Slab Light"/>
             </a:endParaRPr>
           </a:p>
         </p:txBody>
@@ -23877,16 +23877,16 @@
                 <a:schemeClr val="dk1"/>
               </a:buClr>
               <a:buSzPts val="3000"/>
-              <a:buFont typeface="Roboto Slab"/>
+              <a:buFont typeface="Roboto Slab Light"/>
               <a:buNone/>
               <a:defRPr b="0" i="0" sz="3000" u="none" cap="none" strike="noStrike">
                 <a:solidFill>
                   <a:schemeClr val="dk1"/>
                 </a:solidFill>
-                <a:latin typeface="Roboto Slab"/>
-                <a:ea typeface="Roboto Slab"/>
-                <a:cs typeface="Roboto Slab"/>
-                <a:sym typeface="Roboto Slab"/>
+                <a:latin typeface="Roboto Slab Light"/>
+                <a:ea typeface="Roboto Slab Light"/>
+                <a:cs typeface="Roboto Slab Light"/>
+                <a:sym typeface="Roboto Slab Light"/>
               </a:defRPr>
             </a:lvl1pPr>
             <a:lvl2pPr lvl="1" marR="0" rtl="0" algn="l">
@@ -24141,16 +24141,16 @@
                 <a:schemeClr val="dk2"/>
               </a:buClr>
               <a:buSzPts val="1800"/>
-              <a:buFont typeface="Roboto Slab"/>
+              <a:buFont typeface="Roboto Slab Light"/>
               <a:buChar char="●"/>
               <a:defRPr i="0" sz="1800" u="none" cap="none" strike="noStrike">
                 <a:solidFill>
                   <a:schemeClr val="dk2"/>
                 </a:solidFill>
-                <a:latin typeface="Roboto Slab"/>
-                <a:ea typeface="Roboto Slab"/>
-                <a:cs typeface="Roboto Slab"/>
-                <a:sym typeface="Roboto Slab"/>
+                <a:latin typeface="Roboto Slab Light"/>
+                <a:ea typeface="Roboto Slab Light"/>
+                <a:cs typeface="Roboto Slab Light"/>
+                <a:sym typeface="Roboto Slab Light"/>
               </a:defRPr>
             </a:lvl1pPr>
             <a:lvl2pPr indent="-317500" lvl="1" marL="914400" marR="0" rtl="0" algn="l">
@@ -24167,16 +24167,16 @@
                 <a:schemeClr val="dk2"/>
               </a:buClr>
               <a:buSzPts val="1400"/>
-              <a:buFont typeface="Roboto Slab"/>
+              <a:buFont typeface="Roboto Slab Light"/>
               <a:buChar char="○"/>
               <a:defRPr i="0" sz="1400" u="none" cap="none" strike="noStrike">
                 <a:solidFill>
                   <a:schemeClr val="dk2"/>
                 </a:solidFill>
-                <a:latin typeface="Roboto Slab"/>
-                <a:ea typeface="Roboto Slab"/>
-                <a:cs typeface="Roboto Slab"/>
-                <a:sym typeface="Roboto Slab"/>
+                <a:latin typeface="Roboto Slab Light"/>
+                <a:ea typeface="Roboto Slab Light"/>
+                <a:cs typeface="Roboto Slab Light"/>
+                <a:sym typeface="Roboto Slab Light"/>
               </a:defRPr>
             </a:lvl2pPr>
             <a:lvl3pPr indent="-317500" lvl="2" marL="1371600" marR="0" rtl="0" algn="l">
@@ -24193,16 +24193,16 @@
                 <a:schemeClr val="dk2"/>
               </a:buClr>
               <a:buSzPts val="1400"/>
-              <a:buFont typeface="Roboto Slab"/>
+              <a:buFont typeface="Roboto Slab Light"/>
               <a:buChar char="■"/>
               <a:defRPr i="0" sz="1400" u="none" cap="none" strike="noStrike">
                 <a:solidFill>
                   <a:schemeClr val="dk2"/>
                 </a:solidFill>
-                <a:latin typeface="Roboto Slab"/>
-                <a:ea typeface="Roboto Slab"/>
-                <a:cs typeface="Roboto Slab"/>
-                <a:sym typeface="Roboto Slab"/>
+                <a:latin typeface="Roboto Slab Light"/>
+                <a:ea typeface="Roboto Slab Light"/>
+                <a:cs typeface="Roboto Slab Light"/>
+                <a:sym typeface="Roboto Slab Light"/>
               </a:defRPr>
             </a:lvl3pPr>
             <a:lvl4pPr indent="-317500" lvl="3" marL="1828800" marR="0" rtl="0" algn="l">
@@ -24219,16 +24219,16 @@
                 <a:schemeClr val="dk2"/>
               </a:buClr>
               <a:buSzPts val="1400"/>
-              <a:buFont typeface="Roboto Slab"/>
+              <a:buFont typeface="Roboto Slab Light"/>
               <a:buChar char="●"/>
               <a:defRPr i="0" sz="1400" u="none" cap="none" strike="noStrike">
                 <a:solidFill>
                   <a:schemeClr val="dk2"/>
                 </a:solidFill>
-                <a:latin typeface="Roboto Slab"/>
-                <a:ea typeface="Roboto Slab"/>
-                <a:cs typeface="Roboto Slab"/>
-                <a:sym typeface="Roboto Slab"/>
+                <a:latin typeface="Roboto Slab Light"/>
+                <a:ea typeface="Roboto Slab Light"/>
+                <a:cs typeface="Roboto Slab Light"/>
+                <a:sym typeface="Roboto Slab Light"/>
               </a:defRPr>
             </a:lvl4pPr>
             <a:lvl5pPr indent="-317500" lvl="4" marL="2286000" marR="0" rtl="0" algn="l">
@@ -24245,16 +24245,16 @@
                 <a:schemeClr val="dk2"/>
               </a:buClr>
               <a:buSzPts val="1400"/>
-              <a:buFont typeface="Roboto Slab"/>
+              <a:buFont typeface="Roboto Slab Light"/>
               <a:buChar char="○"/>
               <a:defRPr i="0" sz="1400" u="none" cap="none" strike="noStrike">
                 <a:solidFill>
                   <a:schemeClr val="dk2"/>
                 </a:solidFill>
-                <a:latin typeface="Roboto Slab"/>
-                <a:ea typeface="Roboto Slab"/>
-                <a:cs typeface="Roboto Slab"/>
-                <a:sym typeface="Roboto Slab"/>
+                <a:latin typeface="Roboto Slab Light"/>
+                <a:ea typeface="Roboto Slab Light"/>
+                <a:cs typeface="Roboto Slab Light"/>
+                <a:sym typeface="Roboto Slab Light"/>
               </a:defRPr>
             </a:lvl5pPr>
             <a:lvl6pPr indent="-317500" lvl="5" marL="2743200" marR="0" rtl="0" algn="l">
@@ -24271,16 +24271,16 @@
                 <a:schemeClr val="dk2"/>
               </a:buClr>
               <a:buSzPts val="1400"/>
-              <a:buFont typeface="Roboto Slab"/>
+              <a:buFont typeface="Roboto Slab Light"/>
               <a:buChar char="■"/>
               <a:defRPr i="0" sz="1400" u="none" cap="none" strike="noStrike">
                 <a:solidFill>
                   <a:schemeClr val="dk2"/>
                 </a:solidFill>
-                <a:latin typeface="Roboto Slab"/>
-                <a:ea typeface="Roboto Slab"/>
-                <a:cs typeface="Roboto Slab"/>
-                <a:sym typeface="Roboto Slab"/>
+                <a:latin typeface="Roboto Slab Light"/>
+                <a:ea typeface="Roboto Slab Light"/>
+                <a:cs typeface="Roboto Slab Light"/>
+                <a:sym typeface="Roboto Slab Light"/>
               </a:defRPr>
             </a:lvl6pPr>
             <a:lvl7pPr indent="-317500" lvl="6" marL="3200400" marR="0" rtl="0" algn="l">
@@ -24297,16 +24297,16 @@
                 <a:schemeClr val="dk2"/>
               </a:buClr>
               <a:buSzPts val="1400"/>
-              <a:buFont typeface="Roboto Slab"/>
+              <a:buFont typeface="Roboto Slab Light"/>
               <a:buChar char="●"/>
               <a:defRPr i="0" sz="1400" u="none" cap="none" strike="noStrike">
                 <a:solidFill>
                   <a:schemeClr val="dk2"/>
                 </a:solidFill>
-                <a:latin typeface="Roboto Slab"/>
-                <a:ea typeface="Roboto Slab"/>
-                <a:cs typeface="Roboto Slab"/>
-                <a:sym typeface="Roboto Slab"/>
+                <a:latin typeface="Roboto Slab Light"/>
+                <a:ea typeface="Roboto Slab Light"/>
+                <a:cs typeface="Roboto Slab Light"/>
+                <a:sym typeface="Roboto Slab Light"/>
               </a:defRPr>
             </a:lvl7pPr>
             <a:lvl8pPr indent="-317500" lvl="7" marL="3657600" marR="0" rtl="0" algn="l">
@@ -24323,16 +24323,16 @@
                 <a:schemeClr val="dk2"/>
               </a:buClr>
               <a:buSzPts val="1400"/>
-              <a:buFont typeface="Roboto Slab"/>
+              <a:buFont typeface="Roboto Slab Light"/>
               <a:buChar char="○"/>
               <a:defRPr i="0" sz="1400" u="none" cap="none" strike="noStrike">
                 <a:solidFill>
                   <a:schemeClr val="dk2"/>
                 </a:solidFill>
-                <a:latin typeface="Roboto Slab"/>
-                <a:ea typeface="Roboto Slab"/>
-                <a:cs typeface="Roboto Slab"/>
-                <a:sym typeface="Roboto Slab"/>
+                <a:latin typeface="Roboto Slab Light"/>
+                <a:ea typeface="Roboto Slab Light"/>
+                <a:cs typeface="Roboto Slab Light"/>
+                <a:sym typeface="Roboto Slab Light"/>
               </a:defRPr>
             </a:lvl8pPr>
             <a:lvl9pPr indent="-317500" lvl="8" marL="4114800" marR="0" rtl="0" algn="l">
@@ -24349,16 +24349,16 @@
                 <a:schemeClr val="dk2"/>
               </a:buClr>
               <a:buSzPts val="1400"/>
-              <a:buFont typeface="Roboto Slab"/>
+              <a:buFont typeface="Roboto Slab Light"/>
               <a:buChar char="■"/>
               <a:defRPr i="0" sz="1400" u="none" cap="none" strike="noStrike">
                 <a:solidFill>
                   <a:schemeClr val="dk2"/>
                 </a:solidFill>
-                <a:latin typeface="Roboto Slab"/>
-                <a:ea typeface="Roboto Slab"/>
-                <a:cs typeface="Roboto Slab"/>
-                <a:sym typeface="Roboto Slab"/>
+                <a:latin typeface="Roboto Slab Light"/>
+                <a:ea typeface="Roboto Slab Light"/>
+                <a:cs typeface="Roboto Slab Light"/>
+                <a:sym typeface="Roboto Slab Light"/>
               </a:defRPr>
             </a:lvl9pPr>
           </a:lstStyle>
@@ -25946,7 +25946,7 @@
             <a:tbl>
               <a:tblPr>
                 <a:noFill/>
-                <a:tableStyleId>{6B021650-3F1B-4908-8C9A-BF79F1FA1910}</a:tableStyleId>
+                <a:tableStyleId>{34942F2D-3CFE-4843-A63F-DCE921DA8480}</a:tableStyleId>
               </a:tblPr>
               <a:tblGrid>
                 <a:gridCol w="1695200"/>
@@ -26736,7 +26736,7 @@
             <a:tbl>
               <a:tblPr>
                 <a:noFill/>
-                <a:tableStyleId>{6B021650-3F1B-4908-8C9A-BF79F1FA1910}</a:tableStyleId>
+                <a:tableStyleId>{34942F2D-3CFE-4843-A63F-DCE921DA8480}</a:tableStyleId>
               </a:tblPr>
               <a:tblGrid>
                 <a:gridCol w="1695200"/>
@@ -27426,7 +27426,7 @@
             <a:tbl>
               <a:tblPr>
                 <a:noFill/>
-                <a:tableStyleId>{6B021650-3F1B-4908-8C9A-BF79F1FA1910}</a:tableStyleId>
+                <a:tableStyleId>{34942F2D-3CFE-4843-A63F-DCE921DA8480}</a:tableStyleId>
               </a:tblPr>
               <a:tblGrid>
                 <a:gridCol w="1695200"/>
@@ -28678,7 +28678,7 @@
             <a:tbl>
               <a:tblPr>
                 <a:noFill/>
-                <a:tableStyleId>{6B021650-3F1B-4908-8C9A-BF79F1FA1910}</a:tableStyleId>
+                <a:tableStyleId>{34942F2D-3CFE-4843-A63F-DCE921DA8480}</a:tableStyleId>
               </a:tblPr>
               <a:tblGrid>
                 <a:gridCol w="1695200"/>
@@ -29670,7 +29670,7 @@
             <a:tbl>
               <a:tblPr>
                 <a:noFill/>
-                <a:tableStyleId>{6B021650-3F1B-4908-8C9A-BF79F1FA1910}</a:tableStyleId>
+                <a:tableStyleId>{34942F2D-3CFE-4843-A63F-DCE921DA8480}</a:tableStyleId>
               </a:tblPr>
               <a:tblGrid>
                 <a:gridCol w="3048000"/>
@@ -31539,10 +31539,10 @@
                 <a:t/>
               </a:r>
               <a:endParaRPr>
-                <a:latin typeface="Roboto Slab"/>
-                <a:ea typeface="Roboto Slab"/>
-                <a:cs typeface="Roboto Slab"/>
-                <a:sym typeface="Roboto Slab"/>
+                <a:latin typeface="Roboto Slab Light"/>
+                <a:ea typeface="Roboto Slab Light"/>
+                <a:cs typeface="Roboto Slab Light"/>
+                <a:sym typeface="Roboto Slab Light"/>
               </a:endParaRPr>
             </a:p>
             <a:p>
@@ -31557,18 +31557,18 @@
               </a:pPr>
               <a:r>
                 <a:rPr lang="en" sz="1050">
-                  <a:latin typeface="Roboto Slab"/>
-                  <a:ea typeface="Roboto Slab"/>
-                  <a:cs typeface="Roboto Slab"/>
-                  <a:sym typeface="Roboto Slab"/>
+                  <a:latin typeface="Roboto Slab Light"/>
+                  <a:ea typeface="Roboto Slab Light"/>
+                  <a:cs typeface="Roboto Slab Light"/>
+                  <a:sym typeface="Roboto Slab Light"/>
                 </a:rPr>
                 <a:t>Early-stage research and prototypes</a:t>
               </a:r>
               <a:endParaRPr sz="1050">
-                <a:latin typeface="Roboto Slab"/>
-                <a:ea typeface="Roboto Slab"/>
-                <a:cs typeface="Roboto Slab"/>
-                <a:sym typeface="Roboto Slab"/>
+                <a:latin typeface="Roboto Slab Light"/>
+                <a:ea typeface="Roboto Slab Light"/>
+                <a:cs typeface="Roboto Slab Light"/>
+                <a:sym typeface="Roboto Slab Light"/>
               </a:endParaRPr>
             </a:p>
           </p:txBody>
@@ -31680,10 +31680,10 @@
                 <a:t/>
               </a:r>
               <a:endParaRPr>
-                <a:latin typeface="Roboto Slab"/>
-                <a:ea typeface="Roboto Slab"/>
-                <a:cs typeface="Roboto Slab"/>
-                <a:sym typeface="Roboto Slab"/>
+                <a:latin typeface="Roboto Slab Light"/>
+                <a:ea typeface="Roboto Slab Light"/>
+                <a:cs typeface="Roboto Slab Light"/>
+                <a:sym typeface="Roboto Slab Light"/>
               </a:endParaRPr>
             </a:p>
             <a:p>
@@ -31698,18 +31698,18 @@
               </a:pPr>
               <a:r>
                 <a:rPr lang="en" sz="1050">
-                  <a:latin typeface="Roboto Slab"/>
-                  <a:ea typeface="Roboto Slab"/>
-                  <a:cs typeface="Roboto Slab"/>
-                  <a:sym typeface="Roboto Slab"/>
+                  <a:latin typeface="Roboto Slab Light"/>
+                  <a:ea typeface="Roboto Slab Light"/>
+                  <a:cs typeface="Roboto Slab Light"/>
+                  <a:sym typeface="Roboto Slab Light"/>
                 </a:rPr>
                 <a:t>Advocacy for investor-owned electric companies</a:t>
               </a:r>
               <a:endParaRPr sz="1050">
-                <a:latin typeface="Roboto Slab"/>
-                <a:ea typeface="Roboto Slab"/>
-                <a:cs typeface="Roboto Slab"/>
-                <a:sym typeface="Roboto Slab"/>
+                <a:latin typeface="Roboto Slab Light"/>
+                <a:ea typeface="Roboto Slab Light"/>
+                <a:cs typeface="Roboto Slab Light"/>
+                <a:sym typeface="Roboto Slab Light"/>
               </a:endParaRPr>
             </a:p>
           </p:txBody>
@@ -31821,10 +31821,10 @@
                 <a:t/>
               </a:r>
               <a:endParaRPr>
-                <a:latin typeface="Roboto Slab"/>
-                <a:ea typeface="Roboto Slab"/>
-                <a:cs typeface="Roboto Slab"/>
-                <a:sym typeface="Roboto Slab"/>
+                <a:latin typeface="Roboto Slab Light"/>
+                <a:ea typeface="Roboto Slab Light"/>
+                <a:cs typeface="Roboto Slab Light"/>
+                <a:sym typeface="Roboto Slab Light"/>
               </a:endParaRPr>
             </a:p>
             <a:p>
@@ -31839,18 +31839,18 @@
               </a:pPr>
               <a:r>
                 <a:rPr lang="en" sz="1050">
-                  <a:latin typeface="Roboto Slab"/>
-                  <a:ea typeface="Roboto Slab"/>
-                  <a:cs typeface="Roboto Slab"/>
-                  <a:sym typeface="Roboto Slab"/>
+                  <a:latin typeface="Roboto Slab Light"/>
+                  <a:ea typeface="Roboto Slab Light"/>
+                  <a:cs typeface="Roboto Slab Light"/>
+                  <a:sym typeface="Roboto Slab Light"/>
                 </a:rPr>
                 <a:t>Publications, conferences</a:t>
               </a:r>
               <a:endParaRPr sz="1050">
-                <a:latin typeface="Roboto Slab"/>
-                <a:ea typeface="Roboto Slab"/>
-                <a:cs typeface="Roboto Slab"/>
-                <a:sym typeface="Roboto Slab"/>
+                <a:latin typeface="Roboto Slab Light"/>
+                <a:ea typeface="Roboto Slab Light"/>
+                <a:cs typeface="Roboto Slab Light"/>
+                <a:sym typeface="Roboto Slab Light"/>
               </a:endParaRPr>
             </a:p>
           </p:txBody>
@@ -31962,10 +31962,10 @@
                 <a:t/>
               </a:r>
               <a:endParaRPr>
-                <a:latin typeface="Roboto Slab"/>
-                <a:ea typeface="Roboto Slab"/>
-                <a:cs typeface="Roboto Slab"/>
-                <a:sym typeface="Roboto Slab"/>
+                <a:latin typeface="Roboto Slab Light"/>
+                <a:ea typeface="Roboto Slab Light"/>
+                <a:cs typeface="Roboto Slab Light"/>
+                <a:sym typeface="Roboto Slab Light"/>
               </a:endParaRPr>
             </a:p>
             <a:p>
@@ -31980,18 +31980,18 @@
               </a:pPr>
               <a:r>
                 <a:rPr lang="en" sz="1050">
-                  <a:latin typeface="Roboto Slab"/>
-                  <a:ea typeface="Roboto Slab"/>
-                  <a:cs typeface="Roboto Slab"/>
-                  <a:sym typeface="Roboto Slab"/>
+                  <a:latin typeface="Roboto Slab Light"/>
+                  <a:ea typeface="Roboto Slab Light"/>
+                  <a:cs typeface="Roboto Slab Light"/>
+                  <a:sym typeface="Roboto Slab Light"/>
                 </a:rPr>
                 <a:t>Publications, conferences, standards</a:t>
               </a:r>
               <a:endParaRPr sz="1050">
-                <a:latin typeface="Roboto Slab"/>
-                <a:ea typeface="Roboto Slab"/>
-                <a:cs typeface="Roboto Slab"/>
-                <a:sym typeface="Roboto Slab"/>
+                <a:latin typeface="Roboto Slab Light"/>
+                <a:ea typeface="Roboto Slab Light"/>
+                <a:cs typeface="Roboto Slab Light"/>
+                <a:sym typeface="Roboto Slab Light"/>
               </a:endParaRPr>
             </a:p>
           </p:txBody>
@@ -32539,10 +32539,10 @@
                 <a:solidFill>
                   <a:schemeClr val="dk2"/>
                 </a:solidFill>
-                <a:latin typeface="Roboto Slab"/>
-                <a:ea typeface="Roboto Slab"/>
-                <a:cs typeface="Roboto Slab"/>
-                <a:sym typeface="Roboto Slab"/>
+                <a:latin typeface="Roboto Slab Light"/>
+                <a:ea typeface="Roboto Slab Light"/>
+                <a:cs typeface="Roboto Slab Light"/>
+                <a:sym typeface="Roboto Slab Light"/>
               </a:rPr>
               <a:t>“Driven by the needs of the energy transition, our digitalization roadmap is becoming titanic. While traditional software development models are failing to keep pace, being a strategic member of LF Energy has enabled us to pave the way for open source collaborations that meet our challenges.”</a:t>
             </a:r>
@@ -32550,10 +32550,10 @@
               <a:solidFill>
                 <a:schemeClr val="dk2"/>
               </a:solidFill>
-              <a:latin typeface="Roboto Slab"/>
-              <a:ea typeface="Roboto Slab"/>
-              <a:cs typeface="Roboto Slab"/>
-              <a:sym typeface="Roboto Slab"/>
+              <a:latin typeface="Roboto Slab Light"/>
+              <a:ea typeface="Roboto Slab Light"/>
+              <a:cs typeface="Roboto Slab Light"/>
+              <a:sym typeface="Roboto Slab Light"/>
             </a:endParaRPr>
           </a:p>
         </p:txBody>
@@ -32665,10 +32665,10 @@
                 <a:solidFill>
                   <a:schemeClr val="dk2"/>
                 </a:solidFill>
-                <a:latin typeface="Roboto Slab"/>
-                <a:ea typeface="Roboto Slab"/>
-                <a:cs typeface="Roboto Slab"/>
-                <a:sym typeface="Roboto Slab"/>
+                <a:latin typeface="Roboto Slab Light"/>
+                <a:ea typeface="Roboto Slab Light"/>
+                <a:cs typeface="Roboto Slab Light"/>
+                <a:sym typeface="Roboto Slab Light"/>
               </a:rPr>
               <a:t>“Joining the LF Energy ecosystem will help Hydro-Québec in its innovation process to better respond to the energy transition, while sharing its know-how and expertise with the energy market and helping to decarbonize it.”</a:t>
             </a:r>
@@ -32676,10 +32676,10 @@
               <a:solidFill>
                 <a:schemeClr val="dk2"/>
               </a:solidFill>
-              <a:latin typeface="Roboto Slab"/>
-              <a:ea typeface="Roboto Slab"/>
-              <a:cs typeface="Roboto Slab"/>
-              <a:sym typeface="Roboto Slab"/>
+              <a:latin typeface="Roboto Slab Light"/>
+              <a:ea typeface="Roboto Slab Light"/>
+              <a:cs typeface="Roboto Slab Light"/>
+              <a:sym typeface="Roboto Slab Light"/>
             </a:endParaRPr>
           </a:p>
         </p:txBody>
@@ -32751,10 +32751,10 @@
                 <a:solidFill>
                   <a:schemeClr val="dk2"/>
                 </a:solidFill>
-                <a:latin typeface="Roboto Slab"/>
-                <a:ea typeface="Roboto Slab"/>
-                <a:cs typeface="Roboto Slab"/>
-                <a:sym typeface="Roboto Slab"/>
+                <a:latin typeface="Roboto Slab Light"/>
+                <a:ea typeface="Roboto Slab Light"/>
+                <a:cs typeface="Roboto Slab Light"/>
+                <a:sym typeface="Roboto Slab Light"/>
               </a:rPr>
               <a:t>“Collaboration and partnerships are central to our digital strategy. As a member of LF Energy, we can expand our open source efforts, leverage the Linux Foundation's expertise in Open Source, and share knowledge and resources across the industry and academia for a greater collective impact.”</a:t>
             </a:r>
@@ -32762,10 +32762,10 @@
               <a:solidFill>
                 <a:schemeClr val="dk2"/>
               </a:solidFill>
-              <a:latin typeface="Roboto Slab"/>
-              <a:ea typeface="Roboto Slab"/>
-              <a:cs typeface="Roboto Slab"/>
-              <a:sym typeface="Roboto Slab"/>
+              <a:latin typeface="Roboto Slab Light"/>
+              <a:ea typeface="Roboto Slab Light"/>
+              <a:cs typeface="Roboto Slab Light"/>
+              <a:sym typeface="Roboto Slab Light"/>
             </a:endParaRPr>
           </a:p>
         </p:txBody>
@@ -32864,10 +32864,10 @@
                 <a:solidFill>
                   <a:schemeClr val="dk2"/>
                 </a:solidFill>
-                <a:latin typeface="Roboto Slab"/>
-                <a:ea typeface="Roboto Slab"/>
-                <a:cs typeface="Roboto Slab"/>
-                <a:sym typeface="Roboto Slab"/>
+                <a:latin typeface="Roboto Slab Light"/>
+                <a:ea typeface="Roboto Slab Light"/>
+                <a:cs typeface="Roboto Slab Light"/>
+                <a:sym typeface="Roboto Slab Light"/>
               </a:rPr>
               <a:t>“LF Energy has been a huge benefit in supporting the EVerest community with knowledge of open source best practices, legal and marketing support, as well as many exciting networking opportunities in the energy industry.”</a:t>
             </a:r>
@@ -32875,10 +32875,10 @@
               <a:solidFill>
                 <a:schemeClr val="dk2"/>
               </a:solidFill>
-              <a:latin typeface="Roboto Slab"/>
-              <a:ea typeface="Roboto Slab"/>
-              <a:cs typeface="Roboto Slab"/>
-              <a:sym typeface="Roboto Slab"/>
+              <a:latin typeface="Roboto Slab Light"/>
+              <a:ea typeface="Roboto Slab Light"/>
+              <a:cs typeface="Roboto Slab Light"/>
+              <a:sym typeface="Roboto Slab Light"/>
             </a:endParaRPr>
           </a:p>
         </p:txBody>
@@ -32950,10 +32950,10 @@
                 <a:solidFill>
                   <a:schemeClr val="dk2"/>
                 </a:solidFill>
-                <a:latin typeface="Roboto Slab"/>
-                <a:ea typeface="Roboto Slab"/>
-                <a:cs typeface="Roboto Slab"/>
-                <a:sym typeface="Roboto Slab"/>
+                <a:latin typeface="Roboto Slab Light"/>
+                <a:ea typeface="Roboto Slab Light"/>
+                <a:cs typeface="Roboto Slab Light"/>
+                <a:sym typeface="Roboto Slab Light"/>
               </a:rPr>
               <a:t>“We’re seeing not only from inside but also from people wanting to work for Shell that they want to work in an open source way, they want to work with tools like that, be a part of a community like LF Energy.”</a:t>
             </a:r>
@@ -32961,10 +32961,10 @@
               <a:solidFill>
                 <a:schemeClr val="dk2"/>
               </a:solidFill>
-              <a:latin typeface="Roboto Slab"/>
-              <a:ea typeface="Roboto Slab"/>
-              <a:cs typeface="Roboto Slab"/>
-              <a:sym typeface="Roboto Slab"/>
+              <a:latin typeface="Roboto Slab Light"/>
+              <a:ea typeface="Roboto Slab Light"/>
+              <a:cs typeface="Roboto Slab Light"/>
+              <a:sym typeface="Roboto Slab Light"/>
             </a:endParaRPr>
           </a:p>
         </p:txBody>
@@ -33008,10 +33008,10 @@
                 <a:solidFill>
                   <a:schemeClr val="dk2"/>
                 </a:solidFill>
-                <a:latin typeface="Roboto Slab"/>
-                <a:ea typeface="Roboto Slab"/>
-                <a:cs typeface="Roboto Slab"/>
-                <a:sym typeface="Roboto Slab"/>
+                <a:latin typeface="Roboto Slab Light"/>
+                <a:ea typeface="Roboto Slab Light"/>
+                <a:cs typeface="Roboto Slab Light"/>
+                <a:sym typeface="Roboto Slab Light"/>
               </a:rPr>
               <a:t>“Simply utilizing open source is not enough. We are committed to actively contributing back, sharing our code with the world, and fostering the growth of the open source landscape. This is why Welotec has joined LF Energy.”</a:t>
             </a:r>
@@ -33019,10 +33019,10 @@
               <a:solidFill>
                 <a:schemeClr val="dk2"/>
               </a:solidFill>
-              <a:latin typeface="Roboto Slab"/>
-              <a:ea typeface="Roboto Slab"/>
-              <a:cs typeface="Roboto Slab"/>
-              <a:sym typeface="Roboto Slab"/>
+              <a:latin typeface="Roboto Slab Light"/>
+              <a:ea typeface="Roboto Slab Light"/>
+              <a:cs typeface="Roboto Slab Light"/>
+              <a:sym typeface="Roboto Slab Light"/>
             </a:endParaRPr>
           </a:p>
         </p:txBody>
@@ -33175,7 +33175,7 @@
             <a:tbl>
               <a:tblPr>
                 <a:noFill/>
-                <a:tableStyleId>{6B021650-3F1B-4908-8C9A-BF79F1FA1910}</a:tableStyleId>
+                <a:tableStyleId>{34942F2D-3CFE-4843-A63F-DCE921DA8480}</a:tableStyleId>
               </a:tblPr>
               <a:tblGrid>
                 <a:gridCol w="1828800"/>
@@ -34002,6 +34002,285 @@
 </file>
 
 <file path=ppt/theme/theme1.xml><?xml version="1.0" encoding="utf-8"?>
+<a:theme xmlns:a="http://schemas.openxmlformats.org/drawingml/2006/main" xmlns:r="http://schemas.openxmlformats.org/officeDocument/2006/relationships">
+  <a:themeElements>
+    <a:clrScheme name="Default">
+      <a:dk1>
+        <a:srgbClr val="000000"/>
+      </a:dk1>
+      <a:lt1>
+        <a:srgbClr val="FFFFFF"/>
+      </a:lt1>
+      <a:dk2>
+        <a:srgbClr val="158158"/>
+      </a:dk2>
+      <a:lt2>
+        <a:srgbClr val="F3F3F3"/>
+      </a:lt2>
+      <a:accent1>
+        <a:srgbClr val="058DC7"/>
+      </a:accent1>
+      <a:accent2>
+        <a:srgbClr val="50B432"/>
+      </a:accent2>
+      <a:accent3>
+        <a:srgbClr val="ED561B"/>
+      </a:accent3>
+      <a:accent4>
+        <a:srgbClr val="EDEF00"/>
+      </a:accent4>
+      <a:accent5>
+        <a:srgbClr val="24CBE5"/>
+      </a:accent5>
+      <a:accent6>
+        <a:srgbClr val="64E572"/>
+      </a:accent6>
+      <a:hlink>
+        <a:srgbClr val="2200CC"/>
+      </a:hlink>
+      <a:folHlink>
+        <a:srgbClr val="551A8B"/>
+      </a:folHlink>
+    </a:clrScheme>
+    <a:fontScheme name="Office">
+      <a:majorFont>
+        <a:latin typeface="Arial"/>
+        <a:ea typeface=""/>
+        <a:cs typeface=""/>
+        <a:font script="Jpan" typeface="ＭＳ Ｐゴシック"/>
+        <a:font script="Hang" typeface="맑은 고딕"/>
+        <a:font script="Hans" typeface="宋体"/>
+        <a:font script="Hant" typeface="新細明體"/>
+        <a:font script="Arab" typeface="Times New Roman"/>
+        <a:font script="Hebr" typeface="Times New Roman"/>
+        <a:font script="Thai" typeface="Angsana New"/>
+        <a:font script="Ethi" typeface="Nyala"/>
+        <a:font script="Beng" typeface="Vrinda"/>
+        <a:font script="Gujr" typeface="Shruti"/>
+        <a:font script="Khmr" typeface="MoolBoran"/>
+        <a:font script="Knda" typeface="Tunga"/>
+        <a:font script="Guru" typeface="Raavi"/>
+        <a:font script="Cans" typeface="Euphemia"/>
+        <a:font script="Cher" typeface="Plantagenet Cherokee"/>
+        <a:font script="Yiii" typeface="Microsoft Yi Baiti"/>
+        <a:font script="Tibt" typeface="Microsoft Himalaya"/>
+        <a:font script="Thaa" typeface="MV Boli"/>
+        <a:font script="Deva" typeface="Mangal"/>
+        <a:font script="Telu" typeface="Gautami"/>
+        <a:font script="Taml" typeface="Latha"/>
+        <a:font script="Syrc" typeface="Estrangelo Edessa"/>
+        <a:font script="Orya" typeface="Kalinga"/>
+        <a:font script="Mlym" typeface="Kartika"/>
+        <a:font script="Laoo" typeface="DokChampa"/>
+        <a:font script="Sinh" typeface="Iskoola Pota"/>
+        <a:font script="Mong" typeface="Mongolian Baiti"/>
+        <a:font script="Viet" typeface="Times New Roman"/>
+        <a:font script="Uigh" typeface="Microsoft Uighur"/>
+        <a:font script="Geor" typeface="Sylfaen"/>
+      </a:majorFont>
+      <a:minorFont>
+        <a:latin typeface="Arial"/>
+        <a:ea typeface=""/>
+        <a:cs typeface=""/>
+        <a:font script="Jpan" typeface="ＭＳ Ｐゴシック"/>
+        <a:font script="Hang" typeface="맑은 고딕"/>
+        <a:font script="Hans" typeface="宋体"/>
+        <a:font script="Hant" typeface="新細明體"/>
+        <a:font script="Arab" typeface="Arial"/>
+        <a:font script="Hebr" typeface="Arial"/>
+        <a:font script="Thai" typeface="Cordia New"/>
+        <a:font script="Ethi" typeface="Nyala"/>
+        <a:font script="Beng" typeface="Vrinda"/>
+        <a:font script="Gujr" typeface="Shruti"/>
+        <a:font script="Khmr" typeface="DaunPenh"/>
+        <a:font script="Knda" typeface="Tunga"/>
+        <a:font script="Guru" typeface="Raavi"/>
+        <a:font script="Cans" typeface="Euphemia"/>
+        <a:font script="Cher" typeface="Plantagenet Cherokee"/>
+        <a:font script="Yiii" typeface="Microsoft Yi Baiti"/>
+        <a:font script="Tibt" typeface="Microsoft Himalaya"/>
+        <a:font script="Thaa" typeface="MV Boli"/>
+        <a:font script="Deva" typeface="Mangal"/>
+        <a:font script="Telu" typeface="Gautami"/>
+        <a:font script="Taml" typeface="Latha"/>
+        <a:font script="Syrc" typeface="Estrangelo Edessa"/>
+        <a:font script="Orya" typeface="Kalinga"/>
+        <a:font script="Mlym" typeface="Kartika"/>
+        <a:font script="Laoo" typeface="DokChampa"/>
+        <a:font script="Sinh" typeface="Iskoola Pota"/>
+        <a:font script="Mong" typeface="Mongolian Baiti"/>
+        <a:font script="Viet" typeface="Arial"/>
+        <a:font script="Uigh" typeface="Microsoft Uighur"/>
+        <a:font script="Geor" typeface="Sylfaen"/>
+      </a:minorFont>
+    </a:fontScheme>
+    <a:fmtScheme name="Office">
+      <a:fillStyleLst>
+        <a:solidFill>
+          <a:schemeClr val="phClr"/>
+        </a:solidFill>
+        <a:gradFill rotWithShape="1">
+          <a:gsLst>
+            <a:gs pos="0">
+              <a:schemeClr val="phClr">
+                <a:tint val="50000"/>
+                <a:satMod val="300000"/>
+              </a:schemeClr>
+            </a:gs>
+            <a:gs pos="35000">
+              <a:schemeClr val="phClr">
+                <a:tint val="37000"/>
+                <a:satMod val="300000"/>
+              </a:schemeClr>
+            </a:gs>
+            <a:gs pos="100000">
+              <a:schemeClr val="phClr">
+                <a:tint val="15000"/>
+                <a:satMod val="350000"/>
+              </a:schemeClr>
+            </a:gs>
+          </a:gsLst>
+          <a:lin ang="16200000" scaled="1"/>
+        </a:gradFill>
+        <a:gradFill rotWithShape="1">
+          <a:gsLst>
+            <a:gs pos="0">
+              <a:schemeClr val="phClr">
+                <a:tint val="100000"/>
+                <a:shade val="100000"/>
+                <a:satMod val="130000"/>
+              </a:schemeClr>
+            </a:gs>
+            <a:gs pos="100000">
+              <a:schemeClr val="phClr">
+                <a:tint val="50000"/>
+                <a:shade val="100000"/>
+                <a:satMod val="350000"/>
+              </a:schemeClr>
+            </a:gs>
+          </a:gsLst>
+          <a:lin ang="16200000" scaled="0"/>
+        </a:gradFill>
+      </a:fillStyleLst>
+      <a:lnStyleLst>
+        <a:ln w="9525" cap="flat" cmpd="sng" algn="ctr">
+          <a:solidFill>
+            <a:schemeClr val="phClr">
+              <a:shade val="95000"/>
+              <a:satMod val="105000"/>
+            </a:schemeClr>
+          </a:solidFill>
+          <a:prstDash val="solid"/>
+        </a:ln>
+        <a:ln w="25400" cap="flat" cmpd="sng" algn="ctr">
+          <a:solidFill>
+            <a:schemeClr val="phClr"/>
+          </a:solidFill>
+          <a:prstDash val="solid"/>
+        </a:ln>
+        <a:ln w="38100" cap="flat" cmpd="sng" algn="ctr">
+          <a:solidFill>
+            <a:schemeClr val="phClr"/>
+          </a:solidFill>
+          <a:prstDash val="solid"/>
+        </a:ln>
+      </a:lnStyleLst>
+      <a:effectStyleLst>
+        <a:effectStyle>
+          <a:effectLst>
+            <a:outerShdw blurRad="40000" dist="20000" dir="5400000" rotWithShape="0">
+              <a:srgbClr val="000000">
+                <a:alpha val="38000"/>
+              </a:srgbClr>
+            </a:outerShdw>
+          </a:effectLst>
+        </a:effectStyle>
+        <a:effectStyle>
+          <a:effectLst>
+            <a:outerShdw blurRad="40000" dist="23000" dir="5400000" rotWithShape="0">
+              <a:srgbClr val="000000">
+                <a:alpha val="35000"/>
+              </a:srgbClr>
+            </a:outerShdw>
+          </a:effectLst>
+        </a:effectStyle>
+        <a:effectStyle>
+          <a:effectLst>
+            <a:outerShdw blurRad="40000" dist="23000" dir="5400000" rotWithShape="0">
+              <a:srgbClr val="000000">
+                <a:alpha val="35000"/>
+              </a:srgbClr>
+            </a:outerShdw>
+          </a:effectLst>
+          <a:scene3d>
+            <a:camera prst="orthographicFront">
+              <a:rot lat="0" lon="0" rev="0"/>
+            </a:camera>
+            <a:lightRig rig="threePt" dir="t">
+              <a:rot lat="0" lon="0" rev="1200000"/>
+            </a:lightRig>
+          </a:scene3d>
+          <a:sp3d>
+            <a:bevelT w="63500" h="25400"/>
+          </a:sp3d>
+        </a:effectStyle>
+      </a:effectStyleLst>
+      <a:bgFillStyleLst>
+        <a:solidFill>
+          <a:schemeClr val="phClr"/>
+        </a:solidFill>
+        <a:gradFill rotWithShape="1">
+          <a:gsLst>
+            <a:gs pos="0">
+              <a:schemeClr val="phClr">
+                <a:tint val="40000"/>
+                <a:satMod val="350000"/>
+              </a:schemeClr>
+            </a:gs>
+            <a:gs pos="40000">
+              <a:schemeClr val="phClr">
+                <a:tint val="45000"/>
+                <a:shade val="99000"/>
+                <a:satMod val="350000"/>
+              </a:schemeClr>
+            </a:gs>
+            <a:gs pos="100000">
+              <a:schemeClr val="phClr">
+                <a:shade val="20000"/>
+                <a:satMod val="255000"/>
+              </a:schemeClr>
+            </a:gs>
+          </a:gsLst>
+          <a:path path="circle">
+            <a:fillToRect l="50000" t="-80000" r="50000" b="180000"/>
+          </a:path>
+        </a:gradFill>
+        <a:gradFill rotWithShape="1">
+          <a:gsLst>
+            <a:gs pos="0">
+              <a:schemeClr val="phClr">
+                <a:tint val="80000"/>
+                <a:satMod val="300000"/>
+              </a:schemeClr>
+            </a:gs>
+            <a:gs pos="100000">
+              <a:schemeClr val="phClr">
+                <a:shade val="30000"/>
+                <a:satMod val="200000"/>
+              </a:schemeClr>
+            </a:gs>
+          </a:gsLst>
+          <a:path path="circle">
+            <a:fillToRect l="50000" t="50000" r="50000" b="50000"/>
+          </a:path>
+        </a:gradFill>
+      </a:bgFillStyleLst>
+    </a:fmtScheme>
+  </a:themeElements>
+</a:theme>
+</file>
+
+<file path=ppt/theme/theme2.xml><?xml version="1.0" encoding="utf-8"?>
 <a:theme xmlns:a="http://schemas.openxmlformats.org/drawingml/2006/main" xmlns:r="http://schemas.openxmlformats.org/officeDocument/2006/relationships" name="LF Energy Theme 2023">
   <a:themeElements>
     <a:clrScheme name="Geometric">
@@ -34280,7 +34559,7 @@
 </a:theme>
 </file>
 
-<file path=ppt/theme/theme2.xml><?xml version="1.0" encoding="utf-8"?>
+<file path=ppt/theme/theme3.xml><?xml version="1.0" encoding="utf-8"?>
 <a:theme xmlns:a="http://schemas.openxmlformats.org/drawingml/2006/main" xmlns:r="http://schemas.openxmlformats.org/officeDocument/2006/relationships" name="Simple Light">
   <a:themeElements>
     <a:clrScheme name="Simple Light">
@@ -34557,283 +34836,4 @@
     </a:fmtScheme>
   </a:themeElements>
 </a:theme>
-</file>
-
-<file path=ppt/theme/theme3.xml><?xml version="1.0" encoding="utf-8"?>
-<a:theme xmlns:a="http://schemas.openxmlformats.org/drawingml/2006/main" xmlns:r="http://schemas.openxmlformats.org/officeDocument/2006/relationships">
-  <a:themeElements>
-    <a:clrScheme name="Default">
-      <a:dk1>
-        <a:srgbClr val="000000"/>
-      </a:dk1>
-      <a:lt1>
-        <a:srgbClr val="FFFFFF"/>
-      </a:lt1>
-      <a:dk2>
-        <a:srgbClr val="158158"/>
-      </a:dk2>
-      <a:lt2>
-        <a:srgbClr val="F3F3F3"/>
-      </a:lt2>
-      <a:accent1>
-        <a:srgbClr val="058DC7"/>
-      </a:accent1>
-      <a:accent2>
-        <a:srgbClr val="50B432"/>
-      </a:accent2>
-      <a:accent3>
-        <a:srgbClr val="ED561B"/>
-      </a:accent3>
-      <a:accent4>
-        <a:srgbClr val="EDEF00"/>
-      </a:accent4>
-      <a:accent5>
-        <a:srgbClr val="24CBE5"/>
-      </a:accent5>
-      <a:accent6>
-        <a:srgbClr val="64E572"/>
-      </a:accent6>
-      <a:hlink>
-        <a:srgbClr val="2200CC"/>
-      </a:hlink>
-      <a:folHlink>
-        <a:srgbClr val="551A8B"/>
-      </a:folHlink>
-    </a:clrScheme>
-    <a:fontScheme name="Office">
-      <a:majorFont>
-        <a:latin typeface="Arial"/>
-        <a:ea typeface=""/>
-        <a:cs typeface=""/>
-        <a:font script="Jpan" typeface="ＭＳ Ｐゴシック"/>
-        <a:font script="Hang" typeface="맑은 고딕"/>
-        <a:font script="Hans" typeface="宋体"/>
-        <a:font script="Hant" typeface="新細明體"/>
-        <a:font script="Arab" typeface="Times New Roman"/>
-        <a:font script="Hebr" typeface="Times New Roman"/>
-        <a:font script="Thai" typeface="Angsana New"/>
-        <a:font script="Ethi" typeface="Nyala"/>
-        <a:font script="Beng" typeface="Vrinda"/>
-        <a:font script="Gujr" typeface="Shruti"/>
-        <a:font script="Khmr" typeface="MoolBoran"/>
-        <a:font script="Knda" typeface="Tunga"/>
-        <a:font script="Guru" typeface="Raavi"/>
-        <a:font script="Cans" typeface="Euphemia"/>
-        <a:font script="Cher" typeface="Plantagenet Cherokee"/>
-        <a:font script="Yiii" typeface="Microsoft Yi Baiti"/>
-        <a:font script="Tibt" typeface="Microsoft Himalaya"/>
-        <a:font script="Thaa" typeface="MV Boli"/>
-        <a:font script="Deva" typeface="Mangal"/>
-        <a:font script="Telu" typeface="Gautami"/>
-        <a:font script="Taml" typeface="Latha"/>
-        <a:font script="Syrc" typeface="Estrangelo Edessa"/>
-        <a:font script="Orya" typeface="Kalinga"/>
-        <a:font script="Mlym" typeface="Kartika"/>
-        <a:font script="Laoo" typeface="DokChampa"/>
-        <a:font script="Sinh" typeface="Iskoola Pota"/>
-        <a:font script="Mong" typeface="Mongolian Baiti"/>
-        <a:font script="Viet" typeface="Times New Roman"/>
-        <a:font script="Uigh" typeface="Microsoft Uighur"/>
-        <a:font script="Geor" typeface="Sylfaen"/>
-      </a:majorFont>
-      <a:minorFont>
-        <a:latin typeface="Arial"/>
-        <a:ea typeface=""/>
-        <a:cs typeface=""/>
-        <a:font script="Jpan" typeface="ＭＳ Ｐゴシック"/>
-        <a:font script="Hang" typeface="맑은 고딕"/>
-        <a:font script="Hans" typeface="宋体"/>
-        <a:font script="Hant" typeface="新細明體"/>
-        <a:font script="Arab" typeface="Arial"/>
-        <a:font script="Hebr" typeface="Arial"/>
-        <a:font script="Thai" typeface="Cordia New"/>
-        <a:font script="Ethi" typeface="Nyala"/>
-        <a:font script="Beng" typeface="Vrinda"/>
-        <a:font script="Gujr" typeface="Shruti"/>
-        <a:font script="Khmr" typeface="DaunPenh"/>
-        <a:font script="Knda" typeface="Tunga"/>
-        <a:font script="Guru" typeface="Raavi"/>
-        <a:font script="Cans" typeface="Euphemia"/>
-        <a:font script="Cher" typeface="Plantagenet Cherokee"/>
-        <a:font script="Yiii" typeface="Microsoft Yi Baiti"/>
-        <a:font script="Tibt" typeface="Microsoft Himalaya"/>
-        <a:font script="Thaa" typeface="MV Boli"/>
-        <a:font script="Deva" typeface="Mangal"/>
-        <a:font script="Telu" typeface="Gautami"/>
-        <a:font script="Taml" typeface="Latha"/>
-        <a:font script="Syrc" typeface="Estrangelo Edessa"/>
-        <a:font script="Orya" typeface="Kalinga"/>
-        <a:font script="Mlym" typeface="Kartika"/>
-        <a:font script="Laoo" typeface="DokChampa"/>
-        <a:font script="Sinh" typeface="Iskoola Pota"/>
-        <a:font script="Mong" typeface="Mongolian Baiti"/>
-        <a:font script="Viet" typeface="Arial"/>
-        <a:font script="Uigh" typeface="Microsoft Uighur"/>
-        <a:font script="Geor" typeface="Sylfaen"/>
-      </a:minorFont>
-    </a:fontScheme>
-    <a:fmtScheme name="Office">
-      <a:fillStyleLst>
-        <a:solidFill>
-          <a:schemeClr val="phClr"/>
-        </a:solidFill>
-        <a:gradFill rotWithShape="1">
-          <a:gsLst>
-            <a:gs pos="0">
-              <a:schemeClr val="phClr">
-                <a:tint val="50000"/>
-                <a:satMod val="300000"/>
-              </a:schemeClr>
-            </a:gs>
-            <a:gs pos="35000">
-              <a:schemeClr val="phClr">
-                <a:tint val="37000"/>
-                <a:satMod val="300000"/>
-              </a:schemeClr>
-            </a:gs>
-            <a:gs pos="100000">
-              <a:schemeClr val="phClr">
-                <a:tint val="15000"/>
-                <a:satMod val="350000"/>
-              </a:schemeClr>
-            </a:gs>
-          </a:gsLst>
-          <a:lin ang="16200000" scaled="1"/>
-        </a:gradFill>
-        <a:gradFill rotWithShape="1">
-          <a:gsLst>
-            <a:gs pos="0">
-              <a:schemeClr val="phClr">
-                <a:tint val="100000"/>
-                <a:shade val="100000"/>
-                <a:satMod val="130000"/>
-              </a:schemeClr>
-            </a:gs>
-            <a:gs pos="100000">
-              <a:schemeClr val="phClr">
-                <a:tint val="50000"/>
-                <a:shade val="100000"/>
-                <a:satMod val="350000"/>
-              </a:schemeClr>
-            </a:gs>
-          </a:gsLst>
-          <a:lin ang="16200000" scaled="0"/>
-        </a:gradFill>
-      </a:fillStyleLst>
-      <a:lnStyleLst>
-        <a:ln w="9525" cap="flat" cmpd="sng" algn="ctr">
-          <a:solidFill>
-            <a:schemeClr val="phClr">
-              <a:shade val="95000"/>
-              <a:satMod val="105000"/>
-            </a:schemeClr>
-          </a:solidFill>
-          <a:prstDash val="solid"/>
-        </a:ln>
-        <a:ln w="25400" cap="flat" cmpd="sng" algn="ctr">
-          <a:solidFill>
-            <a:schemeClr val="phClr"/>
-          </a:solidFill>
-          <a:prstDash val="solid"/>
-        </a:ln>
-        <a:ln w="38100" cap="flat" cmpd="sng" algn="ctr">
-          <a:solidFill>
-            <a:schemeClr val="phClr"/>
-          </a:solidFill>
-          <a:prstDash val="solid"/>
-        </a:ln>
-      </a:lnStyleLst>
-      <a:effectStyleLst>
-        <a:effectStyle>
-          <a:effectLst>
-            <a:outerShdw blurRad="40000" dist="20000" dir="5400000" rotWithShape="0">
-              <a:srgbClr val="000000">
-                <a:alpha val="38000"/>
-              </a:srgbClr>
-            </a:outerShdw>
-          </a:effectLst>
-        </a:effectStyle>
-        <a:effectStyle>
-          <a:effectLst>
-            <a:outerShdw blurRad="40000" dist="23000" dir="5400000" rotWithShape="0">
-              <a:srgbClr val="000000">
-                <a:alpha val="35000"/>
-              </a:srgbClr>
-            </a:outerShdw>
-          </a:effectLst>
-        </a:effectStyle>
-        <a:effectStyle>
-          <a:effectLst>
-            <a:outerShdw blurRad="40000" dist="23000" dir="5400000" rotWithShape="0">
-              <a:srgbClr val="000000">
-                <a:alpha val="35000"/>
-              </a:srgbClr>
-            </a:outerShdw>
-          </a:effectLst>
-          <a:scene3d>
-            <a:camera prst="orthographicFront">
-              <a:rot lat="0" lon="0" rev="0"/>
-            </a:camera>
-            <a:lightRig rig="threePt" dir="t">
-              <a:rot lat="0" lon="0" rev="1200000"/>
-            </a:lightRig>
-          </a:scene3d>
-          <a:sp3d>
-            <a:bevelT w="63500" h="25400"/>
-          </a:sp3d>
-        </a:effectStyle>
-      </a:effectStyleLst>
-      <a:bgFillStyleLst>
-        <a:solidFill>
-          <a:schemeClr val="phClr"/>
-        </a:solidFill>
-        <a:gradFill rotWithShape="1">
-          <a:gsLst>
-            <a:gs pos="0">
-              <a:schemeClr val="phClr">
-                <a:tint val="40000"/>
-                <a:satMod val="350000"/>
-              </a:schemeClr>
-            </a:gs>
-            <a:gs pos="40000">
-              <a:schemeClr val="phClr">
-                <a:tint val="45000"/>
-                <a:shade val="99000"/>
-                <a:satMod val="350000"/>
-              </a:schemeClr>
-            </a:gs>
-            <a:gs pos="100000">
-              <a:schemeClr val="phClr">
-                <a:shade val="20000"/>
-                <a:satMod val="255000"/>
-              </a:schemeClr>
-            </a:gs>
-          </a:gsLst>
-          <a:path path="circle">
-            <a:fillToRect l="50000" t="-80000" r="50000" b="180000"/>
-          </a:path>
-        </a:gradFill>
-        <a:gradFill rotWithShape="1">
-          <a:gsLst>
-            <a:gs pos="0">
-              <a:schemeClr val="phClr">
-                <a:tint val="80000"/>
-                <a:satMod val="300000"/>
-              </a:schemeClr>
-            </a:gs>
-            <a:gs pos="100000">
-              <a:schemeClr val="phClr">
-                <a:shade val="30000"/>
-                <a:satMod val="200000"/>
-              </a:schemeClr>
-            </a:gs>
-          </a:gsLst>
-          <a:path path="circle">
-            <a:fillToRect l="50000" t="50000" r="50000" b="50000"/>
-          </a:path>
-        </a:gradFill>
-      </a:bgFillStyleLst>
-    </a:fmtScheme>
-  </a:themeElements>
-</a:theme>
 </file>
</xml_diff>

<commit_message>
Update Data Sources from LFX 2026-10-13 (#340)
Update Data Sources from LFX

Signed-off-by: github-actions[bot] <41898282+github-actions[bot]@users.noreply.github.com>
Co-authored-by: jmertic <296737+jmertic@users.noreply.github.com>
</commit_message>
<xml_diff>
--- a/overview_deck/LF Energy High Level Overview.pptx
+++ b/overview_deck/LF Energy High Level Overview.pptx
@@ -25946,7 +25946,7 @@
             <a:tbl>
               <a:tblPr>
                 <a:noFill/>
-                <a:tableStyleId>{34942F2D-3CFE-4843-A63F-DCE921DA8480}</a:tableStyleId>
+                <a:tableStyleId>{79EED69C-6B42-446E-B878-0199D09D1945}</a:tableStyleId>
               </a:tblPr>
               <a:tblGrid>
                 <a:gridCol w="1695200"/>
@@ -26736,7 +26736,7 @@
             <a:tbl>
               <a:tblPr>
                 <a:noFill/>
-                <a:tableStyleId>{34942F2D-3CFE-4843-A63F-DCE921DA8480}</a:tableStyleId>
+                <a:tableStyleId>{79EED69C-6B42-446E-B878-0199D09D1945}</a:tableStyleId>
               </a:tblPr>
               <a:tblGrid>
                 <a:gridCol w="1695200"/>
@@ -27426,7 +27426,7 @@
             <a:tbl>
               <a:tblPr>
                 <a:noFill/>
-                <a:tableStyleId>{34942F2D-3CFE-4843-A63F-DCE921DA8480}</a:tableStyleId>
+                <a:tableStyleId>{79EED69C-6B42-446E-B878-0199D09D1945}</a:tableStyleId>
               </a:tblPr>
               <a:tblGrid>
                 <a:gridCol w="1695200"/>
@@ -28678,7 +28678,7 @@
             <a:tbl>
               <a:tblPr>
                 <a:noFill/>
-                <a:tableStyleId>{34942F2D-3CFE-4843-A63F-DCE921DA8480}</a:tableStyleId>
+                <a:tableStyleId>{79EED69C-6B42-446E-B878-0199D09D1945}</a:tableStyleId>
               </a:tblPr>
               <a:tblGrid>
                 <a:gridCol w="1695200"/>
@@ -29670,7 +29670,7 @@
             <a:tbl>
               <a:tblPr>
                 <a:noFill/>
-                <a:tableStyleId>{34942F2D-3CFE-4843-A63F-DCE921DA8480}</a:tableStyleId>
+                <a:tableStyleId>{79EED69C-6B42-446E-B878-0199D09D1945}</a:tableStyleId>
               </a:tblPr>
               <a:tblGrid>
                 <a:gridCol w="3048000"/>
@@ -33175,7 +33175,7 @@
             <a:tbl>
               <a:tblPr>
                 <a:noFill/>
-                <a:tableStyleId>{34942F2D-3CFE-4843-A63F-DCE921DA8480}</a:tableStyleId>
+                <a:tableStyleId>{79EED69C-6B42-446E-B878-0199D09D1945}</a:tableStyleId>
               </a:tblPr>
               <a:tblGrid>
                 <a:gridCol w="1828800"/>
@@ -34002,6 +34002,285 @@
 </file>
 
 <file path=ppt/theme/theme1.xml><?xml version="1.0" encoding="utf-8"?>
+<a:theme xmlns:a="http://schemas.openxmlformats.org/drawingml/2006/main" xmlns:r="http://schemas.openxmlformats.org/officeDocument/2006/relationships" name="Simple Light">
+  <a:themeElements>
+    <a:clrScheme name="Simple Light">
+      <a:dk1>
+        <a:srgbClr val="000000"/>
+      </a:dk1>
+      <a:lt1>
+        <a:srgbClr val="FFFFFF"/>
+      </a:lt1>
+      <a:dk2>
+        <a:srgbClr val="595959"/>
+      </a:dk2>
+      <a:lt2>
+        <a:srgbClr val="EEEEEE"/>
+      </a:lt2>
+      <a:accent1>
+        <a:srgbClr val="4285F4"/>
+      </a:accent1>
+      <a:accent2>
+        <a:srgbClr val="212121"/>
+      </a:accent2>
+      <a:accent3>
+        <a:srgbClr val="78909C"/>
+      </a:accent3>
+      <a:accent4>
+        <a:srgbClr val="FFAB40"/>
+      </a:accent4>
+      <a:accent5>
+        <a:srgbClr val="0097A7"/>
+      </a:accent5>
+      <a:accent6>
+        <a:srgbClr val="EEFF41"/>
+      </a:accent6>
+      <a:hlink>
+        <a:srgbClr val="0097A7"/>
+      </a:hlink>
+      <a:folHlink>
+        <a:srgbClr val="0097A7"/>
+      </a:folHlink>
+    </a:clrScheme>
+    <a:fontScheme name="Office">
+      <a:majorFont>
+        <a:latin typeface="Arial"/>
+        <a:ea typeface=""/>
+        <a:cs typeface=""/>
+        <a:font script="Jpan" typeface="ＭＳ Ｐゴシック"/>
+        <a:font script="Hang" typeface="맑은 고딕"/>
+        <a:font script="Hans" typeface="宋体"/>
+        <a:font script="Hant" typeface="新細明體"/>
+        <a:font script="Arab" typeface="Times New Roman"/>
+        <a:font script="Hebr" typeface="Times New Roman"/>
+        <a:font script="Thai" typeface="Angsana New"/>
+        <a:font script="Ethi" typeface="Nyala"/>
+        <a:font script="Beng" typeface="Vrinda"/>
+        <a:font script="Gujr" typeface="Shruti"/>
+        <a:font script="Khmr" typeface="MoolBoran"/>
+        <a:font script="Knda" typeface="Tunga"/>
+        <a:font script="Guru" typeface="Raavi"/>
+        <a:font script="Cans" typeface="Euphemia"/>
+        <a:font script="Cher" typeface="Plantagenet Cherokee"/>
+        <a:font script="Yiii" typeface="Microsoft Yi Baiti"/>
+        <a:font script="Tibt" typeface="Microsoft Himalaya"/>
+        <a:font script="Thaa" typeface="MV Boli"/>
+        <a:font script="Deva" typeface="Mangal"/>
+        <a:font script="Telu" typeface="Gautami"/>
+        <a:font script="Taml" typeface="Latha"/>
+        <a:font script="Syrc" typeface="Estrangelo Edessa"/>
+        <a:font script="Orya" typeface="Kalinga"/>
+        <a:font script="Mlym" typeface="Kartika"/>
+        <a:font script="Laoo" typeface="DokChampa"/>
+        <a:font script="Sinh" typeface="Iskoola Pota"/>
+        <a:font script="Mong" typeface="Mongolian Baiti"/>
+        <a:font script="Viet" typeface="Times New Roman"/>
+        <a:font script="Uigh" typeface="Microsoft Uighur"/>
+        <a:font script="Geor" typeface="Sylfaen"/>
+      </a:majorFont>
+      <a:minorFont>
+        <a:latin typeface="Arial"/>
+        <a:ea typeface=""/>
+        <a:cs typeface=""/>
+        <a:font script="Jpan" typeface="ＭＳ Ｐゴシック"/>
+        <a:font script="Hang" typeface="맑은 고딕"/>
+        <a:font script="Hans" typeface="宋体"/>
+        <a:font script="Hant" typeface="新細明體"/>
+        <a:font script="Arab" typeface="Arial"/>
+        <a:font script="Hebr" typeface="Arial"/>
+        <a:font script="Thai" typeface="Cordia New"/>
+        <a:font script="Ethi" typeface="Nyala"/>
+        <a:font script="Beng" typeface="Vrinda"/>
+        <a:font script="Gujr" typeface="Shruti"/>
+        <a:font script="Khmr" typeface="DaunPenh"/>
+        <a:font script="Knda" typeface="Tunga"/>
+        <a:font script="Guru" typeface="Raavi"/>
+        <a:font script="Cans" typeface="Euphemia"/>
+        <a:font script="Cher" typeface="Plantagenet Cherokee"/>
+        <a:font script="Yiii" typeface="Microsoft Yi Baiti"/>
+        <a:font script="Tibt" typeface="Microsoft Himalaya"/>
+        <a:font script="Thaa" typeface="MV Boli"/>
+        <a:font script="Deva" typeface="Mangal"/>
+        <a:font script="Telu" typeface="Gautami"/>
+        <a:font script="Taml" typeface="Latha"/>
+        <a:font script="Syrc" typeface="Estrangelo Edessa"/>
+        <a:font script="Orya" typeface="Kalinga"/>
+        <a:font script="Mlym" typeface="Kartika"/>
+        <a:font script="Laoo" typeface="DokChampa"/>
+        <a:font script="Sinh" typeface="Iskoola Pota"/>
+        <a:font script="Mong" typeface="Mongolian Baiti"/>
+        <a:font script="Viet" typeface="Arial"/>
+        <a:font script="Uigh" typeface="Microsoft Uighur"/>
+        <a:font script="Geor" typeface="Sylfaen"/>
+      </a:minorFont>
+    </a:fontScheme>
+    <a:fmtScheme name="Office">
+      <a:fillStyleLst>
+        <a:solidFill>
+          <a:schemeClr val="phClr"/>
+        </a:solidFill>
+        <a:gradFill rotWithShape="1">
+          <a:gsLst>
+            <a:gs pos="0">
+              <a:schemeClr val="phClr">
+                <a:tint val="50000"/>
+                <a:satMod val="300000"/>
+              </a:schemeClr>
+            </a:gs>
+            <a:gs pos="35000">
+              <a:schemeClr val="phClr">
+                <a:tint val="37000"/>
+                <a:satMod val="300000"/>
+              </a:schemeClr>
+            </a:gs>
+            <a:gs pos="100000">
+              <a:schemeClr val="phClr">
+                <a:tint val="15000"/>
+                <a:satMod val="350000"/>
+              </a:schemeClr>
+            </a:gs>
+          </a:gsLst>
+          <a:lin ang="16200000" scaled="1"/>
+        </a:gradFill>
+        <a:gradFill rotWithShape="1">
+          <a:gsLst>
+            <a:gs pos="0">
+              <a:schemeClr val="phClr">
+                <a:tint val="100000"/>
+                <a:shade val="100000"/>
+                <a:satMod val="130000"/>
+              </a:schemeClr>
+            </a:gs>
+            <a:gs pos="100000">
+              <a:schemeClr val="phClr">
+                <a:tint val="50000"/>
+                <a:shade val="100000"/>
+                <a:satMod val="350000"/>
+              </a:schemeClr>
+            </a:gs>
+          </a:gsLst>
+          <a:lin ang="16200000" scaled="0"/>
+        </a:gradFill>
+      </a:fillStyleLst>
+      <a:lnStyleLst>
+        <a:ln w="9525" cap="flat" cmpd="sng" algn="ctr">
+          <a:solidFill>
+            <a:schemeClr val="phClr">
+              <a:shade val="95000"/>
+              <a:satMod val="105000"/>
+            </a:schemeClr>
+          </a:solidFill>
+          <a:prstDash val="solid"/>
+        </a:ln>
+        <a:ln w="25400" cap="flat" cmpd="sng" algn="ctr">
+          <a:solidFill>
+            <a:schemeClr val="phClr"/>
+          </a:solidFill>
+          <a:prstDash val="solid"/>
+        </a:ln>
+        <a:ln w="38100" cap="flat" cmpd="sng" algn="ctr">
+          <a:solidFill>
+            <a:schemeClr val="phClr"/>
+          </a:solidFill>
+          <a:prstDash val="solid"/>
+        </a:ln>
+      </a:lnStyleLst>
+      <a:effectStyleLst>
+        <a:effectStyle>
+          <a:effectLst>
+            <a:outerShdw blurRad="40000" dist="20000" dir="5400000" rotWithShape="0">
+              <a:srgbClr val="000000">
+                <a:alpha val="38000"/>
+              </a:srgbClr>
+            </a:outerShdw>
+          </a:effectLst>
+        </a:effectStyle>
+        <a:effectStyle>
+          <a:effectLst>
+            <a:outerShdw blurRad="40000" dist="23000" dir="5400000" rotWithShape="0">
+              <a:srgbClr val="000000">
+                <a:alpha val="35000"/>
+              </a:srgbClr>
+            </a:outerShdw>
+          </a:effectLst>
+        </a:effectStyle>
+        <a:effectStyle>
+          <a:effectLst>
+            <a:outerShdw blurRad="40000" dist="23000" dir="5400000" rotWithShape="0">
+              <a:srgbClr val="000000">
+                <a:alpha val="35000"/>
+              </a:srgbClr>
+            </a:outerShdw>
+          </a:effectLst>
+          <a:scene3d>
+            <a:camera prst="orthographicFront">
+              <a:rot lat="0" lon="0" rev="0"/>
+            </a:camera>
+            <a:lightRig rig="threePt" dir="t">
+              <a:rot lat="0" lon="0" rev="1200000"/>
+            </a:lightRig>
+          </a:scene3d>
+          <a:sp3d>
+            <a:bevelT w="63500" h="25400"/>
+          </a:sp3d>
+        </a:effectStyle>
+      </a:effectStyleLst>
+      <a:bgFillStyleLst>
+        <a:solidFill>
+          <a:schemeClr val="phClr"/>
+        </a:solidFill>
+        <a:gradFill rotWithShape="1">
+          <a:gsLst>
+            <a:gs pos="0">
+              <a:schemeClr val="phClr">
+                <a:tint val="40000"/>
+                <a:satMod val="350000"/>
+              </a:schemeClr>
+            </a:gs>
+            <a:gs pos="40000">
+              <a:schemeClr val="phClr">
+                <a:tint val="45000"/>
+                <a:shade val="99000"/>
+                <a:satMod val="350000"/>
+              </a:schemeClr>
+            </a:gs>
+            <a:gs pos="100000">
+              <a:schemeClr val="phClr">
+                <a:shade val="20000"/>
+                <a:satMod val="255000"/>
+              </a:schemeClr>
+            </a:gs>
+          </a:gsLst>
+          <a:path path="circle">
+            <a:fillToRect l="50000" t="-80000" r="50000" b="180000"/>
+          </a:path>
+        </a:gradFill>
+        <a:gradFill rotWithShape="1">
+          <a:gsLst>
+            <a:gs pos="0">
+              <a:schemeClr val="phClr">
+                <a:tint val="80000"/>
+                <a:satMod val="300000"/>
+              </a:schemeClr>
+            </a:gs>
+            <a:gs pos="100000">
+              <a:schemeClr val="phClr">
+                <a:shade val="30000"/>
+                <a:satMod val="200000"/>
+              </a:schemeClr>
+            </a:gs>
+          </a:gsLst>
+          <a:path path="circle">
+            <a:fillToRect l="50000" t="50000" r="50000" b="50000"/>
+          </a:path>
+        </a:gradFill>
+      </a:bgFillStyleLst>
+    </a:fmtScheme>
+  </a:themeElements>
+</a:theme>
+</file>
+
+<file path=ppt/theme/theme2.xml><?xml version="1.0" encoding="utf-8"?>
 <a:theme xmlns:a="http://schemas.openxmlformats.org/drawingml/2006/main" xmlns:r="http://schemas.openxmlformats.org/officeDocument/2006/relationships">
   <a:themeElements>
     <a:clrScheme name="Default">
@@ -34280,7 +34559,7 @@
 </a:theme>
 </file>
 
-<file path=ppt/theme/theme2.xml><?xml version="1.0" encoding="utf-8"?>
+<file path=ppt/theme/theme3.xml><?xml version="1.0" encoding="utf-8"?>
 <a:theme xmlns:a="http://schemas.openxmlformats.org/drawingml/2006/main" xmlns:r="http://schemas.openxmlformats.org/officeDocument/2006/relationships" name="LF Energy Theme 2023">
   <a:themeElements>
     <a:clrScheme name="Geometric">
@@ -34557,283 +34836,4 @@
     </a:fmtScheme>
   </a:themeElements>
 </a:theme>
-</file>
-
-<file path=ppt/theme/theme3.xml><?xml version="1.0" encoding="utf-8"?>
-<a:theme xmlns:a="http://schemas.openxmlformats.org/drawingml/2006/main" xmlns:r="http://schemas.openxmlformats.org/officeDocument/2006/relationships" name="Simple Light">
-  <a:themeElements>
-    <a:clrScheme name="Simple Light">
-      <a:dk1>
-        <a:srgbClr val="000000"/>
-      </a:dk1>
-      <a:lt1>
-        <a:srgbClr val="FFFFFF"/>
-      </a:lt1>
-      <a:dk2>
-        <a:srgbClr val="595959"/>
-      </a:dk2>
-      <a:lt2>
-        <a:srgbClr val="EEEEEE"/>
-      </a:lt2>
-      <a:accent1>
-        <a:srgbClr val="4285F4"/>
-      </a:accent1>
-      <a:accent2>
-        <a:srgbClr val="212121"/>
-      </a:accent2>
-      <a:accent3>
-        <a:srgbClr val="78909C"/>
-      </a:accent3>
-      <a:accent4>
-        <a:srgbClr val="FFAB40"/>
-      </a:accent4>
-      <a:accent5>
-        <a:srgbClr val="0097A7"/>
-      </a:accent5>
-      <a:accent6>
-        <a:srgbClr val="EEFF41"/>
-      </a:accent6>
-      <a:hlink>
-        <a:srgbClr val="0097A7"/>
-      </a:hlink>
-      <a:folHlink>
-        <a:srgbClr val="0097A7"/>
-      </a:folHlink>
-    </a:clrScheme>
-    <a:fontScheme name="Office">
-      <a:majorFont>
-        <a:latin typeface="Arial"/>
-        <a:ea typeface=""/>
-        <a:cs typeface=""/>
-        <a:font script="Jpan" typeface="ＭＳ Ｐゴシック"/>
-        <a:font script="Hang" typeface="맑은 고딕"/>
-        <a:font script="Hans" typeface="宋体"/>
-        <a:font script="Hant" typeface="新細明體"/>
-        <a:font script="Arab" typeface="Times New Roman"/>
-        <a:font script="Hebr" typeface="Times New Roman"/>
-        <a:font script="Thai" typeface="Angsana New"/>
-        <a:font script="Ethi" typeface="Nyala"/>
-        <a:font script="Beng" typeface="Vrinda"/>
-        <a:font script="Gujr" typeface="Shruti"/>
-        <a:font script="Khmr" typeface="MoolBoran"/>
-        <a:font script="Knda" typeface="Tunga"/>
-        <a:font script="Guru" typeface="Raavi"/>
-        <a:font script="Cans" typeface="Euphemia"/>
-        <a:font script="Cher" typeface="Plantagenet Cherokee"/>
-        <a:font script="Yiii" typeface="Microsoft Yi Baiti"/>
-        <a:font script="Tibt" typeface="Microsoft Himalaya"/>
-        <a:font script="Thaa" typeface="MV Boli"/>
-        <a:font script="Deva" typeface="Mangal"/>
-        <a:font script="Telu" typeface="Gautami"/>
-        <a:font script="Taml" typeface="Latha"/>
-        <a:font script="Syrc" typeface="Estrangelo Edessa"/>
-        <a:font script="Orya" typeface="Kalinga"/>
-        <a:font script="Mlym" typeface="Kartika"/>
-        <a:font script="Laoo" typeface="DokChampa"/>
-        <a:font script="Sinh" typeface="Iskoola Pota"/>
-        <a:font script="Mong" typeface="Mongolian Baiti"/>
-        <a:font script="Viet" typeface="Times New Roman"/>
-        <a:font script="Uigh" typeface="Microsoft Uighur"/>
-        <a:font script="Geor" typeface="Sylfaen"/>
-      </a:majorFont>
-      <a:minorFont>
-        <a:latin typeface="Arial"/>
-        <a:ea typeface=""/>
-        <a:cs typeface=""/>
-        <a:font script="Jpan" typeface="ＭＳ Ｐゴシック"/>
-        <a:font script="Hang" typeface="맑은 고딕"/>
-        <a:font script="Hans" typeface="宋体"/>
-        <a:font script="Hant" typeface="新細明體"/>
-        <a:font script="Arab" typeface="Arial"/>
-        <a:font script="Hebr" typeface="Arial"/>
-        <a:font script="Thai" typeface="Cordia New"/>
-        <a:font script="Ethi" typeface="Nyala"/>
-        <a:font script="Beng" typeface="Vrinda"/>
-        <a:font script="Gujr" typeface="Shruti"/>
-        <a:font script="Khmr" typeface="DaunPenh"/>
-        <a:font script="Knda" typeface="Tunga"/>
-        <a:font script="Guru" typeface="Raavi"/>
-        <a:font script="Cans" typeface="Euphemia"/>
-        <a:font script="Cher" typeface="Plantagenet Cherokee"/>
-        <a:font script="Yiii" typeface="Microsoft Yi Baiti"/>
-        <a:font script="Tibt" typeface="Microsoft Himalaya"/>
-        <a:font script="Thaa" typeface="MV Boli"/>
-        <a:font script="Deva" typeface="Mangal"/>
-        <a:font script="Telu" typeface="Gautami"/>
-        <a:font script="Taml" typeface="Latha"/>
-        <a:font script="Syrc" typeface="Estrangelo Edessa"/>
-        <a:font script="Orya" typeface="Kalinga"/>
-        <a:font script="Mlym" typeface="Kartika"/>
-        <a:font script="Laoo" typeface="DokChampa"/>
-        <a:font script="Sinh" typeface="Iskoola Pota"/>
-        <a:font script="Mong" typeface="Mongolian Baiti"/>
-        <a:font script="Viet" typeface="Arial"/>
-        <a:font script="Uigh" typeface="Microsoft Uighur"/>
-        <a:font script="Geor" typeface="Sylfaen"/>
-      </a:minorFont>
-    </a:fontScheme>
-    <a:fmtScheme name="Office">
-      <a:fillStyleLst>
-        <a:solidFill>
-          <a:schemeClr val="phClr"/>
-        </a:solidFill>
-        <a:gradFill rotWithShape="1">
-          <a:gsLst>
-            <a:gs pos="0">
-              <a:schemeClr val="phClr">
-                <a:tint val="50000"/>
-                <a:satMod val="300000"/>
-              </a:schemeClr>
-            </a:gs>
-            <a:gs pos="35000">
-              <a:schemeClr val="phClr">
-                <a:tint val="37000"/>
-                <a:satMod val="300000"/>
-              </a:schemeClr>
-            </a:gs>
-            <a:gs pos="100000">
-              <a:schemeClr val="phClr">
-                <a:tint val="15000"/>
-                <a:satMod val="350000"/>
-              </a:schemeClr>
-            </a:gs>
-          </a:gsLst>
-          <a:lin ang="16200000" scaled="1"/>
-        </a:gradFill>
-        <a:gradFill rotWithShape="1">
-          <a:gsLst>
-            <a:gs pos="0">
-              <a:schemeClr val="phClr">
-                <a:tint val="100000"/>
-                <a:shade val="100000"/>
-                <a:satMod val="130000"/>
-              </a:schemeClr>
-            </a:gs>
-            <a:gs pos="100000">
-              <a:schemeClr val="phClr">
-                <a:tint val="50000"/>
-                <a:shade val="100000"/>
-                <a:satMod val="350000"/>
-              </a:schemeClr>
-            </a:gs>
-          </a:gsLst>
-          <a:lin ang="16200000" scaled="0"/>
-        </a:gradFill>
-      </a:fillStyleLst>
-      <a:lnStyleLst>
-        <a:ln w="9525" cap="flat" cmpd="sng" algn="ctr">
-          <a:solidFill>
-            <a:schemeClr val="phClr">
-              <a:shade val="95000"/>
-              <a:satMod val="105000"/>
-            </a:schemeClr>
-          </a:solidFill>
-          <a:prstDash val="solid"/>
-        </a:ln>
-        <a:ln w="25400" cap="flat" cmpd="sng" algn="ctr">
-          <a:solidFill>
-            <a:schemeClr val="phClr"/>
-          </a:solidFill>
-          <a:prstDash val="solid"/>
-        </a:ln>
-        <a:ln w="38100" cap="flat" cmpd="sng" algn="ctr">
-          <a:solidFill>
-            <a:schemeClr val="phClr"/>
-          </a:solidFill>
-          <a:prstDash val="solid"/>
-        </a:ln>
-      </a:lnStyleLst>
-      <a:effectStyleLst>
-        <a:effectStyle>
-          <a:effectLst>
-            <a:outerShdw blurRad="40000" dist="20000" dir="5400000" rotWithShape="0">
-              <a:srgbClr val="000000">
-                <a:alpha val="38000"/>
-              </a:srgbClr>
-            </a:outerShdw>
-          </a:effectLst>
-        </a:effectStyle>
-        <a:effectStyle>
-          <a:effectLst>
-            <a:outerShdw blurRad="40000" dist="23000" dir="5400000" rotWithShape="0">
-              <a:srgbClr val="000000">
-                <a:alpha val="35000"/>
-              </a:srgbClr>
-            </a:outerShdw>
-          </a:effectLst>
-        </a:effectStyle>
-        <a:effectStyle>
-          <a:effectLst>
-            <a:outerShdw blurRad="40000" dist="23000" dir="5400000" rotWithShape="0">
-              <a:srgbClr val="000000">
-                <a:alpha val="35000"/>
-              </a:srgbClr>
-            </a:outerShdw>
-          </a:effectLst>
-          <a:scene3d>
-            <a:camera prst="orthographicFront">
-              <a:rot lat="0" lon="0" rev="0"/>
-            </a:camera>
-            <a:lightRig rig="threePt" dir="t">
-              <a:rot lat="0" lon="0" rev="1200000"/>
-            </a:lightRig>
-          </a:scene3d>
-          <a:sp3d>
-            <a:bevelT w="63500" h="25400"/>
-          </a:sp3d>
-        </a:effectStyle>
-      </a:effectStyleLst>
-      <a:bgFillStyleLst>
-        <a:solidFill>
-          <a:schemeClr val="phClr"/>
-        </a:solidFill>
-        <a:gradFill rotWithShape="1">
-          <a:gsLst>
-            <a:gs pos="0">
-              <a:schemeClr val="phClr">
-                <a:tint val="40000"/>
-                <a:satMod val="350000"/>
-              </a:schemeClr>
-            </a:gs>
-            <a:gs pos="40000">
-              <a:schemeClr val="phClr">
-                <a:tint val="45000"/>
-                <a:shade val="99000"/>
-                <a:satMod val="350000"/>
-              </a:schemeClr>
-            </a:gs>
-            <a:gs pos="100000">
-              <a:schemeClr val="phClr">
-                <a:shade val="20000"/>
-                <a:satMod val="255000"/>
-              </a:schemeClr>
-            </a:gs>
-          </a:gsLst>
-          <a:path path="circle">
-            <a:fillToRect l="50000" t="-80000" r="50000" b="180000"/>
-          </a:path>
-        </a:gradFill>
-        <a:gradFill rotWithShape="1">
-          <a:gsLst>
-            <a:gs pos="0">
-              <a:schemeClr val="phClr">
-                <a:tint val="80000"/>
-                <a:satMod val="300000"/>
-              </a:schemeClr>
-            </a:gs>
-            <a:gs pos="100000">
-              <a:schemeClr val="phClr">
-                <a:shade val="30000"/>
-                <a:satMod val="200000"/>
-              </a:schemeClr>
-            </a:gs>
-          </a:gsLst>
-          <a:path path="circle">
-            <a:fillToRect l="50000" t="50000" r="50000" b="50000"/>
-          </a:path>
-        </a:gradFill>
-      </a:bgFillStyleLst>
-    </a:fmtScheme>
-  </a:themeElements>
-</a:theme>
 </file>
</xml_diff>

<commit_message>
Update Data Sources from LFX 2026-10-14 (#341)
Update Data Sources from LFX

Signed-off-by: github-actions[bot] <41898282+github-actions[bot]@users.noreply.github.com>
Co-authored-by: jmertic <296737+jmertic@users.noreply.github.com>
</commit_message>
<xml_diff>
--- a/overview_deck/LF Energy High Level Overview.pptx
+++ b/overview_deck/LF Energy High Level Overview.pptx
@@ -25946,7 +25946,7 @@
             <a:tbl>
               <a:tblPr>
                 <a:noFill/>
-                <a:tableStyleId>{79EED69C-6B42-446E-B878-0199D09D1945}</a:tableStyleId>
+                <a:tableStyleId>{3B70FBA1-6E8E-4870-8A7F-0DCADBD7905E}</a:tableStyleId>
               </a:tblPr>
               <a:tblGrid>
                 <a:gridCol w="1695200"/>
@@ -26736,7 +26736,7 @@
             <a:tbl>
               <a:tblPr>
                 <a:noFill/>
-                <a:tableStyleId>{79EED69C-6B42-446E-B878-0199D09D1945}</a:tableStyleId>
+                <a:tableStyleId>{3B70FBA1-6E8E-4870-8A7F-0DCADBD7905E}</a:tableStyleId>
               </a:tblPr>
               <a:tblGrid>
                 <a:gridCol w="1695200"/>
@@ -27426,7 +27426,7 @@
             <a:tbl>
               <a:tblPr>
                 <a:noFill/>
-                <a:tableStyleId>{79EED69C-6B42-446E-B878-0199D09D1945}</a:tableStyleId>
+                <a:tableStyleId>{3B70FBA1-6E8E-4870-8A7F-0DCADBD7905E}</a:tableStyleId>
               </a:tblPr>
               <a:tblGrid>
                 <a:gridCol w="1695200"/>
@@ -28678,7 +28678,7 @@
             <a:tbl>
               <a:tblPr>
                 <a:noFill/>
-                <a:tableStyleId>{79EED69C-6B42-446E-B878-0199D09D1945}</a:tableStyleId>
+                <a:tableStyleId>{3B70FBA1-6E8E-4870-8A7F-0DCADBD7905E}</a:tableStyleId>
               </a:tblPr>
               <a:tblGrid>
                 <a:gridCol w="1695200"/>
@@ -29670,7 +29670,7 @@
             <a:tbl>
               <a:tblPr>
                 <a:noFill/>
-                <a:tableStyleId>{79EED69C-6B42-446E-B878-0199D09D1945}</a:tableStyleId>
+                <a:tableStyleId>{3B70FBA1-6E8E-4870-8A7F-0DCADBD7905E}</a:tableStyleId>
               </a:tblPr>
               <a:tblGrid>
                 <a:gridCol w="3048000"/>
@@ -33175,7 +33175,7 @@
             <a:tbl>
               <a:tblPr>
                 <a:noFill/>
-                <a:tableStyleId>{79EED69C-6B42-446E-B878-0199D09D1945}</a:tableStyleId>
+                <a:tableStyleId>{3B70FBA1-6E8E-4870-8A7F-0DCADBD7905E}</a:tableStyleId>
               </a:tblPr>
               <a:tblGrid>
                 <a:gridCol w="1828800"/>
@@ -34002,9 +34002,9 @@
 </file>
 
 <file path=ppt/theme/theme1.xml><?xml version="1.0" encoding="utf-8"?>
-<a:theme xmlns:a="http://schemas.openxmlformats.org/drawingml/2006/main" xmlns:r="http://schemas.openxmlformats.org/officeDocument/2006/relationships" name="Simple Light">
+<a:theme xmlns:a="http://schemas.openxmlformats.org/drawingml/2006/main" xmlns:r="http://schemas.openxmlformats.org/officeDocument/2006/relationships">
   <a:themeElements>
-    <a:clrScheme name="Simple Light">
+    <a:clrScheme name="Default">
       <a:dk1>
         <a:srgbClr val="000000"/>
       </a:dk1>
@@ -34012,34 +34012,34 @@
         <a:srgbClr val="FFFFFF"/>
       </a:lt1>
       <a:dk2>
-        <a:srgbClr val="595959"/>
+        <a:srgbClr val="158158"/>
       </a:dk2>
       <a:lt2>
-        <a:srgbClr val="EEEEEE"/>
+        <a:srgbClr val="F3F3F3"/>
       </a:lt2>
       <a:accent1>
-        <a:srgbClr val="4285F4"/>
+        <a:srgbClr val="058DC7"/>
       </a:accent1>
       <a:accent2>
-        <a:srgbClr val="212121"/>
+        <a:srgbClr val="50B432"/>
       </a:accent2>
       <a:accent3>
-        <a:srgbClr val="78909C"/>
+        <a:srgbClr val="ED561B"/>
       </a:accent3>
       <a:accent4>
-        <a:srgbClr val="FFAB40"/>
+        <a:srgbClr val="EDEF00"/>
       </a:accent4>
       <a:accent5>
-        <a:srgbClr val="0097A7"/>
+        <a:srgbClr val="24CBE5"/>
       </a:accent5>
       <a:accent6>
-        <a:srgbClr val="EEFF41"/>
+        <a:srgbClr val="64E572"/>
       </a:accent6>
       <a:hlink>
-        <a:srgbClr val="0097A7"/>
+        <a:srgbClr val="2200CC"/>
       </a:hlink>
       <a:folHlink>
-        <a:srgbClr val="0097A7"/>
+        <a:srgbClr val="551A8B"/>
       </a:folHlink>
     </a:clrScheme>
     <a:fontScheme name="Office">
@@ -34281,9 +34281,9 @@
 </file>
 
 <file path=ppt/theme/theme2.xml><?xml version="1.0" encoding="utf-8"?>
-<a:theme xmlns:a="http://schemas.openxmlformats.org/drawingml/2006/main" xmlns:r="http://schemas.openxmlformats.org/officeDocument/2006/relationships">
+<a:theme xmlns:a="http://schemas.openxmlformats.org/drawingml/2006/main" xmlns:r="http://schemas.openxmlformats.org/officeDocument/2006/relationships" name="Simple Light">
   <a:themeElements>
-    <a:clrScheme name="Default">
+    <a:clrScheme name="Simple Light">
       <a:dk1>
         <a:srgbClr val="000000"/>
       </a:dk1>
@@ -34291,34 +34291,34 @@
         <a:srgbClr val="FFFFFF"/>
       </a:lt1>
       <a:dk2>
-        <a:srgbClr val="158158"/>
+        <a:srgbClr val="595959"/>
       </a:dk2>
       <a:lt2>
-        <a:srgbClr val="F3F3F3"/>
+        <a:srgbClr val="EEEEEE"/>
       </a:lt2>
       <a:accent1>
-        <a:srgbClr val="058DC7"/>
+        <a:srgbClr val="4285F4"/>
       </a:accent1>
       <a:accent2>
-        <a:srgbClr val="50B432"/>
+        <a:srgbClr val="212121"/>
       </a:accent2>
       <a:accent3>
-        <a:srgbClr val="ED561B"/>
+        <a:srgbClr val="78909C"/>
       </a:accent3>
       <a:accent4>
-        <a:srgbClr val="EDEF00"/>
+        <a:srgbClr val="FFAB40"/>
       </a:accent4>
       <a:accent5>
-        <a:srgbClr val="24CBE5"/>
+        <a:srgbClr val="0097A7"/>
       </a:accent5>
       <a:accent6>
-        <a:srgbClr val="64E572"/>
+        <a:srgbClr val="EEFF41"/>
       </a:accent6>
       <a:hlink>
-        <a:srgbClr val="2200CC"/>
+        <a:srgbClr val="0097A7"/>
       </a:hlink>
       <a:folHlink>
-        <a:srgbClr val="551A8B"/>
+        <a:srgbClr val="0097A7"/>
       </a:folHlink>
     </a:clrScheme>
     <a:fontScheme name="Office">

</xml_diff>

<commit_message>
Update Data Sources from LFX 2026-10-15 (#342)
Update Data Sources from LFX

Signed-off-by: github-actions[bot] <41898282+github-actions[bot]@users.noreply.github.com>
Co-authored-by: jmertic <296737+jmertic@users.noreply.github.com>
</commit_message>
<xml_diff>
--- a/overview_deck/LF Energy High Level Overview.pptx
+++ b/overview_deck/LF Energy High Level Overview.pptx
@@ -25946,7 +25946,7 @@
             <a:tbl>
               <a:tblPr>
                 <a:noFill/>
-                <a:tableStyleId>{3B70FBA1-6E8E-4870-8A7F-0DCADBD7905E}</a:tableStyleId>
+                <a:tableStyleId>{062D59AC-B552-4475-B42D-0F1F6A6BA9A4}</a:tableStyleId>
               </a:tblPr>
               <a:tblGrid>
                 <a:gridCol w="1695200"/>
@@ -26736,7 +26736,7 @@
             <a:tbl>
               <a:tblPr>
                 <a:noFill/>
-                <a:tableStyleId>{3B70FBA1-6E8E-4870-8A7F-0DCADBD7905E}</a:tableStyleId>
+                <a:tableStyleId>{062D59AC-B552-4475-B42D-0F1F6A6BA9A4}</a:tableStyleId>
               </a:tblPr>
               <a:tblGrid>
                 <a:gridCol w="1695200"/>
@@ -27426,7 +27426,7 @@
             <a:tbl>
               <a:tblPr>
                 <a:noFill/>
-                <a:tableStyleId>{3B70FBA1-6E8E-4870-8A7F-0DCADBD7905E}</a:tableStyleId>
+                <a:tableStyleId>{062D59AC-B552-4475-B42D-0F1F6A6BA9A4}</a:tableStyleId>
               </a:tblPr>
               <a:tblGrid>
                 <a:gridCol w="1695200"/>
@@ -28678,7 +28678,7 @@
             <a:tbl>
               <a:tblPr>
                 <a:noFill/>
-                <a:tableStyleId>{3B70FBA1-6E8E-4870-8A7F-0DCADBD7905E}</a:tableStyleId>
+                <a:tableStyleId>{062D59AC-B552-4475-B42D-0F1F6A6BA9A4}</a:tableStyleId>
               </a:tblPr>
               <a:tblGrid>
                 <a:gridCol w="1695200"/>
@@ -29670,7 +29670,7 @@
             <a:tbl>
               <a:tblPr>
                 <a:noFill/>
-                <a:tableStyleId>{3B70FBA1-6E8E-4870-8A7F-0DCADBD7905E}</a:tableStyleId>
+                <a:tableStyleId>{062D59AC-B552-4475-B42D-0F1F6A6BA9A4}</a:tableStyleId>
               </a:tblPr>
               <a:tblGrid>
                 <a:gridCol w="3048000"/>
@@ -33175,7 +33175,7 @@
             <a:tbl>
               <a:tblPr>
                 <a:noFill/>
-                <a:tableStyleId>{3B70FBA1-6E8E-4870-8A7F-0DCADBD7905E}</a:tableStyleId>
+                <a:tableStyleId>{062D59AC-B552-4475-B42D-0F1F6A6BA9A4}</a:tableStyleId>
               </a:tblPr>
               <a:tblGrid>
                 <a:gridCol w="1828800"/>
@@ -34002,285 +34002,6 @@
 </file>
 
 <file path=ppt/theme/theme1.xml><?xml version="1.0" encoding="utf-8"?>
-<a:theme xmlns:a="http://schemas.openxmlformats.org/drawingml/2006/main" xmlns:r="http://schemas.openxmlformats.org/officeDocument/2006/relationships">
-  <a:themeElements>
-    <a:clrScheme name="Default">
-      <a:dk1>
-        <a:srgbClr val="000000"/>
-      </a:dk1>
-      <a:lt1>
-        <a:srgbClr val="FFFFFF"/>
-      </a:lt1>
-      <a:dk2>
-        <a:srgbClr val="158158"/>
-      </a:dk2>
-      <a:lt2>
-        <a:srgbClr val="F3F3F3"/>
-      </a:lt2>
-      <a:accent1>
-        <a:srgbClr val="058DC7"/>
-      </a:accent1>
-      <a:accent2>
-        <a:srgbClr val="50B432"/>
-      </a:accent2>
-      <a:accent3>
-        <a:srgbClr val="ED561B"/>
-      </a:accent3>
-      <a:accent4>
-        <a:srgbClr val="EDEF00"/>
-      </a:accent4>
-      <a:accent5>
-        <a:srgbClr val="24CBE5"/>
-      </a:accent5>
-      <a:accent6>
-        <a:srgbClr val="64E572"/>
-      </a:accent6>
-      <a:hlink>
-        <a:srgbClr val="2200CC"/>
-      </a:hlink>
-      <a:folHlink>
-        <a:srgbClr val="551A8B"/>
-      </a:folHlink>
-    </a:clrScheme>
-    <a:fontScheme name="Office">
-      <a:majorFont>
-        <a:latin typeface="Arial"/>
-        <a:ea typeface=""/>
-        <a:cs typeface=""/>
-        <a:font script="Jpan" typeface="ＭＳ Ｐゴシック"/>
-        <a:font script="Hang" typeface="맑은 고딕"/>
-        <a:font script="Hans" typeface="宋体"/>
-        <a:font script="Hant" typeface="新細明體"/>
-        <a:font script="Arab" typeface="Times New Roman"/>
-        <a:font script="Hebr" typeface="Times New Roman"/>
-        <a:font script="Thai" typeface="Angsana New"/>
-        <a:font script="Ethi" typeface="Nyala"/>
-        <a:font script="Beng" typeface="Vrinda"/>
-        <a:font script="Gujr" typeface="Shruti"/>
-        <a:font script="Khmr" typeface="MoolBoran"/>
-        <a:font script="Knda" typeface="Tunga"/>
-        <a:font script="Guru" typeface="Raavi"/>
-        <a:font script="Cans" typeface="Euphemia"/>
-        <a:font script="Cher" typeface="Plantagenet Cherokee"/>
-        <a:font script="Yiii" typeface="Microsoft Yi Baiti"/>
-        <a:font script="Tibt" typeface="Microsoft Himalaya"/>
-        <a:font script="Thaa" typeface="MV Boli"/>
-        <a:font script="Deva" typeface="Mangal"/>
-        <a:font script="Telu" typeface="Gautami"/>
-        <a:font script="Taml" typeface="Latha"/>
-        <a:font script="Syrc" typeface="Estrangelo Edessa"/>
-        <a:font script="Orya" typeface="Kalinga"/>
-        <a:font script="Mlym" typeface="Kartika"/>
-        <a:font script="Laoo" typeface="DokChampa"/>
-        <a:font script="Sinh" typeface="Iskoola Pota"/>
-        <a:font script="Mong" typeface="Mongolian Baiti"/>
-        <a:font script="Viet" typeface="Times New Roman"/>
-        <a:font script="Uigh" typeface="Microsoft Uighur"/>
-        <a:font script="Geor" typeface="Sylfaen"/>
-      </a:majorFont>
-      <a:minorFont>
-        <a:latin typeface="Arial"/>
-        <a:ea typeface=""/>
-        <a:cs typeface=""/>
-        <a:font script="Jpan" typeface="ＭＳ Ｐゴシック"/>
-        <a:font script="Hang" typeface="맑은 고딕"/>
-        <a:font script="Hans" typeface="宋体"/>
-        <a:font script="Hant" typeface="新細明體"/>
-        <a:font script="Arab" typeface="Arial"/>
-        <a:font script="Hebr" typeface="Arial"/>
-        <a:font script="Thai" typeface="Cordia New"/>
-        <a:font script="Ethi" typeface="Nyala"/>
-        <a:font script="Beng" typeface="Vrinda"/>
-        <a:font script="Gujr" typeface="Shruti"/>
-        <a:font script="Khmr" typeface="DaunPenh"/>
-        <a:font script="Knda" typeface="Tunga"/>
-        <a:font script="Guru" typeface="Raavi"/>
-        <a:font script="Cans" typeface="Euphemia"/>
-        <a:font script="Cher" typeface="Plantagenet Cherokee"/>
-        <a:font script="Yiii" typeface="Microsoft Yi Baiti"/>
-        <a:font script="Tibt" typeface="Microsoft Himalaya"/>
-        <a:font script="Thaa" typeface="MV Boli"/>
-        <a:font script="Deva" typeface="Mangal"/>
-        <a:font script="Telu" typeface="Gautami"/>
-        <a:font script="Taml" typeface="Latha"/>
-        <a:font script="Syrc" typeface="Estrangelo Edessa"/>
-        <a:font script="Orya" typeface="Kalinga"/>
-        <a:font script="Mlym" typeface="Kartika"/>
-        <a:font script="Laoo" typeface="DokChampa"/>
-        <a:font script="Sinh" typeface="Iskoola Pota"/>
-        <a:font script="Mong" typeface="Mongolian Baiti"/>
-        <a:font script="Viet" typeface="Arial"/>
-        <a:font script="Uigh" typeface="Microsoft Uighur"/>
-        <a:font script="Geor" typeface="Sylfaen"/>
-      </a:minorFont>
-    </a:fontScheme>
-    <a:fmtScheme name="Office">
-      <a:fillStyleLst>
-        <a:solidFill>
-          <a:schemeClr val="phClr"/>
-        </a:solidFill>
-        <a:gradFill rotWithShape="1">
-          <a:gsLst>
-            <a:gs pos="0">
-              <a:schemeClr val="phClr">
-                <a:tint val="50000"/>
-                <a:satMod val="300000"/>
-              </a:schemeClr>
-            </a:gs>
-            <a:gs pos="35000">
-              <a:schemeClr val="phClr">
-                <a:tint val="37000"/>
-                <a:satMod val="300000"/>
-              </a:schemeClr>
-            </a:gs>
-            <a:gs pos="100000">
-              <a:schemeClr val="phClr">
-                <a:tint val="15000"/>
-                <a:satMod val="350000"/>
-              </a:schemeClr>
-            </a:gs>
-          </a:gsLst>
-          <a:lin ang="16200000" scaled="1"/>
-        </a:gradFill>
-        <a:gradFill rotWithShape="1">
-          <a:gsLst>
-            <a:gs pos="0">
-              <a:schemeClr val="phClr">
-                <a:tint val="100000"/>
-                <a:shade val="100000"/>
-                <a:satMod val="130000"/>
-              </a:schemeClr>
-            </a:gs>
-            <a:gs pos="100000">
-              <a:schemeClr val="phClr">
-                <a:tint val="50000"/>
-                <a:shade val="100000"/>
-                <a:satMod val="350000"/>
-              </a:schemeClr>
-            </a:gs>
-          </a:gsLst>
-          <a:lin ang="16200000" scaled="0"/>
-        </a:gradFill>
-      </a:fillStyleLst>
-      <a:lnStyleLst>
-        <a:ln w="9525" cap="flat" cmpd="sng" algn="ctr">
-          <a:solidFill>
-            <a:schemeClr val="phClr">
-              <a:shade val="95000"/>
-              <a:satMod val="105000"/>
-            </a:schemeClr>
-          </a:solidFill>
-          <a:prstDash val="solid"/>
-        </a:ln>
-        <a:ln w="25400" cap="flat" cmpd="sng" algn="ctr">
-          <a:solidFill>
-            <a:schemeClr val="phClr"/>
-          </a:solidFill>
-          <a:prstDash val="solid"/>
-        </a:ln>
-        <a:ln w="38100" cap="flat" cmpd="sng" algn="ctr">
-          <a:solidFill>
-            <a:schemeClr val="phClr"/>
-          </a:solidFill>
-          <a:prstDash val="solid"/>
-        </a:ln>
-      </a:lnStyleLst>
-      <a:effectStyleLst>
-        <a:effectStyle>
-          <a:effectLst>
-            <a:outerShdw blurRad="40000" dist="20000" dir="5400000" rotWithShape="0">
-              <a:srgbClr val="000000">
-                <a:alpha val="38000"/>
-              </a:srgbClr>
-            </a:outerShdw>
-          </a:effectLst>
-        </a:effectStyle>
-        <a:effectStyle>
-          <a:effectLst>
-            <a:outerShdw blurRad="40000" dist="23000" dir="5400000" rotWithShape="0">
-              <a:srgbClr val="000000">
-                <a:alpha val="35000"/>
-              </a:srgbClr>
-            </a:outerShdw>
-          </a:effectLst>
-        </a:effectStyle>
-        <a:effectStyle>
-          <a:effectLst>
-            <a:outerShdw blurRad="40000" dist="23000" dir="5400000" rotWithShape="0">
-              <a:srgbClr val="000000">
-                <a:alpha val="35000"/>
-              </a:srgbClr>
-            </a:outerShdw>
-          </a:effectLst>
-          <a:scene3d>
-            <a:camera prst="orthographicFront">
-              <a:rot lat="0" lon="0" rev="0"/>
-            </a:camera>
-            <a:lightRig rig="threePt" dir="t">
-              <a:rot lat="0" lon="0" rev="1200000"/>
-            </a:lightRig>
-          </a:scene3d>
-          <a:sp3d>
-            <a:bevelT w="63500" h="25400"/>
-          </a:sp3d>
-        </a:effectStyle>
-      </a:effectStyleLst>
-      <a:bgFillStyleLst>
-        <a:solidFill>
-          <a:schemeClr val="phClr"/>
-        </a:solidFill>
-        <a:gradFill rotWithShape="1">
-          <a:gsLst>
-            <a:gs pos="0">
-              <a:schemeClr val="phClr">
-                <a:tint val="40000"/>
-                <a:satMod val="350000"/>
-              </a:schemeClr>
-            </a:gs>
-            <a:gs pos="40000">
-              <a:schemeClr val="phClr">
-                <a:tint val="45000"/>
-                <a:shade val="99000"/>
-                <a:satMod val="350000"/>
-              </a:schemeClr>
-            </a:gs>
-            <a:gs pos="100000">
-              <a:schemeClr val="phClr">
-                <a:shade val="20000"/>
-                <a:satMod val="255000"/>
-              </a:schemeClr>
-            </a:gs>
-          </a:gsLst>
-          <a:path path="circle">
-            <a:fillToRect l="50000" t="-80000" r="50000" b="180000"/>
-          </a:path>
-        </a:gradFill>
-        <a:gradFill rotWithShape="1">
-          <a:gsLst>
-            <a:gs pos="0">
-              <a:schemeClr val="phClr">
-                <a:tint val="80000"/>
-                <a:satMod val="300000"/>
-              </a:schemeClr>
-            </a:gs>
-            <a:gs pos="100000">
-              <a:schemeClr val="phClr">
-                <a:shade val="30000"/>
-                <a:satMod val="200000"/>
-              </a:schemeClr>
-            </a:gs>
-          </a:gsLst>
-          <a:path path="circle">
-            <a:fillToRect l="50000" t="50000" r="50000" b="50000"/>
-          </a:path>
-        </a:gradFill>
-      </a:bgFillStyleLst>
-    </a:fmtScheme>
-  </a:themeElements>
-</a:theme>
-</file>
-
-<file path=ppt/theme/theme2.xml><?xml version="1.0" encoding="utf-8"?>
 <a:theme xmlns:a="http://schemas.openxmlformats.org/drawingml/2006/main" xmlns:r="http://schemas.openxmlformats.org/officeDocument/2006/relationships" name="Simple Light">
   <a:themeElements>
     <a:clrScheme name="Simple Light">
@@ -34559,7 +34280,7 @@
 </a:theme>
 </file>
 
-<file path=ppt/theme/theme3.xml><?xml version="1.0" encoding="utf-8"?>
+<file path=ppt/theme/theme2.xml><?xml version="1.0" encoding="utf-8"?>
 <a:theme xmlns:a="http://schemas.openxmlformats.org/drawingml/2006/main" xmlns:r="http://schemas.openxmlformats.org/officeDocument/2006/relationships" name="LF Energy Theme 2023">
   <a:themeElements>
     <a:clrScheme name="Geometric">
@@ -34836,4 +34557,283 @@
     </a:fmtScheme>
   </a:themeElements>
 </a:theme>
+</file>
+
+<file path=ppt/theme/theme3.xml><?xml version="1.0" encoding="utf-8"?>
+<a:theme xmlns:a="http://schemas.openxmlformats.org/drawingml/2006/main" xmlns:r="http://schemas.openxmlformats.org/officeDocument/2006/relationships">
+  <a:themeElements>
+    <a:clrScheme name="Default">
+      <a:dk1>
+        <a:srgbClr val="000000"/>
+      </a:dk1>
+      <a:lt1>
+        <a:srgbClr val="FFFFFF"/>
+      </a:lt1>
+      <a:dk2>
+        <a:srgbClr val="158158"/>
+      </a:dk2>
+      <a:lt2>
+        <a:srgbClr val="F3F3F3"/>
+      </a:lt2>
+      <a:accent1>
+        <a:srgbClr val="058DC7"/>
+      </a:accent1>
+      <a:accent2>
+        <a:srgbClr val="50B432"/>
+      </a:accent2>
+      <a:accent3>
+        <a:srgbClr val="ED561B"/>
+      </a:accent3>
+      <a:accent4>
+        <a:srgbClr val="EDEF00"/>
+      </a:accent4>
+      <a:accent5>
+        <a:srgbClr val="24CBE5"/>
+      </a:accent5>
+      <a:accent6>
+        <a:srgbClr val="64E572"/>
+      </a:accent6>
+      <a:hlink>
+        <a:srgbClr val="2200CC"/>
+      </a:hlink>
+      <a:folHlink>
+        <a:srgbClr val="551A8B"/>
+      </a:folHlink>
+    </a:clrScheme>
+    <a:fontScheme name="Office">
+      <a:majorFont>
+        <a:latin typeface="Arial"/>
+        <a:ea typeface=""/>
+        <a:cs typeface=""/>
+        <a:font script="Jpan" typeface="ＭＳ Ｐゴシック"/>
+        <a:font script="Hang" typeface="맑은 고딕"/>
+        <a:font script="Hans" typeface="宋体"/>
+        <a:font script="Hant" typeface="新細明體"/>
+        <a:font script="Arab" typeface="Times New Roman"/>
+        <a:font script="Hebr" typeface="Times New Roman"/>
+        <a:font script="Thai" typeface="Angsana New"/>
+        <a:font script="Ethi" typeface="Nyala"/>
+        <a:font script="Beng" typeface="Vrinda"/>
+        <a:font script="Gujr" typeface="Shruti"/>
+        <a:font script="Khmr" typeface="MoolBoran"/>
+        <a:font script="Knda" typeface="Tunga"/>
+        <a:font script="Guru" typeface="Raavi"/>
+        <a:font script="Cans" typeface="Euphemia"/>
+        <a:font script="Cher" typeface="Plantagenet Cherokee"/>
+        <a:font script="Yiii" typeface="Microsoft Yi Baiti"/>
+        <a:font script="Tibt" typeface="Microsoft Himalaya"/>
+        <a:font script="Thaa" typeface="MV Boli"/>
+        <a:font script="Deva" typeface="Mangal"/>
+        <a:font script="Telu" typeface="Gautami"/>
+        <a:font script="Taml" typeface="Latha"/>
+        <a:font script="Syrc" typeface="Estrangelo Edessa"/>
+        <a:font script="Orya" typeface="Kalinga"/>
+        <a:font script="Mlym" typeface="Kartika"/>
+        <a:font script="Laoo" typeface="DokChampa"/>
+        <a:font script="Sinh" typeface="Iskoola Pota"/>
+        <a:font script="Mong" typeface="Mongolian Baiti"/>
+        <a:font script="Viet" typeface="Times New Roman"/>
+        <a:font script="Uigh" typeface="Microsoft Uighur"/>
+        <a:font script="Geor" typeface="Sylfaen"/>
+      </a:majorFont>
+      <a:minorFont>
+        <a:latin typeface="Arial"/>
+        <a:ea typeface=""/>
+        <a:cs typeface=""/>
+        <a:font script="Jpan" typeface="ＭＳ Ｐゴシック"/>
+        <a:font script="Hang" typeface="맑은 고딕"/>
+        <a:font script="Hans" typeface="宋体"/>
+        <a:font script="Hant" typeface="新細明體"/>
+        <a:font script="Arab" typeface="Arial"/>
+        <a:font script="Hebr" typeface="Arial"/>
+        <a:font script="Thai" typeface="Cordia New"/>
+        <a:font script="Ethi" typeface="Nyala"/>
+        <a:font script="Beng" typeface="Vrinda"/>
+        <a:font script="Gujr" typeface="Shruti"/>
+        <a:font script="Khmr" typeface="DaunPenh"/>
+        <a:font script="Knda" typeface="Tunga"/>
+        <a:font script="Guru" typeface="Raavi"/>
+        <a:font script="Cans" typeface="Euphemia"/>
+        <a:font script="Cher" typeface="Plantagenet Cherokee"/>
+        <a:font script="Yiii" typeface="Microsoft Yi Baiti"/>
+        <a:font script="Tibt" typeface="Microsoft Himalaya"/>
+        <a:font script="Thaa" typeface="MV Boli"/>
+        <a:font script="Deva" typeface="Mangal"/>
+        <a:font script="Telu" typeface="Gautami"/>
+        <a:font script="Taml" typeface="Latha"/>
+        <a:font script="Syrc" typeface="Estrangelo Edessa"/>
+        <a:font script="Orya" typeface="Kalinga"/>
+        <a:font script="Mlym" typeface="Kartika"/>
+        <a:font script="Laoo" typeface="DokChampa"/>
+        <a:font script="Sinh" typeface="Iskoola Pota"/>
+        <a:font script="Mong" typeface="Mongolian Baiti"/>
+        <a:font script="Viet" typeface="Arial"/>
+        <a:font script="Uigh" typeface="Microsoft Uighur"/>
+        <a:font script="Geor" typeface="Sylfaen"/>
+      </a:minorFont>
+    </a:fontScheme>
+    <a:fmtScheme name="Office">
+      <a:fillStyleLst>
+        <a:solidFill>
+          <a:schemeClr val="phClr"/>
+        </a:solidFill>
+        <a:gradFill rotWithShape="1">
+          <a:gsLst>
+            <a:gs pos="0">
+              <a:schemeClr val="phClr">
+                <a:tint val="50000"/>
+                <a:satMod val="300000"/>
+              </a:schemeClr>
+            </a:gs>
+            <a:gs pos="35000">
+              <a:schemeClr val="phClr">
+                <a:tint val="37000"/>
+                <a:satMod val="300000"/>
+              </a:schemeClr>
+            </a:gs>
+            <a:gs pos="100000">
+              <a:schemeClr val="phClr">
+                <a:tint val="15000"/>
+                <a:satMod val="350000"/>
+              </a:schemeClr>
+            </a:gs>
+          </a:gsLst>
+          <a:lin ang="16200000" scaled="1"/>
+        </a:gradFill>
+        <a:gradFill rotWithShape="1">
+          <a:gsLst>
+            <a:gs pos="0">
+              <a:schemeClr val="phClr">
+                <a:tint val="100000"/>
+                <a:shade val="100000"/>
+                <a:satMod val="130000"/>
+              </a:schemeClr>
+            </a:gs>
+            <a:gs pos="100000">
+              <a:schemeClr val="phClr">
+                <a:tint val="50000"/>
+                <a:shade val="100000"/>
+                <a:satMod val="350000"/>
+              </a:schemeClr>
+            </a:gs>
+          </a:gsLst>
+          <a:lin ang="16200000" scaled="0"/>
+        </a:gradFill>
+      </a:fillStyleLst>
+      <a:lnStyleLst>
+        <a:ln w="9525" cap="flat" cmpd="sng" algn="ctr">
+          <a:solidFill>
+            <a:schemeClr val="phClr">
+              <a:shade val="95000"/>
+              <a:satMod val="105000"/>
+            </a:schemeClr>
+          </a:solidFill>
+          <a:prstDash val="solid"/>
+        </a:ln>
+        <a:ln w="25400" cap="flat" cmpd="sng" algn="ctr">
+          <a:solidFill>
+            <a:schemeClr val="phClr"/>
+          </a:solidFill>
+          <a:prstDash val="solid"/>
+        </a:ln>
+        <a:ln w="38100" cap="flat" cmpd="sng" algn="ctr">
+          <a:solidFill>
+            <a:schemeClr val="phClr"/>
+          </a:solidFill>
+          <a:prstDash val="solid"/>
+        </a:ln>
+      </a:lnStyleLst>
+      <a:effectStyleLst>
+        <a:effectStyle>
+          <a:effectLst>
+            <a:outerShdw blurRad="40000" dist="20000" dir="5400000" rotWithShape="0">
+              <a:srgbClr val="000000">
+                <a:alpha val="38000"/>
+              </a:srgbClr>
+            </a:outerShdw>
+          </a:effectLst>
+        </a:effectStyle>
+        <a:effectStyle>
+          <a:effectLst>
+            <a:outerShdw blurRad="40000" dist="23000" dir="5400000" rotWithShape="0">
+              <a:srgbClr val="000000">
+                <a:alpha val="35000"/>
+              </a:srgbClr>
+            </a:outerShdw>
+          </a:effectLst>
+        </a:effectStyle>
+        <a:effectStyle>
+          <a:effectLst>
+            <a:outerShdw blurRad="40000" dist="23000" dir="5400000" rotWithShape="0">
+              <a:srgbClr val="000000">
+                <a:alpha val="35000"/>
+              </a:srgbClr>
+            </a:outerShdw>
+          </a:effectLst>
+          <a:scene3d>
+            <a:camera prst="orthographicFront">
+              <a:rot lat="0" lon="0" rev="0"/>
+            </a:camera>
+            <a:lightRig rig="threePt" dir="t">
+              <a:rot lat="0" lon="0" rev="1200000"/>
+            </a:lightRig>
+          </a:scene3d>
+          <a:sp3d>
+            <a:bevelT w="63500" h="25400"/>
+          </a:sp3d>
+        </a:effectStyle>
+      </a:effectStyleLst>
+      <a:bgFillStyleLst>
+        <a:solidFill>
+          <a:schemeClr val="phClr"/>
+        </a:solidFill>
+        <a:gradFill rotWithShape="1">
+          <a:gsLst>
+            <a:gs pos="0">
+              <a:schemeClr val="phClr">
+                <a:tint val="40000"/>
+                <a:satMod val="350000"/>
+              </a:schemeClr>
+            </a:gs>
+            <a:gs pos="40000">
+              <a:schemeClr val="phClr">
+                <a:tint val="45000"/>
+                <a:shade val="99000"/>
+                <a:satMod val="350000"/>
+              </a:schemeClr>
+            </a:gs>
+            <a:gs pos="100000">
+              <a:schemeClr val="phClr">
+                <a:shade val="20000"/>
+                <a:satMod val="255000"/>
+              </a:schemeClr>
+            </a:gs>
+          </a:gsLst>
+          <a:path path="circle">
+            <a:fillToRect l="50000" t="-80000" r="50000" b="180000"/>
+          </a:path>
+        </a:gradFill>
+        <a:gradFill rotWithShape="1">
+          <a:gsLst>
+            <a:gs pos="0">
+              <a:schemeClr val="phClr">
+                <a:tint val="80000"/>
+                <a:satMod val="300000"/>
+              </a:schemeClr>
+            </a:gs>
+            <a:gs pos="100000">
+              <a:schemeClr val="phClr">
+                <a:shade val="30000"/>
+                <a:satMod val="200000"/>
+              </a:schemeClr>
+            </a:gs>
+          </a:gsLst>
+          <a:path path="circle">
+            <a:fillToRect l="50000" t="50000" r="50000" b="50000"/>
+          </a:path>
+        </a:gradFill>
+      </a:bgFillStyleLst>
+    </a:fmtScheme>
+  </a:themeElements>
+</a:theme>
 </file>
</xml_diff>

<commit_message>
Update Data Sources from LFX 2026-10-16 (#343)
Update Data Sources from LFX

Signed-off-by: github-actions[bot] <41898282+github-actions[bot]@users.noreply.github.com>
Co-authored-by: jmertic <296737+jmertic@users.noreply.github.com>
</commit_message>
<xml_diff>
--- a/overview_deck/LF Energy High Level Overview.pptx
+++ b/overview_deck/LF Energy High Level Overview.pptx
@@ -25946,7 +25946,7 @@
             <a:tbl>
               <a:tblPr>
                 <a:noFill/>
-                <a:tableStyleId>{062D59AC-B552-4475-B42D-0F1F6A6BA9A4}</a:tableStyleId>
+                <a:tableStyleId>{EA26423E-8F4A-4417-ADA0-3FE4B0367542}</a:tableStyleId>
               </a:tblPr>
               <a:tblGrid>
                 <a:gridCol w="1695200"/>
@@ -26736,7 +26736,7 @@
             <a:tbl>
               <a:tblPr>
                 <a:noFill/>
-                <a:tableStyleId>{062D59AC-B552-4475-B42D-0F1F6A6BA9A4}</a:tableStyleId>
+                <a:tableStyleId>{EA26423E-8F4A-4417-ADA0-3FE4B0367542}</a:tableStyleId>
               </a:tblPr>
               <a:tblGrid>
                 <a:gridCol w="1695200"/>
@@ -27426,7 +27426,7 @@
             <a:tbl>
               <a:tblPr>
                 <a:noFill/>
-                <a:tableStyleId>{062D59AC-B552-4475-B42D-0F1F6A6BA9A4}</a:tableStyleId>
+                <a:tableStyleId>{EA26423E-8F4A-4417-ADA0-3FE4B0367542}</a:tableStyleId>
               </a:tblPr>
               <a:tblGrid>
                 <a:gridCol w="1695200"/>
@@ -28678,7 +28678,7 @@
             <a:tbl>
               <a:tblPr>
                 <a:noFill/>
-                <a:tableStyleId>{062D59AC-B552-4475-B42D-0F1F6A6BA9A4}</a:tableStyleId>
+                <a:tableStyleId>{EA26423E-8F4A-4417-ADA0-3FE4B0367542}</a:tableStyleId>
               </a:tblPr>
               <a:tblGrid>
                 <a:gridCol w="1695200"/>
@@ -29670,7 +29670,7 @@
             <a:tbl>
               <a:tblPr>
                 <a:noFill/>
-                <a:tableStyleId>{062D59AC-B552-4475-B42D-0F1F6A6BA9A4}</a:tableStyleId>
+                <a:tableStyleId>{EA26423E-8F4A-4417-ADA0-3FE4B0367542}</a:tableStyleId>
               </a:tblPr>
               <a:tblGrid>
                 <a:gridCol w="3048000"/>
@@ -33175,7 +33175,7 @@
             <a:tbl>
               <a:tblPr>
                 <a:noFill/>
-                <a:tableStyleId>{062D59AC-B552-4475-B42D-0F1F6A6BA9A4}</a:tableStyleId>
+                <a:tableStyleId>{EA26423E-8F4A-4417-ADA0-3FE4B0367542}</a:tableStyleId>
               </a:tblPr>
               <a:tblGrid>
                 <a:gridCol w="1828800"/>
@@ -34002,9 +34002,9 @@
 </file>
 
 <file path=ppt/theme/theme1.xml><?xml version="1.0" encoding="utf-8"?>
-<a:theme xmlns:a="http://schemas.openxmlformats.org/drawingml/2006/main" xmlns:r="http://schemas.openxmlformats.org/officeDocument/2006/relationships" name="Simple Light">
+<a:theme xmlns:a="http://schemas.openxmlformats.org/drawingml/2006/main" xmlns:r="http://schemas.openxmlformats.org/officeDocument/2006/relationships">
   <a:themeElements>
-    <a:clrScheme name="Simple Light">
+    <a:clrScheme name="Default">
       <a:dk1>
         <a:srgbClr val="000000"/>
       </a:dk1>
@@ -34012,34 +34012,34 @@
         <a:srgbClr val="FFFFFF"/>
       </a:lt1>
       <a:dk2>
-        <a:srgbClr val="595959"/>
+        <a:srgbClr val="158158"/>
       </a:dk2>
       <a:lt2>
-        <a:srgbClr val="EEEEEE"/>
+        <a:srgbClr val="F3F3F3"/>
       </a:lt2>
       <a:accent1>
-        <a:srgbClr val="4285F4"/>
+        <a:srgbClr val="058DC7"/>
       </a:accent1>
       <a:accent2>
-        <a:srgbClr val="212121"/>
+        <a:srgbClr val="50B432"/>
       </a:accent2>
       <a:accent3>
-        <a:srgbClr val="78909C"/>
+        <a:srgbClr val="ED561B"/>
       </a:accent3>
       <a:accent4>
-        <a:srgbClr val="FFAB40"/>
+        <a:srgbClr val="EDEF00"/>
       </a:accent4>
       <a:accent5>
-        <a:srgbClr val="0097A7"/>
+        <a:srgbClr val="24CBE5"/>
       </a:accent5>
       <a:accent6>
-        <a:srgbClr val="EEFF41"/>
+        <a:srgbClr val="64E572"/>
       </a:accent6>
       <a:hlink>
-        <a:srgbClr val="0097A7"/>
+        <a:srgbClr val="2200CC"/>
       </a:hlink>
       <a:folHlink>
-        <a:srgbClr val="0097A7"/>
+        <a:srgbClr val="551A8B"/>
       </a:folHlink>
     </a:clrScheme>
     <a:fontScheme name="Office">
@@ -34560,9 +34560,9 @@
 </file>
 
 <file path=ppt/theme/theme3.xml><?xml version="1.0" encoding="utf-8"?>
-<a:theme xmlns:a="http://schemas.openxmlformats.org/drawingml/2006/main" xmlns:r="http://schemas.openxmlformats.org/officeDocument/2006/relationships">
+<a:theme xmlns:a="http://schemas.openxmlformats.org/drawingml/2006/main" xmlns:r="http://schemas.openxmlformats.org/officeDocument/2006/relationships" name="Simple Light">
   <a:themeElements>
-    <a:clrScheme name="Default">
+    <a:clrScheme name="Simple Light">
       <a:dk1>
         <a:srgbClr val="000000"/>
       </a:dk1>
@@ -34570,34 +34570,34 @@
         <a:srgbClr val="FFFFFF"/>
       </a:lt1>
       <a:dk2>
-        <a:srgbClr val="158158"/>
+        <a:srgbClr val="595959"/>
       </a:dk2>
       <a:lt2>
-        <a:srgbClr val="F3F3F3"/>
+        <a:srgbClr val="EEEEEE"/>
       </a:lt2>
       <a:accent1>
-        <a:srgbClr val="058DC7"/>
+        <a:srgbClr val="4285F4"/>
       </a:accent1>
       <a:accent2>
-        <a:srgbClr val="50B432"/>
+        <a:srgbClr val="212121"/>
       </a:accent2>
       <a:accent3>
-        <a:srgbClr val="ED561B"/>
+        <a:srgbClr val="78909C"/>
       </a:accent3>
       <a:accent4>
-        <a:srgbClr val="EDEF00"/>
+        <a:srgbClr val="FFAB40"/>
       </a:accent4>
       <a:accent5>
-        <a:srgbClr val="24CBE5"/>
+        <a:srgbClr val="0097A7"/>
       </a:accent5>
       <a:accent6>
-        <a:srgbClr val="64E572"/>
+        <a:srgbClr val="EEFF41"/>
       </a:accent6>
       <a:hlink>
-        <a:srgbClr val="2200CC"/>
+        <a:srgbClr val="0097A7"/>
       </a:hlink>
       <a:folHlink>
-        <a:srgbClr val="551A8B"/>
+        <a:srgbClr val="0097A7"/>
       </a:folHlink>
     </a:clrScheme>
     <a:fontScheme name="Office">

</xml_diff>

<commit_message>
Update Data Sources from LFX 2026-10-17 (#344)
Update Data Sources from LFX

Signed-off-by: github-actions[bot] <41898282+github-actions[bot]@users.noreply.github.com>
Co-authored-by: jmertic <296737+jmertic@users.noreply.github.com>
</commit_message>
<xml_diff>
--- a/overview_deck/LF Energy High Level Overview.pptx
+++ b/overview_deck/LF Energy High Level Overview.pptx
@@ -25946,7 +25946,7 @@
             <a:tbl>
               <a:tblPr>
                 <a:noFill/>
-                <a:tableStyleId>{EA26423E-8F4A-4417-ADA0-3FE4B0367542}</a:tableStyleId>
+                <a:tableStyleId>{C41F053F-3E11-4132-91DE-DD6FA936511D}</a:tableStyleId>
               </a:tblPr>
               <a:tblGrid>
                 <a:gridCol w="1695200"/>
@@ -26736,7 +26736,7 @@
             <a:tbl>
               <a:tblPr>
                 <a:noFill/>
-                <a:tableStyleId>{EA26423E-8F4A-4417-ADA0-3FE4B0367542}</a:tableStyleId>
+                <a:tableStyleId>{C41F053F-3E11-4132-91DE-DD6FA936511D}</a:tableStyleId>
               </a:tblPr>
               <a:tblGrid>
                 <a:gridCol w="1695200"/>
@@ -27426,7 +27426,7 @@
             <a:tbl>
               <a:tblPr>
                 <a:noFill/>
-                <a:tableStyleId>{EA26423E-8F4A-4417-ADA0-3FE4B0367542}</a:tableStyleId>
+                <a:tableStyleId>{C41F053F-3E11-4132-91DE-DD6FA936511D}</a:tableStyleId>
               </a:tblPr>
               <a:tblGrid>
                 <a:gridCol w="1695200"/>
@@ -28678,7 +28678,7 @@
             <a:tbl>
               <a:tblPr>
                 <a:noFill/>
-                <a:tableStyleId>{EA26423E-8F4A-4417-ADA0-3FE4B0367542}</a:tableStyleId>
+                <a:tableStyleId>{C41F053F-3E11-4132-91DE-DD6FA936511D}</a:tableStyleId>
               </a:tblPr>
               <a:tblGrid>
                 <a:gridCol w="1695200"/>
@@ -29670,7 +29670,7 @@
             <a:tbl>
               <a:tblPr>
                 <a:noFill/>
-                <a:tableStyleId>{EA26423E-8F4A-4417-ADA0-3FE4B0367542}</a:tableStyleId>
+                <a:tableStyleId>{C41F053F-3E11-4132-91DE-DD6FA936511D}</a:tableStyleId>
               </a:tblPr>
               <a:tblGrid>
                 <a:gridCol w="3048000"/>
@@ -33175,7 +33175,7 @@
             <a:tbl>
               <a:tblPr>
                 <a:noFill/>
-                <a:tableStyleId>{EA26423E-8F4A-4417-ADA0-3FE4B0367542}</a:tableStyleId>
+                <a:tableStyleId>{C41F053F-3E11-4132-91DE-DD6FA936511D}</a:tableStyleId>
               </a:tblPr>
               <a:tblGrid>
                 <a:gridCol w="1828800"/>
@@ -34281,6 +34281,285 @@
 </file>
 
 <file path=ppt/theme/theme2.xml><?xml version="1.0" encoding="utf-8"?>
+<a:theme xmlns:a="http://schemas.openxmlformats.org/drawingml/2006/main" xmlns:r="http://schemas.openxmlformats.org/officeDocument/2006/relationships" name="Simple Light">
+  <a:themeElements>
+    <a:clrScheme name="Simple Light">
+      <a:dk1>
+        <a:srgbClr val="000000"/>
+      </a:dk1>
+      <a:lt1>
+        <a:srgbClr val="FFFFFF"/>
+      </a:lt1>
+      <a:dk2>
+        <a:srgbClr val="595959"/>
+      </a:dk2>
+      <a:lt2>
+        <a:srgbClr val="EEEEEE"/>
+      </a:lt2>
+      <a:accent1>
+        <a:srgbClr val="4285F4"/>
+      </a:accent1>
+      <a:accent2>
+        <a:srgbClr val="212121"/>
+      </a:accent2>
+      <a:accent3>
+        <a:srgbClr val="78909C"/>
+      </a:accent3>
+      <a:accent4>
+        <a:srgbClr val="FFAB40"/>
+      </a:accent4>
+      <a:accent5>
+        <a:srgbClr val="0097A7"/>
+      </a:accent5>
+      <a:accent6>
+        <a:srgbClr val="EEFF41"/>
+      </a:accent6>
+      <a:hlink>
+        <a:srgbClr val="0097A7"/>
+      </a:hlink>
+      <a:folHlink>
+        <a:srgbClr val="0097A7"/>
+      </a:folHlink>
+    </a:clrScheme>
+    <a:fontScheme name="Office">
+      <a:majorFont>
+        <a:latin typeface="Arial"/>
+        <a:ea typeface=""/>
+        <a:cs typeface=""/>
+        <a:font script="Jpan" typeface="ＭＳ Ｐゴシック"/>
+        <a:font script="Hang" typeface="맑은 고딕"/>
+        <a:font script="Hans" typeface="宋体"/>
+        <a:font script="Hant" typeface="新細明體"/>
+        <a:font script="Arab" typeface="Times New Roman"/>
+        <a:font script="Hebr" typeface="Times New Roman"/>
+        <a:font script="Thai" typeface="Angsana New"/>
+        <a:font script="Ethi" typeface="Nyala"/>
+        <a:font script="Beng" typeface="Vrinda"/>
+        <a:font script="Gujr" typeface="Shruti"/>
+        <a:font script="Khmr" typeface="MoolBoran"/>
+        <a:font script="Knda" typeface="Tunga"/>
+        <a:font script="Guru" typeface="Raavi"/>
+        <a:font script="Cans" typeface="Euphemia"/>
+        <a:font script="Cher" typeface="Plantagenet Cherokee"/>
+        <a:font script="Yiii" typeface="Microsoft Yi Baiti"/>
+        <a:font script="Tibt" typeface="Microsoft Himalaya"/>
+        <a:font script="Thaa" typeface="MV Boli"/>
+        <a:font script="Deva" typeface="Mangal"/>
+        <a:font script="Telu" typeface="Gautami"/>
+        <a:font script="Taml" typeface="Latha"/>
+        <a:font script="Syrc" typeface="Estrangelo Edessa"/>
+        <a:font script="Orya" typeface="Kalinga"/>
+        <a:font script="Mlym" typeface="Kartika"/>
+        <a:font script="Laoo" typeface="DokChampa"/>
+        <a:font script="Sinh" typeface="Iskoola Pota"/>
+        <a:font script="Mong" typeface="Mongolian Baiti"/>
+        <a:font script="Viet" typeface="Times New Roman"/>
+        <a:font script="Uigh" typeface="Microsoft Uighur"/>
+        <a:font script="Geor" typeface="Sylfaen"/>
+      </a:majorFont>
+      <a:minorFont>
+        <a:latin typeface="Arial"/>
+        <a:ea typeface=""/>
+        <a:cs typeface=""/>
+        <a:font script="Jpan" typeface="ＭＳ Ｐゴシック"/>
+        <a:font script="Hang" typeface="맑은 고딕"/>
+        <a:font script="Hans" typeface="宋体"/>
+        <a:font script="Hant" typeface="新細明體"/>
+        <a:font script="Arab" typeface="Arial"/>
+        <a:font script="Hebr" typeface="Arial"/>
+        <a:font script="Thai" typeface="Cordia New"/>
+        <a:font script="Ethi" typeface="Nyala"/>
+        <a:font script="Beng" typeface="Vrinda"/>
+        <a:font script="Gujr" typeface="Shruti"/>
+        <a:font script="Khmr" typeface="DaunPenh"/>
+        <a:font script="Knda" typeface="Tunga"/>
+        <a:font script="Guru" typeface="Raavi"/>
+        <a:font script="Cans" typeface="Euphemia"/>
+        <a:font script="Cher" typeface="Plantagenet Cherokee"/>
+        <a:font script="Yiii" typeface="Microsoft Yi Baiti"/>
+        <a:font script="Tibt" typeface="Microsoft Himalaya"/>
+        <a:font script="Thaa" typeface="MV Boli"/>
+        <a:font script="Deva" typeface="Mangal"/>
+        <a:font script="Telu" typeface="Gautami"/>
+        <a:font script="Taml" typeface="Latha"/>
+        <a:font script="Syrc" typeface="Estrangelo Edessa"/>
+        <a:font script="Orya" typeface="Kalinga"/>
+        <a:font script="Mlym" typeface="Kartika"/>
+        <a:font script="Laoo" typeface="DokChampa"/>
+        <a:font script="Sinh" typeface="Iskoola Pota"/>
+        <a:font script="Mong" typeface="Mongolian Baiti"/>
+        <a:font script="Viet" typeface="Arial"/>
+        <a:font script="Uigh" typeface="Microsoft Uighur"/>
+        <a:font script="Geor" typeface="Sylfaen"/>
+      </a:minorFont>
+    </a:fontScheme>
+    <a:fmtScheme name="Office">
+      <a:fillStyleLst>
+        <a:solidFill>
+          <a:schemeClr val="phClr"/>
+        </a:solidFill>
+        <a:gradFill rotWithShape="1">
+          <a:gsLst>
+            <a:gs pos="0">
+              <a:schemeClr val="phClr">
+                <a:tint val="50000"/>
+                <a:satMod val="300000"/>
+              </a:schemeClr>
+            </a:gs>
+            <a:gs pos="35000">
+              <a:schemeClr val="phClr">
+                <a:tint val="37000"/>
+                <a:satMod val="300000"/>
+              </a:schemeClr>
+            </a:gs>
+            <a:gs pos="100000">
+              <a:schemeClr val="phClr">
+                <a:tint val="15000"/>
+                <a:satMod val="350000"/>
+              </a:schemeClr>
+            </a:gs>
+          </a:gsLst>
+          <a:lin ang="16200000" scaled="1"/>
+        </a:gradFill>
+        <a:gradFill rotWithShape="1">
+          <a:gsLst>
+            <a:gs pos="0">
+              <a:schemeClr val="phClr">
+                <a:tint val="100000"/>
+                <a:shade val="100000"/>
+                <a:satMod val="130000"/>
+              </a:schemeClr>
+            </a:gs>
+            <a:gs pos="100000">
+              <a:schemeClr val="phClr">
+                <a:tint val="50000"/>
+                <a:shade val="100000"/>
+                <a:satMod val="350000"/>
+              </a:schemeClr>
+            </a:gs>
+          </a:gsLst>
+          <a:lin ang="16200000" scaled="0"/>
+        </a:gradFill>
+      </a:fillStyleLst>
+      <a:lnStyleLst>
+        <a:ln w="9525" cap="flat" cmpd="sng" algn="ctr">
+          <a:solidFill>
+            <a:schemeClr val="phClr">
+              <a:shade val="95000"/>
+              <a:satMod val="105000"/>
+            </a:schemeClr>
+          </a:solidFill>
+          <a:prstDash val="solid"/>
+        </a:ln>
+        <a:ln w="25400" cap="flat" cmpd="sng" algn="ctr">
+          <a:solidFill>
+            <a:schemeClr val="phClr"/>
+          </a:solidFill>
+          <a:prstDash val="solid"/>
+        </a:ln>
+        <a:ln w="38100" cap="flat" cmpd="sng" algn="ctr">
+          <a:solidFill>
+            <a:schemeClr val="phClr"/>
+          </a:solidFill>
+          <a:prstDash val="solid"/>
+        </a:ln>
+      </a:lnStyleLst>
+      <a:effectStyleLst>
+        <a:effectStyle>
+          <a:effectLst>
+            <a:outerShdw blurRad="40000" dist="20000" dir="5400000" rotWithShape="0">
+              <a:srgbClr val="000000">
+                <a:alpha val="38000"/>
+              </a:srgbClr>
+            </a:outerShdw>
+          </a:effectLst>
+        </a:effectStyle>
+        <a:effectStyle>
+          <a:effectLst>
+            <a:outerShdw blurRad="40000" dist="23000" dir="5400000" rotWithShape="0">
+              <a:srgbClr val="000000">
+                <a:alpha val="35000"/>
+              </a:srgbClr>
+            </a:outerShdw>
+          </a:effectLst>
+        </a:effectStyle>
+        <a:effectStyle>
+          <a:effectLst>
+            <a:outerShdw blurRad="40000" dist="23000" dir="5400000" rotWithShape="0">
+              <a:srgbClr val="000000">
+                <a:alpha val="35000"/>
+              </a:srgbClr>
+            </a:outerShdw>
+          </a:effectLst>
+          <a:scene3d>
+            <a:camera prst="orthographicFront">
+              <a:rot lat="0" lon="0" rev="0"/>
+            </a:camera>
+            <a:lightRig rig="threePt" dir="t">
+              <a:rot lat="0" lon="0" rev="1200000"/>
+            </a:lightRig>
+          </a:scene3d>
+          <a:sp3d>
+            <a:bevelT w="63500" h="25400"/>
+          </a:sp3d>
+        </a:effectStyle>
+      </a:effectStyleLst>
+      <a:bgFillStyleLst>
+        <a:solidFill>
+          <a:schemeClr val="phClr"/>
+        </a:solidFill>
+        <a:gradFill rotWithShape="1">
+          <a:gsLst>
+            <a:gs pos="0">
+              <a:schemeClr val="phClr">
+                <a:tint val="40000"/>
+                <a:satMod val="350000"/>
+              </a:schemeClr>
+            </a:gs>
+            <a:gs pos="40000">
+              <a:schemeClr val="phClr">
+                <a:tint val="45000"/>
+                <a:shade val="99000"/>
+                <a:satMod val="350000"/>
+              </a:schemeClr>
+            </a:gs>
+            <a:gs pos="100000">
+              <a:schemeClr val="phClr">
+                <a:shade val="20000"/>
+                <a:satMod val="255000"/>
+              </a:schemeClr>
+            </a:gs>
+          </a:gsLst>
+          <a:path path="circle">
+            <a:fillToRect l="50000" t="-80000" r="50000" b="180000"/>
+          </a:path>
+        </a:gradFill>
+        <a:gradFill rotWithShape="1">
+          <a:gsLst>
+            <a:gs pos="0">
+              <a:schemeClr val="phClr">
+                <a:tint val="80000"/>
+                <a:satMod val="300000"/>
+              </a:schemeClr>
+            </a:gs>
+            <a:gs pos="100000">
+              <a:schemeClr val="phClr">
+                <a:shade val="30000"/>
+                <a:satMod val="200000"/>
+              </a:schemeClr>
+            </a:gs>
+          </a:gsLst>
+          <a:path path="circle">
+            <a:fillToRect l="50000" t="50000" r="50000" b="50000"/>
+          </a:path>
+        </a:gradFill>
+      </a:bgFillStyleLst>
+    </a:fmtScheme>
+  </a:themeElements>
+</a:theme>
+</file>
+
+<file path=ppt/theme/theme3.xml><?xml version="1.0" encoding="utf-8"?>
 <a:theme xmlns:a="http://schemas.openxmlformats.org/drawingml/2006/main" xmlns:r="http://schemas.openxmlformats.org/officeDocument/2006/relationships" name="LF Energy Theme 2023">
   <a:themeElements>
     <a:clrScheme name="Geometric">
@@ -34557,283 +34836,4 @@
     </a:fmtScheme>
   </a:themeElements>
 </a:theme>
-</file>
-
-<file path=ppt/theme/theme3.xml><?xml version="1.0" encoding="utf-8"?>
-<a:theme xmlns:a="http://schemas.openxmlformats.org/drawingml/2006/main" xmlns:r="http://schemas.openxmlformats.org/officeDocument/2006/relationships" name="Simple Light">
-  <a:themeElements>
-    <a:clrScheme name="Simple Light">
-      <a:dk1>
-        <a:srgbClr val="000000"/>
-      </a:dk1>
-      <a:lt1>
-        <a:srgbClr val="FFFFFF"/>
-      </a:lt1>
-      <a:dk2>
-        <a:srgbClr val="595959"/>
-      </a:dk2>
-      <a:lt2>
-        <a:srgbClr val="EEEEEE"/>
-      </a:lt2>
-      <a:accent1>
-        <a:srgbClr val="4285F4"/>
-      </a:accent1>
-      <a:accent2>
-        <a:srgbClr val="212121"/>
-      </a:accent2>
-      <a:accent3>
-        <a:srgbClr val="78909C"/>
-      </a:accent3>
-      <a:accent4>
-        <a:srgbClr val="FFAB40"/>
-      </a:accent4>
-      <a:accent5>
-        <a:srgbClr val="0097A7"/>
-      </a:accent5>
-      <a:accent6>
-        <a:srgbClr val="EEFF41"/>
-      </a:accent6>
-      <a:hlink>
-        <a:srgbClr val="0097A7"/>
-      </a:hlink>
-      <a:folHlink>
-        <a:srgbClr val="0097A7"/>
-      </a:folHlink>
-    </a:clrScheme>
-    <a:fontScheme name="Office">
-      <a:majorFont>
-        <a:latin typeface="Arial"/>
-        <a:ea typeface=""/>
-        <a:cs typeface=""/>
-        <a:font script="Jpan" typeface="ＭＳ Ｐゴシック"/>
-        <a:font script="Hang" typeface="맑은 고딕"/>
-        <a:font script="Hans" typeface="宋体"/>
-        <a:font script="Hant" typeface="新細明體"/>
-        <a:font script="Arab" typeface="Times New Roman"/>
-        <a:font script="Hebr" typeface="Times New Roman"/>
-        <a:font script="Thai" typeface="Angsana New"/>
-        <a:font script="Ethi" typeface="Nyala"/>
-        <a:font script="Beng" typeface="Vrinda"/>
-        <a:font script="Gujr" typeface="Shruti"/>
-        <a:font script="Khmr" typeface="MoolBoran"/>
-        <a:font script="Knda" typeface="Tunga"/>
-        <a:font script="Guru" typeface="Raavi"/>
-        <a:font script="Cans" typeface="Euphemia"/>
-        <a:font script="Cher" typeface="Plantagenet Cherokee"/>
-        <a:font script="Yiii" typeface="Microsoft Yi Baiti"/>
-        <a:font script="Tibt" typeface="Microsoft Himalaya"/>
-        <a:font script="Thaa" typeface="MV Boli"/>
-        <a:font script="Deva" typeface="Mangal"/>
-        <a:font script="Telu" typeface="Gautami"/>
-        <a:font script="Taml" typeface="Latha"/>
-        <a:font script="Syrc" typeface="Estrangelo Edessa"/>
-        <a:font script="Orya" typeface="Kalinga"/>
-        <a:font script="Mlym" typeface="Kartika"/>
-        <a:font script="Laoo" typeface="DokChampa"/>
-        <a:font script="Sinh" typeface="Iskoola Pota"/>
-        <a:font script="Mong" typeface="Mongolian Baiti"/>
-        <a:font script="Viet" typeface="Times New Roman"/>
-        <a:font script="Uigh" typeface="Microsoft Uighur"/>
-        <a:font script="Geor" typeface="Sylfaen"/>
-      </a:majorFont>
-      <a:minorFont>
-        <a:latin typeface="Arial"/>
-        <a:ea typeface=""/>
-        <a:cs typeface=""/>
-        <a:font script="Jpan" typeface="ＭＳ Ｐゴシック"/>
-        <a:font script="Hang" typeface="맑은 고딕"/>
-        <a:font script="Hans" typeface="宋体"/>
-        <a:font script="Hant" typeface="新細明體"/>
-        <a:font script="Arab" typeface="Arial"/>
-        <a:font script="Hebr" typeface="Arial"/>
-        <a:font script="Thai" typeface="Cordia New"/>
-        <a:font script="Ethi" typeface="Nyala"/>
-        <a:font script="Beng" typeface="Vrinda"/>
-        <a:font script="Gujr" typeface="Shruti"/>
-        <a:font script="Khmr" typeface="DaunPenh"/>
-        <a:font script="Knda" typeface="Tunga"/>
-        <a:font script="Guru" typeface="Raavi"/>
-        <a:font script="Cans" typeface="Euphemia"/>
-        <a:font script="Cher" typeface="Plantagenet Cherokee"/>
-        <a:font script="Yiii" typeface="Microsoft Yi Baiti"/>
-        <a:font script="Tibt" typeface="Microsoft Himalaya"/>
-        <a:font script="Thaa" typeface="MV Boli"/>
-        <a:font script="Deva" typeface="Mangal"/>
-        <a:font script="Telu" typeface="Gautami"/>
-        <a:font script="Taml" typeface="Latha"/>
-        <a:font script="Syrc" typeface="Estrangelo Edessa"/>
-        <a:font script="Orya" typeface="Kalinga"/>
-        <a:font script="Mlym" typeface="Kartika"/>
-        <a:font script="Laoo" typeface="DokChampa"/>
-        <a:font script="Sinh" typeface="Iskoola Pota"/>
-        <a:font script="Mong" typeface="Mongolian Baiti"/>
-        <a:font script="Viet" typeface="Arial"/>
-        <a:font script="Uigh" typeface="Microsoft Uighur"/>
-        <a:font script="Geor" typeface="Sylfaen"/>
-      </a:minorFont>
-    </a:fontScheme>
-    <a:fmtScheme name="Office">
-      <a:fillStyleLst>
-        <a:solidFill>
-          <a:schemeClr val="phClr"/>
-        </a:solidFill>
-        <a:gradFill rotWithShape="1">
-          <a:gsLst>
-            <a:gs pos="0">
-              <a:schemeClr val="phClr">
-                <a:tint val="50000"/>
-                <a:satMod val="300000"/>
-              </a:schemeClr>
-            </a:gs>
-            <a:gs pos="35000">
-              <a:schemeClr val="phClr">
-                <a:tint val="37000"/>
-                <a:satMod val="300000"/>
-              </a:schemeClr>
-            </a:gs>
-            <a:gs pos="100000">
-              <a:schemeClr val="phClr">
-                <a:tint val="15000"/>
-                <a:satMod val="350000"/>
-              </a:schemeClr>
-            </a:gs>
-          </a:gsLst>
-          <a:lin ang="16200000" scaled="1"/>
-        </a:gradFill>
-        <a:gradFill rotWithShape="1">
-          <a:gsLst>
-            <a:gs pos="0">
-              <a:schemeClr val="phClr">
-                <a:tint val="100000"/>
-                <a:shade val="100000"/>
-                <a:satMod val="130000"/>
-              </a:schemeClr>
-            </a:gs>
-            <a:gs pos="100000">
-              <a:schemeClr val="phClr">
-                <a:tint val="50000"/>
-                <a:shade val="100000"/>
-                <a:satMod val="350000"/>
-              </a:schemeClr>
-            </a:gs>
-          </a:gsLst>
-          <a:lin ang="16200000" scaled="0"/>
-        </a:gradFill>
-      </a:fillStyleLst>
-      <a:lnStyleLst>
-        <a:ln w="9525" cap="flat" cmpd="sng" algn="ctr">
-          <a:solidFill>
-            <a:schemeClr val="phClr">
-              <a:shade val="95000"/>
-              <a:satMod val="105000"/>
-            </a:schemeClr>
-          </a:solidFill>
-          <a:prstDash val="solid"/>
-        </a:ln>
-        <a:ln w="25400" cap="flat" cmpd="sng" algn="ctr">
-          <a:solidFill>
-            <a:schemeClr val="phClr"/>
-          </a:solidFill>
-          <a:prstDash val="solid"/>
-        </a:ln>
-        <a:ln w="38100" cap="flat" cmpd="sng" algn="ctr">
-          <a:solidFill>
-            <a:schemeClr val="phClr"/>
-          </a:solidFill>
-          <a:prstDash val="solid"/>
-        </a:ln>
-      </a:lnStyleLst>
-      <a:effectStyleLst>
-        <a:effectStyle>
-          <a:effectLst>
-            <a:outerShdw blurRad="40000" dist="20000" dir="5400000" rotWithShape="0">
-              <a:srgbClr val="000000">
-                <a:alpha val="38000"/>
-              </a:srgbClr>
-            </a:outerShdw>
-          </a:effectLst>
-        </a:effectStyle>
-        <a:effectStyle>
-          <a:effectLst>
-            <a:outerShdw blurRad="40000" dist="23000" dir="5400000" rotWithShape="0">
-              <a:srgbClr val="000000">
-                <a:alpha val="35000"/>
-              </a:srgbClr>
-            </a:outerShdw>
-          </a:effectLst>
-        </a:effectStyle>
-        <a:effectStyle>
-          <a:effectLst>
-            <a:outerShdw blurRad="40000" dist="23000" dir="5400000" rotWithShape="0">
-              <a:srgbClr val="000000">
-                <a:alpha val="35000"/>
-              </a:srgbClr>
-            </a:outerShdw>
-          </a:effectLst>
-          <a:scene3d>
-            <a:camera prst="orthographicFront">
-              <a:rot lat="0" lon="0" rev="0"/>
-            </a:camera>
-            <a:lightRig rig="threePt" dir="t">
-              <a:rot lat="0" lon="0" rev="1200000"/>
-            </a:lightRig>
-          </a:scene3d>
-          <a:sp3d>
-            <a:bevelT w="63500" h="25400"/>
-          </a:sp3d>
-        </a:effectStyle>
-      </a:effectStyleLst>
-      <a:bgFillStyleLst>
-        <a:solidFill>
-          <a:schemeClr val="phClr"/>
-        </a:solidFill>
-        <a:gradFill rotWithShape="1">
-          <a:gsLst>
-            <a:gs pos="0">
-              <a:schemeClr val="phClr">
-                <a:tint val="40000"/>
-                <a:satMod val="350000"/>
-              </a:schemeClr>
-            </a:gs>
-            <a:gs pos="40000">
-              <a:schemeClr val="phClr">
-                <a:tint val="45000"/>
-                <a:shade val="99000"/>
-                <a:satMod val="350000"/>
-              </a:schemeClr>
-            </a:gs>
-            <a:gs pos="100000">
-              <a:schemeClr val="phClr">
-                <a:shade val="20000"/>
-                <a:satMod val="255000"/>
-              </a:schemeClr>
-            </a:gs>
-          </a:gsLst>
-          <a:path path="circle">
-            <a:fillToRect l="50000" t="-80000" r="50000" b="180000"/>
-          </a:path>
-        </a:gradFill>
-        <a:gradFill rotWithShape="1">
-          <a:gsLst>
-            <a:gs pos="0">
-              <a:schemeClr val="phClr">
-                <a:tint val="80000"/>
-                <a:satMod val="300000"/>
-              </a:schemeClr>
-            </a:gs>
-            <a:gs pos="100000">
-              <a:schemeClr val="phClr">
-                <a:shade val="30000"/>
-                <a:satMod val="200000"/>
-              </a:schemeClr>
-            </a:gs>
-          </a:gsLst>
-          <a:path path="circle">
-            <a:fillToRect l="50000" t="50000" r="50000" b="50000"/>
-          </a:path>
-        </a:gradFill>
-      </a:bgFillStyleLst>
-    </a:fmtScheme>
-  </a:themeElements>
-</a:theme>
 </file>
</xml_diff>

<commit_message>
Update Data Sources from LFX 2026-10-18 (#345)
Update Data Sources from LFX

Signed-off-by: github-actions[bot] <41898282+github-actions[bot]@users.noreply.github.com>
Co-authored-by: jmertic <296737+jmertic@users.noreply.github.com>
</commit_message>
<xml_diff>
--- a/overview_deck/LF Energy High Level Overview.pptx
+++ b/overview_deck/LF Energy High Level Overview.pptx
@@ -25946,7 +25946,7 @@
             <a:tbl>
               <a:tblPr>
                 <a:noFill/>
-                <a:tableStyleId>{C41F053F-3E11-4132-91DE-DD6FA936511D}</a:tableStyleId>
+                <a:tableStyleId>{38460B15-25ED-4A30-9E0A-DDD4A41D72A6}</a:tableStyleId>
               </a:tblPr>
               <a:tblGrid>
                 <a:gridCol w="1695200"/>
@@ -26736,7 +26736,7 @@
             <a:tbl>
               <a:tblPr>
                 <a:noFill/>
-                <a:tableStyleId>{C41F053F-3E11-4132-91DE-DD6FA936511D}</a:tableStyleId>
+                <a:tableStyleId>{38460B15-25ED-4A30-9E0A-DDD4A41D72A6}</a:tableStyleId>
               </a:tblPr>
               <a:tblGrid>
                 <a:gridCol w="1695200"/>
@@ -27426,7 +27426,7 @@
             <a:tbl>
               <a:tblPr>
                 <a:noFill/>
-                <a:tableStyleId>{C41F053F-3E11-4132-91DE-DD6FA936511D}</a:tableStyleId>
+                <a:tableStyleId>{38460B15-25ED-4A30-9E0A-DDD4A41D72A6}</a:tableStyleId>
               </a:tblPr>
               <a:tblGrid>
                 <a:gridCol w="1695200"/>
@@ -28678,7 +28678,7 @@
             <a:tbl>
               <a:tblPr>
                 <a:noFill/>
-                <a:tableStyleId>{C41F053F-3E11-4132-91DE-DD6FA936511D}</a:tableStyleId>
+                <a:tableStyleId>{38460B15-25ED-4A30-9E0A-DDD4A41D72A6}</a:tableStyleId>
               </a:tblPr>
               <a:tblGrid>
                 <a:gridCol w="1695200"/>
@@ -29670,7 +29670,7 @@
             <a:tbl>
               <a:tblPr>
                 <a:noFill/>
-                <a:tableStyleId>{C41F053F-3E11-4132-91DE-DD6FA936511D}</a:tableStyleId>
+                <a:tableStyleId>{38460B15-25ED-4A30-9E0A-DDD4A41D72A6}</a:tableStyleId>
               </a:tblPr>
               <a:tblGrid>
                 <a:gridCol w="3048000"/>
@@ -33175,7 +33175,7 @@
             <a:tbl>
               <a:tblPr>
                 <a:noFill/>
-                <a:tableStyleId>{C41F053F-3E11-4132-91DE-DD6FA936511D}</a:tableStyleId>
+                <a:tableStyleId>{38460B15-25ED-4A30-9E0A-DDD4A41D72A6}</a:tableStyleId>
               </a:tblPr>
               <a:tblGrid>
                 <a:gridCol w="1828800"/>
@@ -34281,6 +34281,285 @@
 </file>
 
 <file path=ppt/theme/theme2.xml><?xml version="1.0" encoding="utf-8"?>
+<a:theme xmlns:a="http://schemas.openxmlformats.org/drawingml/2006/main" xmlns:r="http://schemas.openxmlformats.org/officeDocument/2006/relationships" name="LF Energy Theme 2023">
+  <a:themeElements>
+    <a:clrScheme name="Geometric">
+      <a:dk1>
+        <a:srgbClr val="222222"/>
+      </a:dk1>
+      <a:lt1>
+        <a:srgbClr val="FFFFFF"/>
+      </a:lt1>
+      <a:dk2>
+        <a:srgbClr val="434343"/>
+      </a:dk2>
+      <a:lt2>
+        <a:srgbClr val="999999"/>
+      </a:lt2>
+      <a:accent1>
+        <a:srgbClr val="003778"/>
+      </a:accent1>
+      <a:accent2>
+        <a:srgbClr val="0094FF"/>
+      </a:accent2>
+      <a:accent3>
+        <a:srgbClr val="5B1DE7"/>
+      </a:accent3>
+      <a:accent4>
+        <a:srgbClr val="12E2E2"/>
+      </a:accent4>
+      <a:accent5>
+        <a:srgbClr val="FF00AA"/>
+      </a:accent5>
+      <a:accent6>
+        <a:srgbClr val="ACDE1F"/>
+      </a:accent6>
+      <a:hlink>
+        <a:srgbClr val="0077CC"/>
+      </a:hlink>
+      <a:folHlink>
+        <a:srgbClr val="F06292"/>
+      </a:folHlink>
+    </a:clrScheme>
+    <a:fontScheme name="Office">
+      <a:majorFont>
+        <a:latin typeface="Arial"/>
+        <a:ea typeface=""/>
+        <a:cs typeface=""/>
+        <a:font script="Jpan" typeface="ＭＳ Ｐゴシック"/>
+        <a:font script="Hang" typeface="맑은 고딕"/>
+        <a:font script="Hans" typeface="宋体"/>
+        <a:font script="Hant" typeface="新細明體"/>
+        <a:font script="Arab" typeface="Times New Roman"/>
+        <a:font script="Hebr" typeface="Times New Roman"/>
+        <a:font script="Thai" typeface="Angsana New"/>
+        <a:font script="Ethi" typeface="Nyala"/>
+        <a:font script="Beng" typeface="Vrinda"/>
+        <a:font script="Gujr" typeface="Shruti"/>
+        <a:font script="Khmr" typeface="MoolBoran"/>
+        <a:font script="Knda" typeface="Tunga"/>
+        <a:font script="Guru" typeface="Raavi"/>
+        <a:font script="Cans" typeface="Euphemia"/>
+        <a:font script="Cher" typeface="Plantagenet Cherokee"/>
+        <a:font script="Yiii" typeface="Microsoft Yi Baiti"/>
+        <a:font script="Tibt" typeface="Microsoft Himalaya"/>
+        <a:font script="Thaa" typeface="MV Boli"/>
+        <a:font script="Deva" typeface="Mangal"/>
+        <a:font script="Telu" typeface="Gautami"/>
+        <a:font script="Taml" typeface="Latha"/>
+        <a:font script="Syrc" typeface="Estrangelo Edessa"/>
+        <a:font script="Orya" typeface="Kalinga"/>
+        <a:font script="Mlym" typeface="Kartika"/>
+        <a:font script="Laoo" typeface="DokChampa"/>
+        <a:font script="Sinh" typeface="Iskoola Pota"/>
+        <a:font script="Mong" typeface="Mongolian Baiti"/>
+        <a:font script="Viet" typeface="Times New Roman"/>
+        <a:font script="Uigh" typeface="Microsoft Uighur"/>
+        <a:font script="Geor" typeface="Sylfaen"/>
+      </a:majorFont>
+      <a:minorFont>
+        <a:latin typeface="Arial"/>
+        <a:ea typeface=""/>
+        <a:cs typeface=""/>
+        <a:font script="Jpan" typeface="ＭＳ Ｐゴシック"/>
+        <a:font script="Hang" typeface="맑은 고딕"/>
+        <a:font script="Hans" typeface="宋体"/>
+        <a:font script="Hant" typeface="新細明體"/>
+        <a:font script="Arab" typeface="Arial"/>
+        <a:font script="Hebr" typeface="Arial"/>
+        <a:font script="Thai" typeface="Cordia New"/>
+        <a:font script="Ethi" typeface="Nyala"/>
+        <a:font script="Beng" typeface="Vrinda"/>
+        <a:font script="Gujr" typeface="Shruti"/>
+        <a:font script="Khmr" typeface="DaunPenh"/>
+        <a:font script="Knda" typeface="Tunga"/>
+        <a:font script="Guru" typeface="Raavi"/>
+        <a:font script="Cans" typeface="Euphemia"/>
+        <a:font script="Cher" typeface="Plantagenet Cherokee"/>
+        <a:font script="Yiii" typeface="Microsoft Yi Baiti"/>
+        <a:font script="Tibt" typeface="Microsoft Himalaya"/>
+        <a:font script="Thaa" typeface="MV Boli"/>
+        <a:font script="Deva" typeface="Mangal"/>
+        <a:font script="Telu" typeface="Gautami"/>
+        <a:font script="Taml" typeface="Latha"/>
+        <a:font script="Syrc" typeface="Estrangelo Edessa"/>
+        <a:font script="Orya" typeface="Kalinga"/>
+        <a:font script="Mlym" typeface="Kartika"/>
+        <a:font script="Laoo" typeface="DokChampa"/>
+        <a:font script="Sinh" typeface="Iskoola Pota"/>
+        <a:font script="Mong" typeface="Mongolian Baiti"/>
+        <a:font script="Viet" typeface="Arial"/>
+        <a:font script="Uigh" typeface="Microsoft Uighur"/>
+        <a:font script="Geor" typeface="Sylfaen"/>
+      </a:minorFont>
+    </a:fontScheme>
+    <a:fmtScheme name="Office">
+      <a:fillStyleLst>
+        <a:solidFill>
+          <a:schemeClr val="phClr"/>
+        </a:solidFill>
+        <a:gradFill rotWithShape="1">
+          <a:gsLst>
+            <a:gs pos="0">
+              <a:schemeClr val="phClr">
+                <a:tint val="50000"/>
+                <a:satMod val="300000"/>
+              </a:schemeClr>
+            </a:gs>
+            <a:gs pos="35000">
+              <a:schemeClr val="phClr">
+                <a:tint val="37000"/>
+                <a:satMod val="300000"/>
+              </a:schemeClr>
+            </a:gs>
+            <a:gs pos="100000">
+              <a:schemeClr val="phClr">
+                <a:tint val="15000"/>
+                <a:satMod val="350000"/>
+              </a:schemeClr>
+            </a:gs>
+          </a:gsLst>
+          <a:lin ang="16200000" scaled="1"/>
+        </a:gradFill>
+        <a:gradFill rotWithShape="1">
+          <a:gsLst>
+            <a:gs pos="0">
+              <a:schemeClr val="phClr">
+                <a:tint val="100000"/>
+                <a:shade val="100000"/>
+                <a:satMod val="130000"/>
+              </a:schemeClr>
+            </a:gs>
+            <a:gs pos="100000">
+              <a:schemeClr val="phClr">
+                <a:tint val="50000"/>
+                <a:shade val="100000"/>
+                <a:satMod val="350000"/>
+              </a:schemeClr>
+            </a:gs>
+          </a:gsLst>
+          <a:lin ang="16200000" scaled="0"/>
+        </a:gradFill>
+      </a:fillStyleLst>
+      <a:lnStyleLst>
+        <a:ln w="9525" cap="flat" cmpd="sng" algn="ctr">
+          <a:solidFill>
+            <a:schemeClr val="phClr">
+              <a:shade val="95000"/>
+              <a:satMod val="105000"/>
+            </a:schemeClr>
+          </a:solidFill>
+          <a:prstDash val="solid"/>
+        </a:ln>
+        <a:ln w="25400" cap="flat" cmpd="sng" algn="ctr">
+          <a:solidFill>
+            <a:schemeClr val="phClr"/>
+          </a:solidFill>
+          <a:prstDash val="solid"/>
+        </a:ln>
+        <a:ln w="38100" cap="flat" cmpd="sng" algn="ctr">
+          <a:solidFill>
+            <a:schemeClr val="phClr"/>
+          </a:solidFill>
+          <a:prstDash val="solid"/>
+        </a:ln>
+      </a:lnStyleLst>
+      <a:effectStyleLst>
+        <a:effectStyle>
+          <a:effectLst>
+            <a:outerShdw blurRad="40000" dist="20000" dir="5400000" rotWithShape="0">
+              <a:srgbClr val="000000">
+                <a:alpha val="38000"/>
+              </a:srgbClr>
+            </a:outerShdw>
+          </a:effectLst>
+        </a:effectStyle>
+        <a:effectStyle>
+          <a:effectLst>
+            <a:outerShdw blurRad="40000" dist="23000" dir="5400000" rotWithShape="0">
+              <a:srgbClr val="000000">
+                <a:alpha val="35000"/>
+              </a:srgbClr>
+            </a:outerShdw>
+          </a:effectLst>
+        </a:effectStyle>
+        <a:effectStyle>
+          <a:effectLst>
+            <a:outerShdw blurRad="40000" dist="23000" dir="5400000" rotWithShape="0">
+              <a:srgbClr val="000000">
+                <a:alpha val="35000"/>
+              </a:srgbClr>
+            </a:outerShdw>
+          </a:effectLst>
+          <a:scene3d>
+            <a:camera prst="orthographicFront">
+              <a:rot lat="0" lon="0" rev="0"/>
+            </a:camera>
+            <a:lightRig rig="threePt" dir="t">
+              <a:rot lat="0" lon="0" rev="1200000"/>
+            </a:lightRig>
+          </a:scene3d>
+          <a:sp3d>
+            <a:bevelT w="63500" h="25400"/>
+          </a:sp3d>
+        </a:effectStyle>
+      </a:effectStyleLst>
+      <a:bgFillStyleLst>
+        <a:solidFill>
+          <a:schemeClr val="phClr"/>
+        </a:solidFill>
+        <a:gradFill rotWithShape="1">
+          <a:gsLst>
+            <a:gs pos="0">
+              <a:schemeClr val="phClr">
+                <a:tint val="40000"/>
+                <a:satMod val="350000"/>
+              </a:schemeClr>
+            </a:gs>
+            <a:gs pos="40000">
+              <a:schemeClr val="phClr">
+                <a:tint val="45000"/>
+                <a:shade val="99000"/>
+                <a:satMod val="350000"/>
+              </a:schemeClr>
+            </a:gs>
+            <a:gs pos="100000">
+              <a:schemeClr val="phClr">
+                <a:shade val="20000"/>
+                <a:satMod val="255000"/>
+              </a:schemeClr>
+            </a:gs>
+          </a:gsLst>
+          <a:path path="circle">
+            <a:fillToRect l="50000" t="-80000" r="50000" b="180000"/>
+          </a:path>
+        </a:gradFill>
+        <a:gradFill rotWithShape="1">
+          <a:gsLst>
+            <a:gs pos="0">
+              <a:schemeClr val="phClr">
+                <a:tint val="80000"/>
+                <a:satMod val="300000"/>
+              </a:schemeClr>
+            </a:gs>
+            <a:gs pos="100000">
+              <a:schemeClr val="phClr">
+                <a:shade val="30000"/>
+                <a:satMod val="200000"/>
+              </a:schemeClr>
+            </a:gs>
+          </a:gsLst>
+          <a:path path="circle">
+            <a:fillToRect l="50000" t="50000" r="50000" b="50000"/>
+          </a:path>
+        </a:gradFill>
+      </a:bgFillStyleLst>
+    </a:fmtScheme>
+  </a:themeElements>
+</a:theme>
+</file>
+
+<file path=ppt/theme/theme3.xml><?xml version="1.0" encoding="utf-8"?>
 <a:theme xmlns:a="http://schemas.openxmlformats.org/drawingml/2006/main" xmlns:r="http://schemas.openxmlformats.org/officeDocument/2006/relationships" name="Simple Light">
   <a:themeElements>
     <a:clrScheme name="Simple Light">
@@ -34557,283 +34836,4 @@
     </a:fmtScheme>
   </a:themeElements>
 </a:theme>
-</file>
-
-<file path=ppt/theme/theme3.xml><?xml version="1.0" encoding="utf-8"?>
-<a:theme xmlns:a="http://schemas.openxmlformats.org/drawingml/2006/main" xmlns:r="http://schemas.openxmlformats.org/officeDocument/2006/relationships" name="LF Energy Theme 2023">
-  <a:themeElements>
-    <a:clrScheme name="Geometric">
-      <a:dk1>
-        <a:srgbClr val="222222"/>
-      </a:dk1>
-      <a:lt1>
-        <a:srgbClr val="FFFFFF"/>
-      </a:lt1>
-      <a:dk2>
-        <a:srgbClr val="434343"/>
-      </a:dk2>
-      <a:lt2>
-        <a:srgbClr val="999999"/>
-      </a:lt2>
-      <a:accent1>
-        <a:srgbClr val="003778"/>
-      </a:accent1>
-      <a:accent2>
-        <a:srgbClr val="0094FF"/>
-      </a:accent2>
-      <a:accent3>
-        <a:srgbClr val="5B1DE7"/>
-      </a:accent3>
-      <a:accent4>
-        <a:srgbClr val="12E2E2"/>
-      </a:accent4>
-      <a:accent5>
-        <a:srgbClr val="FF00AA"/>
-      </a:accent5>
-      <a:accent6>
-        <a:srgbClr val="ACDE1F"/>
-      </a:accent6>
-      <a:hlink>
-        <a:srgbClr val="0077CC"/>
-      </a:hlink>
-      <a:folHlink>
-        <a:srgbClr val="F06292"/>
-      </a:folHlink>
-    </a:clrScheme>
-    <a:fontScheme name="Office">
-      <a:majorFont>
-        <a:latin typeface="Arial"/>
-        <a:ea typeface=""/>
-        <a:cs typeface=""/>
-        <a:font script="Jpan" typeface="ＭＳ Ｐゴシック"/>
-        <a:font script="Hang" typeface="맑은 고딕"/>
-        <a:font script="Hans" typeface="宋体"/>
-        <a:font script="Hant" typeface="新細明體"/>
-        <a:font script="Arab" typeface="Times New Roman"/>
-        <a:font script="Hebr" typeface="Times New Roman"/>
-        <a:font script="Thai" typeface="Angsana New"/>
-        <a:font script="Ethi" typeface="Nyala"/>
-        <a:font script="Beng" typeface="Vrinda"/>
-        <a:font script="Gujr" typeface="Shruti"/>
-        <a:font script="Khmr" typeface="MoolBoran"/>
-        <a:font script="Knda" typeface="Tunga"/>
-        <a:font script="Guru" typeface="Raavi"/>
-        <a:font script="Cans" typeface="Euphemia"/>
-        <a:font script="Cher" typeface="Plantagenet Cherokee"/>
-        <a:font script="Yiii" typeface="Microsoft Yi Baiti"/>
-        <a:font script="Tibt" typeface="Microsoft Himalaya"/>
-        <a:font script="Thaa" typeface="MV Boli"/>
-        <a:font script="Deva" typeface="Mangal"/>
-        <a:font script="Telu" typeface="Gautami"/>
-        <a:font script="Taml" typeface="Latha"/>
-        <a:font script="Syrc" typeface="Estrangelo Edessa"/>
-        <a:font script="Orya" typeface="Kalinga"/>
-        <a:font script="Mlym" typeface="Kartika"/>
-        <a:font script="Laoo" typeface="DokChampa"/>
-        <a:font script="Sinh" typeface="Iskoola Pota"/>
-        <a:font script="Mong" typeface="Mongolian Baiti"/>
-        <a:font script="Viet" typeface="Times New Roman"/>
-        <a:font script="Uigh" typeface="Microsoft Uighur"/>
-        <a:font script="Geor" typeface="Sylfaen"/>
-      </a:majorFont>
-      <a:minorFont>
-        <a:latin typeface="Arial"/>
-        <a:ea typeface=""/>
-        <a:cs typeface=""/>
-        <a:font script="Jpan" typeface="ＭＳ Ｐゴシック"/>
-        <a:font script="Hang" typeface="맑은 고딕"/>
-        <a:font script="Hans" typeface="宋体"/>
-        <a:font script="Hant" typeface="新細明體"/>
-        <a:font script="Arab" typeface="Arial"/>
-        <a:font script="Hebr" typeface="Arial"/>
-        <a:font script="Thai" typeface="Cordia New"/>
-        <a:font script="Ethi" typeface="Nyala"/>
-        <a:font script="Beng" typeface="Vrinda"/>
-        <a:font script="Gujr" typeface="Shruti"/>
-        <a:font script="Khmr" typeface="DaunPenh"/>
-        <a:font script="Knda" typeface="Tunga"/>
-        <a:font script="Guru" typeface="Raavi"/>
-        <a:font script="Cans" typeface="Euphemia"/>
-        <a:font script="Cher" typeface="Plantagenet Cherokee"/>
-        <a:font script="Yiii" typeface="Microsoft Yi Baiti"/>
-        <a:font script="Tibt" typeface="Microsoft Himalaya"/>
-        <a:font script="Thaa" typeface="MV Boli"/>
-        <a:font script="Deva" typeface="Mangal"/>
-        <a:font script="Telu" typeface="Gautami"/>
-        <a:font script="Taml" typeface="Latha"/>
-        <a:font script="Syrc" typeface="Estrangelo Edessa"/>
-        <a:font script="Orya" typeface="Kalinga"/>
-        <a:font script="Mlym" typeface="Kartika"/>
-        <a:font script="Laoo" typeface="DokChampa"/>
-        <a:font script="Sinh" typeface="Iskoola Pota"/>
-        <a:font script="Mong" typeface="Mongolian Baiti"/>
-        <a:font script="Viet" typeface="Arial"/>
-        <a:font script="Uigh" typeface="Microsoft Uighur"/>
-        <a:font script="Geor" typeface="Sylfaen"/>
-      </a:minorFont>
-    </a:fontScheme>
-    <a:fmtScheme name="Office">
-      <a:fillStyleLst>
-        <a:solidFill>
-          <a:schemeClr val="phClr"/>
-        </a:solidFill>
-        <a:gradFill rotWithShape="1">
-          <a:gsLst>
-            <a:gs pos="0">
-              <a:schemeClr val="phClr">
-                <a:tint val="50000"/>
-                <a:satMod val="300000"/>
-              </a:schemeClr>
-            </a:gs>
-            <a:gs pos="35000">
-              <a:schemeClr val="phClr">
-                <a:tint val="37000"/>
-                <a:satMod val="300000"/>
-              </a:schemeClr>
-            </a:gs>
-            <a:gs pos="100000">
-              <a:schemeClr val="phClr">
-                <a:tint val="15000"/>
-                <a:satMod val="350000"/>
-              </a:schemeClr>
-            </a:gs>
-          </a:gsLst>
-          <a:lin ang="16200000" scaled="1"/>
-        </a:gradFill>
-        <a:gradFill rotWithShape="1">
-          <a:gsLst>
-            <a:gs pos="0">
-              <a:schemeClr val="phClr">
-                <a:tint val="100000"/>
-                <a:shade val="100000"/>
-                <a:satMod val="130000"/>
-              </a:schemeClr>
-            </a:gs>
-            <a:gs pos="100000">
-              <a:schemeClr val="phClr">
-                <a:tint val="50000"/>
-                <a:shade val="100000"/>
-                <a:satMod val="350000"/>
-              </a:schemeClr>
-            </a:gs>
-          </a:gsLst>
-          <a:lin ang="16200000" scaled="0"/>
-        </a:gradFill>
-      </a:fillStyleLst>
-      <a:lnStyleLst>
-        <a:ln w="9525" cap="flat" cmpd="sng" algn="ctr">
-          <a:solidFill>
-            <a:schemeClr val="phClr">
-              <a:shade val="95000"/>
-              <a:satMod val="105000"/>
-            </a:schemeClr>
-          </a:solidFill>
-          <a:prstDash val="solid"/>
-        </a:ln>
-        <a:ln w="25400" cap="flat" cmpd="sng" algn="ctr">
-          <a:solidFill>
-            <a:schemeClr val="phClr"/>
-          </a:solidFill>
-          <a:prstDash val="solid"/>
-        </a:ln>
-        <a:ln w="38100" cap="flat" cmpd="sng" algn="ctr">
-          <a:solidFill>
-            <a:schemeClr val="phClr"/>
-          </a:solidFill>
-          <a:prstDash val="solid"/>
-        </a:ln>
-      </a:lnStyleLst>
-      <a:effectStyleLst>
-        <a:effectStyle>
-          <a:effectLst>
-            <a:outerShdw blurRad="40000" dist="20000" dir="5400000" rotWithShape="0">
-              <a:srgbClr val="000000">
-                <a:alpha val="38000"/>
-              </a:srgbClr>
-            </a:outerShdw>
-          </a:effectLst>
-        </a:effectStyle>
-        <a:effectStyle>
-          <a:effectLst>
-            <a:outerShdw blurRad="40000" dist="23000" dir="5400000" rotWithShape="0">
-              <a:srgbClr val="000000">
-                <a:alpha val="35000"/>
-              </a:srgbClr>
-            </a:outerShdw>
-          </a:effectLst>
-        </a:effectStyle>
-        <a:effectStyle>
-          <a:effectLst>
-            <a:outerShdw blurRad="40000" dist="23000" dir="5400000" rotWithShape="0">
-              <a:srgbClr val="000000">
-                <a:alpha val="35000"/>
-              </a:srgbClr>
-            </a:outerShdw>
-          </a:effectLst>
-          <a:scene3d>
-            <a:camera prst="orthographicFront">
-              <a:rot lat="0" lon="0" rev="0"/>
-            </a:camera>
-            <a:lightRig rig="threePt" dir="t">
-              <a:rot lat="0" lon="0" rev="1200000"/>
-            </a:lightRig>
-          </a:scene3d>
-          <a:sp3d>
-            <a:bevelT w="63500" h="25400"/>
-          </a:sp3d>
-        </a:effectStyle>
-      </a:effectStyleLst>
-      <a:bgFillStyleLst>
-        <a:solidFill>
-          <a:schemeClr val="phClr"/>
-        </a:solidFill>
-        <a:gradFill rotWithShape="1">
-          <a:gsLst>
-            <a:gs pos="0">
-              <a:schemeClr val="phClr">
-                <a:tint val="40000"/>
-                <a:satMod val="350000"/>
-              </a:schemeClr>
-            </a:gs>
-            <a:gs pos="40000">
-              <a:schemeClr val="phClr">
-                <a:tint val="45000"/>
-                <a:shade val="99000"/>
-                <a:satMod val="350000"/>
-              </a:schemeClr>
-            </a:gs>
-            <a:gs pos="100000">
-              <a:schemeClr val="phClr">
-                <a:shade val="20000"/>
-                <a:satMod val="255000"/>
-              </a:schemeClr>
-            </a:gs>
-          </a:gsLst>
-          <a:path path="circle">
-            <a:fillToRect l="50000" t="-80000" r="50000" b="180000"/>
-          </a:path>
-        </a:gradFill>
-        <a:gradFill rotWithShape="1">
-          <a:gsLst>
-            <a:gs pos="0">
-              <a:schemeClr val="phClr">
-                <a:tint val="80000"/>
-                <a:satMod val="300000"/>
-              </a:schemeClr>
-            </a:gs>
-            <a:gs pos="100000">
-              <a:schemeClr val="phClr">
-                <a:shade val="30000"/>
-                <a:satMod val="200000"/>
-              </a:schemeClr>
-            </a:gs>
-          </a:gsLst>
-          <a:path path="circle">
-            <a:fillToRect l="50000" t="50000" r="50000" b="50000"/>
-          </a:path>
-        </a:gradFill>
-      </a:bgFillStyleLst>
-    </a:fmtScheme>
-  </a:themeElements>
-</a:theme>
 </file>
</xml_diff>

<commit_message>
Update Data Sources from LFX 2026-10-19 (#346)
Update Data Sources from LFX

Signed-off-by: github-actions[bot] <41898282+github-actions[bot]@users.noreply.github.com>
Co-authored-by: jmertic <296737+jmertic@users.noreply.github.com>
</commit_message>
<xml_diff>
--- a/overview_deck/LF Energy High Level Overview.pptx
+++ b/overview_deck/LF Energy High Level Overview.pptx
@@ -25946,7 +25946,7 @@
             <a:tbl>
               <a:tblPr>
                 <a:noFill/>
-                <a:tableStyleId>{38460B15-25ED-4A30-9E0A-DDD4A41D72A6}</a:tableStyleId>
+                <a:tableStyleId>{B88757F2-B4D0-4F89-9977-C34386016688}</a:tableStyleId>
               </a:tblPr>
               <a:tblGrid>
                 <a:gridCol w="1695200"/>
@@ -26736,7 +26736,7 @@
             <a:tbl>
               <a:tblPr>
                 <a:noFill/>
-                <a:tableStyleId>{38460B15-25ED-4A30-9E0A-DDD4A41D72A6}</a:tableStyleId>
+                <a:tableStyleId>{B88757F2-B4D0-4F89-9977-C34386016688}</a:tableStyleId>
               </a:tblPr>
               <a:tblGrid>
                 <a:gridCol w="1695200"/>
@@ -27426,7 +27426,7 @@
             <a:tbl>
               <a:tblPr>
                 <a:noFill/>
-                <a:tableStyleId>{38460B15-25ED-4A30-9E0A-DDD4A41D72A6}</a:tableStyleId>
+                <a:tableStyleId>{B88757F2-B4D0-4F89-9977-C34386016688}</a:tableStyleId>
               </a:tblPr>
               <a:tblGrid>
                 <a:gridCol w="1695200"/>
@@ -28678,7 +28678,7 @@
             <a:tbl>
               <a:tblPr>
                 <a:noFill/>
-                <a:tableStyleId>{38460B15-25ED-4A30-9E0A-DDD4A41D72A6}</a:tableStyleId>
+                <a:tableStyleId>{B88757F2-B4D0-4F89-9977-C34386016688}</a:tableStyleId>
               </a:tblPr>
               <a:tblGrid>
                 <a:gridCol w="1695200"/>
@@ -29670,7 +29670,7 @@
             <a:tbl>
               <a:tblPr>
                 <a:noFill/>
-                <a:tableStyleId>{38460B15-25ED-4A30-9E0A-DDD4A41D72A6}</a:tableStyleId>
+                <a:tableStyleId>{B88757F2-B4D0-4F89-9977-C34386016688}</a:tableStyleId>
               </a:tblPr>
               <a:tblGrid>
                 <a:gridCol w="3048000"/>
@@ -33175,7 +33175,7 @@
             <a:tbl>
               <a:tblPr>
                 <a:noFill/>
-                <a:tableStyleId>{38460B15-25ED-4A30-9E0A-DDD4A41D72A6}</a:tableStyleId>
+                <a:tableStyleId>{B88757F2-B4D0-4F89-9977-C34386016688}</a:tableStyleId>
               </a:tblPr>
               <a:tblGrid>
                 <a:gridCol w="1828800"/>

</xml_diff>

<commit_message>
Update Data Sources from LFX 2026-10-20 (#348)
Update Data Sources from LFX

Signed-off-by: github-actions[bot] <41898282+github-actions[bot]@users.noreply.github.com>
Co-authored-by: jmertic <296737+jmertic@users.noreply.github.com>
</commit_message>
<xml_diff>
--- a/overview_deck/LF Energy High Level Overview.pptx
+++ b/overview_deck/LF Energy High Level Overview.pptx
@@ -25946,7 +25946,7 @@
             <a:tbl>
               <a:tblPr>
                 <a:noFill/>
-                <a:tableStyleId>{B88757F2-B4D0-4F89-9977-C34386016688}</a:tableStyleId>
+                <a:tableStyleId>{C055FBE5-E7DB-4825-B173-92FA9CDC115A}</a:tableStyleId>
               </a:tblPr>
               <a:tblGrid>
                 <a:gridCol w="1695200"/>
@@ -26736,7 +26736,7 @@
             <a:tbl>
               <a:tblPr>
                 <a:noFill/>
-                <a:tableStyleId>{B88757F2-B4D0-4F89-9977-C34386016688}</a:tableStyleId>
+                <a:tableStyleId>{C055FBE5-E7DB-4825-B173-92FA9CDC115A}</a:tableStyleId>
               </a:tblPr>
               <a:tblGrid>
                 <a:gridCol w="1695200"/>
@@ -27426,7 +27426,7 @@
             <a:tbl>
               <a:tblPr>
                 <a:noFill/>
-                <a:tableStyleId>{B88757F2-B4D0-4F89-9977-C34386016688}</a:tableStyleId>
+                <a:tableStyleId>{C055FBE5-E7DB-4825-B173-92FA9CDC115A}</a:tableStyleId>
               </a:tblPr>
               <a:tblGrid>
                 <a:gridCol w="1695200"/>
@@ -28678,7 +28678,7 @@
             <a:tbl>
               <a:tblPr>
                 <a:noFill/>
-                <a:tableStyleId>{B88757F2-B4D0-4F89-9977-C34386016688}</a:tableStyleId>
+                <a:tableStyleId>{C055FBE5-E7DB-4825-B173-92FA9CDC115A}</a:tableStyleId>
               </a:tblPr>
               <a:tblGrid>
                 <a:gridCol w="1695200"/>
@@ -29670,7 +29670,7 @@
             <a:tbl>
               <a:tblPr>
                 <a:noFill/>
-                <a:tableStyleId>{B88757F2-B4D0-4F89-9977-C34386016688}</a:tableStyleId>
+                <a:tableStyleId>{C055FBE5-E7DB-4825-B173-92FA9CDC115A}</a:tableStyleId>
               </a:tblPr>
               <a:tblGrid>
                 <a:gridCol w="3048000"/>
@@ -33175,7 +33175,7 @@
             <a:tbl>
               <a:tblPr>
                 <a:noFill/>
-                <a:tableStyleId>{B88757F2-B4D0-4F89-9977-C34386016688}</a:tableStyleId>
+                <a:tableStyleId>{C055FBE5-E7DB-4825-B173-92FA9CDC115A}</a:tableStyleId>
               </a:tblPr>
               <a:tblGrid>
                 <a:gridCol w="1828800"/>
@@ -34002,9 +34002,9 @@
 </file>
 
 <file path=ppt/theme/theme1.xml><?xml version="1.0" encoding="utf-8"?>
-<a:theme xmlns:a="http://schemas.openxmlformats.org/drawingml/2006/main" xmlns:r="http://schemas.openxmlformats.org/officeDocument/2006/relationships">
+<a:theme xmlns:a="http://schemas.openxmlformats.org/drawingml/2006/main" xmlns:r="http://schemas.openxmlformats.org/officeDocument/2006/relationships" name="Simple Light">
   <a:themeElements>
-    <a:clrScheme name="Default">
+    <a:clrScheme name="Simple Light">
       <a:dk1>
         <a:srgbClr val="000000"/>
       </a:dk1>
@@ -34012,34 +34012,34 @@
         <a:srgbClr val="FFFFFF"/>
       </a:lt1>
       <a:dk2>
-        <a:srgbClr val="158158"/>
+        <a:srgbClr val="595959"/>
       </a:dk2>
       <a:lt2>
-        <a:srgbClr val="F3F3F3"/>
+        <a:srgbClr val="EEEEEE"/>
       </a:lt2>
       <a:accent1>
-        <a:srgbClr val="058DC7"/>
+        <a:srgbClr val="4285F4"/>
       </a:accent1>
       <a:accent2>
-        <a:srgbClr val="50B432"/>
+        <a:srgbClr val="212121"/>
       </a:accent2>
       <a:accent3>
-        <a:srgbClr val="ED561B"/>
+        <a:srgbClr val="78909C"/>
       </a:accent3>
       <a:accent4>
-        <a:srgbClr val="EDEF00"/>
+        <a:srgbClr val="FFAB40"/>
       </a:accent4>
       <a:accent5>
-        <a:srgbClr val="24CBE5"/>
+        <a:srgbClr val="0097A7"/>
       </a:accent5>
       <a:accent6>
-        <a:srgbClr val="64E572"/>
+        <a:srgbClr val="EEFF41"/>
       </a:accent6>
       <a:hlink>
-        <a:srgbClr val="2200CC"/>
+        <a:srgbClr val="0097A7"/>
       </a:hlink>
       <a:folHlink>
-        <a:srgbClr val="551A8B"/>
+        <a:srgbClr val="0097A7"/>
       </a:folHlink>
     </a:clrScheme>
     <a:fontScheme name="Office">
@@ -34560,9 +34560,9 @@
 </file>
 
 <file path=ppt/theme/theme3.xml><?xml version="1.0" encoding="utf-8"?>
-<a:theme xmlns:a="http://schemas.openxmlformats.org/drawingml/2006/main" xmlns:r="http://schemas.openxmlformats.org/officeDocument/2006/relationships" name="Simple Light">
+<a:theme xmlns:a="http://schemas.openxmlformats.org/drawingml/2006/main" xmlns:r="http://schemas.openxmlformats.org/officeDocument/2006/relationships">
   <a:themeElements>
-    <a:clrScheme name="Simple Light">
+    <a:clrScheme name="Default">
       <a:dk1>
         <a:srgbClr val="000000"/>
       </a:dk1>
@@ -34570,34 +34570,34 @@
         <a:srgbClr val="FFFFFF"/>
       </a:lt1>
       <a:dk2>
-        <a:srgbClr val="595959"/>
+        <a:srgbClr val="158158"/>
       </a:dk2>
       <a:lt2>
-        <a:srgbClr val="EEEEEE"/>
+        <a:srgbClr val="F3F3F3"/>
       </a:lt2>
       <a:accent1>
-        <a:srgbClr val="4285F4"/>
+        <a:srgbClr val="058DC7"/>
       </a:accent1>
       <a:accent2>
-        <a:srgbClr val="212121"/>
+        <a:srgbClr val="50B432"/>
       </a:accent2>
       <a:accent3>
-        <a:srgbClr val="78909C"/>
+        <a:srgbClr val="ED561B"/>
       </a:accent3>
       <a:accent4>
-        <a:srgbClr val="FFAB40"/>
+        <a:srgbClr val="EDEF00"/>
       </a:accent4>
       <a:accent5>
-        <a:srgbClr val="0097A7"/>
+        <a:srgbClr val="24CBE5"/>
       </a:accent5>
       <a:accent6>
-        <a:srgbClr val="EEFF41"/>
+        <a:srgbClr val="64E572"/>
       </a:accent6>
       <a:hlink>
-        <a:srgbClr val="0097A7"/>
+        <a:srgbClr val="2200CC"/>
       </a:hlink>
       <a:folHlink>
-        <a:srgbClr val="0097A7"/>
+        <a:srgbClr val="551A8B"/>
       </a:folHlink>
     </a:clrScheme>
     <a:fontScheme name="Office">

</xml_diff>

<commit_message>
Update Data Sources from LFX 2026-10-21 (#349)
Update Data Sources from LFX

Signed-off-by: github-actions[bot] <41898282+github-actions[bot]@users.noreply.github.com>
Co-authored-by: jmertic <296737+jmertic@users.noreply.github.com>
</commit_message>
<xml_diff>
--- a/overview_deck/LF Energy High Level Overview.pptx
+++ b/overview_deck/LF Energy High Level Overview.pptx
@@ -25946,7 +25946,7 @@
             <a:tbl>
               <a:tblPr>
                 <a:noFill/>
-                <a:tableStyleId>{C055FBE5-E7DB-4825-B173-92FA9CDC115A}</a:tableStyleId>
+                <a:tableStyleId>{2209E725-4619-46C2-B5AF-B407D870B5BC}</a:tableStyleId>
               </a:tblPr>
               <a:tblGrid>
                 <a:gridCol w="1695200"/>
@@ -26736,7 +26736,7 @@
             <a:tbl>
               <a:tblPr>
                 <a:noFill/>
-                <a:tableStyleId>{C055FBE5-E7DB-4825-B173-92FA9CDC115A}</a:tableStyleId>
+                <a:tableStyleId>{2209E725-4619-46C2-B5AF-B407D870B5BC}</a:tableStyleId>
               </a:tblPr>
               <a:tblGrid>
                 <a:gridCol w="1695200"/>
@@ -27426,7 +27426,7 @@
             <a:tbl>
               <a:tblPr>
                 <a:noFill/>
-                <a:tableStyleId>{C055FBE5-E7DB-4825-B173-92FA9CDC115A}</a:tableStyleId>
+                <a:tableStyleId>{2209E725-4619-46C2-B5AF-B407D870B5BC}</a:tableStyleId>
               </a:tblPr>
               <a:tblGrid>
                 <a:gridCol w="1695200"/>
@@ -28678,7 +28678,7 @@
             <a:tbl>
               <a:tblPr>
                 <a:noFill/>
-                <a:tableStyleId>{C055FBE5-E7DB-4825-B173-92FA9CDC115A}</a:tableStyleId>
+                <a:tableStyleId>{2209E725-4619-46C2-B5AF-B407D870B5BC}</a:tableStyleId>
               </a:tblPr>
               <a:tblGrid>
                 <a:gridCol w="1695200"/>
@@ -29670,7 +29670,7 @@
             <a:tbl>
               <a:tblPr>
                 <a:noFill/>
-                <a:tableStyleId>{C055FBE5-E7DB-4825-B173-92FA9CDC115A}</a:tableStyleId>
+                <a:tableStyleId>{2209E725-4619-46C2-B5AF-B407D870B5BC}</a:tableStyleId>
               </a:tblPr>
               <a:tblGrid>
                 <a:gridCol w="3048000"/>
@@ -33175,7 +33175,7 @@
             <a:tbl>
               <a:tblPr>
                 <a:noFill/>
-                <a:tableStyleId>{C055FBE5-E7DB-4825-B173-92FA9CDC115A}</a:tableStyleId>
+                <a:tableStyleId>{2209E725-4619-46C2-B5AF-B407D870B5BC}</a:tableStyleId>
               </a:tblPr>
               <a:tblGrid>
                 <a:gridCol w="1828800"/>
@@ -34002,44 +34002,44 @@
 </file>
 
 <file path=ppt/theme/theme1.xml><?xml version="1.0" encoding="utf-8"?>
-<a:theme xmlns:a="http://schemas.openxmlformats.org/drawingml/2006/main" xmlns:r="http://schemas.openxmlformats.org/officeDocument/2006/relationships" name="Simple Light">
+<a:theme xmlns:a="http://schemas.openxmlformats.org/drawingml/2006/main" xmlns:r="http://schemas.openxmlformats.org/officeDocument/2006/relationships" name="LF Energy Theme 2023">
   <a:themeElements>
-    <a:clrScheme name="Simple Light">
+    <a:clrScheme name="Geometric">
       <a:dk1>
-        <a:srgbClr val="000000"/>
+        <a:srgbClr val="222222"/>
       </a:dk1>
       <a:lt1>
         <a:srgbClr val="FFFFFF"/>
       </a:lt1>
       <a:dk2>
-        <a:srgbClr val="595959"/>
+        <a:srgbClr val="434343"/>
       </a:dk2>
       <a:lt2>
-        <a:srgbClr val="EEEEEE"/>
+        <a:srgbClr val="999999"/>
       </a:lt2>
       <a:accent1>
-        <a:srgbClr val="4285F4"/>
+        <a:srgbClr val="003778"/>
       </a:accent1>
       <a:accent2>
-        <a:srgbClr val="212121"/>
+        <a:srgbClr val="0094FF"/>
       </a:accent2>
       <a:accent3>
-        <a:srgbClr val="78909C"/>
+        <a:srgbClr val="5B1DE7"/>
       </a:accent3>
       <a:accent4>
-        <a:srgbClr val="FFAB40"/>
+        <a:srgbClr val="12E2E2"/>
       </a:accent4>
       <a:accent5>
-        <a:srgbClr val="0097A7"/>
+        <a:srgbClr val="FF00AA"/>
       </a:accent5>
       <a:accent6>
-        <a:srgbClr val="EEFF41"/>
+        <a:srgbClr val="ACDE1F"/>
       </a:accent6>
       <a:hlink>
-        <a:srgbClr val="0097A7"/>
+        <a:srgbClr val="0077CC"/>
       </a:hlink>
       <a:folHlink>
-        <a:srgbClr val="0097A7"/>
+        <a:srgbClr val="F06292"/>
       </a:folHlink>
     </a:clrScheme>
     <a:fontScheme name="Office">
@@ -34281,44 +34281,44 @@
 </file>
 
 <file path=ppt/theme/theme2.xml><?xml version="1.0" encoding="utf-8"?>
-<a:theme xmlns:a="http://schemas.openxmlformats.org/drawingml/2006/main" xmlns:r="http://schemas.openxmlformats.org/officeDocument/2006/relationships" name="LF Energy Theme 2023">
+<a:theme xmlns:a="http://schemas.openxmlformats.org/drawingml/2006/main" xmlns:r="http://schemas.openxmlformats.org/officeDocument/2006/relationships" name="Simple Light">
   <a:themeElements>
-    <a:clrScheme name="Geometric">
+    <a:clrScheme name="Simple Light">
       <a:dk1>
-        <a:srgbClr val="222222"/>
+        <a:srgbClr val="000000"/>
       </a:dk1>
       <a:lt1>
         <a:srgbClr val="FFFFFF"/>
       </a:lt1>
       <a:dk2>
-        <a:srgbClr val="434343"/>
+        <a:srgbClr val="595959"/>
       </a:dk2>
       <a:lt2>
-        <a:srgbClr val="999999"/>
+        <a:srgbClr val="EEEEEE"/>
       </a:lt2>
       <a:accent1>
-        <a:srgbClr val="003778"/>
+        <a:srgbClr val="4285F4"/>
       </a:accent1>
       <a:accent2>
-        <a:srgbClr val="0094FF"/>
+        <a:srgbClr val="212121"/>
       </a:accent2>
       <a:accent3>
-        <a:srgbClr val="5B1DE7"/>
+        <a:srgbClr val="78909C"/>
       </a:accent3>
       <a:accent4>
-        <a:srgbClr val="12E2E2"/>
+        <a:srgbClr val="FFAB40"/>
       </a:accent4>
       <a:accent5>
-        <a:srgbClr val="FF00AA"/>
+        <a:srgbClr val="0097A7"/>
       </a:accent5>
       <a:accent6>
-        <a:srgbClr val="ACDE1F"/>
+        <a:srgbClr val="EEFF41"/>
       </a:accent6>
       <a:hlink>
-        <a:srgbClr val="0077CC"/>
+        <a:srgbClr val="0097A7"/>
       </a:hlink>
       <a:folHlink>
-        <a:srgbClr val="F06292"/>
+        <a:srgbClr val="0097A7"/>
       </a:folHlink>
     </a:clrScheme>
     <a:fontScheme name="Office">

</xml_diff>

<commit_message>
Update Data Sources from LFX 2026-10-22 (#350)
Update Data Sources from LFX

Signed-off-by: github-actions[bot] <41898282+github-actions[bot]@users.noreply.github.com>
Co-authored-by: jmertic <296737+jmertic@users.noreply.github.com>
</commit_message>
<xml_diff>
--- a/overview_deck/LF Energy High Level Overview.pptx
+++ b/overview_deck/LF Energy High Level Overview.pptx
@@ -25946,7 +25946,7 @@
             <a:tbl>
               <a:tblPr>
                 <a:noFill/>
-                <a:tableStyleId>{2209E725-4619-46C2-B5AF-B407D870B5BC}</a:tableStyleId>
+                <a:tableStyleId>{499718C8-7B70-496B-A35B-B445A857B25C}</a:tableStyleId>
               </a:tblPr>
               <a:tblGrid>
                 <a:gridCol w="1695200"/>
@@ -26736,7 +26736,7 @@
             <a:tbl>
               <a:tblPr>
                 <a:noFill/>
-                <a:tableStyleId>{2209E725-4619-46C2-B5AF-B407D870B5BC}</a:tableStyleId>
+                <a:tableStyleId>{499718C8-7B70-496B-A35B-B445A857B25C}</a:tableStyleId>
               </a:tblPr>
               <a:tblGrid>
                 <a:gridCol w="1695200"/>
@@ -27426,7 +27426,7 @@
             <a:tbl>
               <a:tblPr>
                 <a:noFill/>
-                <a:tableStyleId>{2209E725-4619-46C2-B5AF-B407D870B5BC}</a:tableStyleId>
+                <a:tableStyleId>{499718C8-7B70-496B-A35B-B445A857B25C}</a:tableStyleId>
               </a:tblPr>
               <a:tblGrid>
                 <a:gridCol w="1695200"/>
@@ -28678,7 +28678,7 @@
             <a:tbl>
               <a:tblPr>
                 <a:noFill/>
-                <a:tableStyleId>{2209E725-4619-46C2-B5AF-B407D870B5BC}</a:tableStyleId>
+                <a:tableStyleId>{499718C8-7B70-496B-A35B-B445A857B25C}</a:tableStyleId>
               </a:tblPr>
               <a:tblGrid>
                 <a:gridCol w="1695200"/>
@@ -29670,7 +29670,7 @@
             <a:tbl>
               <a:tblPr>
                 <a:noFill/>
-                <a:tableStyleId>{2209E725-4619-46C2-B5AF-B407D870B5BC}</a:tableStyleId>
+                <a:tableStyleId>{499718C8-7B70-496B-A35B-B445A857B25C}</a:tableStyleId>
               </a:tblPr>
               <a:tblGrid>
                 <a:gridCol w="3048000"/>
@@ -33175,7 +33175,7 @@
             <a:tbl>
               <a:tblPr>
                 <a:noFill/>
-                <a:tableStyleId>{2209E725-4619-46C2-B5AF-B407D870B5BC}</a:tableStyleId>
+                <a:tableStyleId>{499718C8-7B70-496B-A35B-B445A857B25C}</a:tableStyleId>
               </a:tblPr>
               <a:tblGrid>
                 <a:gridCol w="1828800"/>

</xml_diff>

<commit_message>
Update Data Sources from LFX 2026-10-23 (#351)
Update Data Sources from LFX

Signed-off-by: github-actions[bot] <41898282+github-actions[bot]@users.noreply.github.com>
Co-authored-by: jmertic <296737+jmertic@users.noreply.github.com>
</commit_message>
<xml_diff>
--- a/overview_deck/LF Energy High Level Overview.pptx
+++ b/overview_deck/LF Energy High Level Overview.pptx
@@ -25946,7 +25946,7 @@
             <a:tbl>
               <a:tblPr>
                 <a:noFill/>
-                <a:tableStyleId>{499718C8-7B70-496B-A35B-B445A857B25C}</a:tableStyleId>
+                <a:tableStyleId>{9A307811-E172-4E01-96F1-1D3E465BE356}</a:tableStyleId>
               </a:tblPr>
               <a:tblGrid>
                 <a:gridCol w="1695200"/>
@@ -26736,7 +26736,7 @@
             <a:tbl>
               <a:tblPr>
                 <a:noFill/>
-                <a:tableStyleId>{499718C8-7B70-496B-A35B-B445A857B25C}</a:tableStyleId>
+                <a:tableStyleId>{9A307811-E172-4E01-96F1-1D3E465BE356}</a:tableStyleId>
               </a:tblPr>
               <a:tblGrid>
                 <a:gridCol w="1695200"/>
@@ -27426,7 +27426,7 @@
             <a:tbl>
               <a:tblPr>
                 <a:noFill/>
-                <a:tableStyleId>{499718C8-7B70-496B-A35B-B445A857B25C}</a:tableStyleId>
+                <a:tableStyleId>{9A307811-E172-4E01-96F1-1D3E465BE356}</a:tableStyleId>
               </a:tblPr>
               <a:tblGrid>
                 <a:gridCol w="1695200"/>
@@ -28678,7 +28678,7 @@
             <a:tbl>
               <a:tblPr>
                 <a:noFill/>
-                <a:tableStyleId>{499718C8-7B70-496B-A35B-B445A857B25C}</a:tableStyleId>
+                <a:tableStyleId>{9A307811-E172-4E01-96F1-1D3E465BE356}</a:tableStyleId>
               </a:tblPr>
               <a:tblGrid>
                 <a:gridCol w="1695200"/>
@@ -29670,7 +29670,7 @@
             <a:tbl>
               <a:tblPr>
                 <a:noFill/>
-                <a:tableStyleId>{499718C8-7B70-496B-A35B-B445A857B25C}</a:tableStyleId>
+                <a:tableStyleId>{9A307811-E172-4E01-96F1-1D3E465BE356}</a:tableStyleId>
               </a:tblPr>
               <a:tblGrid>
                 <a:gridCol w="3048000"/>
@@ -33175,7 +33175,7 @@
             <a:tbl>
               <a:tblPr>
                 <a:noFill/>
-                <a:tableStyleId>{499718C8-7B70-496B-A35B-B445A857B25C}</a:tableStyleId>
+                <a:tableStyleId>{9A307811-E172-4E01-96F1-1D3E465BE356}</a:tableStyleId>
               </a:tblPr>
               <a:tblGrid>
                 <a:gridCol w="1828800"/>
@@ -34002,44 +34002,44 @@
 </file>
 
 <file path=ppt/theme/theme1.xml><?xml version="1.0" encoding="utf-8"?>
-<a:theme xmlns:a="http://schemas.openxmlformats.org/drawingml/2006/main" xmlns:r="http://schemas.openxmlformats.org/officeDocument/2006/relationships" name="LF Energy Theme 2023">
+<a:theme xmlns:a="http://schemas.openxmlformats.org/drawingml/2006/main" xmlns:r="http://schemas.openxmlformats.org/officeDocument/2006/relationships" name="Simple Light">
   <a:themeElements>
-    <a:clrScheme name="Geometric">
+    <a:clrScheme name="Simple Light">
       <a:dk1>
-        <a:srgbClr val="222222"/>
+        <a:srgbClr val="000000"/>
       </a:dk1>
       <a:lt1>
         <a:srgbClr val="FFFFFF"/>
       </a:lt1>
       <a:dk2>
-        <a:srgbClr val="434343"/>
+        <a:srgbClr val="595959"/>
       </a:dk2>
       <a:lt2>
-        <a:srgbClr val="999999"/>
+        <a:srgbClr val="EEEEEE"/>
       </a:lt2>
       <a:accent1>
-        <a:srgbClr val="003778"/>
+        <a:srgbClr val="4285F4"/>
       </a:accent1>
       <a:accent2>
-        <a:srgbClr val="0094FF"/>
+        <a:srgbClr val="212121"/>
       </a:accent2>
       <a:accent3>
-        <a:srgbClr val="5B1DE7"/>
+        <a:srgbClr val="78909C"/>
       </a:accent3>
       <a:accent4>
-        <a:srgbClr val="12E2E2"/>
+        <a:srgbClr val="FFAB40"/>
       </a:accent4>
       <a:accent5>
-        <a:srgbClr val="FF00AA"/>
+        <a:srgbClr val="0097A7"/>
       </a:accent5>
       <a:accent6>
-        <a:srgbClr val="ACDE1F"/>
+        <a:srgbClr val="EEFF41"/>
       </a:accent6>
       <a:hlink>
-        <a:srgbClr val="0077CC"/>
+        <a:srgbClr val="0097A7"/>
       </a:hlink>
       <a:folHlink>
-        <a:srgbClr val="F06292"/>
+        <a:srgbClr val="0097A7"/>
       </a:folHlink>
     </a:clrScheme>
     <a:fontScheme name="Office">
@@ -34281,44 +34281,44 @@
 </file>
 
 <file path=ppt/theme/theme2.xml><?xml version="1.0" encoding="utf-8"?>
-<a:theme xmlns:a="http://schemas.openxmlformats.org/drawingml/2006/main" xmlns:r="http://schemas.openxmlformats.org/officeDocument/2006/relationships" name="Simple Light">
+<a:theme xmlns:a="http://schemas.openxmlformats.org/drawingml/2006/main" xmlns:r="http://schemas.openxmlformats.org/officeDocument/2006/relationships" name="LF Energy Theme 2023">
   <a:themeElements>
-    <a:clrScheme name="Simple Light">
+    <a:clrScheme name="Geometric">
       <a:dk1>
-        <a:srgbClr val="000000"/>
+        <a:srgbClr val="222222"/>
       </a:dk1>
       <a:lt1>
         <a:srgbClr val="FFFFFF"/>
       </a:lt1>
       <a:dk2>
-        <a:srgbClr val="595959"/>
+        <a:srgbClr val="434343"/>
       </a:dk2>
       <a:lt2>
-        <a:srgbClr val="EEEEEE"/>
+        <a:srgbClr val="999999"/>
       </a:lt2>
       <a:accent1>
-        <a:srgbClr val="4285F4"/>
+        <a:srgbClr val="003778"/>
       </a:accent1>
       <a:accent2>
-        <a:srgbClr val="212121"/>
+        <a:srgbClr val="0094FF"/>
       </a:accent2>
       <a:accent3>
-        <a:srgbClr val="78909C"/>
+        <a:srgbClr val="5B1DE7"/>
       </a:accent3>
       <a:accent4>
-        <a:srgbClr val="FFAB40"/>
+        <a:srgbClr val="12E2E2"/>
       </a:accent4>
       <a:accent5>
-        <a:srgbClr val="0097A7"/>
+        <a:srgbClr val="FF00AA"/>
       </a:accent5>
       <a:accent6>
-        <a:srgbClr val="EEFF41"/>
+        <a:srgbClr val="ACDE1F"/>
       </a:accent6>
       <a:hlink>
-        <a:srgbClr val="0097A7"/>
+        <a:srgbClr val="0077CC"/>
       </a:hlink>
       <a:folHlink>
-        <a:srgbClr val="0097A7"/>
+        <a:srgbClr val="F06292"/>
       </a:folHlink>
     </a:clrScheme>
     <a:fontScheme name="Office">

</xml_diff>

<commit_message>
Update Data Sources from LFX 2026-10-24 (#352)
Update Data Sources from LFX

Signed-off-by: github-actions[bot] <41898282+github-actions[bot]@users.noreply.github.com>
Co-authored-by: jmertic <296737+jmertic@users.noreply.github.com>
</commit_message>
<xml_diff>
--- a/overview_deck/LF Energy High Level Overview.pptx
+++ b/overview_deck/LF Energy High Level Overview.pptx
@@ -25946,7 +25946,7 @@
             <a:tbl>
               <a:tblPr>
                 <a:noFill/>
-                <a:tableStyleId>{9A307811-E172-4E01-96F1-1D3E465BE356}</a:tableStyleId>
+                <a:tableStyleId>{3E152A79-7DA0-45A2-B214-F2CD6FB42C79}</a:tableStyleId>
               </a:tblPr>
               <a:tblGrid>
                 <a:gridCol w="1695200"/>
@@ -26736,7 +26736,7 @@
             <a:tbl>
               <a:tblPr>
                 <a:noFill/>
-                <a:tableStyleId>{9A307811-E172-4E01-96F1-1D3E465BE356}</a:tableStyleId>
+                <a:tableStyleId>{3E152A79-7DA0-45A2-B214-F2CD6FB42C79}</a:tableStyleId>
               </a:tblPr>
               <a:tblGrid>
                 <a:gridCol w="1695200"/>
@@ -27426,7 +27426,7 @@
             <a:tbl>
               <a:tblPr>
                 <a:noFill/>
-                <a:tableStyleId>{9A307811-E172-4E01-96F1-1D3E465BE356}</a:tableStyleId>
+                <a:tableStyleId>{3E152A79-7DA0-45A2-B214-F2CD6FB42C79}</a:tableStyleId>
               </a:tblPr>
               <a:tblGrid>
                 <a:gridCol w="1695200"/>
@@ -28678,7 +28678,7 @@
             <a:tbl>
               <a:tblPr>
                 <a:noFill/>
-                <a:tableStyleId>{9A307811-E172-4E01-96F1-1D3E465BE356}</a:tableStyleId>
+                <a:tableStyleId>{3E152A79-7DA0-45A2-B214-F2CD6FB42C79}</a:tableStyleId>
               </a:tblPr>
               <a:tblGrid>
                 <a:gridCol w="1695200"/>
@@ -29670,7 +29670,7 @@
             <a:tbl>
               <a:tblPr>
                 <a:noFill/>
-                <a:tableStyleId>{9A307811-E172-4E01-96F1-1D3E465BE356}</a:tableStyleId>
+                <a:tableStyleId>{3E152A79-7DA0-45A2-B214-F2CD6FB42C79}</a:tableStyleId>
               </a:tblPr>
               <a:tblGrid>
                 <a:gridCol w="3048000"/>
@@ -33175,7 +33175,7 @@
             <a:tbl>
               <a:tblPr>
                 <a:noFill/>
-                <a:tableStyleId>{9A307811-E172-4E01-96F1-1D3E465BE356}</a:tableStyleId>
+                <a:tableStyleId>{3E152A79-7DA0-45A2-B214-F2CD6FB42C79}</a:tableStyleId>
               </a:tblPr>
               <a:tblGrid>
                 <a:gridCol w="1828800"/>
@@ -34002,9 +34002,9 @@
 </file>
 
 <file path=ppt/theme/theme1.xml><?xml version="1.0" encoding="utf-8"?>
-<a:theme xmlns:a="http://schemas.openxmlformats.org/drawingml/2006/main" xmlns:r="http://schemas.openxmlformats.org/officeDocument/2006/relationships" name="Simple Light">
+<a:theme xmlns:a="http://schemas.openxmlformats.org/drawingml/2006/main" xmlns:r="http://schemas.openxmlformats.org/officeDocument/2006/relationships">
   <a:themeElements>
-    <a:clrScheme name="Simple Light">
+    <a:clrScheme name="Default">
       <a:dk1>
         <a:srgbClr val="000000"/>
       </a:dk1>
@@ -34012,34 +34012,34 @@
         <a:srgbClr val="FFFFFF"/>
       </a:lt1>
       <a:dk2>
-        <a:srgbClr val="595959"/>
+        <a:srgbClr val="158158"/>
       </a:dk2>
       <a:lt2>
-        <a:srgbClr val="EEEEEE"/>
+        <a:srgbClr val="F3F3F3"/>
       </a:lt2>
       <a:accent1>
-        <a:srgbClr val="4285F4"/>
+        <a:srgbClr val="058DC7"/>
       </a:accent1>
       <a:accent2>
-        <a:srgbClr val="212121"/>
+        <a:srgbClr val="50B432"/>
       </a:accent2>
       <a:accent3>
-        <a:srgbClr val="78909C"/>
+        <a:srgbClr val="ED561B"/>
       </a:accent3>
       <a:accent4>
-        <a:srgbClr val="FFAB40"/>
+        <a:srgbClr val="EDEF00"/>
       </a:accent4>
       <a:accent5>
-        <a:srgbClr val="0097A7"/>
+        <a:srgbClr val="24CBE5"/>
       </a:accent5>
       <a:accent6>
-        <a:srgbClr val="EEFF41"/>
+        <a:srgbClr val="64E572"/>
       </a:accent6>
       <a:hlink>
-        <a:srgbClr val="0097A7"/>
+        <a:srgbClr val="2200CC"/>
       </a:hlink>
       <a:folHlink>
-        <a:srgbClr val="0097A7"/>
+        <a:srgbClr val="551A8B"/>
       </a:folHlink>
     </a:clrScheme>
     <a:fontScheme name="Office">
@@ -34560,9 +34560,9 @@
 </file>
 
 <file path=ppt/theme/theme3.xml><?xml version="1.0" encoding="utf-8"?>
-<a:theme xmlns:a="http://schemas.openxmlformats.org/drawingml/2006/main" xmlns:r="http://schemas.openxmlformats.org/officeDocument/2006/relationships">
+<a:theme xmlns:a="http://schemas.openxmlformats.org/drawingml/2006/main" xmlns:r="http://schemas.openxmlformats.org/officeDocument/2006/relationships" name="Simple Light">
   <a:themeElements>
-    <a:clrScheme name="Default">
+    <a:clrScheme name="Simple Light">
       <a:dk1>
         <a:srgbClr val="000000"/>
       </a:dk1>
@@ -34570,34 +34570,34 @@
         <a:srgbClr val="FFFFFF"/>
       </a:lt1>
       <a:dk2>
-        <a:srgbClr val="158158"/>
+        <a:srgbClr val="595959"/>
       </a:dk2>
       <a:lt2>
-        <a:srgbClr val="F3F3F3"/>
+        <a:srgbClr val="EEEEEE"/>
       </a:lt2>
       <a:accent1>
-        <a:srgbClr val="058DC7"/>
+        <a:srgbClr val="4285F4"/>
       </a:accent1>
       <a:accent2>
-        <a:srgbClr val="50B432"/>
+        <a:srgbClr val="212121"/>
       </a:accent2>
       <a:accent3>
-        <a:srgbClr val="ED561B"/>
+        <a:srgbClr val="78909C"/>
       </a:accent3>
       <a:accent4>
-        <a:srgbClr val="EDEF00"/>
+        <a:srgbClr val="FFAB40"/>
       </a:accent4>
       <a:accent5>
-        <a:srgbClr val="24CBE5"/>
+        <a:srgbClr val="0097A7"/>
       </a:accent5>
       <a:accent6>
-        <a:srgbClr val="64E572"/>
+        <a:srgbClr val="EEFF41"/>
       </a:accent6>
       <a:hlink>
-        <a:srgbClr val="2200CC"/>
+        <a:srgbClr val="0097A7"/>
       </a:hlink>
       <a:folHlink>
-        <a:srgbClr val="551A8B"/>
+        <a:srgbClr val="0097A7"/>
       </a:folHlink>
     </a:clrScheme>
     <a:fontScheme name="Office">

</xml_diff>

<commit_message>
Update Data Sources from LFX 2026-10-25 (#353)
Update Data Sources from LFX

Signed-off-by: github-actions[bot] <41898282+github-actions[bot]@users.noreply.github.com>
Co-authored-by: jmertic <296737+jmertic@users.noreply.github.com>
</commit_message>
<xml_diff>
--- a/overview_deck/LF Energy High Level Overview.pptx
+++ b/overview_deck/LF Energy High Level Overview.pptx
@@ -25946,7 +25946,7 @@
             <a:tbl>
               <a:tblPr>
                 <a:noFill/>
-                <a:tableStyleId>{3E152A79-7DA0-45A2-B214-F2CD6FB42C79}</a:tableStyleId>
+                <a:tableStyleId>{B80D0C47-2438-47AF-B457-F5EB1A81DCF8}</a:tableStyleId>
               </a:tblPr>
               <a:tblGrid>
                 <a:gridCol w="1695200"/>
@@ -26736,7 +26736,7 @@
             <a:tbl>
               <a:tblPr>
                 <a:noFill/>
-                <a:tableStyleId>{3E152A79-7DA0-45A2-B214-F2CD6FB42C79}</a:tableStyleId>
+                <a:tableStyleId>{B80D0C47-2438-47AF-B457-F5EB1A81DCF8}</a:tableStyleId>
               </a:tblPr>
               <a:tblGrid>
                 <a:gridCol w="1695200"/>
@@ -27426,7 +27426,7 @@
             <a:tbl>
               <a:tblPr>
                 <a:noFill/>
-                <a:tableStyleId>{3E152A79-7DA0-45A2-B214-F2CD6FB42C79}</a:tableStyleId>
+                <a:tableStyleId>{B80D0C47-2438-47AF-B457-F5EB1A81DCF8}</a:tableStyleId>
               </a:tblPr>
               <a:tblGrid>
                 <a:gridCol w="1695200"/>
@@ -28678,7 +28678,7 @@
             <a:tbl>
               <a:tblPr>
                 <a:noFill/>
-                <a:tableStyleId>{3E152A79-7DA0-45A2-B214-F2CD6FB42C79}</a:tableStyleId>
+                <a:tableStyleId>{B80D0C47-2438-47AF-B457-F5EB1A81DCF8}</a:tableStyleId>
               </a:tblPr>
               <a:tblGrid>
                 <a:gridCol w="1695200"/>
@@ -29670,7 +29670,7 @@
             <a:tbl>
               <a:tblPr>
                 <a:noFill/>
-                <a:tableStyleId>{3E152A79-7DA0-45A2-B214-F2CD6FB42C79}</a:tableStyleId>
+                <a:tableStyleId>{B80D0C47-2438-47AF-B457-F5EB1A81DCF8}</a:tableStyleId>
               </a:tblPr>
               <a:tblGrid>
                 <a:gridCol w="3048000"/>
@@ -33175,7 +33175,7 @@
             <a:tbl>
               <a:tblPr>
                 <a:noFill/>
-                <a:tableStyleId>{3E152A79-7DA0-45A2-B214-F2CD6FB42C79}</a:tableStyleId>
+                <a:tableStyleId>{B80D0C47-2438-47AF-B457-F5EB1A81DCF8}</a:tableStyleId>
               </a:tblPr>
               <a:tblGrid>
                 <a:gridCol w="1828800"/>
@@ -34002,285 +34002,6 @@
 </file>
 
 <file path=ppt/theme/theme1.xml><?xml version="1.0" encoding="utf-8"?>
-<a:theme xmlns:a="http://schemas.openxmlformats.org/drawingml/2006/main" xmlns:r="http://schemas.openxmlformats.org/officeDocument/2006/relationships">
-  <a:themeElements>
-    <a:clrScheme name="Default">
-      <a:dk1>
-        <a:srgbClr val="000000"/>
-      </a:dk1>
-      <a:lt1>
-        <a:srgbClr val="FFFFFF"/>
-      </a:lt1>
-      <a:dk2>
-        <a:srgbClr val="158158"/>
-      </a:dk2>
-      <a:lt2>
-        <a:srgbClr val="F3F3F3"/>
-      </a:lt2>
-      <a:accent1>
-        <a:srgbClr val="058DC7"/>
-      </a:accent1>
-      <a:accent2>
-        <a:srgbClr val="50B432"/>
-      </a:accent2>
-      <a:accent3>
-        <a:srgbClr val="ED561B"/>
-      </a:accent3>
-      <a:accent4>
-        <a:srgbClr val="EDEF00"/>
-      </a:accent4>
-      <a:accent5>
-        <a:srgbClr val="24CBE5"/>
-      </a:accent5>
-      <a:accent6>
-        <a:srgbClr val="64E572"/>
-      </a:accent6>
-      <a:hlink>
-        <a:srgbClr val="2200CC"/>
-      </a:hlink>
-      <a:folHlink>
-        <a:srgbClr val="551A8B"/>
-      </a:folHlink>
-    </a:clrScheme>
-    <a:fontScheme name="Office">
-      <a:majorFont>
-        <a:latin typeface="Arial"/>
-        <a:ea typeface=""/>
-        <a:cs typeface=""/>
-        <a:font script="Jpan" typeface="ＭＳ Ｐゴシック"/>
-        <a:font script="Hang" typeface="맑은 고딕"/>
-        <a:font script="Hans" typeface="宋体"/>
-        <a:font script="Hant" typeface="新細明體"/>
-        <a:font script="Arab" typeface="Times New Roman"/>
-        <a:font script="Hebr" typeface="Times New Roman"/>
-        <a:font script="Thai" typeface="Angsana New"/>
-        <a:font script="Ethi" typeface="Nyala"/>
-        <a:font script="Beng" typeface="Vrinda"/>
-        <a:font script="Gujr" typeface="Shruti"/>
-        <a:font script="Khmr" typeface="MoolBoran"/>
-        <a:font script="Knda" typeface="Tunga"/>
-        <a:font script="Guru" typeface="Raavi"/>
-        <a:font script="Cans" typeface="Euphemia"/>
-        <a:font script="Cher" typeface="Plantagenet Cherokee"/>
-        <a:font script="Yiii" typeface="Microsoft Yi Baiti"/>
-        <a:font script="Tibt" typeface="Microsoft Himalaya"/>
-        <a:font script="Thaa" typeface="MV Boli"/>
-        <a:font script="Deva" typeface="Mangal"/>
-        <a:font script="Telu" typeface="Gautami"/>
-        <a:font script="Taml" typeface="Latha"/>
-        <a:font script="Syrc" typeface="Estrangelo Edessa"/>
-        <a:font script="Orya" typeface="Kalinga"/>
-        <a:font script="Mlym" typeface="Kartika"/>
-        <a:font script="Laoo" typeface="DokChampa"/>
-        <a:font script="Sinh" typeface="Iskoola Pota"/>
-        <a:font script="Mong" typeface="Mongolian Baiti"/>
-        <a:font script="Viet" typeface="Times New Roman"/>
-        <a:font script="Uigh" typeface="Microsoft Uighur"/>
-        <a:font script="Geor" typeface="Sylfaen"/>
-      </a:majorFont>
-      <a:minorFont>
-        <a:latin typeface="Arial"/>
-        <a:ea typeface=""/>
-        <a:cs typeface=""/>
-        <a:font script="Jpan" typeface="ＭＳ Ｐゴシック"/>
-        <a:font script="Hang" typeface="맑은 고딕"/>
-        <a:font script="Hans" typeface="宋体"/>
-        <a:font script="Hant" typeface="新細明體"/>
-        <a:font script="Arab" typeface="Arial"/>
-        <a:font script="Hebr" typeface="Arial"/>
-        <a:font script="Thai" typeface="Cordia New"/>
-        <a:font script="Ethi" typeface="Nyala"/>
-        <a:font script="Beng" typeface="Vrinda"/>
-        <a:font script="Gujr" typeface="Shruti"/>
-        <a:font script="Khmr" typeface="DaunPenh"/>
-        <a:font script="Knda" typeface="Tunga"/>
-        <a:font script="Guru" typeface="Raavi"/>
-        <a:font script="Cans" typeface="Euphemia"/>
-        <a:font script="Cher" typeface="Plantagenet Cherokee"/>
-        <a:font script="Yiii" typeface="Microsoft Yi Baiti"/>
-        <a:font script="Tibt" typeface="Microsoft Himalaya"/>
-        <a:font script="Thaa" typeface="MV Boli"/>
-        <a:font script="Deva" typeface="Mangal"/>
-        <a:font script="Telu" typeface="Gautami"/>
-        <a:font script="Taml" typeface="Latha"/>
-        <a:font script="Syrc" typeface="Estrangelo Edessa"/>
-        <a:font script="Orya" typeface="Kalinga"/>
-        <a:font script="Mlym" typeface="Kartika"/>
-        <a:font script="Laoo" typeface="DokChampa"/>
-        <a:font script="Sinh" typeface="Iskoola Pota"/>
-        <a:font script="Mong" typeface="Mongolian Baiti"/>
-        <a:font script="Viet" typeface="Arial"/>
-        <a:font script="Uigh" typeface="Microsoft Uighur"/>
-        <a:font script="Geor" typeface="Sylfaen"/>
-      </a:minorFont>
-    </a:fontScheme>
-    <a:fmtScheme name="Office">
-      <a:fillStyleLst>
-        <a:solidFill>
-          <a:schemeClr val="phClr"/>
-        </a:solidFill>
-        <a:gradFill rotWithShape="1">
-          <a:gsLst>
-            <a:gs pos="0">
-              <a:schemeClr val="phClr">
-                <a:tint val="50000"/>
-                <a:satMod val="300000"/>
-              </a:schemeClr>
-            </a:gs>
-            <a:gs pos="35000">
-              <a:schemeClr val="phClr">
-                <a:tint val="37000"/>
-                <a:satMod val="300000"/>
-              </a:schemeClr>
-            </a:gs>
-            <a:gs pos="100000">
-              <a:schemeClr val="phClr">
-                <a:tint val="15000"/>
-                <a:satMod val="350000"/>
-              </a:schemeClr>
-            </a:gs>
-          </a:gsLst>
-          <a:lin ang="16200000" scaled="1"/>
-        </a:gradFill>
-        <a:gradFill rotWithShape="1">
-          <a:gsLst>
-            <a:gs pos="0">
-              <a:schemeClr val="phClr">
-                <a:tint val="100000"/>
-                <a:shade val="100000"/>
-                <a:satMod val="130000"/>
-              </a:schemeClr>
-            </a:gs>
-            <a:gs pos="100000">
-              <a:schemeClr val="phClr">
-                <a:tint val="50000"/>
-                <a:shade val="100000"/>
-                <a:satMod val="350000"/>
-              </a:schemeClr>
-            </a:gs>
-          </a:gsLst>
-          <a:lin ang="16200000" scaled="0"/>
-        </a:gradFill>
-      </a:fillStyleLst>
-      <a:lnStyleLst>
-        <a:ln w="9525" cap="flat" cmpd="sng" algn="ctr">
-          <a:solidFill>
-            <a:schemeClr val="phClr">
-              <a:shade val="95000"/>
-              <a:satMod val="105000"/>
-            </a:schemeClr>
-          </a:solidFill>
-          <a:prstDash val="solid"/>
-        </a:ln>
-        <a:ln w="25400" cap="flat" cmpd="sng" algn="ctr">
-          <a:solidFill>
-            <a:schemeClr val="phClr"/>
-          </a:solidFill>
-          <a:prstDash val="solid"/>
-        </a:ln>
-        <a:ln w="38100" cap="flat" cmpd="sng" algn="ctr">
-          <a:solidFill>
-            <a:schemeClr val="phClr"/>
-          </a:solidFill>
-          <a:prstDash val="solid"/>
-        </a:ln>
-      </a:lnStyleLst>
-      <a:effectStyleLst>
-        <a:effectStyle>
-          <a:effectLst>
-            <a:outerShdw blurRad="40000" dist="20000" dir="5400000" rotWithShape="0">
-              <a:srgbClr val="000000">
-                <a:alpha val="38000"/>
-              </a:srgbClr>
-            </a:outerShdw>
-          </a:effectLst>
-        </a:effectStyle>
-        <a:effectStyle>
-          <a:effectLst>
-            <a:outerShdw blurRad="40000" dist="23000" dir="5400000" rotWithShape="0">
-              <a:srgbClr val="000000">
-                <a:alpha val="35000"/>
-              </a:srgbClr>
-            </a:outerShdw>
-          </a:effectLst>
-        </a:effectStyle>
-        <a:effectStyle>
-          <a:effectLst>
-            <a:outerShdw blurRad="40000" dist="23000" dir="5400000" rotWithShape="0">
-              <a:srgbClr val="000000">
-                <a:alpha val="35000"/>
-              </a:srgbClr>
-            </a:outerShdw>
-          </a:effectLst>
-          <a:scene3d>
-            <a:camera prst="orthographicFront">
-              <a:rot lat="0" lon="0" rev="0"/>
-            </a:camera>
-            <a:lightRig rig="threePt" dir="t">
-              <a:rot lat="0" lon="0" rev="1200000"/>
-            </a:lightRig>
-          </a:scene3d>
-          <a:sp3d>
-            <a:bevelT w="63500" h="25400"/>
-          </a:sp3d>
-        </a:effectStyle>
-      </a:effectStyleLst>
-      <a:bgFillStyleLst>
-        <a:solidFill>
-          <a:schemeClr val="phClr"/>
-        </a:solidFill>
-        <a:gradFill rotWithShape="1">
-          <a:gsLst>
-            <a:gs pos="0">
-              <a:schemeClr val="phClr">
-                <a:tint val="40000"/>
-                <a:satMod val="350000"/>
-              </a:schemeClr>
-            </a:gs>
-            <a:gs pos="40000">
-              <a:schemeClr val="phClr">
-                <a:tint val="45000"/>
-                <a:shade val="99000"/>
-                <a:satMod val="350000"/>
-              </a:schemeClr>
-            </a:gs>
-            <a:gs pos="100000">
-              <a:schemeClr val="phClr">
-                <a:shade val="20000"/>
-                <a:satMod val="255000"/>
-              </a:schemeClr>
-            </a:gs>
-          </a:gsLst>
-          <a:path path="circle">
-            <a:fillToRect l="50000" t="-80000" r="50000" b="180000"/>
-          </a:path>
-        </a:gradFill>
-        <a:gradFill rotWithShape="1">
-          <a:gsLst>
-            <a:gs pos="0">
-              <a:schemeClr val="phClr">
-                <a:tint val="80000"/>
-                <a:satMod val="300000"/>
-              </a:schemeClr>
-            </a:gs>
-            <a:gs pos="100000">
-              <a:schemeClr val="phClr">
-                <a:shade val="30000"/>
-                <a:satMod val="200000"/>
-              </a:schemeClr>
-            </a:gs>
-          </a:gsLst>
-          <a:path path="circle">
-            <a:fillToRect l="50000" t="50000" r="50000" b="50000"/>
-          </a:path>
-        </a:gradFill>
-      </a:bgFillStyleLst>
-    </a:fmtScheme>
-  </a:themeElements>
-</a:theme>
-</file>
-
-<file path=ppt/theme/theme2.xml><?xml version="1.0" encoding="utf-8"?>
 <a:theme xmlns:a="http://schemas.openxmlformats.org/drawingml/2006/main" xmlns:r="http://schemas.openxmlformats.org/officeDocument/2006/relationships" name="LF Energy Theme 2023">
   <a:themeElements>
     <a:clrScheme name="Geometric">
@@ -34559,7 +34280,7 @@
 </a:theme>
 </file>
 
-<file path=ppt/theme/theme3.xml><?xml version="1.0" encoding="utf-8"?>
+<file path=ppt/theme/theme2.xml><?xml version="1.0" encoding="utf-8"?>
 <a:theme xmlns:a="http://schemas.openxmlformats.org/drawingml/2006/main" xmlns:r="http://schemas.openxmlformats.org/officeDocument/2006/relationships" name="Simple Light">
   <a:themeElements>
     <a:clrScheme name="Simple Light">
@@ -34836,4 +34557,283 @@
     </a:fmtScheme>
   </a:themeElements>
 </a:theme>
+</file>
+
+<file path=ppt/theme/theme3.xml><?xml version="1.0" encoding="utf-8"?>
+<a:theme xmlns:a="http://schemas.openxmlformats.org/drawingml/2006/main" xmlns:r="http://schemas.openxmlformats.org/officeDocument/2006/relationships">
+  <a:themeElements>
+    <a:clrScheme name="Default">
+      <a:dk1>
+        <a:srgbClr val="000000"/>
+      </a:dk1>
+      <a:lt1>
+        <a:srgbClr val="FFFFFF"/>
+      </a:lt1>
+      <a:dk2>
+        <a:srgbClr val="158158"/>
+      </a:dk2>
+      <a:lt2>
+        <a:srgbClr val="F3F3F3"/>
+      </a:lt2>
+      <a:accent1>
+        <a:srgbClr val="058DC7"/>
+      </a:accent1>
+      <a:accent2>
+        <a:srgbClr val="50B432"/>
+      </a:accent2>
+      <a:accent3>
+        <a:srgbClr val="ED561B"/>
+      </a:accent3>
+      <a:accent4>
+        <a:srgbClr val="EDEF00"/>
+      </a:accent4>
+      <a:accent5>
+        <a:srgbClr val="24CBE5"/>
+      </a:accent5>
+      <a:accent6>
+        <a:srgbClr val="64E572"/>
+      </a:accent6>
+      <a:hlink>
+        <a:srgbClr val="2200CC"/>
+      </a:hlink>
+      <a:folHlink>
+        <a:srgbClr val="551A8B"/>
+      </a:folHlink>
+    </a:clrScheme>
+    <a:fontScheme name="Office">
+      <a:majorFont>
+        <a:latin typeface="Arial"/>
+        <a:ea typeface=""/>
+        <a:cs typeface=""/>
+        <a:font script="Jpan" typeface="ＭＳ Ｐゴシック"/>
+        <a:font script="Hang" typeface="맑은 고딕"/>
+        <a:font script="Hans" typeface="宋体"/>
+        <a:font script="Hant" typeface="新細明體"/>
+        <a:font script="Arab" typeface="Times New Roman"/>
+        <a:font script="Hebr" typeface="Times New Roman"/>
+        <a:font script="Thai" typeface="Angsana New"/>
+        <a:font script="Ethi" typeface="Nyala"/>
+        <a:font script="Beng" typeface="Vrinda"/>
+        <a:font script="Gujr" typeface="Shruti"/>
+        <a:font script="Khmr" typeface="MoolBoran"/>
+        <a:font script="Knda" typeface="Tunga"/>
+        <a:font script="Guru" typeface="Raavi"/>
+        <a:font script="Cans" typeface="Euphemia"/>
+        <a:font script="Cher" typeface="Plantagenet Cherokee"/>
+        <a:font script="Yiii" typeface="Microsoft Yi Baiti"/>
+        <a:font script="Tibt" typeface="Microsoft Himalaya"/>
+        <a:font script="Thaa" typeface="MV Boli"/>
+        <a:font script="Deva" typeface="Mangal"/>
+        <a:font script="Telu" typeface="Gautami"/>
+        <a:font script="Taml" typeface="Latha"/>
+        <a:font script="Syrc" typeface="Estrangelo Edessa"/>
+        <a:font script="Orya" typeface="Kalinga"/>
+        <a:font script="Mlym" typeface="Kartika"/>
+        <a:font script="Laoo" typeface="DokChampa"/>
+        <a:font script="Sinh" typeface="Iskoola Pota"/>
+        <a:font script="Mong" typeface="Mongolian Baiti"/>
+        <a:font script="Viet" typeface="Times New Roman"/>
+        <a:font script="Uigh" typeface="Microsoft Uighur"/>
+        <a:font script="Geor" typeface="Sylfaen"/>
+      </a:majorFont>
+      <a:minorFont>
+        <a:latin typeface="Arial"/>
+        <a:ea typeface=""/>
+        <a:cs typeface=""/>
+        <a:font script="Jpan" typeface="ＭＳ Ｐゴシック"/>
+        <a:font script="Hang" typeface="맑은 고딕"/>
+        <a:font script="Hans" typeface="宋体"/>
+        <a:font script="Hant" typeface="新細明體"/>
+        <a:font script="Arab" typeface="Arial"/>
+        <a:font script="Hebr" typeface="Arial"/>
+        <a:font script="Thai" typeface="Cordia New"/>
+        <a:font script="Ethi" typeface="Nyala"/>
+        <a:font script="Beng" typeface="Vrinda"/>
+        <a:font script="Gujr" typeface="Shruti"/>
+        <a:font script="Khmr" typeface="DaunPenh"/>
+        <a:font script="Knda" typeface="Tunga"/>
+        <a:font script="Guru" typeface="Raavi"/>
+        <a:font script="Cans" typeface="Euphemia"/>
+        <a:font script="Cher" typeface="Plantagenet Cherokee"/>
+        <a:font script="Yiii" typeface="Microsoft Yi Baiti"/>
+        <a:font script="Tibt" typeface="Microsoft Himalaya"/>
+        <a:font script="Thaa" typeface="MV Boli"/>
+        <a:font script="Deva" typeface="Mangal"/>
+        <a:font script="Telu" typeface="Gautami"/>
+        <a:font script="Taml" typeface="Latha"/>
+        <a:font script="Syrc" typeface="Estrangelo Edessa"/>
+        <a:font script="Orya" typeface="Kalinga"/>
+        <a:font script="Mlym" typeface="Kartika"/>
+        <a:font script="Laoo" typeface="DokChampa"/>
+        <a:font script="Sinh" typeface="Iskoola Pota"/>
+        <a:font script="Mong" typeface="Mongolian Baiti"/>
+        <a:font script="Viet" typeface="Arial"/>
+        <a:font script="Uigh" typeface="Microsoft Uighur"/>
+        <a:font script="Geor" typeface="Sylfaen"/>
+      </a:minorFont>
+    </a:fontScheme>
+    <a:fmtScheme name="Office">
+      <a:fillStyleLst>
+        <a:solidFill>
+          <a:schemeClr val="phClr"/>
+        </a:solidFill>
+        <a:gradFill rotWithShape="1">
+          <a:gsLst>
+            <a:gs pos="0">
+              <a:schemeClr val="phClr">
+                <a:tint val="50000"/>
+                <a:satMod val="300000"/>
+              </a:schemeClr>
+            </a:gs>
+            <a:gs pos="35000">
+              <a:schemeClr val="phClr">
+                <a:tint val="37000"/>
+                <a:satMod val="300000"/>
+              </a:schemeClr>
+            </a:gs>
+            <a:gs pos="100000">
+              <a:schemeClr val="phClr">
+                <a:tint val="15000"/>
+                <a:satMod val="350000"/>
+              </a:schemeClr>
+            </a:gs>
+          </a:gsLst>
+          <a:lin ang="16200000" scaled="1"/>
+        </a:gradFill>
+        <a:gradFill rotWithShape="1">
+          <a:gsLst>
+            <a:gs pos="0">
+              <a:schemeClr val="phClr">
+                <a:tint val="100000"/>
+                <a:shade val="100000"/>
+                <a:satMod val="130000"/>
+              </a:schemeClr>
+            </a:gs>
+            <a:gs pos="100000">
+              <a:schemeClr val="phClr">
+                <a:tint val="50000"/>
+                <a:shade val="100000"/>
+                <a:satMod val="350000"/>
+              </a:schemeClr>
+            </a:gs>
+          </a:gsLst>
+          <a:lin ang="16200000" scaled="0"/>
+        </a:gradFill>
+      </a:fillStyleLst>
+      <a:lnStyleLst>
+        <a:ln w="9525" cap="flat" cmpd="sng" algn="ctr">
+          <a:solidFill>
+            <a:schemeClr val="phClr">
+              <a:shade val="95000"/>
+              <a:satMod val="105000"/>
+            </a:schemeClr>
+          </a:solidFill>
+          <a:prstDash val="solid"/>
+        </a:ln>
+        <a:ln w="25400" cap="flat" cmpd="sng" algn="ctr">
+          <a:solidFill>
+            <a:schemeClr val="phClr"/>
+          </a:solidFill>
+          <a:prstDash val="solid"/>
+        </a:ln>
+        <a:ln w="38100" cap="flat" cmpd="sng" algn="ctr">
+          <a:solidFill>
+            <a:schemeClr val="phClr"/>
+          </a:solidFill>
+          <a:prstDash val="solid"/>
+        </a:ln>
+      </a:lnStyleLst>
+      <a:effectStyleLst>
+        <a:effectStyle>
+          <a:effectLst>
+            <a:outerShdw blurRad="40000" dist="20000" dir="5400000" rotWithShape="0">
+              <a:srgbClr val="000000">
+                <a:alpha val="38000"/>
+              </a:srgbClr>
+            </a:outerShdw>
+          </a:effectLst>
+        </a:effectStyle>
+        <a:effectStyle>
+          <a:effectLst>
+            <a:outerShdw blurRad="40000" dist="23000" dir="5400000" rotWithShape="0">
+              <a:srgbClr val="000000">
+                <a:alpha val="35000"/>
+              </a:srgbClr>
+            </a:outerShdw>
+          </a:effectLst>
+        </a:effectStyle>
+        <a:effectStyle>
+          <a:effectLst>
+            <a:outerShdw blurRad="40000" dist="23000" dir="5400000" rotWithShape="0">
+              <a:srgbClr val="000000">
+                <a:alpha val="35000"/>
+              </a:srgbClr>
+            </a:outerShdw>
+          </a:effectLst>
+          <a:scene3d>
+            <a:camera prst="orthographicFront">
+              <a:rot lat="0" lon="0" rev="0"/>
+            </a:camera>
+            <a:lightRig rig="threePt" dir="t">
+              <a:rot lat="0" lon="0" rev="1200000"/>
+            </a:lightRig>
+          </a:scene3d>
+          <a:sp3d>
+            <a:bevelT w="63500" h="25400"/>
+          </a:sp3d>
+        </a:effectStyle>
+      </a:effectStyleLst>
+      <a:bgFillStyleLst>
+        <a:solidFill>
+          <a:schemeClr val="phClr"/>
+        </a:solidFill>
+        <a:gradFill rotWithShape="1">
+          <a:gsLst>
+            <a:gs pos="0">
+              <a:schemeClr val="phClr">
+                <a:tint val="40000"/>
+                <a:satMod val="350000"/>
+              </a:schemeClr>
+            </a:gs>
+            <a:gs pos="40000">
+              <a:schemeClr val="phClr">
+                <a:tint val="45000"/>
+                <a:shade val="99000"/>
+                <a:satMod val="350000"/>
+              </a:schemeClr>
+            </a:gs>
+            <a:gs pos="100000">
+              <a:schemeClr val="phClr">
+                <a:shade val="20000"/>
+                <a:satMod val="255000"/>
+              </a:schemeClr>
+            </a:gs>
+          </a:gsLst>
+          <a:path path="circle">
+            <a:fillToRect l="50000" t="-80000" r="50000" b="180000"/>
+          </a:path>
+        </a:gradFill>
+        <a:gradFill rotWithShape="1">
+          <a:gsLst>
+            <a:gs pos="0">
+              <a:schemeClr val="phClr">
+                <a:tint val="80000"/>
+                <a:satMod val="300000"/>
+              </a:schemeClr>
+            </a:gs>
+            <a:gs pos="100000">
+              <a:schemeClr val="phClr">
+                <a:shade val="30000"/>
+                <a:satMod val="200000"/>
+              </a:schemeClr>
+            </a:gs>
+          </a:gsLst>
+          <a:path path="circle">
+            <a:fillToRect l="50000" t="50000" r="50000" b="50000"/>
+          </a:path>
+        </a:gradFill>
+      </a:bgFillStyleLst>
+    </a:fmtScheme>
+  </a:themeElements>
+</a:theme>
 </file>
</xml_diff>

<commit_message>
Update Data Sources from LFX 2026-10-26 (#354)
Update Data Sources from LFX

Signed-off-by: github-actions[bot] <41898282+github-actions[bot]@users.noreply.github.com>
Co-authored-by: jmertic <296737+jmertic@users.noreply.github.com>
</commit_message>
<xml_diff>
--- a/overview_deck/LF Energy High Level Overview.pptx
+++ b/overview_deck/LF Energy High Level Overview.pptx
@@ -25946,7 +25946,7 @@
             <a:tbl>
               <a:tblPr>
                 <a:noFill/>
-                <a:tableStyleId>{B80D0C47-2438-47AF-B457-F5EB1A81DCF8}</a:tableStyleId>
+                <a:tableStyleId>{45420FB6-9C73-43AA-BCE3-C5B82946E482}</a:tableStyleId>
               </a:tblPr>
               <a:tblGrid>
                 <a:gridCol w="1695200"/>
@@ -26736,7 +26736,7 @@
             <a:tbl>
               <a:tblPr>
                 <a:noFill/>
-                <a:tableStyleId>{B80D0C47-2438-47AF-B457-F5EB1A81DCF8}</a:tableStyleId>
+                <a:tableStyleId>{45420FB6-9C73-43AA-BCE3-C5B82946E482}</a:tableStyleId>
               </a:tblPr>
               <a:tblGrid>
                 <a:gridCol w="1695200"/>
@@ -27426,7 +27426,7 @@
             <a:tbl>
               <a:tblPr>
                 <a:noFill/>
-                <a:tableStyleId>{B80D0C47-2438-47AF-B457-F5EB1A81DCF8}</a:tableStyleId>
+                <a:tableStyleId>{45420FB6-9C73-43AA-BCE3-C5B82946E482}</a:tableStyleId>
               </a:tblPr>
               <a:tblGrid>
                 <a:gridCol w="1695200"/>
@@ -28678,7 +28678,7 @@
             <a:tbl>
               <a:tblPr>
                 <a:noFill/>
-                <a:tableStyleId>{B80D0C47-2438-47AF-B457-F5EB1A81DCF8}</a:tableStyleId>
+                <a:tableStyleId>{45420FB6-9C73-43AA-BCE3-C5B82946E482}</a:tableStyleId>
               </a:tblPr>
               <a:tblGrid>
                 <a:gridCol w="1695200"/>
@@ -29670,7 +29670,7 @@
             <a:tbl>
               <a:tblPr>
                 <a:noFill/>
-                <a:tableStyleId>{B80D0C47-2438-47AF-B457-F5EB1A81DCF8}</a:tableStyleId>
+                <a:tableStyleId>{45420FB6-9C73-43AA-BCE3-C5B82946E482}</a:tableStyleId>
               </a:tblPr>
               <a:tblGrid>
                 <a:gridCol w="3048000"/>
@@ -33175,7 +33175,7 @@
             <a:tbl>
               <a:tblPr>
                 <a:noFill/>
-                <a:tableStyleId>{B80D0C47-2438-47AF-B457-F5EB1A81DCF8}</a:tableStyleId>
+                <a:tableStyleId>{45420FB6-9C73-43AA-BCE3-C5B82946E482}</a:tableStyleId>
               </a:tblPr>
               <a:tblGrid>
                 <a:gridCol w="1828800"/>
@@ -34281,6 +34281,285 @@
 </file>
 
 <file path=ppt/theme/theme2.xml><?xml version="1.0" encoding="utf-8"?>
+<a:theme xmlns:a="http://schemas.openxmlformats.org/drawingml/2006/main" xmlns:r="http://schemas.openxmlformats.org/officeDocument/2006/relationships">
+  <a:themeElements>
+    <a:clrScheme name="Default">
+      <a:dk1>
+        <a:srgbClr val="000000"/>
+      </a:dk1>
+      <a:lt1>
+        <a:srgbClr val="FFFFFF"/>
+      </a:lt1>
+      <a:dk2>
+        <a:srgbClr val="158158"/>
+      </a:dk2>
+      <a:lt2>
+        <a:srgbClr val="F3F3F3"/>
+      </a:lt2>
+      <a:accent1>
+        <a:srgbClr val="058DC7"/>
+      </a:accent1>
+      <a:accent2>
+        <a:srgbClr val="50B432"/>
+      </a:accent2>
+      <a:accent3>
+        <a:srgbClr val="ED561B"/>
+      </a:accent3>
+      <a:accent4>
+        <a:srgbClr val="EDEF00"/>
+      </a:accent4>
+      <a:accent5>
+        <a:srgbClr val="24CBE5"/>
+      </a:accent5>
+      <a:accent6>
+        <a:srgbClr val="64E572"/>
+      </a:accent6>
+      <a:hlink>
+        <a:srgbClr val="2200CC"/>
+      </a:hlink>
+      <a:folHlink>
+        <a:srgbClr val="551A8B"/>
+      </a:folHlink>
+    </a:clrScheme>
+    <a:fontScheme name="Office">
+      <a:majorFont>
+        <a:latin typeface="Arial"/>
+        <a:ea typeface=""/>
+        <a:cs typeface=""/>
+        <a:font script="Jpan" typeface="ＭＳ Ｐゴシック"/>
+        <a:font script="Hang" typeface="맑은 고딕"/>
+        <a:font script="Hans" typeface="宋体"/>
+        <a:font script="Hant" typeface="新細明體"/>
+        <a:font script="Arab" typeface="Times New Roman"/>
+        <a:font script="Hebr" typeface="Times New Roman"/>
+        <a:font script="Thai" typeface="Angsana New"/>
+        <a:font script="Ethi" typeface="Nyala"/>
+        <a:font script="Beng" typeface="Vrinda"/>
+        <a:font script="Gujr" typeface="Shruti"/>
+        <a:font script="Khmr" typeface="MoolBoran"/>
+        <a:font script="Knda" typeface="Tunga"/>
+        <a:font script="Guru" typeface="Raavi"/>
+        <a:font script="Cans" typeface="Euphemia"/>
+        <a:font script="Cher" typeface="Plantagenet Cherokee"/>
+        <a:font script="Yiii" typeface="Microsoft Yi Baiti"/>
+        <a:font script="Tibt" typeface="Microsoft Himalaya"/>
+        <a:font script="Thaa" typeface="MV Boli"/>
+        <a:font script="Deva" typeface="Mangal"/>
+        <a:font script="Telu" typeface="Gautami"/>
+        <a:font script="Taml" typeface="Latha"/>
+        <a:font script="Syrc" typeface="Estrangelo Edessa"/>
+        <a:font script="Orya" typeface="Kalinga"/>
+        <a:font script="Mlym" typeface="Kartika"/>
+        <a:font script="Laoo" typeface="DokChampa"/>
+        <a:font script="Sinh" typeface="Iskoola Pota"/>
+        <a:font script="Mong" typeface="Mongolian Baiti"/>
+        <a:font script="Viet" typeface="Times New Roman"/>
+        <a:font script="Uigh" typeface="Microsoft Uighur"/>
+        <a:font script="Geor" typeface="Sylfaen"/>
+      </a:majorFont>
+      <a:minorFont>
+        <a:latin typeface="Arial"/>
+        <a:ea typeface=""/>
+        <a:cs typeface=""/>
+        <a:font script="Jpan" typeface="ＭＳ Ｐゴシック"/>
+        <a:font script="Hang" typeface="맑은 고딕"/>
+        <a:font script="Hans" typeface="宋体"/>
+        <a:font script="Hant" typeface="新細明體"/>
+        <a:font script="Arab" typeface="Arial"/>
+        <a:font script="Hebr" typeface="Arial"/>
+        <a:font script="Thai" typeface="Cordia New"/>
+        <a:font script="Ethi" typeface="Nyala"/>
+        <a:font script="Beng" typeface="Vrinda"/>
+        <a:font script="Gujr" typeface="Shruti"/>
+        <a:font script="Khmr" typeface="DaunPenh"/>
+        <a:font script="Knda" typeface="Tunga"/>
+        <a:font script="Guru" typeface="Raavi"/>
+        <a:font script="Cans" typeface="Euphemia"/>
+        <a:font script="Cher" typeface="Plantagenet Cherokee"/>
+        <a:font script="Yiii" typeface="Microsoft Yi Baiti"/>
+        <a:font script="Tibt" typeface="Microsoft Himalaya"/>
+        <a:font script="Thaa" typeface="MV Boli"/>
+        <a:font script="Deva" typeface="Mangal"/>
+        <a:font script="Telu" typeface="Gautami"/>
+        <a:font script="Taml" typeface="Latha"/>
+        <a:font script="Syrc" typeface="Estrangelo Edessa"/>
+        <a:font script="Orya" typeface="Kalinga"/>
+        <a:font script="Mlym" typeface="Kartika"/>
+        <a:font script="Laoo" typeface="DokChampa"/>
+        <a:font script="Sinh" typeface="Iskoola Pota"/>
+        <a:font script="Mong" typeface="Mongolian Baiti"/>
+        <a:font script="Viet" typeface="Arial"/>
+        <a:font script="Uigh" typeface="Microsoft Uighur"/>
+        <a:font script="Geor" typeface="Sylfaen"/>
+      </a:minorFont>
+    </a:fontScheme>
+    <a:fmtScheme name="Office">
+      <a:fillStyleLst>
+        <a:solidFill>
+          <a:schemeClr val="phClr"/>
+        </a:solidFill>
+        <a:gradFill rotWithShape="1">
+          <a:gsLst>
+            <a:gs pos="0">
+              <a:schemeClr val="phClr">
+                <a:tint val="50000"/>
+                <a:satMod val="300000"/>
+              </a:schemeClr>
+            </a:gs>
+            <a:gs pos="35000">
+              <a:schemeClr val="phClr">
+                <a:tint val="37000"/>
+                <a:satMod val="300000"/>
+              </a:schemeClr>
+            </a:gs>
+            <a:gs pos="100000">
+              <a:schemeClr val="phClr">
+                <a:tint val="15000"/>
+                <a:satMod val="350000"/>
+              </a:schemeClr>
+            </a:gs>
+          </a:gsLst>
+          <a:lin ang="16200000" scaled="1"/>
+        </a:gradFill>
+        <a:gradFill rotWithShape="1">
+          <a:gsLst>
+            <a:gs pos="0">
+              <a:schemeClr val="phClr">
+                <a:tint val="100000"/>
+                <a:shade val="100000"/>
+                <a:satMod val="130000"/>
+              </a:schemeClr>
+            </a:gs>
+            <a:gs pos="100000">
+              <a:schemeClr val="phClr">
+                <a:tint val="50000"/>
+                <a:shade val="100000"/>
+                <a:satMod val="350000"/>
+              </a:schemeClr>
+            </a:gs>
+          </a:gsLst>
+          <a:lin ang="16200000" scaled="0"/>
+        </a:gradFill>
+      </a:fillStyleLst>
+      <a:lnStyleLst>
+        <a:ln w="9525" cap="flat" cmpd="sng" algn="ctr">
+          <a:solidFill>
+            <a:schemeClr val="phClr">
+              <a:shade val="95000"/>
+              <a:satMod val="105000"/>
+            </a:schemeClr>
+          </a:solidFill>
+          <a:prstDash val="solid"/>
+        </a:ln>
+        <a:ln w="25400" cap="flat" cmpd="sng" algn="ctr">
+          <a:solidFill>
+            <a:schemeClr val="phClr"/>
+          </a:solidFill>
+          <a:prstDash val="solid"/>
+        </a:ln>
+        <a:ln w="38100" cap="flat" cmpd="sng" algn="ctr">
+          <a:solidFill>
+            <a:schemeClr val="phClr"/>
+          </a:solidFill>
+          <a:prstDash val="solid"/>
+        </a:ln>
+      </a:lnStyleLst>
+      <a:effectStyleLst>
+        <a:effectStyle>
+          <a:effectLst>
+            <a:outerShdw blurRad="40000" dist="20000" dir="5400000" rotWithShape="0">
+              <a:srgbClr val="000000">
+                <a:alpha val="38000"/>
+              </a:srgbClr>
+            </a:outerShdw>
+          </a:effectLst>
+        </a:effectStyle>
+        <a:effectStyle>
+          <a:effectLst>
+            <a:outerShdw blurRad="40000" dist="23000" dir="5400000" rotWithShape="0">
+              <a:srgbClr val="000000">
+                <a:alpha val="35000"/>
+              </a:srgbClr>
+            </a:outerShdw>
+          </a:effectLst>
+        </a:effectStyle>
+        <a:effectStyle>
+          <a:effectLst>
+            <a:outerShdw blurRad="40000" dist="23000" dir="5400000" rotWithShape="0">
+              <a:srgbClr val="000000">
+                <a:alpha val="35000"/>
+              </a:srgbClr>
+            </a:outerShdw>
+          </a:effectLst>
+          <a:scene3d>
+            <a:camera prst="orthographicFront">
+              <a:rot lat="0" lon="0" rev="0"/>
+            </a:camera>
+            <a:lightRig rig="threePt" dir="t">
+              <a:rot lat="0" lon="0" rev="1200000"/>
+            </a:lightRig>
+          </a:scene3d>
+          <a:sp3d>
+            <a:bevelT w="63500" h="25400"/>
+          </a:sp3d>
+        </a:effectStyle>
+      </a:effectStyleLst>
+      <a:bgFillStyleLst>
+        <a:solidFill>
+          <a:schemeClr val="phClr"/>
+        </a:solidFill>
+        <a:gradFill rotWithShape="1">
+          <a:gsLst>
+            <a:gs pos="0">
+              <a:schemeClr val="phClr">
+                <a:tint val="40000"/>
+                <a:satMod val="350000"/>
+              </a:schemeClr>
+            </a:gs>
+            <a:gs pos="40000">
+              <a:schemeClr val="phClr">
+                <a:tint val="45000"/>
+                <a:shade val="99000"/>
+                <a:satMod val="350000"/>
+              </a:schemeClr>
+            </a:gs>
+            <a:gs pos="100000">
+              <a:schemeClr val="phClr">
+                <a:shade val="20000"/>
+                <a:satMod val="255000"/>
+              </a:schemeClr>
+            </a:gs>
+          </a:gsLst>
+          <a:path path="circle">
+            <a:fillToRect l="50000" t="-80000" r="50000" b="180000"/>
+          </a:path>
+        </a:gradFill>
+        <a:gradFill rotWithShape="1">
+          <a:gsLst>
+            <a:gs pos="0">
+              <a:schemeClr val="phClr">
+                <a:tint val="80000"/>
+                <a:satMod val="300000"/>
+              </a:schemeClr>
+            </a:gs>
+            <a:gs pos="100000">
+              <a:schemeClr val="phClr">
+                <a:shade val="30000"/>
+                <a:satMod val="200000"/>
+              </a:schemeClr>
+            </a:gs>
+          </a:gsLst>
+          <a:path path="circle">
+            <a:fillToRect l="50000" t="50000" r="50000" b="50000"/>
+          </a:path>
+        </a:gradFill>
+      </a:bgFillStyleLst>
+    </a:fmtScheme>
+  </a:themeElements>
+</a:theme>
+</file>
+
+<file path=ppt/theme/theme3.xml><?xml version="1.0" encoding="utf-8"?>
 <a:theme xmlns:a="http://schemas.openxmlformats.org/drawingml/2006/main" xmlns:r="http://schemas.openxmlformats.org/officeDocument/2006/relationships" name="Simple Light">
   <a:themeElements>
     <a:clrScheme name="Simple Light">
@@ -34557,283 +34836,4 @@
     </a:fmtScheme>
   </a:themeElements>
 </a:theme>
-</file>
-
-<file path=ppt/theme/theme3.xml><?xml version="1.0" encoding="utf-8"?>
-<a:theme xmlns:a="http://schemas.openxmlformats.org/drawingml/2006/main" xmlns:r="http://schemas.openxmlformats.org/officeDocument/2006/relationships">
-  <a:themeElements>
-    <a:clrScheme name="Default">
-      <a:dk1>
-        <a:srgbClr val="000000"/>
-      </a:dk1>
-      <a:lt1>
-        <a:srgbClr val="FFFFFF"/>
-      </a:lt1>
-      <a:dk2>
-        <a:srgbClr val="158158"/>
-      </a:dk2>
-      <a:lt2>
-        <a:srgbClr val="F3F3F3"/>
-      </a:lt2>
-      <a:accent1>
-        <a:srgbClr val="058DC7"/>
-      </a:accent1>
-      <a:accent2>
-        <a:srgbClr val="50B432"/>
-      </a:accent2>
-      <a:accent3>
-        <a:srgbClr val="ED561B"/>
-      </a:accent3>
-      <a:accent4>
-        <a:srgbClr val="EDEF00"/>
-      </a:accent4>
-      <a:accent5>
-        <a:srgbClr val="24CBE5"/>
-      </a:accent5>
-      <a:accent6>
-        <a:srgbClr val="64E572"/>
-      </a:accent6>
-      <a:hlink>
-        <a:srgbClr val="2200CC"/>
-      </a:hlink>
-      <a:folHlink>
-        <a:srgbClr val="551A8B"/>
-      </a:folHlink>
-    </a:clrScheme>
-    <a:fontScheme name="Office">
-      <a:majorFont>
-        <a:latin typeface="Arial"/>
-        <a:ea typeface=""/>
-        <a:cs typeface=""/>
-        <a:font script="Jpan" typeface="ＭＳ Ｐゴシック"/>
-        <a:font script="Hang" typeface="맑은 고딕"/>
-        <a:font script="Hans" typeface="宋体"/>
-        <a:font script="Hant" typeface="新細明體"/>
-        <a:font script="Arab" typeface="Times New Roman"/>
-        <a:font script="Hebr" typeface="Times New Roman"/>
-        <a:font script="Thai" typeface="Angsana New"/>
-        <a:font script="Ethi" typeface="Nyala"/>
-        <a:font script="Beng" typeface="Vrinda"/>
-        <a:font script="Gujr" typeface="Shruti"/>
-        <a:font script="Khmr" typeface="MoolBoran"/>
-        <a:font script="Knda" typeface="Tunga"/>
-        <a:font script="Guru" typeface="Raavi"/>
-        <a:font script="Cans" typeface="Euphemia"/>
-        <a:font script="Cher" typeface="Plantagenet Cherokee"/>
-        <a:font script="Yiii" typeface="Microsoft Yi Baiti"/>
-        <a:font script="Tibt" typeface="Microsoft Himalaya"/>
-        <a:font script="Thaa" typeface="MV Boli"/>
-        <a:font script="Deva" typeface="Mangal"/>
-        <a:font script="Telu" typeface="Gautami"/>
-        <a:font script="Taml" typeface="Latha"/>
-        <a:font script="Syrc" typeface="Estrangelo Edessa"/>
-        <a:font script="Orya" typeface="Kalinga"/>
-        <a:font script="Mlym" typeface="Kartika"/>
-        <a:font script="Laoo" typeface="DokChampa"/>
-        <a:font script="Sinh" typeface="Iskoola Pota"/>
-        <a:font script="Mong" typeface="Mongolian Baiti"/>
-        <a:font script="Viet" typeface="Times New Roman"/>
-        <a:font script="Uigh" typeface="Microsoft Uighur"/>
-        <a:font script="Geor" typeface="Sylfaen"/>
-      </a:majorFont>
-      <a:minorFont>
-        <a:latin typeface="Arial"/>
-        <a:ea typeface=""/>
-        <a:cs typeface=""/>
-        <a:font script="Jpan" typeface="ＭＳ Ｐゴシック"/>
-        <a:font script="Hang" typeface="맑은 고딕"/>
-        <a:font script="Hans" typeface="宋体"/>
-        <a:font script="Hant" typeface="新細明體"/>
-        <a:font script="Arab" typeface="Arial"/>
-        <a:font script="Hebr" typeface="Arial"/>
-        <a:font script="Thai" typeface="Cordia New"/>
-        <a:font script="Ethi" typeface="Nyala"/>
-        <a:font script="Beng" typeface="Vrinda"/>
-        <a:font script="Gujr" typeface="Shruti"/>
-        <a:font script="Khmr" typeface="DaunPenh"/>
-        <a:font script="Knda" typeface="Tunga"/>
-        <a:font script="Guru" typeface="Raavi"/>
-        <a:font script="Cans" typeface="Euphemia"/>
-        <a:font script="Cher" typeface="Plantagenet Cherokee"/>
-        <a:font script="Yiii" typeface="Microsoft Yi Baiti"/>
-        <a:font script="Tibt" typeface="Microsoft Himalaya"/>
-        <a:font script="Thaa" typeface="MV Boli"/>
-        <a:font script="Deva" typeface="Mangal"/>
-        <a:font script="Telu" typeface="Gautami"/>
-        <a:font script="Taml" typeface="Latha"/>
-        <a:font script="Syrc" typeface="Estrangelo Edessa"/>
-        <a:font script="Orya" typeface="Kalinga"/>
-        <a:font script="Mlym" typeface="Kartika"/>
-        <a:font script="Laoo" typeface="DokChampa"/>
-        <a:font script="Sinh" typeface="Iskoola Pota"/>
-        <a:font script="Mong" typeface="Mongolian Baiti"/>
-        <a:font script="Viet" typeface="Arial"/>
-        <a:font script="Uigh" typeface="Microsoft Uighur"/>
-        <a:font script="Geor" typeface="Sylfaen"/>
-      </a:minorFont>
-    </a:fontScheme>
-    <a:fmtScheme name="Office">
-      <a:fillStyleLst>
-        <a:solidFill>
-          <a:schemeClr val="phClr"/>
-        </a:solidFill>
-        <a:gradFill rotWithShape="1">
-          <a:gsLst>
-            <a:gs pos="0">
-              <a:schemeClr val="phClr">
-                <a:tint val="50000"/>
-                <a:satMod val="300000"/>
-              </a:schemeClr>
-            </a:gs>
-            <a:gs pos="35000">
-              <a:schemeClr val="phClr">
-                <a:tint val="37000"/>
-                <a:satMod val="300000"/>
-              </a:schemeClr>
-            </a:gs>
-            <a:gs pos="100000">
-              <a:schemeClr val="phClr">
-                <a:tint val="15000"/>
-                <a:satMod val="350000"/>
-              </a:schemeClr>
-            </a:gs>
-          </a:gsLst>
-          <a:lin ang="16200000" scaled="1"/>
-        </a:gradFill>
-        <a:gradFill rotWithShape="1">
-          <a:gsLst>
-            <a:gs pos="0">
-              <a:schemeClr val="phClr">
-                <a:tint val="100000"/>
-                <a:shade val="100000"/>
-                <a:satMod val="130000"/>
-              </a:schemeClr>
-            </a:gs>
-            <a:gs pos="100000">
-              <a:schemeClr val="phClr">
-                <a:tint val="50000"/>
-                <a:shade val="100000"/>
-                <a:satMod val="350000"/>
-              </a:schemeClr>
-            </a:gs>
-          </a:gsLst>
-          <a:lin ang="16200000" scaled="0"/>
-        </a:gradFill>
-      </a:fillStyleLst>
-      <a:lnStyleLst>
-        <a:ln w="9525" cap="flat" cmpd="sng" algn="ctr">
-          <a:solidFill>
-            <a:schemeClr val="phClr">
-              <a:shade val="95000"/>
-              <a:satMod val="105000"/>
-            </a:schemeClr>
-          </a:solidFill>
-          <a:prstDash val="solid"/>
-        </a:ln>
-        <a:ln w="25400" cap="flat" cmpd="sng" algn="ctr">
-          <a:solidFill>
-            <a:schemeClr val="phClr"/>
-          </a:solidFill>
-          <a:prstDash val="solid"/>
-        </a:ln>
-        <a:ln w="38100" cap="flat" cmpd="sng" algn="ctr">
-          <a:solidFill>
-            <a:schemeClr val="phClr"/>
-          </a:solidFill>
-          <a:prstDash val="solid"/>
-        </a:ln>
-      </a:lnStyleLst>
-      <a:effectStyleLst>
-        <a:effectStyle>
-          <a:effectLst>
-            <a:outerShdw blurRad="40000" dist="20000" dir="5400000" rotWithShape="0">
-              <a:srgbClr val="000000">
-                <a:alpha val="38000"/>
-              </a:srgbClr>
-            </a:outerShdw>
-          </a:effectLst>
-        </a:effectStyle>
-        <a:effectStyle>
-          <a:effectLst>
-            <a:outerShdw blurRad="40000" dist="23000" dir="5400000" rotWithShape="0">
-              <a:srgbClr val="000000">
-                <a:alpha val="35000"/>
-              </a:srgbClr>
-            </a:outerShdw>
-          </a:effectLst>
-        </a:effectStyle>
-        <a:effectStyle>
-          <a:effectLst>
-            <a:outerShdw blurRad="40000" dist="23000" dir="5400000" rotWithShape="0">
-              <a:srgbClr val="000000">
-                <a:alpha val="35000"/>
-              </a:srgbClr>
-            </a:outerShdw>
-          </a:effectLst>
-          <a:scene3d>
-            <a:camera prst="orthographicFront">
-              <a:rot lat="0" lon="0" rev="0"/>
-            </a:camera>
-            <a:lightRig rig="threePt" dir="t">
-              <a:rot lat="0" lon="0" rev="1200000"/>
-            </a:lightRig>
-          </a:scene3d>
-          <a:sp3d>
-            <a:bevelT w="63500" h="25400"/>
-          </a:sp3d>
-        </a:effectStyle>
-      </a:effectStyleLst>
-      <a:bgFillStyleLst>
-        <a:solidFill>
-          <a:schemeClr val="phClr"/>
-        </a:solidFill>
-        <a:gradFill rotWithShape="1">
-          <a:gsLst>
-            <a:gs pos="0">
-              <a:schemeClr val="phClr">
-                <a:tint val="40000"/>
-                <a:satMod val="350000"/>
-              </a:schemeClr>
-            </a:gs>
-            <a:gs pos="40000">
-              <a:schemeClr val="phClr">
-                <a:tint val="45000"/>
-                <a:shade val="99000"/>
-                <a:satMod val="350000"/>
-              </a:schemeClr>
-            </a:gs>
-            <a:gs pos="100000">
-              <a:schemeClr val="phClr">
-                <a:shade val="20000"/>
-                <a:satMod val="255000"/>
-              </a:schemeClr>
-            </a:gs>
-          </a:gsLst>
-          <a:path path="circle">
-            <a:fillToRect l="50000" t="-80000" r="50000" b="180000"/>
-          </a:path>
-        </a:gradFill>
-        <a:gradFill rotWithShape="1">
-          <a:gsLst>
-            <a:gs pos="0">
-              <a:schemeClr val="phClr">
-                <a:tint val="80000"/>
-                <a:satMod val="300000"/>
-              </a:schemeClr>
-            </a:gs>
-            <a:gs pos="100000">
-              <a:schemeClr val="phClr">
-                <a:shade val="30000"/>
-                <a:satMod val="200000"/>
-              </a:schemeClr>
-            </a:gs>
-          </a:gsLst>
-          <a:path path="circle">
-            <a:fillToRect l="50000" t="50000" r="50000" b="50000"/>
-          </a:path>
-        </a:gradFill>
-      </a:bgFillStyleLst>
-    </a:fmtScheme>
-  </a:themeElements>
-</a:theme>
 </file>
</xml_diff>

<commit_message>
Update Data Sources from LFX 2026-10-27 (#355)
Update Data Sources from LFX

Signed-off-by: github-actions[bot] <41898282+github-actions[bot]@users.noreply.github.com>
Co-authored-by: jmertic <296737+jmertic@users.noreply.github.com>
</commit_message>
<xml_diff>
--- a/overview_deck/LF Energy High Level Overview.pptx
+++ b/overview_deck/LF Energy High Level Overview.pptx
@@ -25946,7 +25946,7 @@
             <a:tbl>
               <a:tblPr>
                 <a:noFill/>
-                <a:tableStyleId>{45420FB6-9C73-43AA-BCE3-C5B82946E482}</a:tableStyleId>
+                <a:tableStyleId>{9BAB03E5-1E38-45C2-A965-D2132A89F11C}</a:tableStyleId>
               </a:tblPr>
               <a:tblGrid>
                 <a:gridCol w="1695200"/>
@@ -26736,7 +26736,7 @@
             <a:tbl>
               <a:tblPr>
                 <a:noFill/>
-                <a:tableStyleId>{45420FB6-9C73-43AA-BCE3-C5B82946E482}</a:tableStyleId>
+                <a:tableStyleId>{9BAB03E5-1E38-45C2-A965-D2132A89F11C}</a:tableStyleId>
               </a:tblPr>
               <a:tblGrid>
                 <a:gridCol w="1695200"/>
@@ -27426,7 +27426,7 @@
             <a:tbl>
               <a:tblPr>
                 <a:noFill/>
-                <a:tableStyleId>{45420FB6-9C73-43AA-BCE3-C5B82946E482}</a:tableStyleId>
+                <a:tableStyleId>{9BAB03E5-1E38-45C2-A965-D2132A89F11C}</a:tableStyleId>
               </a:tblPr>
               <a:tblGrid>
                 <a:gridCol w="1695200"/>
@@ -28678,7 +28678,7 @@
             <a:tbl>
               <a:tblPr>
                 <a:noFill/>
-                <a:tableStyleId>{45420FB6-9C73-43AA-BCE3-C5B82946E482}</a:tableStyleId>
+                <a:tableStyleId>{9BAB03E5-1E38-45C2-A965-D2132A89F11C}</a:tableStyleId>
               </a:tblPr>
               <a:tblGrid>
                 <a:gridCol w="1695200"/>
@@ -29670,7 +29670,7 @@
             <a:tbl>
               <a:tblPr>
                 <a:noFill/>
-                <a:tableStyleId>{45420FB6-9C73-43AA-BCE3-C5B82946E482}</a:tableStyleId>
+                <a:tableStyleId>{9BAB03E5-1E38-45C2-A965-D2132A89F11C}</a:tableStyleId>
               </a:tblPr>
               <a:tblGrid>
                 <a:gridCol w="3048000"/>
@@ -33175,7 +33175,7 @@
             <a:tbl>
               <a:tblPr>
                 <a:noFill/>
-                <a:tableStyleId>{45420FB6-9C73-43AA-BCE3-C5B82946E482}</a:tableStyleId>
+                <a:tableStyleId>{9BAB03E5-1E38-45C2-A965-D2132A89F11C}</a:tableStyleId>
               </a:tblPr>
               <a:tblGrid>
                 <a:gridCol w="1828800"/>
@@ -34002,6 +34002,285 @@
 </file>
 
 <file path=ppt/theme/theme1.xml><?xml version="1.0" encoding="utf-8"?>
+<a:theme xmlns:a="http://schemas.openxmlformats.org/drawingml/2006/main" xmlns:r="http://schemas.openxmlformats.org/officeDocument/2006/relationships" name="Simple Light">
+  <a:themeElements>
+    <a:clrScheme name="Simple Light">
+      <a:dk1>
+        <a:srgbClr val="000000"/>
+      </a:dk1>
+      <a:lt1>
+        <a:srgbClr val="FFFFFF"/>
+      </a:lt1>
+      <a:dk2>
+        <a:srgbClr val="595959"/>
+      </a:dk2>
+      <a:lt2>
+        <a:srgbClr val="EEEEEE"/>
+      </a:lt2>
+      <a:accent1>
+        <a:srgbClr val="4285F4"/>
+      </a:accent1>
+      <a:accent2>
+        <a:srgbClr val="212121"/>
+      </a:accent2>
+      <a:accent3>
+        <a:srgbClr val="78909C"/>
+      </a:accent3>
+      <a:accent4>
+        <a:srgbClr val="FFAB40"/>
+      </a:accent4>
+      <a:accent5>
+        <a:srgbClr val="0097A7"/>
+      </a:accent5>
+      <a:accent6>
+        <a:srgbClr val="EEFF41"/>
+      </a:accent6>
+      <a:hlink>
+        <a:srgbClr val="0097A7"/>
+      </a:hlink>
+      <a:folHlink>
+        <a:srgbClr val="0097A7"/>
+      </a:folHlink>
+    </a:clrScheme>
+    <a:fontScheme name="Office">
+      <a:majorFont>
+        <a:latin typeface="Arial"/>
+        <a:ea typeface=""/>
+        <a:cs typeface=""/>
+        <a:font script="Jpan" typeface="ＭＳ Ｐゴシック"/>
+        <a:font script="Hang" typeface="맑은 고딕"/>
+        <a:font script="Hans" typeface="宋体"/>
+        <a:font script="Hant" typeface="新細明體"/>
+        <a:font script="Arab" typeface="Times New Roman"/>
+        <a:font script="Hebr" typeface="Times New Roman"/>
+        <a:font script="Thai" typeface="Angsana New"/>
+        <a:font script="Ethi" typeface="Nyala"/>
+        <a:font script="Beng" typeface="Vrinda"/>
+        <a:font script="Gujr" typeface="Shruti"/>
+        <a:font script="Khmr" typeface="MoolBoran"/>
+        <a:font script="Knda" typeface="Tunga"/>
+        <a:font script="Guru" typeface="Raavi"/>
+        <a:font script="Cans" typeface="Euphemia"/>
+        <a:font script="Cher" typeface="Plantagenet Cherokee"/>
+        <a:font script="Yiii" typeface="Microsoft Yi Baiti"/>
+        <a:font script="Tibt" typeface="Microsoft Himalaya"/>
+        <a:font script="Thaa" typeface="MV Boli"/>
+        <a:font script="Deva" typeface="Mangal"/>
+        <a:font script="Telu" typeface="Gautami"/>
+        <a:font script="Taml" typeface="Latha"/>
+        <a:font script="Syrc" typeface="Estrangelo Edessa"/>
+        <a:font script="Orya" typeface="Kalinga"/>
+        <a:font script="Mlym" typeface="Kartika"/>
+        <a:font script="Laoo" typeface="DokChampa"/>
+        <a:font script="Sinh" typeface="Iskoola Pota"/>
+        <a:font script="Mong" typeface="Mongolian Baiti"/>
+        <a:font script="Viet" typeface="Times New Roman"/>
+        <a:font script="Uigh" typeface="Microsoft Uighur"/>
+        <a:font script="Geor" typeface="Sylfaen"/>
+      </a:majorFont>
+      <a:minorFont>
+        <a:latin typeface="Arial"/>
+        <a:ea typeface=""/>
+        <a:cs typeface=""/>
+        <a:font script="Jpan" typeface="ＭＳ Ｐゴシック"/>
+        <a:font script="Hang" typeface="맑은 고딕"/>
+        <a:font script="Hans" typeface="宋体"/>
+        <a:font script="Hant" typeface="新細明體"/>
+        <a:font script="Arab" typeface="Arial"/>
+        <a:font script="Hebr" typeface="Arial"/>
+        <a:font script="Thai" typeface="Cordia New"/>
+        <a:font script="Ethi" typeface="Nyala"/>
+        <a:font script="Beng" typeface="Vrinda"/>
+        <a:font script="Gujr" typeface="Shruti"/>
+        <a:font script="Khmr" typeface="DaunPenh"/>
+        <a:font script="Knda" typeface="Tunga"/>
+        <a:font script="Guru" typeface="Raavi"/>
+        <a:font script="Cans" typeface="Euphemia"/>
+        <a:font script="Cher" typeface="Plantagenet Cherokee"/>
+        <a:font script="Yiii" typeface="Microsoft Yi Baiti"/>
+        <a:font script="Tibt" typeface="Microsoft Himalaya"/>
+        <a:font script="Thaa" typeface="MV Boli"/>
+        <a:font script="Deva" typeface="Mangal"/>
+        <a:font script="Telu" typeface="Gautami"/>
+        <a:font script="Taml" typeface="Latha"/>
+        <a:font script="Syrc" typeface="Estrangelo Edessa"/>
+        <a:font script="Orya" typeface="Kalinga"/>
+        <a:font script="Mlym" typeface="Kartika"/>
+        <a:font script="Laoo" typeface="DokChampa"/>
+        <a:font script="Sinh" typeface="Iskoola Pota"/>
+        <a:font script="Mong" typeface="Mongolian Baiti"/>
+        <a:font script="Viet" typeface="Arial"/>
+        <a:font script="Uigh" typeface="Microsoft Uighur"/>
+        <a:font script="Geor" typeface="Sylfaen"/>
+      </a:minorFont>
+    </a:fontScheme>
+    <a:fmtScheme name="Office">
+      <a:fillStyleLst>
+        <a:solidFill>
+          <a:schemeClr val="phClr"/>
+        </a:solidFill>
+        <a:gradFill rotWithShape="1">
+          <a:gsLst>
+            <a:gs pos="0">
+              <a:schemeClr val="phClr">
+                <a:tint val="50000"/>
+                <a:satMod val="300000"/>
+              </a:schemeClr>
+            </a:gs>
+            <a:gs pos="35000">
+              <a:schemeClr val="phClr">
+                <a:tint val="37000"/>
+                <a:satMod val="300000"/>
+              </a:schemeClr>
+            </a:gs>
+            <a:gs pos="100000">
+              <a:schemeClr val="phClr">
+                <a:tint val="15000"/>
+                <a:satMod val="350000"/>
+              </a:schemeClr>
+            </a:gs>
+          </a:gsLst>
+          <a:lin ang="16200000" scaled="1"/>
+        </a:gradFill>
+        <a:gradFill rotWithShape="1">
+          <a:gsLst>
+            <a:gs pos="0">
+              <a:schemeClr val="phClr">
+                <a:tint val="100000"/>
+                <a:shade val="100000"/>
+                <a:satMod val="130000"/>
+              </a:schemeClr>
+            </a:gs>
+            <a:gs pos="100000">
+              <a:schemeClr val="phClr">
+                <a:tint val="50000"/>
+                <a:shade val="100000"/>
+                <a:satMod val="350000"/>
+              </a:schemeClr>
+            </a:gs>
+          </a:gsLst>
+          <a:lin ang="16200000" scaled="0"/>
+        </a:gradFill>
+      </a:fillStyleLst>
+      <a:lnStyleLst>
+        <a:ln w="9525" cap="flat" cmpd="sng" algn="ctr">
+          <a:solidFill>
+            <a:schemeClr val="phClr">
+              <a:shade val="95000"/>
+              <a:satMod val="105000"/>
+            </a:schemeClr>
+          </a:solidFill>
+          <a:prstDash val="solid"/>
+        </a:ln>
+        <a:ln w="25400" cap="flat" cmpd="sng" algn="ctr">
+          <a:solidFill>
+            <a:schemeClr val="phClr"/>
+          </a:solidFill>
+          <a:prstDash val="solid"/>
+        </a:ln>
+        <a:ln w="38100" cap="flat" cmpd="sng" algn="ctr">
+          <a:solidFill>
+            <a:schemeClr val="phClr"/>
+          </a:solidFill>
+          <a:prstDash val="solid"/>
+        </a:ln>
+      </a:lnStyleLst>
+      <a:effectStyleLst>
+        <a:effectStyle>
+          <a:effectLst>
+            <a:outerShdw blurRad="40000" dist="20000" dir="5400000" rotWithShape="0">
+              <a:srgbClr val="000000">
+                <a:alpha val="38000"/>
+              </a:srgbClr>
+            </a:outerShdw>
+          </a:effectLst>
+        </a:effectStyle>
+        <a:effectStyle>
+          <a:effectLst>
+            <a:outerShdw blurRad="40000" dist="23000" dir="5400000" rotWithShape="0">
+              <a:srgbClr val="000000">
+                <a:alpha val="35000"/>
+              </a:srgbClr>
+            </a:outerShdw>
+          </a:effectLst>
+        </a:effectStyle>
+        <a:effectStyle>
+          <a:effectLst>
+            <a:outerShdw blurRad="40000" dist="23000" dir="5400000" rotWithShape="0">
+              <a:srgbClr val="000000">
+                <a:alpha val="35000"/>
+              </a:srgbClr>
+            </a:outerShdw>
+          </a:effectLst>
+          <a:scene3d>
+            <a:camera prst="orthographicFront">
+              <a:rot lat="0" lon="0" rev="0"/>
+            </a:camera>
+            <a:lightRig rig="threePt" dir="t">
+              <a:rot lat="0" lon="0" rev="1200000"/>
+            </a:lightRig>
+          </a:scene3d>
+          <a:sp3d>
+            <a:bevelT w="63500" h="25400"/>
+          </a:sp3d>
+        </a:effectStyle>
+      </a:effectStyleLst>
+      <a:bgFillStyleLst>
+        <a:solidFill>
+          <a:schemeClr val="phClr"/>
+        </a:solidFill>
+        <a:gradFill rotWithShape="1">
+          <a:gsLst>
+            <a:gs pos="0">
+              <a:schemeClr val="phClr">
+                <a:tint val="40000"/>
+                <a:satMod val="350000"/>
+              </a:schemeClr>
+            </a:gs>
+            <a:gs pos="40000">
+              <a:schemeClr val="phClr">
+                <a:tint val="45000"/>
+                <a:shade val="99000"/>
+                <a:satMod val="350000"/>
+              </a:schemeClr>
+            </a:gs>
+            <a:gs pos="100000">
+              <a:schemeClr val="phClr">
+                <a:shade val="20000"/>
+                <a:satMod val="255000"/>
+              </a:schemeClr>
+            </a:gs>
+          </a:gsLst>
+          <a:path path="circle">
+            <a:fillToRect l="50000" t="-80000" r="50000" b="180000"/>
+          </a:path>
+        </a:gradFill>
+        <a:gradFill rotWithShape="1">
+          <a:gsLst>
+            <a:gs pos="0">
+              <a:schemeClr val="phClr">
+                <a:tint val="80000"/>
+                <a:satMod val="300000"/>
+              </a:schemeClr>
+            </a:gs>
+            <a:gs pos="100000">
+              <a:schemeClr val="phClr">
+                <a:shade val="30000"/>
+                <a:satMod val="200000"/>
+              </a:schemeClr>
+            </a:gs>
+          </a:gsLst>
+          <a:path path="circle">
+            <a:fillToRect l="50000" t="50000" r="50000" b="50000"/>
+          </a:path>
+        </a:gradFill>
+      </a:bgFillStyleLst>
+    </a:fmtScheme>
+  </a:themeElements>
+</a:theme>
+</file>
+
+<file path=ppt/theme/theme2.xml><?xml version="1.0" encoding="utf-8"?>
 <a:theme xmlns:a="http://schemas.openxmlformats.org/drawingml/2006/main" xmlns:r="http://schemas.openxmlformats.org/officeDocument/2006/relationships" name="LF Energy Theme 2023">
   <a:themeElements>
     <a:clrScheme name="Geometric">
@@ -34280,7 +34559,7 @@
 </a:theme>
 </file>
 
-<file path=ppt/theme/theme2.xml><?xml version="1.0" encoding="utf-8"?>
+<file path=ppt/theme/theme3.xml><?xml version="1.0" encoding="utf-8"?>
 <a:theme xmlns:a="http://schemas.openxmlformats.org/drawingml/2006/main" xmlns:r="http://schemas.openxmlformats.org/officeDocument/2006/relationships">
   <a:themeElements>
     <a:clrScheme name="Default">
@@ -34557,283 +34836,4 @@
     </a:fmtScheme>
   </a:themeElements>
 </a:theme>
-</file>
-
-<file path=ppt/theme/theme3.xml><?xml version="1.0" encoding="utf-8"?>
-<a:theme xmlns:a="http://schemas.openxmlformats.org/drawingml/2006/main" xmlns:r="http://schemas.openxmlformats.org/officeDocument/2006/relationships" name="Simple Light">
-  <a:themeElements>
-    <a:clrScheme name="Simple Light">
-      <a:dk1>
-        <a:srgbClr val="000000"/>
-      </a:dk1>
-      <a:lt1>
-        <a:srgbClr val="FFFFFF"/>
-      </a:lt1>
-      <a:dk2>
-        <a:srgbClr val="595959"/>
-      </a:dk2>
-      <a:lt2>
-        <a:srgbClr val="EEEEEE"/>
-      </a:lt2>
-      <a:accent1>
-        <a:srgbClr val="4285F4"/>
-      </a:accent1>
-      <a:accent2>
-        <a:srgbClr val="212121"/>
-      </a:accent2>
-      <a:accent3>
-        <a:srgbClr val="78909C"/>
-      </a:accent3>
-      <a:accent4>
-        <a:srgbClr val="FFAB40"/>
-      </a:accent4>
-      <a:accent5>
-        <a:srgbClr val="0097A7"/>
-      </a:accent5>
-      <a:accent6>
-        <a:srgbClr val="EEFF41"/>
-      </a:accent6>
-      <a:hlink>
-        <a:srgbClr val="0097A7"/>
-      </a:hlink>
-      <a:folHlink>
-        <a:srgbClr val="0097A7"/>
-      </a:folHlink>
-    </a:clrScheme>
-    <a:fontScheme name="Office">
-      <a:majorFont>
-        <a:latin typeface="Arial"/>
-        <a:ea typeface=""/>
-        <a:cs typeface=""/>
-        <a:font script="Jpan" typeface="ＭＳ Ｐゴシック"/>
-        <a:font script="Hang" typeface="맑은 고딕"/>
-        <a:font script="Hans" typeface="宋体"/>
-        <a:font script="Hant" typeface="新細明體"/>
-        <a:font script="Arab" typeface="Times New Roman"/>
-        <a:font script="Hebr" typeface="Times New Roman"/>
-        <a:font script="Thai" typeface="Angsana New"/>
-        <a:font script="Ethi" typeface="Nyala"/>
-        <a:font script="Beng" typeface="Vrinda"/>
-        <a:font script="Gujr" typeface="Shruti"/>
-        <a:font script="Khmr" typeface="MoolBoran"/>
-        <a:font script="Knda" typeface="Tunga"/>
-        <a:font script="Guru" typeface="Raavi"/>
-        <a:font script="Cans" typeface="Euphemia"/>
-        <a:font script="Cher" typeface="Plantagenet Cherokee"/>
-        <a:font script="Yiii" typeface="Microsoft Yi Baiti"/>
-        <a:font script="Tibt" typeface="Microsoft Himalaya"/>
-        <a:font script="Thaa" typeface="MV Boli"/>
-        <a:font script="Deva" typeface="Mangal"/>
-        <a:font script="Telu" typeface="Gautami"/>
-        <a:font script="Taml" typeface="Latha"/>
-        <a:font script="Syrc" typeface="Estrangelo Edessa"/>
-        <a:font script="Orya" typeface="Kalinga"/>
-        <a:font script="Mlym" typeface="Kartika"/>
-        <a:font script="Laoo" typeface="DokChampa"/>
-        <a:font script="Sinh" typeface="Iskoola Pota"/>
-        <a:font script="Mong" typeface="Mongolian Baiti"/>
-        <a:font script="Viet" typeface="Times New Roman"/>
-        <a:font script="Uigh" typeface="Microsoft Uighur"/>
-        <a:font script="Geor" typeface="Sylfaen"/>
-      </a:majorFont>
-      <a:minorFont>
-        <a:latin typeface="Arial"/>
-        <a:ea typeface=""/>
-        <a:cs typeface=""/>
-        <a:font script="Jpan" typeface="ＭＳ Ｐゴシック"/>
-        <a:font script="Hang" typeface="맑은 고딕"/>
-        <a:font script="Hans" typeface="宋体"/>
-        <a:font script="Hant" typeface="新細明體"/>
-        <a:font script="Arab" typeface="Arial"/>
-        <a:font script="Hebr" typeface="Arial"/>
-        <a:font script="Thai" typeface="Cordia New"/>
-        <a:font script="Ethi" typeface="Nyala"/>
-        <a:font script="Beng" typeface="Vrinda"/>
-        <a:font script="Gujr" typeface="Shruti"/>
-        <a:font script="Khmr" typeface="DaunPenh"/>
-        <a:font script="Knda" typeface="Tunga"/>
-        <a:font script="Guru" typeface="Raavi"/>
-        <a:font script="Cans" typeface="Euphemia"/>
-        <a:font script="Cher" typeface="Plantagenet Cherokee"/>
-        <a:font script="Yiii" typeface="Microsoft Yi Baiti"/>
-        <a:font script="Tibt" typeface="Microsoft Himalaya"/>
-        <a:font script="Thaa" typeface="MV Boli"/>
-        <a:font script="Deva" typeface="Mangal"/>
-        <a:font script="Telu" typeface="Gautami"/>
-        <a:font script="Taml" typeface="Latha"/>
-        <a:font script="Syrc" typeface="Estrangelo Edessa"/>
-        <a:font script="Orya" typeface="Kalinga"/>
-        <a:font script="Mlym" typeface="Kartika"/>
-        <a:font script="Laoo" typeface="DokChampa"/>
-        <a:font script="Sinh" typeface="Iskoola Pota"/>
-        <a:font script="Mong" typeface="Mongolian Baiti"/>
-        <a:font script="Viet" typeface="Arial"/>
-        <a:font script="Uigh" typeface="Microsoft Uighur"/>
-        <a:font script="Geor" typeface="Sylfaen"/>
-      </a:minorFont>
-    </a:fontScheme>
-    <a:fmtScheme name="Office">
-      <a:fillStyleLst>
-        <a:solidFill>
-          <a:schemeClr val="phClr"/>
-        </a:solidFill>
-        <a:gradFill rotWithShape="1">
-          <a:gsLst>
-            <a:gs pos="0">
-              <a:schemeClr val="phClr">
-                <a:tint val="50000"/>
-                <a:satMod val="300000"/>
-              </a:schemeClr>
-            </a:gs>
-            <a:gs pos="35000">
-              <a:schemeClr val="phClr">
-                <a:tint val="37000"/>
-                <a:satMod val="300000"/>
-              </a:schemeClr>
-            </a:gs>
-            <a:gs pos="100000">
-              <a:schemeClr val="phClr">
-                <a:tint val="15000"/>
-                <a:satMod val="350000"/>
-              </a:schemeClr>
-            </a:gs>
-          </a:gsLst>
-          <a:lin ang="16200000" scaled="1"/>
-        </a:gradFill>
-        <a:gradFill rotWithShape="1">
-          <a:gsLst>
-            <a:gs pos="0">
-              <a:schemeClr val="phClr">
-                <a:tint val="100000"/>
-                <a:shade val="100000"/>
-                <a:satMod val="130000"/>
-              </a:schemeClr>
-            </a:gs>
-            <a:gs pos="100000">
-              <a:schemeClr val="phClr">
-                <a:tint val="50000"/>
-                <a:shade val="100000"/>
-                <a:satMod val="350000"/>
-              </a:schemeClr>
-            </a:gs>
-          </a:gsLst>
-          <a:lin ang="16200000" scaled="0"/>
-        </a:gradFill>
-      </a:fillStyleLst>
-      <a:lnStyleLst>
-        <a:ln w="9525" cap="flat" cmpd="sng" algn="ctr">
-          <a:solidFill>
-            <a:schemeClr val="phClr">
-              <a:shade val="95000"/>
-              <a:satMod val="105000"/>
-            </a:schemeClr>
-          </a:solidFill>
-          <a:prstDash val="solid"/>
-        </a:ln>
-        <a:ln w="25400" cap="flat" cmpd="sng" algn="ctr">
-          <a:solidFill>
-            <a:schemeClr val="phClr"/>
-          </a:solidFill>
-          <a:prstDash val="solid"/>
-        </a:ln>
-        <a:ln w="38100" cap="flat" cmpd="sng" algn="ctr">
-          <a:solidFill>
-            <a:schemeClr val="phClr"/>
-          </a:solidFill>
-          <a:prstDash val="solid"/>
-        </a:ln>
-      </a:lnStyleLst>
-      <a:effectStyleLst>
-        <a:effectStyle>
-          <a:effectLst>
-            <a:outerShdw blurRad="40000" dist="20000" dir="5400000" rotWithShape="0">
-              <a:srgbClr val="000000">
-                <a:alpha val="38000"/>
-              </a:srgbClr>
-            </a:outerShdw>
-          </a:effectLst>
-        </a:effectStyle>
-        <a:effectStyle>
-          <a:effectLst>
-            <a:outerShdw blurRad="40000" dist="23000" dir="5400000" rotWithShape="0">
-              <a:srgbClr val="000000">
-                <a:alpha val="35000"/>
-              </a:srgbClr>
-            </a:outerShdw>
-          </a:effectLst>
-        </a:effectStyle>
-        <a:effectStyle>
-          <a:effectLst>
-            <a:outerShdw blurRad="40000" dist="23000" dir="5400000" rotWithShape="0">
-              <a:srgbClr val="000000">
-                <a:alpha val="35000"/>
-              </a:srgbClr>
-            </a:outerShdw>
-          </a:effectLst>
-          <a:scene3d>
-            <a:camera prst="orthographicFront">
-              <a:rot lat="0" lon="0" rev="0"/>
-            </a:camera>
-            <a:lightRig rig="threePt" dir="t">
-              <a:rot lat="0" lon="0" rev="1200000"/>
-            </a:lightRig>
-          </a:scene3d>
-          <a:sp3d>
-            <a:bevelT w="63500" h="25400"/>
-          </a:sp3d>
-        </a:effectStyle>
-      </a:effectStyleLst>
-      <a:bgFillStyleLst>
-        <a:solidFill>
-          <a:schemeClr val="phClr"/>
-        </a:solidFill>
-        <a:gradFill rotWithShape="1">
-          <a:gsLst>
-            <a:gs pos="0">
-              <a:schemeClr val="phClr">
-                <a:tint val="40000"/>
-                <a:satMod val="350000"/>
-              </a:schemeClr>
-            </a:gs>
-            <a:gs pos="40000">
-              <a:schemeClr val="phClr">
-                <a:tint val="45000"/>
-                <a:shade val="99000"/>
-                <a:satMod val="350000"/>
-              </a:schemeClr>
-            </a:gs>
-            <a:gs pos="100000">
-              <a:schemeClr val="phClr">
-                <a:shade val="20000"/>
-                <a:satMod val="255000"/>
-              </a:schemeClr>
-            </a:gs>
-          </a:gsLst>
-          <a:path path="circle">
-            <a:fillToRect l="50000" t="-80000" r="50000" b="180000"/>
-          </a:path>
-        </a:gradFill>
-        <a:gradFill rotWithShape="1">
-          <a:gsLst>
-            <a:gs pos="0">
-              <a:schemeClr val="phClr">
-                <a:tint val="80000"/>
-                <a:satMod val="300000"/>
-              </a:schemeClr>
-            </a:gs>
-            <a:gs pos="100000">
-              <a:schemeClr val="phClr">
-                <a:shade val="30000"/>
-                <a:satMod val="200000"/>
-              </a:schemeClr>
-            </a:gs>
-          </a:gsLst>
-          <a:path path="circle">
-            <a:fillToRect l="50000" t="50000" r="50000" b="50000"/>
-          </a:path>
-        </a:gradFill>
-      </a:bgFillStyleLst>
-    </a:fmtScheme>
-  </a:themeElements>
-</a:theme>
 </file>
</xml_diff>

<commit_message>
Update Data Sources from LFX 2026-10-28 (#356)
Update Data Sources from LFX

Signed-off-by: github-actions[bot] <41898282+github-actions[bot]@users.noreply.github.com>
Co-authored-by: jmertic <296737+jmertic@users.noreply.github.com>
</commit_message>
<xml_diff>
--- a/overview_deck/LF Energy High Level Overview.pptx
+++ b/overview_deck/LF Energy High Level Overview.pptx
@@ -25946,7 +25946,7 @@
             <a:tbl>
               <a:tblPr>
                 <a:noFill/>
-                <a:tableStyleId>{9BAB03E5-1E38-45C2-A965-D2132A89F11C}</a:tableStyleId>
+                <a:tableStyleId>{419C5B26-E27D-436E-83DE-19265549C941}</a:tableStyleId>
               </a:tblPr>
               <a:tblGrid>
                 <a:gridCol w="1695200"/>
@@ -26736,7 +26736,7 @@
             <a:tbl>
               <a:tblPr>
                 <a:noFill/>
-                <a:tableStyleId>{9BAB03E5-1E38-45C2-A965-D2132A89F11C}</a:tableStyleId>
+                <a:tableStyleId>{419C5B26-E27D-436E-83DE-19265549C941}</a:tableStyleId>
               </a:tblPr>
               <a:tblGrid>
                 <a:gridCol w="1695200"/>
@@ -27426,7 +27426,7 @@
             <a:tbl>
               <a:tblPr>
                 <a:noFill/>
-                <a:tableStyleId>{9BAB03E5-1E38-45C2-A965-D2132A89F11C}</a:tableStyleId>
+                <a:tableStyleId>{419C5B26-E27D-436E-83DE-19265549C941}</a:tableStyleId>
               </a:tblPr>
               <a:tblGrid>
                 <a:gridCol w="1695200"/>
@@ -28678,7 +28678,7 @@
             <a:tbl>
               <a:tblPr>
                 <a:noFill/>
-                <a:tableStyleId>{9BAB03E5-1E38-45C2-A965-D2132A89F11C}</a:tableStyleId>
+                <a:tableStyleId>{419C5B26-E27D-436E-83DE-19265549C941}</a:tableStyleId>
               </a:tblPr>
               <a:tblGrid>
                 <a:gridCol w="1695200"/>
@@ -29670,7 +29670,7 @@
             <a:tbl>
               <a:tblPr>
                 <a:noFill/>
-                <a:tableStyleId>{9BAB03E5-1E38-45C2-A965-D2132A89F11C}</a:tableStyleId>
+                <a:tableStyleId>{419C5B26-E27D-436E-83DE-19265549C941}</a:tableStyleId>
               </a:tblPr>
               <a:tblGrid>
                 <a:gridCol w="3048000"/>
@@ -33175,7 +33175,7 @@
             <a:tbl>
               <a:tblPr>
                 <a:noFill/>
-                <a:tableStyleId>{9BAB03E5-1E38-45C2-A965-D2132A89F11C}</a:tableStyleId>
+                <a:tableStyleId>{419C5B26-E27D-436E-83DE-19265549C941}</a:tableStyleId>
               </a:tblPr>
               <a:tblGrid>
                 <a:gridCol w="1828800"/>
@@ -34281,6 +34281,285 @@
 </file>
 
 <file path=ppt/theme/theme2.xml><?xml version="1.0" encoding="utf-8"?>
+<a:theme xmlns:a="http://schemas.openxmlformats.org/drawingml/2006/main" xmlns:r="http://schemas.openxmlformats.org/officeDocument/2006/relationships">
+  <a:themeElements>
+    <a:clrScheme name="Default">
+      <a:dk1>
+        <a:srgbClr val="000000"/>
+      </a:dk1>
+      <a:lt1>
+        <a:srgbClr val="FFFFFF"/>
+      </a:lt1>
+      <a:dk2>
+        <a:srgbClr val="158158"/>
+      </a:dk2>
+      <a:lt2>
+        <a:srgbClr val="F3F3F3"/>
+      </a:lt2>
+      <a:accent1>
+        <a:srgbClr val="058DC7"/>
+      </a:accent1>
+      <a:accent2>
+        <a:srgbClr val="50B432"/>
+      </a:accent2>
+      <a:accent3>
+        <a:srgbClr val="ED561B"/>
+      </a:accent3>
+      <a:accent4>
+        <a:srgbClr val="EDEF00"/>
+      </a:accent4>
+      <a:accent5>
+        <a:srgbClr val="24CBE5"/>
+      </a:accent5>
+      <a:accent6>
+        <a:srgbClr val="64E572"/>
+      </a:accent6>
+      <a:hlink>
+        <a:srgbClr val="2200CC"/>
+      </a:hlink>
+      <a:folHlink>
+        <a:srgbClr val="551A8B"/>
+      </a:folHlink>
+    </a:clrScheme>
+    <a:fontScheme name="Office">
+      <a:majorFont>
+        <a:latin typeface="Arial"/>
+        <a:ea typeface=""/>
+        <a:cs typeface=""/>
+        <a:font script="Jpan" typeface="ＭＳ Ｐゴシック"/>
+        <a:font script="Hang" typeface="맑은 고딕"/>
+        <a:font script="Hans" typeface="宋体"/>
+        <a:font script="Hant" typeface="新細明體"/>
+        <a:font script="Arab" typeface="Times New Roman"/>
+        <a:font script="Hebr" typeface="Times New Roman"/>
+        <a:font script="Thai" typeface="Angsana New"/>
+        <a:font script="Ethi" typeface="Nyala"/>
+        <a:font script="Beng" typeface="Vrinda"/>
+        <a:font script="Gujr" typeface="Shruti"/>
+        <a:font script="Khmr" typeface="MoolBoran"/>
+        <a:font script="Knda" typeface="Tunga"/>
+        <a:font script="Guru" typeface="Raavi"/>
+        <a:font script="Cans" typeface="Euphemia"/>
+        <a:font script="Cher" typeface="Plantagenet Cherokee"/>
+        <a:font script="Yiii" typeface="Microsoft Yi Baiti"/>
+        <a:font script="Tibt" typeface="Microsoft Himalaya"/>
+        <a:font script="Thaa" typeface="MV Boli"/>
+        <a:font script="Deva" typeface="Mangal"/>
+        <a:font script="Telu" typeface="Gautami"/>
+        <a:font script="Taml" typeface="Latha"/>
+        <a:font script="Syrc" typeface="Estrangelo Edessa"/>
+        <a:font script="Orya" typeface="Kalinga"/>
+        <a:font script="Mlym" typeface="Kartika"/>
+        <a:font script="Laoo" typeface="DokChampa"/>
+        <a:font script="Sinh" typeface="Iskoola Pota"/>
+        <a:font script="Mong" typeface="Mongolian Baiti"/>
+        <a:font script="Viet" typeface="Times New Roman"/>
+        <a:font script="Uigh" typeface="Microsoft Uighur"/>
+        <a:font script="Geor" typeface="Sylfaen"/>
+      </a:majorFont>
+      <a:minorFont>
+        <a:latin typeface="Arial"/>
+        <a:ea typeface=""/>
+        <a:cs typeface=""/>
+        <a:font script="Jpan" typeface="ＭＳ Ｐゴシック"/>
+        <a:font script="Hang" typeface="맑은 고딕"/>
+        <a:font script="Hans" typeface="宋体"/>
+        <a:font script="Hant" typeface="新細明體"/>
+        <a:font script="Arab" typeface="Arial"/>
+        <a:font script="Hebr" typeface="Arial"/>
+        <a:font script="Thai" typeface="Cordia New"/>
+        <a:font script="Ethi" typeface="Nyala"/>
+        <a:font script="Beng" typeface="Vrinda"/>
+        <a:font script="Gujr" typeface="Shruti"/>
+        <a:font script="Khmr" typeface="DaunPenh"/>
+        <a:font script="Knda" typeface="Tunga"/>
+        <a:font script="Guru" typeface="Raavi"/>
+        <a:font script="Cans" typeface="Euphemia"/>
+        <a:font script="Cher" typeface="Plantagenet Cherokee"/>
+        <a:font script="Yiii" typeface="Microsoft Yi Baiti"/>
+        <a:font script="Tibt" typeface="Microsoft Himalaya"/>
+        <a:font script="Thaa" typeface="MV Boli"/>
+        <a:font script="Deva" typeface="Mangal"/>
+        <a:font script="Telu" typeface="Gautami"/>
+        <a:font script="Taml" typeface="Latha"/>
+        <a:font script="Syrc" typeface="Estrangelo Edessa"/>
+        <a:font script="Orya" typeface="Kalinga"/>
+        <a:font script="Mlym" typeface="Kartika"/>
+        <a:font script="Laoo" typeface="DokChampa"/>
+        <a:font script="Sinh" typeface="Iskoola Pota"/>
+        <a:font script="Mong" typeface="Mongolian Baiti"/>
+        <a:font script="Viet" typeface="Arial"/>
+        <a:font script="Uigh" typeface="Microsoft Uighur"/>
+        <a:font script="Geor" typeface="Sylfaen"/>
+      </a:minorFont>
+    </a:fontScheme>
+    <a:fmtScheme name="Office">
+      <a:fillStyleLst>
+        <a:solidFill>
+          <a:schemeClr val="phClr"/>
+        </a:solidFill>
+        <a:gradFill rotWithShape="1">
+          <a:gsLst>
+            <a:gs pos="0">
+              <a:schemeClr val="phClr">
+                <a:tint val="50000"/>
+                <a:satMod val="300000"/>
+              </a:schemeClr>
+            </a:gs>
+            <a:gs pos="35000">
+              <a:schemeClr val="phClr">
+                <a:tint val="37000"/>
+                <a:satMod val="300000"/>
+              </a:schemeClr>
+            </a:gs>
+            <a:gs pos="100000">
+              <a:schemeClr val="phClr">
+                <a:tint val="15000"/>
+                <a:satMod val="350000"/>
+              </a:schemeClr>
+            </a:gs>
+          </a:gsLst>
+          <a:lin ang="16200000" scaled="1"/>
+        </a:gradFill>
+        <a:gradFill rotWithShape="1">
+          <a:gsLst>
+            <a:gs pos="0">
+              <a:schemeClr val="phClr">
+                <a:tint val="100000"/>
+                <a:shade val="100000"/>
+                <a:satMod val="130000"/>
+              </a:schemeClr>
+            </a:gs>
+            <a:gs pos="100000">
+              <a:schemeClr val="phClr">
+                <a:tint val="50000"/>
+                <a:shade val="100000"/>
+                <a:satMod val="350000"/>
+              </a:schemeClr>
+            </a:gs>
+          </a:gsLst>
+          <a:lin ang="16200000" scaled="0"/>
+        </a:gradFill>
+      </a:fillStyleLst>
+      <a:lnStyleLst>
+        <a:ln w="9525" cap="flat" cmpd="sng" algn="ctr">
+          <a:solidFill>
+            <a:schemeClr val="phClr">
+              <a:shade val="95000"/>
+              <a:satMod val="105000"/>
+            </a:schemeClr>
+          </a:solidFill>
+          <a:prstDash val="solid"/>
+        </a:ln>
+        <a:ln w="25400" cap="flat" cmpd="sng" algn="ctr">
+          <a:solidFill>
+            <a:schemeClr val="phClr"/>
+          </a:solidFill>
+          <a:prstDash val="solid"/>
+        </a:ln>
+        <a:ln w="38100" cap="flat" cmpd="sng" algn="ctr">
+          <a:solidFill>
+            <a:schemeClr val="phClr"/>
+          </a:solidFill>
+          <a:prstDash val="solid"/>
+        </a:ln>
+      </a:lnStyleLst>
+      <a:effectStyleLst>
+        <a:effectStyle>
+          <a:effectLst>
+            <a:outerShdw blurRad="40000" dist="20000" dir="5400000" rotWithShape="0">
+              <a:srgbClr val="000000">
+                <a:alpha val="38000"/>
+              </a:srgbClr>
+            </a:outerShdw>
+          </a:effectLst>
+        </a:effectStyle>
+        <a:effectStyle>
+          <a:effectLst>
+            <a:outerShdw blurRad="40000" dist="23000" dir="5400000" rotWithShape="0">
+              <a:srgbClr val="000000">
+                <a:alpha val="35000"/>
+              </a:srgbClr>
+            </a:outerShdw>
+          </a:effectLst>
+        </a:effectStyle>
+        <a:effectStyle>
+          <a:effectLst>
+            <a:outerShdw blurRad="40000" dist="23000" dir="5400000" rotWithShape="0">
+              <a:srgbClr val="000000">
+                <a:alpha val="35000"/>
+              </a:srgbClr>
+            </a:outerShdw>
+          </a:effectLst>
+          <a:scene3d>
+            <a:camera prst="orthographicFront">
+              <a:rot lat="0" lon="0" rev="0"/>
+            </a:camera>
+            <a:lightRig rig="threePt" dir="t">
+              <a:rot lat="0" lon="0" rev="1200000"/>
+            </a:lightRig>
+          </a:scene3d>
+          <a:sp3d>
+            <a:bevelT w="63500" h="25400"/>
+          </a:sp3d>
+        </a:effectStyle>
+      </a:effectStyleLst>
+      <a:bgFillStyleLst>
+        <a:solidFill>
+          <a:schemeClr val="phClr"/>
+        </a:solidFill>
+        <a:gradFill rotWithShape="1">
+          <a:gsLst>
+            <a:gs pos="0">
+              <a:schemeClr val="phClr">
+                <a:tint val="40000"/>
+                <a:satMod val="350000"/>
+              </a:schemeClr>
+            </a:gs>
+            <a:gs pos="40000">
+              <a:schemeClr val="phClr">
+                <a:tint val="45000"/>
+                <a:shade val="99000"/>
+                <a:satMod val="350000"/>
+              </a:schemeClr>
+            </a:gs>
+            <a:gs pos="100000">
+              <a:schemeClr val="phClr">
+                <a:shade val="20000"/>
+                <a:satMod val="255000"/>
+              </a:schemeClr>
+            </a:gs>
+          </a:gsLst>
+          <a:path path="circle">
+            <a:fillToRect l="50000" t="-80000" r="50000" b="180000"/>
+          </a:path>
+        </a:gradFill>
+        <a:gradFill rotWithShape="1">
+          <a:gsLst>
+            <a:gs pos="0">
+              <a:schemeClr val="phClr">
+                <a:tint val="80000"/>
+                <a:satMod val="300000"/>
+              </a:schemeClr>
+            </a:gs>
+            <a:gs pos="100000">
+              <a:schemeClr val="phClr">
+                <a:shade val="30000"/>
+                <a:satMod val="200000"/>
+              </a:schemeClr>
+            </a:gs>
+          </a:gsLst>
+          <a:path path="circle">
+            <a:fillToRect l="50000" t="50000" r="50000" b="50000"/>
+          </a:path>
+        </a:gradFill>
+      </a:bgFillStyleLst>
+    </a:fmtScheme>
+  </a:themeElements>
+</a:theme>
+</file>
+
+<file path=ppt/theme/theme3.xml><?xml version="1.0" encoding="utf-8"?>
 <a:theme xmlns:a="http://schemas.openxmlformats.org/drawingml/2006/main" xmlns:r="http://schemas.openxmlformats.org/officeDocument/2006/relationships" name="LF Energy Theme 2023">
   <a:themeElements>
     <a:clrScheme name="Geometric">
@@ -34557,283 +34836,4 @@
     </a:fmtScheme>
   </a:themeElements>
 </a:theme>
-</file>
-
-<file path=ppt/theme/theme3.xml><?xml version="1.0" encoding="utf-8"?>
-<a:theme xmlns:a="http://schemas.openxmlformats.org/drawingml/2006/main" xmlns:r="http://schemas.openxmlformats.org/officeDocument/2006/relationships">
-  <a:themeElements>
-    <a:clrScheme name="Default">
-      <a:dk1>
-        <a:srgbClr val="000000"/>
-      </a:dk1>
-      <a:lt1>
-        <a:srgbClr val="FFFFFF"/>
-      </a:lt1>
-      <a:dk2>
-        <a:srgbClr val="158158"/>
-      </a:dk2>
-      <a:lt2>
-        <a:srgbClr val="F3F3F3"/>
-      </a:lt2>
-      <a:accent1>
-        <a:srgbClr val="058DC7"/>
-      </a:accent1>
-      <a:accent2>
-        <a:srgbClr val="50B432"/>
-      </a:accent2>
-      <a:accent3>
-        <a:srgbClr val="ED561B"/>
-      </a:accent3>
-      <a:accent4>
-        <a:srgbClr val="EDEF00"/>
-      </a:accent4>
-      <a:accent5>
-        <a:srgbClr val="24CBE5"/>
-      </a:accent5>
-      <a:accent6>
-        <a:srgbClr val="64E572"/>
-      </a:accent6>
-      <a:hlink>
-        <a:srgbClr val="2200CC"/>
-      </a:hlink>
-      <a:folHlink>
-        <a:srgbClr val="551A8B"/>
-      </a:folHlink>
-    </a:clrScheme>
-    <a:fontScheme name="Office">
-      <a:majorFont>
-        <a:latin typeface="Arial"/>
-        <a:ea typeface=""/>
-        <a:cs typeface=""/>
-        <a:font script="Jpan" typeface="ＭＳ Ｐゴシック"/>
-        <a:font script="Hang" typeface="맑은 고딕"/>
-        <a:font script="Hans" typeface="宋体"/>
-        <a:font script="Hant" typeface="新細明體"/>
-        <a:font script="Arab" typeface="Times New Roman"/>
-        <a:font script="Hebr" typeface="Times New Roman"/>
-        <a:font script="Thai" typeface="Angsana New"/>
-        <a:font script="Ethi" typeface="Nyala"/>
-        <a:font script="Beng" typeface="Vrinda"/>
-        <a:font script="Gujr" typeface="Shruti"/>
-        <a:font script="Khmr" typeface="MoolBoran"/>
-        <a:font script="Knda" typeface="Tunga"/>
-        <a:font script="Guru" typeface="Raavi"/>
-        <a:font script="Cans" typeface="Euphemia"/>
-        <a:font script="Cher" typeface="Plantagenet Cherokee"/>
-        <a:font script="Yiii" typeface="Microsoft Yi Baiti"/>
-        <a:font script="Tibt" typeface="Microsoft Himalaya"/>
-        <a:font script="Thaa" typeface="MV Boli"/>
-        <a:font script="Deva" typeface="Mangal"/>
-        <a:font script="Telu" typeface="Gautami"/>
-        <a:font script="Taml" typeface="Latha"/>
-        <a:font script="Syrc" typeface="Estrangelo Edessa"/>
-        <a:font script="Orya" typeface="Kalinga"/>
-        <a:font script="Mlym" typeface="Kartika"/>
-        <a:font script="Laoo" typeface="DokChampa"/>
-        <a:font script="Sinh" typeface="Iskoola Pota"/>
-        <a:font script="Mong" typeface="Mongolian Baiti"/>
-        <a:font script="Viet" typeface="Times New Roman"/>
-        <a:font script="Uigh" typeface="Microsoft Uighur"/>
-        <a:font script="Geor" typeface="Sylfaen"/>
-      </a:majorFont>
-      <a:minorFont>
-        <a:latin typeface="Arial"/>
-        <a:ea typeface=""/>
-        <a:cs typeface=""/>
-        <a:font script="Jpan" typeface="ＭＳ Ｐゴシック"/>
-        <a:font script="Hang" typeface="맑은 고딕"/>
-        <a:font script="Hans" typeface="宋体"/>
-        <a:font script="Hant" typeface="新細明體"/>
-        <a:font script="Arab" typeface="Arial"/>
-        <a:font script="Hebr" typeface="Arial"/>
-        <a:font script="Thai" typeface="Cordia New"/>
-        <a:font script="Ethi" typeface="Nyala"/>
-        <a:font script="Beng" typeface="Vrinda"/>
-        <a:font script="Gujr" typeface="Shruti"/>
-        <a:font script="Khmr" typeface="DaunPenh"/>
-        <a:font script="Knda" typeface="Tunga"/>
-        <a:font script="Guru" typeface="Raavi"/>
-        <a:font script="Cans" typeface="Euphemia"/>
-        <a:font script="Cher" typeface="Plantagenet Cherokee"/>
-        <a:font script="Yiii" typeface="Microsoft Yi Baiti"/>
-        <a:font script="Tibt" typeface="Microsoft Himalaya"/>
-        <a:font script="Thaa" typeface="MV Boli"/>
-        <a:font script="Deva" typeface="Mangal"/>
-        <a:font script="Telu" typeface="Gautami"/>
-        <a:font script="Taml" typeface="Latha"/>
-        <a:font script="Syrc" typeface="Estrangelo Edessa"/>
-        <a:font script="Orya" typeface="Kalinga"/>
-        <a:font script="Mlym" typeface="Kartika"/>
-        <a:font script="Laoo" typeface="DokChampa"/>
-        <a:font script="Sinh" typeface="Iskoola Pota"/>
-        <a:font script="Mong" typeface="Mongolian Baiti"/>
-        <a:font script="Viet" typeface="Arial"/>
-        <a:font script="Uigh" typeface="Microsoft Uighur"/>
-        <a:font script="Geor" typeface="Sylfaen"/>
-      </a:minorFont>
-    </a:fontScheme>
-    <a:fmtScheme name="Office">
-      <a:fillStyleLst>
-        <a:solidFill>
-          <a:schemeClr val="phClr"/>
-        </a:solidFill>
-        <a:gradFill rotWithShape="1">
-          <a:gsLst>
-            <a:gs pos="0">
-              <a:schemeClr val="phClr">
-                <a:tint val="50000"/>
-                <a:satMod val="300000"/>
-              </a:schemeClr>
-            </a:gs>
-            <a:gs pos="35000">
-              <a:schemeClr val="phClr">
-                <a:tint val="37000"/>
-                <a:satMod val="300000"/>
-              </a:schemeClr>
-            </a:gs>
-            <a:gs pos="100000">
-              <a:schemeClr val="phClr">
-                <a:tint val="15000"/>
-                <a:satMod val="350000"/>
-              </a:schemeClr>
-            </a:gs>
-          </a:gsLst>
-          <a:lin ang="16200000" scaled="1"/>
-        </a:gradFill>
-        <a:gradFill rotWithShape="1">
-          <a:gsLst>
-            <a:gs pos="0">
-              <a:schemeClr val="phClr">
-                <a:tint val="100000"/>
-                <a:shade val="100000"/>
-                <a:satMod val="130000"/>
-              </a:schemeClr>
-            </a:gs>
-            <a:gs pos="100000">
-              <a:schemeClr val="phClr">
-                <a:tint val="50000"/>
-                <a:shade val="100000"/>
-                <a:satMod val="350000"/>
-              </a:schemeClr>
-            </a:gs>
-          </a:gsLst>
-          <a:lin ang="16200000" scaled="0"/>
-        </a:gradFill>
-      </a:fillStyleLst>
-      <a:lnStyleLst>
-        <a:ln w="9525" cap="flat" cmpd="sng" algn="ctr">
-          <a:solidFill>
-            <a:schemeClr val="phClr">
-              <a:shade val="95000"/>
-              <a:satMod val="105000"/>
-            </a:schemeClr>
-          </a:solidFill>
-          <a:prstDash val="solid"/>
-        </a:ln>
-        <a:ln w="25400" cap="flat" cmpd="sng" algn="ctr">
-          <a:solidFill>
-            <a:schemeClr val="phClr"/>
-          </a:solidFill>
-          <a:prstDash val="solid"/>
-        </a:ln>
-        <a:ln w="38100" cap="flat" cmpd="sng" algn="ctr">
-          <a:solidFill>
-            <a:schemeClr val="phClr"/>
-          </a:solidFill>
-          <a:prstDash val="solid"/>
-        </a:ln>
-      </a:lnStyleLst>
-      <a:effectStyleLst>
-        <a:effectStyle>
-          <a:effectLst>
-            <a:outerShdw blurRad="40000" dist="20000" dir="5400000" rotWithShape="0">
-              <a:srgbClr val="000000">
-                <a:alpha val="38000"/>
-              </a:srgbClr>
-            </a:outerShdw>
-          </a:effectLst>
-        </a:effectStyle>
-        <a:effectStyle>
-          <a:effectLst>
-            <a:outerShdw blurRad="40000" dist="23000" dir="5400000" rotWithShape="0">
-              <a:srgbClr val="000000">
-                <a:alpha val="35000"/>
-              </a:srgbClr>
-            </a:outerShdw>
-          </a:effectLst>
-        </a:effectStyle>
-        <a:effectStyle>
-          <a:effectLst>
-            <a:outerShdw blurRad="40000" dist="23000" dir="5400000" rotWithShape="0">
-              <a:srgbClr val="000000">
-                <a:alpha val="35000"/>
-              </a:srgbClr>
-            </a:outerShdw>
-          </a:effectLst>
-          <a:scene3d>
-            <a:camera prst="orthographicFront">
-              <a:rot lat="0" lon="0" rev="0"/>
-            </a:camera>
-            <a:lightRig rig="threePt" dir="t">
-              <a:rot lat="0" lon="0" rev="1200000"/>
-            </a:lightRig>
-          </a:scene3d>
-          <a:sp3d>
-            <a:bevelT w="63500" h="25400"/>
-          </a:sp3d>
-        </a:effectStyle>
-      </a:effectStyleLst>
-      <a:bgFillStyleLst>
-        <a:solidFill>
-          <a:schemeClr val="phClr"/>
-        </a:solidFill>
-        <a:gradFill rotWithShape="1">
-          <a:gsLst>
-            <a:gs pos="0">
-              <a:schemeClr val="phClr">
-                <a:tint val="40000"/>
-                <a:satMod val="350000"/>
-              </a:schemeClr>
-            </a:gs>
-            <a:gs pos="40000">
-              <a:schemeClr val="phClr">
-                <a:tint val="45000"/>
-                <a:shade val="99000"/>
-                <a:satMod val="350000"/>
-              </a:schemeClr>
-            </a:gs>
-            <a:gs pos="100000">
-              <a:schemeClr val="phClr">
-                <a:shade val="20000"/>
-                <a:satMod val="255000"/>
-              </a:schemeClr>
-            </a:gs>
-          </a:gsLst>
-          <a:path path="circle">
-            <a:fillToRect l="50000" t="-80000" r="50000" b="180000"/>
-          </a:path>
-        </a:gradFill>
-        <a:gradFill rotWithShape="1">
-          <a:gsLst>
-            <a:gs pos="0">
-              <a:schemeClr val="phClr">
-                <a:tint val="80000"/>
-                <a:satMod val="300000"/>
-              </a:schemeClr>
-            </a:gs>
-            <a:gs pos="100000">
-              <a:schemeClr val="phClr">
-                <a:shade val="30000"/>
-                <a:satMod val="200000"/>
-              </a:schemeClr>
-            </a:gs>
-          </a:gsLst>
-          <a:path path="circle">
-            <a:fillToRect l="50000" t="50000" r="50000" b="50000"/>
-          </a:path>
-        </a:gradFill>
-      </a:bgFillStyleLst>
-    </a:fmtScheme>
-  </a:themeElements>
-</a:theme>
 </file>
</xml_diff>

<commit_message>
Update Data Sources from LFX 2026-10-29 (#357)
Update Data Sources from LFX

Signed-off-by: github-actions[bot] <41898282+github-actions[bot]@users.noreply.github.com>
Co-authored-by: jmertic <296737+jmertic@users.noreply.github.com>
</commit_message>
<xml_diff>
--- a/overview_deck/LF Energy High Level Overview.pptx
+++ b/overview_deck/LF Energy High Level Overview.pptx
@@ -25946,7 +25946,7 @@
             <a:tbl>
               <a:tblPr>
                 <a:noFill/>
-                <a:tableStyleId>{419C5B26-E27D-436E-83DE-19265549C941}</a:tableStyleId>
+                <a:tableStyleId>{C26113E1-182A-4027-ABFA-8594D162625F}</a:tableStyleId>
               </a:tblPr>
               <a:tblGrid>
                 <a:gridCol w="1695200"/>
@@ -26736,7 +26736,7 @@
             <a:tbl>
               <a:tblPr>
                 <a:noFill/>
-                <a:tableStyleId>{419C5B26-E27D-436E-83DE-19265549C941}</a:tableStyleId>
+                <a:tableStyleId>{C26113E1-182A-4027-ABFA-8594D162625F}</a:tableStyleId>
               </a:tblPr>
               <a:tblGrid>
                 <a:gridCol w="1695200"/>
@@ -27426,7 +27426,7 @@
             <a:tbl>
               <a:tblPr>
                 <a:noFill/>
-                <a:tableStyleId>{419C5B26-E27D-436E-83DE-19265549C941}</a:tableStyleId>
+                <a:tableStyleId>{C26113E1-182A-4027-ABFA-8594D162625F}</a:tableStyleId>
               </a:tblPr>
               <a:tblGrid>
                 <a:gridCol w="1695200"/>
@@ -28678,7 +28678,7 @@
             <a:tbl>
               <a:tblPr>
                 <a:noFill/>
-                <a:tableStyleId>{419C5B26-E27D-436E-83DE-19265549C941}</a:tableStyleId>
+                <a:tableStyleId>{C26113E1-182A-4027-ABFA-8594D162625F}</a:tableStyleId>
               </a:tblPr>
               <a:tblGrid>
                 <a:gridCol w="1695200"/>
@@ -29670,7 +29670,7 @@
             <a:tbl>
               <a:tblPr>
                 <a:noFill/>
-                <a:tableStyleId>{419C5B26-E27D-436E-83DE-19265549C941}</a:tableStyleId>
+                <a:tableStyleId>{C26113E1-182A-4027-ABFA-8594D162625F}</a:tableStyleId>
               </a:tblPr>
               <a:tblGrid>
                 <a:gridCol w="3048000"/>
@@ -33175,7 +33175,7 @@
             <a:tbl>
               <a:tblPr>
                 <a:noFill/>
-                <a:tableStyleId>{419C5B26-E27D-436E-83DE-19265549C941}</a:tableStyleId>
+                <a:tableStyleId>{C26113E1-182A-4027-ABFA-8594D162625F}</a:tableStyleId>
               </a:tblPr>
               <a:tblGrid>
                 <a:gridCol w="1828800"/>
@@ -34002,285 +34002,6 @@
 </file>
 
 <file path=ppt/theme/theme1.xml><?xml version="1.0" encoding="utf-8"?>
-<a:theme xmlns:a="http://schemas.openxmlformats.org/drawingml/2006/main" xmlns:r="http://schemas.openxmlformats.org/officeDocument/2006/relationships" name="Simple Light">
-  <a:themeElements>
-    <a:clrScheme name="Simple Light">
-      <a:dk1>
-        <a:srgbClr val="000000"/>
-      </a:dk1>
-      <a:lt1>
-        <a:srgbClr val="FFFFFF"/>
-      </a:lt1>
-      <a:dk2>
-        <a:srgbClr val="595959"/>
-      </a:dk2>
-      <a:lt2>
-        <a:srgbClr val="EEEEEE"/>
-      </a:lt2>
-      <a:accent1>
-        <a:srgbClr val="4285F4"/>
-      </a:accent1>
-      <a:accent2>
-        <a:srgbClr val="212121"/>
-      </a:accent2>
-      <a:accent3>
-        <a:srgbClr val="78909C"/>
-      </a:accent3>
-      <a:accent4>
-        <a:srgbClr val="FFAB40"/>
-      </a:accent4>
-      <a:accent5>
-        <a:srgbClr val="0097A7"/>
-      </a:accent5>
-      <a:accent6>
-        <a:srgbClr val="EEFF41"/>
-      </a:accent6>
-      <a:hlink>
-        <a:srgbClr val="0097A7"/>
-      </a:hlink>
-      <a:folHlink>
-        <a:srgbClr val="0097A7"/>
-      </a:folHlink>
-    </a:clrScheme>
-    <a:fontScheme name="Office">
-      <a:majorFont>
-        <a:latin typeface="Arial"/>
-        <a:ea typeface=""/>
-        <a:cs typeface=""/>
-        <a:font script="Jpan" typeface="ＭＳ Ｐゴシック"/>
-        <a:font script="Hang" typeface="맑은 고딕"/>
-        <a:font script="Hans" typeface="宋体"/>
-        <a:font script="Hant" typeface="新細明體"/>
-        <a:font script="Arab" typeface="Times New Roman"/>
-        <a:font script="Hebr" typeface="Times New Roman"/>
-        <a:font script="Thai" typeface="Angsana New"/>
-        <a:font script="Ethi" typeface="Nyala"/>
-        <a:font script="Beng" typeface="Vrinda"/>
-        <a:font script="Gujr" typeface="Shruti"/>
-        <a:font script="Khmr" typeface="MoolBoran"/>
-        <a:font script="Knda" typeface="Tunga"/>
-        <a:font script="Guru" typeface="Raavi"/>
-        <a:font script="Cans" typeface="Euphemia"/>
-        <a:font script="Cher" typeface="Plantagenet Cherokee"/>
-        <a:font script="Yiii" typeface="Microsoft Yi Baiti"/>
-        <a:font script="Tibt" typeface="Microsoft Himalaya"/>
-        <a:font script="Thaa" typeface="MV Boli"/>
-        <a:font script="Deva" typeface="Mangal"/>
-        <a:font script="Telu" typeface="Gautami"/>
-        <a:font script="Taml" typeface="Latha"/>
-        <a:font script="Syrc" typeface="Estrangelo Edessa"/>
-        <a:font script="Orya" typeface="Kalinga"/>
-        <a:font script="Mlym" typeface="Kartika"/>
-        <a:font script="Laoo" typeface="DokChampa"/>
-        <a:font script="Sinh" typeface="Iskoola Pota"/>
-        <a:font script="Mong" typeface="Mongolian Baiti"/>
-        <a:font script="Viet" typeface="Times New Roman"/>
-        <a:font script="Uigh" typeface="Microsoft Uighur"/>
-        <a:font script="Geor" typeface="Sylfaen"/>
-      </a:majorFont>
-      <a:minorFont>
-        <a:latin typeface="Arial"/>
-        <a:ea typeface=""/>
-        <a:cs typeface=""/>
-        <a:font script="Jpan" typeface="ＭＳ Ｐゴシック"/>
-        <a:font script="Hang" typeface="맑은 고딕"/>
-        <a:font script="Hans" typeface="宋体"/>
-        <a:font script="Hant" typeface="新細明體"/>
-        <a:font script="Arab" typeface="Arial"/>
-        <a:font script="Hebr" typeface="Arial"/>
-        <a:font script="Thai" typeface="Cordia New"/>
-        <a:font script="Ethi" typeface="Nyala"/>
-        <a:font script="Beng" typeface="Vrinda"/>
-        <a:font script="Gujr" typeface="Shruti"/>
-        <a:font script="Khmr" typeface="DaunPenh"/>
-        <a:font script="Knda" typeface="Tunga"/>
-        <a:font script="Guru" typeface="Raavi"/>
-        <a:font script="Cans" typeface="Euphemia"/>
-        <a:font script="Cher" typeface="Plantagenet Cherokee"/>
-        <a:font script="Yiii" typeface="Microsoft Yi Baiti"/>
-        <a:font script="Tibt" typeface="Microsoft Himalaya"/>
-        <a:font script="Thaa" typeface="MV Boli"/>
-        <a:font script="Deva" typeface="Mangal"/>
-        <a:font script="Telu" typeface="Gautami"/>
-        <a:font script="Taml" typeface="Latha"/>
-        <a:font script="Syrc" typeface="Estrangelo Edessa"/>
-        <a:font script="Orya" typeface="Kalinga"/>
-        <a:font script="Mlym" typeface="Kartika"/>
-        <a:font script="Laoo" typeface="DokChampa"/>
-        <a:font script="Sinh" typeface="Iskoola Pota"/>
-        <a:font script="Mong" typeface="Mongolian Baiti"/>
-        <a:font script="Viet" typeface="Arial"/>
-        <a:font script="Uigh" typeface="Microsoft Uighur"/>
-        <a:font script="Geor" typeface="Sylfaen"/>
-      </a:minorFont>
-    </a:fontScheme>
-    <a:fmtScheme name="Office">
-      <a:fillStyleLst>
-        <a:solidFill>
-          <a:schemeClr val="phClr"/>
-        </a:solidFill>
-        <a:gradFill rotWithShape="1">
-          <a:gsLst>
-            <a:gs pos="0">
-              <a:schemeClr val="phClr">
-                <a:tint val="50000"/>
-                <a:satMod val="300000"/>
-              </a:schemeClr>
-            </a:gs>
-            <a:gs pos="35000">
-              <a:schemeClr val="phClr">
-                <a:tint val="37000"/>
-                <a:satMod val="300000"/>
-              </a:schemeClr>
-            </a:gs>
-            <a:gs pos="100000">
-              <a:schemeClr val="phClr">
-                <a:tint val="15000"/>
-                <a:satMod val="350000"/>
-              </a:schemeClr>
-            </a:gs>
-          </a:gsLst>
-          <a:lin ang="16200000" scaled="1"/>
-        </a:gradFill>
-        <a:gradFill rotWithShape="1">
-          <a:gsLst>
-            <a:gs pos="0">
-              <a:schemeClr val="phClr">
-                <a:tint val="100000"/>
-                <a:shade val="100000"/>
-                <a:satMod val="130000"/>
-              </a:schemeClr>
-            </a:gs>
-            <a:gs pos="100000">
-              <a:schemeClr val="phClr">
-                <a:tint val="50000"/>
-                <a:shade val="100000"/>
-                <a:satMod val="350000"/>
-              </a:schemeClr>
-            </a:gs>
-          </a:gsLst>
-          <a:lin ang="16200000" scaled="0"/>
-        </a:gradFill>
-      </a:fillStyleLst>
-      <a:lnStyleLst>
-        <a:ln w="9525" cap="flat" cmpd="sng" algn="ctr">
-          <a:solidFill>
-            <a:schemeClr val="phClr">
-              <a:shade val="95000"/>
-              <a:satMod val="105000"/>
-            </a:schemeClr>
-          </a:solidFill>
-          <a:prstDash val="solid"/>
-        </a:ln>
-        <a:ln w="25400" cap="flat" cmpd="sng" algn="ctr">
-          <a:solidFill>
-            <a:schemeClr val="phClr"/>
-          </a:solidFill>
-          <a:prstDash val="solid"/>
-        </a:ln>
-        <a:ln w="38100" cap="flat" cmpd="sng" algn="ctr">
-          <a:solidFill>
-            <a:schemeClr val="phClr"/>
-          </a:solidFill>
-          <a:prstDash val="solid"/>
-        </a:ln>
-      </a:lnStyleLst>
-      <a:effectStyleLst>
-        <a:effectStyle>
-          <a:effectLst>
-            <a:outerShdw blurRad="40000" dist="20000" dir="5400000" rotWithShape="0">
-              <a:srgbClr val="000000">
-                <a:alpha val="38000"/>
-              </a:srgbClr>
-            </a:outerShdw>
-          </a:effectLst>
-        </a:effectStyle>
-        <a:effectStyle>
-          <a:effectLst>
-            <a:outerShdw blurRad="40000" dist="23000" dir="5400000" rotWithShape="0">
-              <a:srgbClr val="000000">
-                <a:alpha val="35000"/>
-              </a:srgbClr>
-            </a:outerShdw>
-          </a:effectLst>
-        </a:effectStyle>
-        <a:effectStyle>
-          <a:effectLst>
-            <a:outerShdw blurRad="40000" dist="23000" dir="5400000" rotWithShape="0">
-              <a:srgbClr val="000000">
-                <a:alpha val="35000"/>
-              </a:srgbClr>
-            </a:outerShdw>
-          </a:effectLst>
-          <a:scene3d>
-            <a:camera prst="orthographicFront">
-              <a:rot lat="0" lon="0" rev="0"/>
-            </a:camera>
-            <a:lightRig rig="threePt" dir="t">
-              <a:rot lat="0" lon="0" rev="1200000"/>
-            </a:lightRig>
-          </a:scene3d>
-          <a:sp3d>
-            <a:bevelT w="63500" h="25400"/>
-          </a:sp3d>
-        </a:effectStyle>
-      </a:effectStyleLst>
-      <a:bgFillStyleLst>
-        <a:solidFill>
-          <a:schemeClr val="phClr"/>
-        </a:solidFill>
-        <a:gradFill rotWithShape="1">
-          <a:gsLst>
-            <a:gs pos="0">
-              <a:schemeClr val="phClr">
-                <a:tint val="40000"/>
-                <a:satMod val="350000"/>
-              </a:schemeClr>
-            </a:gs>
-            <a:gs pos="40000">
-              <a:schemeClr val="phClr">
-                <a:tint val="45000"/>
-                <a:shade val="99000"/>
-                <a:satMod val="350000"/>
-              </a:schemeClr>
-            </a:gs>
-            <a:gs pos="100000">
-              <a:schemeClr val="phClr">
-                <a:shade val="20000"/>
-                <a:satMod val="255000"/>
-              </a:schemeClr>
-            </a:gs>
-          </a:gsLst>
-          <a:path path="circle">
-            <a:fillToRect l="50000" t="-80000" r="50000" b="180000"/>
-          </a:path>
-        </a:gradFill>
-        <a:gradFill rotWithShape="1">
-          <a:gsLst>
-            <a:gs pos="0">
-              <a:schemeClr val="phClr">
-                <a:tint val="80000"/>
-                <a:satMod val="300000"/>
-              </a:schemeClr>
-            </a:gs>
-            <a:gs pos="100000">
-              <a:schemeClr val="phClr">
-                <a:shade val="30000"/>
-                <a:satMod val="200000"/>
-              </a:schemeClr>
-            </a:gs>
-          </a:gsLst>
-          <a:path path="circle">
-            <a:fillToRect l="50000" t="50000" r="50000" b="50000"/>
-          </a:path>
-        </a:gradFill>
-      </a:bgFillStyleLst>
-    </a:fmtScheme>
-  </a:themeElements>
-</a:theme>
-</file>
-
-<file path=ppt/theme/theme2.xml><?xml version="1.0" encoding="utf-8"?>
 <a:theme xmlns:a="http://schemas.openxmlformats.org/drawingml/2006/main" xmlns:r="http://schemas.openxmlformats.org/officeDocument/2006/relationships">
   <a:themeElements>
     <a:clrScheme name="Default">
@@ -34559,7 +34280,7 @@
 </a:theme>
 </file>
 
-<file path=ppt/theme/theme3.xml><?xml version="1.0" encoding="utf-8"?>
+<file path=ppt/theme/theme2.xml><?xml version="1.0" encoding="utf-8"?>
 <a:theme xmlns:a="http://schemas.openxmlformats.org/drawingml/2006/main" xmlns:r="http://schemas.openxmlformats.org/officeDocument/2006/relationships" name="LF Energy Theme 2023">
   <a:themeElements>
     <a:clrScheme name="Geometric">
@@ -34836,4 +34557,283 @@
     </a:fmtScheme>
   </a:themeElements>
 </a:theme>
+</file>
+
+<file path=ppt/theme/theme3.xml><?xml version="1.0" encoding="utf-8"?>
+<a:theme xmlns:a="http://schemas.openxmlformats.org/drawingml/2006/main" xmlns:r="http://schemas.openxmlformats.org/officeDocument/2006/relationships" name="Simple Light">
+  <a:themeElements>
+    <a:clrScheme name="Simple Light">
+      <a:dk1>
+        <a:srgbClr val="000000"/>
+      </a:dk1>
+      <a:lt1>
+        <a:srgbClr val="FFFFFF"/>
+      </a:lt1>
+      <a:dk2>
+        <a:srgbClr val="595959"/>
+      </a:dk2>
+      <a:lt2>
+        <a:srgbClr val="EEEEEE"/>
+      </a:lt2>
+      <a:accent1>
+        <a:srgbClr val="4285F4"/>
+      </a:accent1>
+      <a:accent2>
+        <a:srgbClr val="212121"/>
+      </a:accent2>
+      <a:accent3>
+        <a:srgbClr val="78909C"/>
+      </a:accent3>
+      <a:accent4>
+        <a:srgbClr val="FFAB40"/>
+      </a:accent4>
+      <a:accent5>
+        <a:srgbClr val="0097A7"/>
+      </a:accent5>
+      <a:accent6>
+        <a:srgbClr val="EEFF41"/>
+      </a:accent6>
+      <a:hlink>
+        <a:srgbClr val="0097A7"/>
+      </a:hlink>
+      <a:folHlink>
+        <a:srgbClr val="0097A7"/>
+      </a:folHlink>
+    </a:clrScheme>
+    <a:fontScheme name="Office">
+      <a:majorFont>
+        <a:latin typeface="Arial"/>
+        <a:ea typeface=""/>
+        <a:cs typeface=""/>
+        <a:font script="Jpan" typeface="ＭＳ Ｐゴシック"/>
+        <a:font script="Hang" typeface="맑은 고딕"/>
+        <a:font script="Hans" typeface="宋体"/>
+        <a:font script="Hant" typeface="新細明體"/>
+        <a:font script="Arab" typeface="Times New Roman"/>
+        <a:font script="Hebr" typeface="Times New Roman"/>
+        <a:font script="Thai" typeface="Angsana New"/>
+        <a:font script="Ethi" typeface="Nyala"/>
+        <a:font script="Beng" typeface="Vrinda"/>
+        <a:font script="Gujr" typeface="Shruti"/>
+        <a:font script="Khmr" typeface="MoolBoran"/>
+        <a:font script="Knda" typeface="Tunga"/>
+        <a:font script="Guru" typeface="Raavi"/>
+        <a:font script="Cans" typeface="Euphemia"/>
+        <a:font script="Cher" typeface="Plantagenet Cherokee"/>
+        <a:font script="Yiii" typeface="Microsoft Yi Baiti"/>
+        <a:font script="Tibt" typeface="Microsoft Himalaya"/>
+        <a:font script="Thaa" typeface="MV Boli"/>
+        <a:font script="Deva" typeface="Mangal"/>
+        <a:font script="Telu" typeface="Gautami"/>
+        <a:font script="Taml" typeface="Latha"/>
+        <a:font script="Syrc" typeface="Estrangelo Edessa"/>
+        <a:font script="Orya" typeface="Kalinga"/>
+        <a:font script="Mlym" typeface="Kartika"/>
+        <a:font script="Laoo" typeface="DokChampa"/>
+        <a:font script="Sinh" typeface="Iskoola Pota"/>
+        <a:font script="Mong" typeface="Mongolian Baiti"/>
+        <a:font script="Viet" typeface="Times New Roman"/>
+        <a:font script="Uigh" typeface="Microsoft Uighur"/>
+        <a:font script="Geor" typeface="Sylfaen"/>
+      </a:majorFont>
+      <a:minorFont>
+        <a:latin typeface="Arial"/>
+        <a:ea typeface=""/>
+        <a:cs typeface=""/>
+        <a:font script="Jpan" typeface="ＭＳ Ｐゴシック"/>
+        <a:font script="Hang" typeface="맑은 고딕"/>
+        <a:font script="Hans" typeface="宋体"/>
+        <a:font script="Hant" typeface="新細明體"/>
+        <a:font script="Arab" typeface="Arial"/>
+        <a:font script="Hebr" typeface="Arial"/>
+        <a:font script="Thai" typeface="Cordia New"/>
+        <a:font script="Ethi" typeface="Nyala"/>
+        <a:font script="Beng" typeface="Vrinda"/>
+        <a:font script="Gujr" typeface="Shruti"/>
+        <a:font script="Khmr" typeface="DaunPenh"/>
+        <a:font script="Knda" typeface="Tunga"/>
+        <a:font script="Guru" typeface="Raavi"/>
+        <a:font script="Cans" typeface="Euphemia"/>
+        <a:font script="Cher" typeface="Plantagenet Cherokee"/>
+        <a:font script="Yiii" typeface="Microsoft Yi Baiti"/>
+        <a:font script="Tibt" typeface="Microsoft Himalaya"/>
+        <a:font script="Thaa" typeface="MV Boli"/>
+        <a:font script="Deva" typeface="Mangal"/>
+        <a:font script="Telu" typeface="Gautami"/>
+        <a:font script="Taml" typeface="Latha"/>
+        <a:font script="Syrc" typeface="Estrangelo Edessa"/>
+        <a:font script="Orya" typeface="Kalinga"/>
+        <a:font script="Mlym" typeface="Kartika"/>
+        <a:font script="Laoo" typeface="DokChampa"/>
+        <a:font script="Sinh" typeface="Iskoola Pota"/>
+        <a:font script="Mong" typeface="Mongolian Baiti"/>
+        <a:font script="Viet" typeface="Arial"/>
+        <a:font script="Uigh" typeface="Microsoft Uighur"/>
+        <a:font script="Geor" typeface="Sylfaen"/>
+      </a:minorFont>
+    </a:fontScheme>
+    <a:fmtScheme name="Office">
+      <a:fillStyleLst>
+        <a:solidFill>
+          <a:schemeClr val="phClr"/>
+        </a:solidFill>
+        <a:gradFill rotWithShape="1">
+          <a:gsLst>
+            <a:gs pos="0">
+              <a:schemeClr val="phClr">
+                <a:tint val="50000"/>
+                <a:satMod val="300000"/>
+              </a:schemeClr>
+            </a:gs>
+            <a:gs pos="35000">
+              <a:schemeClr val="phClr">
+                <a:tint val="37000"/>
+                <a:satMod val="300000"/>
+              </a:schemeClr>
+            </a:gs>
+            <a:gs pos="100000">
+              <a:schemeClr val="phClr">
+                <a:tint val="15000"/>
+                <a:satMod val="350000"/>
+              </a:schemeClr>
+            </a:gs>
+          </a:gsLst>
+          <a:lin ang="16200000" scaled="1"/>
+        </a:gradFill>
+        <a:gradFill rotWithShape="1">
+          <a:gsLst>
+            <a:gs pos="0">
+              <a:schemeClr val="phClr">
+                <a:tint val="100000"/>
+                <a:shade val="100000"/>
+                <a:satMod val="130000"/>
+              </a:schemeClr>
+            </a:gs>
+            <a:gs pos="100000">
+              <a:schemeClr val="phClr">
+                <a:tint val="50000"/>
+                <a:shade val="100000"/>
+                <a:satMod val="350000"/>
+              </a:schemeClr>
+            </a:gs>
+          </a:gsLst>
+          <a:lin ang="16200000" scaled="0"/>
+        </a:gradFill>
+      </a:fillStyleLst>
+      <a:lnStyleLst>
+        <a:ln w="9525" cap="flat" cmpd="sng" algn="ctr">
+          <a:solidFill>
+            <a:schemeClr val="phClr">
+              <a:shade val="95000"/>
+              <a:satMod val="105000"/>
+            </a:schemeClr>
+          </a:solidFill>
+          <a:prstDash val="solid"/>
+        </a:ln>
+        <a:ln w="25400" cap="flat" cmpd="sng" algn="ctr">
+          <a:solidFill>
+            <a:schemeClr val="phClr"/>
+          </a:solidFill>
+          <a:prstDash val="solid"/>
+        </a:ln>
+        <a:ln w="38100" cap="flat" cmpd="sng" algn="ctr">
+          <a:solidFill>
+            <a:schemeClr val="phClr"/>
+          </a:solidFill>
+          <a:prstDash val="solid"/>
+        </a:ln>
+      </a:lnStyleLst>
+      <a:effectStyleLst>
+        <a:effectStyle>
+          <a:effectLst>
+            <a:outerShdw blurRad="40000" dist="20000" dir="5400000" rotWithShape="0">
+              <a:srgbClr val="000000">
+                <a:alpha val="38000"/>
+              </a:srgbClr>
+            </a:outerShdw>
+          </a:effectLst>
+        </a:effectStyle>
+        <a:effectStyle>
+          <a:effectLst>
+            <a:outerShdw blurRad="40000" dist="23000" dir="5400000" rotWithShape="0">
+              <a:srgbClr val="000000">
+                <a:alpha val="35000"/>
+              </a:srgbClr>
+            </a:outerShdw>
+          </a:effectLst>
+        </a:effectStyle>
+        <a:effectStyle>
+          <a:effectLst>
+            <a:outerShdw blurRad="40000" dist="23000" dir="5400000" rotWithShape="0">
+              <a:srgbClr val="000000">
+                <a:alpha val="35000"/>
+              </a:srgbClr>
+            </a:outerShdw>
+          </a:effectLst>
+          <a:scene3d>
+            <a:camera prst="orthographicFront">
+              <a:rot lat="0" lon="0" rev="0"/>
+            </a:camera>
+            <a:lightRig rig="threePt" dir="t">
+              <a:rot lat="0" lon="0" rev="1200000"/>
+            </a:lightRig>
+          </a:scene3d>
+          <a:sp3d>
+            <a:bevelT w="63500" h="25400"/>
+          </a:sp3d>
+        </a:effectStyle>
+      </a:effectStyleLst>
+      <a:bgFillStyleLst>
+        <a:solidFill>
+          <a:schemeClr val="phClr"/>
+        </a:solidFill>
+        <a:gradFill rotWithShape="1">
+          <a:gsLst>
+            <a:gs pos="0">
+              <a:schemeClr val="phClr">
+                <a:tint val="40000"/>
+                <a:satMod val="350000"/>
+              </a:schemeClr>
+            </a:gs>
+            <a:gs pos="40000">
+              <a:schemeClr val="phClr">
+                <a:tint val="45000"/>
+                <a:shade val="99000"/>
+                <a:satMod val="350000"/>
+              </a:schemeClr>
+            </a:gs>
+            <a:gs pos="100000">
+              <a:schemeClr val="phClr">
+                <a:shade val="20000"/>
+                <a:satMod val="255000"/>
+              </a:schemeClr>
+            </a:gs>
+          </a:gsLst>
+          <a:path path="circle">
+            <a:fillToRect l="50000" t="-80000" r="50000" b="180000"/>
+          </a:path>
+        </a:gradFill>
+        <a:gradFill rotWithShape="1">
+          <a:gsLst>
+            <a:gs pos="0">
+              <a:schemeClr val="phClr">
+                <a:tint val="80000"/>
+                <a:satMod val="300000"/>
+              </a:schemeClr>
+            </a:gs>
+            <a:gs pos="100000">
+              <a:schemeClr val="phClr">
+                <a:shade val="30000"/>
+                <a:satMod val="200000"/>
+              </a:schemeClr>
+            </a:gs>
+          </a:gsLst>
+          <a:path path="circle">
+            <a:fillToRect l="50000" t="50000" r="50000" b="50000"/>
+          </a:path>
+        </a:gradFill>
+      </a:bgFillStyleLst>
+    </a:fmtScheme>
+  </a:themeElements>
+</a:theme>
 </file>
</xml_diff>

<commit_message>
Update Data Sources from LFX 2026-10-30 (#358)
Update Data Sources from LFX

Signed-off-by: github-actions[bot] <41898282+github-actions[bot]@users.noreply.github.com>
Co-authored-by: jmertic <296737+jmertic@users.noreply.github.com>
</commit_message>
<xml_diff>
--- a/overview_deck/LF Energy High Level Overview.pptx
+++ b/overview_deck/LF Energy High Level Overview.pptx
@@ -25946,7 +25946,7 @@
             <a:tbl>
               <a:tblPr>
                 <a:noFill/>
-                <a:tableStyleId>{C26113E1-182A-4027-ABFA-8594D162625F}</a:tableStyleId>
+                <a:tableStyleId>{9A83F135-37BF-4D01-8559-FB1B940BD517}</a:tableStyleId>
               </a:tblPr>
               <a:tblGrid>
                 <a:gridCol w="1695200"/>
@@ -26736,7 +26736,7 @@
             <a:tbl>
               <a:tblPr>
                 <a:noFill/>
-                <a:tableStyleId>{C26113E1-182A-4027-ABFA-8594D162625F}</a:tableStyleId>
+                <a:tableStyleId>{9A83F135-37BF-4D01-8559-FB1B940BD517}</a:tableStyleId>
               </a:tblPr>
               <a:tblGrid>
                 <a:gridCol w="1695200"/>
@@ -27426,7 +27426,7 @@
             <a:tbl>
               <a:tblPr>
                 <a:noFill/>
-                <a:tableStyleId>{C26113E1-182A-4027-ABFA-8594D162625F}</a:tableStyleId>
+                <a:tableStyleId>{9A83F135-37BF-4D01-8559-FB1B940BD517}</a:tableStyleId>
               </a:tblPr>
               <a:tblGrid>
                 <a:gridCol w="1695200"/>
@@ -28678,7 +28678,7 @@
             <a:tbl>
               <a:tblPr>
                 <a:noFill/>
-                <a:tableStyleId>{C26113E1-182A-4027-ABFA-8594D162625F}</a:tableStyleId>
+                <a:tableStyleId>{9A83F135-37BF-4D01-8559-FB1B940BD517}</a:tableStyleId>
               </a:tblPr>
               <a:tblGrid>
                 <a:gridCol w="1695200"/>
@@ -29670,7 +29670,7 @@
             <a:tbl>
               <a:tblPr>
                 <a:noFill/>
-                <a:tableStyleId>{C26113E1-182A-4027-ABFA-8594D162625F}</a:tableStyleId>
+                <a:tableStyleId>{9A83F135-37BF-4D01-8559-FB1B940BD517}</a:tableStyleId>
               </a:tblPr>
               <a:tblGrid>
                 <a:gridCol w="3048000"/>
@@ -33175,7 +33175,7 @@
             <a:tbl>
               <a:tblPr>
                 <a:noFill/>
-                <a:tableStyleId>{C26113E1-182A-4027-ABFA-8594D162625F}</a:tableStyleId>
+                <a:tableStyleId>{9A83F135-37BF-4D01-8559-FB1B940BD517}</a:tableStyleId>
               </a:tblPr>
               <a:tblGrid>
                 <a:gridCol w="1828800"/>
@@ -34002,44 +34002,44 @@
 </file>
 
 <file path=ppt/theme/theme1.xml><?xml version="1.0" encoding="utf-8"?>
-<a:theme xmlns:a="http://schemas.openxmlformats.org/drawingml/2006/main" xmlns:r="http://schemas.openxmlformats.org/officeDocument/2006/relationships">
+<a:theme xmlns:a="http://schemas.openxmlformats.org/drawingml/2006/main" xmlns:r="http://schemas.openxmlformats.org/officeDocument/2006/relationships" name="LF Energy Theme 2023">
   <a:themeElements>
-    <a:clrScheme name="Default">
+    <a:clrScheme name="Geometric">
       <a:dk1>
-        <a:srgbClr val="000000"/>
+        <a:srgbClr val="222222"/>
       </a:dk1>
       <a:lt1>
         <a:srgbClr val="FFFFFF"/>
       </a:lt1>
       <a:dk2>
-        <a:srgbClr val="158158"/>
+        <a:srgbClr val="434343"/>
       </a:dk2>
       <a:lt2>
-        <a:srgbClr val="F3F3F3"/>
+        <a:srgbClr val="999999"/>
       </a:lt2>
       <a:accent1>
-        <a:srgbClr val="058DC7"/>
+        <a:srgbClr val="003778"/>
       </a:accent1>
       <a:accent2>
-        <a:srgbClr val="50B432"/>
+        <a:srgbClr val="0094FF"/>
       </a:accent2>
       <a:accent3>
-        <a:srgbClr val="ED561B"/>
+        <a:srgbClr val="5B1DE7"/>
       </a:accent3>
       <a:accent4>
-        <a:srgbClr val="EDEF00"/>
+        <a:srgbClr val="12E2E2"/>
       </a:accent4>
       <a:accent5>
-        <a:srgbClr val="24CBE5"/>
+        <a:srgbClr val="FF00AA"/>
       </a:accent5>
       <a:accent6>
-        <a:srgbClr val="64E572"/>
+        <a:srgbClr val="ACDE1F"/>
       </a:accent6>
       <a:hlink>
-        <a:srgbClr val="2200CC"/>
+        <a:srgbClr val="0077CC"/>
       </a:hlink>
       <a:folHlink>
-        <a:srgbClr val="551A8B"/>
+        <a:srgbClr val="F06292"/>
       </a:folHlink>
     </a:clrScheme>
     <a:fontScheme name="Office">
@@ -34281,44 +34281,44 @@
 </file>
 
 <file path=ppt/theme/theme2.xml><?xml version="1.0" encoding="utf-8"?>
-<a:theme xmlns:a="http://schemas.openxmlformats.org/drawingml/2006/main" xmlns:r="http://schemas.openxmlformats.org/officeDocument/2006/relationships" name="LF Energy Theme 2023">
+<a:theme xmlns:a="http://schemas.openxmlformats.org/drawingml/2006/main" xmlns:r="http://schemas.openxmlformats.org/officeDocument/2006/relationships">
   <a:themeElements>
-    <a:clrScheme name="Geometric">
+    <a:clrScheme name="Default">
       <a:dk1>
-        <a:srgbClr val="222222"/>
+        <a:srgbClr val="000000"/>
       </a:dk1>
       <a:lt1>
         <a:srgbClr val="FFFFFF"/>
       </a:lt1>
       <a:dk2>
-        <a:srgbClr val="434343"/>
+        <a:srgbClr val="158158"/>
       </a:dk2>
       <a:lt2>
-        <a:srgbClr val="999999"/>
+        <a:srgbClr val="F3F3F3"/>
       </a:lt2>
       <a:accent1>
-        <a:srgbClr val="003778"/>
+        <a:srgbClr val="058DC7"/>
       </a:accent1>
       <a:accent2>
-        <a:srgbClr val="0094FF"/>
+        <a:srgbClr val="50B432"/>
       </a:accent2>
       <a:accent3>
-        <a:srgbClr val="5B1DE7"/>
+        <a:srgbClr val="ED561B"/>
       </a:accent3>
       <a:accent4>
-        <a:srgbClr val="12E2E2"/>
+        <a:srgbClr val="EDEF00"/>
       </a:accent4>
       <a:accent5>
-        <a:srgbClr val="FF00AA"/>
+        <a:srgbClr val="24CBE5"/>
       </a:accent5>
       <a:accent6>
-        <a:srgbClr val="ACDE1F"/>
+        <a:srgbClr val="64E572"/>
       </a:accent6>
       <a:hlink>
-        <a:srgbClr val="0077CC"/>
+        <a:srgbClr val="2200CC"/>
       </a:hlink>
       <a:folHlink>
-        <a:srgbClr val="F06292"/>
+        <a:srgbClr val="551A8B"/>
       </a:folHlink>
     </a:clrScheme>
     <a:fontScheme name="Office">

</xml_diff>

<commit_message>
Update Data Sources from LFX 2026-10-31 (#359)
Update Data Sources from LFX

Signed-off-by: github-actions[bot] <41898282+github-actions[bot]@users.noreply.github.com>
Co-authored-by: jmertic <296737+jmertic@users.noreply.github.com>
</commit_message>
<xml_diff>
--- a/overview_deck/LF Energy High Level Overview.pptx
+++ b/overview_deck/LF Energy High Level Overview.pptx
@@ -25946,7 +25946,7 @@
             <a:tbl>
               <a:tblPr>
                 <a:noFill/>
-                <a:tableStyleId>{9A83F135-37BF-4D01-8559-FB1B940BD517}</a:tableStyleId>
+                <a:tableStyleId>{3C17A0D2-8790-4EEC-B478-88DC4D83B637}</a:tableStyleId>
               </a:tblPr>
               <a:tblGrid>
                 <a:gridCol w="1695200"/>
@@ -26736,7 +26736,7 @@
             <a:tbl>
               <a:tblPr>
                 <a:noFill/>
-                <a:tableStyleId>{9A83F135-37BF-4D01-8559-FB1B940BD517}</a:tableStyleId>
+                <a:tableStyleId>{3C17A0D2-8790-4EEC-B478-88DC4D83B637}</a:tableStyleId>
               </a:tblPr>
               <a:tblGrid>
                 <a:gridCol w="1695200"/>
@@ -27426,7 +27426,7 @@
             <a:tbl>
               <a:tblPr>
                 <a:noFill/>
-                <a:tableStyleId>{9A83F135-37BF-4D01-8559-FB1B940BD517}</a:tableStyleId>
+                <a:tableStyleId>{3C17A0D2-8790-4EEC-B478-88DC4D83B637}</a:tableStyleId>
               </a:tblPr>
               <a:tblGrid>
                 <a:gridCol w="1695200"/>
@@ -28678,7 +28678,7 @@
             <a:tbl>
               <a:tblPr>
                 <a:noFill/>
-                <a:tableStyleId>{9A83F135-37BF-4D01-8559-FB1B940BD517}</a:tableStyleId>
+                <a:tableStyleId>{3C17A0D2-8790-4EEC-B478-88DC4D83B637}</a:tableStyleId>
               </a:tblPr>
               <a:tblGrid>
                 <a:gridCol w="1695200"/>
@@ -29670,7 +29670,7 @@
             <a:tbl>
               <a:tblPr>
                 <a:noFill/>
-                <a:tableStyleId>{9A83F135-37BF-4D01-8559-FB1B940BD517}</a:tableStyleId>
+                <a:tableStyleId>{3C17A0D2-8790-4EEC-B478-88DC4D83B637}</a:tableStyleId>
               </a:tblPr>
               <a:tblGrid>
                 <a:gridCol w="3048000"/>
@@ -33175,7 +33175,7 @@
             <a:tbl>
               <a:tblPr>
                 <a:noFill/>
-                <a:tableStyleId>{9A83F135-37BF-4D01-8559-FB1B940BD517}</a:tableStyleId>
+                <a:tableStyleId>{3C17A0D2-8790-4EEC-B478-88DC4D83B637}</a:tableStyleId>
               </a:tblPr>
               <a:tblGrid>
                 <a:gridCol w="1828800"/>

</xml_diff>